<commit_message>
Reorganize mutation testing inputs and baseline feedback path
</commit_message>
<xml_diff>
--- a/5g-thesis-presentation-5min/tesi-5min-statico.pptx
+++ b/5g-thesis-presentation-5min/tesi-5min-statico.pptx
@@ -2,19 +2,19 @@
 <file path=ppt/presentation.xml><?xml version="1.0" encoding="utf-8"?>
 <p:presentation xmlns:p="http://schemas.openxmlformats.org/presentationml/2006/main">
   <p:sldMasterIdLst>
-    <p:sldMasterId xmlns:r="http://schemas.openxmlformats.org/officeDocument/2006/relationships" id="2147483648" r:id="R4b1624102d3f4f69"/>
+    <p:sldMasterId xmlns:r="http://schemas.openxmlformats.org/officeDocument/2006/relationships" id="2147483648" r:id="R45c7171876144a49"/>
   </p:sldMasterIdLst>
   <p:notesMasterIdLst>
-    <p:notesMasterId xmlns:r="http://schemas.openxmlformats.org/officeDocument/2006/relationships" r:id="Re375bd14d4e141dd"/>
+    <p:notesMasterId xmlns:r="http://schemas.openxmlformats.org/officeDocument/2006/relationships" r:id="R43868e43004a44aa"/>
   </p:notesMasterIdLst>
   <p:sldIdLst>
-    <p:sldId xmlns:r="http://schemas.openxmlformats.org/officeDocument/2006/relationships" id="256" r:id="Rca69cd72d7d845f1"/>
-    <p:sldId xmlns:r="http://schemas.openxmlformats.org/officeDocument/2006/relationships" id="257" r:id="R3a3f55411d3241d9"/>
-    <p:sldId xmlns:r="http://schemas.openxmlformats.org/officeDocument/2006/relationships" id="258" r:id="R44befe82503b42c9"/>
-    <p:sldId xmlns:r="http://schemas.openxmlformats.org/officeDocument/2006/relationships" id="259" r:id="Rd8dbe95467ba4ea0"/>
-    <p:sldId xmlns:r="http://schemas.openxmlformats.org/officeDocument/2006/relationships" id="260" r:id="R13311727e4804248"/>
-    <p:sldId xmlns:r="http://schemas.openxmlformats.org/officeDocument/2006/relationships" id="261" r:id="Rb3f5c74518d1421a"/>
-    <p:sldId xmlns:r="http://schemas.openxmlformats.org/officeDocument/2006/relationships" id="262" r:id="R346b7621800f4103"/>
+    <p:sldId xmlns:r="http://schemas.openxmlformats.org/officeDocument/2006/relationships" id="256" r:id="R89a8cb36b901428c"/>
+    <p:sldId xmlns:r="http://schemas.openxmlformats.org/officeDocument/2006/relationships" id="257" r:id="Rc44d972dae8c4bd5"/>
+    <p:sldId xmlns:r="http://schemas.openxmlformats.org/officeDocument/2006/relationships" id="258" r:id="R8a69348e4f814a36"/>
+    <p:sldId xmlns:r="http://schemas.openxmlformats.org/officeDocument/2006/relationships" id="259" r:id="Rfe29da69dbc14462"/>
+    <p:sldId xmlns:r="http://schemas.openxmlformats.org/officeDocument/2006/relationships" id="260" r:id="R0115ff00dc104204"/>
+    <p:sldId xmlns:r="http://schemas.openxmlformats.org/officeDocument/2006/relationships" id="261" r:id="Rad1e9efb7cd7483d"/>
+    <p:sldId xmlns:r="http://schemas.openxmlformats.org/officeDocument/2006/relationships" id="262" r:id="Rccfa56830d424394"/>
   </p:sldIdLst>
   <p:sldSz cx="15240000" cy="8572500"/>
   <p:notesSz cx="6858000" cy="9144000"/>
@@ -1135,7 +1135,7 @@
           <p:cNvPr id="3" name="Title">
             <a:extLst xmlns:a="http://schemas.openxmlformats.org/drawingml/2006/main">
               <a:ext uri="{FF2B5EF4-FFF2-40B4-BE49-F238E27FC236}">
-                <a16:creationId xmlns:a16="http://schemas.microsoft.com/office/drawing/2014/main" id="{F5827589-7B4C-4FB4-A2D4-A236BFE547F6}"/>
+                <a16:creationId xmlns:a16="http://schemas.microsoft.com/office/drawing/2014/main" id="{8FE6C73A-BBCE-4D70-AE6B-BA1B16477AA2}"/>
               </a:ext>
             </a:extLst>
           </p:cNvPr>
@@ -1364,7 +1364,7 @@
           <p:cNvPr id="2" name="Subtitle">
             <a:extLst xmlns:a="http://schemas.openxmlformats.org/drawingml/2006/main">
               <a:ext uri="{FF2B5EF4-FFF2-40B4-BE49-F238E27FC236}">
-                <a16:creationId xmlns:a16="http://schemas.microsoft.com/office/drawing/2014/main" id="{E5C705AD-788F-4D9A-8557-4D340208A1B6}"/>
+                <a16:creationId xmlns:a16="http://schemas.microsoft.com/office/drawing/2014/main" id="{2547F167-2F2A-4616-829C-DC0D8D41C126}"/>
               </a:ext>
             </a:extLst>
           </p:cNvPr>
@@ -1610,7 +1610,7 @@
           <p:cNvPr id="2" name="Section title">
             <a:extLst xmlns:a="http://schemas.openxmlformats.org/drawingml/2006/main">
               <a:ext uri="{FF2B5EF4-FFF2-40B4-BE49-F238E27FC236}">
-                <a16:creationId xmlns:a16="http://schemas.microsoft.com/office/drawing/2014/main" id="{C816CDBB-84C8-40B6-A188-617B72920B60}"/>
+                <a16:creationId xmlns:a16="http://schemas.microsoft.com/office/drawing/2014/main" id="{D6DA0569-94FF-450A-8C2B-6BBB0DDAEDBE}"/>
               </a:ext>
             </a:extLst>
           </p:cNvPr>
@@ -1856,7 +1856,7 @@
           <p:cNvPr id="3" name="Title">
             <a:extLst xmlns:a="http://schemas.openxmlformats.org/drawingml/2006/main">
               <a:ext uri="{FF2B5EF4-FFF2-40B4-BE49-F238E27FC236}">
-                <a16:creationId xmlns:a16="http://schemas.microsoft.com/office/drawing/2014/main" id="{11BC299F-0A20-4F9F-A991-2BA95F17C066}"/>
+                <a16:creationId xmlns:a16="http://schemas.microsoft.com/office/drawing/2014/main" id="{5BCA3811-F8F4-45DF-9C54-7CDCFE32B0A1}"/>
               </a:ext>
             </a:extLst>
           </p:cNvPr>
@@ -2085,7 +2085,7 @@
           <p:cNvPr id="2" name="Body">
             <a:extLst xmlns:a="http://schemas.openxmlformats.org/drawingml/2006/main">
               <a:ext uri="{FF2B5EF4-FFF2-40B4-BE49-F238E27FC236}">
-                <a16:creationId xmlns:a16="http://schemas.microsoft.com/office/drawing/2014/main" id="{8728D5CD-982C-417B-8460-E27F83ECE09D}"/>
+                <a16:creationId xmlns:a16="http://schemas.microsoft.com/office/drawing/2014/main" id="{5CDB676D-ADA2-47A7-AB6B-D1C296F3C177}"/>
               </a:ext>
             </a:extLst>
           </p:cNvPr>
@@ -2331,7 +2331,7 @@
           <p:cNvPr id="4" name="Title">
             <a:extLst xmlns:a="http://schemas.openxmlformats.org/drawingml/2006/main">
               <a:ext uri="{FF2B5EF4-FFF2-40B4-BE49-F238E27FC236}">
-                <a16:creationId xmlns:a16="http://schemas.microsoft.com/office/drawing/2014/main" id="{7C680802-8BE9-46C4-A461-925CA779F16F}"/>
+                <a16:creationId xmlns:a16="http://schemas.microsoft.com/office/drawing/2014/main" id="{BECB4981-7089-44E9-92D1-AF95D89960D0}"/>
               </a:ext>
             </a:extLst>
           </p:cNvPr>
@@ -2560,7 +2560,7 @@
           <p:cNvPr id="2" name="Left column">
             <a:extLst xmlns:a="http://schemas.openxmlformats.org/drawingml/2006/main">
               <a:ext uri="{FF2B5EF4-FFF2-40B4-BE49-F238E27FC236}">
-                <a16:creationId xmlns:a16="http://schemas.microsoft.com/office/drawing/2014/main" id="{E54D8792-7668-4520-886A-9EF001A87A6F}"/>
+                <a16:creationId xmlns:a16="http://schemas.microsoft.com/office/drawing/2014/main" id="{5803174A-9FCF-4E3D-B7D0-FEA43AECEE19}"/>
               </a:ext>
             </a:extLst>
           </p:cNvPr>
@@ -2789,7 +2789,7 @@
           <p:cNvPr id="3" name="Right column">
             <a:extLst xmlns:a="http://schemas.openxmlformats.org/drawingml/2006/main">
               <a:ext uri="{FF2B5EF4-FFF2-40B4-BE49-F238E27FC236}">
-                <a16:creationId xmlns:a16="http://schemas.microsoft.com/office/drawing/2014/main" id="{40CAFDB0-4BA5-450F-9FE5-A22F0F26B8C2}"/>
+                <a16:creationId xmlns:a16="http://schemas.microsoft.com/office/drawing/2014/main" id="{9DC75260-157F-4AE6-B53A-313EEE665B98}"/>
               </a:ext>
             </a:extLst>
           </p:cNvPr>
@@ -3035,7 +3035,7 @@
           <p:cNvPr id="3" name="Title">
             <a:extLst xmlns:a="http://schemas.openxmlformats.org/drawingml/2006/main">
               <a:ext uri="{FF2B5EF4-FFF2-40B4-BE49-F238E27FC236}">
-                <a16:creationId xmlns:a16="http://schemas.microsoft.com/office/drawing/2014/main" id="{43EEB030-A2FA-4A99-BF40-FAFD171CF02E}"/>
+                <a16:creationId xmlns:a16="http://schemas.microsoft.com/office/drawing/2014/main" id="{843AF58A-BC44-4CBD-81E4-1EC4D2FCB0BB}"/>
               </a:ext>
             </a:extLst>
           </p:cNvPr>
@@ -3264,7 +3264,7 @@
           <p:cNvPr id="2" name="Left column">
             <a:extLst xmlns:a="http://schemas.openxmlformats.org/drawingml/2006/main">
               <a:ext uri="{FF2B5EF4-FFF2-40B4-BE49-F238E27FC236}">
-                <a16:creationId xmlns:a16="http://schemas.microsoft.com/office/drawing/2014/main" id="{DEA96260-4413-4BF6-B14F-70FA4F6ED77F}"/>
+                <a16:creationId xmlns:a16="http://schemas.microsoft.com/office/drawing/2014/main" id="{1E0C145F-82F3-41EE-B8E8-1024FC5C0BB2}"/>
               </a:ext>
             </a:extLst>
           </p:cNvPr>
@@ -3531,12 +3531,12 @@
   </p:cSld>
   <p:clrMap bg1="lt1" tx1="dk1" bg2="lt2" tx2="dk2" accent1="accent1" accent2="accent2" accent3="accent3" accent4="accent4" accent5="accent5" accent6="accent6" hlink="hlink" folHlink="folHlink"/>
   <p:sldLayoutIdLst>
-    <p:sldLayoutId xmlns:r="http://schemas.openxmlformats.org/officeDocument/2006/relationships" id="2147483649" r:id="R479ce6d5d9e842cc"/>
-    <p:sldLayoutId xmlns:r="http://schemas.openxmlformats.org/officeDocument/2006/relationships" id="2147483650" r:id="R8d131a1733944ba2"/>
-    <p:sldLayoutId xmlns:r="http://schemas.openxmlformats.org/officeDocument/2006/relationships" id="2147483651" r:id="R720bfcab579440f5"/>
-    <p:sldLayoutId xmlns:r="http://schemas.openxmlformats.org/officeDocument/2006/relationships" id="2147483652" r:id="Rd8d58f2dc096421a"/>
-    <p:sldLayoutId xmlns:r="http://schemas.openxmlformats.org/officeDocument/2006/relationships" id="2147483653" r:id="R7e9749649418410f"/>
-    <p:sldLayoutId xmlns:r="http://schemas.openxmlformats.org/officeDocument/2006/relationships" id="2147483654" r:id="Re51770322b06497d"/>
+    <p:sldLayoutId xmlns:r="http://schemas.openxmlformats.org/officeDocument/2006/relationships" id="2147483649" r:id="R4fb492e712c24ce5"/>
+    <p:sldLayoutId xmlns:r="http://schemas.openxmlformats.org/officeDocument/2006/relationships" id="2147483650" r:id="Ra550e679a33a4b6d"/>
+    <p:sldLayoutId xmlns:r="http://schemas.openxmlformats.org/officeDocument/2006/relationships" id="2147483651" r:id="R49a02fae15634e7d"/>
+    <p:sldLayoutId xmlns:r="http://schemas.openxmlformats.org/officeDocument/2006/relationships" id="2147483652" r:id="Rcc5c6d6bc0b84d08"/>
+    <p:sldLayoutId xmlns:r="http://schemas.openxmlformats.org/officeDocument/2006/relationships" id="2147483653" r:id="Rc6d1285052004112"/>
+    <p:sldLayoutId xmlns:r="http://schemas.openxmlformats.org/officeDocument/2006/relationships" id="2147483654" r:id="R1b2f2946f3f64cdb"/>
   </p:sldLayoutIdLst>
   <p:txStyles>
     <p:titleStyle>
@@ -4087,7 +4087,7 @@
           <p:cNvPr id="21" name="">
             <a:extLst xmlns:a="http://schemas.openxmlformats.org/drawingml/2006/main">
               <a:ext uri="{FF2B5EF4-FFF2-40B4-BE49-F238E27FC236}">
-                <a16:creationId xmlns:a16="http://schemas.microsoft.com/office/drawing/2014/main" id="{92B05E7B-198B-4F25-9724-AF4D6A030A57}"/>
+                <a16:creationId xmlns:a16="http://schemas.microsoft.com/office/drawing/2014/main" id="{EF03AD46-624E-454B-9DB3-0287F41BD9FC}"/>
               </a:ext>
             </a:extLst>
           </p:cNvPr>
@@ -4097,7 +4097,7 @@
           <p:nvPr/>
         </p:nvPicPr>
         <p:blipFill>
-          <a:blip xmlns:r="http://schemas.openxmlformats.org/officeDocument/2006/relationships" xmlns:a="http://schemas.openxmlformats.org/drawingml/2006/main" r:embed="R1f58e9e7a17a4ae2"/>
+          <a:blip xmlns:r="http://schemas.openxmlformats.org/officeDocument/2006/relationships" xmlns:a="http://schemas.openxmlformats.org/drawingml/2006/main" r:embed="R460e947876964cd3"/>
           <a:stretch xmlns:a="http://schemas.openxmlformats.org/drawingml/2006/main"/>
         </p:blipFill>
         <p:spPr>
@@ -4115,7 +4115,7 @@
           <p:cNvPr id="2" name="f2">
             <a:extLst xmlns:a="http://schemas.openxmlformats.org/drawingml/2006/main">
               <a:ext uri="{FF2B5EF4-FFF2-40B4-BE49-F238E27FC236}">
-                <a16:creationId xmlns:a16="http://schemas.microsoft.com/office/drawing/2014/main" id="{7D0DBAE3-210B-419E-89D6-005834141926}"/>
+                <a16:creationId xmlns:a16="http://schemas.microsoft.com/office/drawing/2014/main" id="{3E2BB6A3-9DE3-444D-A320-2F09A9D4B8DD}"/>
               </a:ext>
             </a:extLst>
           </p:cNvPr>
@@ -4274,7 +4274,7 @@
           <p:cNvPr id="3" name="f3">
             <a:extLst xmlns:a="http://schemas.openxmlformats.org/drawingml/2006/main">
               <a:ext uri="{FF2B5EF4-FFF2-40B4-BE49-F238E27FC236}">
-                <a16:creationId xmlns:a16="http://schemas.microsoft.com/office/drawing/2014/main" id="{DAE93BA3-E935-476F-BE4D-D1604BBC83AA}"/>
+                <a16:creationId xmlns:a16="http://schemas.microsoft.com/office/drawing/2014/main" id="{0651A0D3-6833-4FF7-AC1F-CD575C718273}"/>
               </a:ext>
             </a:extLst>
           </p:cNvPr>
@@ -4433,7 +4433,7 @@
           <p:cNvPr id="4" name="f4">
             <a:extLst xmlns:a="http://schemas.openxmlformats.org/drawingml/2006/main">
               <a:ext uri="{FF2B5EF4-FFF2-40B4-BE49-F238E27FC236}">
-                <a16:creationId xmlns:a16="http://schemas.microsoft.com/office/drawing/2014/main" id="{754A3CB6-1D18-4D59-B99F-34F67A916886}"/>
+                <a16:creationId xmlns:a16="http://schemas.microsoft.com/office/drawing/2014/main" id="{EA3A99D5-D31D-4828-90BF-A56537AD49AD}"/>
               </a:ext>
             </a:extLst>
           </p:cNvPr>
@@ -4592,7 +4592,7 @@
           <p:cNvPr id="5" name="f5">
             <a:extLst xmlns:a="http://schemas.openxmlformats.org/drawingml/2006/main">
               <a:ext uri="{FF2B5EF4-FFF2-40B4-BE49-F238E27FC236}">
-                <a16:creationId xmlns:a16="http://schemas.microsoft.com/office/drawing/2014/main" id="{B2153987-8598-4495-B072-382814ED1C02}"/>
+                <a16:creationId xmlns:a16="http://schemas.microsoft.com/office/drawing/2014/main" id="{0D0D9FB3-8DEE-440C-B1CB-A592D9545CBA}"/>
               </a:ext>
             </a:extLst>
           </p:cNvPr>
@@ -4751,7 +4751,7 @@
           <p:cNvPr id="6" name="f6">
             <a:extLst xmlns:a="http://schemas.openxmlformats.org/drawingml/2006/main">
               <a:ext uri="{FF2B5EF4-FFF2-40B4-BE49-F238E27FC236}">
-                <a16:creationId xmlns:a16="http://schemas.microsoft.com/office/drawing/2014/main" id="{874012CD-4017-4723-A6A6-7440716ED33F}"/>
+                <a16:creationId xmlns:a16="http://schemas.microsoft.com/office/drawing/2014/main" id="{DD227CE4-EAAE-432A-AE9D-1427C96A1EA7}"/>
               </a:ext>
             </a:extLst>
           </p:cNvPr>
@@ -4910,7 +4910,7 @@
           <p:cNvPr id="7" name="f7">
             <a:extLst xmlns:a="http://schemas.openxmlformats.org/drawingml/2006/main">
               <a:ext uri="{FF2B5EF4-FFF2-40B4-BE49-F238E27FC236}">
-                <a16:creationId xmlns:a16="http://schemas.microsoft.com/office/drawing/2014/main" id="{095F0584-316A-4EB3-808D-99CFDEE3EE88}"/>
+                <a16:creationId xmlns:a16="http://schemas.microsoft.com/office/drawing/2014/main" id="{036C3A9A-EAD4-4892-B2D9-2E4B3819F8C9}"/>
               </a:ext>
             </a:extLst>
           </p:cNvPr>
@@ -5069,7 +5069,7 @@
           <p:cNvPr id="8" name="f8">
             <a:extLst xmlns:a="http://schemas.openxmlformats.org/drawingml/2006/main">
               <a:ext uri="{FF2B5EF4-FFF2-40B4-BE49-F238E27FC236}">
-                <a16:creationId xmlns:a16="http://schemas.microsoft.com/office/drawing/2014/main" id="{C84D3C85-7255-47B3-85CE-499CC4000901}"/>
+                <a16:creationId xmlns:a16="http://schemas.microsoft.com/office/drawing/2014/main" id="{C58305C9-7703-4D80-8525-2C6430F6422E}"/>
               </a:ext>
             </a:extLst>
           </p:cNvPr>
@@ -5228,7 +5228,7 @@
           <p:cNvPr id="9" name="f9">
             <a:extLst xmlns:a="http://schemas.openxmlformats.org/drawingml/2006/main">
               <a:ext uri="{FF2B5EF4-FFF2-40B4-BE49-F238E27FC236}">
-                <a16:creationId xmlns:a16="http://schemas.microsoft.com/office/drawing/2014/main" id="{F5970A3D-1732-487C-B1CD-2664ACE1D076}"/>
+                <a16:creationId xmlns:a16="http://schemas.microsoft.com/office/drawing/2014/main" id="{6D50A069-25F4-4D93-9BA6-82711785BCB0}"/>
               </a:ext>
             </a:extLst>
           </p:cNvPr>
@@ -5387,7 +5387,7 @@
           <p:cNvPr id="10" name="f10">
             <a:extLst xmlns:a="http://schemas.openxmlformats.org/drawingml/2006/main">
               <a:ext uri="{FF2B5EF4-FFF2-40B4-BE49-F238E27FC236}">
-                <a16:creationId xmlns:a16="http://schemas.microsoft.com/office/drawing/2014/main" id="{76CA94A5-C86B-40AC-BE2B-0E09738BF174}"/>
+                <a16:creationId xmlns:a16="http://schemas.microsoft.com/office/drawing/2014/main" id="{769A7FB0-63C1-40DF-96EF-A30420ACF19E}"/>
               </a:ext>
             </a:extLst>
           </p:cNvPr>
@@ -5546,7 +5546,7 @@
           <p:cNvPr id="11" name="f11">
             <a:extLst xmlns:a="http://schemas.openxmlformats.org/drawingml/2006/main">
               <a:ext uri="{FF2B5EF4-FFF2-40B4-BE49-F238E27FC236}">
-                <a16:creationId xmlns:a16="http://schemas.microsoft.com/office/drawing/2014/main" id="{FF3E690D-0B42-4C04-8A88-BAB9E798CBE4}"/>
+                <a16:creationId xmlns:a16="http://schemas.microsoft.com/office/drawing/2014/main" id="{6CC3875E-1D87-4AE2-B0B6-040556F6F0F4}"/>
               </a:ext>
             </a:extLst>
           </p:cNvPr>
@@ -5705,7 +5705,7 @@
           <p:cNvPr id="12" name="f12">
             <a:extLst xmlns:a="http://schemas.openxmlformats.org/drawingml/2006/main">
               <a:ext uri="{FF2B5EF4-FFF2-40B4-BE49-F238E27FC236}">
-                <a16:creationId xmlns:a16="http://schemas.microsoft.com/office/drawing/2014/main" id="{E9D6E330-6B5F-4F1E-9498-37EB0A3E2C00}"/>
+                <a16:creationId xmlns:a16="http://schemas.microsoft.com/office/drawing/2014/main" id="{7471D0FC-9208-4A04-88C4-3CFB51517729}"/>
               </a:ext>
             </a:extLst>
           </p:cNvPr>
@@ -5864,7 +5864,7 @@
           <p:cNvPr id="13" name="f13">
             <a:extLst xmlns:a="http://schemas.openxmlformats.org/drawingml/2006/main">
               <a:ext uri="{FF2B5EF4-FFF2-40B4-BE49-F238E27FC236}">
-                <a16:creationId xmlns:a16="http://schemas.microsoft.com/office/drawing/2014/main" id="{B3A3A5C5-6454-4682-9968-D1173815FA65}"/>
+                <a16:creationId xmlns:a16="http://schemas.microsoft.com/office/drawing/2014/main" id="{39BEF633-0628-43B6-8CD3-73B4B5092F7F}"/>
               </a:ext>
             </a:extLst>
           </p:cNvPr>
@@ -6023,7 +6023,7 @@
           <p:cNvPr id="14" name="f14">
             <a:extLst xmlns:a="http://schemas.openxmlformats.org/drawingml/2006/main">
               <a:ext uri="{FF2B5EF4-FFF2-40B4-BE49-F238E27FC236}">
-                <a16:creationId xmlns:a16="http://schemas.microsoft.com/office/drawing/2014/main" id="{3C1C9B65-0E7B-46FA-AF99-752BDD2DA108}"/>
+                <a16:creationId xmlns:a16="http://schemas.microsoft.com/office/drawing/2014/main" id="{60E3524A-5D0B-413F-B95F-9E42DD530ABE}"/>
               </a:ext>
             </a:extLst>
           </p:cNvPr>
@@ -6182,7 +6182,7 @@
           <p:cNvPr id="15" name="f15">
             <a:extLst xmlns:a="http://schemas.openxmlformats.org/drawingml/2006/main">
               <a:ext uri="{FF2B5EF4-FFF2-40B4-BE49-F238E27FC236}">
-                <a16:creationId xmlns:a16="http://schemas.microsoft.com/office/drawing/2014/main" id="{62B3FEF1-E15C-4B72-B905-8C395A34B634}"/>
+                <a16:creationId xmlns:a16="http://schemas.microsoft.com/office/drawing/2014/main" id="{131A3327-3FC5-44D2-AC97-08E3088E98D1}"/>
               </a:ext>
             </a:extLst>
           </p:cNvPr>
@@ -6341,7 +6341,7 @@
           <p:cNvPr id="16" name="f16">
             <a:extLst xmlns:a="http://schemas.openxmlformats.org/drawingml/2006/main">
               <a:ext uri="{FF2B5EF4-FFF2-40B4-BE49-F238E27FC236}">
-                <a16:creationId xmlns:a16="http://schemas.microsoft.com/office/drawing/2014/main" id="{7A8A114B-E746-489C-B20D-B42978AFF70B}"/>
+                <a16:creationId xmlns:a16="http://schemas.microsoft.com/office/drawing/2014/main" id="{988B0B97-4DB2-461F-934D-C8F76F0EF7F0}"/>
               </a:ext>
             </a:extLst>
           </p:cNvPr>
@@ -6500,7 +6500,7 @@
           <p:cNvPr id="17" name="f17">
             <a:extLst xmlns:a="http://schemas.openxmlformats.org/drawingml/2006/main">
               <a:ext uri="{FF2B5EF4-FFF2-40B4-BE49-F238E27FC236}">
-                <a16:creationId xmlns:a16="http://schemas.microsoft.com/office/drawing/2014/main" id="{6A69C208-B7E1-45C4-80AF-128990E5261A}"/>
+                <a16:creationId xmlns:a16="http://schemas.microsoft.com/office/drawing/2014/main" id="{43AFB416-4970-4A6C-8BE4-D701AFAFC65C}"/>
               </a:ext>
             </a:extLst>
           </p:cNvPr>
@@ -6659,7 +6659,7 @@
           <p:cNvPr id="18" name="f18">
             <a:extLst xmlns:a="http://schemas.openxmlformats.org/drawingml/2006/main">
               <a:ext uri="{FF2B5EF4-FFF2-40B4-BE49-F238E27FC236}">
-                <a16:creationId xmlns:a16="http://schemas.microsoft.com/office/drawing/2014/main" id="{8ED9E915-EDFB-4F78-9341-F92553B94524}"/>
+                <a16:creationId xmlns:a16="http://schemas.microsoft.com/office/drawing/2014/main" id="{0F50D955-4B09-4C80-A27F-BABD7D2E5FC2}"/>
               </a:ext>
             </a:extLst>
           </p:cNvPr>
@@ -6818,7 +6818,7 @@
           <p:cNvPr id="19" name="f19">
             <a:extLst xmlns:a="http://schemas.openxmlformats.org/drawingml/2006/main">
               <a:ext uri="{FF2B5EF4-FFF2-40B4-BE49-F238E27FC236}">
-                <a16:creationId xmlns:a16="http://schemas.microsoft.com/office/drawing/2014/main" id="{C2132C43-120F-4A40-8F7D-8B3A9A2E4D12}"/>
+                <a16:creationId xmlns:a16="http://schemas.microsoft.com/office/drawing/2014/main" id="{91C9588D-6CD4-43F5-B66E-ACF163ED31E6}"/>
               </a:ext>
             </a:extLst>
           </p:cNvPr>
@@ -6977,7 +6977,7 @@
           <p:cNvPr id="20" name="f20">
             <a:extLst xmlns:a="http://schemas.openxmlformats.org/drawingml/2006/main">
               <a:ext uri="{FF2B5EF4-FFF2-40B4-BE49-F238E27FC236}">
-                <a16:creationId xmlns:a16="http://schemas.microsoft.com/office/drawing/2014/main" id="{4513B31A-6AE1-4FBB-A582-9C1DB9831505}"/>
+                <a16:creationId xmlns:a16="http://schemas.microsoft.com/office/drawing/2014/main" id="{8EB0730B-2DB8-49E4-9AAF-108A0BE7AE7A}"/>
               </a:ext>
             </a:extLst>
           </p:cNvPr>
@@ -7134,7 +7134,7 @@
     </p:spTree>
     <p:extLst>
       <p:ext uri="{BB962C8B-B14F-4D97-AF65-F5344CB8AC3E}">
-        <p14:creationId xmlns:p14="http://schemas.microsoft.com/office/powerpoint/2010/main" val="546992989"/>
+        <p14:creationId xmlns:p14="http://schemas.microsoft.com/office/powerpoint/2010/main" val="372116789"/>
       </p:ext>
     </p:extLst>
   </p:cSld>
@@ -7165,7 +7165,7 @@
           <p:cNvPr id="24" name="f21">
             <a:extLst xmlns:a="http://schemas.openxmlformats.org/drawingml/2006/main">
               <a:ext uri="{FF2B5EF4-FFF2-40B4-BE49-F238E27FC236}">
-                <a16:creationId xmlns:a16="http://schemas.microsoft.com/office/drawing/2014/main" id="{FD125CCF-4566-4587-B7B1-E2CC549A4854}"/>
+                <a16:creationId xmlns:a16="http://schemas.microsoft.com/office/drawing/2014/main" id="{ED6CB717-ABBE-4557-A8BC-523E97D66540}"/>
               </a:ext>
             </a:extLst>
           </p:cNvPr>
@@ -7324,7 +7324,7 @@
           <p:cNvPr id="2" name="f22">
             <a:extLst xmlns:a="http://schemas.openxmlformats.org/drawingml/2006/main">
               <a:ext uri="{FF2B5EF4-FFF2-40B4-BE49-F238E27FC236}">
-                <a16:creationId xmlns:a16="http://schemas.microsoft.com/office/drawing/2014/main" id="{51ED8B2D-3A53-49C7-9F7D-7BD570634B43}"/>
+                <a16:creationId xmlns:a16="http://schemas.microsoft.com/office/drawing/2014/main" id="{733A0C94-0968-47B8-90D5-E212BC8A5D07}"/>
               </a:ext>
             </a:extLst>
           </p:cNvPr>
@@ -7483,7 +7483,7 @@
           <p:cNvPr id="3" name="f23">
             <a:extLst xmlns:a="http://schemas.openxmlformats.org/drawingml/2006/main">
               <a:ext uri="{FF2B5EF4-FFF2-40B4-BE49-F238E27FC236}">
-                <a16:creationId xmlns:a16="http://schemas.microsoft.com/office/drawing/2014/main" id="{03B500F1-98D6-4445-9DA8-34B3C402D95D}"/>
+                <a16:creationId xmlns:a16="http://schemas.microsoft.com/office/drawing/2014/main" id="{E682C433-4127-4492-821B-EEC89F79AFF3}"/>
               </a:ext>
             </a:extLst>
           </p:cNvPr>
@@ -7642,7 +7642,7 @@
           <p:cNvPr id="4" name="f24">
             <a:extLst xmlns:a="http://schemas.openxmlformats.org/drawingml/2006/main">
               <a:ext uri="{FF2B5EF4-FFF2-40B4-BE49-F238E27FC236}">
-                <a16:creationId xmlns:a16="http://schemas.microsoft.com/office/drawing/2014/main" id="{4BE103D2-1811-4DDC-8C06-FFD4C1234894}"/>
+                <a16:creationId xmlns:a16="http://schemas.microsoft.com/office/drawing/2014/main" id="{62CF49C3-5C95-4E12-9E3A-EBFE4BF614F7}"/>
               </a:ext>
             </a:extLst>
           </p:cNvPr>
@@ -7801,7 +7801,7 @@
           <p:cNvPr id="5" name="f25">
             <a:extLst xmlns:a="http://schemas.openxmlformats.org/drawingml/2006/main">
               <a:ext uri="{FF2B5EF4-FFF2-40B4-BE49-F238E27FC236}">
-                <a16:creationId xmlns:a16="http://schemas.microsoft.com/office/drawing/2014/main" id="{DA819CE7-495F-4288-B769-1165C8FEBD08}"/>
+                <a16:creationId xmlns:a16="http://schemas.microsoft.com/office/drawing/2014/main" id="{71890CED-2DBF-4894-B458-64E0E1493FE0}"/>
               </a:ext>
             </a:extLst>
           </p:cNvPr>
@@ -7960,7 +7960,7 @@
           <p:cNvPr id="6" name="f26">
             <a:extLst xmlns:a="http://schemas.openxmlformats.org/drawingml/2006/main">
               <a:ext uri="{FF2B5EF4-FFF2-40B4-BE49-F238E27FC236}">
-                <a16:creationId xmlns:a16="http://schemas.microsoft.com/office/drawing/2014/main" id="{E9B1B775-EF3F-4C5F-9BA8-6777FF423C16}"/>
+                <a16:creationId xmlns:a16="http://schemas.microsoft.com/office/drawing/2014/main" id="{3319DDFE-1CE5-412F-938B-989D4603E202}"/>
               </a:ext>
             </a:extLst>
           </p:cNvPr>
@@ -8119,7 +8119,7 @@
           <p:cNvPr id="7" name="f27">
             <a:extLst xmlns:a="http://schemas.openxmlformats.org/drawingml/2006/main">
               <a:ext uri="{FF2B5EF4-FFF2-40B4-BE49-F238E27FC236}">
-                <a16:creationId xmlns:a16="http://schemas.microsoft.com/office/drawing/2014/main" id="{7EBE0CA3-C605-4517-9A4D-F6562256EF8C}"/>
+                <a16:creationId xmlns:a16="http://schemas.microsoft.com/office/drawing/2014/main" id="{84236307-E0A5-40E9-A6B1-66FA846E9724}"/>
               </a:ext>
             </a:extLst>
           </p:cNvPr>
@@ -8154,7 +8154,7 @@
           <p:cNvPr id="8" name="f28">
             <a:extLst xmlns:a="http://schemas.openxmlformats.org/drawingml/2006/main">
               <a:ext uri="{FF2B5EF4-FFF2-40B4-BE49-F238E27FC236}">
-                <a16:creationId xmlns:a16="http://schemas.microsoft.com/office/drawing/2014/main" id="{2AE429EB-1A57-4227-93D6-5C151D8A8DDC}"/>
+                <a16:creationId xmlns:a16="http://schemas.microsoft.com/office/drawing/2014/main" id="{9A9F7338-B46D-47F3-808C-EFB257C39D5C}"/>
               </a:ext>
             </a:extLst>
           </p:cNvPr>
@@ -8185,7 +8185,7 @@
           <p:cNvPr id="9" name="f29">
             <a:extLst xmlns:a="http://schemas.openxmlformats.org/drawingml/2006/main">
               <a:ext uri="{FF2B5EF4-FFF2-40B4-BE49-F238E27FC236}">
-                <a16:creationId xmlns:a16="http://schemas.microsoft.com/office/drawing/2014/main" id="{5BB315D0-7A64-440B-861D-70A2776BDEA3}"/>
+                <a16:creationId xmlns:a16="http://schemas.microsoft.com/office/drawing/2014/main" id="{F9A6E795-0714-4694-A117-75264AD1BD9F}"/>
               </a:ext>
             </a:extLst>
           </p:cNvPr>
@@ -8216,7 +8216,7 @@
           <p:cNvPr id="10" name="f30">
             <a:extLst xmlns:a="http://schemas.openxmlformats.org/drawingml/2006/main">
               <a:ext uri="{FF2B5EF4-FFF2-40B4-BE49-F238E27FC236}">
-                <a16:creationId xmlns:a16="http://schemas.microsoft.com/office/drawing/2014/main" id="{9897839E-4D6C-4FEF-BD56-38180A83B48E}"/>
+                <a16:creationId xmlns:a16="http://schemas.microsoft.com/office/drawing/2014/main" id="{65AFC1C3-286B-4E10-B0E8-BCCCE6EE6659}"/>
               </a:ext>
             </a:extLst>
           </p:cNvPr>
@@ -8247,7 +8247,7 @@
           <p:cNvPr id="11" name="f31">
             <a:extLst xmlns:a="http://schemas.openxmlformats.org/drawingml/2006/main">
               <a:ext uri="{FF2B5EF4-FFF2-40B4-BE49-F238E27FC236}">
-                <a16:creationId xmlns:a16="http://schemas.microsoft.com/office/drawing/2014/main" id="{7FCFB39E-D74F-46AD-95CF-A8C746633E73}"/>
+                <a16:creationId xmlns:a16="http://schemas.microsoft.com/office/drawing/2014/main" id="{83831625-D1C1-4BCA-AD07-5408A5954A5D}"/>
               </a:ext>
             </a:extLst>
           </p:cNvPr>
@@ -8282,7 +8282,7 @@
           <p:cNvPr id="12" name="f32">
             <a:extLst xmlns:a="http://schemas.openxmlformats.org/drawingml/2006/main">
               <a:ext uri="{FF2B5EF4-FFF2-40B4-BE49-F238E27FC236}">
-                <a16:creationId xmlns:a16="http://schemas.microsoft.com/office/drawing/2014/main" id="{B009BCE6-6CDA-47EB-87ED-36AF1A5EA43C}"/>
+                <a16:creationId xmlns:a16="http://schemas.microsoft.com/office/drawing/2014/main" id="{61968A65-63BE-4233-9C04-F239C6FBDD1F}"/>
               </a:ext>
             </a:extLst>
           </p:cNvPr>
@@ -8313,7 +8313,7 @@
           <p:cNvPr id="13" name="f33">
             <a:extLst xmlns:a="http://schemas.openxmlformats.org/drawingml/2006/main">
               <a:ext uri="{FF2B5EF4-FFF2-40B4-BE49-F238E27FC236}">
-                <a16:creationId xmlns:a16="http://schemas.microsoft.com/office/drawing/2014/main" id="{5A75314C-94B8-485F-BB9D-7EA33DC90F16}"/>
+                <a16:creationId xmlns:a16="http://schemas.microsoft.com/office/drawing/2014/main" id="{C9D37ED6-AB6B-4EE4-9716-F72A1A5865E2}"/>
               </a:ext>
             </a:extLst>
           </p:cNvPr>
@@ -8346,7 +8346,7 @@
           <p:cNvPr id="14" name="f34">
             <a:extLst xmlns:a="http://schemas.openxmlformats.org/drawingml/2006/main">
               <a:ext uri="{FF2B5EF4-FFF2-40B4-BE49-F238E27FC236}">
-                <a16:creationId xmlns:a16="http://schemas.microsoft.com/office/drawing/2014/main" id="{7643CF38-1340-4592-A2E6-67F7DED538C0}"/>
+                <a16:creationId xmlns:a16="http://schemas.microsoft.com/office/drawing/2014/main" id="{40C41A39-82B6-4C8E-9572-BEA6200E9A64}"/>
               </a:ext>
             </a:extLst>
           </p:cNvPr>
@@ -8379,7 +8379,7 @@
           <p:cNvPr id="15" name="f35">
             <a:extLst xmlns:a="http://schemas.openxmlformats.org/drawingml/2006/main">
               <a:ext uri="{FF2B5EF4-FFF2-40B4-BE49-F238E27FC236}">
-                <a16:creationId xmlns:a16="http://schemas.microsoft.com/office/drawing/2014/main" id="{348FB94F-DECA-414B-8546-6F639B1E122E}"/>
+                <a16:creationId xmlns:a16="http://schemas.microsoft.com/office/drawing/2014/main" id="{0A876F6D-9433-4247-91B2-82B8A31C2C72}"/>
               </a:ext>
             </a:extLst>
           </p:cNvPr>
@@ -8412,7 +8412,7 @@
           <p:cNvPr id="16" name="f36">
             <a:extLst xmlns:a="http://schemas.openxmlformats.org/drawingml/2006/main">
               <a:ext uri="{FF2B5EF4-FFF2-40B4-BE49-F238E27FC236}">
-                <a16:creationId xmlns:a16="http://schemas.microsoft.com/office/drawing/2014/main" id="{4E443ABD-BAFD-4850-A886-B611BAC6E1C5}"/>
+                <a16:creationId xmlns:a16="http://schemas.microsoft.com/office/drawing/2014/main" id="{A9477BDD-1EC2-4B68-BA33-49CE2EFCC03B}"/>
               </a:ext>
             </a:extLst>
           </p:cNvPr>
@@ -8571,7 +8571,7 @@
           <p:cNvPr id="17" name="f37">
             <a:extLst xmlns:a="http://schemas.openxmlformats.org/drawingml/2006/main">
               <a:ext uri="{FF2B5EF4-FFF2-40B4-BE49-F238E27FC236}">
-                <a16:creationId xmlns:a16="http://schemas.microsoft.com/office/drawing/2014/main" id="{F3B1FB7D-C9D0-48F0-A554-34E3CD965153}"/>
+                <a16:creationId xmlns:a16="http://schemas.microsoft.com/office/drawing/2014/main" id="{AA00C338-104F-44AD-8EF0-05D4C2BC342E}"/>
               </a:ext>
             </a:extLst>
           </p:cNvPr>
@@ -8602,7 +8602,7 @@
           <p:cNvPr id="18" name="f38">
             <a:extLst xmlns:a="http://schemas.openxmlformats.org/drawingml/2006/main">
               <a:ext uri="{FF2B5EF4-FFF2-40B4-BE49-F238E27FC236}">
-                <a16:creationId xmlns:a16="http://schemas.microsoft.com/office/drawing/2014/main" id="{B8692C49-10FD-4578-8EFD-94FF07EE300F}"/>
+                <a16:creationId xmlns:a16="http://schemas.microsoft.com/office/drawing/2014/main" id="{63966254-0311-41AA-8142-B9592A0EB54B}"/>
               </a:ext>
             </a:extLst>
           </p:cNvPr>
@@ -8633,7 +8633,7 @@
           <p:cNvPr id="19" name="f39">
             <a:extLst xmlns:a="http://schemas.openxmlformats.org/drawingml/2006/main">
               <a:ext uri="{FF2B5EF4-FFF2-40B4-BE49-F238E27FC236}">
-                <a16:creationId xmlns:a16="http://schemas.microsoft.com/office/drawing/2014/main" id="{E876AB3B-34AA-4900-9534-E14CAE3C5A60}"/>
+                <a16:creationId xmlns:a16="http://schemas.microsoft.com/office/drawing/2014/main" id="{F0256E74-B2CF-429F-A9A6-A824A4AB8E5F}"/>
               </a:ext>
             </a:extLst>
           </p:cNvPr>
@@ -8668,7 +8668,7 @@
           <p:cNvPr id="20" name="f40">
             <a:extLst xmlns:a="http://schemas.openxmlformats.org/drawingml/2006/main">
               <a:ext uri="{FF2B5EF4-FFF2-40B4-BE49-F238E27FC236}">
-                <a16:creationId xmlns:a16="http://schemas.microsoft.com/office/drawing/2014/main" id="{A3E4CCE4-D2B3-4EBA-9838-24567C88DCCD}"/>
+                <a16:creationId xmlns:a16="http://schemas.microsoft.com/office/drawing/2014/main" id="{ADD07E89-C783-432A-86EA-1E8A2EB35696}"/>
               </a:ext>
             </a:extLst>
           </p:cNvPr>
@@ -8850,7 +8850,7 @@
           <p:cNvPr id="21" name="f41">
             <a:extLst xmlns:a="http://schemas.openxmlformats.org/drawingml/2006/main">
               <a:ext uri="{FF2B5EF4-FFF2-40B4-BE49-F238E27FC236}">
-                <a16:creationId xmlns:a16="http://schemas.microsoft.com/office/drawing/2014/main" id="{45844FDF-42E0-4654-865E-23EA559C4A33}"/>
+                <a16:creationId xmlns:a16="http://schemas.microsoft.com/office/drawing/2014/main" id="{466285EF-0541-4BB1-87A5-B0F01E766C1D}"/>
               </a:ext>
             </a:extLst>
           </p:cNvPr>
@@ -9032,7 +9032,7 @@
           <p:cNvPr id="22" name="f42">
             <a:extLst xmlns:a="http://schemas.openxmlformats.org/drawingml/2006/main">
               <a:ext uri="{FF2B5EF4-FFF2-40B4-BE49-F238E27FC236}">
-                <a16:creationId xmlns:a16="http://schemas.microsoft.com/office/drawing/2014/main" id="{CEDEEDD2-FE46-47C6-B75D-26985BA178A6}"/>
+                <a16:creationId xmlns:a16="http://schemas.microsoft.com/office/drawing/2014/main" id="{207A288C-FFB1-49A1-814B-1EE2623A8F95}"/>
               </a:ext>
             </a:extLst>
           </p:cNvPr>
@@ -9191,7 +9191,7 @@
           <p:cNvPr id="23" name="f43">
             <a:extLst xmlns:a="http://schemas.openxmlformats.org/drawingml/2006/main">
               <a:ext uri="{FF2B5EF4-FFF2-40B4-BE49-F238E27FC236}">
-                <a16:creationId xmlns:a16="http://schemas.microsoft.com/office/drawing/2014/main" id="{4E4A79A7-2C64-42E3-B79B-0EE162F4314B}"/>
+                <a16:creationId xmlns:a16="http://schemas.microsoft.com/office/drawing/2014/main" id="{FA7E283C-BFE6-4D57-9860-EF206CF95E36}"/>
               </a:ext>
             </a:extLst>
           </p:cNvPr>
@@ -9348,7 +9348,7 @@
     </p:spTree>
     <p:extLst>
       <p:ext uri="{BB962C8B-B14F-4D97-AF65-F5344CB8AC3E}">
-        <p14:creationId xmlns:p14="http://schemas.microsoft.com/office/powerpoint/2010/main" val="1146686997"/>
+        <p14:creationId xmlns:p14="http://schemas.microsoft.com/office/powerpoint/2010/main" val="113949665"/>
       </p:ext>
     </p:extLst>
   </p:cSld>
@@ -9379,7 +9379,7 @@
           <p:cNvPr id="24" name="">
             <a:extLst xmlns:a="http://schemas.openxmlformats.org/drawingml/2006/main">
               <a:ext uri="{FF2B5EF4-FFF2-40B4-BE49-F238E27FC236}">
-                <a16:creationId xmlns:a16="http://schemas.microsoft.com/office/drawing/2014/main" id="{ECFB977D-8279-43EF-97D8-E47214A8032F}"/>
+                <a16:creationId xmlns:a16="http://schemas.microsoft.com/office/drawing/2014/main" id="{0F7A68C0-D7A3-4550-9A16-6A4D4D1C8BE7}"/>
               </a:ext>
             </a:extLst>
           </p:cNvPr>
@@ -9389,7 +9389,7 @@
           <p:nvPr/>
         </p:nvPicPr>
         <p:blipFill>
-          <a:blip xmlns:r="http://schemas.openxmlformats.org/officeDocument/2006/relationships" xmlns:a="http://schemas.openxmlformats.org/drawingml/2006/main" r:embed="Rd0a5feae76b944e6"/>
+          <a:blip xmlns:r="http://schemas.openxmlformats.org/officeDocument/2006/relationships" xmlns:a="http://schemas.openxmlformats.org/drawingml/2006/main" r:embed="R9d0302bf288f4e89"/>
           <a:stretch xmlns:a="http://schemas.openxmlformats.org/drawingml/2006/main"/>
         </p:blipFill>
         <p:spPr>
@@ -9407,7 +9407,7 @@
           <p:cNvPr id="2" name="f45">
             <a:extLst xmlns:a="http://schemas.openxmlformats.org/drawingml/2006/main">
               <a:ext uri="{FF2B5EF4-FFF2-40B4-BE49-F238E27FC236}">
-                <a16:creationId xmlns:a16="http://schemas.microsoft.com/office/drawing/2014/main" id="{576ACBFC-237A-4751-BA18-76E2E00695F7}"/>
+                <a16:creationId xmlns:a16="http://schemas.microsoft.com/office/drawing/2014/main" id="{5992C5EF-6603-449B-A18F-86CF7EF05CAF}"/>
               </a:ext>
             </a:extLst>
           </p:cNvPr>
@@ -9566,7 +9566,7 @@
           <p:cNvPr id="3" name="f46">
             <a:extLst xmlns:a="http://schemas.openxmlformats.org/drawingml/2006/main">
               <a:ext uri="{FF2B5EF4-FFF2-40B4-BE49-F238E27FC236}">
-                <a16:creationId xmlns:a16="http://schemas.microsoft.com/office/drawing/2014/main" id="{4C82BF1A-34C9-42F3-B19F-E59241AB00AB}"/>
+                <a16:creationId xmlns:a16="http://schemas.microsoft.com/office/drawing/2014/main" id="{315C530E-DDA1-4ADD-8D13-951385E7B1F5}"/>
               </a:ext>
             </a:extLst>
           </p:cNvPr>
@@ -9725,7 +9725,7 @@
           <p:cNvPr id="4" name="f47">
             <a:extLst xmlns:a="http://schemas.openxmlformats.org/drawingml/2006/main">
               <a:ext uri="{FF2B5EF4-FFF2-40B4-BE49-F238E27FC236}">
-                <a16:creationId xmlns:a16="http://schemas.microsoft.com/office/drawing/2014/main" id="{97B3E269-D7CC-4DAF-9414-04C3B71BCA46}"/>
+                <a16:creationId xmlns:a16="http://schemas.microsoft.com/office/drawing/2014/main" id="{BED93621-8B2A-4BC1-A870-DEA6A5DCC928}"/>
               </a:ext>
             </a:extLst>
           </p:cNvPr>
@@ -9884,7 +9884,7 @@
           <p:cNvPr id="5" name="f48">
             <a:extLst xmlns:a="http://schemas.openxmlformats.org/drawingml/2006/main">
               <a:ext uri="{FF2B5EF4-FFF2-40B4-BE49-F238E27FC236}">
-                <a16:creationId xmlns:a16="http://schemas.microsoft.com/office/drawing/2014/main" id="{B0533A93-4A52-4564-BF93-E5189E9D23BB}"/>
+                <a16:creationId xmlns:a16="http://schemas.microsoft.com/office/drawing/2014/main" id="{FBAACD3F-1183-4DB2-9B53-3D9E3DB82D0A}"/>
               </a:ext>
             </a:extLst>
           </p:cNvPr>
@@ -10043,7 +10043,7 @@
           <p:cNvPr id="6" name="f49">
             <a:extLst xmlns:a="http://schemas.openxmlformats.org/drawingml/2006/main">
               <a:ext uri="{FF2B5EF4-FFF2-40B4-BE49-F238E27FC236}">
-                <a16:creationId xmlns:a16="http://schemas.microsoft.com/office/drawing/2014/main" id="{C03E6A25-31DE-4875-8169-75F8E163B6D4}"/>
+                <a16:creationId xmlns:a16="http://schemas.microsoft.com/office/drawing/2014/main" id="{3E5D2824-EA93-4275-B84C-CC269BCA151B}"/>
               </a:ext>
             </a:extLst>
           </p:cNvPr>
@@ -10202,7 +10202,7 @@
           <p:cNvPr id="7" name="f50">
             <a:extLst xmlns:a="http://schemas.openxmlformats.org/drawingml/2006/main">
               <a:ext uri="{FF2B5EF4-FFF2-40B4-BE49-F238E27FC236}">
-                <a16:creationId xmlns:a16="http://schemas.microsoft.com/office/drawing/2014/main" id="{02CA44F8-D079-4607-8E06-21353D929D67}"/>
+                <a16:creationId xmlns:a16="http://schemas.microsoft.com/office/drawing/2014/main" id="{B116F515-C303-4C8D-BC0E-F8080B1FF835}"/>
               </a:ext>
             </a:extLst>
           </p:cNvPr>
@@ -10361,7 +10361,7 @@
           <p:cNvPr id="8" name="f51">
             <a:extLst xmlns:a="http://schemas.openxmlformats.org/drawingml/2006/main">
               <a:ext uri="{FF2B5EF4-FFF2-40B4-BE49-F238E27FC236}">
-                <a16:creationId xmlns:a16="http://schemas.microsoft.com/office/drawing/2014/main" id="{0586F632-03AD-4CFB-A3A4-AA9E350F0A75}"/>
+                <a16:creationId xmlns:a16="http://schemas.microsoft.com/office/drawing/2014/main" id="{72245C53-B8EF-4F7E-B91D-4B04461C4D2A}"/>
               </a:ext>
             </a:extLst>
           </p:cNvPr>
@@ -10520,7 +10520,7 @@
           <p:cNvPr id="9" name="f52">
             <a:extLst xmlns:a="http://schemas.openxmlformats.org/drawingml/2006/main">
               <a:ext uri="{FF2B5EF4-FFF2-40B4-BE49-F238E27FC236}">
-                <a16:creationId xmlns:a16="http://schemas.microsoft.com/office/drawing/2014/main" id="{CF98F909-6189-4F9D-9295-8D82B6CFE8E9}"/>
+                <a16:creationId xmlns:a16="http://schemas.microsoft.com/office/drawing/2014/main" id="{D447A4CD-1085-4628-8EE1-FB081DE0F030}"/>
               </a:ext>
             </a:extLst>
           </p:cNvPr>
@@ -10679,7 +10679,7 @@
           <p:cNvPr id="10" name="f53">
             <a:extLst xmlns:a="http://schemas.openxmlformats.org/drawingml/2006/main">
               <a:ext uri="{FF2B5EF4-FFF2-40B4-BE49-F238E27FC236}">
-                <a16:creationId xmlns:a16="http://schemas.microsoft.com/office/drawing/2014/main" id="{4892DF77-C826-4D21-AA87-2817BA442855}"/>
+                <a16:creationId xmlns:a16="http://schemas.microsoft.com/office/drawing/2014/main" id="{76C777F7-B23C-4C96-98B7-07E51B9C2698}"/>
               </a:ext>
             </a:extLst>
           </p:cNvPr>
@@ -10838,7 +10838,7 @@
           <p:cNvPr id="11" name="f54">
             <a:extLst xmlns:a="http://schemas.openxmlformats.org/drawingml/2006/main">
               <a:ext uri="{FF2B5EF4-FFF2-40B4-BE49-F238E27FC236}">
-                <a16:creationId xmlns:a16="http://schemas.microsoft.com/office/drawing/2014/main" id="{C016C60D-BDB2-4445-BAF2-94B970010086}"/>
+                <a16:creationId xmlns:a16="http://schemas.microsoft.com/office/drawing/2014/main" id="{1D384CA9-A6BB-43A1-9904-A3B38CE4F9D7}"/>
               </a:ext>
             </a:extLst>
           </p:cNvPr>
@@ -10997,7 +10997,7 @@
           <p:cNvPr id="12" name="f55">
             <a:extLst xmlns:a="http://schemas.openxmlformats.org/drawingml/2006/main">
               <a:ext uri="{FF2B5EF4-FFF2-40B4-BE49-F238E27FC236}">
-                <a16:creationId xmlns:a16="http://schemas.microsoft.com/office/drawing/2014/main" id="{879A09D1-27B2-402D-9994-5536F78C75E8}"/>
+                <a16:creationId xmlns:a16="http://schemas.microsoft.com/office/drawing/2014/main" id="{0601A362-D066-4952-959D-5460316D6E84}"/>
               </a:ext>
             </a:extLst>
           </p:cNvPr>
@@ -11156,7 +11156,7 @@
           <p:cNvPr id="13" name="f56">
             <a:extLst xmlns:a="http://schemas.openxmlformats.org/drawingml/2006/main">
               <a:ext uri="{FF2B5EF4-FFF2-40B4-BE49-F238E27FC236}">
-                <a16:creationId xmlns:a16="http://schemas.microsoft.com/office/drawing/2014/main" id="{6E25D707-6C7E-41D0-8ACF-31B3AD1E79BD}"/>
+                <a16:creationId xmlns:a16="http://schemas.microsoft.com/office/drawing/2014/main" id="{D05303F4-62BB-408A-8333-A31BD2B55E1E}"/>
               </a:ext>
             </a:extLst>
           </p:cNvPr>
@@ -11315,7 +11315,7 @@
           <p:cNvPr id="14" name="f57">
             <a:extLst xmlns:a="http://schemas.openxmlformats.org/drawingml/2006/main">
               <a:ext uri="{FF2B5EF4-FFF2-40B4-BE49-F238E27FC236}">
-                <a16:creationId xmlns:a16="http://schemas.microsoft.com/office/drawing/2014/main" id="{259483BB-6B59-4603-A9CD-94BEBC4172D1}"/>
+                <a16:creationId xmlns:a16="http://schemas.microsoft.com/office/drawing/2014/main" id="{D89F1ECC-2672-4C69-9058-95CD1CDB5CA4}"/>
               </a:ext>
             </a:extLst>
           </p:cNvPr>
@@ -11474,7 +11474,7 @@
           <p:cNvPr id="15" name="f58">
             <a:extLst xmlns:a="http://schemas.openxmlformats.org/drawingml/2006/main">
               <a:ext uri="{FF2B5EF4-FFF2-40B4-BE49-F238E27FC236}">
-                <a16:creationId xmlns:a16="http://schemas.microsoft.com/office/drawing/2014/main" id="{D06155AE-592D-4F38-80DB-E3E19510A1B5}"/>
+                <a16:creationId xmlns:a16="http://schemas.microsoft.com/office/drawing/2014/main" id="{E901E0E3-BBE6-4936-A25E-4FAA783311FB}"/>
               </a:ext>
             </a:extLst>
           </p:cNvPr>
@@ -11633,7 +11633,7 @@
           <p:cNvPr id="16" name="f59">
             <a:extLst xmlns:a="http://schemas.openxmlformats.org/drawingml/2006/main">
               <a:ext uri="{FF2B5EF4-FFF2-40B4-BE49-F238E27FC236}">
-                <a16:creationId xmlns:a16="http://schemas.microsoft.com/office/drawing/2014/main" id="{20A8554B-D348-46FD-B454-1252DB8668F7}"/>
+                <a16:creationId xmlns:a16="http://schemas.microsoft.com/office/drawing/2014/main" id="{943322A7-8FC4-4AA5-8DA7-4AD98C2EC374}"/>
               </a:ext>
             </a:extLst>
           </p:cNvPr>
@@ -11792,7 +11792,7 @@
           <p:cNvPr id="17" name="f60">
             <a:extLst xmlns:a="http://schemas.openxmlformats.org/drawingml/2006/main">
               <a:ext uri="{FF2B5EF4-FFF2-40B4-BE49-F238E27FC236}">
-                <a16:creationId xmlns:a16="http://schemas.microsoft.com/office/drawing/2014/main" id="{6E19C25A-A163-4FF7-BE2D-F3E4AD841095}"/>
+                <a16:creationId xmlns:a16="http://schemas.microsoft.com/office/drawing/2014/main" id="{8D17A2E2-EE52-4C98-AF75-AB3ACE148491}"/>
               </a:ext>
             </a:extLst>
           </p:cNvPr>
@@ -11951,7 +11951,7 @@
           <p:cNvPr id="18" name="f61">
             <a:extLst xmlns:a="http://schemas.openxmlformats.org/drawingml/2006/main">
               <a:ext uri="{FF2B5EF4-FFF2-40B4-BE49-F238E27FC236}">
-                <a16:creationId xmlns:a16="http://schemas.microsoft.com/office/drawing/2014/main" id="{A56855E0-25F1-4A89-AA2F-8ABE68290503}"/>
+                <a16:creationId xmlns:a16="http://schemas.microsoft.com/office/drawing/2014/main" id="{9ED698B5-1C3E-4943-8D72-EE626A3AD3BB}"/>
               </a:ext>
             </a:extLst>
           </p:cNvPr>
@@ -12110,7 +12110,7 @@
           <p:cNvPr id="19" name="f62">
             <a:extLst xmlns:a="http://schemas.openxmlformats.org/drawingml/2006/main">
               <a:ext uri="{FF2B5EF4-FFF2-40B4-BE49-F238E27FC236}">
-                <a16:creationId xmlns:a16="http://schemas.microsoft.com/office/drawing/2014/main" id="{D27D2D76-AAFF-4753-ACE1-B7FFA650A56F}"/>
+                <a16:creationId xmlns:a16="http://schemas.microsoft.com/office/drawing/2014/main" id="{ECD46024-5D4A-4182-80FA-39913F96F251}"/>
               </a:ext>
             </a:extLst>
           </p:cNvPr>
@@ -12269,7 +12269,7 @@
           <p:cNvPr id="20" name="f63">
             <a:extLst xmlns:a="http://schemas.openxmlformats.org/drawingml/2006/main">
               <a:ext uri="{FF2B5EF4-FFF2-40B4-BE49-F238E27FC236}">
-                <a16:creationId xmlns:a16="http://schemas.microsoft.com/office/drawing/2014/main" id="{0FE440B5-6BFD-4028-8FE1-6DBA3F946DE4}"/>
+                <a16:creationId xmlns:a16="http://schemas.microsoft.com/office/drawing/2014/main" id="{F5865B97-6B12-4EED-81AB-E47F70040FAE}"/>
               </a:ext>
             </a:extLst>
           </p:cNvPr>
@@ -12428,7 +12428,7 @@
           <p:cNvPr id="21" name="f64">
             <a:extLst xmlns:a="http://schemas.openxmlformats.org/drawingml/2006/main">
               <a:ext uri="{FF2B5EF4-FFF2-40B4-BE49-F238E27FC236}">
-                <a16:creationId xmlns:a16="http://schemas.microsoft.com/office/drawing/2014/main" id="{A4CAF0AB-FBB0-44ED-A0D9-1273A5BE74F3}"/>
+                <a16:creationId xmlns:a16="http://schemas.microsoft.com/office/drawing/2014/main" id="{FE99074B-BACB-4F21-8652-FE5EEDC24A3F}"/>
               </a:ext>
             </a:extLst>
           </p:cNvPr>
@@ -12587,7 +12587,7 @@
           <p:cNvPr id="22" name="f65">
             <a:extLst xmlns:a="http://schemas.openxmlformats.org/drawingml/2006/main">
               <a:ext uri="{FF2B5EF4-FFF2-40B4-BE49-F238E27FC236}">
-                <a16:creationId xmlns:a16="http://schemas.microsoft.com/office/drawing/2014/main" id="{0239262C-C23F-4070-81DD-D9A7F73F4AA4}"/>
+                <a16:creationId xmlns:a16="http://schemas.microsoft.com/office/drawing/2014/main" id="{65737B06-13A5-49B0-A33D-75C3896591F1}"/>
               </a:ext>
             </a:extLst>
           </p:cNvPr>
@@ -12746,7 +12746,7 @@
           <p:cNvPr id="23" name="f66">
             <a:extLst xmlns:a="http://schemas.openxmlformats.org/drawingml/2006/main">
               <a:ext uri="{FF2B5EF4-FFF2-40B4-BE49-F238E27FC236}">
-                <a16:creationId xmlns:a16="http://schemas.microsoft.com/office/drawing/2014/main" id="{32F853DE-614D-4123-AD78-719572E6561C}"/>
+                <a16:creationId xmlns:a16="http://schemas.microsoft.com/office/drawing/2014/main" id="{A22FBB40-649E-4414-B499-2F589D7D0A8B}"/>
               </a:ext>
             </a:extLst>
           </p:cNvPr>
@@ -12903,7 +12903,7 @@
     </p:spTree>
     <p:extLst>
       <p:ext uri="{BB962C8B-B14F-4D97-AF65-F5344CB8AC3E}">
-        <p14:creationId xmlns:p14="http://schemas.microsoft.com/office/powerpoint/2010/main" val="2000603175"/>
+        <p14:creationId xmlns:p14="http://schemas.microsoft.com/office/powerpoint/2010/main" val="1497803154"/>
       </p:ext>
     </p:extLst>
   </p:cSld>
@@ -12934,7 +12934,7 @@
           <p:cNvPr id="18" name="f67">
             <a:extLst xmlns:a="http://schemas.openxmlformats.org/drawingml/2006/main">
               <a:ext uri="{FF2B5EF4-FFF2-40B4-BE49-F238E27FC236}">
-                <a16:creationId xmlns:a16="http://schemas.microsoft.com/office/drawing/2014/main" id="{255D08E1-0437-468D-BDE1-B5577E6AE26E}"/>
+                <a16:creationId xmlns:a16="http://schemas.microsoft.com/office/drawing/2014/main" id="{545CF73C-0BEC-43B1-A979-8EC0BB60E1F1}"/>
               </a:ext>
             </a:extLst>
           </p:cNvPr>
@@ -13093,7 +13093,7 @@
           <p:cNvPr id="2" name="f68">
             <a:extLst xmlns:a="http://schemas.openxmlformats.org/drawingml/2006/main">
               <a:ext uri="{FF2B5EF4-FFF2-40B4-BE49-F238E27FC236}">
-                <a16:creationId xmlns:a16="http://schemas.microsoft.com/office/drawing/2014/main" id="{FF8CA1FF-1188-48F6-8875-44408809276C}"/>
+                <a16:creationId xmlns:a16="http://schemas.microsoft.com/office/drawing/2014/main" id="{9560B7C4-1830-429D-8ADC-25A32503D72A}"/>
               </a:ext>
             </a:extLst>
           </p:cNvPr>
@@ -13252,7 +13252,7 @@
           <p:cNvPr id="3" name="f69">
             <a:extLst xmlns:a="http://schemas.openxmlformats.org/drawingml/2006/main">
               <a:ext uri="{FF2B5EF4-FFF2-40B4-BE49-F238E27FC236}">
-                <a16:creationId xmlns:a16="http://schemas.microsoft.com/office/drawing/2014/main" id="{7B94911F-0594-4BF3-A932-DBD890DF4F26}"/>
+                <a16:creationId xmlns:a16="http://schemas.microsoft.com/office/drawing/2014/main" id="{3175A81D-A993-4EF3-84CA-BE44A5CFAA5C}"/>
               </a:ext>
             </a:extLst>
           </p:cNvPr>
@@ -13411,7 +13411,7 @@
           <p:cNvPr id="4" name="f70">
             <a:extLst xmlns:a="http://schemas.openxmlformats.org/drawingml/2006/main">
               <a:ext uri="{FF2B5EF4-FFF2-40B4-BE49-F238E27FC236}">
-                <a16:creationId xmlns:a16="http://schemas.microsoft.com/office/drawing/2014/main" id="{1EBBDF93-CF3A-49AC-9D02-B8B0080C9350}"/>
+                <a16:creationId xmlns:a16="http://schemas.microsoft.com/office/drawing/2014/main" id="{A2BE4953-CBEA-4FCF-A94E-41B054860346}"/>
               </a:ext>
             </a:extLst>
           </p:cNvPr>
@@ -13570,7 +13570,7 @@
           <p:cNvPr id="5" name="f103">
             <a:extLst xmlns:a="http://schemas.openxmlformats.org/drawingml/2006/main">
               <a:ext uri="{FF2B5EF4-FFF2-40B4-BE49-F238E27FC236}">
-                <a16:creationId xmlns:a16="http://schemas.microsoft.com/office/drawing/2014/main" id="{A481E2E3-E1E4-4B84-A0AE-1314B472122A}"/>
+                <a16:creationId xmlns:a16="http://schemas.microsoft.com/office/drawing/2014/main" id="{F67A86E4-0AF6-4B59-AB6A-923CB8F0428F}"/>
               </a:ext>
             </a:extLst>
           </p:cNvPr>
@@ -13729,7 +13729,7 @@
           <p:cNvPr id="6" name="f104">
             <a:extLst xmlns:a="http://schemas.openxmlformats.org/drawingml/2006/main">
               <a:ext uri="{FF2B5EF4-FFF2-40B4-BE49-F238E27FC236}">
-                <a16:creationId xmlns:a16="http://schemas.microsoft.com/office/drawing/2014/main" id="{2AB634C6-0866-4C2E-AEDC-C8B6CCFBF517}"/>
+                <a16:creationId xmlns:a16="http://schemas.microsoft.com/office/drawing/2014/main" id="{3C1F1927-3AF0-4815-98F2-5B4BAF168144}"/>
               </a:ext>
             </a:extLst>
           </p:cNvPr>
@@ -13764,7 +13764,7 @@
           <p:cNvPr id="7" name="f105">
             <a:extLst xmlns:a="http://schemas.openxmlformats.org/drawingml/2006/main">
               <a:ext uri="{FF2B5EF4-FFF2-40B4-BE49-F238E27FC236}">
-                <a16:creationId xmlns:a16="http://schemas.microsoft.com/office/drawing/2014/main" id="{431E96A3-3829-474C-BA17-125B2539F19F}"/>
+                <a16:creationId xmlns:a16="http://schemas.microsoft.com/office/drawing/2014/main" id="{D7C70755-7A6A-4A13-8EA5-C8BC0578D292}"/>
               </a:ext>
             </a:extLst>
           </p:cNvPr>
@@ -13923,7 +13923,7 @@
           <p:cNvPr id="8" name="f106">
             <a:extLst xmlns:a="http://schemas.openxmlformats.org/drawingml/2006/main">
               <a:ext uri="{FF2B5EF4-FFF2-40B4-BE49-F238E27FC236}">
-                <a16:creationId xmlns:a16="http://schemas.microsoft.com/office/drawing/2014/main" id="{D2DCB783-F272-4219-8ADE-E6890FED9051}"/>
+                <a16:creationId xmlns:a16="http://schemas.microsoft.com/office/drawing/2014/main" id="{AAE31310-9EE4-4FC6-8279-F927FB794B51}"/>
               </a:ext>
             </a:extLst>
           </p:cNvPr>
@@ -14105,7 +14105,7 @@
           <p:cNvPr id="9" name="f107">
             <a:extLst xmlns:a="http://schemas.openxmlformats.org/drawingml/2006/main">
               <a:ext uri="{FF2B5EF4-FFF2-40B4-BE49-F238E27FC236}">
-                <a16:creationId xmlns:a16="http://schemas.microsoft.com/office/drawing/2014/main" id="{7FEC5BE1-BE85-4909-9936-0AA62A21D609}"/>
+                <a16:creationId xmlns:a16="http://schemas.microsoft.com/office/drawing/2014/main" id="{AB484214-CFD6-41F5-B2B3-237ACDFCCD51}"/>
               </a:ext>
             </a:extLst>
           </p:cNvPr>
@@ -14264,7 +14264,7 @@
           <p:cNvPr id="10" name="f108">
             <a:extLst xmlns:a="http://schemas.openxmlformats.org/drawingml/2006/main">
               <a:ext uri="{FF2B5EF4-FFF2-40B4-BE49-F238E27FC236}">
-                <a16:creationId xmlns:a16="http://schemas.microsoft.com/office/drawing/2014/main" id="{1CF935D2-B439-4E75-9779-CA510D863DC8}"/>
+                <a16:creationId xmlns:a16="http://schemas.microsoft.com/office/drawing/2014/main" id="{537769B9-C798-452B-910C-91D714FAC3B4}"/>
               </a:ext>
             </a:extLst>
           </p:cNvPr>
@@ -14423,7 +14423,7 @@
           <p:cNvPr id="11" name="f109">
             <a:extLst xmlns:a="http://schemas.openxmlformats.org/drawingml/2006/main">
               <a:ext uri="{FF2B5EF4-FFF2-40B4-BE49-F238E27FC236}">
-                <a16:creationId xmlns:a16="http://schemas.microsoft.com/office/drawing/2014/main" id="{29815676-10ED-4AB7-A411-730A307FF56B}"/>
+                <a16:creationId xmlns:a16="http://schemas.microsoft.com/office/drawing/2014/main" id="{75C4B58E-F0E4-4B18-8C19-74149DB76DA5}"/>
               </a:ext>
             </a:extLst>
           </p:cNvPr>
@@ -14454,7 +14454,7 @@
           <p:cNvPr id="12" name="f110">
             <a:extLst xmlns:a="http://schemas.openxmlformats.org/drawingml/2006/main">
               <a:ext uri="{FF2B5EF4-FFF2-40B4-BE49-F238E27FC236}">
-                <a16:creationId xmlns:a16="http://schemas.microsoft.com/office/drawing/2014/main" id="{FCCCB5EE-B953-44F0-B727-376EDA83DBE1}"/>
+                <a16:creationId xmlns:a16="http://schemas.microsoft.com/office/drawing/2014/main" id="{7BE5E7DD-1480-487E-BA3E-B3B20EE8BB8F}"/>
               </a:ext>
             </a:extLst>
           </p:cNvPr>
@@ -14485,7 +14485,7 @@
           <p:cNvPr id="13" name="f111">
             <a:extLst xmlns:a="http://schemas.openxmlformats.org/drawingml/2006/main">
               <a:ext uri="{FF2B5EF4-FFF2-40B4-BE49-F238E27FC236}">
-                <a16:creationId xmlns:a16="http://schemas.microsoft.com/office/drawing/2014/main" id="{B5063897-5494-4189-8EC5-D760DA8123E2}"/>
+                <a16:creationId xmlns:a16="http://schemas.microsoft.com/office/drawing/2014/main" id="{03928440-6A9C-4EBF-BE2D-754908763346}"/>
               </a:ext>
             </a:extLst>
           </p:cNvPr>
@@ -14644,7 +14644,7 @@
           <p:cNvPr id="14" name="f112">
             <a:extLst xmlns:a="http://schemas.openxmlformats.org/drawingml/2006/main">
               <a:ext uri="{FF2B5EF4-FFF2-40B4-BE49-F238E27FC236}">
-                <a16:creationId xmlns:a16="http://schemas.microsoft.com/office/drawing/2014/main" id="{2908E1D0-E6AB-4FD8-950A-52461C9029AA}"/>
+                <a16:creationId xmlns:a16="http://schemas.microsoft.com/office/drawing/2014/main" id="{3324DF9B-6138-47DB-BF9A-6ABD5E93A602}"/>
               </a:ext>
             </a:extLst>
           </p:cNvPr>
@@ -14679,7 +14679,7 @@
           <p:cNvPr id="15" name="f113">
             <a:extLst xmlns:a="http://schemas.openxmlformats.org/drawingml/2006/main">
               <a:ext uri="{FF2B5EF4-FFF2-40B4-BE49-F238E27FC236}">
-                <a16:creationId xmlns:a16="http://schemas.microsoft.com/office/drawing/2014/main" id="{43E88327-7B0D-4327-B0E6-0DB9093961BC}"/>
+                <a16:creationId xmlns:a16="http://schemas.microsoft.com/office/drawing/2014/main" id="{EA03B86F-C636-49D2-B5DC-6318634BE198}"/>
               </a:ext>
             </a:extLst>
           </p:cNvPr>
@@ -14861,7 +14861,7 @@
           <p:cNvPr id="16" name="f114">
             <a:extLst xmlns:a="http://schemas.openxmlformats.org/drawingml/2006/main">
               <a:ext uri="{FF2B5EF4-FFF2-40B4-BE49-F238E27FC236}">
-                <a16:creationId xmlns:a16="http://schemas.microsoft.com/office/drawing/2014/main" id="{8AE1C2BE-3090-45BE-A1BA-200B5CADACEA}"/>
+                <a16:creationId xmlns:a16="http://schemas.microsoft.com/office/drawing/2014/main" id="{DF22FF0B-BDE1-4314-9B00-F5752143AF8E}"/>
               </a:ext>
             </a:extLst>
           </p:cNvPr>
@@ -14896,7 +14896,7 @@
           <p:cNvPr id="17" name="f115">
             <a:extLst xmlns:a="http://schemas.openxmlformats.org/drawingml/2006/main">
               <a:ext uri="{FF2B5EF4-FFF2-40B4-BE49-F238E27FC236}">
-                <a16:creationId xmlns:a16="http://schemas.microsoft.com/office/drawing/2014/main" id="{E39D5E44-A0AD-4E88-B586-0051B325E2F6}"/>
+                <a16:creationId xmlns:a16="http://schemas.microsoft.com/office/drawing/2014/main" id="{BC15316E-65C7-4CCE-B587-55892079EE9A}"/>
               </a:ext>
             </a:extLst>
           </p:cNvPr>
@@ -15076,7 +15076,7 @@
     </p:spTree>
     <p:extLst>
       <p:ext uri="{BB962C8B-B14F-4D97-AF65-F5344CB8AC3E}">
-        <p14:creationId xmlns:p14="http://schemas.microsoft.com/office/powerpoint/2010/main" val="1310737145"/>
+        <p14:creationId xmlns:p14="http://schemas.microsoft.com/office/powerpoint/2010/main" val="1956201557"/>
       </p:ext>
     </p:extLst>
   </p:cSld>
@@ -15107,7 +15107,7 @@
           <p:cNvPr id="15" name="">
             <a:extLst xmlns:a="http://schemas.openxmlformats.org/drawingml/2006/main">
               <a:ext uri="{FF2B5EF4-FFF2-40B4-BE49-F238E27FC236}">
-                <a16:creationId xmlns:a16="http://schemas.microsoft.com/office/drawing/2014/main" id="{C5E6AD9F-7D13-4195-B00D-988FFADB4A3A}"/>
+                <a16:creationId xmlns:a16="http://schemas.microsoft.com/office/drawing/2014/main" id="{C8F9D777-E1A4-43F8-B551-80357B7EF124}"/>
               </a:ext>
             </a:extLst>
           </p:cNvPr>
@@ -15117,7 +15117,7 @@
           <p:nvPr/>
         </p:nvPicPr>
         <p:blipFill>
-          <a:blip xmlns:r="http://schemas.openxmlformats.org/officeDocument/2006/relationships" xmlns:a="http://schemas.openxmlformats.org/drawingml/2006/main" r:embed="R29336291263940c2"/>
+          <a:blip xmlns:r="http://schemas.openxmlformats.org/officeDocument/2006/relationships" xmlns:a="http://schemas.openxmlformats.org/drawingml/2006/main" r:embed="R83fda5a7cce14a8a"/>
           <a:stretch xmlns:a="http://schemas.openxmlformats.org/drawingml/2006/main"/>
         </p:blipFill>
         <p:spPr>
@@ -15135,7 +15135,7 @@
           <p:cNvPr id="2" name="f117">
             <a:extLst xmlns:a="http://schemas.openxmlformats.org/drawingml/2006/main">
               <a:ext uri="{FF2B5EF4-FFF2-40B4-BE49-F238E27FC236}">
-                <a16:creationId xmlns:a16="http://schemas.microsoft.com/office/drawing/2014/main" id="{295DAF06-CDE0-4013-B2A5-12689AB69C1A}"/>
+                <a16:creationId xmlns:a16="http://schemas.microsoft.com/office/drawing/2014/main" id="{F93A2280-4AF7-49CE-8DCC-44A045620A9F}"/>
               </a:ext>
             </a:extLst>
           </p:cNvPr>
@@ -15294,7 +15294,7 @@
           <p:cNvPr id="3" name="f118">
             <a:extLst xmlns:a="http://schemas.openxmlformats.org/drawingml/2006/main">
               <a:ext uri="{FF2B5EF4-FFF2-40B4-BE49-F238E27FC236}">
-                <a16:creationId xmlns:a16="http://schemas.microsoft.com/office/drawing/2014/main" id="{B1623AB8-3F1D-4CEB-845E-CBAFB80D2E87}"/>
+                <a16:creationId xmlns:a16="http://schemas.microsoft.com/office/drawing/2014/main" id="{BD2C68B3-0532-496C-9C9B-696CED4429DB}"/>
               </a:ext>
             </a:extLst>
           </p:cNvPr>
@@ -15453,7 +15453,7 @@
           <p:cNvPr id="4" name="f119">
             <a:extLst xmlns:a="http://schemas.openxmlformats.org/drawingml/2006/main">
               <a:ext uri="{FF2B5EF4-FFF2-40B4-BE49-F238E27FC236}">
-                <a16:creationId xmlns:a16="http://schemas.microsoft.com/office/drawing/2014/main" id="{07294506-1286-405D-A7F9-1771A4DF11A3}"/>
+                <a16:creationId xmlns:a16="http://schemas.microsoft.com/office/drawing/2014/main" id="{DB243A82-CC6C-4797-B26D-1E59A017A2F0}"/>
               </a:ext>
             </a:extLst>
           </p:cNvPr>
@@ -15612,7 +15612,7 @@
           <p:cNvPr id="5" name="f120">
             <a:extLst xmlns:a="http://schemas.openxmlformats.org/drawingml/2006/main">
               <a:ext uri="{FF2B5EF4-FFF2-40B4-BE49-F238E27FC236}">
-                <a16:creationId xmlns:a16="http://schemas.microsoft.com/office/drawing/2014/main" id="{0E4F47FF-E296-463E-B5B5-8CF8C1A99887}"/>
+                <a16:creationId xmlns:a16="http://schemas.microsoft.com/office/drawing/2014/main" id="{E406D2AC-B4FC-4CCF-83D0-E95D95E4CFDF}"/>
               </a:ext>
             </a:extLst>
           </p:cNvPr>
@@ -15771,7 +15771,7 @@
           <p:cNvPr id="6" name="f121">
             <a:extLst xmlns:a="http://schemas.openxmlformats.org/drawingml/2006/main">
               <a:ext uri="{FF2B5EF4-FFF2-40B4-BE49-F238E27FC236}">
-                <a16:creationId xmlns:a16="http://schemas.microsoft.com/office/drawing/2014/main" id="{091B4C7F-BB90-49BF-81FB-E965F4773186}"/>
+                <a16:creationId xmlns:a16="http://schemas.microsoft.com/office/drawing/2014/main" id="{AB0C41A7-D4BF-4514-AFD8-478F40512A5A}"/>
               </a:ext>
             </a:extLst>
           </p:cNvPr>
@@ -15930,7 +15930,7 @@
           <p:cNvPr id="7" name="f122">
             <a:extLst xmlns:a="http://schemas.openxmlformats.org/drawingml/2006/main">
               <a:ext uri="{FF2B5EF4-FFF2-40B4-BE49-F238E27FC236}">
-                <a16:creationId xmlns:a16="http://schemas.microsoft.com/office/drawing/2014/main" id="{869B6067-0E57-4F04-9B79-E68D1B55ADA3}"/>
+                <a16:creationId xmlns:a16="http://schemas.microsoft.com/office/drawing/2014/main" id="{DD72C646-9259-4451-B76B-11720593C5F3}"/>
               </a:ext>
             </a:extLst>
           </p:cNvPr>
@@ -16089,7 +16089,7 @@
           <p:cNvPr id="8" name="f123">
             <a:extLst xmlns:a="http://schemas.openxmlformats.org/drawingml/2006/main">
               <a:ext uri="{FF2B5EF4-FFF2-40B4-BE49-F238E27FC236}">
-                <a16:creationId xmlns:a16="http://schemas.microsoft.com/office/drawing/2014/main" id="{00B80771-D2F1-46D7-9FB2-D296888742A3}"/>
+                <a16:creationId xmlns:a16="http://schemas.microsoft.com/office/drawing/2014/main" id="{895B7727-BDFC-46EE-BC0F-E28635CFB331}"/>
               </a:ext>
             </a:extLst>
           </p:cNvPr>
@@ -16248,7 +16248,7 @@
           <p:cNvPr id="9" name="f124">
             <a:extLst xmlns:a="http://schemas.openxmlformats.org/drawingml/2006/main">
               <a:ext uri="{FF2B5EF4-FFF2-40B4-BE49-F238E27FC236}">
-                <a16:creationId xmlns:a16="http://schemas.microsoft.com/office/drawing/2014/main" id="{31F6612A-AB6A-4E71-BE3F-21BD55D26464}"/>
+                <a16:creationId xmlns:a16="http://schemas.microsoft.com/office/drawing/2014/main" id="{208DEFF9-1E47-441E-AB3B-AF1AE78B5243}"/>
               </a:ext>
             </a:extLst>
           </p:cNvPr>
@@ -16407,7 +16407,7 @@
           <p:cNvPr id="10" name="f125">
             <a:extLst xmlns:a="http://schemas.openxmlformats.org/drawingml/2006/main">
               <a:ext uri="{FF2B5EF4-FFF2-40B4-BE49-F238E27FC236}">
-                <a16:creationId xmlns:a16="http://schemas.microsoft.com/office/drawing/2014/main" id="{FC953AEB-AFA5-4657-B41E-67682C157F67}"/>
+                <a16:creationId xmlns:a16="http://schemas.microsoft.com/office/drawing/2014/main" id="{26CD5067-81EE-409B-98FF-9BF3949749F2}"/>
               </a:ext>
             </a:extLst>
           </p:cNvPr>
@@ -16566,7 +16566,7 @@
           <p:cNvPr id="11" name="f126">
             <a:extLst xmlns:a="http://schemas.openxmlformats.org/drawingml/2006/main">
               <a:ext uri="{FF2B5EF4-FFF2-40B4-BE49-F238E27FC236}">
-                <a16:creationId xmlns:a16="http://schemas.microsoft.com/office/drawing/2014/main" id="{A09E4266-9833-4D9A-914A-FB514FA0D5CD}"/>
+                <a16:creationId xmlns:a16="http://schemas.microsoft.com/office/drawing/2014/main" id="{465CF1E0-1A5A-42DB-A850-E84516741D38}"/>
               </a:ext>
             </a:extLst>
           </p:cNvPr>
@@ -16725,7 +16725,7 @@
           <p:cNvPr id="12" name="f127">
             <a:extLst xmlns:a="http://schemas.openxmlformats.org/drawingml/2006/main">
               <a:ext uri="{FF2B5EF4-FFF2-40B4-BE49-F238E27FC236}">
-                <a16:creationId xmlns:a16="http://schemas.microsoft.com/office/drawing/2014/main" id="{953778B1-2F3F-4072-AE82-1AC7D7E1E07B}"/>
+                <a16:creationId xmlns:a16="http://schemas.microsoft.com/office/drawing/2014/main" id="{55350AAD-EF17-42D3-BB34-1D5C4DC5927D}"/>
               </a:ext>
             </a:extLst>
           </p:cNvPr>
@@ -16884,7 +16884,7 @@
           <p:cNvPr id="13" name="f128">
             <a:extLst xmlns:a="http://schemas.openxmlformats.org/drawingml/2006/main">
               <a:ext uri="{FF2B5EF4-FFF2-40B4-BE49-F238E27FC236}">
-                <a16:creationId xmlns:a16="http://schemas.microsoft.com/office/drawing/2014/main" id="{9D7738C4-20A3-4854-AD95-3703EACA77E0}"/>
+                <a16:creationId xmlns:a16="http://schemas.microsoft.com/office/drawing/2014/main" id="{EE90AC2C-62E1-4571-9089-8045E79F5162}"/>
               </a:ext>
             </a:extLst>
           </p:cNvPr>
@@ -17043,7 +17043,7 @@
           <p:cNvPr id="14" name="f129">
             <a:extLst xmlns:a="http://schemas.openxmlformats.org/drawingml/2006/main">
               <a:ext uri="{FF2B5EF4-FFF2-40B4-BE49-F238E27FC236}">
-                <a16:creationId xmlns:a16="http://schemas.microsoft.com/office/drawing/2014/main" id="{8FB89AEE-E822-4EBC-A85A-CDD54F363A5B}"/>
+                <a16:creationId xmlns:a16="http://schemas.microsoft.com/office/drawing/2014/main" id="{766F869A-E726-4593-9DBD-CE8FB5DE151F}"/>
               </a:ext>
             </a:extLst>
           </p:cNvPr>
@@ -17200,7 +17200,7 @@
     </p:spTree>
     <p:extLst>
       <p:ext uri="{BB962C8B-B14F-4D97-AF65-F5344CB8AC3E}">
-        <p14:creationId xmlns:p14="http://schemas.microsoft.com/office/powerpoint/2010/main" val="1014993930"/>
+        <p14:creationId xmlns:p14="http://schemas.microsoft.com/office/powerpoint/2010/main" val="1709248655"/>
       </p:ext>
     </p:extLst>
   </p:cSld>
@@ -17231,7 +17231,7 @@
           <p:cNvPr id="13" name="f130">
             <a:extLst xmlns:a="http://schemas.openxmlformats.org/drawingml/2006/main">
               <a:ext uri="{FF2B5EF4-FFF2-40B4-BE49-F238E27FC236}">
-                <a16:creationId xmlns:a16="http://schemas.microsoft.com/office/drawing/2014/main" id="{A7A95DF2-2918-41A1-BA68-7835142227B0}"/>
+                <a16:creationId xmlns:a16="http://schemas.microsoft.com/office/drawing/2014/main" id="{B9F134A7-2553-443B-BAAF-88BB7082857F}"/>
               </a:ext>
             </a:extLst>
           </p:cNvPr>
@@ -17390,7 +17390,7 @@
           <p:cNvPr id="2" name="f131">
             <a:extLst xmlns:a="http://schemas.openxmlformats.org/drawingml/2006/main">
               <a:ext uri="{FF2B5EF4-FFF2-40B4-BE49-F238E27FC236}">
-                <a16:creationId xmlns:a16="http://schemas.microsoft.com/office/drawing/2014/main" id="{91EC9E79-1DC0-41E5-91AF-CF779DA75CB1}"/>
+                <a16:creationId xmlns:a16="http://schemas.microsoft.com/office/drawing/2014/main" id="{1577DC9F-7E60-496B-A4B9-96DEDDB0074E}"/>
               </a:ext>
             </a:extLst>
           </p:cNvPr>
@@ -17549,7 +17549,7 @@
           <p:cNvPr id="3" name="f132">
             <a:extLst xmlns:a="http://schemas.openxmlformats.org/drawingml/2006/main">
               <a:ext uri="{FF2B5EF4-FFF2-40B4-BE49-F238E27FC236}">
-                <a16:creationId xmlns:a16="http://schemas.microsoft.com/office/drawing/2014/main" id="{24350F58-6637-441C-964F-54AB304E9001}"/>
+                <a16:creationId xmlns:a16="http://schemas.microsoft.com/office/drawing/2014/main" id="{EA975D8F-053D-4C23-8214-B7A781811DDC}"/>
               </a:ext>
             </a:extLst>
           </p:cNvPr>
@@ -17708,7 +17708,7 @@
           <p:cNvPr id="4" name="f133">
             <a:extLst xmlns:a="http://schemas.openxmlformats.org/drawingml/2006/main">
               <a:ext uri="{FF2B5EF4-FFF2-40B4-BE49-F238E27FC236}">
-                <a16:creationId xmlns:a16="http://schemas.microsoft.com/office/drawing/2014/main" id="{09282848-AFBA-47CC-BEA0-50361F52A927}"/>
+                <a16:creationId xmlns:a16="http://schemas.microsoft.com/office/drawing/2014/main" id="{86E9D298-5B4B-4903-B2DF-9DD2E9FFC289}"/>
               </a:ext>
             </a:extLst>
           </p:cNvPr>
@@ -17867,7 +17867,7 @@
           <p:cNvPr id="5" name="">
             <a:extLst xmlns:a="http://schemas.openxmlformats.org/drawingml/2006/main">
               <a:ext uri="{FF2B5EF4-FFF2-40B4-BE49-F238E27FC236}">
-                <a16:creationId xmlns:a16="http://schemas.microsoft.com/office/drawing/2014/main" id="{9015D807-AD40-47EA-A838-BE588142CD4C}"/>
+                <a16:creationId xmlns:a16="http://schemas.microsoft.com/office/drawing/2014/main" id="{F8DA9346-2B98-4D15-9131-231B17AC9B4B}"/>
               </a:ext>
             </a:extLst>
           </p:cNvPr>
@@ -18703,7 +18703,7 @@
           <p:cNvPr id="6" name="f135">
             <a:extLst xmlns:a="http://schemas.openxmlformats.org/drawingml/2006/main">
               <a:ext uri="{FF2B5EF4-FFF2-40B4-BE49-F238E27FC236}">
-                <a16:creationId xmlns:a16="http://schemas.microsoft.com/office/drawing/2014/main" id="{486D6312-8D01-4644-A694-264A3068E37B}"/>
+                <a16:creationId xmlns:a16="http://schemas.microsoft.com/office/drawing/2014/main" id="{12D38032-58C5-449D-A7ED-AE51621B547D}"/>
               </a:ext>
             </a:extLst>
           </p:cNvPr>
@@ -18738,7 +18738,7 @@
           <p:cNvPr id="7" name="f136">
             <a:extLst xmlns:a="http://schemas.openxmlformats.org/drawingml/2006/main">
               <a:ext uri="{FF2B5EF4-FFF2-40B4-BE49-F238E27FC236}">
-                <a16:creationId xmlns:a16="http://schemas.microsoft.com/office/drawing/2014/main" id="{AFCF6CF6-1D69-4136-A704-E490750D7594}"/>
+                <a16:creationId xmlns:a16="http://schemas.microsoft.com/office/drawing/2014/main" id="{67039B0F-FDDD-43D5-9D8C-81F083184126}"/>
               </a:ext>
             </a:extLst>
           </p:cNvPr>
@@ -18897,7 +18897,7 @@
           <p:cNvPr id="8" name="f137">
             <a:extLst xmlns:a="http://schemas.openxmlformats.org/drawingml/2006/main">
               <a:ext uri="{FF2B5EF4-FFF2-40B4-BE49-F238E27FC236}">
-                <a16:creationId xmlns:a16="http://schemas.microsoft.com/office/drawing/2014/main" id="{07D1AA39-6FDE-4E42-8F79-BB75243D3945}"/>
+                <a16:creationId xmlns:a16="http://schemas.microsoft.com/office/drawing/2014/main" id="{D6DD3E92-7CC1-48F7-8EB4-63F0771253B2}"/>
               </a:ext>
             </a:extLst>
           </p:cNvPr>
@@ -19056,7 +19056,7 @@
           <p:cNvPr id="9" name="f138">
             <a:extLst xmlns:a="http://schemas.openxmlformats.org/drawingml/2006/main">
               <a:ext uri="{FF2B5EF4-FFF2-40B4-BE49-F238E27FC236}">
-                <a16:creationId xmlns:a16="http://schemas.microsoft.com/office/drawing/2014/main" id="{CAC0245E-D0BA-4A77-92E8-829E218D8F0C}"/>
+                <a16:creationId xmlns:a16="http://schemas.microsoft.com/office/drawing/2014/main" id="{09C16576-BEF8-468E-90C6-6A1D40FF337A}"/>
               </a:ext>
             </a:extLst>
           </p:cNvPr>
@@ -19215,7 +19215,7 @@
           <p:cNvPr id="10" name="f139">
             <a:extLst xmlns:a="http://schemas.openxmlformats.org/drawingml/2006/main">
               <a:ext uri="{FF2B5EF4-FFF2-40B4-BE49-F238E27FC236}">
-                <a16:creationId xmlns:a16="http://schemas.microsoft.com/office/drawing/2014/main" id="{79A590FB-C80F-4005-B159-91E1D65976CD}"/>
+                <a16:creationId xmlns:a16="http://schemas.microsoft.com/office/drawing/2014/main" id="{83180A38-5E26-474E-9109-C3C4FAB3F3DC}"/>
               </a:ext>
             </a:extLst>
           </p:cNvPr>
@@ -19374,7 +19374,7 @@
           <p:cNvPr id="11" name="f140">
             <a:extLst xmlns:a="http://schemas.openxmlformats.org/drawingml/2006/main">
               <a:ext uri="{FF2B5EF4-FFF2-40B4-BE49-F238E27FC236}">
-                <a16:creationId xmlns:a16="http://schemas.microsoft.com/office/drawing/2014/main" id="{FE02C749-3470-4E87-B5DA-AAF190483A7C}"/>
+                <a16:creationId xmlns:a16="http://schemas.microsoft.com/office/drawing/2014/main" id="{B8D92E61-4F87-4443-A7F3-78FBBBCAD62C}"/>
               </a:ext>
             </a:extLst>
           </p:cNvPr>
@@ -19533,7 +19533,7 @@
           <p:cNvPr id="12" name="f141">
             <a:extLst xmlns:a="http://schemas.openxmlformats.org/drawingml/2006/main">
               <a:ext uri="{FF2B5EF4-FFF2-40B4-BE49-F238E27FC236}">
-                <a16:creationId xmlns:a16="http://schemas.microsoft.com/office/drawing/2014/main" id="{403708EC-3106-47B0-A556-C413DA3E7C3D}"/>
+                <a16:creationId xmlns:a16="http://schemas.microsoft.com/office/drawing/2014/main" id="{5B4F2F00-5964-4DCA-9A66-CCB3735406BB}"/>
               </a:ext>
             </a:extLst>
           </p:cNvPr>
@@ -19690,7 +19690,7 @@
     </p:spTree>
     <p:extLst>
       <p:ext uri="{BB962C8B-B14F-4D97-AF65-F5344CB8AC3E}">
-        <p14:creationId xmlns:p14="http://schemas.microsoft.com/office/powerpoint/2010/main" val="1493251670"/>
+        <p14:creationId xmlns:p14="http://schemas.microsoft.com/office/powerpoint/2010/main" val="1615713505"/>
       </p:ext>
     </p:extLst>
   </p:cSld>
@@ -19721,7 +19721,7 @@
           <p:cNvPr id="49" name="f142">
             <a:extLst xmlns:a="http://schemas.openxmlformats.org/drawingml/2006/main">
               <a:ext uri="{FF2B5EF4-FFF2-40B4-BE49-F238E27FC236}">
-                <a16:creationId xmlns:a16="http://schemas.microsoft.com/office/drawing/2014/main" id="{60121B99-A88B-4D19-8406-0857731F4A50}"/>
+                <a16:creationId xmlns:a16="http://schemas.microsoft.com/office/drawing/2014/main" id="{A7843F50-B1DF-427B-9879-F6C88943F79C}"/>
               </a:ext>
             </a:extLst>
           </p:cNvPr>
@@ -19880,7 +19880,7 @@
           <p:cNvPr id="2" name="f143">
             <a:extLst xmlns:a="http://schemas.openxmlformats.org/drawingml/2006/main">
               <a:ext uri="{FF2B5EF4-FFF2-40B4-BE49-F238E27FC236}">
-                <a16:creationId xmlns:a16="http://schemas.microsoft.com/office/drawing/2014/main" id="{217195AB-E189-4BD9-9DD0-E3CB172E7B8E}"/>
+                <a16:creationId xmlns:a16="http://schemas.microsoft.com/office/drawing/2014/main" id="{9012041B-1DC9-43BB-AA60-B3DFCF986FEA}"/>
               </a:ext>
             </a:extLst>
           </p:cNvPr>
@@ -20039,7 +20039,7 @@
           <p:cNvPr id="3" name="f144">
             <a:extLst xmlns:a="http://schemas.openxmlformats.org/drawingml/2006/main">
               <a:ext uri="{FF2B5EF4-FFF2-40B4-BE49-F238E27FC236}">
-                <a16:creationId xmlns:a16="http://schemas.microsoft.com/office/drawing/2014/main" id="{A50EB6C3-405D-4465-B6C0-0F2D7FE5124C}"/>
+                <a16:creationId xmlns:a16="http://schemas.microsoft.com/office/drawing/2014/main" id="{C99CE9FE-9A76-469C-9DCB-8E89B54FF45F}"/>
               </a:ext>
             </a:extLst>
           </p:cNvPr>
@@ -20198,7 +20198,7 @@
           <p:cNvPr id="4" name="f145">
             <a:extLst xmlns:a="http://schemas.openxmlformats.org/drawingml/2006/main">
               <a:ext uri="{FF2B5EF4-FFF2-40B4-BE49-F238E27FC236}">
-                <a16:creationId xmlns:a16="http://schemas.microsoft.com/office/drawing/2014/main" id="{EE2ED967-E571-41BA-B636-AD7510DA500E}"/>
+                <a16:creationId xmlns:a16="http://schemas.microsoft.com/office/drawing/2014/main" id="{007DAF5B-C35B-41CE-991A-B17575155763}"/>
               </a:ext>
             </a:extLst>
           </p:cNvPr>
@@ -20357,7 +20357,7 @@
           <p:cNvPr id="5" name="f146">
             <a:extLst xmlns:a="http://schemas.openxmlformats.org/drawingml/2006/main">
               <a:ext uri="{FF2B5EF4-FFF2-40B4-BE49-F238E27FC236}">
-                <a16:creationId xmlns:a16="http://schemas.microsoft.com/office/drawing/2014/main" id="{850ECB51-B1BF-46AE-890F-8306C185E5B9}"/>
+                <a16:creationId xmlns:a16="http://schemas.microsoft.com/office/drawing/2014/main" id="{A80AB85E-A249-4D5B-84F1-71FC0A43BA9B}"/>
               </a:ext>
             </a:extLst>
           </p:cNvPr>
@@ -20368,7 +20368,201 @@
         </p:nvSpPr>
         <p:spPr>
           <a:xfrm xmlns:a="http://schemas.openxmlformats.org/drawingml/2006/main">
-            <a:off x="3048000" y="3048000"/>
+            <a:off x="571500" y="3048000"/>
+            <a:ext cx="1428750" cy="590550"/>
+          </a:xfrm>
+          <a:prstGeom xmlns:a="http://schemas.openxmlformats.org/drawingml/2006/main" prst="roundRect">
+            <a:avLst>
+              <a:gd name="adj" fmla="val 19355"/>
+            </a:avLst>
+          </a:prstGeom>
+          <a:solidFill xmlns:a="http://schemas.openxmlformats.org/drawingml/2006/main">
+            <a:srgbClr val="F0F4FF"/>
+          </a:solidFill>
+          <a:ln xmlns:a="http://schemas.openxmlformats.org/drawingml/2006/main" w="17145">
+            <a:solidFill>
+              <a:srgbClr val="D9E3EF"/>
+            </a:solidFill>
+            <a:prstDash val="solid"/>
+          </a:ln>
+        </p:spPr>
+      </p:sp>
+      <p:sp>
+        <p:nvSpPr>
+          <p:cNvPr id="6" name="f147">
+            <a:extLst xmlns:a="http://schemas.openxmlformats.org/drawingml/2006/main">
+              <a:ext uri="{FF2B5EF4-FFF2-40B4-BE49-F238E27FC236}">
+                <a16:creationId xmlns:a16="http://schemas.microsoft.com/office/drawing/2014/main" id="{CA3704B9-BA61-49BC-A89E-1922C4271C65}"/>
+              </a:ext>
+            </a:extLst>
+          </p:cNvPr>
+          <p:cNvSpPr>
+            <a:spLocks xmlns:a="http://schemas.openxmlformats.org/drawingml/2006/main" noGrp="1"/>
+          </p:cNvSpPr>
+          <p:nvPr/>
+        </p:nvSpPr>
+        <p:spPr>
+          <a:xfrm xmlns:a="http://schemas.openxmlformats.org/drawingml/2006/main">
+            <a:off x="666750" y="3200400"/>
+            <a:ext cx="1238250" cy="361950"/>
+          </a:xfrm>
+          <a:prstGeom xmlns:a="http://schemas.openxmlformats.org/drawingml/2006/main" prst="rect">
+            <a:avLst/>
+          </a:prstGeom>
+          <a:noFill xmlns:a="http://schemas.openxmlformats.org/drawingml/2006/main"/>
+          <a:ln xmlns:a="http://schemas.openxmlformats.org/drawingml/2006/main" w="0">
+            <a:noFill/>
+            <a:prstDash val="solid"/>
+          </a:ln>
+        </p:spPr>
+        <p:txBody>
+          <a:bodyPr xmlns:a="http://schemas.openxmlformats.org/drawingml/2006/main" wrap="none" lIns="0" tIns="0" rIns="0" bIns="0" anchor="t">
+            <a:noAutofit/>
+          </a:bodyPr>
+          <a:lstStyle xmlns:a="http://schemas.openxmlformats.org/drawingml/2006/main">
+            <a:defPPr algn="ctr">
+              <a:defRPr sz="2250" b="1">
+                <a:solidFill>
+                  <a:srgbClr val="4264D0"/>
+                </a:solidFill>
+                <a:latin typeface="Nimbus Sans"/>
+                <a:ea typeface="Nimbus Sans"/>
+                <a:cs typeface="Nimbus Sans"/>
+              </a:defRPr>
+            </a:defPPr>
+            <a:lvl1pPr algn="ctr">
+              <a:defRPr sz="2250" b="1">
+                <a:solidFill>
+                  <a:srgbClr val="4264D0"/>
+                </a:solidFill>
+                <a:latin typeface="Nimbus Sans"/>
+                <a:ea typeface="Nimbus Sans"/>
+                <a:cs typeface="Nimbus Sans"/>
+              </a:defRPr>
+            </a:lvl1pPr>
+            <a:lvl2pPr algn="ctr">
+              <a:defRPr sz="2250" b="1">
+                <a:solidFill>
+                  <a:srgbClr val="4264D0"/>
+                </a:solidFill>
+                <a:latin typeface="Nimbus Sans"/>
+                <a:ea typeface="Nimbus Sans"/>
+                <a:cs typeface="Nimbus Sans"/>
+              </a:defRPr>
+            </a:lvl2pPr>
+            <a:lvl3pPr algn="ctr">
+              <a:defRPr sz="2250" b="1">
+                <a:solidFill>
+                  <a:srgbClr val="4264D0"/>
+                </a:solidFill>
+                <a:latin typeface="Nimbus Sans"/>
+                <a:ea typeface="Nimbus Sans"/>
+                <a:cs typeface="Nimbus Sans"/>
+              </a:defRPr>
+            </a:lvl3pPr>
+            <a:lvl4pPr algn="ctr">
+              <a:defRPr sz="2250" b="1">
+                <a:solidFill>
+                  <a:srgbClr val="4264D0"/>
+                </a:solidFill>
+                <a:latin typeface="Nimbus Sans"/>
+                <a:ea typeface="Nimbus Sans"/>
+                <a:cs typeface="Nimbus Sans"/>
+              </a:defRPr>
+            </a:lvl4pPr>
+            <a:lvl5pPr algn="ctr">
+              <a:defRPr sz="2250" b="1">
+                <a:solidFill>
+                  <a:srgbClr val="4264D0"/>
+                </a:solidFill>
+                <a:latin typeface="Nimbus Sans"/>
+                <a:ea typeface="Nimbus Sans"/>
+                <a:cs typeface="Nimbus Sans"/>
+              </a:defRPr>
+            </a:lvl5pPr>
+            <a:lvl6pPr algn="ctr">
+              <a:defRPr sz="2250" b="1">
+                <a:solidFill>
+                  <a:srgbClr val="4264D0"/>
+                </a:solidFill>
+                <a:latin typeface="Nimbus Sans"/>
+                <a:ea typeface="Nimbus Sans"/>
+                <a:cs typeface="Nimbus Sans"/>
+              </a:defRPr>
+            </a:lvl6pPr>
+            <a:lvl7pPr algn="ctr">
+              <a:defRPr sz="2250" b="1">
+                <a:solidFill>
+                  <a:srgbClr val="4264D0"/>
+                </a:solidFill>
+                <a:latin typeface="Nimbus Sans"/>
+                <a:ea typeface="Nimbus Sans"/>
+                <a:cs typeface="Nimbus Sans"/>
+              </a:defRPr>
+            </a:lvl7pPr>
+            <a:lvl8pPr algn="ctr">
+              <a:defRPr sz="2250" b="1">
+                <a:solidFill>
+                  <a:srgbClr val="4264D0"/>
+                </a:solidFill>
+                <a:latin typeface="Nimbus Sans"/>
+                <a:ea typeface="Nimbus Sans"/>
+                <a:cs typeface="Nimbus Sans"/>
+              </a:defRPr>
+            </a:lvl8pPr>
+            <a:lvl9pPr algn="ctr">
+              <a:defRPr sz="2250" b="1">
+                <a:solidFill>
+                  <a:srgbClr val="4264D0"/>
+                </a:solidFill>
+                <a:latin typeface="Nimbus Sans"/>
+                <a:ea typeface="Nimbus Sans"/>
+                <a:cs typeface="Nimbus Sans"/>
+              </a:defRPr>
+            </a:lvl9pPr>
+          </a:lstStyle>
+          <a:p xmlns:a="http://schemas.openxmlformats.org/drawingml/2006/main">
+            <a:pPr algn="ctr">
+              <a:defRPr sz="2250" b="1">
+                <a:solidFill>
+                  <a:srgbClr val="4264D0"/>
+                </a:solidFill>
+                <a:latin typeface="Nimbus Sans"/>
+                <a:ea typeface="Nimbus Sans"/>
+                <a:cs typeface="Nimbus Sans"/>
+              </a:defRPr>
+            </a:pPr>
+            <a:r>
+              <a:rPr sz="2250" b="1">
+                <a:solidFill>
+                  <a:srgbClr val="4264D0"/>
+                </a:solidFill>
+                <a:latin typeface="Nimbus Sans"/>
+                <a:ea typeface="Nimbus Sans"/>
+                <a:cs typeface="Nimbus Sans"/>
+              </a:rPr>
+              <a:t>DSL</a:t>
+            </a:r>
+          </a:p>
+        </p:txBody>
+      </p:sp>
+      <p:sp>
+        <p:nvSpPr>
+          <p:cNvPr id="7" name="f148">
+            <a:extLst xmlns:a="http://schemas.openxmlformats.org/drawingml/2006/main">
+              <a:ext uri="{FF2B5EF4-FFF2-40B4-BE49-F238E27FC236}">
+                <a16:creationId xmlns:a16="http://schemas.microsoft.com/office/drawing/2014/main" id="{2ACE68C0-8C93-4ACF-9B9F-88E405DF6634}"/>
+              </a:ext>
+            </a:extLst>
+          </p:cNvPr>
+          <p:cNvSpPr>
+            <a:spLocks xmlns:a="http://schemas.openxmlformats.org/drawingml/2006/main" noGrp="1"/>
+          </p:cNvSpPr>
+          <p:nvPr/>
+        </p:nvSpPr>
+        <p:spPr>
+          <a:xfrm xmlns:a="http://schemas.openxmlformats.org/drawingml/2006/main">
+            <a:off x="2952750" y="3048000"/>
             <a:ext cx="2095500" cy="590550"/>
           </a:xfrm>
           <a:prstGeom xmlns:a="http://schemas.openxmlformats.org/drawingml/2006/main" prst="roundRect">
@@ -20389,10 +20583,10 @@
       </p:sp>
       <p:sp>
         <p:nvSpPr>
-          <p:cNvPr id="6" name="f147">
+          <p:cNvPr id="8" name="f149">
             <a:extLst xmlns:a="http://schemas.openxmlformats.org/drawingml/2006/main">
               <a:ext uri="{FF2B5EF4-FFF2-40B4-BE49-F238E27FC236}">
-                <a16:creationId xmlns:a16="http://schemas.microsoft.com/office/drawing/2014/main" id="{730BA463-A684-4437-AE06-10C5387E18A1}"/>
+                <a16:creationId xmlns:a16="http://schemas.microsoft.com/office/drawing/2014/main" id="{7870EA06-80E3-4731-89CE-C46626DB0A96}"/>
               </a:ext>
             </a:extLst>
           </p:cNvPr>
@@ -20403,7 +20597,7 @@
         </p:nvSpPr>
         <p:spPr>
           <a:xfrm xmlns:a="http://schemas.openxmlformats.org/drawingml/2006/main">
-            <a:off x="3143250" y="3238500"/>
+            <a:off x="3048000" y="3238500"/>
             <a:ext cx="1905000" cy="285750"/>
           </a:xfrm>
           <a:prstGeom xmlns:a="http://schemas.openxmlformats.org/drawingml/2006/main" prst="rect">
@@ -20548,10 +20742,10 @@
       </p:sp>
       <p:sp>
         <p:nvSpPr>
-          <p:cNvPr id="7" name="f148">
+          <p:cNvPr id="9" name="f150">
             <a:extLst xmlns:a="http://schemas.openxmlformats.org/drawingml/2006/main">
               <a:ext uri="{FF2B5EF4-FFF2-40B4-BE49-F238E27FC236}">
-                <a16:creationId xmlns:a16="http://schemas.microsoft.com/office/drawing/2014/main" id="{C2F9419A-22A1-4CD7-835C-120CC1E998D7}"/>
+                <a16:creationId xmlns:a16="http://schemas.microsoft.com/office/drawing/2014/main" id="{B1388504-07EA-486F-8C75-2BDAB16FC484}"/>
               </a:ext>
             </a:extLst>
           </p:cNvPr>
@@ -20562,12 +20756,12 @@
         </p:nvSpPr>
         <p:spPr>
           <a:xfrm xmlns:a="http://schemas.openxmlformats.org/drawingml/2006/main">
-            <a:off x="3143250" y="4524375"/>
-            <a:ext cx="1905000" cy="952500"/>
+            <a:off x="381000" y="4524375"/>
+            <a:ext cx="4667250" cy="819150"/>
           </a:xfrm>
           <a:prstGeom xmlns:a="http://schemas.openxmlformats.org/drawingml/2006/main" prst="roundRect">
             <a:avLst>
-              <a:gd name="adj" fmla="val 12000"/>
+              <a:gd name="adj" fmla="val 13953"/>
             </a:avLst>
           </a:prstGeom>
           <a:solidFill xmlns:a="http://schemas.openxmlformats.org/drawingml/2006/main">
@@ -20583,10 +20777,10 @@
       </p:sp>
       <p:sp>
         <p:nvSpPr>
-          <p:cNvPr id="8" name="f149">
+          <p:cNvPr id="10" name="f151">
             <a:extLst xmlns:a="http://schemas.openxmlformats.org/drawingml/2006/main">
               <a:ext uri="{FF2B5EF4-FFF2-40B4-BE49-F238E27FC236}">
-                <a16:creationId xmlns:a16="http://schemas.microsoft.com/office/drawing/2014/main" id="{35972998-BBE8-42A1-9D80-102949C689F7}"/>
+                <a16:creationId xmlns:a16="http://schemas.microsoft.com/office/drawing/2014/main" id="{B2C247FA-9A2E-4F95-A246-F8C1140F316D}"/>
               </a:ext>
             </a:extLst>
           </p:cNvPr>
@@ -20597,225 +20791,8 @@
         </p:nvSpPr>
         <p:spPr>
           <a:xfrm xmlns:a="http://schemas.openxmlformats.org/drawingml/2006/main">
-            <a:off x="3238500" y="4707446"/>
-            <a:ext cx="1714500" cy="662559"/>
-          </a:xfrm>
-          <a:prstGeom xmlns:a="http://schemas.openxmlformats.org/drawingml/2006/main" prst="rect">
-            <a:avLst/>
-          </a:prstGeom>
-          <a:noFill xmlns:a="http://schemas.openxmlformats.org/drawingml/2006/main"/>
-          <a:ln xmlns:a="http://schemas.openxmlformats.org/drawingml/2006/main" w="0">
-            <a:noFill/>
-            <a:prstDash val="solid"/>
-          </a:ln>
-        </p:spPr>
-        <p:txBody>
-          <a:bodyPr xmlns:a="http://schemas.openxmlformats.org/drawingml/2006/main" wrap="none" lIns="0" tIns="0" rIns="0" bIns="0" anchor="t">
-            <a:noAutofit/>
-          </a:bodyPr>
-          <a:lstStyle xmlns:a="http://schemas.openxmlformats.org/drawingml/2006/main">
-            <a:defPPr algn="ctr">
-              <a:defRPr sz="2025" b="1">
-                <a:solidFill>
-                  <a:srgbClr val="278766"/>
-                </a:solidFill>
-                <a:latin typeface="Nimbus Sans"/>
-                <a:ea typeface="Nimbus Sans"/>
-                <a:cs typeface="Nimbus Sans"/>
-              </a:defRPr>
-            </a:defPPr>
-            <a:lvl1pPr algn="ctr">
-              <a:defRPr sz="2025" b="1">
-                <a:solidFill>
-                  <a:srgbClr val="278766"/>
-                </a:solidFill>
-                <a:latin typeface="Nimbus Sans"/>
-                <a:ea typeface="Nimbus Sans"/>
-                <a:cs typeface="Nimbus Sans"/>
-              </a:defRPr>
-            </a:lvl1pPr>
-            <a:lvl2pPr algn="ctr">
-              <a:defRPr sz="2025" b="1">
-                <a:solidFill>
-                  <a:srgbClr val="278766"/>
-                </a:solidFill>
-                <a:latin typeface="Nimbus Sans"/>
-                <a:ea typeface="Nimbus Sans"/>
-                <a:cs typeface="Nimbus Sans"/>
-              </a:defRPr>
-            </a:lvl2pPr>
-            <a:lvl3pPr algn="ctr">
-              <a:defRPr sz="2025" b="1">
-                <a:solidFill>
-                  <a:srgbClr val="278766"/>
-                </a:solidFill>
-                <a:latin typeface="Nimbus Sans"/>
-                <a:ea typeface="Nimbus Sans"/>
-                <a:cs typeface="Nimbus Sans"/>
-              </a:defRPr>
-            </a:lvl3pPr>
-            <a:lvl4pPr algn="ctr">
-              <a:defRPr sz="2025" b="1">
-                <a:solidFill>
-                  <a:srgbClr val="278766"/>
-                </a:solidFill>
-                <a:latin typeface="Nimbus Sans"/>
-                <a:ea typeface="Nimbus Sans"/>
-                <a:cs typeface="Nimbus Sans"/>
-              </a:defRPr>
-            </a:lvl4pPr>
-            <a:lvl5pPr algn="ctr">
-              <a:defRPr sz="2025" b="1">
-                <a:solidFill>
-                  <a:srgbClr val="278766"/>
-                </a:solidFill>
-                <a:latin typeface="Nimbus Sans"/>
-                <a:ea typeface="Nimbus Sans"/>
-                <a:cs typeface="Nimbus Sans"/>
-              </a:defRPr>
-            </a:lvl5pPr>
-            <a:lvl6pPr algn="ctr">
-              <a:defRPr sz="2025" b="1">
-                <a:solidFill>
-                  <a:srgbClr val="278766"/>
-                </a:solidFill>
-                <a:latin typeface="Nimbus Sans"/>
-                <a:ea typeface="Nimbus Sans"/>
-                <a:cs typeface="Nimbus Sans"/>
-              </a:defRPr>
-            </a:lvl6pPr>
-            <a:lvl7pPr algn="ctr">
-              <a:defRPr sz="2025" b="1">
-                <a:solidFill>
-                  <a:srgbClr val="278766"/>
-                </a:solidFill>
-                <a:latin typeface="Nimbus Sans"/>
-                <a:ea typeface="Nimbus Sans"/>
-                <a:cs typeface="Nimbus Sans"/>
-              </a:defRPr>
-            </a:lvl7pPr>
-            <a:lvl8pPr algn="ctr">
-              <a:defRPr sz="2025" b="1">
-                <a:solidFill>
-                  <a:srgbClr val="278766"/>
-                </a:solidFill>
-                <a:latin typeface="Nimbus Sans"/>
-                <a:ea typeface="Nimbus Sans"/>
-                <a:cs typeface="Nimbus Sans"/>
-              </a:defRPr>
-            </a:lvl8pPr>
-            <a:lvl9pPr algn="ctr">
-              <a:defRPr sz="2025" b="1">
-                <a:solidFill>
-                  <a:srgbClr val="278766"/>
-                </a:solidFill>
-                <a:latin typeface="Nimbus Sans"/>
-                <a:ea typeface="Nimbus Sans"/>
-                <a:cs typeface="Nimbus Sans"/>
-              </a:defRPr>
-            </a:lvl9pPr>
-          </a:lstStyle>
-          <a:p xmlns:a="http://schemas.openxmlformats.org/drawingml/2006/main">
-            <a:pPr algn="ctr">
-              <a:defRPr sz="2025" b="1">
-                <a:solidFill>
-                  <a:srgbClr val="278766"/>
-                </a:solidFill>
-                <a:latin typeface="Nimbus Sans"/>
-                <a:ea typeface="Nimbus Sans"/>
-                <a:cs typeface="Nimbus Sans"/>
-              </a:defRPr>
-            </a:pPr>
-            <a:r>
-              <a:rPr sz="2025" b="1">
-                <a:solidFill>
-                  <a:srgbClr val="278766"/>
-                </a:solidFill>
-                <a:latin typeface="Nimbus Sans"/>
-                <a:ea typeface="Nimbus Sans"/>
-                <a:cs typeface="Nimbus Sans"/>
-              </a:rPr>
-              <a:t>Pipeline di</a:t>
-            </a:r>
-          </a:p>
-          <a:p xmlns:a="http://schemas.openxmlformats.org/drawingml/2006/main">
-            <a:pPr algn="ctr">
-              <a:defRPr sz="2025" b="1">
-                <a:solidFill>
-                  <a:srgbClr val="278766"/>
-                </a:solidFill>
-                <a:latin typeface="Nimbus Sans"/>
-                <a:ea typeface="Nimbus Sans"/>
-                <a:cs typeface="Nimbus Sans"/>
-              </a:defRPr>
-            </a:pPr>
-            <a:r>
-              <a:rPr sz="2025" b="1">
-                <a:solidFill>
-                  <a:srgbClr val="278766"/>
-                </a:solidFill>
-                <a:latin typeface="Nimbus Sans"/>
-                <a:ea typeface="Nimbus Sans"/>
-                <a:cs typeface="Nimbus Sans"/>
-              </a:rPr>
-              <a:t>verifica</a:t>
-            </a:r>
-          </a:p>
-        </p:txBody>
-      </p:sp>
-      <p:sp>
-        <p:nvSpPr>
-          <p:cNvPr id="9" name="f150">
-            <a:extLst xmlns:a="http://schemas.openxmlformats.org/drawingml/2006/main">
-              <a:ext uri="{FF2B5EF4-FFF2-40B4-BE49-F238E27FC236}">
-                <a16:creationId xmlns:a16="http://schemas.microsoft.com/office/drawing/2014/main" id="{968A44FA-4B2E-4451-8233-211C378B004B}"/>
-              </a:ext>
-            </a:extLst>
-          </p:cNvPr>
-          <p:cNvSpPr>
-            <a:spLocks xmlns:a="http://schemas.openxmlformats.org/drawingml/2006/main" noGrp="1"/>
-          </p:cNvSpPr>
-          <p:nvPr/>
-        </p:nvSpPr>
-        <p:spPr>
-          <a:xfrm xmlns:a="http://schemas.openxmlformats.org/drawingml/2006/main">
-            <a:off x="762000" y="4714875"/>
-            <a:ext cx="1428750" cy="571500"/>
-          </a:xfrm>
-          <a:prstGeom xmlns:a="http://schemas.openxmlformats.org/drawingml/2006/main" prst="roundRect">
-            <a:avLst>
-              <a:gd name="adj" fmla="val 20000"/>
-            </a:avLst>
-          </a:prstGeom>
-          <a:solidFill xmlns:a="http://schemas.openxmlformats.org/drawingml/2006/main">
-            <a:srgbClr val="F0F4FF"/>
-          </a:solidFill>
-          <a:ln xmlns:a="http://schemas.openxmlformats.org/drawingml/2006/main" w="17145">
-            <a:solidFill>
-              <a:srgbClr val="D9E3EF"/>
-            </a:solidFill>
-            <a:prstDash val="solid"/>
-          </a:ln>
-        </p:spPr>
-      </p:sp>
-      <p:sp>
-        <p:nvSpPr>
-          <p:cNvPr id="10" name="f151">
-            <a:extLst xmlns:a="http://schemas.openxmlformats.org/drawingml/2006/main">
-              <a:ext uri="{FF2B5EF4-FFF2-40B4-BE49-F238E27FC236}">
-                <a16:creationId xmlns:a16="http://schemas.microsoft.com/office/drawing/2014/main" id="{61A9912F-C7C9-49EB-A268-1940E18AFF95}"/>
-              </a:ext>
-            </a:extLst>
-          </p:cNvPr>
-          <p:cNvSpPr>
-            <a:spLocks xmlns:a="http://schemas.openxmlformats.org/drawingml/2006/main" noGrp="1"/>
-          </p:cNvSpPr>
-          <p:nvPr/>
-        </p:nvSpPr>
-        <p:spPr>
-          <a:xfrm xmlns:a="http://schemas.openxmlformats.org/drawingml/2006/main">
-            <a:off x="857250" y="4857750"/>
-            <a:ext cx="1238250" cy="361950"/>
+            <a:off x="476250" y="4791075"/>
+            <a:ext cx="4476750" cy="361950"/>
           </a:xfrm>
           <a:prstGeom xmlns:a="http://schemas.openxmlformats.org/drawingml/2006/main" prst="rect">
             <a:avLst/>
@@ -20834,7 +20811,7 @@
             <a:defPPr algn="ctr">
               <a:defRPr sz="2250" b="1">
                 <a:solidFill>
-                  <a:srgbClr val="4264D0"/>
+                  <a:srgbClr val="278766"/>
                 </a:solidFill>
                 <a:latin typeface="Nimbus Sans"/>
                 <a:ea typeface="Nimbus Sans"/>
@@ -20844,7 +20821,7 @@
             <a:lvl1pPr algn="ctr">
               <a:defRPr sz="2250" b="1">
                 <a:solidFill>
-                  <a:srgbClr val="4264D0"/>
+                  <a:srgbClr val="278766"/>
                 </a:solidFill>
                 <a:latin typeface="Nimbus Sans"/>
                 <a:ea typeface="Nimbus Sans"/>
@@ -20854,7 +20831,7 @@
             <a:lvl2pPr algn="ctr">
               <a:defRPr sz="2250" b="1">
                 <a:solidFill>
-                  <a:srgbClr val="4264D0"/>
+                  <a:srgbClr val="278766"/>
                 </a:solidFill>
                 <a:latin typeface="Nimbus Sans"/>
                 <a:ea typeface="Nimbus Sans"/>
@@ -20864,7 +20841,7 @@
             <a:lvl3pPr algn="ctr">
               <a:defRPr sz="2250" b="1">
                 <a:solidFill>
-                  <a:srgbClr val="4264D0"/>
+                  <a:srgbClr val="278766"/>
                 </a:solidFill>
                 <a:latin typeface="Nimbus Sans"/>
                 <a:ea typeface="Nimbus Sans"/>
@@ -20874,7 +20851,7 @@
             <a:lvl4pPr algn="ctr">
               <a:defRPr sz="2250" b="1">
                 <a:solidFill>
-                  <a:srgbClr val="4264D0"/>
+                  <a:srgbClr val="278766"/>
                 </a:solidFill>
                 <a:latin typeface="Nimbus Sans"/>
                 <a:ea typeface="Nimbus Sans"/>
@@ -20884,7 +20861,7 @@
             <a:lvl5pPr algn="ctr">
               <a:defRPr sz="2250" b="1">
                 <a:solidFill>
-                  <a:srgbClr val="4264D0"/>
+                  <a:srgbClr val="278766"/>
                 </a:solidFill>
                 <a:latin typeface="Nimbus Sans"/>
                 <a:ea typeface="Nimbus Sans"/>
@@ -20894,7 +20871,7 @@
             <a:lvl6pPr algn="ctr">
               <a:defRPr sz="2250" b="1">
                 <a:solidFill>
-                  <a:srgbClr val="4264D0"/>
+                  <a:srgbClr val="278766"/>
                 </a:solidFill>
                 <a:latin typeface="Nimbus Sans"/>
                 <a:ea typeface="Nimbus Sans"/>
@@ -20904,7 +20881,7 @@
             <a:lvl7pPr algn="ctr">
               <a:defRPr sz="2250" b="1">
                 <a:solidFill>
-                  <a:srgbClr val="4264D0"/>
+                  <a:srgbClr val="278766"/>
                 </a:solidFill>
                 <a:latin typeface="Nimbus Sans"/>
                 <a:ea typeface="Nimbus Sans"/>
@@ -20914,7 +20891,7 @@
             <a:lvl8pPr algn="ctr">
               <a:defRPr sz="2250" b="1">
                 <a:solidFill>
-                  <a:srgbClr val="4264D0"/>
+                  <a:srgbClr val="278766"/>
                 </a:solidFill>
                 <a:latin typeface="Nimbus Sans"/>
                 <a:ea typeface="Nimbus Sans"/>
@@ -20924,7 +20901,7 @@
             <a:lvl9pPr algn="ctr">
               <a:defRPr sz="2250" b="1">
                 <a:solidFill>
-                  <a:srgbClr val="4264D0"/>
+                  <a:srgbClr val="278766"/>
                 </a:solidFill>
                 <a:latin typeface="Nimbus Sans"/>
                 <a:ea typeface="Nimbus Sans"/>
@@ -20936,7 +20913,7 @@
             <a:pPr algn="ctr">
               <a:defRPr sz="2250" b="1">
                 <a:solidFill>
-                  <a:srgbClr val="4264D0"/>
+                  <a:srgbClr val="278766"/>
                 </a:solidFill>
                 <a:latin typeface="Nimbus Sans"/>
                 <a:ea typeface="Nimbus Sans"/>
@@ -20946,13 +20923,13 @@
             <a:r>
               <a:rPr sz="2250" b="1">
                 <a:solidFill>
-                  <a:srgbClr val="4264D0"/>
+                  <a:srgbClr val="278766"/>
                 </a:solidFill>
                 <a:latin typeface="Nimbus Sans"/>
                 <a:ea typeface="Nimbus Sans"/>
                 <a:cs typeface="Nimbus Sans"/>
               </a:rPr>
-              <a:t>DSL</a:t>
+              <a:t>Pipeline di verifica</a:t>
             </a:r>
           </a:p>
         </p:txBody>
@@ -20962,7 +20939,7 @@
           <p:cNvPr id="11" name="f152">
             <a:extLst xmlns:a="http://schemas.openxmlformats.org/drawingml/2006/main">
               <a:ext uri="{FF2B5EF4-FFF2-40B4-BE49-F238E27FC236}">
-                <a16:creationId xmlns:a16="http://schemas.microsoft.com/office/drawing/2014/main" id="{0BF11A5F-6603-4E81-AB94-998C06D2752B}"/>
+                <a16:creationId xmlns:a16="http://schemas.microsoft.com/office/drawing/2014/main" id="{3FD1E973-0055-4B1E-885D-4613877C3482}"/>
               </a:ext>
             </a:extLst>
           </p:cNvPr>
@@ -20973,8 +20950,8 @@
         </p:nvSpPr>
         <p:spPr>
           <a:xfrm xmlns:a="http://schemas.openxmlformats.org/drawingml/2006/main">
-            <a:off x="2047875" y="6524625"/>
-            <a:ext cx="2000250" cy="590550"/>
+            <a:off x="381000" y="6286500"/>
+            <a:ext cx="2095500" cy="590550"/>
           </a:xfrm>
           <a:prstGeom xmlns:a="http://schemas.openxmlformats.org/drawingml/2006/main" prst="roundRect">
             <a:avLst>
@@ -20997,7 +20974,7 @@
           <p:cNvPr id="12" name="f153">
             <a:extLst xmlns:a="http://schemas.openxmlformats.org/drawingml/2006/main">
               <a:ext uri="{FF2B5EF4-FFF2-40B4-BE49-F238E27FC236}">
-                <a16:creationId xmlns:a16="http://schemas.microsoft.com/office/drawing/2014/main" id="{C11206A3-ED06-4254-96A7-13628B53088C}"/>
+                <a16:creationId xmlns:a16="http://schemas.microsoft.com/office/drawing/2014/main" id="{84FBCC2A-2871-4DEF-8596-C9E16E214144}"/>
               </a:ext>
             </a:extLst>
           </p:cNvPr>
@@ -21008,8 +20985,8 @@
         </p:nvSpPr>
         <p:spPr>
           <a:xfrm xmlns:a="http://schemas.openxmlformats.org/drawingml/2006/main">
-            <a:off x="2143125" y="6705600"/>
-            <a:ext cx="1809750" cy="304800"/>
+            <a:off x="476250" y="6467475"/>
+            <a:ext cx="1905000" cy="304800"/>
           </a:xfrm>
           <a:prstGeom xmlns:a="http://schemas.openxmlformats.org/drawingml/2006/main" prst="rect">
             <a:avLst/>
@@ -21156,7 +21133,7 @@
           <p:cNvPr id="13" name="f154">
             <a:extLst xmlns:a="http://schemas.openxmlformats.org/drawingml/2006/main">
               <a:ext uri="{FF2B5EF4-FFF2-40B4-BE49-F238E27FC236}">
-                <a16:creationId xmlns:a16="http://schemas.microsoft.com/office/drawing/2014/main" id="{84A0466F-74FF-45A4-ABEE-8CCB97362435}"/>
+                <a16:creationId xmlns:a16="http://schemas.microsoft.com/office/drawing/2014/main" id="{9CD06E7E-435F-4E5A-9EDB-321DB6AF586F}"/>
               </a:ext>
             </a:extLst>
           </p:cNvPr>
@@ -21167,8 +21144,8 @@
         </p:nvSpPr>
         <p:spPr>
           <a:xfrm xmlns:a="http://schemas.openxmlformats.org/drawingml/2006/main">
-            <a:off x="4381500" y="6524625"/>
-            <a:ext cx="2000250" cy="590550"/>
+            <a:off x="2952750" y="6286500"/>
+            <a:ext cx="2095500" cy="590550"/>
           </a:xfrm>
           <a:prstGeom xmlns:a="http://schemas.openxmlformats.org/drawingml/2006/main" prst="roundRect">
             <a:avLst>
@@ -21191,7 +21168,7 @@
           <p:cNvPr id="14" name="f155">
             <a:extLst xmlns:a="http://schemas.openxmlformats.org/drawingml/2006/main">
               <a:ext uri="{FF2B5EF4-FFF2-40B4-BE49-F238E27FC236}">
-                <a16:creationId xmlns:a16="http://schemas.microsoft.com/office/drawing/2014/main" id="{12640F2A-2561-419E-99CB-60357E7809C4}"/>
+                <a16:creationId xmlns:a16="http://schemas.microsoft.com/office/drawing/2014/main" id="{C2A3300B-9998-49E2-8A83-685A5A0E52DE}"/>
               </a:ext>
             </a:extLst>
           </p:cNvPr>
@@ -21202,8 +21179,8 @@
         </p:nvSpPr>
         <p:spPr>
           <a:xfrm xmlns:a="http://schemas.openxmlformats.org/drawingml/2006/main">
-            <a:off x="4476750" y="6705600"/>
-            <a:ext cx="1809750" cy="304800"/>
+            <a:off x="3048000" y="6467475"/>
+            <a:ext cx="1905000" cy="304800"/>
           </a:xfrm>
           <a:prstGeom xmlns:a="http://schemas.openxmlformats.org/drawingml/2006/main" prst="rect">
             <a:avLst/>
@@ -21350,7 +21327,7 @@
           <p:cNvPr id="15" name="f156">
             <a:extLst xmlns:a="http://schemas.openxmlformats.org/drawingml/2006/main">
               <a:ext uri="{FF2B5EF4-FFF2-40B4-BE49-F238E27FC236}">
-                <a16:creationId xmlns:a16="http://schemas.microsoft.com/office/drawing/2014/main" id="{70139070-BEB8-472C-BB65-A383A8500825}"/>
+                <a16:creationId xmlns:a16="http://schemas.microsoft.com/office/drawing/2014/main" id="{8667917F-82F1-43D8-960B-6647E2E692BC}"/>
               </a:ext>
             </a:extLst>
           </p:cNvPr>
@@ -21361,8 +21338,8 @@
         </p:nvSpPr>
         <p:spPr>
           <a:xfrm xmlns:a="http://schemas.openxmlformats.org/drawingml/2006/main">
-            <a:off x="6572250" y="4619625"/>
-            <a:ext cx="1524000" cy="857250"/>
+            <a:off x="5953125" y="5143500"/>
+            <a:ext cx="1714500" cy="857250"/>
           </a:xfrm>
           <a:prstGeom xmlns:a="http://schemas.openxmlformats.org/drawingml/2006/main" prst="roundRect">
             <a:avLst>
@@ -21385,7 +21362,7 @@
           <p:cNvPr id="16" name="f157">
             <a:extLst xmlns:a="http://schemas.openxmlformats.org/drawingml/2006/main">
               <a:ext uri="{FF2B5EF4-FFF2-40B4-BE49-F238E27FC236}">
-                <a16:creationId xmlns:a16="http://schemas.microsoft.com/office/drawing/2014/main" id="{1D59284F-3797-470C-AE04-2E0CA811CE79}"/>
+                <a16:creationId xmlns:a16="http://schemas.microsoft.com/office/drawing/2014/main" id="{6F08C1D0-46EB-4081-9A6E-CB77761FEC02}"/>
               </a:ext>
             </a:extLst>
           </p:cNvPr>
@@ -21396,8 +21373,8 @@
         </p:nvSpPr>
         <p:spPr>
           <a:xfrm xmlns:a="http://schemas.openxmlformats.org/drawingml/2006/main">
-            <a:off x="6667500" y="4798505"/>
-            <a:ext cx="1333500" cy="575691"/>
+            <a:off x="6048375" y="5300663"/>
+            <a:ext cx="1524000" cy="619125"/>
           </a:xfrm>
           <a:prstGeom xmlns:a="http://schemas.openxmlformats.org/drawingml/2006/main" prst="rect">
             <a:avLst/>
@@ -21414,7 +21391,7 @@
           </a:bodyPr>
           <a:lstStyle xmlns:a="http://schemas.openxmlformats.org/drawingml/2006/main">
             <a:defPPr algn="ctr">
-              <a:defRPr sz="1725" b="1">
+              <a:defRPr sz="1875" b="1">
                 <a:solidFill>
                   <a:srgbClr val="9D7139"/>
                 </a:solidFill>
@@ -21424,7 +21401,7 @@
               </a:defRPr>
             </a:defPPr>
             <a:lvl1pPr algn="ctr">
-              <a:defRPr sz="1725" b="1">
+              <a:defRPr sz="1875" b="1">
                 <a:solidFill>
                   <a:srgbClr val="9D7139"/>
                 </a:solidFill>
@@ -21434,7 +21411,7 @@
               </a:defRPr>
             </a:lvl1pPr>
             <a:lvl2pPr algn="ctr">
-              <a:defRPr sz="1725" b="1">
+              <a:defRPr sz="1875" b="1">
                 <a:solidFill>
                   <a:srgbClr val="9D7139"/>
                 </a:solidFill>
@@ -21444,7 +21421,7 @@
               </a:defRPr>
             </a:lvl2pPr>
             <a:lvl3pPr algn="ctr">
-              <a:defRPr sz="1725" b="1">
+              <a:defRPr sz="1875" b="1">
                 <a:solidFill>
                   <a:srgbClr val="9D7139"/>
                 </a:solidFill>
@@ -21454,7 +21431,7 @@
               </a:defRPr>
             </a:lvl3pPr>
             <a:lvl4pPr algn="ctr">
-              <a:defRPr sz="1725" b="1">
+              <a:defRPr sz="1875" b="1">
                 <a:solidFill>
                   <a:srgbClr val="9D7139"/>
                 </a:solidFill>
@@ -21464,7 +21441,7 @@
               </a:defRPr>
             </a:lvl4pPr>
             <a:lvl5pPr algn="ctr">
-              <a:defRPr sz="1725" b="1">
+              <a:defRPr sz="1875" b="1">
                 <a:solidFill>
                   <a:srgbClr val="9D7139"/>
                 </a:solidFill>
@@ -21474,7 +21451,7 @@
               </a:defRPr>
             </a:lvl5pPr>
             <a:lvl6pPr algn="ctr">
-              <a:defRPr sz="1725" b="1">
+              <a:defRPr sz="1875" b="1">
                 <a:solidFill>
                   <a:srgbClr val="9D7139"/>
                 </a:solidFill>
@@ -21484,7 +21461,7 @@
               </a:defRPr>
             </a:lvl6pPr>
             <a:lvl7pPr algn="ctr">
-              <a:defRPr sz="1725" b="1">
+              <a:defRPr sz="1875" b="1">
                 <a:solidFill>
                   <a:srgbClr val="9D7139"/>
                 </a:solidFill>
@@ -21494,7 +21471,7 @@
               </a:defRPr>
             </a:lvl7pPr>
             <a:lvl8pPr algn="ctr">
-              <a:defRPr sz="1725" b="1">
+              <a:defRPr sz="1875" b="1">
                 <a:solidFill>
                   <a:srgbClr val="9D7139"/>
                 </a:solidFill>
@@ -21504,7 +21481,7 @@
               </a:defRPr>
             </a:lvl8pPr>
             <a:lvl9pPr algn="ctr">
-              <a:defRPr sz="1725" b="1">
+              <a:defRPr sz="1875" b="1">
                 <a:solidFill>
                   <a:srgbClr val="9D7139"/>
                 </a:solidFill>
@@ -21516,7 +21493,7 @@
           </a:lstStyle>
           <a:p xmlns:a="http://schemas.openxmlformats.org/drawingml/2006/main">
             <a:pPr algn="ctr">
-              <a:defRPr sz="1725" b="1">
+              <a:defRPr sz="1875" b="1">
                 <a:solidFill>
                   <a:srgbClr val="9D7139"/>
                 </a:solidFill>
@@ -21526,7 +21503,7 @@
               </a:defRPr>
             </a:pPr>
             <a:r>
-              <a:rPr sz="1725" b="1">
+              <a:rPr sz="1875" b="1">
                 <a:solidFill>
                   <a:srgbClr val="9D7139"/>
                 </a:solidFill>
@@ -21539,7 +21516,7 @@
           </a:p>
           <a:p xmlns:a="http://schemas.openxmlformats.org/drawingml/2006/main">
             <a:pPr algn="ctr">
-              <a:defRPr sz="1725" b="1">
+              <a:defRPr sz="1875" b="1">
                 <a:solidFill>
                   <a:srgbClr val="9D7139"/>
                 </a:solidFill>
@@ -21549,7 +21526,7 @@
               </a:defRPr>
             </a:pPr>
             <a:r>
-              <a:rPr sz="1725" b="1">
+              <a:rPr sz="1875" b="1">
                 <a:solidFill>
                   <a:srgbClr val="9D7139"/>
                 </a:solidFill>
@@ -21567,7 +21544,7 @@
           <p:cNvPr id="17" name="f158">
             <a:extLst xmlns:a="http://schemas.openxmlformats.org/drawingml/2006/main">
               <a:ext uri="{FF2B5EF4-FFF2-40B4-BE49-F238E27FC236}">
-                <a16:creationId xmlns:a16="http://schemas.microsoft.com/office/drawing/2014/main" id="{59C10BED-C272-4530-A25F-7B427293E8DD}"/>
+                <a16:creationId xmlns:a16="http://schemas.microsoft.com/office/drawing/2014/main" id="{9A28D102-7E14-4189-92FE-1BA647AFE566}"/>
               </a:ext>
             </a:extLst>
           </p:cNvPr>
@@ -21578,8 +21555,8 @@
         </p:nvSpPr>
         <p:spPr>
           <a:xfrm xmlns:a="http://schemas.openxmlformats.org/drawingml/2006/main">
-            <a:off x="6572250" y="3571875"/>
-            <a:ext cx="1524000" cy="590550"/>
+            <a:off x="5953125" y="3714750"/>
+            <a:ext cx="1714500" cy="590550"/>
           </a:xfrm>
           <a:prstGeom xmlns:a="http://schemas.openxmlformats.org/drawingml/2006/main" prst="roundRect">
             <a:avLst>
@@ -21602,7 +21579,7 @@
           <p:cNvPr id="18" name="f159">
             <a:extLst xmlns:a="http://schemas.openxmlformats.org/drawingml/2006/main">
               <a:ext uri="{FF2B5EF4-FFF2-40B4-BE49-F238E27FC236}">
-                <a16:creationId xmlns:a16="http://schemas.microsoft.com/office/drawing/2014/main" id="{FB902540-5C24-4EC3-BAB7-BF179AB14B97}"/>
+                <a16:creationId xmlns:a16="http://schemas.microsoft.com/office/drawing/2014/main" id="{1A712BE1-2D18-492A-B875-4CEDDC4FE8EE}"/>
               </a:ext>
             </a:extLst>
           </p:cNvPr>
@@ -21613,8 +21590,8 @@
         </p:nvSpPr>
         <p:spPr>
           <a:xfrm xmlns:a="http://schemas.openxmlformats.org/drawingml/2006/main">
-            <a:off x="6667500" y="3771900"/>
-            <a:ext cx="1333500" cy="266700"/>
+            <a:off x="6048375" y="3905250"/>
+            <a:ext cx="1524000" cy="285750"/>
           </a:xfrm>
           <a:prstGeom xmlns:a="http://schemas.openxmlformats.org/drawingml/2006/main" prst="rect">
             <a:avLst/>
@@ -21631,7 +21608,7 @@
           </a:bodyPr>
           <a:lstStyle xmlns:a="http://schemas.openxmlformats.org/drawingml/2006/main">
             <a:defPPr algn="ctr">
-              <a:defRPr sz="1500" b="1">
+              <a:defRPr sz="1650" b="1">
                 <a:solidFill>
                   <a:srgbClr val="182536"/>
                 </a:solidFill>
@@ -21641,7 +21618,7 @@
               </a:defRPr>
             </a:defPPr>
             <a:lvl1pPr algn="ctr">
-              <a:defRPr sz="1500" b="1">
+              <a:defRPr sz="1650" b="1">
                 <a:solidFill>
                   <a:srgbClr val="182536"/>
                 </a:solidFill>
@@ -21651,7 +21628,7 @@
               </a:defRPr>
             </a:lvl1pPr>
             <a:lvl2pPr algn="ctr">
-              <a:defRPr sz="1500" b="1">
+              <a:defRPr sz="1650" b="1">
                 <a:solidFill>
                   <a:srgbClr val="182536"/>
                 </a:solidFill>
@@ -21661,7 +21638,7 @@
               </a:defRPr>
             </a:lvl2pPr>
             <a:lvl3pPr algn="ctr">
-              <a:defRPr sz="1500" b="1">
+              <a:defRPr sz="1650" b="1">
                 <a:solidFill>
                   <a:srgbClr val="182536"/>
                 </a:solidFill>
@@ -21671,7 +21648,7 @@
               </a:defRPr>
             </a:lvl3pPr>
             <a:lvl4pPr algn="ctr">
-              <a:defRPr sz="1500" b="1">
+              <a:defRPr sz="1650" b="1">
                 <a:solidFill>
                   <a:srgbClr val="182536"/>
                 </a:solidFill>
@@ -21681,7 +21658,7 @@
               </a:defRPr>
             </a:lvl4pPr>
             <a:lvl5pPr algn="ctr">
-              <a:defRPr sz="1500" b="1">
+              <a:defRPr sz="1650" b="1">
                 <a:solidFill>
                   <a:srgbClr val="182536"/>
                 </a:solidFill>
@@ -21691,7 +21668,7 @@
               </a:defRPr>
             </a:lvl5pPr>
             <a:lvl6pPr algn="ctr">
-              <a:defRPr sz="1500" b="1">
+              <a:defRPr sz="1650" b="1">
                 <a:solidFill>
                   <a:srgbClr val="182536"/>
                 </a:solidFill>
@@ -21701,7 +21678,7 @@
               </a:defRPr>
             </a:lvl6pPr>
             <a:lvl7pPr algn="ctr">
-              <a:defRPr sz="1500" b="1">
+              <a:defRPr sz="1650" b="1">
                 <a:solidFill>
                   <a:srgbClr val="182536"/>
                 </a:solidFill>
@@ -21711,7 +21688,7 @@
               </a:defRPr>
             </a:lvl7pPr>
             <a:lvl8pPr algn="ctr">
-              <a:defRPr sz="1500" b="1">
+              <a:defRPr sz="1650" b="1">
                 <a:solidFill>
                   <a:srgbClr val="182536"/>
                 </a:solidFill>
@@ -21721,7 +21698,7 @@
               </a:defRPr>
             </a:lvl8pPr>
             <a:lvl9pPr algn="ctr">
-              <a:defRPr sz="1500" b="1">
+              <a:defRPr sz="1650" b="1">
                 <a:solidFill>
                   <a:srgbClr val="182536"/>
                 </a:solidFill>
@@ -21733,7 +21710,7 @@
           </a:lstStyle>
           <a:p xmlns:a="http://schemas.openxmlformats.org/drawingml/2006/main">
             <a:pPr algn="ctr">
-              <a:defRPr sz="1500" b="1">
+              <a:defRPr sz="1650" b="1">
                 <a:solidFill>
                   <a:srgbClr val="182536"/>
                 </a:solidFill>
@@ -21743,7 +21720,7 @@
               </a:defRPr>
             </a:pPr>
             <a:r>
-              <a:rPr sz="1500" b="1">
+              <a:rPr sz="1650" b="1">
                 <a:solidFill>
                   <a:srgbClr val="182536"/>
                 </a:solidFill>
@@ -21761,7 +21738,7 @@
           <p:cNvPr id="19" name="f160">
             <a:extLst xmlns:a="http://schemas.openxmlformats.org/drawingml/2006/main">
               <a:ext uri="{FF2B5EF4-FFF2-40B4-BE49-F238E27FC236}">
-                <a16:creationId xmlns:a16="http://schemas.microsoft.com/office/drawing/2014/main" id="{8002FCD6-1E5B-41F2-915A-F2348E179E5A}"/>
+                <a16:creationId xmlns:a16="http://schemas.microsoft.com/office/drawing/2014/main" id="{4D4E389A-A45F-498A-94EF-ECBD54131269}"/>
               </a:ext>
             </a:extLst>
           </p:cNvPr>
@@ -21772,7 +21749,7 @@
         </p:nvSpPr>
         <p:spPr>
           <a:xfrm xmlns:a="http://schemas.openxmlformats.org/drawingml/2006/main">
-            <a:off x="4095750" y="3752850"/>
+            <a:off x="1285875" y="3752850"/>
             <a:ext cx="95" cy="619125"/>
           </a:xfrm>
           <a:prstGeom xmlns:a="http://schemas.openxmlformats.org/drawingml/2006/main" prst="line">
@@ -21792,7 +21769,7 @@
           <p:cNvPr id="20" name="f161">
             <a:extLst xmlns:a="http://schemas.openxmlformats.org/drawingml/2006/main">
               <a:ext uri="{FF2B5EF4-FFF2-40B4-BE49-F238E27FC236}">
-                <a16:creationId xmlns:a16="http://schemas.microsoft.com/office/drawing/2014/main" id="{0EBDF750-5B02-423A-9EE1-09E1136A281D}"/>
+                <a16:creationId xmlns:a16="http://schemas.microsoft.com/office/drawing/2014/main" id="{184C0334-C959-460B-AA7E-AA520DAA4159}"/>
               </a:ext>
             </a:extLst>
           </p:cNvPr>
@@ -21803,7 +21780,7 @@
         </p:nvSpPr>
         <p:spPr>
           <a:xfrm xmlns:a="http://schemas.openxmlformats.org/drawingml/2006/main">
-            <a:off x="4038600" y="4371975"/>
+            <a:off x="1228725" y="4371975"/>
             <a:ext cx="114300" cy="114300"/>
           </a:xfrm>
           <a:prstGeom xmlns:a="http://schemas.openxmlformats.org/drawingml/2006/main" prst="downArrow">
@@ -21823,7 +21800,7 @@
           <p:cNvPr id="21" name="f162">
             <a:extLst xmlns:a="http://schemas.openxmlformats.org/drawingml/2006/main">
               <a:ext uri="{FF2B5EF4-FFF2-40B4-BE49-F238E27FC236}">
-                <a16:creationId xmlns:a16="http://schemas.microsoft.com/office/drawing/2014/main" id="{BAF3EE89-30C9-42DD-814A-C1128D645E0D}"/>
+                <a16:creationId xmlns:a16="http://schemas.microsoft.com/office/drawing/2014/main" id="{B692232C-A06E-4E12-A937-62EE2F2FEB29}"/>
               </a:ext>
             </a:extLst>
           </p:cNvPr>
@@ -21834,39 +21811,8 @@
         </p:nvSpPr>
         <p:spPr>
           <a:xfrm xmlns:a="http://schemas.openxmlformats.org/drawingml/2006/main">
-            <a:off x="2305050" y="4914900"/>
-            <a:ext cx="704850" cy="171450"/>
-          </a:xfrm>
-          <a:prstGeom xmlns:a="http://schemas.openxmlformats.org/drawingml/2006/main" prst="rightArrow">
-            <a:avLst/>
-          </a:prstGeom>
-          <a:solidFill xmlns:a="http://schemas.openxmlformats.org/drawingml/2006/main">
-            <a:srgbClr val="4264D0"/>
-          </a:solidFill>
-          <a:ln xmlns:a="http://schemas.openxmlformats.org/drawingml/2006/main" w="0">
-            <a:noFill/>
-            <a:prstDash val="solid"/>
-          </a:ln>
-        </p:spPr>
-      </p:sp>
-      <p:sp>
-        <p:nvSpPr>
-          <p:cNvPr id="22" name="f163">
-            <a:extLst xmlns:a="http://schemas.openxmlformats.org/drawingml/2006/main">
-              <a:ext uri="{FF2B5EF4-FFF2-40B4-BE49-F238E27FC236}">
-                <a16:creationId xmlns:a16="http://schemas.microsoft.com/office/drawing/2014/main" id="{87EF51E2-CC27-47B8-8ACF-6A43D145A2D3}"/>
-              </a:ext>
-            </a:extLst>
-          </p:cNvPr>
-          <p:cNvSpPr>
-            <a:spLocks xmlns:a="http://schemas.openxmlformats.org/drawingml/2006/main" noGrp="1"/>
-          </p:cNvSpPr>
-          <p:nvPr/>
-        </p:nvSpPr>
-        <p:spPr>
-          <a:xfrm xmlns:a="http://schemas.openxmlformats.org/drawingml/2006/main">
-            <a:off x="4095750" y="5591175"/>
-            <a:ext cx="95" cy="409575"/>
+            <a:off x="4000500" y="3752850"/>
+            <a:ext cx="95" cy="619125"/>
           </a:xfrm>
           <a:prstGeom xmlns:a="http://schemas.openxmlformats.org/drawingml/2006/main" prst="line">
             <a:avLst/>
@@ -21882,10 +21828,10 @@
       </p:sp>
       <p:sp>
         <p:nvSpPr>
-          <p:cNvPr id="23" name="f164">
+          <p:cNvPr id="22" name="f163">
             <a:extLst xmlns:a="http://schemas.openxmlformats.org/drawingml/2006/main">
               <a:ext uri="{FF2B5EF4-FFF2-40B4-BE49-F238E27FC236}">
-                <a16:creationId xmlns:a16="http://schemas.microsoft.com/office/drawing/2014/main" id="{885D87CD-A484-4DB8-B987-5BFF265D765B}"/>
+                <a16:creationId xmlns:a16="http://schemas.microsoft.com/office/drawing/2014/main" id="{5FE2C42A-DF07-440A-9A44-9738065D98E8}"/>
               </a:ext>
             </a:extLst>
           </p:cNvPr>
@@ -21896,8 +21842,39 @@
         </p:nvSpPr>
         <p:spPr>
           <a:xfrm xmlns:a="http://schemas.openxmlformats.org/drawingml/2006/main">
-            <a:off x="3048000" y="6000750"/>
-            <a:ext cx="1047750" cy="95"/>
+            <a:off x="3943350" y="4371975"/>
+            <a:ext cx="114300" cy="114300"/>
+          </a:xfrm>
+          <a:prstGeom xmlns:a="http://schemas.openxmlformats.org/drawingml/2006/main" prst="downArrow">
+            <a:avLst/>
+          </a:prstGeom>
+          <a:solidFill xmlns:a="http://schemas.openxmlformats.org/drawingml/2006/main">
+            <a:srgbClr val="4264D0"/>
+          </a:solidFill>
+          <a:ln xmlns:a="http://schemas.openxmlformats.org/drawingml/2006/main" w="0">
+            <a:noFill/>
+            <a:prstDash val="solid"/>
+          </a:ln>
+        </p:spPr>
+      </p:sp>
+      <p:sp>
+        <p:nvSpPr>
+          <p:cNvPr id="23" name="f164">
+            <a:extLst xmlns:a="http://schemas.openxmlformats.org/drawingml/2006/main">
+              <a:ext uri="{FF2B5EF4-FFF2-40B4-BE49-F238E27FC236}">
+                <a16:creationId xmlns:a16="http://schemas.microsoft.com/office/drawing/2014/main" id="{207E0F13-CDB1-4EB4-A3E6-397C3C35B033}"/>
+              </a:ext>
+            </a:extLst>
+          </p:cNvPr>
+          <p:cNvSpPr>
+            <a:spLocks xmlns:a="http://schemas.openxmlformats.org/drawingml/2006/main" noGrp="1"/>
+          </p:cNvSpPr>
+          <p:nvPr/>
+        </p:nvSpPr>
+        <p:spPr>
+          <a:xfrm xmlns:a="http://schemas.openxmlformats.org/drawingml/2006/main">
+            <a:off x="2714625" y="5457825"/>
+            <a:ext cx="95" cy="314325"/>
           </a:xfrm>
           <a:prstGeom xmlns:a="http://schemas.openxmlformats.org/drawingml/2006/main" prst="line">
             <a:avLst/>
@@ -21916,7 +21893,7 @@
           <p:cNvPr id="24" name="f165">
             <a:extLst xmlns:a="http://schemas.openxmlformats.org/drawingml/2006/main">
               <a:ext uri="{FF2B5EF4-FFF2-40B4-BE49-F238E27FC236}">
-                <a16:creationId xmlns:a16="http://schemas.microsoft.com/office/drawing/2014/main" id="{C758D815-D981-469F-AA0F-86654947A7C2}"/>
+                <a16:creationId xmlns:a16="http://schemas.microsoft.com/office/drawing/2014/main" id="{69981450-9D9F-40D4-93EE-7CCC0693FAAC}"/>
               </a:ext>
             </a:extLst>
           </p:cNvPr>
@@ -21927,8 +21904,8 @@
         </p:nvSpPr>
         <p:spPr>
           <a:xfrm xmlns:a="http://schemas.openxmlformats.org/drawingml/2006/main">
-            <a:off x="3048000" y="6000750"/>
-            <a:ext cx="95" cy="352425"/>
+            <a:off x="1428750" y="5772150"/>
+            <a:ext cx="1285875" cy="95"/>
           </a:xfrm>
           <a:prstGeom xmlns:a="http://schemas.openxmlformats.org/drawingml/2006/main" prst="line">
             <a:avLst/>
@@ -21947,7 +21924,7 @@
           <p:cNvPr id="25" name="f166">
             <a:extLst xmlns:a="http://schemas.openxmlformats.org/drawingml/2006/main">
               <a:ext uri="{FF2B5EF4-FFF2-40B4-BE49-F238E27FC236}">
-                <a16:creationId xmlns:a16="http://schemas.microsoft.com/office/drawing/2014/main" id="{EF75FB5A-8701-4F38-BDF9-8E357EB88B66}"/>
+                <a16:creationId xmlns:a16="http://schemas.microsoft.com/office/drawing/2014/main" id="{D411A154-D018-4707-AF04-8E0BF77EDEC2}"/>
               </a:ext>
             </a:extLst>
           </p:cNvPr>
@@ -21958,7 +21935,38 @@
         </p:nvSpPr>
         <p:spPr>
           <a:xfrm xmlns:a="http://schemas.openxmlformats.org/drawingml/2006/main">
-            <a:off x="2990850" y="6353175"/>
+            <a:off x="1428750" y="5772150"/>
+            <a:ext cx="95" cy="352425"/>
+          </a:xfrm>
+          <a:prstGeom xmlns:a="http://schemas.openxmlformats.org/drawingml/2006/main" prst="line">
+            <a:avLst/>
+          </a:prstGeom>
+          <a:noFill xmlns:a="http://schemas.openxmlformats.org/drawingml/2006/main"/>
+          <a:ln xmlns:a="http://schemas.openxmlformats.org/drawingml/2006/main" w="28575">
+            <a:solidFill>
+              <a:srgbClr val="4264D0"/>
+            </a:solidFill>
+            <a:prstDash val="solid"/>
+          </a:ln>
+        </p:spPr>
+      </p:sp>
+      <p:sp>
+        <p:nvSpPr>
+          <p:cNvPr id="26" name="f167">
+            <a:extLst xmlns:a="http://schemas.openxmlformats.org/drawingml/2006/main">
+              <a:ext uri="{FF2B5EF4-FFF2-40B4-BE49-F238E27FC236}">
+                <a16:creationId xmlns:a16="http://schemas.microsoft.com/office/drawing/2014/main" id="{79CEB5C9-CEA1-4F4D-995C-8484F72275C9}"/>
+              </a:ext>
+            </a:extLst>
+          </p:cNvPr>
+          <p:cNvSpPr>
+            <a:spLocks xmlns:a="http://schemas.openxmlformats.org/drawingml/2006/main" noGrp="1"/>
+          </p:cNvSpPr>
+          <p:nvPr/>
+        </p:nvSpPr>
+        <p:spPr>
+          <a:xfrm xmlns:a="http://schemas.openxmlformats.org/drawingml/2006/main">
+            <a:off x="1371600" y="6124575"/>
             <a:ext cx="114300" cy="114300"/>
           </a:xfrm>
           <a:prstGeom xmlns:a="http://schemas.openxmlformats.org/drawingml/2006/main" prst="downArrow">
@@ -21975,10 +21983,10 @@
       </p:sp>
       <p:sp>
         <p:nvSpPr>
-          <p:cNvPr id="26" name="f167">
+          <p:cNvPr id="27" name="f168">
             <a:extLst xmlns:a="http://schemas.openxmlformats.org/drawingml/2006/main">
               <a:ext uri="{FF2B5EF4-FFF2-40B4-BE49-F238E27FC236}">
-                <a16:creationId xmlns:a16="http://schemas.microsoft.com/office/drawing/2014/main" id="{AD8273C1-2906-43B1-8F68-98E07E8E1D04}"/>
+                <a16:creationId xmlns:a16="http://schemas.microsoft.com/office/drawing/2014/main" id="{05F91E44-CE5F-463A-BF8D-39C8FA38B491}"/>
               </a:ext>
             </a:extLst>
           </p:cNvPr>
@@ -21989,39 +21997,8 @@
         </p:nvSpPr>
         <p:spPr>
           <a:xfrm xmlns:a="http://schemas.openxmlformats.org/drawingml/2006/main">
-            <a:off x="4095750" y="6000750"/>
+            <a:off x="2714625" y="5772150"/>
             <a:ext cx="1285875" cy="95"/>
-          </a:xfrm>
-          <a:prstGeom xmlns:a="http://schemas.openxmlformats.org/drawingml/2006/main" prst="line">
-            <a:avLst/>
-          </a:prstGeom>
-          <a:noFill xmlns:a="http://schemas.openxmlformats.org/drawingml/2006/main"/>
-          <a:ln xmlns:a="http://schemas.openxmlformats.org/drawingml/2006/main" w="28575">
-            <a:solidFill>
-              <a:srgbClr val="4264D0"/>
-            </a:solidFill>
-            <a:prstDash val="solid"/>
-          </a:ln>
-        </p:spPr>
-      </p:sp>
-      <p:sp>
-        <p:nvSpPr>
-          <p:cNvPr id="27" name="f168">
-            <a:extLst xmlns:a="http://schemas.openxmlformats.org/drawingml/2006/main">
-              <a:ext uri="{FF2B5EF4-FFF2-40B4-BE49-F238E27FC236}">
-                <a16:creationId xmlns:a16="http://schemas.microsoft.com/office/drawing/2014/main" id="{9FB7ABC3-EC62-4820-B860-61E64EB79674}"/>
-              </a:ext>
-            </a:extLst>
-          </p:cNvPr>
-          <p:cNvSpPr>
-            <a:spLocks xmlns:a="http://schemas.openxmlformats.org/drawingml/2006/main" noGrp="1"/>
-          </p:cNvSpPr>
-          <p:nvPr/>
-        </p:nvSpPr>
-        <p:spPr>
-          <a:xfrm xmlns:a="http://schemas.openxmlformats.org/drawingml/2006/main">
-            <a:off x="5381625" y="6000750"/>
-            <a:ext cx="95" cy="352425"/>
           </a:xfrm>
           <a:prstGeom xmlns:a="http://schemas.openxmlformats.org/drawingml/2006/main" prst="line">
             <a:avLst/>
@@ -22040,7 +22017,7 @@
           <p:cNvPr id="28" name="f169">
             <a:extLst xmlns:a="http://schemas.openxmlformats.org/drawingml/2006/main">
               <a:ext uri="{FF2B5EF4-FFF2-40B4-BE49-F238E27FC236}">
-                <a16:creationId xmlns:a16="http://schemas.microsoft.com/office/drawing/2014/main" id="{11CBE083-C017-4CE5-8071-E9685E969261}"/>
+                <a16:creationId xmlns:a16="http://schemas.microsoft.com/office/drawing/2014/main" id="{80C780C2-EE40-4F7E-9A2A-1FF7508546F4}"/>
               </a:ext>
             </a:extLst>
           </p:cNvPr>
@@ -22051,7 +22028,38 @@
         </p:nvSpPr>
         <p:spPr>
           <a:xfrm xmlns:a="http://schemas.openxmlformats.org/drawingml/2006/main">
-            <a:off x="5324475" y="6353175"/>
+            <a:off x="4000500" y="5772150"/>
+            <a:ext cx="95" cy="352425"/>
+          </a:xfrm>
+          <a:prstGeom xmlns:a="http://schemas.openxmlformats.org/drawingml/2006/main" prst="line">
+            <a:avLst/>
+          </a:prstGeom>
+          <a:noFill xmlns:a="http://schemas.openxmlformats.org/drawingml/2006/main"/>
+          <a:ln xmlns:a="http://schemas.openxmlformats.org/drawingml/2006/main" w="28575">
+            <a:solidFill>
+              <a:srgbClr val="4264D0"/>
+            </a:solidFill>
+            <a:prstDash val="solid"/>
+          </a:ln>
+        </p:spPr>
+      </p:sp>
+      <p:sp>
+        <p:nvSpPr>
+          <p:cNvPr id="29" name="f170">
+            <a:extLst xmlns:a="http://schemas.openxmlformats.org/drawingml/2006/main">
+              <a:ext uri="{FF2B5EF4-FFF2-40B4-BE49-F238E27FC236}">
+                <a16:creationId xmlns:a16="http://schemas.microsoft.com/office/drawing/2014/main" id="{CB5562BC-CCDC-4BF0-9EC0-81DB21B6E55F}"/>
+              </a:ext>
+            </a:extLst>
+          </p:cNvPr>
+          <p:cNvSpPr>
+            <a:spLocks xmlns:a="http://schemas.openxmlformats.org/drawingml/2006/main" noGrp="1"/>
+          </p:cNvSpPr>
+          <p:nvPr/>
+        </p:nvSpPr>
+        <p:spPr>
+          <a:xfrm xmlns:a="http://schemas.openxmlformats.org/drawingml/2006/main">
+            <a:off x="3943350" y="6124575"/>
             <a:ext cx="114300" cy="114300"/>
           </a:xfrm>
           <a:prstGeom xmlns:a="http://schemas.openxmlformats.org/drawingml/2006/main" prst="downArrow">
@@ -22068,10 +22076,10 @@
       </p:sp>
       <p:sp>
         <p:nvSpPr>
-          <p:cNvPr id="29" name="f170">
+          <p:cNvPr id="30" name="f171">
             <a:extLst xmlns:a="http://schemas.openxmlformats.org/drawingml/2006/main">
               <a:ext uri="{FF2B5EF4-FFF2-40B4-BE49-F238E27FC236}">
-                <a16:creationId xmlns:a16="http://schemas.microsoft.com/office/drawing/2014/main" id="{E2ECBDE3-1CFA-4FF1-9E59-2D8373420C95}"/>
+                <a16:creationId xmlns:a16="http://schemas.microsoft.com/office/drawing/2014/main" id="{04730B43-515A-4377-8DF6-7BEBA1031776}"/>
               </a:ext>
             </a:extLst>
           </p:cNvPr>
@@ -22082,39 +22090,8 @@
         </p:nvSpPr>
         <p:spPr>
           <a:xfrm xmlns:a="http://schemas.openxmlformats.org/drawingml/2006/main">
-            <a:off x="4162425" y="6819900"/>
-            <a:ext cx="47625" cy="95"/>
-          </a:xfrm>
-          <a:prstGeom xmlns:a="http://schemas.openxmlformats.org/drawingml/2006/main" prst="line">
-            <a:avLst/>
-          </a:prstGeom>
-          <a:noFill xmlns:a="http://schemas.openxmlformats.org/drawingml/2006/main"/>
-          <a:ln xmlns:a="http://schemas.openxmlformats.org/drawingml/2006/main" w="28575">
-            <a:solidFill>
-              <a:srgbClr val="4264D0"/>
-            </a:solidFill>
-            <a:prstDash val="solid"/>
-          </a:ln>
-        </p:spPr>
-      </p:sp>
-      <p:sp>
-        <p:nvSpPr>
-          <p:cNvPr id="30" name="f171">
-            <a:extLst xmlns:a="http://schemas.openxmlformats.org/drawingml/2006/main">
-              <a:ext uri="{FF2B5EF4-FFF2-40B4-BE49-F238E27FC236}">
-                <a16:creationId xmlns:a16="http://schemas.microsoft.com/office/drawing/2014/main" id="{C02A19F2-EEF8-47EE-A920-950FFAAB4CF3}"/>
-              </a:ext>
-            </a:extLst>
-          </p:cNvPr>
-          <p:cNvSpPr>
-            <a:spLocks xmlns:a="http://schemas.openxmlformats.org/drawingml/2006/main" noGrp="1"/>
-          </p:cNvSpPr>
-          <p:nvPr/>
-        </p:nvSpPr>
-        <p:spPr>
-          <a:xfrm xmlns:a="http://schemas.openxmlformats.org/drawingml/2006/main">
-            <a:off x="4210050" y="6819900"/>
-            <a:ext cx="95" cy="609600"/>
+            <a:off x="1428750" y="6877050"/>
+            <a:ext cx="95" cy="647700"/>
           </a:xfrm>
           <a:prstGeom xmlns:a="http://schemas.openxmlformats.org/drawingml/2006/main" prst="line">
             <a:avLst/>
@@ -22133,7 +22110,7 @@
           <p:cNvPr id="31" name="f172">
             <a:extLst xmlns:a="http://schemas.openxmlformats.org/drawingml/2006/main">
               <a:ext uri="{FF2B5EF4-FFF2-40B4-BE49-F238E27FC236}">
-                <a16:creationId xmlns:a16="http://schemas.microsoft.com/office/drawing/2014/main" id="{7BCC3675-CACB-4CAB-B2C8-98AB615B4D05}"/>
+                <a16:creationId xmlns:a16="http://schemas.microsoft.com/office/drawing/2014/main" id="{E2BFDDEB-FB2A-4C57-B0CA-1EC5BD914799}"/>
               </a:ext>
             </a:extLst>
           </p:cNvPr>
@@ -22144,8 +22121,8 @@
         </p:nvSpPr>
         <p:spPr>
           <a:xfrm xmlns:a="http://schemas.openxmlformats.org/drawingml/2006/main">
-            <a:off x="4210050" y="7429500"/>
-            <a:ext cx="2266950" cy="95"/>
+            <a:off x="1428750" y="7524750"/>
+            <a:ext cx="5381625" cy="95"/>
           </a:xfrm>
           <a:prstGeom xmlns:a="http://schemas.openxmlformats.org/drawingml/2006/main" prst="line">
             <a:avLst/>
@@ -22164,7 +22141,7 @@
           <p:cNvPr id="32" name="f173">
             <a:extLst xmlns:a="http://schemas.openxmlformats.org/drawingml/2006/main">
               <a:ext uri="{FF2B5EF4-FFF2-40B4-BE49-F238E27FC236}">
-                <a16:creationId xmlns:a16="http://schemas.microsoft.com/office/drawing/2014/main" id="{BA9B7307-F36B-4281-A49E-6CA45FE9682A}"/>
+                <a16:creationId xmlns:a16="http://schemas.microsoft.com/office/drawing/2014/main" id="{655A1775-8755-42B7-A7D2-1C465B4D3C0D}"/>
               </a:ext>
             </a:extLst>
           </p:cNvPr>
@@ -22175,8 +22152,8 @@
         </p:nvSpPr>
         <p:spPr>
           <a:xfrm xmlns:a="http://schemas.openxmlformats.org/drawingml/2006/main">
-            <a:off x="6477000" y="5048250"/>
-            <a:ext cx="95" cy="2381250"/>
+            <a:off x="6810375" y="6172200"/>
+            <a:ext cx="95" cy="1352550"/>
           </a:xfrm>
           <a:prstGeom xmlns:a="http://schemas.openxmlformats.org/drawingml/2006/main" prst="line">
             <a:avLst/>
@@ -22195,7 +22172,7 @@
           <p:cNvPr id="33" name="f174">
             <a:extLst xmlns:a="http://schemas.openxmlformats.org/drawingml/2006/main">
               <a:ext uri="{FF2B5EF4-FFF2-40B4-BE49-F238E27FC236}">
-                <a16:creationId xmlns:a16="http://schemas.microsoft.com/office/drawing/2014/main" id="{194B7C26-7314-435B-AFA2-0C8B1F91465F}"/>
+                <a16:creationId xmlns:a16="http://schemas.microsoft.com/office/drawing/2014/main" id="{D7231857-AC6C-48E9-BCD0-A37E53936DFF}"/>
               </a:ext>
             </a:extLst>
           </p:cNvPr>
@@ -22206,10 +22183,10 @@
         </p:nvSpPr>
         <p:spPr>
           <a:xfrm xmlns:a="http://schemas.openxmlformats.org/drawingml/2006/main">
-            <a:off x="6419850" y="4962525"/>
-            <a:ext cx="114300" cy="171450"/>
+            <a:off x="6753225" y="6057900"/>
+            <a:ext cx="114300" cy="114300"/>
           </a:xfrm>
-          <a:prstGeom xmlns:a="http://schemas.openxmlformats.org/drawingml/2006/main" prst="rightArrow">
+          <a:prstGeom xmlns:a="http://schemas.openxmlformats.org/drawingml/2006/main" prst="upArrow">
             <a:avLst/>
           </a:prstGeom>
           <a:solidFill xmlns:a="http://schemas.openxmlformats.org/drawingml/2006/main">
@@ -22226,7 +22203,7 @@
           <p:cNvPr id="34" name="f175">
             <a:extLst xmlns:a="http://schemas.openxmlformats.org/drawingml/2006/main">
               <a:ext uri="{FF2B5EF4-FFF2-40B4-BE49-F238E27FC236}">
-                <a16:creationId xmlns:a16="http://schemas.microsoft.com/office/drawing/2014/main" id="{5B498833-7F22-4CC1-8CA6-B0437FD05358}"/>
+                <a16:creationId xmlns:a16="http://schemas.microsoft.com/office/drawing/2014/main" id="{609274E2-0D68-413C-9BCC-64C9435822C0}"/>
               </a:ext>
             </a:extLst>
           </p:cNvPr>
@@ -22237,27 +22214,155 @@
         </p:nvSpPr>
         <p:spPr>
           <a:xfrm xmlns:a="http://schemas.openxmlformats.org/drawingml/2006/main">
-            <a:off x="5295900" y="3343275"/>
-            <a:ext cx="2971800" cy="95"/>
+            <a:off x="1905000" y="7162800"/>
+            <a:ext cx="4476750" cy="304800"/>
           </a:xfrm>
-          <a:prstGeom xmlns:a="http://schemas.openxmlformats.org/drawingml/2006/main" prst="line">
+          <a:prstGeom xmlns:a="http://schemas.openxmlformats.org/drawingml/2006/main" prst="rect">
             <a:avLst/>
           </a:prstGeom>
           <a:noFill xmlns:a="http://schemas.openxmlformats.org/drawingml/2006/main"/>
-          <a:ln xmlns:a="http://schemas.openxmlformats.org/drawingml/2006/main" w="28575">
-            <a:solidFill>
-              <a:srgbClr val="4264D0"/>
-            </a:solidFill>
+          <a:ln xmlns:a="http://schemas.openxmlformats.org/drawingml/2006/main" w="0">
+            <a:noFill/>
             <a:prstDash val="solid"/>
           </a:ln>
         </p:spPr>
+        <p:txBody>
+          <a:bodyPr xmlns:a="http://schemas.openxmlformats.org/drawingml/2006/main" wrap="none" lIns="0" tIns="0" rIns="0" bIns="0" anchor="t">
+            <a:noAutofit/>
+          </a:bodyPr>
+          <a:lstStyle xmlns:a="http://schemas.openxmlformats.org/drawingml/2006/main">
+            <a:defPPr algn="ctr">
+              <a:defRPr sz="1575" b="0">
+                <a:solidFill>
+                  <a:srgbClr val="52627B"/>
+                </a:solidFill>
+                <a:latin typeface="Nimbus Sans"/>
+                <a:ea typeface="Nimbus Sans"/>
+                <a:cs typeface="Nimbus Sans"/>
+              </a:defRPr>
+            </a:defPPr>
+            <a:lvl1pPr algn="ctr">
+              <a:defRPr sz="1575" b="0">
+                <a:solidFill>
+                  <a:srgbClr val="52627B"/>
+                </a:solidFill>
+                <a:latin typeface="Nimbus Sans"/>
+                <a:ea typeface="Nimbus Sans"/>
+                <a:cs typeface="Nimbus Sans"/>
+              </a:defRPr>
+            </a:lvl1pPr>
+            <a:lvl2pPr algn="ctr">
+              <a:defRPr sz="1575" b="0">
+                <a:solidFill>
+                  <a:srgbClr val="52627B"/>
+                </a:solidFill>
+                <a:latin typeface="Nimbus Sans"/>
+                <a:ea typeface="Nimbus Sans"/>
+                <a:cs typeface="Nimbus Sans"/>
+              </a:defRPr>
+            </a:lvl2pPr>
+            <a:lvl3pPr algn="ctr">
+              <a:defRPr sz="1575" b="0">
+                <a:solidFill>
+                  <a:srgbClr val="52627B"/>
+                </a:solidFill>
+                <a:latin typeface="Nimbus Sans"/>
+                <a:ea typeface="Nimbus Sans"/>
+                <a:cs typeface="Nimbus Sans"/>
+              </a:defRPr>
+            </a:lvl3pPr>
+            <a:lvl4pPr algn="ctr">
+              <a:defRPr sz="1575" b="0">
+                <a:solidFill>
+                  <a:srgbClr val="52627B"/>
+                </a:solidFill>
+                <a:latin typeface="Nimbus Sans"/>
+                <a:ea typeface="Nimbus Sans"/>
+                <a:cs typeface="Nimbus Sans"/>
+              </a:defRPr>
+            </a:lvl4pPr>
+            <a:lvl5pPr algn="ctr">
+              <a:defRPr sz="1575" b="0">
+                <a:solidFill>
+                  <a:srgbClr val="52627B"/>
+                </a:solidFill>
+                <a:latin typeface="Nimbus Sans"/>
+                <a:ea typeface="Nimbus Sans"/>
+                <a:cs typeface="Nimbus Sans"/>
+              </a:defRPr>
+            </a:lvl5pPr>
+            <a:lvl6pPr algn="ctr">
+              <a:defRPr sz="1575" b="0">
+                <a:solidFill>
+                  <a:srgbClr val="52627B"/>
+                </a:solidFill>
+                <a:latin typeface="Nimbus Sans"/>
+                <a:ea typeface="Nimbus Sans"/>
+                <a:cs typeface="Nimbus Sans"/>
+              </a:defRPr>
+            </a:lvl6pPr>
+            <a:lvl7pPr algn="ctr">
+              <a:defRPr sz="1575" b="0">
+                <a:solidFill>
+                  <a:srgbClr val="52627B"/>
+                </a:solidFill>
+                <a:latin typeface="Nimbus Sans"/>
+                <a:ea typeface="Nimbus Sans"/>
+                <a:cs typeface="Nimbus Sans"/>
+              </a:defRPr>
+            </a:lvl7pPr>
+            <a:lvl8pPr algn="ctr">
+              <a:defRPr sz="1575" b="0">
+                <a:solidFill>
+                  <a:srgbClr val="52627B"/>
+                </a:solidFill>
+                <a:latin typeface="Nimbus Sans"/>
+                <a:ea typeface="Nimbus Sans"/>
+                <a:cs typeface="Nimbus Sans"/>
+              </a:defRPr>
+            </a:lvl8pPr>
+            <a:lvl9pPr algn="ctr">
+              <a:defRPr sz="1575" b="0">
+                <a:solidFill>
+                  <a:srgbClr val="52627B"/>
+                </a:solidFill>
+                <a:latin typeface="Nimbus Sans"/>
+                <a:ea typeface="Nimbus Sans"/>
+                <a:cs typeface="Nimbus Sans"/>
+              </a:defRPr>
+            </a:lvl9pPr>
+          </a:lstStyle>
+          <a:p xmlns:a="http://schemas.openxmlformats.org/drawingml/2006/main">
+            <a:pPr algn="ctr">
+              <a:defRPr sz="1575" b="0">
+                <a:solidFill>
+                  <a:srgbClr val="52627B"/>
+                </a:solidFill>
+                <a:latin typeface="Nimbus Sans"/>
+                <a:ea typeface="Nimbus Sans"/>
+                <a:cs typeface="Nimbus Sans"/>
+              </a:defRPr>
+            </a:pPr>
+            <a:r>
+              <a:rPr sz="1575" b="0">
+                <a:solidFill>
+                  <a:srgbClr val="52627B"/>
+                </a:solidFill>
+                <a:latin typeface="Nimbus Sans"/>
+                <a:ea typeface="Nimbus Sans"/>
+                <a:cs typeface="Nimbus Sans"/>
+              </a:rPr>
+              <a:t>Selezione dei frame rilevanti da modificare</a:t>
+            </a:r>
+          </a:p>
+        </p:txBody>
       </p:sp>
       <p:sp>
         <p:nvSpPr>
           <p:cNvPr id="35" name="f176">
             <a:extLst xmlns:a="http://schemas.openxmlformats.org/drawingml/2006/main">
               <a:ext uri="{FF2B5EF4-FFF2-40B4-BE49-F238E27FC236}">
-                <a16:creationId xmlns:a16="http://schemas.microsoft.com/office/drawing/2014/main" id="{D520BFD9-A676-4345-93B9-A6E5E1746531}"/>
+                <a16:creationId xmlns:a16="http://schemas.microsoft.com/office/drawing/2014/main" id="{CDBA6A27-C716-4A72-B435-7A94DD45EADA}"/>
               </a:ext>
             </a:extLst>
           </p:cNvPr>
@@ -22268,8 +22373,8 @@
         </p:nvSpPr>
         <p:spPr>
           <a:xfrm xmlns:a="http://schemas.openxmlformats.org/drawingml/2006/main">
-            <a:off x="8267700" y="3343275"/>
-            <a:ext cx="95" cy="1704975"/>
+            <a:off x="5200650" y="3343275"/>
+            <a:ext cx="2895600" cy="95"/>
           </a:xfrm>
           <a:prstGeom xmlns:a="http://schemas.openxmlformats.org/drawingml/2006/main" prst="line">
             <a:avLst/>
@@ -22288,7 +22393,7 @@
           <p:cNvPr id="36" name="f177">
             <a:extLst xmlns:a="http://schemas.openxmlformats.org/drawingml/2006/main">
               <a:ext uri="{FF2B5EF4-FFF2-40B4-BE49-F238E27FC236}">
-                <a16:creationId xmlns:a16="http://schemas.microsoft.com/office/drawing/2014/main" id="{61B2D15E-0465-4C6B-B64A-77EE4CDE368F}"/>
+                <a16:creationId xmlns:a16="http://schemas.microsoft.com/office/drawing/2014/main" id="{BACF0201-6783-4329-9854-832BBE14010E}"/>
               </a:ext>
             </a:extLst>
           </p:cNvPr>
@@ -22299,17 +22404,17 @@
         </p:nvSpPr>
         <p:spPr>
           <a:xfrm xmlns:a="http://schemas.openxmlformats.org/drawingml/2006/main">
-            <a:off x="8153400" y="4962525"/>
-            <a:ext cx="114300" cy="171450"/>
+            <a:off x="8096250" y="3343275"/>
+            <a:ext cx="95" cy="2228850"/>
           </a:xfrm>
-          <a:prstGeom xmlns:a="http://schemas.openxmlformats.org/drawingml/2006/main" prst="leftArrow">
+          <a:prstGeom xmlns:a="http://schemas.openxmlformats.org/drawingml/2006/main" prst="line">
             <a:avLst/>
           </a:prstGeom>
-          <a:solidFill xmlns:a="http://schemas.openxmlformats.org/drawingml/2006/main">
-            <a:srgbClr val="4264D0"/>
-          </a:solidFill>
-          <a:ln xmlns:a="http://schemas.openxmlformats.org/drawingml/2006/main" w="0">
-            <a:noFill/>
+          <a:noFill xmlns:a="http://schemas.openxmlformats.org/drawingml/2006/main"/>
+          <a:ln xmlns:a="http://schemas.openxmlformats.org/drawingml/2006/main" w="28575">
+            <a:solidFill>
+              <a:srgbClr val="4264D0"/>
+            </a:solidFill>
             <a:prstDash val="solid"/>
           </a:ln>
         </p:spPr>
@@ -22319,7 +22424,7 @@
           <p:cNvPr id="37" name="f178">
             <a:extLst xmlns:a="http://schemas.openxmlformats.org/drawingml/2006/main">
               <a:ext uri="{FF2B5EF4-FFF2-40B4-BE49-F238E27FC236}">
-                <a16:creationId xmlns:a16="http://schemas.microsoft.com/office/drawing/2014/main" id="{255EF17D-F356-411C-8334-57943EA25507}"/>
+                <a16:creationId xmlns:a16="http://schemas.microsoft.com/office/drawing/2014/main" id="{6C6ABB35-48CE-4F91-BB2B-3EBF29FD5875}"/>
               </a:ext>
             </a:extLst>
           </p:cNvPr>
@@ -22330,8 +22435,8 @@
         </p:nvSpPr>
         <p:spPr>
           <a:xfrm xmlns:a="http://schemas.openxmlformats.org/drawingml/2006/main">
-            <a:off x="7334250" y="4333875"/>
-            <a:ext cx="95" cy="171450"/>
+            <a:off x="7896225" y="5572125"/>
+            <a:ext cx="200025" cy="95"/>
           </a:xfrm>
           <a:prstGeom xmlns:a="http://schemas.openxmlformats.org/drawingml/2006/main" prst="line">
             <a:avLst/>
@@ -22350,7 +22455,7 @@
           <p:cNvPr id="38" name="f179">
             <a:extLst xmlns:a="http://schemas.openxmlformats.org/drawingml/2006/main">
               <a:ext uri="{FF2B5EF4-FFF2-40B4-BE49-F238E27FC236}">
-                <a16:creationId xmlns:a16="http://schemas.microsoft.com/office/drawing/2014/main" id="{CB9467BA-58A1-4206-8AF3-F074B33278D9}"/>
+                <a16:creationId xmlns:a16="http://schemas.microsoft.com/office/drawing/2014/main" id="{266397D4-5B19-4E6A-A19C-882DB926190F}"/>
               </a:ext>
             </a:extLst>
           </p:cNvPr>
@@ -22361,10 +22466,10 @@
         </p:nvSpPr>
         <p:spPr>
           <a:xfrm xmlns:a="http://schemas.openxmlformats.org/drawingml/2006/main">
-            <a:off x="7277100" y="4219575"/>
-            <a:ext cx="114300" cy="114300"/>
+            <a:off x="7724775" y="5486400"/>
+            <a:ext cx="171450" cy="171450"/>
           </a:xfrm>
-          <a:prstGeom xmlns:a="http://schemas.openxmlformats.org/drawingml/2006/main" prst="upArrow">
+          <a:prstGeom xmlns:a="http://schemas.openxmlformats.org/drawingml/2006/main" prst="leftArrow">
             <a:avLst/>
           </a:prstGeom>
           <a:solidFill xmlns:a="http://schemas.openxmlformats.org/drawingml/2006/main">
@@ -22381,7 +22486,7 @@
           <p:cNvPr id="39" name="f180">
             <a:extLst xmlns:a="http://schemas.openxmlformats.org/drawingml/2006/main">
               <a:ext uri="{FF2B5EF4-FFF2-40B4-BE49-F238E27FC236}">
-                <a16:creationId xmlns:a16="http://schemas.microsoft.com/office/drawing/2014/main" id="{0BCB81F1-44EB-49F9-A5DC-FCEA62004EF4}"/>
+                <a16:creationId xmlns:a16="http://schemas.microsoft.com/office/drawing/2014/main" id="{B632F246-A5D8-4C4F-A1C0-FC7956EC3A56}"/>
               </a:ext>
             </a:extLst>
           </p:cNvPr>
@@ -22392,8 +22497,8 @@
         </p:nvSpPr>
         <p:spPr>
           <a:xfrm xmlns:a="http://schemas.openxmlformats.org/drawingml/2006/main">
-            <a:off x="6096000" y="3867150"/>
-            <a:ext cx="361950" cy="95"/>
+            <a:off x="6810375" y="4476750"/>
+            <a:ext cx="95" cy="552450"/>
           </a:xfrm>
           <a:prstGeom xmlns:a="http://schemas.openxmlformats.org/drawingml/2006/main" prst="line">
             <a:avLst/>
@@ -22412,7 +22517,7 @@
           <p:cNvPr id="40" name="f181">
             <a:extLst xmlns:a="http://schemas.openxmlformats.org/drawingml/2006/main">
               <a:ext uri="{FF2B5EF4-FFF2-40B4-BE49-F238E27FC236}">
-                <a16:creationId xmlns:a16="http://schemas.microsoft.com/office/drawing/2014/main" id="{4F61F02D-F774-4F54-BA7F-9B0C7377F873}"/>
+                <a16:creationId xmlns:a16="http://schemas.microsoft.com/office/drawing/2014/main" id="{B995046F-087E-41E5-A804-57236E12A255}"/>
               </a:ext>
             </a:extLst>
           </p:cNvPr>
@@ -22423,17 +22528,17 @@
         </p:nvSpPr>
         <p:spPr>
           <a:xfrm xmlns:a="http://schemas.openxmlformats.org/drawingml/2006/main">
-            <a:off x="6096000" y="3867150"/>
-            <a:ext cx="95" cy="942975"/>
+            <a:off x="6753225" y="4362450"/>
+            <a:ext cx="114300" cy="114300"/>
           </a:xfrm>
-          <a:prstGeom xmlns:a="http://schemas.openxmlformats.org/drawingml/2006/main" prst="line">
+          <a:prstGeom xmlns:a="http://schemas.openxmlformats.org/drawingml/2006/main" prst="upArrow">
             <a:avLst/>
           </a:prstGeom>
-          <a:noFill xmlns:a="http://schemas.openxmlformats.org/drawingml/2006/main"/>
-          <a:ln xmlns:a="http://schemas.openxmlformats.org/drawingml/2006/main" w="28575">
-            <a:solidFill>
-              <a:srgbClr val="4264D0"/>
-            </a:solidFill>
+          <a:solidFill xmlns:a="http://schemas.openxmlformats.org/drawingml/2006/main">
+            <a:srgbClr val="4264D0"/>
+          </a:solidFill>
+          <a:ln xmlns:a="http://schemas.openxmlformats.org/drawingml/2006/main" w="0">
+            <a:noFill/>
             <a:prstDash val="solid"/>
           </a:ln>
         </p:spPr>
@@ -22443,7 +22548,7 @@
           <p:cNvPr id="41" name="f182">
             <a:extLst xmlns:a="http://schemas.openxmlformats.org/drawingml/2006/main">
               <a:ext uri="{FF2B5EF4-FFF2-40B4-BE49-F238E27FC236}">
-                <a16:creationId xmlns:a16="http://schemas.microsoft.com/office/drawing/2014/main" id="{049B7E75-3146-43DC-BE8A-008FB2F77598}"/>
+                <a16:creationId xmlns:a16="http://schemas.microsoft.com/office/drawing/2014/main" id="{63048B75-8F96-4336-B239-D1AF0CFCD1B8}"/>
               </a:ext>
             </a:extLst>
           </p:cNvPr>
@@ -22454,8 +22559,8 @@
         </p:nvSpPr>
         <p:spPr>
           <a:xfrm xmlns:a="http://schemas.openxmlformats.org/drawingml/2006/main">
-            <a:off x="5219700" y="4810125"/>
-            <a:ext cx="876300" cy="95"/>
+            <a:off x="5572125" y="4010025"/>
+            <a:ext cx="266700" cy="95"/>
           </a:xfrm>
           <a:prstGeom xmlns:a="http://schemas.openxmlformats.org/drawingml/2006/main" prst="line">
             <a:avLst/>
@@ -22474,7 +22579,69 @@
           <p:cNvPr id="42" name="f183">
             <a:extLst xmlns:a="http://schemas.openxmlformats.org/drawingml/2006/main">
               <a:ext uri="{FF2B5EF4-FFF2-40B4-BE49-F238E27FC236}">
-                <a16:creationId xmlns:a16="http://schemas.microsoft.com/office/drawing/2014/main" id="{FDD272E0-46F8-40BE-A2CB-18A5F5B73913}"/>
+                <a16:creationId xmlns:a16="http://schemas.microsoft.com/office/drawing/2014/main" id="{605AC6FA-AE8F-446D-A013-4B925D7282D7}"/>
+              </a:ext>
+            </a:extLst>
+          </p:cNvPr>
+          <p:cNvSpPr>
+            <a:spLocks xmlns:a="http://schemas.openxmlformats.org/drawingml/2006/main" noGrp="1"/>
+          </p:cNvSpPr>
+          <p:nvPr/>
+        </p:nvSpPr>
+        <p:spPr>
+          <a:xfrm xmlns:a="http://schemas.openxmlformats.org/drawingml/2006/main">
+            <a:off x="5572125" y="4010025"/>
+            <a:ext cx="95" cy="800100"/>
+          </a:xfrm>
+          <a:prstGeom xmlns:a="http://schemas.openxmlformats.org/drawingml/2006/main" prst="line">
+            <a:avLst/>
+          </a:prstGeom>
+          <a:noFill xmlns:a="http://schemas.openxmlformats.org/drawingml/2006/main"/>
+          <a:ln xmlns:a="http://schemas.openxmlformats.org/drawingml/2006/main" w="28575">
+            <a:solidFill>
+              <a:srgbClr val="4264D0"/>
+            </a:solidFill>
+            <a:prstDash val="solid"/>
+          </a:ln>
+        </p:spPr>
+      </p:sp>
+      <p:sp>
+        <p:nvSpPr>
+          <p:cNvPr id="43" name="f184">
+            <a:extLst xmlns:a="http://schemas.openxmlformats.org/drawingml/2006/main">
+              <a:ext uri="{FF2B5EF4-FFF2-40B4-BE49-F238E27FC236}">
+                <a16:creationId xmlns:a16="http://schemas.microsoft.com/office/drawing/2014/main" id="{532AEBC0-46CC-44CE-A198-4043102EB64E}"/>
+              </a:ext>
+            </a:extLst>
+          </p:cNvPr>
+          <p:cNvSpPr>
+            <a:spLocks xmlns:a="http://schemas.openxmlformats.org/drawingml/2006/main" noGrp="1"/>
+          </p:cNvSpPr>
+          <p:nvPr/>
+        </p:nvSpPr>
+        <p:spPr>
+          <a:xfrm xmlns:a="http://schemas.openxmlformats.org/drawingml/2006/main">
+            <a:off x="5219700" y="4810125"/>
+            <a:ext cx="352425" cy="95"/>
+          </a:xfrm>
+          <a:prstGeom xmlns:a="http://schemas.openxmlformats.org/drawingml/2006/main" prst="line">
+            <a:avLst/>
+          </a:prstGeom>
+          <a:noFill xmlns:a="http://schemas.openxmlformats.org/drawingml/2006/main"/>
+          <a:ln xmlns:a="http://schemas.openxmlformats.org/drawingml/2006/main" w="28575">
+            <a:solidFill>
+              <a:srgbClr val="4264D0"/>
+            </a:solidFill>
+            <a:prstDash val="solid"/>
+          </a:ln>
+        </p:spPr>
+      </p:sp>
+      <p:sp>
+        <p:nvSpPr>
+          <p:cNvPr id="44" name="f185">
+            <a:extLst xmlns:a="http://schemas.openxmlformats.org/drawingml/2006/main">
+              <a:ext uri="{FF2B5EF4-FFF2-40B4-BE49-F238E27FC236}">
+                <a16:creationId xmlns:a16="http://schemas.microsoft.com/office/drawing/2014/main" id="{8241F6DC-6CBB-47C0-8303-534DADABFA52}"/>
               </a:ext>
             </a:extLst>
           </p:cNvPr>
@@ -22502,351 +22669,10 @@
       </p:sp>
       <p:sp>
         <p:nvSpPr>
-          <p:cNvPr id="43" name="f184">
-            <a:extLst xmlns:a="http://schemas.openxmlformats.org/drawingml/2006/main">
-              <a:ext uri="{FF2B5EF4-FFF2-40B4-BE49-F238E27FC236}">
-                <a16:creationId xmlns:a16="http://schemas.microsoft.com/office/drawing/2014/main" id="{A4537D89-1191-4C08-BB37-61541B4FABFD}"/>
-              </a:ext>
-            </a:extLst>
-          </p:cNvPr>
-          <p:cNvSpPr>
-            <a:spLocks xmlns:a="http://schemas.openxmlformats.org/drawingml/2006/main" noGrp="1"/>
-          </p:cNvSpPr>
-          <p:nvPr/>
-        </p:nvSpPr>
-        <p:spPr>
-          <a:xfrm xmlns:a="http://schemas.openxmlformats.org/drawingml/2006/main">
-            <a:off x="6477000" y="5715000"/>
-            <a:ext cx="1714500" cy="285750"/>
-          </a:xfrm>
-          <a:prstGeom xmlns:a="http://schemas.openxmlformats.org/drawingml/2006/main" prst="rect">
-            <a:avLst/>
-          </a:prstGeom>
-          <a:noFill xmlns:a="http://schemas.openxmlformats.org/drawingml/2006/main"/>
-          <a:ln xmlns:a="http://schemas.openxmlformats.org/drawingml/2006/main" w="0">
-            <a:noFill/>
-            <a:prstDash val="solid"/>
-          </a:ln>
-        </p:spPr>
-        <p:txBody>
-          <a:bodyPr xmlns:a="http://schemas.openxmlformats.org/drawingml/2006/main" wrap="none" lIns="0" tIns="0" rIns="0" bIns="0" anchor="t">
-            <a:noAutofit/>
-          </a:bodyPr>
-          <a:lstStyle xmlns:a="http://schemas.openxmlformats.org/drawingml/2006/main">
-            <a:defPPr algn="ctr">
-              <a:defRPr sz="1425" b="0">
-                <a:solidFill>
-                  <a:srgbClr val="9D7139"/>
-                </a:solidFill>
-                <a:latin typeface="Nimbus Sans"/>
-                <a:ea typeface="Nimbus Sans"/>
-                <a:cs typeface="Nimbus Sans"/>
-              </a:defRPr>
-            </a:defPPr>
-            <a:lvl1pPr algn="ctr">
-              <a:defRPr sz="1425" b="0">
-                <a:solidFill>
-                  <a:srgbClr val="9D7139"/>
-                </a:solidFill>
-                <a:latin typeface="Nimbus Sans"/>
-                <a:ea typeface="Nimbus Sans"/>
-                <a:cs typeface="Nimbus Sans"/>
-              </a:defRPr>
-            </a:lvl1pPr>
-            <a:lvl2pPr algn="ctr">
-              <a:defRPr sz="1425" b="0">
-                <a:solidFill>
-                  <a:srgbClr val="9D7139"/>
-                </a:solidFill>
-                <a:latin typeface="Nimbus Sans"/>
-                <a:ea typeface="Nimbus Sans"/>
-                <a:cs typeface="Nimbus Sans"/>
-              </a:defRPr>
-            </a:lvl2pPr>
-            <a:lvl3pPr algn="ctr">
-              <a:defRPr sz="1425" b="0">
-                <a:solidFill>
-                  <a:srgbClr val="9D7139"/>
-                </a:solidFill>
-                <a:latin typeface="Nimbus Sans"/>
-                <a:ea typeface="Nimbus Sans"/>
-                <a:cs typeface="Nimbus Sans"/>
-              </a:defRPr>
-            </a:lvl3pPr>
-            <a:lvl4pPr algn="ctr">
-              <a:defRPr sz="1425" b="0">
-                <a:solidFill>
-                  <a:srgbClr val="9D7139"/>
-                </a:solidFill>
-                <a:latin typeface="Nimbus Sans"/>
-                <a:ea typeface="Nimbus Sans"/>
-                <a:cs typeface="Nimbus Sans"/>
-              </a:defRPr>
-            </a:lvl4pPr>
-            <a:lvl5pPr algn="ctr">
-              <a:defRPr sz="1425" b="0">
-                <a:solidFill>
-                  <a:srgbClr val="9D7139"/>
-                </a:solidFill>
-                <a:latin typeface="Nimbus Sans"/>
-                <a:ea typeface="Nimbus Sans"/>
-                <a:cs typeface="Nimbus Sans"/>
-              </a:defRPr>
-            </a:lvl5pPr>
-            <a:lvl6pPr algn="ctr">
-              <a:defRPr sz="1425" b="0">
-                <a:solidFill>
-                  <a:srgbClr val="9D7139"/>
-                </a:solidFill>
-                <a:latin typeface="Nimbus Sans"/>
-                <a:ea typeface="Nimbus Sans"/>
-                <a:cs typeface="Nimbus Sans"/>
-              </a:defRPr>
-            </a:lvl6pPr>
-            <a:lvl7pPr algn="ctr">
-              <a:defRPr sz="1425" b="0">
-                <a:solidFill>
-                  <a:srgbClr val="9D7139"/>
-                </a:solidFill>
-                <a:latin typeface="Nimbus Sans"/>
-                <a:ea typeface="Nimbus Sans"/>
-                <a:cs typeface="Nimbus Sans"/>
-              </a:defRPr>
-            </a:lvl7pPr>
-            <a:lvl8pPr algn="ctr">
-              <a:defRPr sz="1425" b="0">
-                <a:solidFill>
-                  <a:srgbClr val="9D7139"/>
-                </a:solidFill>
-                <a:latin typeface="Nimbus Sans"/>
-                <a:ea typeface="Nimbus Sans"/>
-                <a:cs typeface="Nimbus Sans"/>
-              </a:defRPr>
-            </a:lvl8pPr>
-            <a:lvl9pPr algn="ctr">
-              <a:defRPr sz="1425" b="0">
-                <a:solidFill>
-                  <a:srgbClr val="9D7139"/>
-                </a:solidFill>
-                <a:latin typeface="Nimbus Sans"/>
-                <a:ea typeface="Nimbus Sans"/>
-                <a:cs typeface="Nimbus Sans"/>
-              </a:defRPr>
-            </a:lvl9pPr>
-          </a:lstStyle>
-          <a:p xmlns:a="http://schemas.openxmlformats.org/drawingml/2006/main">
-            <a:pPr algn="ctr">
-              <a:defRPr sz="1425" b="0">
-                <a:solidFill>
-                  <a:srgbClr val="9D7139"/>
-                </a:solidFill>
-                <a:latin typeface="Nimbus Sans"/>
-                <a:ea typeface="Nimbus Sans"/>
-                <a:cs typeface="Nimbus Sans"/>
-              </a:defRPr>
-            </a:pPr>
-            <a:r>
-              <a:rPr sz="1425" b="0">
-                <a:solidFill>
-                  <a:srgbClr val="9D7139"/>
-                </a:solidFill>
-                <a:latin typeface="Nimbus Sans"/>
-                <a:ea typeface="Nimbus Sans"/>
-                <a:cs typeface="Nimbus Sans"/>
-              </a:rPr>
-              <a:t>Esterno · offline</a:t>
-            </a:r>
-          </a:p>
-        </p:txBody>
-      </p:sp>
-      <p:sp>
-        <p:nvSpPr>
-          <p:cNvPr id="44" name="f185">
-            <a:extLst xmlns:a="http://schemas.openxmlformats.org/drawingml/2006/main">
-              <a:ext uri="{FF2B5EF4-FFF2-40B4-BE49-F238E27FC236}">
-                <a16:creationId xmlns:a16="http://schemas.microsoft.com/office/drawing/2014/main" id="{189B9964-ABBC-43C8-92F2-931D2688AD01}"/>
-              </a:ext>
-            </a:extLst>
-          </p:cNvPr>
-          <p:cNvSpPr>
-            <a:spLocks xmlns:a="http://schemas.openxmlformats.org/drawingml/2006/main" noGrp="1"/>
-          </p:cNvSpPr>
-          <p:nvPr/>
-        </p:nvSpPr>
-        <p:spPr>
-          <a:xfrm xmlns:a="http://schemas.openxmlformats.org/drawingml/2006/main">
-            <a:off x="6429375" y="6057900"/>
-            <a:ext cx="1809750" cy="561975"/>
-          </a:xfrm>
-          <a:prstGeom xmlns:a="http://schemas.openxmlformats.org/drawingml/2006/main" prst="rect">
-            <a:avLst/>
-          </a:prstGeom>
-          <a:noFill xmlns:a="http://schemas.openxmlformats.org/drawingml/2006/main"/>
-          <a:ln xmlns:a="http://schemas.openxmlformats.org/drawingml/2006/main" w="0">
-            <a:noFill/>
-            <a:prstDash val="solid"/>
-          </a:ln>
-        </p:spPr>
-        <p:txBody>
-          <a:bodyPr xmlns:a="http://schemas.openxmlformats.org/drawingml/2006/main" wrap="none" lIns="0" tIns="0" rIns="0" bIns="0" anchor="t">
-            <a:noAutofit/>
-          </a:bodyPr>
-          <a:lstStyle xmlns:a="http://schemas.openxmlformats.org/drawingml/2006/main">
-            <a:defPPr algn="ctr">
-              <a:defRPr sz="1425" b="0">
-                <a:solidFill>
-                  <a:srgbClr val="52627B"/>
-                </a:solidFill>
-                <a:latin typeface="Nimbus Sans"/>
-                <a:ea typeface="Nimbus Sans"/>
-                <a:cs typeface="Nimbus Sans"/>
-              </a:defRPr>
-            </a:defPPr>
-            <a:lvl1pPr algn="ctr">
-              <a:defRPr sz="1425" b="0">
-                <a:solidFill>
-                  <a:srgbClr val="52627B"/>
-                </a:solidFill>
-                <a:latin typeface="Nimbus Sans"/>
-                <a:ea typeface="Nimbus Sans"/>
-                <a:cs typeface="Nimbus Sans"/>
-              </a:defRPr>
-            </a:lvl1pPr>
-            <a:lvl2pPr algn="ctr">
-              <a:defRPr sz="1425" b="0">
-                <a:solidFill>
-                  <a:srgbClr val="52627B"/>
-                </a:solidFill>
-                <a:latin typeface="Nimbus Sans"/>
-                <a:ea typeface="Nimbus Sans"/>
-                <a:cs typeface="Nimbus Sans"/>
-              </a:defRPr>
-            </a:lvl2pPr>
-            <a:lvl3pPr algn="ctr">
-              <a:defRPr sz="1425" b="0">
-                <a:solidFill>
-                  <a:srgbClr val="52627B"/>
-                </a:solidFill>
-                <a:latin typeface="Nimbus Sans"/>
-                <a:ea typeface="Nimbus Sans"/>
-                <a:cs typeface="Nimbus Sans"/>
-              </a:defRPr>
-            </a:lvl3pPr>
-            <a:lvl4pPr algn="ctr">
-              <a:defRPr sz="1425" b="0">
-                <a:solidFill>
-                  <a:srgbClr val="52627B"/>
-                </a:solidFill>
-                <a:latin typeface="Nimbus Sans"/>
-                <a:ea typeface="Nimbus Sans"/>
-                <a:cs typeface="Nimbus Sans"/>
-              </a:defRPr>
-            </a:lvl4pPr>
-            <a:lvl5pPr algn="ctr">
-              <a:defRPr sz="1425" b="0">
-                <a:solidFill>
-                  <a:srgbClr val="52627B"/>
-                </a:solidFill>
-                <a:latin typeface="Nimbus Sans"/>
-                <a:ea typeface="Nimbus Sans"/>
-                <a:cs typeface="Nimbus Sans"/>
-              </a:defRPr>
-            </a:lvl5pPr>
-            <a:lvl6pPr algn="ctr">
-              <a:defRPr sz="1425" b="0">
-                <a:solidFill>
-                  <a:srgbClr val="52627B"/>
-                </a:solidFill>
-                <a:latin typeface="Nimbus Sans"/>
-                <a:ea typeface="Nimbus Sans"/>
-                <a:cs typeface="Nimbus Sans"/>
-              </a:defRPr>
-            </a:lvl6pPr>
-            <a:lvl7pPr algn="ctr">
-              <a:defRPr sz="1425" b="0">
-                <a:solidFill>
-                  <a:srgbClr val="52627B"/>
-                </a:solidFill>
-                <a:latin typeface="Nimbus Sans"/>
-                <a:ea typeface="Nimbus Sans"/>
-                <a:cs typeface="Nimbus Sans"/>
-              </a:defRPr>
-            </a:lvl7pPr>
-            <a:lvl8pPr algn="ctr">
-              <a:defRPr sz="1425" b="0">
-                <a:solidFill>
-                  <a:srgbClr val="52627B"/>
-                </a:solidFill>
-                <a:latin typeface="Nimbus Sans"/>
-                <a:ea typeface="Nimbus Sans"/>
-                <a:cs typeface="Nimbus Sans"/>
-              </a:defRPr>
-            </a:lvl8pPr>
-            <a:lvl9pPr algn="ctr">
-              <a:defRPr sz="1425" b="0">
-                <a:solidFill>
-                  <a:srgbClr val="52627B"/>
-                </a:solidFill>
-                <a:latin typeface="Nimbus Sans"/>
-                <a:ea typeface="Nimbus Sans"/>
-                <a:cs typeface="Nimbus Sans"/>
-              </a:defRPr>
-            </a:lvl9pPr>
-          </a:lstStyle>
-          <a:p xmlns:a="http://schemas.openxmlformats.org/drawingml/2006/main">
-            <a:pPr algn="ctr">
-              <a:defRPr sz="1425" b="0">
-                <a:solidFill>
-                  <a:srgbClr val="52627B"/>
-                </a:solidFill>
-                <a:latin typeface="Nimbus Sans"/>
-                <a:ea typeface="Nimbus Sans"/>
-                <a:cs typeface="Nimbus Sans"/>
-              </a:defRPr>
-            </a:pPr>
-            <a:r>
-              <a:rPr sz="1425" b="0">
-                <a:solidFill>
-                  <a:srgbClr val="52627B"/>
-                </a:solidFill>
-                <a:latin typeface="Nimbus Sans"/>
-                <a:ea typeface="Nimbus Sans"/>
-                <a:cs typeface="Nimbus Sans"/>
-              </a:rPr>
-              <a:t>Selezione dei frame</a:t>
-            </a:r>
-          </a:p>
-          <a:p xmlns:a="http://schemas.openxmlformats.org/drawingml/2006/main">
-            <a:pPr algn="ctr">
-              <a:defRPr sz="1425" b="0">
-                <a:solidFill>
-                  <a:srgbClr val="52627B"/>
-                </a:solidFill>
-                <a:latin typeface="Nimbus Sans"/>
-                <a:ea typeface="Nimbus Sans"/>
-                <a:cs typeface="Nimbus Sans"/>
-              </a:defRPr>
-            </a:pPr>
-            <a:r>
-              <a:rPr sz="1425" b="0">
-                <a:solidFill>
-                  <a:srgbClr val="52627B"/>
-                </a:solidFill>
-                <a:latin typeface="Nimbus Sans"/>
-                <a:ea typeface="Nimbus Sans"/>
-                <a:cs typeface="Nimbus Sans"/>
-              </a:rPr>
-              <a:t>rilevanti da modificare</a:t>
-            </a:r>
-          </a:p>
-        </p:txBody>
-      </p:sp>
-      <p:sp>
-        <p:nvSpPr>
           <p:cNvPr id="45" name="f186">
             <a:extLst xmlns:a="http://schemas.openxmlformats.org/drawingml/2006/main">
               <a:ext uri="{FF2B5EF4-FFF2-40B4-BE49-F238E27FC236}">
-                <a16:creationId xmlns:a16="http://schemas.microsoft.com/office/drawing/2014/main" id="{702899C9-A636-4B4C-B548-EF949F1C3293}"/>
+                <a16:creationId xmlns:a16="http://schemas.microsoft.com/office/drawing/2014/main" id="{D2BB4608-34DE-46A6-AD6C-86E0BB32E8EB}"/>
               </a:ext>
             </a:extLst>
           </p:cNvPr>
@@ -23005,7 +22831,7 @@
           <p:cNvPr id="46" name="">
             <a:extLst xmlns:a="http://schemas.openxmlformats.org/drawingml/2006/main">
               <a:ext uri="{FF2B5EF4-FFF2-40B4-BE49-F238E27FC236}">
-                <a16:creationId xmlns:a16="http://schemas.microsoft.com/office/drawing/2014/main" id="{2641AB07-2FBC-4B2A-AB65-93E48583ADB8}"/>
+                <a16:creationId xmlns:a16="http://schemas.microsoft.com/office/drawing/2014/main" id="{C5EE1700-CF70-4441-BD73-A4A3C35BDC3A}"/>
               </a:ext>
             </a:extLst>
           </p:cNvPr>
@@ -23608,7 +23434,7 @@
           <p:cNvPr id="47" name="f188">
             <a:extLst xmlns:a="http://schemas.openxmlformats.org/drawingml/2006/main">
               <a:ext uri="{FF2B5EF4-FFF2-40B4-BE49-F238E27FC236}">
-                <a16:creationId xmlns:a16="http://schemas.microsoft.com/office/drawing/2014/main" id="{2DAE94E1-8B4A-49AF-AECB-23BA4C6E6D07}"/>
+                <a16:creationId xmlns:a16="http://schemas.microsoft.com/office/drawing/2014/main" id="{E36E5F54-D02F-42C1-A0A7-34E5AF369261}"/>
               </a:ext>
             </a:extLst>
           </p:cNvPr>
@@ -23767,7 +23593,7 @@
           <p:cNvPr id="48" name="f189">
             <a:extLst xmlns:a="http://schemas.openxmlformats.org/drawingml/2006/main">
               <a:ext uri="{FF2B5EF4-FFF2-40B4-BE49-F238E27FC236}">
-                <a16:creationId xmlns:a16="http://schemas.microsoft.com/office/drawing/2014/main" id="{4017E7A4-DE1C-4C7D-9920-524BC9D4D254}"/>
+                <a16:creationId xmlns:a16="http://schemas.microsoft.com/office/drawing/2014/main" id="{0243ED90-1A24-4D92-AD9E-4267784AA64E}"/>
               </a:ext>
             </a:extLst>
           </p:cNvPr>
@@ -23947,7 +23773,7 @@
     </p:spTree>
     <p:extLst>
       <p:ext uri="{BB962C8B-B14F-4D97-AF65-F5344CB8AC3E}">
-        <p14:creationId xmlns:p14="http://schemas.microsoft.com/office/powerpoint/2010/main" val="854085806"/>
+        <p14:creationId xmlns:p14="http://schemas.microsoft.com/office/powerpoint/2010/main" val="171307039"/>
       </p:ext>
     </p:extLst>
   </p:cSld>

</xml_diff>

<commit_message>
Add two-phase baseline and mutation emphasis animation to slide 7
</commit_message>
<xml_diff>
--- a/5g-thesis-presentation-5min/tesi-5min-statico.pptx
+++ b/5g-thesis-presentation-5min/tesi-5min-statico.pptx
@@ -2,19 +2,19 @@
 <file path=ppt/presentation.xml><?xml version="1.0" encoding="utf-8"?>
 <p:presentation xmlns:p="http://schemas.openxmlformats.org/presentationml/2006/main">
   <p:sldMasterIdLst>
-    <p:sldMasterId xmlns:r="http://schemas.openxmlformats.org/officeDocument/2006/relationships" id="2147483648" r:id="R45c7171876144a49"/>
+    <p:sldMasterId xmlns:r="http://schemas.openxmlformats.org/officeDocument/2006/relationships" id="2147483648" r:id="R2ca2d8a7bc7d4b38"/>
   </p:sldMasterIdLst>
   <p:notesMasterIdLst>
-    <p:notesMasterId xmlns:r="http://schemas.openxmlformats.org/officeDocument/2006/relationships" r:id="R43868e43004a44aa"/>
+    <p:notesMasterId xmlns:r="http://schemas.openxmlformats.org/officeDocument/2006/relationships" r:id="R55425d0d98b84033"/>
   </p:notesMasterIdLst>
   <p:sldIdLst>
-    <p:sldId xmlns:r="http://schemas.openxmlformats.org/officeDocument/2006/relationships" id="256" r:id="R89a8cb36b901428c"/>
-    <p:sldId xmlns:r="http://schemas.openxmlformats.org/officeDocument/2006/relationships" id="257" r:id="Rc44d972dae8c4bd5"/>
-    <p:sldId xmlns:r="http://schemas.openxmlformats.org/officeDocument/2006/relationships" id="258" r:id="R8a69348e4f814a36"/>
-    <p:sldId xmlns:r="http://schemas.openxmlformats.org/officeDocument/2006/relationships" id="259" r:id="Rfe29da69dbc14462"/>
-    <p:sldId xmlns:r="http://schemas.openxmlformats.org/officeDocument/2006/relationships" id="260" r:id="R0115ff00dc104204"/>
-    <p:sldId xmlns:r="http://schemas.openxmlformats.org/officeDocument/2006/relationships" id="261" r:id="Rad1e9efb7cd7483d"/>
-    <p:sldId xmlns:r="http://schemas.openxmlformats.org/officeDocument/2006/relationships" id="262" r:id="Rccfa56830d424394"/>
+    <p:sldId xmlns:r="http://schemas.openxmlformats.org/officeDocument/2006/relationships" id="256" r:id="R90090369c0de4471"/>
+    <p:sldId xmlns:r="http://schemas.openxmlformats.org/officeDocument/2006/relationships" id="257" r:id="R229d8e9c322247ad"/>
+    <p:sldId xmlns:r="http://schemas.openxmlformats.org/officeDocument/2006/relationships" id="258" r:id="R59ae73be39254184"/>
+    <p:sldId xmlns:r="http://schemas.openxmlformats.org/officeDocument/2006/relationships" id="259" r:id="R77fe9015c59a4d1b"/>
+    <p:sldId xmlns:r="http://schemas.openxmlformats.org/officeDocument/2006/relationships" id="260" r:id="R768286205e0141cf"/>
+    <p:sldId xmlns:r="http://schemas.openxmlformats.org/officeDocument/2006/relationships" id="261" r:id="R2cd8f3f5fa064c5d"/>
+    <p:sldId xmlns:r="http://schemas.openxmlformats.org/officeDocument/2006/relationships" id="262" r:id="R4dd26d0b3eaa4406"/>
   </p:sldIdLst>
   <p:sldSz cx="15240000" cy="8572500"/>
   <p:notesSz cx="6858000" cy="9144000"/>
@@ -1053,7 +1053,7 @@
           <a:lstStyle xmlns:a="http://schemas.openxmlformats.org/drawingml/2006/main"/>
           <a:p xmlns:a="http://schemas.openxmlformats.org/drawingml/2006/main">
             <a:r>
-              <a:t>Per valutare la sensibilità del sistema ho introdotto modifiche controllate nelle catture. Il mutatore è separato dalla pipeline: riceve la PCAP originale e le evidenze del report baseline, individua i dati da modificare e produce la PCAP mutata. Questa torna nello stesso sistema di verifica, con la stessa DSL. Il confronto dei risultati deve corrispondere alla modifica introdotta. Nei 13 scenari completati ho ottenuto tutti i verdetti attesi. Gli esempi mostrano il cambio di stato NRF da HTTP 200 a 403, la violazione dell’intervallo temporale nel caso AMF A e la rimozione degli F-TEID disponibili per la verifica UPF. In quest’ultimo esperimento sono state rimosse le risposte PFCP rilevanti, producendo INCONCLUSIVE.</a:t>
+              <a:t>[Prima fase: baseline in evidenza. Un clic passa alla seconda fase: mutazione in evidenza. DSL e pipeline restano sempre attivi.] Per valutare la sensibilità del sistema ho introdotto modifiche controllate nelle catture. Il mutatore è separato dalla pipeline: riceve la PCAP originale e le evidenze del report baseline, individua i dati da modificare e produce la PCAP mutata. Questa torna nello stesso sistema di verifica, con la stessa DSL. Il confronto dei risultati deve corrispondere alla modifica introdotta. Nei 13 scenari completati ho ottenuto tutti i verdetti attesi. Gli esempi mostrano il cambio di stato NRF da HTTP 200 a 403, la violazione dell’intervallo temporale nel caso AMF A e la rimozione degli F-TEID disponibili per la verifica UPF. In quest’ultimo esperimento sono state rimosse le risposte PFCP rilevanti, producendo INCONCLUSIVE.</a:t>
             </a:r>
           </a:p>
           <a:p xmlns:a="http://schemas.openxmlformats.org/drawingml/2006/main">
@@ -1135,7 +1135,7 @@
           <p:cNvPr id="3" name="Title">
             <a:extLst xmlns:a="http://schemas.openxmlformats.org/drawingml/2006/main">
               <a:ext uri="{FF2B5EF4-FFF2-40B4-BE49-F238E27FC236}">
-                <a16:creationId xmlns:a16="http://schemas.microsoft.com/office/drawing/2014/main" id="{8FE6C73A-BBCE-4D70-AE6B-BA1B16477AA2}"/>
+                <a16:creationId xmlns:a16="http://schemas.microsoft.com/office/drawing/2014/main" id="{E4349258-73DC-4F40-B220-529F8B7A1DAA}"/>
               </a:ext>
             </a:extLst>
           </p:cNvPr>
@@ -1364,7 +1364,7 @@
           <p:cNvPr id="2" name="Subtitle">
             <a:extLst xmlns:a="http://schemas.openxmlformats.org/drawingml/2006/main">
               <a:ext uri="{FF2B5EF4-FFF2-40B4-BE49-F238E27FC236}">
-                <a16:creationId xmlns:a16="http://schemas.microsoft.com/office/drawing/2014/main" id="{2547F167-2F2A-4616-829C-DC0D8D41C126}"/>
+                <a16:creationId xmlns:a16="http://schemas.microsoft.com/office/drawing/2014/main" id="{4AFFB083-48F1-4F74-9DB1-5945E00F92C4}"/>
               </a:ext>
             </a:extLst>
           </p:cNvPr>
@@ -1610,7 +1610,7 @@
           <p:cNvPr id="2" name="Section title">
             <a:extLst xmlns:a="http://schemas.openxmlformats.org/drawingml/2006/main">
               <a:ext uri="{FF2B5EF4-FFF2-40B4-BE49-F238E27FC236}">
-                <a16:creationId xmlns:a16="http://schemas.microsoft.com/office/drawing/2014/main" id="{D6DA0569-94FF-450A-8C2B-6BBB0DDAEDBE}"/>
+                <a16:creationId xmlns:a16="http://schemas.microsoft.com/office/drawing/2014/main" id="{6637C521-8648-4AE8-9BF5-539F81868292}"/>
               </a:ext>
             </a:extLst>
           </p:cNvPr>
@@ -1856,7 +1856,7 @@
           <p:cNvPr id="3" name="Title">
             <a:extLst xmlns:a="http://schemas.openxmlformats.org/drawingml/2006/main">
               <a:ext uri="{FF2B5EF4-FFF2-40B4-BE49-F238E27FC236}">
-                <a16:creationId xmlns:a16="http://schemas.microsoft.com/office/drawing/2014/main" id="{5BCA3811-F8F4-45DF-9C54-7CDCFE32B0A1}"/>
+                <a16:creationId xmlns:a16="http://schemas.microsoft.com/office/drawing/2014/main" id="{18AB4CD2-BB9C-4196-BBF3-55B57CF98469}"/>
               </a:ext>
             </a:extLst>
           </p:cNvPr>
@@ -2085,7 +2085,7 @@
           <p:cNvPr id="2" name="Body">
             <a:extLst xmlns:a="http://schemas.openxmlformats.org/drawingml/2006/main">
               <a:ext uri="{FF2B5EF4-FFF2-40B4-BE49-F238E27FC236}">
-                <a16:creationId xmlns:a16="http://schemas.microsoft.com/office/drawing/2014/main" id="{5CDB676D-ADA2-47A7-AB6B-D1C296F3C177}"/>
+                <a16:creationId xmlns:a16="http://schemas.microsoft.com/office/drawing/2014/main" id="{6BC370F6-02E9-4127-B6F5-484C89BD306C}"/>
               </a:ext>
             </a:extLst>
           </p:cNvPr>
@@ -2331,7 +2331,7 @@
           <p:cNvPr id="4" name="Title">
             <a:extLst xmlns:a="http://schemas.openxmlformats.org/drawingml/2006/main">
               <a:ext uri="{FF2B5EF4-FFF2-40B4-BE49-F238E27FC236}">
-                <a16:creationId xmlns:a16="http://schemas.microsoft.com/office/drawing/2014/main" id="{BECB4981-7089-44E9-92D1-AF95D89960D0}"/>
+                <a16:creationId xmlns:a16="http://schemas.microsoft.com/office/drawing/2014/main" id="{6E944ABF-EA58-4685-BDBD-3B261410DBC5}"/>
               </a:ext>
             </a:extLst>
           </p:cNvPr>
@@ -2560,7 +2560,7 @@
           <p:cNvPr id="2" name="Left column">
             <a:extLst xmlns:a="http://schemas.openxmlformats.org/drawingml/2006/main">
               <a:ext uri="{FF2B5EF4-FFF2-40B4-BE49-F238E27FC236}">
-                <a16:creationId xmlns:a16="http://schemas.microsoft.com/office/drawing/2014/main" id="{5803174A-9FCF-4E3D-B7D0-FEA43AECEE19}"/>
+                <a16:creationId xmlns:a16="http://schemas.microsoft.com/office/drawing/2014/main" id="{1E33F2F6-9079-49F1-A97D-750E1CF3F8E3}"/>
               </a:ext>
             </a:extLst>
           </p:cNvPr>
@@ -2789,7 +2789,7 @@
           <p:cNvPr id="3" name="Right column">
             <a:extLst xmlns:a="http://schemas.openxmlformats.org/drawingml/2006/main">
               <a:ext uri="{FF2B5EF4-FFF2-40B4-BE49-F238E27FC236}">
-                <a16:creationId xmlns:a16="http://schemas.microsoft.com/office/drawing/2014/main" id="{9DC75260-157F-4AE6-B53A-313EEE665B98}"/>
+                <a16:creationId xmlns:a16="http://schemas.microsoft.com/office/drawing/2014/main" id="{5C67A6F7-2C98-49DE-ADF0-9D44CD69232B}"/>
               </a:ext>
             </a:extLst>
           </p:cNvPr>
@@ -3035,7 +3035,7 @@
           <p:cNvPr id="3" name="Title">
             <a:extLst xmlns:a="http://schemas.openxmlformats.org/drawingml/2006/main">
               <a:ext uri="{FF2B5EF4-FFF2-40B4-BE49-F238E27FC236}">
-                <a16:creationId xmlns:a16="http://schemas.microsoft.com/office/drawing/2014/main" id="{843AF58A-BC44-4CBD-81E4-1EC4D2FCB0BB}"/>
+                <a16:creationId xmlns:a16="http://schemas.microsoft.com/office/drawing/2014/main" id="{7F752A6E-A98C-414D-A9B0-174B861CEE35}"/>
               </a:ext>
             </a:extLst>
           </p:cNvPr>
@@ -3264,7 +3264,7 @@
           <p:cNvPr id="2" name="Left column">
             <a:extLst xmlns:a="http://schemas.openxmlformats.org/drawingml/2006/main">
               <a:ext uri="{FF2B5EF4-FFF2-40B4-BE49-F238E27FC236}">
-                <a16:creationId xmlns:a16="http://schemas.microsoft.com/office/drawing/2014/main" id="{1E0C145F-82F3-41EE-B8E8-1024FC5C0BB2}"/>
+                <a16:creationId xmlns:a16="http://schemas.microsoft.com/office/drawing/2014/main" id="{61D78A9D-5ED4-4693-BBB0-3D1C5BA5C400}"/>
               </a:ext>
             </a:extLst>
           </p:cNvPr>
@@ -3531,12 +3531,12 @@
   </p:cSld>
   <p:clrMap bg1="lt1" tx1="dk1" bg2="lt2" tx2="dk2" accent1="accent1" accent2="accent2" accent3="accent3" accent4="accent4" accent5="accent5" accent6="accent6" hlink="hlink" folHlink="folHlink"/>
   <p:sldLayoutIdLst>
-    <p:sldLayoutId xmlns:r="http://schemas.openxmlformats.org/officeDocument/2006/relationships" id="2147483649" r:id="R4fb492e712c24ce5"/>
-    <p:sldLayoutId xmlns:r="http://schemas.openxmlformats.org/officeDocument/2006/relationships" id="2147483650" r:id="Ra550e679a33a4b6d"/>
-    <p:sldLayoutId xmlns:r="http://schemas.openxmlformats.org/officeDocument/2006/relationships" id="2147483651" r:id="R49a02fae15634e7d"/>
-    <p:sldLayoutId xmlns:r="http://schemas.openxmlformats.org/officeDocument/2006/relationships" id="2147483652" r:id="Rcc5c6d6bc0b84d08"/>
-    <p:sldLayoutId xmlns:r="http://schemas.openxmlformats.org/officeDocument/2006/relationships" id="2147483653" r:id="Rc6d1285052004112"/>
-    <p:sldLayoutId xmlns:r="http://schemas.openxmlformats.org/officeDocument/2006/relationships" id="2147483654" r:id="R1b2f2946f3f64cdb"/>
+    <p:sldLayoutId xmlns:r="http://schemas.openxmlformats.org/officeDocument/2006/relationships" id="2147483649" r:id="R634f08903e844444"/>
+    <p:sldLayoutId xmlns:r="http://schemas.openxmlformats.org/officeDocument/2006/relationships" id="2147483650" r:id="Rb62e7b7debfb49f4"/>
+    <p:sldLayoutId xmlns:r="http://schemas.openxmlformats.org/officeDocument/2006/relationships" id="2147483651" r:id="Rea4189e311e04d98"/>
+    <p:sldLayoutId xmlns:r="http://schemas.openxmlformats.org/officeDocument/2006/relationships" id="2147483652" r:id="R9295788890c94e80"/>
+    <p:sldLayoutId xmlns:r="http://schemas.openxmlformats.org/officeDocument/2006/relationships" id="2147483653" r:id="Rfa2ad073730c4a86"/>
+    <p:sldLayoutId xmlns:r="http://schemas.openxmlformats.org/officeDocument/2006/relationships" id="2147483654" r:id="R78b1918674934552"/>
   </p:sldLayoutIdLst>
   <p:txStyles>
     <p:titleStyle>
@@ -4087,7 +4087,7 @@
           <p:cNvPr id="21" name="">
             <a:extLst xmlns:a="http://schemas.openxmlformats.org/drawingml/2006/main">
               <a:ext uri="{FF2B5EF4-FFF2-40B4-BE49-F238E27FC236}">
-                <a16:creationId xmlns:a16="http://schemas.microsoft.com/office/drawing/2014/main" id="{EF03AD46-624E-454B-9DB3-0287F41BD9FC}"/>
+                <a16:creationId xmlns:a16="http://schemas.microsoft.com/office/drawing/2014/main" id="{7D45A3AF-40C0-4454-B573-6AD74A981AED}"/>
               </a:ext>
             </a:extLst>
           </p:cNvPr>
@@ -4097,7 +4097,7 @@
           <p:nvPr/>
         </p:nvPicPr>
         <p:blipFill>
-          <a:blip xmlns:r="http://schemas.openxmlformats.org/officeDocument/2006/relationships" xmlns:a="http://schemas.openxmlformats.org/drawingml/2006/main" r:embed="R460e947876964cd3"/>
+          <a:blip xmlns:r="http://schemas.openxmlformats.org/officeDocument/2006/relationships" xmlns:a="http://schemas.openxmlformats.org/drawingml/2006/main" r:embed="Re5ce24a44eeb4502"/>
           <a:stretch xmlns:a="http://schemas.openxmlformats.org/drawingml/2006/main"/>
         </p:blipFill>
         <p:spPr>
@@ -4115,7 +4115,7 @@
           <p:cNvPr id="2" name="f2">
             <a:extLst xmlns:a="http://schemas.openxmlformats.org/drawingml/2006/main">
               <a:ext uri="{FF2B5EF4-FFF2-40B4-BE49-F238E27FC236}">
-                <a16:creationId xmlns:a16="http://schemas.microsoft.com/office/drawing/2014/main" id="{3E2BB6A3-9DE3-444D-A320-2F09A9D4B8DD}"/>
+                <a16:creationId xmlns:a16="http://schemas.microsoft.com/office/drawing/2014/main" id="{3C21C327-AC37-4AA7-87BE-8387918D8263}"/>
               </a:ext>
             </a:extLst>
           </p:cNvPr>
@@ -4274,7 +4274,7 @@
           <p:cNvPr id="3" name="f3">
             <a:extLst xmlns:a="http://schemas.openxmlformats.org/drawingml/2006/main">
               <a:ext uri="{FF2B5EF4-FFF2-40B4-BE49-F238E27FC236}">
-                <a16:creationId xmlns:a16="http://schemas.microsoft.com/office/drawing/2014/main" id="{0651A0D3-6833-4FF7-AC1F-CD575C718273}"/>
+                <a16:creationId xmlns:a16="http://schemas.microsoft.com/office/drawing/2014/main" id="{A3FF57A9-0712-4887-A63B-65B75B65D456}"/>
               </a:ext>
             </a:extLst>
           </p:cNvPr>
@@ -4433,7 +4433,7 @@
           <p:cNvPr id="4" name="f4">
             <a:extLst xmlns:a="http://schemas.openxmlformats.org/drawingml/2006/main">
               <a:ext uri="{FF2B5EF4-FFF2-40B4-BE49-F238E27FC236}">
-                <a16:creationId xmlns:a16="http://schemas.microsoft.com/office/drawing/2014/main" id="{EA3A99D5-D31D-4828-90BF-A56537AD49AD}"/>
+                <a16:creationId xmlns:a16="http://schemas.microsoft.com/office/drawing/2014/main" id="{61FE4749-C415-451E-8887-952FB2A98589}"/>
               </a:ext>
             </a:extLst>
           </p:cNvPr>
@@ -4592,7 +4592,7 @@
           <p:cNvPr id="5" name="f5">
             <a:extLst xmlns:a="http://schemas.openxmlformats.org/drawingml/2006/main">
               <a:ext uri="{FF2B5EF4-FFF2-40B4-BE49-F238E27FC236}">
-                <a16:creationId xmlns:a16="http://schemas.microsoft.com/office/drawing/2014/main" id="{0D0D9FB3-8DEE-440C-B1CB-A592D9545CBA}"/>
+                <a16:creationId xmlns:a16="http://schemas.microsoft.com/office/drawing/2014/main" id="{2A7D6AC7-C334-4EA3-AA9B-C4BE7B617E23}"/>
               </a:ext>
             </a:extLst>
           </p:cNvPr>
@@ -4751,7 +4751,7 @@
           <p:cNvPr id="6" name="f6">
             <a:extLst xmlns:a="http://schemas.openxmlformats.org/drawingml/2006/main">
               <a:ext uri="{FF2B5EF4-FFF2-40B4-BE49-F238E27FC236}">
-                <a16:creationId xmlns:a16="http://schemas.microsoft.com/office/drawing/2014/main" id="{DD227CE4-EAAE-432A-AE9D-1427C96A1EA7}"/>
+                <a16:creationId xmlns:a16="http://schemas.microsoft.com/office/drawing/2014/main" id="{85F59F09-2A2C-4607-90F1-561A78635122}"/>
               </a:ext>
             </a:extLst>
           </p:cNvPr>
@@ -4910,7 +4910,7 @@
           <p:cNvPr id="7" name="f7">
             <a:extLst xmlns:a="http://schemas.openxmlformats.org/drawingml/2006/main">
               <a:ext uri="{FF2B5EF4-FFF2-40B4-BE49-F238E27FC236}">
-                <a16:creationId xmlns:a16="http://schemas.microsoft.com/office/drawing/2014/main" id="{036C3A9A-EAD4-4892-B2D9-2E4B3819F8C9}"/>
+                <a16:creationId xmlns:a16="http://schemas.microsoft.com/office/drawing/2014/main" id="{650F8B68-F6FA-4A44-B5D0-95967B072EA4}"/>
               </a:ext>
             </a:extLst>
           </p:cNvPr>
@@ -5069,7 +5069,7 @@
           <p:cNvPr id="8" name="f8">
             <a:extLst xmlns:a="http://schemas.openxmlformats.org/drawingml/2006/main">
               <a:ext uri="{FF2B5EF4-FFF2-40B4-BE49-F238E27FC236}">
-                <a16:creationId xmlns:a16="http://schemas.microsoft.com/office/drawing/2014/main" id="{C58305C9-7703-4D80-8525-2C6430F6422E}"/>
+                <a16:creationId xmlns:a16="http://schemas.microsoft.com/office/drawing/2014/main" id="{1D360B00-98C3-44FB-959F-7408B4EB5C58}"/>
               </a:ext>
             </a:extLst>
           </p:cNvPr>
@@ -5228,7 +5228,7 @@
           <p:cNvPr id="9" name="f9">
             <a:extLst xmlns:a="http://schemas.openxmlformats.org/drawingml/2006/main">
               <a:ext uri="{FF2B5EF4-FFF2-40B4-BE49-F238E27FC236}">
-                <a16:creationId xmlns:a16="http://schemas.microsoft.com/office/drawing/2014/main" id="{6D50A069-25F4-4D93-9BA6-82711785BCB0}"/>
+                <a16:creationId xmlns:a16="http://schemas.microsoft.com/office/drawing/2014/main" id="{C100A410-579B-44D3-9214-B8DFA4D6B24F}"/>
               </a:ext>
             </a:extLst>
           </p:cNvPr>
@@ -5387,7 +5387,7 @@
           <p:cNvPr id="10" name="f10">
             <a:extLst xmlns:a="http://schemas.openxmlformats.org/drawingml/2006/main">
               <a:ext uri="{FF2B5EF4-FFF2-40B4-BE49-F238E27FC236}">
-                <a16:creationId xmlns:a16="http://schemas.microsoft.com/office/drawing/2014/main" id="{769A7FB0-63C1-40DF-96EF-A30420ACF19E}"/>
+                <a16:creationId xmlns:a16="http://schemas.microsoft.com/office/drawing/2014/main" id="{9D99E828-72A1-4005-9947-57F07FBBC673}"/>
               </a:ext>
             </a:extLst>
           </p:cNvPr>
@@ -5546,7 +5546,7 @@
           <p:cNvPr id="11" name="f11">
             <a:extLst xmlns:a="http://schemas.openxmlformats.org/drawingml/2006/main">
               <a:ext uri="{FF2B5EF4-FFF2-40B4-BE49-F238E27FC236}">
-                <a16:creationId xmlns:a16="http://schemas.microsoft.com/office/drawing/2014/main" id="{6CC3875E-1D87-4AE2-B0B6-040556F6F0F4}"/>
+                <a16:creationId xmlns:a16="http://schemas.microsoft.com/office/drawing/2014/main" id="{8F11941A-4A46-4BB3-9999-8961A746BCEE}"/>
               </a:ext>
             </a:extLst>
           </p:cNvPr>
@@ -5705,7 +5705,7 @@
           <p:cNvPr id="12" name="f12">
             <a:extLst xmlns:a="http://schemas.openxmlformats.org/drawingml/2006/main">
               <a:ext uri="{FF2B5EF4-FFF2-40B4-BE49-F238E27FC236}">
-                <a16:creationId xmlns:a16="http://schemas.microsoft.com/office/drawing/2014/main" id="{7471D0FC-9208-4A04-88C4-3CFB51517729}"/>
+                <a16:creationId xmlns:a16="http://schemas.microsoft.com/office/drawing/2014/main" id="{81714A75-F66A-468C-950F-0EAE0FB0FB80}"/>
               </a:ext>
             </a:extLst>
           </p:cNvPr>
@@ -5864,7 +5864,7 @@
           <p:cNvPr id="13" name="f13">
             <a:extLst xmlns:a="http://schemas.openxmlformats.org/drawingml/2006/main">
               <a:ext uri="{FF2B5EF4-FFF2-40B4-BE49-F238E27FC236}">
-                <a16:creationId xmlns:a16="http://schemas.microsoft.com/office/drawing/2014/main" id="{39BEF633-0628-43B6-8CD3-73B4B5092F7F}"/>
+                <a16:creationId xmlns:a16="http://schemas.microsoft.com/office/drawing/2014/main" id="{B1935F4A-CED3-4D27-8AD0-B8B6EA1114B2}"/>
               </a:ext>
             </a:extLst>
           </p:cNvPr>
@@ -6023,7 +6023,7 @@
           <p:cNvPr id="14" name="f14">
             <a:extLst xmlns:a="http://schemas.openxmlformats.org/drawingml/2006/main">
               <a:ext uri="{FF2B5EF4-FFF2-40B4-BE49-F238E27FC236}">
-                <a16:creationId xmlns:a16="http://schemas.microsoft.com/office/drawing/2014/main" id="{60E3524A-5D0B-413F-B95F-9E42DD530ABE}"/>
+                <a16:creationId xmlns:a16="http://schemas.microsoft.com/office/drawing/2014/main" id="{2DBFC8DC-F048-4E00-9400-D8E05766C151}"/>
               </a:ext>
             </a:extLst>
           </p:cNvPr>
@@ -6182,7 +6182,7 @@
           <p:cNvPr id="15" name="f15">
             <a:extLst xmlns:a="http://schemas.openxmlformats.org/drawingml/2006/main">
               <a:ext uri="{FF2B5EF4-FFF2-40B4-BE49-F238E27FC236}">
-                <a16:creationId xmlns:a16="http://schemas.microsoft.com/office/drawing/2014/main" id="{131A3327-3FC5-44D2-AC97-08E3088E98D1}"/>
+                <a16:creationId xmlns:a16="http://schemas.microsoft.com/office/drawing/2014/main" id="{348EC166-6C28-4227-9F5F-22EEC7382FDF}"/>
               </a:ext>
             </a:extLst>
           </p:cNvPr>
@@ -6341,7 +6341,7 @@
           <p:cNvPr id="16" name="f16">
             <a:extLst xmlns:a="http://schemas.openxmlformats.org/drawingml/2006/main">
               <a:ext uri="{FF2B5EF4-FFF2-40B4-BE49-F238E27FC236}">
-                <a16:creationId xmlns:a16="http://schemas.microsoft.com/office/drawing/2014/main" id="{988B0B97-4DB2-461F-934D-C8F76F0EF7F0}"/>
+                <a16:creationId xmlns:a16="http://schemas.microsoft.com/office/drawing/2014/main" id="{AB9F7DB8-6929-484A-A675-F9DBA27CA41A}"/>
               </a:ext>
             </a:extLst>
           </p:cNvPr>
@@ -6500,7 +6500,7 @@
           <p:cNvPr id="17" name="f17">
             <a:extLst xmlns:a="http://schemas.openxmlformats.org/drawingml/2006/main">
               <a:ext uri="{FF2B5EF4-FFF2-40B4-BE49-F238E27FC236}">
-                <a16:creationId xmlns:a16="http://schemas.microsoft.com/office/drawing/2014/main" id="{43AFB416-4970-4A6C-8BE4-D701AFAFC65C}"/>
+                <a16:creationId xmlns:a16="http://schemas.microsoft.com/office/drawing/2014/main" id="{4ADE4287-797E-4CC1-8119-EAF1D9F554DA}"/>
               </a:ext>
             </a:extLst>
           </p:cNvPr>
@@ -6659,7 +6659,7 @@
           <p:cNvPr id="18" name="f18">
             <a:extLst xmlns:a="http://schemas.openxmlformats.org/drawingml/2006/main">
               <a:ext uri="{FF2B5EF4-FFF2-40B4-BE49-F238E27FC236}">
-                <a16:creationId xmlns:a16="http://schemas.microsoft.com/office/drawing/2014/main" id="{0F50D955-4B09-4C80-A27F-BABD7D2E5FC2}"/>
+                <a16:creationId xmlns:a16="http://schemas.microsoft.com/office/drawing/2014/main" id="{358D8C0E-DBE4-4CA9-A583-9B0B90112B57}"/>
               </a:ext>
             </a:extLst>
           </p:cNvPr>
@@ -6818,7 +6818,7 @@
           <p:cNvPr id="19" name="f19">
             <a:extLst xmlns:a="http://schemas.openxmlformats.org/drawingml/2006/main">
               <a:ext uri="{FF2B5EF4-FFF2-40B4-BE49-F238E27FC236}">
-                <a16:creationId xmlns:a16="http://schemas.microsoft.com/office/drawing/2014/main" id="{91C9588D-6CD4-43F5-B66E-ACF163ED31E6}"/>
+                <a16:creationId xmlns:a16="http://schemas.microsoft.com/office/drawing/2014/main" id="{D1B4F772-B7C7-4566-BAA5-CF08892C991D}"/>
               </a:ext>
             </a:extLst>
           </p:cNvPr>
@@ -6977,7 +6977,7 @@
           <p:cNvPr id="20" name="f20">
             <a:extLst xmlns:a="http://schemas.openxmlformats.org/drawingml/2006/main">
               <a:ext uri="{FF2B5EF4-FFF2-40B4-BE49-F238E27FC236}">
-                <a16:creationId xmlns:a16="http://schemas.microsoft.com/office/drawing/2014/main" id="{8EB0730B-2DB8-49E4-9AAF-108A0BE7AE7A}"/>
+                <a16:creationId xmlns:a16="http://schemas.microsoft.com/office/drawing/2014/main" id="{8FF84202-338C-481C-B1ED-7612A9C2C6A5}"/>
               </a:ext>
             </a:extLst>
           </p:cNvPr>
@@ -7134,7 +7134,7 @@
     </p:spTree>
     <p:extLst>
       <p:ext uri="{BB962C8B-B14F-4D97-AF65-F5344CB8AC3E}">
-        <p14:creationId xmlns:p14="http://schemas.microsoft.com/office/powerpoint/2010/main" val="372116789"/>
+        <p14:creationId xmlns:p14="http://schemas.microsoft.com/office/powerpoint/2010/main" val="1191677107"/>
       </p:ext>
     </p:extLst>
   </p:cSld>
@@ -7165,7 +7165,7 @@
           <p:cNvPr id="24" name="f21">
             <a:extLst xmlns:a="http://schemas.openxmlformats.org/drawingml/2006/main">
               <a:ext uri="{FF2B5EF4-FFF2-40B4-BE49-F238E27FC236}">
-                <a16:creationId xmlns:a16="http://schemas.microsoft.com/office/drawing/2014/main" id="{ED6CB717-ABBE-4557-A8BC-523E97D66540}"/>
+                <a16:creationId xmlns:a16="http://schemas.microsoft.com/office/drawing/2014/main" id="{1AB6216C-28FA-4E7A-984A-CFF73174CE14}"/>
               </a:ext>
             </a:extLst>
           </p:cNvPr>
@@ -7324,7 +7324,7 @@
           <p:cNvPr id="2" name="f22">
             <a:extLst xmlns:a="http://schemas.openxmlformats.org/drawingml/2006/main">
               <a:ext uri="{FF2B5EF4-FFF2-40B4-BE49-F238E27FC236}">
-                <a16:creationId xmlns:a16="http://schemas.microsoft.com/office/drawing/2014/main" id="{733A0C94-0968-47B8-90D5-E212BC8A5D07}"/>
+                <a16:creationId xmlns:a16="http://schemas.microsoft.com/office/drawing/2014/main" id="{9AFA3FF2-BD9E-4AF9-ACF8-8256FF4B92FD}"/>
               </a:ext>
             </a:extLst>
           </p:cNvPr>
@@ -7483,7 +7483,7 @@
           <p:cNvPr id="3" name="f23">
             <a:extLst xmlns:a="http://schemas.openxmlformats.org/drawingml/2006/main">
               <a:ext uri="{FF2B5EF4-FFF2-40B4-BE49-F238E27FC236}">
-                <a16:creationId xmlns:a16="http://schemas.microsoft.com/office/drawing/2014/main" id="{E682C433-4127-4492-821B-EEC89F79AFF3}"/>
+                <a16:creationId xmlns:a16="http://schemas.microsoft.com/office/drawing/2014/main" id="{62C36A55-CA70-484D-97B7-55050D74E469}"/>
               </a:ext>
             </a:extLst>
           </p:cNvPr>
@@ -7642,7 +7642,7 @@
           <p:cNvPr id="4" name="f24">
             <a:extLst xmlns:a="http://schemas.openxmlformats.org/drawingml/2006/main">
               <a:ext uri="{FF2B5EF4-FFF2-40B4-BE49-F238E27FC236}">
-                <a16:creationId xmlns:a16="http://schemas.microsoft.com/office/drawing/2014/main" id="{62CF49C3-5C95-4E12-9E3A-EBFE4BF614F7}"/>
+                <a16:creationId xmlns:a16="http://schemas.microsoft.com/office/drawing/2014/main" id="{474D705C-002E-459A-A278-E84C214AD689}"/>
               </a:ext>
             </a:extLst>
           </p:cNvPr>
@@ -7801,7 +7801,7 @@
           <p:cNvPr id="5" name="f25">
             <a:extLst xmlns:a="http://schemas.openxmlformats.org/drawingml/2006/main">
               <a:ext uri="{FF2B5EF4-FFF2-40B4-BE49-F238E27FC236}">
-                <a16:creationId xmlns:a16="http://schemas.microsoft.com/office/drawing/2014/main" id="{71890CED-2DBF-4894-B458-64E0E1493FE0}"/>
+                <a16:creationId xmlns:a16="http://schemas.microsoft.com/office/drawing/2014/main" id="{F089B7C9-86E6-42B3-A922-68DDE2B6BF56}"/>
               </a:ext>
             </a:extLst>
           </p:cNvPr>
@@ -7960,7 +7960,7 @@
           <p:cNvPr id="6" name="f26">
             <a:extLst xmlns:a="http://schemas.openxmlformats.org/drawingml/2006/main">
               <a:ext uri="{FF2B5EF4-FFF2-40B4-BE49-F238E27FC236}">
-                <a16:creationId xmlns:a16="http://schemas.microsoft.com/office/drawing/2014/main" id="{3319DDFE-1CE5-412F-938B-989D4603E202}"/>
+                <a16:creationId xmlns:a16="http://schemas.microsoft.com/office/drawing/2014/main" id="{E158022F-004A-4F7C-A8C0-0AB554ACE41A}"/>
               </a:ext>
             </a:extLst>
           </p:cNvPr>
@@ -8119,7 +8119,7 @@
           <p:cNvPr id="7" name="f27">
             <a:extLst xmlns:a="http://schemas.openxmlformats.org/drawingml/2006/main">
               <a:ext uri="{FF2B5EF4-FFF2-40B4-BE49-F238E27FC236}">
-                <a16:creationId xmlns:a16="http://schemas.microsoft.com/office/drawing/2014/main" id="{84236307-E0A5-40E9-A6B1-66FA846E9724}"/>
+                <a16:creationId xmlns:a16="http://schemas.microsoft.com/office/drawing/2014/main" id="{17C7A4AC-9C82-4017-8C31-9BB8714675CC}"/>
               </a:ext>
             </a:extLst>
           </p:cNvPr>
@@ -8154,7 +8154,7 @@
           <p:cNvPr id="8" name="f28">
             <a:extLst xmlns:a="http://schemas.openxmlformats.org/drawingml/2006/main">
               <a:ext uri="{FF2B5EF4-FFF2-40B4-BE49-F238E27FC236}">
-                <a16:creationId xmlns:a16="http://schemas.microsoft.com/office/drawing/2014/main" id="{9A9F7338-B46D-47F3-808C-EFB257C39D5C}"/>
+                <a16:creationId xmlns:a16="http://schemas.microsoft.com/office/drawing/2014/main" id="{41857395-0270-440D-B6F0-37EEB9824680}"/>
               </a:ext>
             </a:extLst>
           </p:cNvPr>
@@ -8185,7 +8185,7 @@
           <p:cNvPr id="9" name="f29">
             <a:extLst xmlns:a="http://schemas.openxmlformats.org/drawingml/2006/main">
               <a:ext uri="{FF2B5EF4-FFF2-40B4-BE49-F238E27FC236}">
-                <a16:creationId xmlns:a16="http://schemas.microsoft.com/office/drawing/2014/main" id="{F9A6E795-0714-4694-A117-75264AD1BD9F}"/>
+                <a16:creationId xmlns:a16="http://schemas.microsoft.com/office/drawing/2014/main" id="{FC0A7FD7-32DE-4E18-8019-C46D74013154}"/>
               </a:ext>
             </a:extLst>
           </p:cNvPr>
@@ -8216,7 +8216,7 @@
           <p:cNvPr id="10" name="f30">
             <a:extLst xmlns:a="http://schemas.openxmlformats.org/drawingml/2006/main">
               <a:ext uri="{FF2B5EF4-FFF2-40B4-BE49-F238E27FC236}">
-                <a16:creationId xmlns:a16="http://schemas.microsoft.com/office/drawing/2014/main" id="{65AFC1C3-286B-4E10-B0E8-BCCCE6EE6659}"/>
+                <a16:creationId xmlns:a16="http://schemas.microsoft.com/office/drawing/2014/main" id="{D884B14E-59B4-4A80-ABF6-79D38571572E}"/>
               </a:ext>
             </a:extLst>
           </p:cNvPr>
@@ -8247,7 +8247,7 @@
           <p:cNvPr id="11" name="f31">
             <a:extLst xmlns:a="http://schemas.openxmlformats.org/drawingml/2006/main">
               <a:ext uri="{FF2B5EF4-FFF2-40B4-BE49-F238E27FC236}">
-                <a16:creationId xmlns:a16="http://schemas.microsoft.com/office/drawing/2014/main" id="{83831625-D1C1-4BCA-AD07-5408A5954A5D}"/>
+                <a16:creationId xmlns:a16="http://schemas.microsoft.com/office/drawing/2014/main" id="{B1B120A2-D9E1-42BA-B7C5-5890FEBBE31D}"/>
               </a:ext>
             </a:extLst>
           </p:cNvPr>
@@ -8282,7 +8282,7 @@
           <p:cNvPr id="12" name="f32">
             <a:extLst xmlns:a="http://schemas.openxmlformats.org/drawingml/2006/main">
               <a:ext uri="{FF2B5EF4-FFF2-40B4-BE49-F238E27FC236}">
-                <a16:creationId xmlns:a16="http://schemas.microsoft.com/office/drawing/2014/main" id="{61968A65-63BE-4233-9C04-F239C6FBDD1F}"/>
+                <a16:creationId xmlns:a16="http://schemas.microsoft.com/office/drawing/2014/main" id="{BFB1AF1F-8CB7-4D7F-9850-69DF8F113AAA}"/>
               </a:ext>
             </a:extLst>
           </p:cNvPr>
@@ -8313,7 +8313,7 @@
           <p:cNvPr id="13" name="f33">
             <a:extLst xmlns:a="http://schemas.openxmlformats.org/drawingml/2006/main">
               <a:ext uri="{FF2B5EF4-FFF2-40B4-BE49-F238E27FC236}">
-                <a16:creationId xmlns:a16="http://schemas.microsoft.com/office/drawing/2014/main" id="{C9D37ED6-AB6B-4EE4-9716-F72A1A5865E2}"/>
+                <a16:creationId xmlns:a16="http://schemas.microsoft.com/office/drawing/2014/main" id="{DCD07A90-FB44-47E6-BC80-D9F7FDC9705B}"/>
               </a:ext>
             </a:extLst>
           </p:cNvPr>
@@ -8346,7 +8346,7 @@
           <p:cNvPr id="14" name="f34">
             <a:extLst xmlns:a="http://schemas.openxmlformats.org/drawingml/2006/main">
               <a:ext uri="{FF2B5EF4-FFF2-40B4-BE49-F238E27FC236}">
-                <a16:creationId xmlns:a16="http://schemas.microsoft.com/office/drawing/2014/main" id="{40C41A39-82B6-4C8E-9572-BEA6200E9A64}"/>
+                <a16:creationId xmlns:a16="http://schemas.microsoft.com/office/drawing/2014/main" id="{7ACF7EF1-C3C0-4849-8A07-6F5F178DF8BA}"/>
               </a:ext>
             </a:extLst>
           </p:cNvPr>
@@ -8379,7 +8379,7 @@
           <p:cNvPr id="15" name="f35">
             <a:extLst xmlns:a="http://schemas.openxmlformats.org/drawingml/2006/main">
               <a:ext uri="{FF2B5EF4-FFF2-40B4-BE49-F238E27FC236}">
-                <a16:creationId xmlns:a16="http://schemas.microsoft.com/office/drawing/2014/main" id="{0A876F6D-9433-4247-91B2-82B8A31C2C72}"/>
+                <a16:creationId xmlns:a16="http://schemas.microsoft.com/office/drawing/2014/main" id="{90BDD31A-A9D3-4850-8EA7-D847FAB689A2}"/>
               </a:ext>
             </a:extLst>
           </p:cNvPr>
@@ -8412,7 +8412,7 @@
           <p:cNvPr id="16" name="f36">
             <a:extLst xmlns:a="http://schemas.openxmlformats.org/drawingml/2006/main">
               <a:ext uri="{FF2B5EF4-FFF2-40B4-BE49-F238E27FC236}">
-                <a16:creationId xmlns:a16="http://schemas.microsoft.com/office/drawing/2014/main" id="{A9477BDD-1EC2-4B68-BA33-49CE2EFCC03B}"/>
+                <a16:creationId xmlns:a16="http://schemas.microsoft.com/office/drawing/2014/main" id="{DF170553-71FB-4851-85A4-CD3F6CA46ED2}"/>
               </a:ext>
             </a:extLst>
           </p:cNvPr>
@@ -8571,7 +8571,7 @@
           <p:cNvPr id="17" name="f37">
             <a:extLst xmlns:a="http://schemas.openxmlformats.org/drawingml/2006/main">
               <a:ext uri="{FF2B5EF4-FFF2-40B4-BE49-F238E27FC236}">
-                <a16:creationId xmlns:a16="http://schemas.microsoft.com/office/drawing/2014/main" id="{AA00C338-104F-44AD-8EF0-05D4C2BC342E}"/>
+                <a16:creationId xmlns:a16="http://schemas.microsoft.com/office/drawing/2014/main" id="{1DA986C4-EAD9-4306-B39F-B442206B2E0C}"/>
               </a:ext>
             </a:extLst>
           </p:cNvPr>
@@ -8602,7 +8602,7 @@
           <p:cNvPr id="18" name="f38">
             <a:extLst xmlns:a="http://schemas.openxmlformats.org/drawingml/2006/main">
               <a:ext uri="{FF2B5EF4-FFF2-40B4-BE49-F238E27FC236}">
-                <a16:creationId xmlns:a16="http://schemas.microsoft.com/office/drawing/2014/main" id="{63966254-0311-41AA-8142-B9592A0EB54B}"/>
+                <a16:creationId xmlns:a16="http://schemas.microsoft.com/office/drawing/2014/main" id="{701DA3C4-0EDC-4258-9931-FF1FEA14595A}"/>
               </a:ext>
             </a:extLst>
           </p:cNvPr>
@@ -8633,7 +8633,7 @@
           <p:cNvPr id="19" name="f39">
             <a:extLst xmlns:a="http://schemas.openxmlformats.org/drawingml/2006/main">
               <a:ext uri="{FF2B5EF4-FFF2-40B4-BE49-F238E27FC236}">
-                <a16:creationId xmlns:a16="http://schemas.microsoft.com/office/drawing/2014/main" id="{F0256E74-B2CF-429F-A9A6-A824A4AB8E5F}"/>
+                <a16:creationId xmlns:a16="http://schemas.microsoft.com/office/drawing/2014/main" id="{C015EDBB-1620-4BE2-94CA-218D0FF4C2E8}"/>
               </a:ext>
             </a:extLst>
           </p:cNvPr>
@@ -8668,7 +8668,7 @@
           <p:cNvPr id="20" name="f40">
             <a:extLst xmlns:a="http://schemas.openxmlformats.org/drawingml/2006/main">
               <a:ext uri="{FF2B5EF4-FFF2-40B4-BE49-F238E27FC236}">
-                <a16:creationId xmlns:a16="http://schemas.microsoft.com/office/drawing/2014/main" id="{ADD07E89-C783-432A-86EA-1E8A2EB35696}"/>
+                <a16:creationId xmlns:a16="http://schemas.microsoft.com/office/drawing/2014/main" id="{A1ECAC0C-2C51-4601-8A04-AA21F194E628}"/>
               </a:ext>
             </a:extLst>
           </p:cNvPr>
@@ -8850,7 +8850,7 @@
           <p:cNvPr id="21" name="f41">
             <a:extLst xmlns:a="http://schemas.openxmlformats.org/drawingml/2006/main">
               <a:ext uri="{FF2B5EF4-FFF2-40B4-BE49-F238E27FC236}">
-                <a16:creationId xmlns:a16="http://schemas.microsoft.com/office/drawing/2014/main" id="{466285EF-0541-4BB1-87A5-B0F01E766C1D}"/>
+                <a16:creationId xmlns:a16="http://schemas.microsoft.com/office/drawing/2014/main" id="{3BB70FEF-3608-4CA8-ADB9-99D4850976C4}"/>
               </a:ext>
             </a:extLst>
           </p:cNvPr>
@@ -9032,7 +9032,7 @@
           <p:cNvPr id="22" name="f42">
             <a:extLst xmlns:a="http://schemas.openxmlformats.org/drawingml/2006/main">
               <a:ext uri="{FF2B5EF4-FFF2-40B4-BE49-F238E27FC236}">
-                <a16:creationId xmlns:a16="http://schemas.microsoft.com/office/drawing/2014/main" id="{207A288C-FFB1-49A1-814B-1EE2623A8F95}"/>
+                <a16:creationId xmlns:a16="http://schemas.microsoft.com/office/drawing/2014/main" id="{FDE7C723-C294-443E-B145-16DD8BF0AD9B}"/>
               </a:ext>
             </a:extLst>
           </p:cNvPr>
@@ -9191,7 +9191,7 @@
           <p:cNvPr id="23" name="f43">
             <a:extLst xmlns:a="http://schemas.openxmlformats.org/drawingml/2006/main">
               <a:ext uri="{FF2B5EF4-FFF2-40B4-BE49-F238E27FC236}">
-                <a16:creationId xmlns:a16="http://schemas.microsoft.com/office/drawing/2014/main" id="{FA7E283C-BFE6-4D57-9860-EF206CF95E36}"/>
+                <a16:creationId xmlns:a16="http://schemas.microsoft.com/office/drawing/2014/main" id="{EA947CB2-E3D1-4556-8D17-1C3ED6FC9BA2}"/>
               </a:ext>
             </a:extLst>
           </p:cNvPr>
@@ -9348,7 +9348,7 @@
     </p:spTree>
     <p:extLst>
       <p:ext uri="{BB962C8B-B14F-4D97-AF65-F5344CB8AC3E}">
-        <p14:creationId xmlns:p14="http://schemas.microsoft.com/office/powerpoint/2010/main" val="113949665"/>
+        <p14:creationId xmlns:p14="http://schemas.microsoft.com/office/powerpoint/2010/main" val="2009226885"/>
       </p:ext>
     </p:extLst>
   </p:cSld>
@@ -9379,7 +9379,7 @@
           <p:cNvPr id="24" name="">
             <a:extLst xmlns:a="http://schemas.openxmlformats.org/drawingml/2006/main">
               <a:ext uri="{FF2B5EF4-FFF2-40B4-BE49-F238E27FC236}">
-                <a16:creationId xmlns:a16="http://schemas.microsoft.com/office/drawing/2014/main" id="{0F7A68C0-D7A3-4550-9A16-6A4D4D1C8BE7}"/>
+                <a16:creationId xmlns:a16="http://schemas.microsoft.com/office/drawing/2014/main" id="{6575E8C3-F827-42BD-9AF3-4EFCCF4C638B}"/>
               </a:ext>
             </a:extLst>
           </p:cNvPr>
@@ -9389,7 +9389,7 @@
           <p:nvPr/>
         </p:nvPicPr>
         <p:blipFill>
-          <a:blip xmlns:r="http://schemas.openxmlformats.org/officeDocument/2006/relationships" xmlns:a="http://schemas.openxmlformats.org/drawingml/2006/main" r:embed="R9d0302bf288f4e89"/>
+          <a:blip xmlns:r="http://schemas.openxmlformats.org/officeDocument/2006/relationships" xmlns:a="http://schemas.openxmlformats.org/drawingml/2006/main" r:embed="R1c5b56750ab84a99"/>
           <a:stretch xmlns:a="http://schemas.openxmlformats.org/drawingml/2006/main"/>
         </p:blipFill>
         <p:spPr>
@@ -9407,7 +9407,7 @@
           <p:cNvPr id="2" name="f45">
             <a:extLst xmlns:a="http://schemas.openxmlformats.org/drawingml/2006/main">
               <a:ext uri="{FF2B5EF4-FFF2-40B4-BE49-F238E27FC236}">
-                <a16:creationId xmlns:a16="http://schemas.microsoft.com/office/drawing/2014/main" id="{5992C5EF-6603-449B-A18F-86CF7EF05CAF}"/>
+                <a16:creationId xmlns:a16="http://schemas.microsoft.com/office/drawing/2014/main" id="{5BF5DF33-B77E-4362-86BA-6FA2A809B878}"/>
               </a:ext>
             </a:extLst>
           </p:cNvPr>
@@ -9566,7 +9566,7 @@
           <p:cNvPr id="3" name="f46">
             <a:extLst xmlns:a="http://schemas.openxmlformats.org/drawingml/2006/main">
               <a:ext uri="{FF2B5EF4-FFF2-40B4-BE49-F238E27FC236}">
-                <a16:creationId xmlns:a16="http://schemas.microsoft.com/office/drawing/2014/main" id="{315C530E-DDA1-4ADD-8D13-951385E7B1F5}"/>
+                <a16:creationId xmlns:a16="http://schemas.microsoft.com/office/drawing/2014/main" id="{042CC9DE-D276-4B9B-A813-5B876025D808}"/>
               </a:ext>
             </a:extLst>
           </p:cNvPr>
@@ -9725,7 +9725,7 @@
           <p:cNvPr id="4" name="f47">
             <a:extLst xmlns:a="http://schemas.openxmlformats.org/drawingml/2006/main">
               <a:ext uri="{FF2B5EF4-FFF2-40B4-BE49-F238E27FC236}">
-                <a16:creationId xmlns:a16="http://schemas.microsoft.com/office/drawing/2014/main" id="{BED93621-8B2A-4BC1-A870-DEA6A5DCC928}"/>
+                <a16:creationId xmlns:a16="http://schemas.microsoft.com/office/drawing/2014/main" id="{E302F1CC-9EE0-49BC-8740-530EBF635279}"/>
               </a:ext>
             </a:extLst>
           </p:cNvPr>
@@ -9884,7 +9884,7 @@
           <p:cNvPr id="5" name="f48">
             <a:extLst xmlns:a="http://schemas.openxmlformats.org/drawingml/2006/main">
               <a:ext uri="{FF2B5EF4-FFF2-40B4-BE49-F238E27FC236}">
-                <a16:creationId xmlns:a16="http://schemas.microsoft.com/office/drawing/2014/main" id="{FBAACD3F-1183-4DB2-9B53-3D9E3DB82D0A}"/>
+                <a16:creationId xmlns:a16="http://schemas.microsoft.com/office/drawing/2014/main" id="{8EE7EBDA-FDF5-4271-BCB0-FA7E57C3ACA7}"/>
               </a:ext>
             </a:extLst>
           </p:cNvPr>
@@ -10043,7 +10043,7 @@
           <p:cNvPr id="6" name="f49">
             <a:extLst xmlns:a="http://schemas.openxmlformats.org/drawingml/2006/main">
               <a:ext uri="{FF2B5EF4-FFF2-40B4-BE49-F238E27FC236}">
-                <a16:creationId xmlns:a16="http://schemas.microsoft.com/office/drawing/2014/main" id="{3E5D2824-EA93-4275-B84C-CC269BCA151B}"/>
+                <a16:creationId xmlns:a16="http://schemas.microsoft.com/office/drawing/2014/main" id="{B54ED89F-0A29-44C2-A544-66E282AD59CA}"/>
               </a:ext>
             </a:extLst>
           </p:cNvPr>
@@ -10202,7 +10202,7 @@
           <p:cNvPr id="7" name="f50">
             <a:extLst xmlns:a="http://schemas.openxmlformats.org/drawingml/2006/main">
               <a:ext uri="{FF2B5EF4-FFF2-40B4-BE49-F238E27FC236}">
-                <a16:creationId xmlns:a16="http://schemas.microsoft.com/office/drawing/2014/main" id="{B116F515-C303-4C8D-BC0E-F8080B1FF835}"/>
+                <a16:creationId xmlns:a16="http://schemas.microsoft.com/office/drawing/2014/main" id="{BDBDD52A-1A19-4054-A46E-740C2364662B}"/>
               </a:ext>
             </a:extLst>
           </p:cNvPr>
@@ -10361,7 +10361,7 @@
           <p:cNvPr id="8" name="f51">
             <a:extLst xmlns:a="http://schemas.openxmlformats.org/drawingml/2006/main">
               <a:ext uri="{FF2B5EF4-FFF2-40B4-BE49-F238E27FC236}">
-                <a16:creationId xmlns:a16="http://schemas.microsoft.com/office/drawing/2014/main" id="{72245C53-B8EF-4F7E-B91D-4B04461C4D2A}"/>
+                <a16:creationId xmlns:a16="http://schemas.microsoft.com/office/drawing/2014/main" id="{D0DF10A9-C446-4446-A9D8-3ABDC204CD09}"/>
               </a:ext>
             </a:extLst>
           </p:cNvPr>
@@ -10520,7 +10520,7 @@
           <p:cNvPr id="9" name="f52">
             <a:extLst xmlns:a="http://schemas.openxmlformats.org/drawingml/2006/main">
               <a:ext uri="{FF2B5EF4-FFF2-40B4-BE49-F238E27FC236}">
-                <a16:creationId xmlns:a16="http://schemas.microsoft.com/office/drawing/2014/main" id="{D447A4CD-1085-4628-8EE1-FB081DE0F030}"/>
+                <a16:creationId xmlns:a16="http://schemas.microsoft.com/office/drawing/2014/main" id="{5FE5354D-67B3-4AF9-B3A4-8EE2D2A9806E}"/>
               </a:ext>
             </a:extLst>
           </p:cNvPr>
@@ -10679,7 +10679,7 @@
           <p:cNvPr id="10" name="f53">
             <a:extLst xmlns:a="http://schemas.openxmlformats.org/drawingml/2006/main">
               <a:ext uri="{FF2B5EF4-FFF2-40B4-BE49-F238E27FC236}">
-                <a16:creationId xmlns:a16="http://schemas.microsoft.com/office/drawing/2014/main" id="{76C777F7-B23C-4C96-98B7-07E51B9C2698}"/>
+                <a16:creationId xmlns:a16="http://schemas.microsoft.com/office/drawing/2014/main" id="{F76867B3-619B-441F-B843-6DB037905D96}"/>
               </a:ext>
             </a:extLst>
           </p:cNvPr>
@@ -10838,7 +10838,7 @@
           <p:cNvPr id="11" name="f54">
             <a:extLst xmlns:a="http://schemas.openxmlformats.org/drawingml/2006/main">
               <a:ext uri="{FF2B5EF4-FFF2-40B4-BE49-F238E27FC236}">
-                <a16:creationId xmlns:a16="http://schemas.microsoft.com/office/drawing/2014/main" id="{1D384CA9-A6BB-43A1-9904-A3B38CE4F9D7}"/>
+                <a16:creationId xmlns:a16="http://schemas.microsoft.com/office/drawing/2014/main" id="{E1D5F7EF-E10C-4785-993F-38DE3974BFF6}"/>
               </a:ext>
             </a:extLst>
           </p:cNvPr>
@@ -10997,7 +10997,7 @@
           <p:cNvPr id="12" name="f55">
             <a:extLst xmlns:a="http://schemas.openxmlformats.org/drawingml/2006/main">
               <a:ext uri="{FF2B5EF4-FFF2-40B4-BE49-F238E27FC236}">
-                <a16:creationId xmlns:a16="http://schemas.microsoft.com/office/drawing/2014/main" id="{0601A362-D066-4952-959D-5460316D6E84}"/>
+                <a16:creationId xmlns:a16="http://schemas.microsoft.com/office/drawing/2014/main" id="{B70BBEA1-3F11-483D-BC43-E6D8A9CF9535}"/>
               </a:ext>
             </a:extLst>
           </p:cNvPr>
@@ -11156,7 +11156,7 @@
           <p:cNvPr id="13" name="f56">
             <a:extLst xmlns:a="http://schemas.openxmlformats.org/drawingml/2006/main">
               <a:ext uri="{FF2B5EF4-FFF2-40B4-BE49-F238E27FC236}">
-                <a16:creationId xmlns:a16="http://schemas.microsoft.com/office/drawing/2014/main" id="{D05303F4-62BB-408A-8333-A31BD2B55E1E}"/>
+                <a16:creationId xmlns:a16="http://schemas.microsoft.com/office/drawing/2014/main" id="{88A31A96-D4A5-4949-AEA8-7A1019DD4884}"/>
               </a:ext>
             </a:extLst>
           </p:cNvPr>
@@ -11315,7 +11315,7 @@
           <p:cNvPr id="14" name="f57">
             <a:extLst xmlns:a="http://schemas.openxmlformats.org/drawingml/2006/main">
               <a:ext uri="{FF2B5EF4-FFF2-40B4-BE49-F238E27FC236}">
-                <a16:creationId xmlns:a16="http://schemas.microsoft.com/office/drawing/2014/main" id="{D89F1ECC-2672-4C69-9058-95CD1CDB5CA4}"/>
+                <a16:creationId xmlns:a16="http://schemas.microsoft.com/office/drawing/2014/main" id="{D90071E9-6D1A-4EFF-BA69-6619C3D3435C}"/>
               </a:ext>
             </a:extLst>
           </p:cNvPr>
@@ -11474,7 +11474,7 @@
           <p:cNvPr id="15" name="f58">
             <a:extLst xmlns:a="http://schemas.openxmlformats.org/drawingml/2006/main">
               <a:ext uri="{FF2B5EF4-FFF2-40B4-BE49-F238E27FC236}">
-                <a16:creationId xmlns:a16="http://schemas.microsoft.com/office/drawing/2014/main" id="{E901E0E3-BBE6-4936-A25E-4FAA783311FB}"/>
+                <a16:creationId xmlns:a16="http://schemas.microsoft.com/office/drawing/2014/main" id="{38229594-7FE9-4491-88CB-8EE8D6560FBF}"/>
               </a:ext>
             </a:extLst>
           </p:cNvPr>
@@ -11633,7 +11633,7 @@
           <p:cNvPr id="16" name="f59">
             <a:extLst xmlns:a="http://schemas.openxmlformats.org/drawingml/2006/main">
               <a:ext uri="{FF2B5EF4-FFF2-40B4-BE49-F238E27FC236}">
-                <a16:creationId xmlns:a16="http://schemas.microsoft.com/office/drawing/2014/main" id="{943322A7-8FC4-4AA5-8DA7-4AD98C2EC374}"/>
+                <a16:creationId xmlns:a16="http://schemas.microsoft.com/office/drawing/2014/main" id="{8939E8B2-195F-4238-9FA9-0D33D2DC9591}"/>
               </a:ext>
             </a:extLst>
           </p:cNvPr>
@@ -11792,7 +11792,7 @@
           <p:cNvPr id="17" name="f60">
             <a:extLst xmlns:a="http://schemas.openxmlformats.org/drawingml/2006/main">
               <a:ext uri="{FF2B5EF4-FFF2-40B4-BE49-F238E27FC236}">
-                <a16:creationId xmlns:a16="http://schemas.microsoft.com/office/drawing/2014/main" id="{8D17A2E2-EE52-4C98-AF75-AB3ACE148491}"/>
+                <a16:creationId xmlns:a16="http://schemas.microsoft.com/office/drawing/2014/main" id="{2E2B0D6F-D77C-4834-9213-4AF0E5D29B70}"/>
               </a:ext>
             </a:extLst>
           </p:cNvPr>
@@ -11951,7 +11951,7 @@
           <p:cNvPr id="18" name="f61">
             <a:extLst xmlns:a="http://schemas.openxmlformats.org/drawingml/2006/main">
               <a:ext uri="{FF2B5EF4-FFF2-40B4-BE49-F238E27FC236}">
-                <a16:creationId xmlns:a16="http://schemas.microsoft.com/office/drawing/2014/main" id="{9ED698B5-1C3E-4943-8D72-EE626A3AD3BB}"/>
+                <a16:creationId xmlns:a16="http://schemas.microsoft.com/office/drawing/2014/main" id="{CDFE7841-EFD6-4D5F-AAF7-A8755A3F31B8}"/>
               </a:ext>
             </a:extLst>
           </p:cNvPr>
@@ -12110,7 +12110,7 @@
           <p:cNvPr id="19" name="f62">
             <a:extLst xmlns:a="http://schemas.openxmlformats.org/drawingml/2006/main">
               <a:ext uri="{FF2B5EF4-FFF2-40B4-BE49-F238E27FC236}">
-                <a16:creationId xmlns:a16="http://schemas.microsoft.com/office/drawing/2014/main" id="{ECD46024-5D4A-4182-80FA-39913F96F251}"/>
+                <a16:creationId xmlns:a16="http://schemas.microsoft.com/office/drawing/2014/main" id="{28B9F215-C209-48FF-8A93-5430A96F3044}"/>
               </a:ext>
             </a:extLst>
           </p:cNvPr>
@@ -12269,7 +12269,7 @@
           <p:cNvPr id="20" name="f63">
             <a:extLst xmlns:a="http://schemas.openxmlformats.org/drawingml/2006/main">
               <a:ext uri="{FF2B5EF4-FFF2-40B4-BE49-F238E27FC236}">
-                <a16:creationId xmlns:a16="http://schemas.microsoft.com/office/drawing/2014/main" id="{F5865B97-6B12-4EED-81AB-E47F70040FAE}"/>
+                <a16:creationId xmlns:a16="http://schemas.microsoft.com/office/drawing/2014/main" id="{68975CAD-D220-468A-A662-EEF0FFB639EB}"/>
               </a:ext>
             </a:extLst>
           </p:cNvPr>
@@ -12428,7 +12428,7 @@
           <p:cNvPr id="21" name="f64">
             <a:extLst xmlns:a="http://schemas.openxmlformats.org/drawingml/2006/main">
               <a:ext uri="{FF2B5EF4-FFF2-40B4-BE49-F238E27FC236}">
-                <a16:creationId xmlns:a16="http://schemas.microsoft.com/office/drawing/2014/main" id="{FE99074B-BACB-4F21-8652-FE5EEDC24A3F}"/>
+                <a16:creationId xmlns:a16="http://schemas.microsoft.com/office/drawing/2014/main" id="{CFE67A19-1C49-446D-BE30-B7F73043B38D}"/>
               </a:ext>
             </a:extLst>
           </p:cNvPr>
@@ -12587,7 +12587,7 @@
           <p:cNvPr id="22" name="f65">
             <a:extLst xmlns:a="http://schemas.openxmlformats.org/drawingml/2006/main">
               <a:ext uri="{FF2B5EF4-FFF2-40B4-BE49-F238E27FC236}">
-                <a16:creationId xmlns:a16="http://schemas.microsoft.com/office/drawing/2014/main" id="{65737B06-13A5-49B0-A33D-75C3896591F1}"/>
+                <a16:creationId xmlns:a16="http://schemas.microsoft.com/office/drawing/2014/main" id="{07C14415-BFD7-4AD4-8259-5E18D99108DE}"/>
               </a:ext>
             </a:extLst>
           </p:cNvPr>
@@ -12746,7 +12746,7 @@
           <p:cNvPr id="23" name="f66">
             <a:extLst xmlns:a="http://schemas.openxmlformats.org/drawingml/2006/main">
               <a:ext uri="{FF2B5EF4-FFF2-40B4-BE49-F238E27FC236}">
-                <a16:creationId xmlns:a16="http://schemas.microsoft.com/office/drawing/2014/main" id="{A22FBB40-649E-4414-B499-2F589D7D0A8B}"/>
+                <a16:creationId xmlns:a16="http://schemas.microsoft.com/office/drawing/2014/main" id="{52A53392-95B8-4AD9-9EBA-D913798077AA}"/>
               </a:ext>
             </a:extLst>
           </p:cNvPr>
@@ -12903,7 +12903,7 @@
     </p:spTree>
     <p:extLst>
       <p:ext uri="{BB962C8B-B14F-4D97-AF65-F5344CB8AC3E}">
-        <p14:creationId xmlns:p14="http://schemas.microsoft.com/office/powerpoint/2010/main" val="1497803154"/>
+        <p14:creationId xmlns:p14="http://schemas.microsoft.com/office/powerpoint/2010/main" val="961672210"/>
       </p:ext>
     </p:extLst>
   </p:cSld>
@@ -12934,7 +12934,7 @@
           <p:cNvPr id="18" name="f67">
             <a:extLst xmlns:a="http://schemas.openxmlformats.org/drawingml/2006/main">
               <a:ext uri="{FF2B5EF4-FFF2-40B4-BE49-F238E27FC236}">
-                <a16:creationId xmlns:a16="http://schemas.microsoft.com/office/drawing/2014/main" id="{545CF73C-0BEC-43B1-A979-8EC0BB60E1F1}"/>
+                <a16:creationId xmlns:a16="http://schemas.microsoft.com/office/drawing/2014/main" id="{CD8ADEA6-C6DC-466D-9C9A-0DD64672CC7E}"/>
               </a:ext>
             </a:extLst>
           </p:cNvPr>
@@ -13093,7 +13093,7 @@
           <p:cNvPr id="2" name="f68">
             <a:extLst xmlns:a="http://schemas.openxmlformats.org/drawingml/2006/main">
               <a:ext uri="{FF2B5EF4-FFF2-40B4-BE49-F238E27FC236}">
-                <a16:creationId xmlns:a16="http://schemas.microsoft.com/office/drawing/2014/main" id="{9560B7C4-1830-429D-8ADC-25A32503D72A}"/>
+                <a16:creationId xmlns:a16="http://schemas.microsoft.com/office/drawing/2014/main" id="{88292557-59F0-4876-8DED-7ECF9E588D75}"/>
               </a:ext>
             </a:extLst>
           </p:cNvPr>
@@ -13252,7 +13252,7 @@
           <p:cNvPr id="3" name="f69">
             <a:extLst xmlns:a="http://schemas.openxmlformats.org/drawingml/2006/main">
               <a:ext uri="{FF2B5EF4-FFF2-40B4-BE49-F238E27FC236}">
-                <a16:creationId xmlns:a16="http://schemas.microsoft.com/office/drawing/2014/main" id="{3175A81D-A993-4EF3-84CA-BE44A5CFAA5C}"/>
+                <a16:creationId xmlns:a16="http://schemas.microsoft.com/office/drawing/2014/main" id="{C1F23252-DF3C-41AB-BADE-50722D233A12}"/>
               </a:ext>
             </a:extLst>
           </p:cNvPr>
@@ -13411,7 +13411,7 @@
           <p:cNvPr id="4" name="f70">
             <a:extLst xmlns:a="http://schemas.openxmlformats.org/drawingml/2006/main">
               <a:ext uri="{FF2B5EF4-FFF2-40B4-BE49-F238E27FC236}">
-                <a16:creationId xmlns:a16="http://schemas.microsoft.com/office/drawing/2014/main" id="{A2BE4953-CBEA-4FCF-A94E-41B054860346}"/>
+                <a16:creationId xmlns:a16="http://schemas.microsoft.com/office/drawing/2014/main" id="{95371814-766C-4314-8AEA-0591DC90299B}"/>
               </a:ext>
             </a:extLst>
           </p:cNvPr>
@@ -13570,7 +13570,7 @@
           <p:cNvPr id="5" name="f103">
             <a:extLst xmlns:a="http://schemas.openxmlformats.org/drawingml/2006/main">
               <a:ext uri="{FF2B5EF4-FFF2-40B4-BE49-F238E27FC236}">
-                <a16:creationId xmlns:a16="http://schemas.microsoft.com/office/drawing/2014/main" id="{F67A86E4-0AF6-4B59-AB6A-923CB8F0428F}"/>
+                <a16:creationId xmlns:a16="http://schemas.microsoft.com/office/drawing/2014/main" id="{5C61F781-8D08-4696-84CA-D1F3CB326F94}"/>
               </a:ext>
             </a:extLst>
           </p:cNvPr>
@@ -13729,7 +13729,7 @@
           <p:cNvPr id="6" name="f104">
             <a:extLst xmlns:a="http://schemas.openxmlformats.org/drawingml/2006/main">
               <a:ext uri="{FF2B5EF4-FFF2-40B4-BE49-F238E27FC236}">
-                <a16:creationId xmlns:a16="http://schemas.microsoft.com/office/drawing/2014/main" id="{3C1F1927-3AF0-4815-98F2-5B4BAF168144}"/>
+                <a16:creationId xmlns:a16="http://schemas.microsoft.com/office/drawing/2014/main" id="{E154A881-E84E-4DED-9B09-945E1446E442}"/>
               </a:ext>
             </a:extLst>
           </p:cNvPr>
@@ -13764,7 +13764,7 @@
           <p:cNvPr id="7" name="f105">
             <a:extLst xmlns:a="http://schemas.openxmlformats.org/drawingml/2006/main">
               <a:ext uri="{FF2B5EF4-FFF2-40B4-BE49-F238E27FC236}">
-                <a16:creationId xmlns:a16="http://schemas.microsoft.com/office/drawing/2014/main" id="{D7C70755-7A6A-4A13-8EA5-C8BC0578D292}"/>
+                <a16:creationId xmlns:a16="http://schemas.microsoft.com/office/drawing/2014/main" id="{B05EBB37-7116-4CCD-A24B-FEB69F0E6703}"/>
               </a:ext>
             </a:extLst>
           </p:cNvPr>
@@ -13923,7 +13923,7 @@
           <p:cNvPr id="8" name="f106">
             <a:extLst xmlns:a="http://schemas.openxmlformats.org/drawingml/2006/main">
               <a:ext uri="{FF2B5EF4-FFF2-40B4-BE49-F238E27FC236}">
-                <a16:creationId xmlns:a16="http://schemas.microsoft.com/office/drawing/2014/main" id="{AAE31310-9EE4-4FC6-8279-F927FB794B51}"/>
+                <a16:creationId xmlns:a16="http://schemas.microsoft.com/office/drawing/2014/main" id="{B57B014C-07C6-4417-AC08-F68FC531D123}"/>
               </a:ext>
             </a:extLst>
           </p:cNvPr>
@@ -14105,7 +14105,7 @@
           <p:cNvPr id="9" name="f107">
             <a:extLst xmlns:a="http://schemas.openxmlformats.org/drawingml/2006/main">
               <a:ext uri="{FF2B5EF4-FFF2-40B4-BE49-F238E27FC236}">
-                <a16:creationId xmlns:a16="http://schemas.microsoft.com/office/drawing/2014/main" id="{AB484214-CFD6-41F5-B2B3-237ACDFCCD51}"/>
+                <a16:creationId xmlns:a16="http://schemas.microsoft.com/office/drawing/2014/main" id="{215DAC90-BC51-4255-88C3-97286224611E}"/>
               </a:ext>
             </a:extLst>
           </p:cNvPr>
@@ -14264,7 +14264,7 @@
           <p:cNvPr id="10" name="f108">
             <a:extLst xmlns:a="http://schemas.openxmlformats.org/drawingml/2006/main">
               <a:ext uri="{FF2B5EF4-FFF2-40B4-BE49-F238E27FC236}">
-                <a16:creationId xmlns:a16="http://schemas.microsoft.com/office/drawing/2014/main" id="{537769B9-C798-452B-910C-91D714FAC3B4}"/>
+                <a16:creationId xmlns:a16="http://schemas.microsoft.com/office/drawing/2014/main" id="{153E6737-0912-4B75-88B8-6187EFC3EB89}"/>
               </a:ext>
             </a:extLst>
           </p:cNvPr>
@@ -14423,7 +14423,7 @@
           <p:cNvPr id="11" name="f109">
             <a:extLst xmlns:a="http://schemas.openxmlformats.org/drawingml/2006/main">
               <a:ext uri="{FF2B5EF4-FFF2-40B4-BE49-F238E27FC236}">
-                <a16:creationId xmlns:a16="http://schemas.microsoft.com/office/drawing/2014/main" id="{75C4B58E-F0E4-4B18-8C19-74149DB76DA5}"/>
+                <a16:creationId xmlns:a16="http://schemas.microsoft.com/office/drawing/2014/main" id="{4AB10B04-205C-4A24-B3E8-DC4C9E260D93}"/>
               </a:ext>
             </a:extLst>
           </p:cNvPr>
@@ -14454,7 +14454,7 @@
           <p:cNvPr id="12" name="f110">
             <a:extLst xmlns:a="http://schemas.openxmlformats.org/drawingml/2006/main">
               <a:ext uri="{FF2B5EF4-FFF2-40B4-BE49-F238E27FC236}">
-                <a16:creationId xmlns:a16="http://schemas.microsoft.com/office/drawing/2014/main" id="{7BE5E7DD-1480-487E-BA3E-B3B20EE8BB8F}"/>
+                <a16:creationId xmlns:a16="http://schemas.microsoft.com/office/drawing/2014/main" id="{C5698F18-91E2-4D59-9A90-98F12203C621}"/>
               </a:ext>
             </a:extLst>
           </p:cNvPr>
@@ -14485,7 +14485,7 @@
           <p:cNvPr id="13" name="f111">
             <a:extLst xmlns:a="http://schemas.openxmlformats.org/drawingml/2006/main">
               <a:ext uri="{FF2B5EF4-FFF2-40B4-BE49-F238E27FC236}">
-                <a16:creationId xmlns:a16="http://schemas.microsoft.com/office/drawing/2014/main" id="{03928440-6A9C-4EBF-BE2D-754908763346}"/>
+                <a16:creationId xmlns:a16="http://schemas.microsoft.com/office/drawing/2014/main" id="{E8AA5743-2E61-49BB-A0E1-98ECFF8D1FE1}"/>
               </a:ext>
             </a:extLst>
           </p:cNvPr>
@@ -14644,7 +14644,7 @@
           <p:cNvPr id="14" name="f112">
             <a:extLst xmlns:a="http://schemas.openxmlformats.org/drawingml/2006/main">
               <a:ext uri="{FF2B5EF4-FFF2-40B4-BE49-F238E27FC236}">
-                <a16:creationId xmlns:a16="http://schemas.microsoft.com/office/drawing/2014/main" id="{3324DF9B-6138-47DB-BF9A-6ABD5E93A602}"/>
+                <a16:creationId xmlns:a16="http://schemas.microsoft.com/office/drawing/2014/main" id="{2918FDFF-6650-4641-A8EA-61A04A62CC5A}"/>
               </a:ext>
             </a:extLst>
           </p:cNvPr>
@@ -14679,7 +14679,7 @@
           <p:cNvPr id="15" name="f113">
             <a:extLst xmlns:a="http://schemas.openxmlformats.org/drawingml/2006/main">
               <a:ext uri="{FF2B5EF4-FFF2-40B4-BE49-F238E27FC236}">
-                <a16:creationId xmlns:a16="http://schemas.microsoft.com/office/drawing/2014/main" id="{EA03B86F-C636-49D2-B5DC-6318634BE198}"/>
+                <a16:creationId xmlns:a16="http://schemas.microsoft.com/office/drawing/2014/main" id="{5CD2BB03-96B7-48EB-B57F-3DFBD94D41F1}"/>
               </a:ext>
             </a:extLst>
           </p:cNvPr>
@@ -14861,7 +14861,7 @@
           <p:cNvPr id="16" name="f114">
             <a:extLst xmlns:a="http://schemas.openxmlformats.org/drawingml/2006/main">
               <a:ext uri="{FF2B5EF4-FFF2-40B4-BE49-F238E27FC236}">
-                <a16:creationId xmlns:a16="http://schemas.microsoft.com/office/drawing/2014/main" id="{DF22FF0B-BDE1-4314-9B00-F5752143AF8E}"/>
+                <a16:creationId xmlns:a16="http://schemas.microsoft.com/office/drawing/2014/main" id="{5BD35901-A35E-4AEC-A56F-5D31D4867CAE}"/>
               </a:ext>
             </a:extLst>
           </p:cNvPr>
@@ -14896,7 +14896,7 @@
           <p:cNvPr id="17" name="f115">
             <a:extLst xmlns:a="http://schemas.openxmlformats.org/drawingml/2006/main">
               <a:ext uri="{FF2B5EF4-FFF2-40B4-BE49-F238E27FC236}">
-                <a16:creationId xmlns:a16="http://schemas.microsoft.com/office/drawing/2014/main" id="{BC15316E-65C7-4CCE-B587-55892079EE9A}"/>
+                <a16:creationId xmlns:a16="http://schemas.microsoft.com/office/drawing/2014/main" id="{3B9EC7DB-E21A-4C23-9646-9962933F9E11}"/>
               </a:ext>
             </a:extLst>
           </p:cNvPr>
@@ -15076,7 +15076,7 @@
     </p:spTree>
     <p:extLst>
       <p:ext uri="{BB962C8B-B14F-4D97-AF65-F5344CB8AC3E}">
-        <p14:creationId xmlns:p14="http://schemas.microsoft.com/office/powerpoint/2010/main" val="1956201557"/>
+        <p14:creationId xmlns:p14="http://schemas.microsoft.com/office/powerpoint/2010/main" val="819393276"/>
       </p:ext>
     </p:extLst>
   </p:cSld>
@@ -15107,7 +15107,7 @@
           <p:cNvPr id="15" name="">
             <a:extLst xmlns:a="http://schemas.openxmlformats.org/drawingml/2006/main">
               <a:ext uri="{FF2B5EF4-FFF2-40B4-BE49-F238E27FC236}">
-                <a16:creationId xmlns:a16="http://schemas.microsoft.com/office/drawing/2014/main" id="{C8F9D777-E1A4-43F8-B551-80357B7EF124}"/>
+                <a16:creationId xmlns:a16="http://schemas.microsoft.com/office/drawing/2014/main" id="{5AC308F9-9651-423C-B6A7-9059CA387304}"/>
               </a:ext>
             </a:extLst>
           </p:cNvPr>
@@ -15117,7 +15117,7 @@
           <p:nvPr/>
         </p:nvPicPr>
         <p:blipFill>
-          <a:blip xmlns:r="http://schemas.openxmlformats.org/officeDocument/2006/relationships" xmlns:a="http://schemas.openxmlformats.org/drawingml/2006/main" r:embed="R83fda5a7cce14a8a"/>
+          <a:blip xmlns:r="http://schemas.openxmlformats.org/officeDocument/2006/relationships" xmlns:a="http://schemas.openxmlformats.org/drawingml/2006/main" r:embed="R9f379bef18414eb7"/>
           <a:stretch xmlns:a="http://schemas.openxmlformats.org/drawingml/2006/main"/>
         </p:blipFill>
         <p:spPr>
@@ -15135,7 +15135,7 @@
           <p:cNvPr id="2" name="f117">
             <a:extLst xmlns:a="http://schemas.openxmlformats.org/drawingml/2006/main">
               <a:ext uri="{FF2B5EF4-FFF2-40B4-BE49-F238E27FC236}">
-                <a16:creationId xmlns:a16="http://schemas.microsoft.com/office/drawing/2014/main" id="{F93A2280-4AF7-49CE-8DCC-44A045620A9F}"/>
+                <a16:creationId xmlns:a16="http://schemas.microsoft.com/office/drawing/2014/main" id="{A12B0194-23E4-4393-8513-BBFC6CBA124A}"/>
               </a:ext>
             </a:extLst>
           </p:cNvPr>
@@ -15294,7 +15294,7 @@
           <p:cNvPr id="3" name="f118">
             <a:extLst xmlns:a="http://schemas.openxmlformats.org/drawingml/2006/main">
               <a:ext uri="{FF2B5EF4-FFF2-40B4-BE49-F238E27FC236}">
-                <a16:creationId xmlns:a16="http://schemas.microsoft.com/office/drawing/2014/main" id="{BD2C68B3-0532-496C-9C9B-696CED4429DB}"/>
+                <a16:creationId xmlns:a16="http://schemas.microsoft.com/office/drawing/2014/main" id="{E9CD10F7-10C9-4B00-82B2-536AC9DD16B7}"/>
               </a:ext>
             </a:extLst>
           </p:cNvPr>
@@ -15453,7 +15453,7 @@
           <p:cNvPr id="4" name="f119">
             <a:extLst xmlns:a="http://schemas.openxmlformats.org/drawingml/2006/main">
               <a:ext uri="{FF2B5EF4-FFF2-40B4-BE49-F238E27FC236}">
-                <a16:creationId xmlns:a16="http://schemas.microsoft.com/office/drawing/2014/main" id="{DB243A82-CC6C-4797-B26D-1E59A017A2F0}"/>
+                <a16:creationId xmlns:a16="http://schemas.microsoft.com/office/drawing/2014/main" id="{D32923E3-09FA-406E-AC67-2E228AD441BD}"/>
               </a:ext>
             </a:extLst>
           </p:cNvPr>
@@ -15612,7 +15612,7 @@
           <p:cNvPr id="5" name="f120">
             <a:extLst xmlns:a="http://schemas.openxmlformats.org/drawingml/2006/main">
               <a:ext uri="{FF2B5EF4-FFF2-40B4-BE49-F238E27FC236}">
-                <a16:creationId xmlns:a16="http://schemas.microsoft.com/office/drawing/2014/main" id="{E406D2AC-B4FC-4CCF-83D0-E95D95E4CFDF}"/>
+                <a16:creationId xmlns:a16="http://schemas.microsoft.com/office/drawing/2014/main" id="{7A84DB75-677F-4847-B64C-D107179CE07C}"/>
               </a:ext>
             </a:extLst>
           </p:cNvPr>
@@ -15771,7 +15771,7 @@
           <p:cNvPr id="6" name="f121">
             <a:extLst xmlns:a="http://schemas.openxmlformats.org/drawingml/2006/main">
               <a:ext uri="{FF2B5EF4-FFF2-40B4-BE49-F238E27FC236}">
-                <a16:creationId xmlns:a16="http://schemas.microsoft.com/office/drawing/2014/main" id="{AB0C41A7-D4BF-4514-AFD8-478F40512A5A}"/>
+                <a16:creationId xmlns:a16="http://schemas.microsoft.com/office/drawing/2014/main" id="{1C66E1F1-DBB9-4C76-8D70-D8751CC4BC7C}"/>
               </a:ext>
             </a:extLst>
           </p:cNvPr>
@@ -15930,7 +15930,7 @@
           <p:cNvPr id="7" name="f122">
             <a:extLst xmlns:a="http://schemas.openxmlformats.org/drawingml/2006/main">
               <a:ext uri="{FF2B5EF4-FFF2-40B4-BE49-F238E27FC236}">
-                <a16:creationId xmlns:a16="http://schemas.microsoft.com/office/drawing/2014/main" id="{DD72C646-9259-4451-B76B-11720593C5F3}"/>
+                <a16:creationId xmlns:a16="http://schemas.microsoft.com/office/drawing/2014/main" id="{4BFAE904-14B6-45EC-87A8-1F4934754875}"/>
               </a:ext>
             </a:extLst>
           </p:cNvPr>
@@ -16089,7 +16089,7 @@
           <p:cNvPr id="8" name="f123">
             <a:extLst xmlns:a="http://schemas.openxmlformats.org/drawingml/2006/main">
               <a:ext uri="{FF2B5EF4-FFF2-40B4-BE49-F238E27FC236}">
-                <a16:creationId xmlns:a16="http://schemas.microsoft.com/office/drawing/2014/main" id="{895B7727-BDFC-46EE-BC0F-E28635CFB331}"/>
+                <a16:creationId xmlns:a16="http://schemas.microsoft.com/office/drawing/2014/main" id="{BF2F70CB-54B8-41B0-BBFD-BD0AAABEAE2A}"/>
               </a:ext>
             </a:extLst>
           </p:cNvPr>
@@ -16248,7 +16248,7 @@
           <p:cNvPr id="9" name="f124">
             <a:extLst xmlns:a="http://schemas.openxmlformats.org/drawingml/2006/main">
               <a:ext uri="{FF2B5EF4-FFF2-40B4-BE49-F238E27FC236}">
-                <a16:creationId xmlns:a16="http://schemas.microsoft.com/office/drawing/2014/main" id="{208DEFF9-1E47-441E-AB3B-AF1AE78B5243}"/>
+                <a16:creationId xmlns:a16="http://schemas.microsoft.com/office/drawing/2014/main" id="{97CEE9C7-D83D-452B-B53A-A4DA22A8307E}"/>
               </a:ext>
             </a:extLst>
           </p:cNvPr>
@@ -16407,7 +16407,7 @@
           <p:cNvPr id="10" name="f125">
             <a:extLst xmlns:a="http://schemas.openxmlformats.org/drawingml/2006/main">
               <a:ext uri="{FF2B5EF4-FFF2-40B4-BE49-F238E27FC236}">
-                <a16:creationId xmlns:a16="http://schemas.microsoft.com/office/drawing/2014/main" id="{26CD5067-81EE-409B-98FF-9BF3949749F2}"/>
+                <a16:creationId xmlns:a16="http://schemas.microsoft.com/office/drawing/2014/main" id="{65D6918B-3351-4CAC-BEE3-F970550FFB53}"/>
               </a:ext>
             </a:extLst>
           </p:cNvPr>
@@ -16566,7 +16566,7 @@
           <p:cNvPr id="11" name="f126">
             <a:extLst xmlns:a="http://schemas.openxmlformats.org/drawingml/2006/main">
               <a:ext uri="{FF2B5EF4-FFF2-40B4-BE49-F238E27FC236}">
-                <a16:creationId xmlns:a16="http://schemas.microsoft.com/office/drawing/2014/main" id="{465CF1E0-1A5A-42DB-A850-E84516741D38}"/>
+                <a16:creationId xmlns:a16="http://schemas.microsoft.com/office/drawing/2014/main" id="{C8D633BD-AD88-44B8-9B59-F7B2F9BA4846}"/>
               </a:ext>
             </a:extLst>
           </p:cNvPr>
@@ -16725,7 +16725,7 @@
           <p:cNvPr id="12" name="f127">
             <a:extLst xmlns:a="http://schemas.openxmlformats.org/drawingml/2006/main">
               <a:ext uri="{FF2B5EF4-FFF2-40B4-BE49-F238E27FC236}">
-                <a16:creationId xmlns:a16="http://schemas.microsoft.com/office/drawing/2014/main" id="{55350AAD-EF17-42D3-BB34-1D5C4DC5927D}"/>
+                <a16:creationId xmlns:a16="http://schemas.microsoft.com/office/drawing/2014/main" id="{B35C6E25-8A4C-454D-8CA5-61DF981400CF}"/>
               </a:ext>
             </a:extLst>
           </p:cNvPr>
@@ -16884,7 +16884,7 @@
           <p:cNvPr id="13" name="f128">
             <a:extLst xmlns:a="http://schemas.openxmlformats.org/drawingml/2006/main">
               <a:ext uri="{FF2B5EF4-FFF2-40B4-BE49-F238E27FC236}">
-                <a16:creationId xmlns:a16="http://schemas.microsoft.com/office/drawing/2014/main" id="{EE90AC2C-62E1-4571-9089-8045E79F5162}"/>
+                <a16:creationId xmlns:a16="http://schemas.microsoft.com/office/drawing/2014/main" id="{50C20EE8-574F-42AF-B07D-6C87750C3041}"/>
               </a:ext>
             </a:extLst>
           </p:cNvPr>
@@ -17043,7 +17043,7 @@
           <p:cNvPr id="14" name="f129">
             <a:extLst xmlns:a="http://schemas.openxmlformats.org/drawingml/2006/main">
               <a:ext uri="{FF2B5EF4-FFF2-40B4-BE49-F238E27FC236}">
-                <a16:creationId xmlns:a16="http://schemas.microsoft.com/office/drawing/2014/main" id="{766F869A-E726-4593-9DBD-CE8FB5DE151F}"/>
+                <a16:creationId xmlns:a16="http://schemas.microsoft.com/office/drawing/2014/main" id="{BB81E9DC-DFBA-4E0C-8454-7FF95214CC2D}"/>
               </a:ext>
             </a:extLst>
           </p:cNvPr>
@@ -17200,7 +17200,7 @@
     </p:spTree>
     <p:extLst>
       <p:ext uri="{BB962C8B-B14F-4D97-AF65-F5344CB8AC3E}">
-        <p14:creationId xmlns:p14="http://schemas.microsoft.com/office/powerpoint/2010/main" val="1709248655"/>
+        <p14:creationId xmlns:p14="http://schemas.microsoft.com/office/powerpoint/2010/main" val="257938701"/>
       </p:ext>
     </p:extLst>
   </p:cSld>
@@ -17231,7 +17231,7 @@
           <p:cNvPr id="13" name="f130">
             <a:extLst xmlns:a="http://schemas.openxmlformats.org/drawingml/2006/main">
               <a:ext uri="{FF2B5EF4-FFF2-40B4-BE49-F238E27FC236}">
-                <a16:creationId xmlns:a16="http://schemas.microsoft.com/office/drawing/2014/main" id="{B9F134A7-2553-443B-BAAF-88BB7082857F}"/>
+                <a16:creationId xmlns:a16="http://schemas.microsoft.com/office/drawing/2014/main" id="{02B68802-F137-4325-9222-63765BF1660D}"/>
               </a:ext>
             </a:extLst>
           </p:cNvPr>
@@ -17390,7 +17390,7 @@
           <p:cNvPr id="2" name="f131">
             <a:extLst xmlns:a="http://schemas.openxmlformats.org/drawingml/2006/main">
               <a:ext uri="{FF2B5EF4-FFF2-40B4-BE49-F238E27FC236}">
-                <a16:creationId xmlns:a16="http://schemas.microsoft.com/office/drawing/2014/main" id="{1577DC9F-7E60-496B-A4B9-96DEDDB0074E}"/>
+                <a16:creationId xmlns:a16="http://schemas.microsoft.com/office/drawing/2014/main" id="{B38F6671-5870-43F7-A32E-1A29F2AB0C4E}"/>
               </a:ext>
             </a:extLst>
           </p:cNvPr>
@@ -17549,7 +17549,7 @@
           <p:cNvPr id="3" name="f132">
             <a:extLst xmlns:a="http://schemas.openxmlformats.org/drawingml/2006/main">
               <a:ext uri="{FF2B5EF4-FFF2-40B4-BE49-F238E27FC236}">
-                <a16:creationId xmlns:a16="http://schemas.microsoft.com/office/drawing/2014/main" id="{EA975D8F-053D-4C23-8214-B7A781811DDC}"/>
+                <a16:creationId xmlns:a16="http://schemas.microsoft.com/office/drawing/2014/main" id="{3DB040BD-5D8B-4C59-813A-D1B837B443D7}"/>
               </a:ext>
             </a:extLst>
           </p:cNvPr>
@@ -17708,7 +17708,7 @@
           <p:cNvPr id="4" name="f133">
             <a:extLst xmlns:a="http://schemas.openxmlformats.org/drawingml/2006/main">
               <a:ext uri="{FF2B5EF4-FFF2-40B4-BE49-F238E27FC236}">
-                <a16:creationId xmlns:a16="http://schemas.microsoft.com/office/drawing/2014/main" id="{86E9D298-5B4B-4903-B2DF-9DD2E9FFC289}"/>
+                <a16:creationId xmlns:a16="http://schemas.microsoft.com/office/drawing/2014/main" id="{9E98D249-7FFC-4DE6-B0AD-2A2CA8D663A2}"/>
               </a:ext>
             </a:extLst>
           </p:cNvPr>
@@ -17867,7 +17867,7 @@
           <p:cNvPr id="5" name="">
             <a:extLst xmlns:a="http://schemas.openxmlformats.org/drawingml/2006/main">
               <a:ext uri="{FF2B5EF4-FFF2-40B4-BE49-F238E27FC236}">
-                <a16:creationId xmlns:a16="http://schemas.microsoft.com/office/drawing/2014/main" id="{F8DA9346-2B98-4D15-9131-231B17AC9B4B}"/>
+                <a16:creationId xmlns:a16="http://schemas.microsoft.com/office/drawing/2014/main" id="{7262E0EC-BD76-47A5-A25E-08603C6EE300}"/>
               </a:ext>
             </a:extLst>
           </p:cNvPr>
@@ -18703,7 +18703,7 @@
           <p:cNvPr id="6" name="f135">
             <a:extLst xmlns:a="http://schemas.openxmlformats.org/drawingml/2006/main">
               <a:ext uri="{FF2B5EF4-FFF2-40B4-BE49-F238E27FC236}">
-                <a16:creationId xmlns:a16="http://schemas.microsoft.com/office/drawing/2014/main" id="{12D38032-58C5-449D-A7ED-AE51621B547D}"/>
+                <a16:creationId xmlns:a16="http://schemas.microsoft.com/office/drawing/2014/main" id="{A46B5714-0F67-4EE2-9271-68836177BDFF}"/>
               </a:ext>
             </a:extLst>
           </p:cNvPr>
@@ -18738,7 +18738,7 @@
           <p:cNvPr id="7" name="f136">
             <a:extLst xmlns:a="http://schemas.openxmlformats.org/drawingml/2006/main">
               <a:ext uri="{FF2B5EF4-FFF2-40B4-BE49-F238E27FC236}">
-                <a16:creationId xmlns:a16="http://schemas.microsoft.com/office/drawing/2014/main" id="{67039B0F-FDDD-43D5-9D8C-81F083184126}"/>
+                <a16:creationId xmlns:a16="http://schemas.microsoft.com/office/drawing/2014/main" id="{AFAE871E-B529-4BB3-894A-03935CEE3234}"/>
               </a:ext>
             </a:extLst>
           </p:cNvPr>
@@ -18897,7 +18897,7 @@
           <p:cNvPr id="8" name="f137">
             <a:extLst xmlns:a="http://schemas.openxmlformats.org/drawingml/2006/main">
               <a:ext uri="{FF2B5EF4-FFF2-40B4-BE49-F238E27FC236}">
-                <a16:creationId xmlns:a16="http://schemas.microsoft.com/office/drawing/2014/main" id="{D6DD3E92-7CC1-48F7-8EB4-63F0771253B2}"/>
+                <a16:creationId xmlns:a16="http://schemas.microsoft.com/office/drawing/2014/main" id="{F3ADFDA7-5160-47C2-B3AD-9B8F76797A8F}"/>
               </a:ext>
             </a:extLst>
           </p:cNvPr>
@@ -19056,7 +19056,7 @@
           <p:cNvPr id="9" name="f138">
             <a:extLst xmlns:a="http://schemas.openxmlformats.org/drawingml/2006/main">
               <a:ext uri="{FF2B5EF4-FFF2-40B4-BE49-F238E27FC236}">
-                <a16:creationId xmlns:a16="http://schemas.microsoft.com/office/drawing/2014/main" id="{09C16576-BEF8-468E-90C6-6A1D40FF337A}"/>
+                <a16:creationId xmlns:a16="http://schemas.microsoft.com/office/drawing/2014/main" id="{1903A85A-7D15-4314-A84B-3A8B2128754A}"/>
               </a:ext>
             </a:extLst>
           </p:cNvPr>
@@ -19215,7 +19215,7 @@
           <p:cNvPr id="10" name="f139">
             <a:extLst xmlns:a="http://schemas.openxmlformats.org/drawingml/2006/main">
               <a:ext uri="{FF2B5EF4-FFF2-40B4-BE49-F238E27FC236}">
-                <a16:creationId xmlns:a16="http://schemas.microsoft.com/office/drawing/2014/main" id="{83180A38-5E26-474E-9109-C3C4FAB3F3DC}"/>
+                <a16:creationId xmlns:a16="http://schemas.microsoft.com/office/drawing/2014/main" id="{4A2D6B34-2F31-4C28-93AF-E7F5F81DB039}"/>
               </a:ext>
             </a:extLst>
           </p:cNvPr>
@@ -19374,7 +19374,7 @@
           <p:cNvPr id="11" name="f140">
             <a:extLst xmlns:a="http://schemas.openxmlformats.org/drawingml/2006/main">
               <a:ext uri="{FF2B5EF4-FFF2-40B4-BE49-F238E27FC236}">
-                <a16:creationId xmlns:a16="http://schemas.microsoft.com/office/drawing/2014/main" id="{B8D92E61-4F87-4443-A7F3-78FBBBCAD62C}"/>
+                <a16:creationId xmlns:a16="http://schemas.microsoft.com/office/drawing/2014/main" id="{6D343CD1-9A22-4754-9EA5-27C5E871B26A}"/>
               </a:ext>
             </a:extLst>
           </p:cNvPr>
@@ -19533,7 +19533,7 @@
           <p:cNvPr id="12" name="f141">
             <a:extLst xmlns:a="http://schemas.openxmlformats.org/drawingml/2006/main">
               <a:ext uri="{FF2B5EF4-FFF2-40B4-BE49-F238E27FC236}">
-                <a16:creationId xmlns:a16="http://schemas.microsoft.com/office/drawing/2014/main" id="{5B4F2F00-5964-4DCA-9A66-CCB3735406BB}"/>
+                <a16:creationId xmlns:a16="http://schemas.microsoft.com/office/drawing/2014/main" id="{F3889260-17FB-4AE4-B33B-3E6972FA3A89}"/>
               </a:ext>
             </a:extLst>
           </p:cNvPr>
@@ -19690,7 +19690,7 @@
     </p:spTree>
     <p:extLst>
       <p:ext uri="{BB962C8B-B14F-4D97-AF65-F5344CB8AC3E}">
-        <p14:creationId xmlns:p14="http://schemas.microsoft.com/office/powerpoint/2010/main" val="1615713505"/>
+        <p14:creationId xmlns:p14="http://schemas.microsoft.com/office/powerpoint/2010/main" val="1004324616"/>
       </p:ext>
     </p:extLst>
   </p:cSld>
@@ -19721,7 +19721,7 @@
           <p:cNvPr id="49" name="f142">
             <a:extLst xmlns:a="http://schemas.openxmlformats.org/drawingml/2006/main">
               <a:ext uri="{FF2B5EF4-FFF2-40B4-BE49-F238E27FC236}">
-                <a16:creationId xmlns:a16="http://schemas.microsoft.com/office/drawing/2014/main" id="{A7843F50-B1DF-427B-9879-F6C88943F79C}"/>
+                <a16:creationId xmlns:a16="http://schemas.microsoft.com/office/drawing/2014/main" id="{FAE84D9B-4533-457A-ACB1-4CFFBCB6F928}"/>
               </a:ext>
             </a:extLst>
           </p:cNvPr>
@@ -19880,7 +19880,7 @@
           <p:cNvPr id="2" name="f143">
             <a:extLst xmlns:a="http://schemas.openxmlformats.org/drawingml/2006/main">
               <a:ext uri="{FF2B5EF4-FFF2-40B4-BE49-F238E27FC236}">
-                <a16:creationId xmlns:a16="http://schemas.microsoft.com/office/drawing/2014/main" id="{9012041B-1DC9-43BB-AA60-B3DFCF986FEA}"/>
+                <a16:creationId xmlns:a16="http://schemas.microsoft.com/office/drawing/2014/main" id="{E940BB28-2915-4B3F-87D5-2664F44CB464}"/>
               </a:ext>
             </a:extLst>
           </p:cNvPr>
@@ -20039,7 +20039,7 @@
           <p:cNvPr id="3" name="f144">
             <a:extLst xmlns:a="http://schemas.openxmlformats.org/drawingml/2006/main">
               <a:ext uri="{FF2B5EF4-FFF2-40B4-BE49-F238E27FC236}">
-                <a16:creationId xmlns:a16="http://schemas.microsoft.com/office/drawing/2014/main" id="{C99CE9FE-9A76-469C-9DCB-8E89B54FF45F}"/>
+                <a16:creationId xmlns:a16="http://schemas.microsoft.com/office/drawing/2014/main" id="{517110F0-F8BF-4118-BFFE-7E3778B30CA5}"/>
               </a:ext>
             </a:extLst>
           </p:cNvPr>
@@ -20198,7 +20198,7 @@
           <p:cNvPr id="4" name="f145">
             <a:extLst xmlns:a="http://schemas.openxmlformats.org/drawingml/2006/main">
               <a:ext uri="{FF2B5EF4-FFF2-40B4-BE49-F238E27FC236}">
-                <a16:creationId xmlns:a16="http://schemas.microsoft.com/office/drawing/2014/main" id="{007DAF5B-C35B-41CE-991A-B17575155763}"/>
+                <a16:creationId xmlns:a16="http://schemas.microsoft.com/office/drawing/2014/main" id="{C6D95EBD-E461-4B54-BC2B-FC82E1E33EE6}"/>
               </a:ext>
             </a:extLst>
           </p:cNvPr>
@@ -20357,7 +20357,7 @@
           <p:cNvPr id="5" name="f146">
             <a:extLst xmlns:a="http://schemas.openxmlformats.org/drawingml/2006/main">
               <a:ext uri="{FF2B5EF4-FFF2-40B4-BE49-F238E27FC236}">
-                <a16:creationId xmlns:a16="http://schemas.microsoft.com/office/drawing/2014/main" id="{A80AB85E-A249-4D5B-84F1-71FC0A43BA9B}"/>
+                <a16:creationId xmlns:a16="http://schemas.microsoft.com/office/drawing/2014/main" id="{542E68A1-A13E-4A6E-B1FC-DE278B495DBD}"/>
               </a:ext>
             </a:extLst>
           </p:cNvPr>
@@ -20392,7 +20392,7 @@
           <p:cNvPr id="6" name="f147">
             <a:extLst xmlns:a="http://schemas.openxmlformats.org/drawingml/2006/main">
               <a:ext uri="{FF2B5EF4-FFF2-40B4-BE49-F238E27FC236}">
-                <a16:creationId xmlns:a16="http://schemas.microsoft.com/office/drawing/2014/main" id="{CA3704B9-BA61-49BC-A89E-1922C4271C65}"/>
+                <a16:creationId xmlns:a16="http://schemas.microsoft.com/office/drawing/2014/main" id="{79DAFEEE-837D-4316-A1D9-9849888D73FD}"/>
               </a:ext>
             </a:extLst>
           </p:cNvPr>
@@ -20551,7 +20551,7 @@
           <p:cNvPr id="7" name="f148">
             <a:extLst xmlns:a="http://schemas.openxmlformats.org/drawingml/2006/main">
               <a:ext uri="{FF2B5EF4-FFF2-40B4-BE49-F238E27FC236}">
-                <a16:creationId xmlns:a16="http://schemas.microsoft.com/office/drawing/2014/main" id="{2ACE68C0-8C93-4ACF-9B9F-88E405DF6634}"/>
+                <a16:creationId xmlns:a16="http://schemas.microsoft.com/office/drawing/2014/main" id="{23B54C86-3E35-4D23-A2F5-0B43F53F3C00}"/>
               </a:ext>
             </a:extLst>
           </p:cNvPr>
@@ -20586,7 +20586,7 @@
           <p:cNvPr id="8" name="f149">
             <a:extLst xmlns:a="http://schemas.openxmlformats.org/drawingml/2006/main">
               <a:ext uri="{FF2B5EF4-FFF2-40B4-BE49-F238E27FC236}">
-                <a16:creationId xmlns:a16="http://schemas.microsoft.com/office/drawing/2014/main" id="{7870EA06-80E3-4731-89CE-C46626DB0A96}"/>
+                <a16:creationId xmlns:a16="http://schemas.microsoft.com/office/drawing/2014/main" id="{28A1F048-6BAE-47F7-9D90-77FF3DE18793}"/>
               </a:ext>
             </a:extLst>
           </p:cNvPr>
@@ -20745,7 +20745,7 @@
           <p:cNvPr id="9" name="f150">
             <a:extLst xmlns:a="http://schemas.openxmlformats.org/drawingml/2006/main">
               <a:ext uri="{FF2B5EF4-FFF2-40B4-BE49-F238E27FC236}">
-                <a16:creationId xmlns:a16="http://schemas.microsoft.com/office/drawing/2014/main" id="{B1388504-07EA-486F-8C75-2BDAB16FC484}"/>
+                <a16:creationId xmlns:a16="http://schemas.microsoft.com/office/drawing/2014/main" id="{E56F0C01-7B21-49BB-A9A8-7C0225FC2232}"/>
               </a:ext>
             </a:extLst>
           </p:cNvPr>
@@ -20780,7 +20780,7 @@
           <p:cNvPr id="10" name="f151">
             <a:extLst xmlns:a="http://schemas.openxmlformats.org/drawingml/2006/main">
               <a:ext uri="{FF2B5EF4-FFF2-40B4-BE49-F238E27FC236}">
-                <a16:creationId xmlns:a16="http://schemas.microsoft.com/office/drawing/2014/main" id="{B2C247FA-9A2E-4F95-A246-F8C1140F316D}"/>
+                <a16:creationId xmlns:a16="http://schemas.microsoft.com/office/drawing/2014/main" id="{7EA61ED8-5D5A-4847-BA1C-D281298946D0}"/>
               </a:ext>
             </a:extLst>
           </p:cNvPr>
@@ -20939,7 +20939,7 @@
           <p:cNvPr id="11" name="f152">
             <a:extLst xmlns:a="http://schemas.openxmlformats.org/drawingml/2006/main">
               <a:ext uri="{FF2B5EF4-FFF2-40B4-BE49-F238E27FC236}">
-                <a16:creationId xmlns:a16="http://schemas.microsoft.com/office/drawing/2014/main" id="{3FD1E973-0055-4B1E-885D-4613877C3482}"/>
+                <a16:creationId xmlns:a16="http://schemas.microsoft.com/office/drawing/2014/main" id="{D11748A5-9A5B-4F65-96CB-1B1A6BF320C2}"/>
               </a:ext>
             </a:extLst>
           </p:cNvPr>
@@ -20974,7 +20974,7 @@
           <p:cNvPr id="12" name="f153">
             <a:extLst xmlns:a="http://schemas.openxmlformats.org/drawingml/2006/main">
               <a:ext uri="{FF2B5EF4-FFF2-40B4-BE49-F238E27FC236}">
-                <a16:creationId xmlns:a16="http://schemas.microsoft.com/office/drawing/2014/main" id="{84FBCC2A-2871-4DEF-8596-C9E16E214144}"/>
+                <a16:creationId xmlns:a16="http://schemas.microsoft.com/office/drawing/2014/main" id="{974D1534-78C1-4654-B544-9CFA33E1AAC5}"/>
               </a:ext>
             </a:extLst>
           </p:cNvPr>
@@ -21133,7 +21133,7 @@
           <p:cNvPr id="13" name="f154">
             <a:extLst xmlns:a="http://schemas.openxmlformats.org/drawingml/2006/main">
               <a:ext uri="{FF2B5EF4-FFF2-40B4-BE49-F238E27FC236}">
-                <a16:creationId xmlns:a16="http://schemas.microsoft.com/office/drawing/2014/main" id="{9CD06E7E-435F-4E5A-9EDB-321DB6AF586F}"/>
+                <a16:creationId xmlns:a16="http://schemas.microsoft.com/office/drawing/2014/main" id="{30FB1C78-4BF9-4C99-BC3E-D3D59336F81A}"/>
               </a:ext>
             </a:extLst>
           </p:cNvPr>
@@ -21168,7 +21168,7 @@
           <p:cNvPr id="14" name="f155">
             <a:extLst xmlns:a="http://schemas.openxmlformats.org/drawingml/2006/main">
               <a:ext uri="{FF2B5EF4-FFF2-40B4-BE49-F238E27FC236}">
-                <a16:creationId xmlns:a16="http://schemas.microsoft.com/office/drawing/2014/main" id="{C2A3300B-9998-49E2-8A83-685A5A0E52DE}"/>
+                <a16:creationId xmlns:a16="http://schemas.microsoft.com/office/drawing/2014/main" id="{2B8A4262-44E6-4D7E-AE6D-4E5A0ED2FCC7}"/>
               </a:ext>
             </a:extLst>
           </p:cNvPr>
@@ -21327,7 +21327,7 @@
           <p:cNvPr id="15" name="f156">
             <a:extLst xmlns:a="http://schemas.openxmlformats.org/drawingml/2006/main">
               <a:ext uri="{FF2B5EF4-FFF2-40B4-BE49-F238E27FC236}">
-                <a16:creationId xmlns:a16="http://schemas.microsoft.com/office/drawing/2014/main" id="{8667917F-82F1-43D8-960B-6647E2E692BC}"/>
+                <a16:creationId xmlns:a16="http://schemas.microsoft.com/office/drawing/2014/main" id="{0EE0B4C8-6E54-4025-A295-6B6155B3D2E8}"/>
               </a:ext>
             </a:extLst>
           </p:cNvPr>
@@ -21362,7 +21362,7 @@
           <p:cNvPr id="16" name="f157">
             <a:extLst xmlns:a="http://schemas.openxmlformats.org/drawingml/2006/main">
               <a:ext uri="{FF2B5EF4-FFF2-40B4-BE49-F238E27FC236}">
-                <a16:creationId xmlns:a16="http://schemas.microsoft.com/office/drawing/2014/main" id="{6F08C1D0-46EB-4081-9A6E-CB77761FEC02}"/>
+                <a16:creationId xmlns:a16="http://schemas.microsoft.com/office/drawing/2014/main" id="{817729EF-6BC3-4ED4-8E9B-913D13211103}"/>
               </a:ext>
             </a:extLst>
           </p:cNvPr>
@@ -21544,7 +21544,7 @@
           <p:cNvPr id="17" name="f158">
             <a:extLst xmlns:a="http://schemas.openxmlformats.org/drawingml/2006/main">
               <a:ext uri="{FF2B5EF4-FFF2-40B4-BE49-F238E27FC236}">
-                <a16:creationId xmlns:a16="http://schemas.microsoft.com/office/drawing/2014/main" id="{9A28D102-7E14-4189-92FE-1BA647AFE566}"/>
+                <a16:creationId xmlns:a16="http://schemas.microsoft.com/office/drawing/2014/main" id="{4CF83769-7222-44AB-8AFA-1D0D21F464B2}"/>
               </a:ext>
             </a:extLst>
           </p:cNvPr>
@@ -21579,7 +21579,7 @@
           <p:cNvPr id="18" name="f159">
             <a:extLst xmlns:a="http://schemas.openxmlformats.org/drawingml/2006/main">
               <a:ext uri="{FF2B5EF4-FFF2-40B4-BE49-F238E27FC236}">
-                <a16:creationId xmlns:a16="http://schemas.microsoft.com/office/drawing/2014/main" id="{1A712BE1-2D18-492A-B875-4CEDDC4FE8EE}"/>
+                <a16:creationId xmlns:a16="http://schemas.microsoft.com/office/drawing/2014/main" id="{881383A0-BC12-42DC-A792-E717B34FD9B2}"/>
               </a:ext>
             </a:extLst>
           </p:cNvPr>
@@ -21738,7 +21738,7 @@
           <p:cNvPr id="19" name="f160">
             <a:extLst xmlns:a="http://schemas.openxmlformats.org/drawingml/2006/main">
               <a:ext uri="{FF2B5EF4-FFF2-40B4-BE49-F238E27FC236}">
-                <a16:creationId xmlns:a16="http://schemas.microsoft.com/office/drawing/2014/main" id="{4D4E389A-A45F-498A-94EF-ECBD54131269}"/>
+                <a16:creationId xmlns:a16="http://schemas.microsoft.com/office/drawing/2014/main" id="{A5762339-2D90-4801-B941-9EA12D960F27}"/>
               </a:ext>
             </a:extLst>
           </p:cNvPr>
@@ -21769,7 +21769,7 @@
           <p:cNvPr id="20" name="f161">
             <a:extLst xmlns:a="http://schemas.openxmlformats.org/drawingml/2006/main">
               <a:ext uri="{FF2B5EF4-FFF2-40B4-BE49-F238E27FC236}">
-                <a16:creationId xmlns:a16="http://schemas.microsoft.com/office/drawing/2014/main" id="{184C0334-C959-460B-AA7E-AA520DAA4159}"/>
+                <a16:creationId xmlns:a16="http://schemas.microsoft.com/office/drawing/2014/main" id="{7AA446F9-328E-439A-A447-847AB0C2A61D}"/>
               </a:ext>
             </a:extLst>
           </p:cNvPr>
@@ -21800,7 +21800,7 @@
           <p:cNvPr id="21" name="f162">
             <a:extLst xmlns:a="http://schemas.openxmlformats.org/drawingml/2006/main">
               <a:ext uri="{FF2B5EF4-FFF2-40B4-BE49-F238E27FC236}">
-                <a16:creationId xmlns:a16="http://schemas.microsoft.com/office/drawing/2014/main" id="{B692232C-A06E-4E12-A937-62EE2F2FEB29}"/>
+                <a16:creationId xmlns:a16="http://schemas.microsoft.com/office/drawing/2014/main" id="{86D6AB1B-06A9-48FB-B1C3-A2104935D95C}"/>
               </a:ext>
             </a:extLst>
           </p:cNvPr>
@@ -21831,7 +21831,7 @@
           <p:cNvPr id="22" name="f163">
             <a:extLst xmlns:a="http://schemas.openxmlformats.org/drawingml/2006/main">
               <a:ext uri="{FF2B5EF4-FFF2-40B4-BE49-F238E27FC236}">
-                <a16:creationId xmlns:a16="http://schemas.microsoft.com/office/drawing/2014/main" id="{5FE2C42A-DF07-440A-9A44-9738065D98E8}"/>
+                <a16:creationId xmlns:a16="http://schemas.microsoft.com/office/drawing/2014/main" id="{48DD45E2-9557-48FD-AECF-6DBB15E5EC2A}"/>
               </a:ext>
             </a:extLst>
           </p:cNvPr>
@@ -21862,7 +21862,7 @@
           <p:cNvPr id="23" name="f164">
             <a:extLst xmlns:a="http://schemas.openxmlformats.org/drawingml/2006/main">
               <a:ext uri="{FF2B5EF4-FFF2-40B4-BE49-F238E27FC236}">
-                <a16:creationId xmlns:a16="http://schemas.microsoft.com/office/drawing/2014/main" id="{207E0F13-CDB1-4EB4-A3E6-397C3C35B033}"/>
+                <a16:creationId xmlns:a16="http://schemas.microsoft.com/office/drawing/2014/main" id="{A7D05815-7409-4546-8235-3CBFE0E8E759}"/>
               </a:ext>
             </a:extLst>
           </p:cNvPr>
@@ -21893,7 +21893,7 @@
           <p:cNvPr id="24" name="f165">
             <a:extLst xmlns:a="http://schemas.openxmlformats.org/drawingml/2006/main">
               <a:ext uri="{FF2B5EF4-FFF2-40B4-BE49-F238E27FC236}">
-                <a16:creationId xmlns:a16="http://schemas.microsoft.com/office/drawing/2014/main" id="{69981450-9D9F-40D4-93EE-7CCC0693FAAC}"/>
+                <a16:creationId xmlns:a16="http://schemas.microsoft.com/office/drawing/2014/main" id="{E0D433A7-D4FD-4681-A236-78B88BDC9649}"/>
               </a:ext>
             </a:extLst>
           </p:cNvPr>
@@ -21924,7 +21924,7 @@
           <p:cNvPr id="25" name="f166">
             <a:extLst xmlns:a="http://schemas.openxmlformats.org/drawingml/2006/main">
               <a:ext uri="{FF2B5EF4-FFF2-40B4-BE49-F238E27FC236}">
-                <a16:creationId xmlns:a16="http://schemas.microsoft.com/office/drawing/2014/main" id="{D411A154-D018-4707-AF04-8E0BF77EDEC2}"/>
+                <a16:creationId xmlns:a16="http://schemas.microsoft.com/office/drawing/2014/main" id="{199DFA5F-F6D2-4D93-A100-2EF3CA379762}"/>
               </a:ext>
             </a:extLst>
           </p:cNvPr>
@@ -21955,7 +21955,7 @@
           <p:cNvPr id="26" name="f167">
             <a:extLst xmlns:a="http://schemas.openxmlformats.org/drawingml/2006/main">
               <a:ext uri="{FF2B5EF4-FFF2-40B4-BE49-F238E27FC236}">
-                <a16:creationId xmlns:a16="http://schemas.microsoft.com/office/drawing/2014/main" id="{79CEB5C9-CEA1-4F4D-995C-8484F72275C9}"/>
+                <a16:creationId xmlns:a16="http://schemas.microsoft.com/office/drawing/2014/main" id="{508FFB0E-93F6-4CB6-A160-AF7258B1EAAE}"/>
               </a:ext>
             </a:extLst>
           </p:cNvPr>
@@ -21986,7 +21986,7 @@
           <p:cNvPr id="27" name="f168">
             <a:extLst xmlns:a="http://schemas.openxmlformats.org/drawingml/2006/main">
               <a:ext uri="{FF2B5EF4-FFF2-40B4-BE49-F238E27FC236}">
-                <a16:creationId xmlns:a16="http://schemas.microsoft.com/office/drawing/2014/main" id="{05F91E44-CE5F-463A-BF8D-39C8FA38B491}"/>
+                <a16:creationId xmlns:a16="http://schemas.microsoft.com/office/drawing/2014/main" id="{FEDDC2AC-677B-485B-B016-C50C18AC83C9}"/>
               </a:ext>
             </a:extLst>
           </p:cNvPr>
@@ -22017,7 +22017,7 @@
           <p:cNvPr id="28" name="f169">
             <a:extLst xmlns:a="http://schemas.openxmlformats.org/drawingml/2006/main">
               <a:ext uri="{FF2B5EF4-FFF2-40B4-BE49-F238E27FC236}">
-                <a16:creationId xmlns:a16="http://schemas.microsoft.com/office/drawing/2014/main" id="{80C780C2-EE40-4F7E-9A2A-1FF7508546F4}"/>
+                <a16:creationId xmlns:a16="http://schemas.microsoft.com/office/drawing/2014/main" id="{A25FCD55-EE3F-44A4-8769-4D5487F38499}"/>
               </a:ext>
             </a:extLst>
           </p:cNvPr>
@@ -22048,7 +22048,7 @@
           <p:cNvPr id="29" name="f170">
             <a:extLst xmlns:a="http://schemas.openxmlformats.org/drawingml/2006/main">
               <a:ext uri="{FF2B5EF4-FFF2-40B4-BE49-F238E27FC236}">
-                <a16:creationId xmlns:a16="http://schemas.microsoft.com/office/drawing/2014/main" id="{CB5562BC-CCDC-4BF0-9EC0-81DB21B6E55F}"/>
+                <a16:creationId xmlns:a16="http://schemas.microsoft.com/office/drawing/2014/main" id="{94A53E58-03AC-44AC-B207-1D2B5001901D}"/>
               </a:ext>
             </a:extLst>
           </p:cNvPr>
@@ -22079,7 +22079,7 @@
           <p:cNvPr id="30" name="f171">
             <a:extLst xmlns:a="http://schemas.openxmlformats.org/drawingml/2006/main">
               <a:ext uri="{FF2B5EF4-FFF2-40B4-BE49-F238E27FC236}">
-                <a16:creationId xmlns:a16="http://schemas.microsoft.com/office/drawing/2014/main" id="{04730B43-515A-4377-8DF6-7BEBA1031776}"/>
+                <a16:creationId xmlns:a16="http://schemas.microsoft.com/office/drawing/2014/main" id="{39CE3B35-A428-4BA5-B1F8-5FA761A449DD}"/>
               </a:ext>
             </a:extLst>
           </p:cNvPr>
@@ -22110,7 +22110,7 @@
           <p:cNvPr id="31" name="f172">
             <a:extLst xmlns:a="http://schemas.openxmlformats.org/drawingml/2006/main">
               <a:ext uri="{FF2B5EF4-FFF2-40B4-BE49-F238E27FC236}">
-                <a16:creationId xmlns:a16="http://schemas.microsoft.com/office/drawing/2014/main" id="{E2BFDDEB-FB2A-4C57-B0CA-1EC5BD914799}"/>
+                <a16:creationId xmlns:a16="http://schemas.microsoft.com/office/drawing/2014/main" id="{9C81D7A3-1C7E-4862-9985-D89C2A8D5C52}"/>
               </a:ext>
             </a:extLst>
           </p:cNvPr>
@@ -22141,7 +22141,7 @@
           <p:cNvPr id="32" name="f173">
             <a:extLst xmlns:a="http://schemas.openxmlformats.org/drawingml/2006/main">
               <a:ext uri="{FF2B5EF4-FFF2-40B4-BE49-F238E27FC236}">
-                <a16:creationId xmlns:a16="http://schemas.microsoft.com/office/drawing/2014/main" id="{655A1775-8755-42B7-A7D2-1C465B4D3C0D}"/>
+                <a16:creationId xmlns:a16="http://schemas.microsoft.com/office/drawing/2014/main" id="{2CEB84E7-C0E3-46B0-B122-0E932897A762}"/>
               </a:ext>
             </a:extLst>
           </p:cNvPr>
@@ -22172,7 +22172,7 @@
           <p:cNvPr id="33" name="f174">
             <a:extLst xmlns:a="http://schemas.openxmlformats.org/drawingml/2006/main">
               <a:ext uri="{FF2B5EF4-FFF2-40B4-BE49-F238E27FC236}">
-                <a16:creationId xmlns:a16="http://schemas.microsoft.com/office/drawing/2014/main" id="{D7231857-AC6C-48E9-BCD0-A37E53936DFF}"/>
+                <a16:creationId xmlns:a16="http://schemas.microsoft.com/office/drawing/2014/main" id="{F0A97875-7CDE-4149-B3D1-58285CBB00BB}"/>
               </a:ext>
             </a:extLst>
           </p:cNvPr>
@@ -22203,7 +22203,7 @@
           <p:cNvPr id="34" name="f175">
             <a:extLst xmlns:a="http://schemas.openxmlformats.org/drawingml/2006/main">
               <a:ext uri="{FF2B5EF4-FFF2-40B4-BE49-F238E27FC236}">
-                <a16:creationId xmlns:a16="http://schemas.microsoft.com/office/drawing/2014/main" id="{609274E2-0D68-413C-9BCC-64C9435822C0}"/>
+                <a16:creationId xmlns:a16="http://schemas.microsoft.com/office/drawing/2014/main" id="{D3D4F963-4FB8-4ADE-A558-FCD72E73495B}"/>
               </a:ext>
             </a:extLst>
           </p:cNvPr>
@@ -22362,7 +22362,7 @@
           <p:cNvPr id="35" name="f176">
             <a:extLst xmlns:a="http://schemas.openxmlformats.org/drawingml/2006/main">
               <a:ext uri="{FF2B5EF4-FFF2-40B4-BE49-F238E27FC236}">
-                <a16:creationId xmlns:a16="http://schemas.microsoft.com/office/drawing/2014/main" id="{CDBA6A27-C716-4A72-B435-7A94DD45EADA}"/>
+                <a16:creationId xmlns:a16="http://schemas.microsoft.com/office/drawing/2014/main" id="{4BEF5EDE-5426-49BF-B692-9553EFDA265A}"/>
               </a:ext>
             </a:extLst>
           </p:cNvPr>
@@ -22393,7 +22393,7 @@
           <p:cNvPr id="36" name="f177">
             <a:extLst xmlns:a="http://schemas.openxmlformats.org/drawingml/2006/main">
               <a:ext uri="{FF2B5EF4-FFF2-40B4-BE49-F238E27FC236}">
-                <a16:creationId xmlns:a16="http://schemas.microsoft.com/office/drawing/2014/main" id="{BACF0201-6783-4329-9854-832BBE14010E}"/>
+                <a16:creationId xmlns:a16="http://schemas.microsoft.com/office/drawing/2014/main" id="{A15C9C21-33AF-415C-BB6E-D8E851F25BA1}"/>
               </a:ext>
             </a:extLst>
           </p:cNvPr>
@@ -22424,7 +22424,7 @@
           <p:cNvPr id="37" name="f178">
             <a:extLst xmlns:a="http://schemas.openxmlformats.org/drawingml/2006/main">
               <a:ext uri="{FF2B5EF4-FFF2-40B4-BE49-F238E27FC236}">
-                <a16:creationId xmlns:a16="http://schemas.microsoft.com/office/drawing/2014/main" id="{6C6ABB35-48CE-4F91-BB2B-3EBF29FD5875}"/>
+                <a16:creationId xmlns:a16="http://schemas.microsoft.com/office/drawing/2014/main" id="{C6427012-EBA2-4CE0-B0B5-F39A63F12AB9}"/>
               </a:ext>
             </a:extLst>
           </p:cNvPr>
@@ -22455,7 +22455,7 @@
           <p:cNvPr id="38" name="f179">
             <a:extLst xmlns:a="http://schemas.openxmlformats.org/drawingml/2006/main">
               <a:ext uri="{FF2B5EF4-FFF2-40B4-BE49-F238E27FC236}">
-                <a16:creationId xmlns:a16="http://schemas.microsoft.com/office/drawing/2014/main" id="{266397D4-5B19-4E6A-A19C-882DB926190F}"/>
+                <a16:creationId xmlns:a16="http://schemas.microsoft.com/office/drawing/2014/main" id="{AC12F035-4BCB-4BCA-963B-8D7444D7DF68}"/>
               </a:ext>
             </a:extLst>
           </p:cNvPr>
@@ -22486,7 +22486,7 @@
           <p:cNvPr id="39" name="f180">
             <a:extLst xmlns:a="http://schemas.openxmlformats.org/drawingml/2006/main">
               <a:ext uri="{FF2B5EF4-FFF2-40B4-BE49-F238E27FC236}">
-                <a16:creationId xmlns:a16="http://schemas.microsoft.com/office/drawing/2014/main" id="{B632F246-A5D8-4C4F-A1C0-FC7956EC3A56}"/>
+                <a16:creationId xmlns:a16="http://schemas.microsoft.com/office/drawing/2014/main" id="{C0F6AF8A-6577-410A-AE59-79AC42662667}"/>
               </a:ext>
             </a:extLst>
           </p:cNvPr>
@@ -22517,7 +22517,7 @@
           <p:cNvPr id="40" name="f181">
             <a:extLst xmlns:a="http://schemas.openxmlformats.org/drawingml/2006/main">
               <a:ext uri="{FF2B5EF4-FFF2-40B4-BE49-F238E27FC236}">
-                <a16:creationId xmlns:a16="http://schemas.microsoft.com/office/drawing/2014/main" id="{B995046F-087E-41E5-A804-57236E12A255}"/>
+                <a16:creationId xmlns:a16="http://schemas.microsoft.com/office/drawing/2014/main" id="{5322EFDC-0981-48CE-A939-9BB258970E3A}"/>
               </a:ext>
             </a:extLst>
           </p:cNvPr>
@@ -22548,7 +22548,7 @@
           <p:cNvPr id="41" name="f182">
             <a:extLst xmlns:a="http://schemas.openxmlformats.org/drawingml/2006/main">
               <a:ext uri="{FF2B5EF4-FFF2-40B4-BE49-F238E27FC236}">
-                <a16:creationId xmlns:a16="http://schemas.microsoft.com/office/drawing/2014/main" id="{63048B75-8F96-4336-B239-D1AF0CFCD1B8}"/>
+                <a16:creationId xmlns:a16="http://schemas.microsoft.com/office/drawing/2014/main" id="{53F69048-7F86-465E-BE72-19AF885B8E52}"/>
               </a:ext>
             </a:extLst>
           </p:cNvPr>
@@ -22579,7 +22579,7 @@
           <p:cNvPr id="42" name="f183">
             <a:extLst xmlns:a="http://schemas.openxmlformats.org/drawingml/2006/main">
               <a:ext uri="{FF2B5EF4-FFF2-40B4-BE49-F238E27FC236}">
-                <a16:creationId xmlns:a16="http://schemas.microsoft.com/office/drawing/2014/main" id="{605AC6FA-AE8F-446D-A013-4B925D7282D7}"/>
+                <a16:creationId xmlns:a16="http://schemas.microsoft.com/office/drawing/2014/main" id="{25537E6E-6D56-4625-969A-6249D127D949}"/>
               </a:ext>
             </a:extLst>
           </p:cNvPr>
@@ -22610,7 +22610,7 @@
           <p:cNvPr id="43" name="f184">
             <a:extLst xmlns:a="http://schemas.openxmlformats.org/drawingml/2006/main">
               <a:ext uri="{FF2B5EF4-FFF2-40B4-BE49-F238E27FC236}">
-                <a16:creationId xmlns:a16="http://schemas.microsoft.com/office/drawing/2014/main" id="{532AEBC0-46CC-44CE-A198-4043102EB64E}"/>
+                <a16:creationId xmlns:a16="http://schemas.microsoft.com/office/drawing/2014/main" id="{0C955191-543C-4881-BD76-790AB1E38FD1}"/>
               </a:ext>
             </a:extLst>
           </p:cNvPr>
@@ -22641,7 +22641,7 @@
           <p:cNvPr id="44" name="f185">
             <a:extLst xmlns:a="http://schemas.openxmlformats.org/drawingml/2006/main">
               <a:ext uri="{FF2B5EF4-FFF2-40B4-BE49-F238E27FC236}">
-                <a16:creationId xmlns:a16="http://schemas.microsoft.com/office/drawing/2014/main" id="{8241F6DC-6CBB-47C0-8303-534DADABFA52}"/>
+                <a16:creationId xmlns:a16="http://schemas.microsoft.com/office/drawing/2014/main" id="{148D418F-E4BB-492A-B8F5-A55BF01573BD}"/>
               </a:ext>
             </a:extLst>
           </p:cNvPr>
@@ -22672,7 +22672,7 @@
           <p:cNvPr id="45" name="f186">
             <a:extLst xmlns:a="http://schemas.openxmlformats.org/drawingml/2006/main">
               <a:ext uri="{FF2B5EF4-FFF2-40B4-BE49-F238E27FC236}">
-                <a16:creationId xmlns:a16="http://schemas.microsoft.com/office/drawing/2014/main" id="{D2BB4608-34DE-46A6-AD6C-86E0BB32E8EB}"/>
+                <a16:creationId xmlns:a16="http://schemas.microsoft.com/office/drawing/2014/main" id="{2041356C-CEC8-4538-B207-67477330066F}"/>
               </a:ext>
             </a:extLst>
           </p:cNvPr>
@@ -22831,7 +22831,7 @@
           <p:cNvPr id="46" name="">
             <a:extLst xmlns:a="http://schemas.openxmlformats.org/drawingml/2006/main">
               <a:ext uri="{FF2B5EF4-FFF2-40B4-BE49-F238E27FC236}">
-                <a16:creationId xmlns:a16="http://schemas.microsoft.com/office/drawing/2014/main" id="{C5EE1700-CF70-4441-BD73-A4A3C35BDC3A}"/>
+                <a16:creationId xmlns:a16="http://schemas.microsoft.com/office/drawing/2014/main" id="{2574253D-69D1-46E1-BFDA-1B35A9B08D0C}"/>
               </a:ext>
             </a:extLst>
           </p:cNvPr>
@@ -23434,7 +23434,7 @@
           <p:cNvPr id="47" name="f188">
             <a:extLst xmlns:a="http://schemas.openxmlformats.org/drawingml/2006/main">
               <a:ext uri="{FF2B5EF4-FFF2-40B4-BE49-F238E27FC236}">
-                <a16:creationId xmlns:a16="http://schemas.microsoft.com/office/drawing/2014/main" id="{E36E5F54-D02F-42C1-A0A7-34E5AF369261}"/>
+                <a16:creationId xmlns:a16="http://schemas.microsoft.com/office/drawing/2014/main" id="{C5A25857-740E-432B-A15C-63403E46EB36}"/>
               </a:ext>
             </a:extLst>
           </p:cNvPr>
@@ -23593,7 +23593,7 @@
           <p:cNvPr id="48" name="f189">
             <a:extLst xmlns:a="http://schemas.openxmlformats.org/drawingml/2006/main">
               <a:ext uri="{FF2B5EF4-FFF2-40B4-BE49-F238E27FC236}">
-                <a16:creationId xmlns:a16="http://schemas.microsoft.com/office/drawing/2014/main" id="{0243ED90-1A24-4D92-AD9E-4267784AA64E}"/>
+                <a16:creationId xmlns:a16="http://schemas.microsoft.com/office/drawing/2014/main" id="{51C27A74-1F2D-4863-866B-AB870A97AC79}"/>
               </a:ext>
             </a:extLst>
           </p:cNvPr>
@@ -23773,7 +23773,7 @@
     </p:spTree>
     <p:extLst>
       <p:ext uri="{BB962C8B-B14F-4D97-AF65-F5344CB8AC3E}">
-        <p14:creationId xmlns:p14="http://schemas.microsoft.com/office/powerpoint/2010/main" val="171307039"/>
+        <p14:creationId xmlns:p14="http://schemas.microsoft.com/office/powerpoint/2010/main" val="632023586"/>
       </p:ext>
     </p:extLst>
   </p:cSld>

</xml_diff>

<commit_message>
Use three animation phases and keep mutation examples always visible
</commit_message>
<xml_diff>
--- a/5g-thesis-presentation-5min/tesi-5min-statico.pptx
+++ b/5g-thesis-presentation-5min/tesi-5min-statico.pptx
@@ -2,19 +2,19 @@
 <file path=ppt/presentation.xml><?xml version="1.0" encoding="utf-8"?>
 <p:presentation xmlns:p="http://schemas.openxmlformats.org/presentationml/2006/main">
   <p:sldMasterIdLst>
-    <p:sldMasterId xmlns:r="http://schemas.openxmlformats.org/officeDocument/2006/relationships" id="2147483648" r:id="R2ca2d8a7bc7d4b38"/>
+    <p:sldMasterId xmlns:r="http://schemas.openxmlformats.org/officeDocument/2006/relationships" id="2147483648" r:id="Rc9a03ea16857466e"/>
   </p:sldMasterIdLst>
   <p:notesMasterIdLst>
-    <p:notesMasterId xmlns:r="http://schemas.openxmlformats.org/officeDocument/2006/relationships" r:id="R55425d0d98b84033"/>
+    <p:notesMasterId xmlns:r="http://schemas.openxmlformats.org/officeDocument/2006/relationships" r:id="R335d0ebf525a4447"/>
   </p:notesMasterIdLst>
   <p:sldIdLst>
-    <p:sldId xmlns:r="http://schemas.openxmlformats.org/officeDocument/2006/relationships" id="256" r:id="R90090369c0de4471"/>
-    <p:sldId xmlns:r="http://schemas.openxmlformats.org/officeDocument/2006/relationships" id="257" r:id="R229d8e9c322247ad"/>
-    <p:sldId xmlns:r="http://schemas.openxmlformats.org/officeDocument/2006/relationships" id="258" r:id="R59ae73be39254184"/>
-    <p:sldId xmlns:r="http://schemas.openxmlformats.org/officeDocument/2006/relationships" id="259" r:id="R77fe9015c59a4d1b"/>
-    <p:sldId xmlns:r="http://schemas.openxmlformats.org/officeDocument/2006/relationships" id="260" r:id="R768286205e0141cf"/>
-    <p:sldId xmlns:r="http://schemas.openxmlformats.org/officeDocument/2006/relationships" id="261" r:id="R2cd8f3f5fa064c5d"/>
-    <p:sldId xmlns:r="http://schemas.openxmlformats.org/officeDocument/2006/relationships" id="262" r:id="R4dd26d0b3eaa4406"/>
+    <p:sldId xmlns:r="http://schemas.openxmlformats.org/officeDocument/2006/relationships" id="256" r:id="R07fce34d24e54e88"/>
+    <p:sldId xmlns:r="http://schemas.openxmlformats.org/officeDocument/2006/relationships" id="257" r:id="Rf943c923a7774e50"/>
+    <p:sldId xmlns:r="http://schemas.openxmlformats.org/officeDocument/2006/relationships" id="258" r:id="Re7a983aa8876476e"/>
+    <p:sldId xmlns:r="http://schemas.openxmlformats.org/officeDocument/2006/relationships" id="259" r:id="Rdd822fe2b47d4d43"/>
+    <p:sldId xmlns:r="http://schemas.openxmlformats.org/officeDocument/2006/relationships" id="260" r:id="Ref38538bd830463a"/>
+    <p:sldId xmlns:r="http://schemas.openxmlformats.org/officeDocument/2006/relationships" id="261" r:id="R2954225013c747d4"/>
+    <p:sldId xmlns:r="http://schemas.openxmlformats.org/officeDocument/2006/relationships" id="262" r:id="R8f5c574976534372"/>
   </p:sldIdLst>
   <p:sldSz cx="15240000" cy="8572500"/>
   <p:notesSz cx="6858000" cy="9144000"/>
@@ -1053,7 +1053,7 @@
           <a:lstStyle xmlns:a="http://schemas.openxmlformats.org/drawingml/2006/main"/>
           <a:p xmlns:a="http://schemas.openxmlformats.org/drawingml/2006/main">
             <a:r>
-              <a:t>[Prima fase: baseline in evidenza. Un clic passa alla seconda fase: mutazione in evidenza. DSL e pipeline restano sempre attivi.] Per valutare la sensibilità del sistema ho introdotto modifiche controllate nelle catture. Il mutatore è separato dalla pipeline: riceve la PCAP originale e le evidenze del report baseline, individua i dati da modificare e produce la PCAP mutata. Questa torna nello stesso sistema di verifica, con la stessa DSL. Il confronto dei risultati deve corrispondere alla modifica introdotta. Nei 13 scenari completati ho ottenuto tutti i verdetti attesi. Gli esempi mostrano il cambio di stato NRF da HTTP 200 a 403, la violazione dell’intervallo temporale nel caso AMF A e la rimozione degli F-TEID disponibili per la verifica UPF. In quest’ultimo esperimento sono state rimosse le risposte PFCP rilevanti, producendo INCONCLUSIVE.</a:t>
+              <a:t>[Tre fasi con due clic: A baseline, B generazione della PCAP mutata dal motore, C verifica della mutazione. Gli esempi a destra restano sempre visibili. DSL e pipeline sono in evidenza nelle fasi A e C.] Per valutare la sensibilità del sistema ho introdotto modifiche controllate nelle catture. Il mutatore è separato dalla pipeline: riceve la PCAP originale e le evidenze del report baseline, individua i dati da modificare e produce la PCAP mutata. Questa torna nello stesso sistema di verifica, con la stessa DSL. Il confronto dei risultati deve corrispondere alla modifica introdotta. Nei 13 scenari completati ho ottenuto tutti i verdetti attesi. Gli esempi mostrano il cambio di stato NRF da HTTP 200 a 403, la violazione dell’intervallo temporale nel caso AMF A e la rimozione degli F-TEID disponibili per la verifica UPF. In quest’ultimo esperimento sono state rimosse le risposte PFCP rilevanti, producendo INCONCLUSIVE.</a:t>
             </a:r>
           </a:p>
           <a:p xmlns:a="http://schemas.openxmlformats.org/drawingml/2006/main">
@@ -1135,7 +1135,7 @@
           <p:cNvPr id="3" name="Title">
             <a:extLst xmlns:a="http://schemas.openxmlformats.org/drawingml/2006/main">
               <a:ext uri="{FF2B5EF4-FFF2-40B4-BE49-F238E27FC236}">
-                <a16:creationId xmlns:a16="http://schemas.microsoft.com/office/drawing/2014/main" id="{E4349258-73DC-4F40-B220-529F8B7A1DAA}"/>
+                <a16:creationId xmlns:a16="http://schemas.microsoft.com/office/drawing/2014/main" id="{EBEC20B4-2969-41EE-8B37-77440FF5B476}"/>
               </a:ext>
             </a:extLst>
           </p:cNvPr>
@@ -1364,7 +1364,7 @@
           <p:cNvPr id="2" name="Subtitle">
             <a:extLst xmlns:a="http://schemas.openxmlformats.org/drawingml/2006/main">
               <a:ext uri="{FF2B5EF4-FFF2-40B4-BE49-F238E27FC236}">
-                <a16:creationId xmlns:a16="http://schemas.microsoft.com/office/drawing/2014/main" id="{4AFFB083-48F1-4F74-9DB1-5945E00F92C4}"/>
+                <a16:creationId xmlns:a16="http://schemas.microsoft.com/office/drawing/2014/main" id="{255CE1B1-00FB-41A7-8F7F-1FA0754EA09B}"/>
               </a:ext>
             </a:extLst>
           </p:cNvPr>
@@ -1610,7 +1610,7 @@
           <p:cNvPr id="2" name="Section title">
             <a:extLst xmlns:a="http://schemas.openxmlformats.org/drawingml/2006/main">
               <a:ext uri="{FF2B5EF4-FFF2-40B4-BE49-F238E27FC236}">
-                <a16:creationId xmlns:a16="http://schemas.microsoft.com/office/drawing/2014/main" id="{6637C521-8648-4AE8-9BF5-539F81868292}"/>
+                <a16:creationId xmlns:a16="http://schemas.microsoft.com/office/drawing/2014/main" id="{90B0E8C9-A108-4C2C-8DD8-A810526B51DF}"/>
               </a:ext>
             </a:extLst>
           </p:cNvPr>
@@ -1856,7 +1856,7 @@
           <p:cNvPr id="3" name="Title">
             <a:extLst xmlns:a="http://schemas.openxmlformats.org/drawingml/2006/main">
               <a:ext uri="{FF2B5EF4-FFF2-40B4-BE49-F238E27FC236}">
-                <a16:creationId xmlns:a16="http://schemas.microsoft.com/office/drawing/2014/main" id="{18AB4CD2-BB9C-4196-BBF3-55B57CF98469}"/>
+                <a16:creationId xmlns:a16="http://schemas.microsoft.com/office/drawing/2014/main" id="{B0E0CCA4-E384-44FA-9F0B-BD20C13C09C4}"/>
               </a:ext>
             </a:extLst>
           </p:cNvPr>
@@ -2085,7 +2085,7 @@
           <p:cNvPr id="2" name="Body">
             <a:extLst xmlns:a="http://schemas.openxmlformats.org/drawingml/2006/main">
               <a:ext uri="{FF2B5EF4-FFF2-40B4-BE49-F238E27FC236}">
-                <a16:creationId xmlns:a16="http://schemas.microsoft.com/office/drawing/2014/main" id="{6BC370F6-02E9-4127-B6F5-484C89BD306C}"/>
+                <a16:creationId xmlns:a16="http://schemas.microsoft.com/office/drawing/2014/main" id="{E22AC889-5AFB-47D7-BB20-F656999EA961}"/>
               </a:ext>
             </a:extLst>
           </p:cNvPr>
@@ -2331,7 +2331,7 @@
           <p:cNvPr id="4" name="Title">
             <a:extLst xmlns:a="http://schemas.openxmlformats.org/drawingml/2006/main">
               <a:ext uri="{FF2B5EF4-FFF2-40B4-BE49-F238E27FC236}">
-                <a16:creationId xmlns:a16="http://schemas.microsoft.com/office/drawing/2014/main" id="{6E944ABF-EA58-4685-BDBD-3B261410DBC5}"/>
+                <a16:creationId xmlns:a16="http://schemas.microsoft.com/office/drawing/2014/main" id="{234E3200-0AD4-438B-9E1F-979702ECF0B3}"/>
               </a:ext>
             </a:extLst>
           </p:cNvPr>
@@ -2560,7 +2560,7 @@
           <p:cNvPr id="2" name="Left column">
             <a:extLst xmlns:a="http://schemas.openxmlformats.org/drawingml/2006/main">
               <a:ext uri="{FF2B5EF4-FFF2-40B4-BE49-F238E27FC236}">
-                <a16:creationId xmlns:a16="http://schemas.microsoft.com/office/drawing/2014/main" id="{1E33F2F6-9079-49F1-A97D-750E1CF3F8E3}"/>
+                <a16:creationId xmlns:a16="http://schemas.microsoft.com/office/drawing/2014/main" id="{B5C7A0EA-5A1D-49CC-9CB6-42CCD904251D}"/>
               </a:ext>
             </a:extLst>
           </p:cNvPr>
@@ -2789,7 +2789,7 @@
           <p:cNvPr id="3" name="Right column">
             <a:extLst xmlns:a="http://schemas.openxmlformats.org/drawingml/2006/main">
               <a:ext uri="{FF2B5EF4-FFF2-40B4-BE49-F238E27FC236}">
-                <a16:creationId xmlns:a16="http://schemas.microsoft.com/office/drawing/2014/main" id="{5C67A6F7-2C98-49DE-ADF0-9D44CD69232B}"/>
+                <a16:creationId xmlns:a16="http://schemas.microsoft.com/office/drawing/2014/main" id="{3254CABD-AE09-400E-85BE-050611654385}"/>
               </a:ext>
             </a:extLst>
           </p:cNvPr>
@@ -3035,7 +3035,7 @@
           <p:cNvPr id="3" name="Title">
             <a:extLst xmlns:a="http://schemas.openxmlformats.org/drawingml/2006/main">
               <a:ext uri="{FF2B5EF4-FFF2-40B4-BE49-F238E27FC236}">
-                <a16:creationId xmlns:a16="http://schemas.microsoft.com/office/drawing/2014/main" id="{7F752A6E-A98C-414D-A9B0-174B861CEE35}"/>
+                <a16:creationId xmlns:a16="http://schemas.microsoft.com/office/drawing/2014/main" id="{3A55BAF0-1DCC-433C-BA1F-612092D5F4F8}"/>
               </a:ext>
             </a:extLst>
           </p:cNvPr>
@@ -3264,7 +3264,7 @@
           <p:cNvPr id="2" name="Left column">
             <a:extLst xmlns:a="http://schemas.openxmlformats.org/drawingml/2006/main">
               <a:ext uri="{FF2B5EF4-FFF2-40B4-BE49-F238E27FC236}">
-                <a16:creationId xmlns:a16="http://schemas.microsoft.com/office/drawing/2014/main" id="{61D78A9D-5ED4-4693-BBB0-3D1C5BA5C400}"/>
+                <a16:creationId xmlns:a16="http://schemas.microsoft.com/office/drawing/2014/main" id="{91116FE8-A480-4F6C-97E8-8AF76DBED865}"/>
               </a:ext>
             </a:extLst>
           </p:cNvPr>
@@ -3531,12 +3531,12 @@
   </p:cSld>
   <p:clrMap bg1="lt1" tx1="dk1" bg2="lt2" tx2="dk2" accent1="accent1" accent2="accent2" accent3="accent3" accent4="accent4" accent5="accent5" accent6="accent6" hlink="hlink" folHlink="folHlink"/>
   <p:sldLayoutIdLst>
-    <p:sldLayoutId xmlns:r="http://schemas.openxmlformats.org/officeDocument/2006/relationships" id="2147483649" r:id="R634f08903e844444"/>
-    <p:sldLayoutId xmlns:r="http://schemas.openxmlformats.org/officeDocument/2006/relationships" id="2147483650" r:id="Rb62e7b7debfb49f4"/>
-    <p:sldLayoutId xmlns:r="http://schemas.openxmlformats.org/officeDocument/2006/relationships" id="2147483651" r:id="Rea4189e311e04d98"/>
-    <p:sldLayoutId xmlns:r="http://schemas.openxmlformats.org/officeDocument/2006/relationships" id="2147483652" r:id="R9295788890c94e80"/>
-    <p:sldLayoutId xmlns:r="http://schemas.openxmlformats.org/officeDocument/2006/relationships" id="2147483653" r:id="Rfa2ad073730c4a86"/>
-    <p:sldLayoutId xmlns:r="http://schemas.openxmlformats.org/officeDocument/2006/relationships" id="2147483654" r:id="R78b1918674934552"/>
+    <p:sldLayoutId xmlns:r="http://schemas.openxmlformats.org/officeDocument/2006/relationships" id="2147483649" r:id="R858fa8fe78a540cc"/>
+    <p:sldLayoutId xmlns:r="http://schemas.openxmlformats.org/officeDocument/2006/relationships" id="2147483650" r:id="R659360ab6eb1440a"/>
+    <p:sldLayoutId xmlns:r="http://schemas.openxmlformats.org/officeDocument/2006/relationships" id="2147483651" r:id="R69184f7349424297"/>
+    <p:sldLayoutId xmlns:r="http://schemas.openxmlformats.org/officeDocument/2006/relationships" id="2147483652" r:id="R8230d9cf907643da"/>
+    <p:sldLayoutId xmlns:r="http://schemas.openxmlformats.org/officeDocument/2006/relationships" id="2147483653" r:id="Rffcae840cf9742df"/>
+    <p:sldLayoutId xmlns:r="http://schemas.openxmlformats.org/officeDocument/2006/relationships" id="2147483654" r:id="R81a1a620cdbe4517"/>
   </p:sldLayoutIdLst>
   <p:txStyles>
     <p:titleStyle>
@@ -4087,7 +4087,7 @@
           <p:cNvPr id="21" name="">
             <a:extLst xmlns:a="http://schemas.openxmlformats.org/drawingml/2006/main">
               <a:ext uri="{FF2B5EF4-FFF2-40B4-BE49-F238E27FC236}">
-                <a16:creationId xmlns:a16="http://schemas.microsoft.com/office/drawing/2014/main" id="{7D45A3AF-40C0-4454-B573-6AD74A981AED}"/>
+                <a16:creationId xmlns:a16="http://schemas.microsoft.com/office/drawing/2014/main" id="{350D251C-EE3D-4522-9ABA-6DBB6F89AAF1}"/>
               </a:ext>
             </a:extLst>
           </p:cNvPr>
@@ -4097,7 +4097,7 @@
           <p:nvPr/>
         </p:nvPicPr>
         <p:blipFill>
-          <a:blip xmlns:r="http://schemas.openxmlformats.org/officeDocument/2006/relationships" xmlns:a="http://schemas.openxmlformats.org/drawingml/2006/main" r:embed="Re5ce24a44eeb4502"/>
+          <a:blip xmlns:r="http://schemas.openxmlformats.org/officeDocument/2006/relationships" xmlns:a="http://schemas.openxmlformats.org/drawingml/2006/main" r:embed="R2d63f5637ce44d3e"/>
           <a:stretch xmlns:a="http://schemas.openxmlformats.org/drawingml/2006/main"/>
         </p:blipFill>
         <p:spPr>
@@ -4115,7 +4115,7 @@
           <p:cNvPr id="2" name="f2">
             <a:extLst xmlns:a="http://schemas.openxmlformats.org/drawingml/2006/main">
               <a:ext uri="{FF2B5EF4-FFF2-40B4-BE49-F238E27FC236}">
-                <a16:creationId xmlns:a16="http://schemas.microsoft.com/office/drawing/2014/main" id="{3C21C327-AC37-4AA7-87BE-8387918D8263}"/>
+                <a16:creationId xmlns:a16="http://schemas.microsoft.com/office/drawing/2014/main" id="{837CA3D0-3017-4BF3-9C41-2DF22EFE7E0F}"/>
               </a:ext>
             </a:extLst>
           </p:cNvPr>
@@ -4274,7 +4274,7 @@
           <p:cNvPr id="3" name="f3">
             <a:extLst xmlns:a="http://schemas.openxmlformats.org/drawingml/2006/main">
               <a:ext uri="{FF2B5EF4-FFF2-40B4-BE49-F238E27FC236}">
-                <a16:creationId xmlns:a16="http://schemas.microsoft.com/office/drawing/2014/main" id="{A3FF57A9-0712-4887-A63B-65B75B65D456}"/>
+                <a16:creationId xmlns:a16="http://schemas.microsoft.com/office/drawing/2014/main" id="{FE0D32E0-812C-4A53-B7FF-8FE000520777}"/>
               </a:ext>
             </a:extLst>
           </p:cNvPr>
@@ -4433,7 +4433,7 @@
           <p:cNvPr id="4" name="f4">
             <a:extLst xmlns:a="http://schemas.openxmlformats.org/drawingml/2006/main">
               <a:ext uri="{FF2B5EF4-FFF2-40B4-BE49-F238E27FC236}">
-                <a16:creationId xmlns:a16="http://schemas.microsoft.com/office/drawing/2014/main" id="{61FE4749-C415-451E-8887-952FB2A98589}"/>
+                <a16:creationId xmlns:a16="http://schemas.microsoft.com/office/drawing/2014/main" id="{375DDE56-A61C-445D-8409-2C37E37EE7D1}"/>
               </a:ext>
             </a:extLst>
           </p:cNvPr>
@@ -4592,7 +4592,7 @@
           <p:cNvPr id="5" name="f5">
             <a:extLst xmlns:a="http://schemas.openxmlformats.org/drawingml/2006/main">
               <a:ext uri="{FF2B5EF4-FFF2-40B4-BE49-F238E27FC236}">
-                <a16:creationId xmlns:a16="http://schemas.microsoft.com/office/drawing/2014/main" id="{2A7D6AC7-C334-4EA3-AA9B-C4BE7B617E23}"/>
+                <a16:creationId xmlns:a16="http://schemas.microsoft.com/office/drawing/2014/main" id="{70C5113F-1649-4C08-8775-269B8A40F09D}"/>
               </a:ext>
             </a:extLst>
           </p:cNvPr>
@@ -4751,7 +4751,7 @@
           <p:cNvPr id="6" name="f6">
             <a:extLst xmlns:a="http://schemas.openxmlformats.org/drawingml/2006/main">
               <a:ext uri="{FF2B5EF4-FFF2-40B4-BE49-F238E27FC236}">
-                <a16:creationId xmlns:a16="http://schemas.microsoft.com/office/drawing/2014/main" id="{85F59F09-2A2C-4607-90F1-561A78635122}"/>
+                <a16:creationId xmlns:a16="http://schemas.microsoft.com/office/drawing/2014/main" id="{517676F4-2F86-4D68-BCCD-F60153802C91}"/>
               </a:ext>
             </a:extLst>
           </p:cNvPr>
@@ -4910,7 +4910,7 @@
           <p:cNvPr id="7" name="f7">
             <a:extLst xmlns:a="http://schemas.openxmlformats.org/drawingml/2006/main">
               <a:ext uri="{FF2B5EF4-FFF2-40B4-BE49-F238E27FC236}">
-                <a16:creationId xmlns:a16="http://schemas.microsoft.com/office/drawing/2014/main" id="{650F8B68-F6FA-4A44-B5D0-95967B072EA4}"/>
+                <a16:creationId xmlns:a16="http://schemas.microsoft.com/office/drawing/2014/main" id="{544FB8D3-0E9F-4D83-8AC7-2B36676BF299}"/>
               </a:ext>
             </a:extLst>
           </p:cNvPr>
@@ -5069,7 +5069,7 @@
           <p:cNvPr id="8" name="f8">
             <a:extLst xmlns:a="http://schemas.openxmlformats.org/drawingml/2006/main">
               <a:ext uri="{FF2B5EF4-FFF2-40B4-BE49-F238E27FC236}">
-                <a16:creationId xmlns:a16="http://schemas.microsoft.com/office/drawing/2014/main" id="{1D360B00-98C3-44FB-959F-7408B4EB5C58}"/>
+                <a16:creationId xmlns:a16="http://schemas.microsoft.com/office/drawing/2014/main" id="{2F9A7DBC-690E-4812-B0FE-8B587A3F0F05}"/>
               </a:ext>
             </a:extLst>
           </p:cNvPr>
@@ -5228,7 +5228,7 @@
           <p:cNvPr id="9" name="f9">
             <a:extLst xmlns:a="http://schemas.openxmlformats.org/drawingml/2006/main">
               <a:ext uri="{FF2B5EF4-FFF2-40B4-BE49-F238E27FC236}">
-                <a16:creationId xmlns:a16="http://schemas.microsoft.com/office/drawing/2014/main" id="{C100A410-579B-44D3-9214-B8DFA4D6B24F}"/>
+                <a16:creationId xmlns:a16="http://schemas.microsoft.com/office/drawing/2014/main" id="{8C4BFF19-E256-4503-838F-E628649EDBF4}"/>
               </a:ext>
             </a:extLst>
           </p:cNvPr>
@@ -5387,7 +5387,7 @@
           <p:cNvPr id="10" name="f10">
             <a:extLst xmlns:a="http://schemas.openxmlformats.org/drawingml/2006/main">
               <a:ext uri="{FF2B5EF4-FFF2-40B4-BE49-F238E27FC236}">
-                <a16:creationId xmlns:a16="http://schemas.microsoft.com/office/drawing/2014/main" id="{9D99E828-72A1-4005-9947-57F07FBBC673}"/>
+                <a16:creationId xmlns:a16="http://schemas.microsoft.com/office/drawing/2014/main" id="{E6E01563-97D9-4F65-8AE6-7A46BB74DB85}"/>
               </a:ext>
             </a:extLst>
           </p:cNvPr>
@@ -5546,7 +5546,7 @@
           <p:cNvPr id="11" name="f11">
             <a:extLst xmlns:a="http://schemas.openxmlformats.org/drawingml/2006/main">
               <a:ext uri="{FF2B5EF4-FFF2-40B4-BE49-F238E27FC236}">
-                <a16:creationId xmlns:a16="http://schemas.microsoft.com/office/drawing/2014/main" id="{8F11941A-4A46-4BB3-9999-8961A746BCEE}"/>
+                <a16:creationId xmlns:a16="http://schemas.microsoft.com/office/drawing/2014/main" id="{5162F518-FDEE-4463-BA2C-F6A46C45927A}"/>
               </a:ext>
             </a:extLst>
           </p:cNvPr>
@@ -5705,7 +5705,7 @@
           <p:cNvPr id="12" name="f12">
             <a:extLst xmlns:a="http://schemas.openxmlformats.org/drawingml/2006/main">
               <a:ext uri="{FF2B5EF4-FFF2-40B4-BE49-F238E27FC236}">
-                <a16:creationId xmlns:a16="http://schemas.microsoft.com/office/drawing/2014/main" id="{81714A75-F66A-468C-950F-0EAE0FB0FB80}"/>
+                <a16:creationId xmlns:a16="http://schemas.microsoft.com/office/drawing/2014/main" id="{77323399-B60F-46C9-AE92-6845D6D418C8}"/>
               </a:ext>
             </a:extLst>
           </p:cNvPr>
@@ -5864,7 +5864,7 @@
           <p:cNvPr id="13" name="f13">
             <a:extLst xmlns:a="http://schemas.openxmlformats.org/drawingml/2006/main">
               <a:ext uri="{FF2B5EF4-FFF2-40B4-BE49-F238E27FC236}">
-                <a16:creationId xmlns:a16="http://schemas.microsoft.com/office/drawing/2014/main" id="{B1935F4A-CED3-4D27-8AD0-B8B6EA1114B2}"/>
+                <a16:creationId xmlns:a16="http://schemas.microsoft.com/office/drawing/2014/main" id="{93D23B5F-170B-40B9-A7A0-89D22951BEF2}"/>
               </a:ext>
             </a:extLst>
           </p:cNvPr>
@@ -6023,7 +6023,7 @@
           <p:cNvPr id="14" name="f14">
             <a:extLst xmlns:a="http://schemas.openxmlformats.org/drawingml/2006/main">
               <a:ext uri="{FF2B5EF4-FFF2-40B4-BE49-F238E27FC236}">
-                <a16:creationId xmlns:a16="http://schemas.microsoft.com/office/drawing/2014/main" id="{2DBFC8DC-F048-4E00-9400-D8E05766C151}"/>
+                <a16:creationId xmlns:a16="http://schemas.microsoft.com/office/drawing/2014/main" id="{2583CB11-DB60-4261-98F5-8DB2D9C58398}"/>
               </a:ext>
             </a:extLst>
           </p:cNvPr>
@@ -6182,7 +6182,7 @@
           <p:cNvPr id="15" name="f15">
             <a:extLst xmlns:a="http://schemas.openxmlformats.org/drawingml/2006/main">
               <a:ext uri="{FF2B5EF4-FFF2-40B4-BE49-F238E27FC236}">
-                <a16:creationId xmlns:a16="http://schemas.microsoft.com/office/drawing/2014/main" id="{348EC166-6C28-4227-9F5F-22EEC7382FDF}"/>
+                <a16:creationId xmlns:a16="http://schemas.microsoft.com/office/drawing/2014/main" id="{AA11CFFD-2458-4E61-979B-8143CD17EE2E}"/>
               </a:ext>
             </a:extLst>
           </p:cNvPr>
@@ -6341,7 +6341,7 @@
           <p:cNvPr id="16" name="f16">
             <a:extLst xmlns:a="http://schemas.openxmlformats.org/drawingml/2006/main">
               <a:ext uri="{FF2B5EF4-FFF2-40B4-BE49-F238E27FC236}">
-                <a16:creationId xmlns:a16="http://schemas.microsoft.com/office/drawing/2014/main" id="{AB9F7DB8-6929-484A-A675-F9DBA27CA41A}"/>
+                <a16:creationId xmlns:a16="http://schemas.microsoft.com/office/drawing/2014/main" id="{A9AE0CBD-5431-4863-A4DC-3A901BF96AE1}"/>
               </a:ext>
             </a:extLst>
           </p:cNvPr>
@@ -6500,7 +6500,7 @@
           <p:cNvPr id="17" name="f17">
             <a:extLst xmlns:a="http://schemas.openxmlformats.org/drawingml/2006/main">
               <a:ext uri="{FF2B5EF4-FFF2-40B4-BE49-F238E27FC236}">
-                <a16:creationId xmlns:a16="http://schemas.microsoft.com/office/drawing/2014/main" id="{4ADE4287-797E-4CC1-8119-EAF1D9F554DA}"/>
+                <a16:creationId xmlns:a16="http://schemas.microsoft.com/office/drawing/2014/main" id="{B2D70A4A-FC99-493E-A11E-FAD49B056407}"/>
               </a:ext>
             </a:extLst>
           </p:cNvPr>
@@ -6659,7 +6659,7 @@
           <p:cNvPr id="18" name="f18">
             <a:extLst xmlns:a="http://schemas.openxmlformats.org/drawingml/2006/main">
               <a:ext uri="{FF2B5EF4-FFF2-40B4-BE49-F238E27FC236}">
-                <a16:creationId xmlns:a16="http://schemas.microsoft.com/office/drawing/2014/main" id="{358D8C0E-DBE4-4CA9-A583-9B0B90112B57}"/>
+                <a16:creationId xmlns:a16="http://schemas.microsoft.com/office/drawing/2014/main" id="{126EB52B-C181-4ACE-8C44-51718BA0DAA7}"/>
               </a:ext>
             </a:extLst>
           </p:cNvPr>
@@ -6818,7 +6818,7 @@
           <p:cNvPr id="19" name="f19">
             <a:extLst xmlns:a="http://schemas.openxmlformats.org/drawingml/2006/main">
               <a:ext uri="{FF2B5EF4-FFF2-40B4-BE49-F238E27FC236}">
-                <a16:creationId xmlns:a16="http://schemas.microsoft.com/office/drawing/2014/main" id="{D1B4F772-B7C7-4566-BAA5-CF08892C991D}"/>
+                <a16:creationId xmlns:a16="http://schemas.microsoft.com/office/drawing/2014/main" id="{168C3727-6796-4423-AC61-04FF336037CB}"/>
               </a:ext>
             </a:extLst>
           </p:cNvPr>
@@ -6977,7 +6977,7 @@
           <p:cNvPr id="20" name="f20">
             <a:extLst xmlns:a="http://schemas.openxmlformats.org/drawingml/2006/main">
               <a:ext uri="{FF2B5EF4-FFF2-40B4-BE49-F238E27FC236}">
-                <a16:creationId xmlns:a16="http://schemas.microsoft.com/office/drawing/2014/main" id="{8FF84202-338C-481C-B1ED-7612A9C2C6A5}"/>
+                <a16:creationId xmlns:a16="http://schemas.microsoft.com/office/drawing/2014/main" id="{8D08D468-6E5A-4D96-AE0A-8BA89B98F8A0}"/>
               </a:ext>
             </a:extLst>
           </p:cNvPr>
@@ -7134,7 +7134,7 @@
     </p:spTree>
     <p:extLst>
       <p:ext uri="{BB962C8B-B14F-4D97-AF65-F5344CB8AC3E}">
-        <p14:creationId xmlns:p14="http://schemas.microsoft.com/office/powerpoint/2010/main" val="1191677107"/>
+        <p14:creationId xmlns:p14="http://schemas.microsoft.com/office/powerpoint/2010/main" val="1744321142"/>
       </p:ext>
     </p:extLst>
   </p:cSld>
@@ -7165,7 +7165,7 @@
           <p:cNvPr id="24" name="f21">
             <a:extLst xmlns:a="http://schemas.openxmlformats.org/drawingml/2006/main">
               <a:ext uri="{FF2B5EF4-FFF2-40B4-BE49-F238E27FC236}">
-                <a16:creationId xmlns:a16="http://schemas.microsoft.com/office/drawing/2014/main" id="{1AB6216C-28FA-4E7A-984A-CFF73174CE14}"/>
+                <a16:creationId xmlns:a16="http://schemas.microsoft.com/office/drawing/2014/main" id="{62570958-586B-49CE-AC66-D9FE9DA67AE3}"/>
               </a:ext>
             </a:extLst>
           </p:cNvPr>
@@ -7324,7 +7324,7 @@
           <p:cNvPr id="2" name="f22">
             <a:extLst xmlns:a="http://schemas.openxmlformats.org/drawingml/2006/main">
               <a:ext uri="{FF2B5EF4-FFF2-40B4-BE49-F238E27FC236}">
-                <a16:creationId xmlns:a16="http://schemas.microsoft.com/office/drawing/2014/main" id="{9AFA3FF2-BD9E-4AF9-ACF8-8256FF4B92FD}"/>
+                <a16:creationId xmlns:a16="http://schemas.microsoft.com/office/drawing/2014/main" id="{2A7D9506-8F4C-41F4-BC01-22FDC6491284}"/>
               </a:ext>
             </a:extLst>
           </p:cNvPr>
@@ -7483,7 +7483,7 @@
           <p:cNvPr id="3" name="f23">
             <a:extLst xmlns:a="http://schemas.openxmlformats.org/drawingml/2006/main">
               <a:ext uri="{FF2B5EF4-FFF2-40B4-BE49-F238E27FC236}">
-                <a16:creationId xmlns:a16="http://schemas.microsoft.com/office/drawing/2014/main" id="{62C36A55-CA70-484D-97B7-55050D74E469}"/>
+                <a16:creationId xmlns:a16="http://schemas.microsoft.com/office/drawing/2014/main" id="{60AB98BD-4B1D-4427-A612-9BECFB6E65D3}"/>
               </a:ext>
             </a:extLst>
           </p:cNvPr>
@@ -7642,7 +7642,7 @@
           <p:cNvPr id="4" name="f24">
             <a:extLst xmlns:a="http://schemas.openxmlformats.org/drawingml/2006/main">
               <a:ext uri="{FF2B5EF4-FFF2-40B4-BE49-F238E27FC236}">
-                <a16:creationId xmlns:a16="http://schemas.microsoft.com/office/drawing/2014/main" id="{474D705C-002E-459A-A278-E84C214AD689}"/>
+                <a16:creationId xmlns:a16="http://schemas.microsoft.com/office/drawing/2014/main" id="{94A914AD-9E9F-4305-9EFD-89A4CD54F67E}"/>
               </a:ext>
             </a:extLst>
           </p:cNvPr>
@@ -7801,7 +7801,7 @@
           <p:cNvPr id="5" name="f25">
             <a:extLst xmlns:a="http://schemas.openxmlformats.org/drawingml/2006/main">
               <a:ext uri="{FF2B5EF4-FFF2-40B4-BE49-F238E27FC236}">
-                <a16:creationId xmlns:a16="http://schemas.microsoft.com/office/drawing/2014/main" id="{F089B7C9-86E6-42B3-A922-68DDE2B6BF56}"/>
+                <a16:creationId xmlns:a16="http://schemas.microsoft.com/office/drawing/2014/main" id="{62EACF9A-C57B-4FDA-B1FE-2EA240401595}"/>
               </a:ext>
             </a:extLst>
           </p:cNvPr>
@@ -7960,7 +7960,7 @@
           <p:cNvPr id="6" name="f26">
             <a:extLst xmlns:a="http://schemas.openxmlformats.org/drawingml/2006/main">
               <a:ext uri="{FF2B5EF4-FFF2-40B4-BE49-F238E27FC236}">
-                <a16:creationId xmlns:a16="http://schemas.microsoft.com/office/drawing/2014/main" id="{E158022F-004A-4F7C-A8C0-0AB554ACE41A}"/>
+                <a16:creationId xmlns:a16="http://schemas.microsoft.com/office/drawing/2014/main" id="{489BFE3A-6297-49CC-9E8B-3CC7D08E4527}"/>
               </a:ext>
             </a:extLst>
           </p:cNvPr>
@@ -8119,7 +8119,7 @@
           <p:cNvPr id="7" name="f27">
             <a:extLst xmlns:a="http://schemas.openxmlformats.org/drawingml/2006/main">
               <a:ext uri="{FF2B5EF4-FFF2-40B4-BE49-F238E27FC236}">
-                <a16:creationId xmlns:a16="http://schemas.microsoft.com/office/drawing/2014/main" id="{17C7A4AC-9C82-4017-8C31-9BB8714675CC}"/>
+                <a16:creationId xmlns:a16="http://schemas.microsoft.com/office/drawing/2014/main" id="{4574B24D-E1BC-4077-99C0-0CA5F409F155}"/>
               </a:ext>
             </a:extLst>
           </p:cNvPr>
@@ -8154,7 +8154,7 @@
           <p:cNvPr id="8" name="f28">
             <a:extLst xmlns:a="http://schemas.openxmlformats.org/drawingml/2006/main">
               <a:ext uri="{FF2B5EF4-FFF2-40B4-BE49-F238E27FC236}">
-                <a16:creationId xmlns:a16="http://schemas.microsoft.com/office/drawing/2014/main" id="{41857395-0270-440D-B6F0-37EEB9824680}"/>
+                <a16:creationId xmlns:a16="http://schemas.microsoft.com/office/drawing/2014/main" id="{F7F46016-5E75-49CB-B3FE-6BC6B8C491DC}"/>
               </a:ext>
             </a:extLst>
           </p:cNvPr>
@@ -8185,7 +8185,7 @@
           <p:cNvPr id="9" name="f29">
             <a:extLst xmlns:a="http://schemas.openxmlformats.org/drawingml/2006/main">
               <a:ext uri="{FF2B5EF4-FFF2-40B4-BE49-F238E27FC236}">
-                <a16:creationId xmlns:a16="http://schemas.microsoft.com/office/drawing/2014/main" id="{FC0A7FD7-32DE-4E18-8019-C46D74013154}"/>
+                <a16:creationId xmlns:a16="http://schemas.microsoft.com/office/drawing/2014/main" id="{8B4F4516-2375-42FB-8045-089EB4CE7899}"/>
               </a:ext>
             </a:extLst>
           </p:cNvPr>
@@ -8216,7 +8216,7 @@
           <p:cNvPr id="10" name="f30">
             <a:extLst xmlns:a="http://schemas.openxmlformats.org/drawingml/2006/main">
               <a:ext uri="{FF2B5EF4-FFF2-40B4-BE49-F238E27FC236}">
-                <a16:creationId xmlns:a16="http://schemas.microsoft.com/office/drawing/2014/main" id="{D884B14E-59B4-4A80-ABF6-79D38571572E}"/>
+                <a16:creationId xmlns:a16="http://schemas.microsoft.com/office/drawing/2014/main" id="{08A53876-B2CA-42AB-A77D-8B4FDDB37115}"/>
               </a:ext>
             </a:extLst>
           </p:cNvPr>
@@ -8247,7 +8247,7 @@
           <p:cNvPr id="11" name="f31">
             <a:extLst xmlns:a="http://schemas.openxmlformats.org/drawingml/2006/main">
               <a:ext uri="{FF2B5EF4-FFF2-40B4-BE49-F238E27FC236}">
-                <a16:creationId xmlns:a16="http://schemas.microsoft.com/office/drawing/2014/main" id="{B1B120A2-D9E1-42BA-B7C5-5890FEBBE31D}"/>
+                <a16:creationId xmlns:a16="http://schemas.microsoft.com/office/drawing/2014/main" id="{D68EFDFF-8C6C-4230-BFCF-73F0D42E1345}"/>
               </a:ext>
             </a:extLst>
           </p:cNvPr>
@@ -8282,7 +8282,7 @@
           <p:cNvPr id="12" name="f32">
             <a:extLst xmlns:a="http://schemas.openxmlformats.org/drawingml/2006/main">
               <a:ext uri="{FF2B5EF4-FFF2-40B4-BE49-F238E27FC236}">
-                <a16:creationId xmlns:a16="http://schemas.microsoft.com/office/drawing/2014/main" id="{BFB1AF1F-8CB7-4D7F-9850-69DF8F113AAA}"/>
+                <a16:creationId xmlns:a16="http://schemas.microsoft.com/office/drawing/2014/main" id="{391A96F9-D2DD-400F-8F23-75AD2B92F673}"/>
               </a:ext>
             </a:extLst>
           </p:cNvPr>
@@ -8313,7 +8313,7 @@
           <p:cNvPr id="13" name="f33">
             <a:extLst xmlns:a="http://schemas.openxmlformats.org/drawingml/2006/main">
               <a:ext uri="{FF2B5EF4-FFF2-40B4-BE49-F238E27FC236}">
-                <a16:creationId xmlns:a16="http://schemas.microsoft.com/office/drawing/2014/main" id="{DCD07A90-FB44-47E6-BC80-D9F7FDC9705B}"/>
+                <a16:creationId xmlns:a16="http://schemas.microsoft.com/office/drawing/2014/main" id="{EDE5CA66-8256-424F-8DAC-05E8460DFE61}"/>
               </a:ext>
             </a:extLst>
           </p:cNvPr>
@@ -8346,7 +8346,7 @@
           <p:cNvPr id="14" name="f34">
             <a:extLst xmlns:a="http://schemas.openxmlformats.org/drawingml/2006/main">
               <a:ext uri="{FF2B5EF4-FFF2-40B4-BE49-F238E27FC236}">
-                <a16:creationId xmlns:a16="http://schemas.microsoft.com/office/drawing/2014/main" id="{7ACF7EF1-C3C0-4849-8A07-6F5F178DF8BA}"/>
+                <a16:creationId xmlns:a16="http://schemas.microsoft.com/office/drawing/2014/main" id="{52632440-2C33-44D7-B92E-5942F7A10A17}"/>
               </a:ext>
             </a:extLst>
           </p:cNvPr>
@@ -8379,7 +8379,7 @@
           <p:cNvPr id="15" name="f35">
             <a:extLst xmlns:a="http://schemas.openxmlformats.org/drawingml/2006/main">
               <a:ext uri="{FF2B5EF4-FFF2-40B4-BE49-F238E27FC236}">
-                <a16:creationId xmlns:a16="http://schemas.microsoft.com/office/drawing/2014/main" id="{90BDD31A-A9D3-4850-8EA7-D847FAB689A2}"/>
+                <a16:creationId xmlns:a16="http://schemas.microsoft.com/office/drawing/2014/main" id="{6C7DB64C-35A5-4704-AD66-E540BDC4675D}"/>
               </a:ext>
             </a:extLst>
           </p:cNvPr>
@@ -8412,7 +8412,7 @@
           <p:cNvPr id="16" name="f36">
             <a:extLst xmlns:a="http://schemas.openxmlformats.org/drawingml/2006/main">
               <a:ext uri="{FF2B5EF4-FFF2-40B4-BE49-F238E27FC236}">
-                <a16:creationId xmlns:a16="http://schemas.microsoft.com/office/drawing/2014/main" id="{DF170553-71FB-4851-85A4-CD3F6CA46ED2}"/>
+                <a16:creationId xmlns:a16="http://schemas.microsoft.com/office/drawing/2014/main" id="{9F414B2A-5A93-45E2-AE5A-45B2F94E4B6F}"/>
               </a:ext>
             </a:extLst>
           </p:cNvPr>
@@ -8571,7 +8571,7 @@
           <p:cNvPr id="17" name="f37">
             <a:extLst xmlns:a="http://schemas.openxmlformats.org/drawingml/2006/main">
               <a:ext uri="{FF2B5EF4-FFF2-40B4-BE49-F238E27FC236}">
-                <a16:creationId xmlns:a16="http://schemas.microsoft.com/office/drawing/2014/main" id="{1DA986C4-EAD9-4306-B39F-B442206B2E0C}"/>
+                <a16:creationId xmlns:a16="http://schemas.microsoft.com/office/drawing/2014/main" id="{1C52070E-AF6A-4F18-907C-CA4C7B98AE99}"/>
               </a:ext>
             </a:extLst>
           </p:cNvPr>
@@ -8602,7 +8602,7 @@
           <p:cNvPr id="18" name="f38">
             <a:extLst xmlns:a="http://schemas.openxmlformats.org/drawingml/2006/main">
               <a:ext uri="{FF2B5EF4-FFF2-40B4-BE49-F238E27FC236}">
-                <a16:creationId xmlns:a16="http://schemas.microsoft.com/office/drawing/2014/main" id="{701DA3C4-0EDC-4258-9931-FF1FEA14595A}"/>
+                <a16:creationId xmlns:a16="http://schemas.microsoft.com/office/drawing/2014/main" id="{FDC89246-E971-4A38-9609-50FF2DFA7C89}"/>
               </a:ext>
             </a:extLst>
           </p:cNvPr>
@@ -8633,7 +8633,7 @@
           <p:cNvPr id="19" name="f39">
             <a:extLst xmlns:a="http://schemas.openxmlformats.org/drawingml/2006/main">
               <a:ext uri="{FF2B5EF4-FFF2-40B4-BE49-F238E27FC236}">
-                <a16:creationId xmlns:a16="http://schemas.microsoft.com/office/drawing/2014/main" id="{C015EDBB-1620-4BE2-94CA-218D0FF4C2E8}"/>
+                <a16:creationId xmlns:a16="http://schemas.microsoft.com/office/drawing/2014/main" id="{9270F574-5A2B-4DA2-8830-50A61AC612AB}"/>
               </a:ext>
             </a:extLst>
           </p:cNvPr>
@@ -8668,7 +8668,7 @@
           <p:cNvPr id="20" name="f40">
             <a:extLst xmlns:a="http://schemas.openxmlformats.org/drawingml/2006/main">
               <a:ext uri="{FF2B5EF4-FFF2-40B4-BE49-F238E27FC236}">
-                <a16:creationId xmlns:a16="http://schemas.microsoft.com/office/drawing/2014/main" id="{A1ECAC0C-2C51-4601-8A04-AA21F194E628}"/>
+                <a16:creationId xmlns:a16="http://schemas.microsoft.com/office/drawing/2014/main" id="{C56D62E3-6A8C-402F-A76A-73AC4B05F679}"/>
               </a:ext>
             </a:extLst>
           </p:cNvPr>
@@ -8850,7 +8850,7 @@
           <p:cNvPr id="21" name="f41">
             <a:extLst xmlns:a="http://schemas.openxmlformats.org/drawingml/2006/main">
               <a:ext uri="{FF2B5EF4-FFF2-40B4-BE49-F238E27FC236}">
-                <a16:creationId xmlns:a16="http://schemas.microsoft.com/office/drawing/2014/main" id="{3BB70FEF-3608-4CA8-ADB9-99D4850976C4}"/>
+                <a16:creationId xmlns:a16="http://schemas.microsoft.com/office/drawing/2014/main" id="{8F8801BB-EC7E-4E4E-954E-CF96CD0AACF7}"/>
               </a:ext>
             </a:extLst>
           </p:cNvPr>
@@ -9032,7 +9032,7 @@
           <p:cNvPr id="22" name="f42">
             <a:extLst xmlns:a="http://schemas.openxmlformats.org/drawingml/2006/main">
               <a:ext uri="{FF2B5EF4-FFF2-40B4-BE49-F238E27FC236}">
-                <a16:creationId xmlns:a16="http://schemas.microsoft.com/office/drawing/2014/main" id="{FDE7C723-C294-443E-B145-16DD8BF0AD9B}"/>
+                <a16:creationId xmlns:a16="http://schemas.microsoft.com/office/drawing/2014/main" id="{C93B46A9-9CFB-497B-A138-15387DF619E2}"/>
               </a:ext>
             </a:extLst>
           </p:cNvPr>
@@ -9191,7 +9191,7 @@
           <p:cNvPr id="23" name="f43">
             <a:extLst xmlns:a="http://schemas.openxmlformats.org/drawingml/2006/main">
               <a:ext uri="{FF2B5EF4-FFF2-40B4-BE49-F238E27FC236}">
-                <a16:creationId xmlns:a16="http://schemas.microsoft.com/office/drawing/2014/main" id="{EA947CB2-E3D1-4556-8D17-1C3ED6FC9BA2}"/>
+                <a16:creationId xmlns:a16="http://schemas.microsoft.com/office/drawing/2014/main" id="{32A52FA9-65B0-425E-A8BF-C5EB7A81A32B}"/>
               </a:ext>
             </a:extLst>
           </p:cNvPr>
@@ -9348,7 +9348,7 @@
     </p:spTree>
     <p:extLst>
       <p:ext uri="{BB962C8B-B14F-4D97-AF65-F5344CB8AC3E}">
-        <p14:creationId xmlns:p14="http://schemas.microsoft.com/office/powerpoint/2010/main" val="2009226885"/>
+        <p14:creationId xmlns:p14="http://schemas.microsoft.com/office/powerpoint/2010/main" val="2063352064"/>
       </p:ext>
     </p:extLst>
   </p:cSld>
@@ -9379,7 +9379,7 @@
           <p:cNvPr id="24" name="">
             <a:extLst xmlns:a="http://schemas.openxmlformats.org/drawingml/2006/main">
               <a:ext uri="{FF2B5EF4-FFF2-40B4-BE49-F238E27FC236}">
-                <a16:creationId xmlns:a16="http://schemas.microsoft.com/office/drawing/2014/main" id="{6575E8C3-F827-42BD-9AF3-4EFCCF4C638B}"/>
+                <a16:creationId xmlns:a16="http://schemas.microsoft.com/office/drawing/2014/main" id="{2C4DB6D7-DE71-4861-92DB-CF6A79693E7E}"/>
               </a:ext>
             </a:extLst>
           </p:cNvPr>
@@ -9389,7 +9389,7 @@
           <p:nvPr/>
         </p:nvPicPr>
         <p:blipFill>
-          <a:blip xmlns:r="http://schemas.openxmlformats.org/officeDocument/2006/relationships" xmlns:a="http://schemas.openxmlformats.org/drawingml/2006/main" r:embed="R1c5b56750ab84a99"/>
+          <a:blip xmlns:r="http://schemas.openxmlformats.org/officeDocument/2006/relationships" xmlns:a="http://schemas.openxmlformats.org/drawingml/2006/main" r:embed="Ra8e0551fe56e43f0"/>
           <a:stretch xmlns:a="http://schemas.openxmlformats.org/drawingml/2006/main"/>
         </p:blipFill>
         <p:spPr>
@@ -9407,7 +9407,7 @@
           <p:cNvPr id="2" name="f45">
             <a:extLst xmlns:a="http://schemas.openxmlformats.org/drawingml/2006/main">
               <a:ext uri="{FF2B5EF4-FFF2-40B4-BE49-F238E27FC236}">
-                <a16:creationId xmlns:a16="http://schemas.microsoft.com/office/drawing/2014/main" id="{5BF5DF33-B77E-4362-86BA-6FA2A809B878}"/>
+                <a16:creationId xmlns:a16="http://schemas.microsoft.com/office/drawing/2014/main" id="{7DEE054C-D21A-4FD2-A63B-0D1339E0F1C7}"/>
               </a:ext>
             </a:extLst>
           </p:cNvPr>
@@ -9566,7 +9566,7 @@
           <p:cNvPr id="3" name="f46">
             <a:extLst xmlns:a="http://schemas.openxmlformats.org/drawingml/2006/main">
               <a:ext uri="{FF2B5EF4-FFF2-40B4-BE49-F238E27FC236}">
-                <a16:creationId xmlns:a16="http://schemas.microsoft.com/office/drawing/2014/main" id="{042CC9DE-D276-4B9B-A813-5B876025D808}"/>
+                <a16:creationId xmlns:a16="http://schemas.microsoft.com/office/drawing/2014/main" id="{9EA49102-D1D6-46A5-A87E-20637AACB8AA}"/>
               </a:ext>
             </a:extLst>
           </p:cNvPr>
@@ -9725,7 +9725,7 @@
           <p:cNvPr id="4" name="f47">
             <a:extLst xmlns:a="http://schemas.openxmlformats.org/drawingml/2006/main">
               <a:ext uri="{FF2B5EF4-FFF2-40B4-BE49-F238E27FC236}">
-                <a16:creationId xmlns:a16="http://schemas.microsoft.com/office/drawing/2014/main" id="{E302F1CC-9EE0-49BC-8740-530EBF635279}"/>
+                <a16:creationId xmlns:a16="http://schemas.microsoft.com/office/drawing/2014/main" id="{7B484570-69BD-4257-A7CD-0C4C05B66B93}"/>
               </a:ext>
             </a:extLst>
           </p:cNvPr>
@@ -9884,7 +9884,7 @@
           <p:cNvPr id="5" name="f48">
             <a:extLst xmlns:a="http://schemas.openxmlformats.org/drawingml/2006/main">
               <a:ext uri="{FF2B5EF4-FFF2-40B4-BE49-F238E27FC236}">
-                <a16:creationId xmlns:a16="http://schemas.microsoft.com/office/drawing/2014/main" id="{8EE7EBDA-FDF5-4271-BCB0-FA7E57C3ACA7}"/>
+                <a16:creationId xmlns:a16="http://schemas.microsoft.com/office/drawing/2014/main" id="{D322E0FB-73B9-4A7D-9EA4-3029204AE5A8}"/>
               </a:ext>
             </a:extLst>
           </p:cNvPr>
@@ -10043,7 +10043,7 @@
           <p:cNvPr id="6" name="f49">
             <a:extLst xmlns:a="http://schemas.openxmlformats.org/drawingml/2006/main">
               <a:ext uri="{FF2B5EF4-FFF2-40B4-BE49-F238E27FC236}">
-                <a16:creationId xmlns:a16="http://schemas.microsoft.com/office/drawing/2014/main" id="{B54ED89F-0A29-44C2-A544-66E282AD59CA}"/>
+                <a16:creationId xmlns:a16="http://schemas.microsoft.com/office/drawing/2014/main" id="{F03F0AC6-51F3-4BE9-8C8D-839816C438CE}"/>
               </a:ext>
             </a:extLst>
           </p:cNvPr>
@@ -10202,7 +10202,7 @@
           <p:cNvPr id="7" name="f50">
             <a:extLst xmlns:a="http://schemas.openxmlformats.org/drawingml/2006/main">
               <a:ext uri="{FF2B5EF4-FFF2-40B4-BE49-F238E27FC236}">
-                <a16:creationId xmlns:a16="http://schemas.microsoft.com/office/drawing/2014/main" id="{BDBDD52A-1A19-4054-A46E-740C2364662B}"/>
+                <a16:creationId xmlns:a16="http://schemas.microsoft.com/office/drawing/2014/main" id="{948C47F3-A0D7-44B2-B7AD-C25786BC16F1}"/>
               </a:ext>
             </a:extLst>
           </p:cNvPr>
@@ -10361,7 +10361,7 @@
           <p:cNvPr id="8" name="f51">
             <a:extLst xmlns:a="http://schemas.openxmlformats.org/drawingml/2006/main">
               <a:ext uri="{FF2B5EF4-FFF2-40B4-BE49-F238E27FC236}">
-                <a16:creationId xmlns:a16="http://schemas.microsoft.com/office/drawing/2014/main" id="{D0DF10A9-C446-4446-A9D8-3ABDC204CD09}"/>
+                <a16:creationId xmlns:a16="http://schemas.microsoft.com/office/drawing/2014/main" id="{283AA079-1097-4BB9-8B45-C5A6F637E035}"/>
               </a:ext>
             </a:extLst>
           </p:cNvPr>
@@ -10520,7 +10520,7 @@
           <p:cNvPr id="9" name="f52">
             <a:extLst xmlns:a="http://schemas.openxmlformats.org/drawingml/2006/main">
               <a:ext uri="{FF2B5EF4-FFF2-40B4-BE49-F238E27FC236}">
-                <a16:creationId xmlns:a16="http://schemas.microsoft.com/office/drawing/2014/main" id="{5FE5354D-67B3-4AF9-B3A4-8EE2D2A9806E}"/>
+                <a16:creationId xmlns:a16="http://schemas.microsoft.com/office/drawing/2014/main" id="{351A331E-C140-4EBA-8C0E-360F1B571F9A}"/>
               </a:ext>
             </a:extLst>
           </p:cNvPr>
@@ -10679,7 +10679,7 @@
           <p:cNvPr id="10" name="f53">
             <a:extLst xmlns:a="http://schemas.openxmlformats.org/drawingml/2006/main">
               <a:ext uri="{FF2B5EF4-FFF2-40B4-BE49-F238E27FC236}">
-                <a16:creationId xmlns:a16="http://schemas.microsoft.com/office/drawing/2014/main" id="{F76867B3-619B-441F-B843-6DB037905D96}"/>
+                <a16:creationId xmlns:a16="http://schemas.microsoft.com/office/drawing/2014/main" id="{F6D09079-909B-456D-8814-5EF2F8F1E1F3}"/>
               </a:ext>
             </a:extLst>
           </p:cNvPr>
@@ -10838,7 +10838,7 @@
           <p:cNvPr id="11" name="f54">
             <a:extLst xmlns:a="http://schemas.openxmlformats.org/drawingml/2006/main">
               <a:ext uri="{FF2B5EF4-FFF2-40B4-BE49-F238E27FC236}">
-                <a16:creationId xmlns:a16="http://schemas.microsoft.com/office/drawing/2014/main" id="{E1D5F7EF-E10C-4785-993F-38DE3974BFF6}"/>
+                <a16:creationId xmlns:a16="http://schemas.microsoft.com/office/drawing/2014/main" id="{92D3FCBE-06F2-4C5D-A530-A42E0504F0A5}"/>
               </a:ext>
             </a:extLst>
           </p:cNvPr>
@@ -10997,7 +10997,7 @@
           <p:cNvPr id="12" name="f55">
             <a:extLst xmlns:a="http://schemas.openxmlformats.org/drawingml/2006/main">
               <a:ext uri="{FF2B5EF4-FFF2-40B4-BE49-F238E27FC236}">
-                <a16:creationId xmlns:a16="http://schemas.microsoft.com/office/drawing/2014/main" id="{B70BBEA1-3F11-483D-BC43-E6D8A9CF9535}"/>
+                <a16:creationId xmlns:a16="http://schemas.microsoft.com/office/drawing/2014/main" id="{AA86459E-F1A0-427E-916C-A3B4298A018A}"/>
               </a:ext>
             </a:extLst>
           </p:cNvPr>
@@ -11156,7 +11156,7 @@
           <p:cNvPr id="13" name="f56">
             <a:extLst xmlns:a="http://schemas.openxmlformats.org/drawingml/2006/main">
               <a:ext uri="{FF2B5EF4-FFF2-40B4-BE49-F238E27FC236}">
-                <a16:creationId xmlns:a16="http://schemas.microsoft.com/office/drawing/2014/main" id="{88A31A96-D4A5-4949-AEA8-7A1019DD4884}"/>
+                <a16:creationId xmlns:a16="http://schemas.microsoft.com/office/drawing/2014/main" id="{C5FCB904-A75F-485A-B59C-5BAD3A850B85}"/>
               </a:ext>
             </a:extLst>
           </p:cNvPr>
@@ -11315,7 +11315,7 @@
           <p:cNvPr id="14" name="f57">
             <a:extLst xmlns:a="http://schemas.openxmlformats.org/drawingml/2006/main">
               <a:ext uri="{FF2B5EF4-FFF2-40B4-BE49-F238E27FC236}">
-                <a16:creationId xmlns:a16="http://schemas.microsoft.com/office/drawing/2014/main" id="{D90071E9-6D1A-4EFF-BA69-6619C3D3435C}"/>
+                <a16:creationId xmlns:a16="http://schemas.microsoft.com/office/drawing/2014/main" id="{BE5AF7C9-3C5D-42D0-86C7-4E0BF2098B43}"/>
               </a:ext>
             </a:extLst>
           </p:cNvPr>
@@ -11474,7 +11474,7 @@
           <p:cNvPr id="15" name="f58">
             <a:extLst xmlns:a="http://schemas.openxmlformats.org/drawingml/2006/main">
               <a:ext uri="{FF2B5EF4-FFF2-40B4-BE49-F238E27FC236}">
-                <a16:creationId xmlns:a16="http://schemas.microsoft.com/office/drawing/2014/main" id="{38229594-7FE9-4491-88CB-8EE8D6560FBF}"/>
+                <a16:creationId xmlns:a16="http://schemas.microsoft.com/office/drawing/2014/main" id="{ED5CB014-FFAF-47A6-BAA4-FB9689BEAF34}"/>
               </a:ext>
             </a:extLst>
           </p:cNvPr>
@@ -11633,7 +11633,7 @@
           <p:cNvPr id="16" name="f59">
             <a:extLst xmlns:a="http://schemas.openxmlformats.org/drawingml/2006/main">
               <a:ext uri="{FF2B5EF4-FFF2-40B4-BE49-F238E27FC236}">
-                <a16:creationId xmlns:a16="http://schemas.microsoft.com/office/drawing/2014/main" id="{8939E8B2-195F-4238-9FA9-0D33D2DC9591}"/>
+                <a16:creationId xmlns:a16="http://schemas.microsoft.com/office/drawing/2014/main" id="{CFE5807F-3820-40EE-BFFE-700390D954C2}"/>
               </a:ext>
             </a:extLst>
           </p:cNvPr>
@@ -11792,7 +11792,7 @@
           <p:cNvPr id="17" name="f60">
             <a:extLst xmlns:a="http://schemas.openxmlformats.org/drawingml/2006/main">
               <a:ext uri="{FF2B5EF4-FFF2-40B4-BE49-F238E27FC236}">
-                <a16:creationId xmlns:a16="http://schemas.microsoft.com/office/drawing/2014/main" id="{2E2B0D6F-D77C-4834-9213-4AF0E5D29B70}"/>
+                <a16:creationId xmlns:a16="http://schemas.microsoft.com/office/drawing/2014/main" id="{4E8953DA-2692-4957-AD4D-DD2C7195109E}"/>
               </a:ext>
             </a:extLst>
           </p:cNvPr>
@@ -11951,7 +11951,7 @@
           <p:cNvPr id="18" name="f61">
             <a:extLst xmlns:a="http://schemas.openxmlformats.org/drawingml/2006/main">
               <a:ext uri="{FF2B5EF4-FFF2-40B4-BE49-F238E27FC236}">
-                <a16:creationId xmlns:a16="http://schemas.microsoft.com/office/drawing/2014/main" id="{CDFE7841-EFD6-4D5F-AAF7-A8755A3F31B8}"/>
+                <a16:creationId xmlns:a16="http://schemas.microsoft.com/office/drawing/2014/main" id="{34C61DA7-FDE8-4D55-885F-065894E3E90D}"/>
               </a:ext>
             </a:extLst>
           </p:cNvPr>
@@ -12110,7 +12110,7 @@
           <p:cNvPr id="19" name="f62">
             <a:extLst xmlns:a="http://schemas.openxmlformats.org/drawingml/2006/main">
               <a:ext uri="{FF2B5EF4-FFF2-40B4-BE49-F238E27FC236}">
-                <a16:creationId xmlns:a16="http://schemas.microsoft.com/office/drawing/2014/main" id="{28B9F215-C209-48FF-8A93-5430A96F3044}"/>
+                <a16:creationId xmlns:a16="http://schemas.microsoft.com/office/drawing/2014/main" id="{B010F025-ACC8-4FAD-8D19-A9D246E61B38}"/>
               </a:ext>
             </a:extLst>
           </p:cNvPr>
@@ -12269,7 +12269,7 @@
           <p:cNvPr id="20" name="f63">
             <a:extLst xmlns:a="http://schemas.openxmlformats.org/drawingml/2006/main">
               <a:ext uri="{FF2B5EF4-FFF2-40B4-BE49-F238E27FC236}">
-                <a16:creationId xmlns:a16="http://schemas.microsoft.com/office/drawing/2014/main" id="{68975CAD-D220-468A-A662-EEF0FFB639EB}"/>
+                <a16:creationId xmlns:a16="http://schemas.microsoft.com/office/drawing/2014/main" id="{1501B4AD-D129-4162-A247-1D34F7DD4B78}"/>
               </a:ext>
             </a:extLst>
           </p:cNvPr>
@@ -12428,7 +12428,7 @@
           <p:cNvPr id="21" name="f64">
             <a:extLst xmlns:a="http://schemas.openxmlformats.org/drawingml/2006/main">
               <a:ext uri="{FF2B5EF4-FFF2-40B4-BE49-F238E27FC236}">
-                <a16:creationId xmlns:a16="http://schemas.microsoft.com/office/drawing/2014/main" id="{CFE67A19-1C49-446D-BE30-B7F73043B38D}"/>
+                <a16:creationId xmlns:a16="http://schemas.microsoft.com/office/drawing/2014/main" id="{CE87DE8C-57A5-4563-BF5F-636730F66967}"/>
               </a:ext>
             </a:extLst>
           </p:cNvPr>
@@ -12587,7 +12587,7 @@
           <p:cNvPr id="22" name="f65">
             <a:extLst xmlns:a="http://schemas.openxmlformats.org/drawingml/2006/main">
               <a:ext uri="{FF2B5EF4-FFF2-40B4-BE49-F238E27FC236}">
-                <a16:creationId xmlns:a16="http://schemas.microsoft.com/office/drawing/2014/main" id="{07C14415-BFD7-4AD4-8259-5E18D99108DE}"/>
+                <a16:creationId xmlns:a16="http://schemas.microsoft.com/office/drawing/2014/main" id="{0964302F-17F8-4C62-ACC5-DE6AE8AA15C2}"/>
               </a:ext>
             </a:extLst>
           </p:cNvPr>
@@ -12746,7 +12746,7 @@
           <p:cNvPr id="23" name="f66">
             <a:extLst xmlns:a="http://schemas.openxmlformats.org/drawingml/2006/main">
               <a:ext uri="{FF2B5EF4-FFF2-40B4-BE49-F238E27FC236}">
-                <a16:creationId xmlns:a16="http://schemas.microsoft.com/office/drawing/2014/main" id="{52A53392-95B8-4AD9-9EBA-D913798077AA}"/>
+                <a16:creationId xmlns:a16="http://schemas.microsoft.com/office/drawing/2014/main" id="{ED4880FF-DE58-4CB4-810D-39534E790385}"/>
               </a:ext>
             </a:extLst>
           </p:cNvPr>
@@ -12903,7 +12903,7 @@
     </p:spTree>
     <p:extLst>
       <p:ext uri="{BB962C8B-B14F-4D97-AF65-F5344CB8AC3E}">
-        <p14:creationId xmlns:p14="http://schemas.microsoft.com/office/powerpoint/2010/main" val="961672210"/>
+        <p14:creationId xmlns:p14="http://schemas.microsoft.com/office/powerpoint/2010/main" val="113186871"/>
       </p:ext>
     </p:extLst>
   </p:cSld>
@@ -12934,7 +12934,7 @@
           <p:cNvPr id="18" name="f67">
             <a:extLst xmlns:a="http://schemas.openxmlformats.org/drawingml/2006/main">
               <a:ext uri="{FF2B5EF4-FFF2-40B4-BE49-F238E27FC236}">
-                <a16:creationId xmlns:a16="http://schemas.microsoft.com/office/drawing/2014/main" id="{CD8ADEA6-C6DC-466D-9C9A-0DD64672CC7E}"/>
+                <a16:creationId xmlns:a16="http://schemas.microsoft.com/office/drawing/2014/main" id="{F682ED86-53DF-462C-A6F2-B840415A254C}"/>
               </a:ext>
             </a:extLst>
           </p:cNvPr>
@@ -13093,7 +13093,7 @@
           <p:cNvPr id="2" name="f68">
             <a:extLst xmlns:a="http://schemas.openxmlformats.org/drawingml/2006/main">
               <a:ext uri="{FF2B5EF4-FFF2-40B4-BE49-F238E27FC236}">
-                <a16:creationId xmlns:a16="http://schemas.microsoft.com/office/drawing/2014/main" id="{88292557-59F0-4876-8DED-7ECF9E588D75}"/>
+                <a16:creationId xmlns:a16="http://schemas.microsoft.com/office/drawing/2014/main" id="{5ACD5B2C-2D32-46A0-87F5-B9A539BE66F5}"/>
               </a:ext>
             </a:extLst>
           </p:cNvPr>
@@ -13252,7 +13252,7 @@
           <p:cNvPr id="3" name="f69">
             <a:extLst xmlns:a="http://schemas.openxmlformats.org/drawingml/2006/main">
               <a:ext uri="{FF2B5EF4-FFF2-40B4-BE49-F238E27FC236}">
-                <a16:creationId xmlns:a16="http://schemas.microsoft.com/office/drawing/2014/main" id="{C1F23252-DF3C-41AB-BADE-50722D233A12}"/>
+                <a16:creationId xmlns:a16="http://schemas.microsoft.com/office/drawing/2014/main" id="{5B3B3CD2-8E00-4162-8223-0A55D9B84BB6}"/>
               </a:ext>
             </a:extLst>
           </p:cNvPr>
@@ -13411,7 +13411,7 @@
           <p:cNvPr id="4" name="f70">
             <a:extLst xmlns:a="http://schemas.openxmlformats.org/drawingml/2006/main">
               <a:ext uri="{FF2B5EF4-FFF2-40B4-BE49-F238E27FC236}">
-                <a16:creationId xmlns:a16="http://schemas.microsoft.com/office/drawing/2014/main" id="{95371814-766C-4314-8AEA-0591DC90299B}"/>
+                <a16:creationId xmlns:a16="http://schemas.microsoft.com/office/drawing/2014/main" id="{ABD488C5-CC21-4672-BC43-74A52DCBFE5D}"/>
               </a:ext>
             </a:extLst>
           </p:cNvPr>
@@ -13570,7 +13570,7 @@
           <p:cNvPr id="5" name="f103">
             <a:extLst xmlns:a="http://schemas.openxmlformats.org/drawingml/2006/main">
               <a:ext uri="{FF2B5EF4-FFF2-40B4-BE49-F238E27FC236}">
-                <a16:creationId xmlns:a16="http://schemas.microsoft.com/office/drawing/2014/main" id="{5C61F781-8D08-4696-84CA-D1F3CB326F94}"/>
+                <a16:creationId xmlns:a16="http://schemas.microsoft.com/office/drawing/2014/main" id="{45A07D68-1995-4512-B38F-CAF620DF0480}"/>
               </a:ext>
             </a:extLst>
           </p:cNvPr>
@@ -13729,7 +13729,7 @@
           <p:cNvPr id="6" name="f104">
             <a:extLst xmlns:a="http://schemas.openxmlformats.org/drawingml/2006/main">
               <a:ext uri="{FF2B5EF4-FFF2-40B4-BE49-F238E27FC236}">
-                <a16:creationId xmlns:a16="http://schemas.microsoft.com/office/drawing/2014/main" id="{E154A881-E84E-4DED-9B09-945E1446E442}"/>
+                <a16:creationId xmlns:a16="http://schemas.microsoft.com/office/drawing/2014/main" id="{EF3C2E2F-E596-4E59-8CEB-72162625B8D2}"/>
               </a:ext>
             </a:extLst>
           </p:cNvPr>
@@ -13764,7 +13764,7 @@
           <p:cNvPr id="7" name="f105">
             <a:extLst xmlns:a="http://schemas.openxmlformats.org/drawingml/2006/main">
               <a:ext uri="{FF2B5EF4-FFF2-40B4-BE49-F238E27FC236}">
-                <a16:creationId xmlns:a16="http://schemas.microsoft.com/office/drawing/2014/main" id="{B05EBB37-7116-4CCD-A24B-FEB69F0E6703}"/>
+                <a16:creationId xmlns:a16="http://schemas.microsoft.com/office/drawing/2014/main" id="{5D46CAC1-2FBA-4C4A-9666-E773AB73F963}"/>
               </a:ext>
             </a:extLst>
           </p:cNvPr>
@@ -13923,7 +13923,7 @@
           <p:cNvPr id="8" name="f106">
             <a:extLst xmlns:a="http://schemas.openxmlformats.org/drawingml/2006/main">
               <a:ext uri="{FF2B5EF4-FFF2-40B4-BE49-F238E27FC236}">
-                <a16:creationId xmlns:a16="http://schemas.microsoft.com/office/drawing/2014/main" id="{B57B014C-07C6-4417-AC08-F68FC531D123}"/>
+                <a16:creationId xmlns:a16="http://schemas.microsoft.com/office/drawing/2014/main" id="{FDE863F6-60E0-42C9-B156-ED29985B84DA}"/>
               </a:ext>
             </a:extLst>
           </p:cNvPr>
@@ -14105,7 +14105,7 @@
           <p:cNvPr id="9" name="f107">
             <a:extLst xmlns:a="http://schemas.openxmlformats.org/drawingml/2006/main">
               <a:ext uri="{FF2B5EF4-FFF2-40B4-BE49-F238E27FC236}">
-                <a16:creationId xmlns:a16="http://schemas.microsoft.com/office/drawing/2014/main" id="{215DAC90-BC51-4255-88C3-97286224611E}"/>
+                <a16:creationId xmlns:a16="http://schemas.microsoft.com/office/drawing/2014/main" id="{B368EC5F-B691-410F-A05D-F85D1D98075D}"/>
               </a:ext>
             </a:extLst>
           </p:cNvPr>
@@ -14264,7 +14264,7 @@
           <p:cNvPr id="10" name="f108">
             <a:extLst xmlns:a="http://schemas.openxmlformats.org/drawingml/2006/main">
               <a:ext uri="{FF2B5EF4-FFF2-40B4-BE49-F238E27FC236}">
-                <a16:creationId xmlns:a16="http://schemas.microsoft.com/office/drawing/2014/main" id="{153E6737-0912-4B75-88B8-6187EFC3EB89}"/>
+                <a16:creationId xmlns:a16="http://schemas.microsoft.com/office/drawing/2014/main" id="{2E65BE27-F92F-4F67-B7D4-B4A7DC7749F4}"/>
               </a:ext>
             </a:extLst>
           </p:cNvPr>
@@ -14423,7 +14423,7 @@
           <p:cNvPr id="11" name="f109">
             <a:extLst xmlns:a="http://schemas.openxmlformats.org/drawingml/2006/main">
               <a:ext uri="{FF2B5EF4-FFF2-40B4-BE49-F238E27FC236}">
-                <a16:creationId xmlns:a16="http://schemas.microsoft.com/office/drawing/2014/main" id="{4AB10B04-205C-4A24-B3E8-DC4C9E260D93}"/>
+                <a16:creationId xmlns:a16="http://schemas.microsoft.com/office/drawing/2014/main" id="{AE367173-51D4-4DCC-94C7-7C016E8AF642}"/>
               </a:ext>
             </a:extLst>
           </p:cNvPr>
@@ -14454,7 +14454,7 @@
           <p:cNvPr id="12" name="f110">
             <a:extLst xmlns:a="http://schemas.openxmlformats.org/drawingml/2006/main">
               <a:ext uri="{FF2B5EF4-FFF2-40B4-BE49-F238E27FC236}">
-                <a16:creationId xmlns:a16="http://schemas.microsoft.com/office/drawing/2014/main" id="{C5698F18-91E2-4D59-9A90-98F12203C621}"/>
+                <a16:creationId xmlns:a16="http://schemas.microsoft.com/office/drawing/2014/main" id="{699CD188-704D-49D4-BDE4-58F917B3D825}"/>
               </a:ext>
             </a:extLst>
           </p:cNvPr>
@@ -14485,7 +14485,7 @@
           <p:cNvPr id="13" name="f111">
             <a:extLst xmlns:a="http://schemas.openxmlformats.org/drawingml/2006/main">
               <a:ext uri="{FF2B5EF4-FFF2-40B4-BE49-F238E27FC236}">
-                <a16:creationId xmlns:a16="http://schemas.microsoft.com/office/drawing/2014/main" id="{E8AA5743-2E61-49BB-A0E1-98ECFF8D1FE1}"/>
+                <a16:creationId xmlns:a16="http://schemas.microsoft.com/office/drawing/2014/main" id="{8A9A31D8-216E-45F9-9E26-72F107FC0507}"/>
               </a:ext>
             </a:extLst>
           </p:cNvPr>
@@ -14644,7 +14644,7 @@
           <p:cNvPr id="14" name="f112">
             <a:extLst xmlns:a="http://schemas.openxmlformats.org/drawingml/2006/main">
               <a:ext uri="{FF2B5EF4-FFF2-40B4-BE49-F238E27FC236}">
-                <a16:creationId xmlns:a16="http://schemas.microsoft.com/office/drawing/2014/main" id="{2918FDFF-6650-4641-A8EA-61A04A62CC5A}"/>
+                <a16:creationId xmlns:a16="http://schemas.microsoft.com/office/drawing/2014/main" id="{C30B618D-6C27-4A48-9E38-01AE8C65BC2F}"/>
               </a:ext>
             </a:extLst>
           </p:cNvPr>
@@ -14679,7 +14679,7 @@
           <p:cNvPr id="15" name="f113">
             <a:extLst xmlns:a="http://schemas.openxmlformats.org/drawingml/2006/main">
               <a:ext uri="{FF2B5EF4-FFF2-40B4-BE49-F238E27FC236}">
-                <a16:creationId xmlns:a16="http://schemas.microsoft.com/office/drawing/2014/main" id="{5CD2BB03-96B7-48EB-B57F-3DFBD94D41F1}"/>
+                <a16:creationId xmlns:a16="http://schemas.microsoft.com/office/drawing/2014/main" id="{1A2D487D-0EFD-48F8-BCC7-250674341B92}"/>
               </a:ext>
             </a:extLst>
           </p:cNvPr>
@@ -14861,7 +14861,7 @@
           <p:cNvPr id="16" name="f114">
             <a:extLst xmlns:a="http://schemas.openxmlformats.org/drawingml/2006/main">
               <a:ext uri="{FF2B5EF4-FFF2-40B4-BE49-F238E27FC236}">
-                <a16:creationId xmlns:a16="http://schemas.microsoft.com/office/drawing/2014/main" id="{5BD35901-A35E-4AEC-A56F-5D31D4867CAE}"/>
+                <a16:creationId xmlns:a16="http://schemas.microsoft.com/office/drawing/2014/main" id="{8BBB4C04-98D3-4E57-AB01-B825422B8BEB}"/>
               </a:ext>
             </a:extLst>
           </p:cNvPr>
@@ -14896,7 +14896,7 @@
           <p:cNvPr id="17" name="f115">
             <a:extLst xmlns:a="http://schemas.openxmlformats.org/drawingml/2006/main">
               <a:ext uri="{FF2B5EF4-FFF2-40B4-BE49-F238E27FC236}">
-                <a16:creationId xmlns:a16="http://schemas.microsoft.com/office/drawing/2014/main" id="{3B9EC7DB-E21A-4C23-9646-9962933F9E11}"/>
+                <a16:creationId xmlns:a16="http://schemas.microsoft.com/office/drawing/2014/main" id="{0295BD96-CE92-40B5-B5AE-A44D904AF6DA}"/>
               </a:ext>
             </a:extLst>
           </p:cNvPr>
@@ -15076,7 +15076,7 @@
     </p:spTree>
     <p:extLst>
       <p:ext uri="{BB962C8B-B14F-4D97-AF65-F5344CB8AC3E}">
-        <p14:creationId xmlns:p14="http://schemas.microsoft.com/office/powerpoint/2010/main" val="819393276"/>
+        <p14:creationId xmlns:p14="http://schemas.microsoft.com/office/powerpoint/2010/main" val="691460266"/>
       </p:ext>
     </p:extLst>
   </p:cSld>
@@ -15107,7 +15107,7 @@
           <p:cNvPr id="15" name="">
             <a:extLst xmlns:a="http://schemas.openxmlformats.org/drawingml/2006/main">
               <a:ext uri="{FF2B5EF4-FFF2-40B4-BE49-F238E27FC236}">
-                <a16:creationId xmlns:a16="http://schemas.microsoft.com/office/drawing/2014/main" id="{5AC308F9-9651-423C-B6A7-9059CA387304}"/>
+                <a16:creationId xmlns:a16="http://schemas.microsoft.com/office/drawing/2014/main" id="{D4FD475B-A86A-432B-9BEB-0A1BE2641D01}"/>
               </a:ext>
             </a:extLst>
           </p:cNvPr>
@@ -15117,7 +15117,7 @@
           <p:nvPr/>
         </p:nvPicPr>
         <p:blipFill>
-          <a:blip xmlns:r="http://schemas.openxmlformats.org/officeDocument/2006/relationships" xmlns:a="http://schemas.openxmlformats.org/drawingml/2006/main" r:embed="R9f379bef18414eb7"/>
+          <a:blip xmlns:r="http://schemas.openxmlformats.org/officeDocument/2006/relationships" xmlns:a="http://schemas.openxmlformats.org/drawingml/2006/main" r:embed="Rf4b37f7578494f9b"/>
           <a:stretch xmlns:a="http://schemas.openxmlformats.org/drawingml/2006/main"/>
         </p:blipFill>
         <p:spPr>
@@ -15135,7 +15135,7 @@
           <p:cNvPr id="2" name="f117">
             <a:extLst xmlns:a="http://schemas.openxmlformats.org/drawingml/2006/main">
               <a:ext uri="{FF2B5EF4-FFF2-40B4-BE49-F238E27FC236}">
-                <a16:creationId xmlns:a16="http://schemas.microsoft.com/office/drawing/2014/main" id="{A12B0194-23E4-4393-8513-BBFC6CBA124A}"/>
+                <a16:creationId xmlns:a16="http://schemas.microsoft.com/office/drawing/2014/main" id="{29DE5338-FC68-4CB0-9D22-A2388A7F367F}"/>
               </a:ext>
             </a:extLst>
           </p:cNvPr>
@@ -15294,7 +15294,7 @@
           <p:cNvPr id="3" name="f118">
             <a:extLst xmlns:a="http://schemas.openxmlformats.org/drawingml/2006/main">
               <a:ext uri="{FF2B5EF4-FFF2-40B4-BE49-F238E27FC236}">
-                <a16:creationId xmlns:a16="http://schemas.microsoft.com/office/drawing/2014/main" id="{E9CD10F7-10C9-4B00-82B2-536AC9DD16B7}"/>
+                <a16:creationId xmlns:a16="http://schemas.microsoft.com/office/drawing/2014/main" id="{7975B12F-C1C0-4634-87FD-062B57E0C00B}"/>
               </a:ext>
             </a:extLst>
           </p:cNvPr>
@@ -15453,7 +15453,7 @@
           <p:cNvPr id="4" name="f119">
             <a:extLst xmlns:a="http://schemas.openxmlformats.org/drawingml/2006/main">
               <a:ext uri="{FF2B5EF4-FFF2-40B4-BE49-F238E27FC236}">
-                <a16:creationId xmlns:a16="http://schemas.microsoft.com/office/drawing/2014/main" id="{D32923E3-09FA-406E-AC67-2E228AD441BD}"/>
+                <a16:creationId xmlns:a16="http://schemas.microsoft.com/office/drawing/2014/main" id="{036D022E-245C-40D1-A8F1-37315D31B5B1}"/>
               </a:ext>
             </a:extLst>
           </p:cNvPr>
@@ -15612,7 +15612,7 @@
           <p:cNvPr id="5" name="f120">
             <a:extLst xmlns:a="http://schemas.openxmlformats.org/drawingml/2006/main">
               <a:ext uri="{FF2B5EF4-FFF2-40B4-BE49-F238E27FC236}">
-                <a16:creationId xmlns:a16="http://schemas.microsoft.com/office/drawing/2014/main" id="{7A84DB75-677F-4847-B64C-D107179CE07C}"/>
+                <a16:creationId xmlns:a16="http://schemas.microsoft.com/office/drawing/2014/main" id="{96F52C9A-E7E3-4654-A5BD-31394727A6FD}"/>
               </a:ext>
             </a:extLst>
           </p:cNvPr>
@@ -15771,7 +15771,7 @@
           <p:cNvPr id="6" name="f121">
             <a:extLst xmlns:a="http://schemas.openxmlformats.org/drawingml/2006/main">
               <a:ext uri="{FF2B5EF4-FFF2-40B4-BE49-F238E27FC236}">
-                <a16:creationId xmlns:a16="http://schemas.microsoft.com/office/drawing/2014/main" id="{1C66E1F1-DBB9-4C76-8D70-D8751CC4BC7C}"/>
+                <a16:creationId xmlns:a16="http://schemas.microsoft.com/office/drawing/2014/main" id="{C2D3866C-9DFF-4A45-B6B3-6AF2F6762890}"/>
               </a:ext>
             </a:extLst>
           </p:cNvPr>
@@ -15930,7 +15930,7 @@
           <p:cNvPr id="7" name="f122">
             <a:extLst xmlns:a="http://schemas.openxmlformats.org/drawingml/2006/main">
               <a:ext uri="{FF2B5EF4-FFF2-40B4-BE49-F238E27FC236}">
-                <a16:creationId xmlns:a16="http://schemas.microsoft.com/office/drawing/2014/main" id="{4BFAE904-14B6-45EC-87A8-1F4934754875}"/>
+                <a16:creationId xmlns:a16="http://schemas.microsoft.com/office/drawing/2014/main" id="{79C76C10-DB88-4AF7-9917-340CC3FFA2FD}"/>
               </a:ext>
             </a:extLst>
           </p:cNvPr>
@@ -16089,7 +16089,7 @@
           <p:cNvPr id="8" name="f123">
             <a:extLst xmlns:a="http://schemas.openxmlformats.org/drawingml/2006/main">
               <a:ext uri="{FF2B5EF4-FFF2-40B4-BE49-F238E27FC236}">
-                <a16:creationId xmlns:a16="http://schemas.microsoft.com/office/drawing/2014/main" id="{BF2F70CB-54B8-41B0-BBFD-BD0AAABEAE2A}"/>
+                <a16:creationId xmlns:a16="http://schemas.microsoft.com/office/drawing/2014/main" id="{0BD4A42B-3083-4F55-8CCE-32A18F537BBC}"/>
               </a:ext>
             </a:extLst>
           </p:cNvPr>
@@ -16248,7 +16248,7 @@
           <p:cNvPr id="9" name="f124">
             <a:extLst xmlns:a="http://schemas.openxmlformats.org/drawingml/2006/main">
               <a:ext uri="{FF2B5EF4-FFF2-40B4-BE49-F238E27FC236}">
-                <a16:creationId xmlns:a16="http://schemas.microsoft.com/office/drawing/2014/main" id="{97CEE9C7-D83D-452B-B53A-A4DA22A8307E}"/>
+                <a16:creationId xmlns:a16="http://schemas.microsoft.com/office/drawing/2014/main" id="{C3CEF9D9-851E-4BA9-AD44-741F1E365008}"/>
               </a:ext>
             </a:extLst>
           </p:cNvPr>
@@ -16407,7 +16407,7 @@
           <p:cNvPr id="10" name="f125">
             <a:extLst xmlns:a="http://schemas.openxmlformats.org/drawingml/2006/main">
               <a:ext uri="{FF2B5EF4-FFF2-40B4-BE49-F238E27FC236}">
-                <a16:creationId xmlns:a16="http://schemas.microsoft.com/office/drawing/2014/main" id="{65D6918B-3351-4CAC-BEE3-F970550FFB53}"/>
+                <a16:creationId xmlns:a16="http://schemas.microsoft.com/office/drawing/2014/main" id="{43EC270E-BA95-4D19-8CF3-2CF143D711ED}"/>
               </a:ext>
             </a:extLst>
           </p:cNvPr>
@@ -16566,7 +16566,7 @@
           <p:cNvPr id="11" name="f126">
             <a:extLst xmlns:a="http://schemas.openxmlformats.org/drawingml/2006/main">
               <a:ext uri="{FF2B5EF4-FFF2-40B4-BE49-F238E27FC236}">
-                <a16:creationId xmlns:a16="http://schemas.microsoft.com/office/drawing/2014/main" id="{C8D633BD-AD88-44B8-9B59-F7B2F9BA4846}"/>
+                <a16:creationId xmlns:a16="http://schemas.microsoft.com/office/drawing/2014/main" id="{E06DAF17-599D-47BD-8DC9-150FC5EC3A58}"/>
               </a:ext>
             </a:extLst>
           </p:cNvPr>
@@ -16725,7 +16725,7 @@
           <p:cNvPr id="12" name="f127">
             <a:extLst xmlns:a="http://schemas.openxmlformats.org/drawingml/2006/main">
               <a:ext uri="{FF2B5EF4-FFF2-40B4-BE49-F238E27FC236}">
-                <a16:creationId xmlns:a16="http://schemas.microsoft.com/office/drawing/2014/main" id="{B35C6E25-8A4C-454D-8CA5-61DF981400CF}"/>
+                <a16:creationId xmlns:a16="http://schemas.microsoft.com/office/drawing/2014/main" id="{39B2D913-6CE8-45A8-92A8-1E5B8289014E}"/>
               </a:ext>
             </a:extLst>
           </p:cNvPr>
@@ -16884,7 +16884,7 @@
           <p:cNvPr id="13" name="f128">
             <a:extLst xmlns:a="http://schemas.openxmlformats.org/drawingml/2006/main">
               <a:ext uri="{FF2B5EF4-FFF2-40B4-BE49-F238E27FC236}">
-                <a16:creationId xmlns:a16="http://schemas.microsoft.com/office/drawing/2014/main" id="{50C20EE8-574F-42AF-B07D-6C87750C3041}"/>
+                <a16:creationId xmlns:a16="http://schemas.microsoft.com/office/drawing/2014/main" id="{6DC9DDC7-1F64-473A-B35A-FFFBA3627555}"/>
               </a:ext>
             </a:extLst>
           </p:cNvPr>
@@ -17043,7 +17043,7 @@
           <p:cNvPr id="14" name="f129">
             <a:extLst xmlns:a="http://schemas.openxmlformats.org/drawingml/2006/main">
               <a:ext uri="{FF2B5EF4-FFF2-40B4-BE49-F238E27FC236}">
-                <a16:creationId xmlns:a16="http://schemas.microsoft.com/office/drawing/2014/main" id="{BB81E9DC-DFBA-4E0C-8454-7FF95214CC2D}"/>
+                <a16:creationId xmlns:a16="http://schemas.microsoft.com/office/drawing/2014/main" id="{87DB7606-52BB-4047-9E66-61D846159192}"/>
               </a:ext>
             </a:extLst>
           </p:cNvPr>
@@ -17200,7 +17200,7 @@
     </p:spTree>
     <p:extLst>
       <p:ext uri="{BB962C8B-B14F-4D97-AF65-F5344CB8AC3E}">
-        <p14:creationId xmlns:p14="http://schemas.microsoft.com/office/powerpoint/2010/main" val="257938701"/>
+        <p14:creationId xmlns:p14="http://schemas.microsoft.com/office/powerpoint/2010/main" val="1534536425"/>
       </p:ext>
     </p:extLst>
   </p:cSld>
@@ -17231,7 +17231,7 @@
           <p:cNvPr id="13" name="f130">
             <a:extLst xmlns:a="http://schemas.openxmlformats.org/drawingml/2006/main">
               <a:ext uri="{FF2B5EF4-FFF2-40B4-BE49-F238E27FC236}">
-                <a16:creationId xmlns:a16="http://schemas.microsoft.com/office/drawing/2014/main" id="{02B68802-F137-4325-9222-63765BF1660D}"/>
+                <a16:creationId xmlns:a16="http://schemas.microsoft.com/office/drawing/2014/main" id="{67CE21E1-A8E7-4C78-BCE5-A685B29EA681}"/>
               </a:ext>
             </a:extLst>
           </p:cNvPr>
@@ -17390,7 +17390,7 @@
           <p:cNvPr id="2" name="f131">
             <a:extLst xmlns:a="http://schemas.openxmlformats.org/drawingml/2006/main">
               <a:ext uri="{FF2B5EF4-FFF2-40B4-BE49-F238E27FC236}">
-                <a16:creationId xmlns:a16="http://schemas.microsoft.com/office/drawing/2014/main" id="{B38F6671-5870-43F7-A32E-1A29F2AB0C4E}"/>
+                <a16:creationId xmlns:a16="http://schemas.microsoft.com/office/drawing/2014/main" id="{EDDC4C45-00F2-485D-8B36-14542002E599}"/>
               </a:ext>
             </a:extLst>
           </p:cNvPr>
@@ -17549,7 +17549,7 @@
           <p:cNvPr id="3" name="f132">
             <a:extLst xmlns:a="http://schemas.openxmlformats.org/drawingml/2006/main">
               <a:ext uri="{FF2B5EF4-FFF2-40B4-BE49-F238E27FC236}">
-                <a16:creationId xmlns:a16="http://schemas.microsoft.com/office/drawing/2014/main" id="{3DB040BD-5D8B-4C59-813A-D1B837B443D7}"/>
+                <a16:creationId xmlns:a16="http://schemas.microsoft.com/office/drawing/2014/main" id="{6661C654-1EE6-49F6-8541-ECB3B2931C46}"/>
               </a:ext>
             </a:extLst>
           </p:cNvPr>
@@ -17708,7 +17708,7 @@
           <p:cNvPr id="4" name="f133">
             <a:extLst xmlns:a="http://schemas.openxmlformats.org/drawingml/2006/main">
               <a:ext uri="{FF2B5EF4-FFF2-40B4-BE49-F238E27FC236}">
-                <a16:creationId xmlns:a16="http://schemas.microsoft.com/office/drawing/2014/main" id="{9E98D249-7FFC-4DE6-B0AD-2A2CA8D663A2}"/>
+                <a16:creationId xmlns:a16="http://schemas.microsoft.com/office/drawing/2014/main" id="{47F87975-511E-4A46-9AA3-8246BB6FB2A6}"/>
               </a:ext>
             </a:extLst>
           </p:cNvPr>
@@ -17867,7 +17867,7 @@
           <p:cNvPr id="5" name="">
             <a:extLst xmlns:a="http://schemas.openxmlformats.org/drawingml/2006/main">
               <a:ext uri="{FF2B5EF4-FFF2-40B4-BE49-F238E27FC236}">
-                <a16:creationId xmlns:a16="http://schemas.microsoft.com/office/drawing/2014/main" id="{7262E0EC-BD76-47A5-A25E-08603C6EE300}"/>
+                <a16:creationId xmlns:a16="http://schemas.microsoft.com/office/drawing/2014/main" id="{E3715459-DC23-46FD-A16B-C0E397885419}"/>
               </a:ext>
             </a:extLst>
           </p:cNvPr>
@@ -18703,7 +18703,7 @@
           <p:cNvPr id="6" name="f135">
             <a:extLst xmlns:a="http://schemas.openxmlformats.org/drawingml/2006/main">
               <a:ext uri="{FF2B5EF4-FFF2-40B4-BE49-F238E27FC236}">
-                <a16:creationId xmlns:a16="http://schemas.microsoft.com/office/drawing/2014/main" id="{A46B5714-0F67-4EE2-9271-68836177BDFF}"/>
+                <a16:creationId xmlns:a16="http://schemas.microsoft.com/office/drawing/2014/main" id="{146646E8-1534-4451-9A3C-C7C739A82D12}"/>
               </a:ext>
             </a:extLst>
           </p:cNvPr>
@@ -18738,7 +18738,7 @@
           <p:cNvPr id="7" name="f136">
             <a:extLst xmlns:a="http://schemas.openxmlformats.org/drawingml/2006/main">
               <a:ext uri="{FF2B5EF4-FFF2-40B4-BE49-F238E27FC236}">
-                <a16:creationId xmlns:a16="http://schemas.microsoft.com/office/drawing/2014/main" id="{AFAE871E-B529-4BB3-894A-03935CEE3234}"/>
+                <a16:creationId xmlns:a16="http://schemas.microsoft.com/office/drawing/2014/main" id="{5B8B7961-463B-48AA-8B50-0E019ADF82AE}"/>
               </a:ext>
             </a:extLst>
           </p:cNvPr>
@@ -18897,7 +18897,7 @@
           <p:cNvPr id="8" name="f137">
             <a:extLst xmlns:a="http://schemas.openxmlformats.org/drawingml/2006/main">
               <a:ext uri="{FF2B5EF4-FFF2-40B4-BE49-F238E27FC236}">
-                <a16:creationId xmlns:a16="http://schemas.microsoft.com/office/drawing/2014/main" id="{F3ADFDA7-5160-47C2-B3AD-9B8F76797A8F}"/>
+                <a16:creationId xmlns:a16="http://schemas.microsoft.com/office/drawing/2014/main" id="{CE7289F5-74D7-4D79-9804-D0A82A202753}"/>
               </a:ext>
             </a:extLst>
           </p:cNvPr>
@@ -19056,7 +19056,7 @@
           <p:cNvPr id="9" name="f138">
             <a:extLst xmlns:a="http://schemas.openxmlformats.org/drawingml/2006/main">
               <a:ext uri="{FF2B5EF4-FFF2-40B4-BE49-F238E27FC236}">
-                <a16:creationId xmlns:a16="http://schemas.microsoft.com/office/drawing/2014/main" id="{1903A85A-7D15-4314-A84B-3A8B2128754A}"/>
+                <a16:creationId xmlns:a16="http://schemas.microsoft.com/office/drawing/2014/main" id="{B6F7E517-C236-481F-9FF5-C71BB6EA0D57}"/>
               </a:ext>
             </a:extLst>
           </p:cNvPr>
@@ -19215,7 +19215,7 @@
           <p:cNvPr id="10" name="f139">
             <a:extLst xmlns:a="http://schemas.openxmlformats.org/drawingml/2006/main">
               <a:ext uri="{FF2B5EF4-FFF2-40B4-BE49-F238E27FC236}">
-                <a16:creationId xmlns:a16="http://schemas.microsoft.com/office/drawing/2014/main" id="{4A2D6B34-2F31-4C28-93AF-E7F5F81DB039}"/>
+                <a16:creationId xmlns:a16="http://schemas.microsoft.com/office/drawing/2014/main" id="{CA126CDA-1B29-4729-9606-82D8B88A8EB6}"/>
               </a:ext>
             </a:extLst>
           </p:cNvPr>
@@ -19374,7 +19374,7 @@
           <p:cNvPr id="11" name="f140">
             <a:extLst xmlns:a="http://schemas.openxmlformats.org/drawingml/2006/main">
               <a:ext uri="{FF2B5EF4-FFF2-40B4-BE49-F238E27FC236}">
-                <a16:creationId xmlns:a16="http://schemas.microsoft.com/office/drawing/2014/main" id="{6D343CD1-9A22-4754-9EA5-27C5E871B26A}"/>
+                <a16:creationId xmlns:a16="http://schemas.microsoft.com/office/drawing/2014/main" id="{BFCD0EC4-76E4-4AC1-AABD-EF41CB31C8C5}"/>
               </a:ext>
             </a:extLst>
           </p:cNvPr>
@@ -19533,7 +19533,7 @@
           <p:cNvPr id="12" name="f141">
             <a:extLst xmlns:a="http://schemas.openxmlformats.org/drawingml/2006/main">
               <a:ext uri="{FF2B5EF4-FFF2-40B4-BE49-F238E27FC236}">
-                <a16:creationId xmlns:a16="http://schemas.microsoft.com/office/drawing/2014/main" id="{F3889260-17FB-4AE4-B33B-3E6972FA3A89}"/>
+                <a16:creationId xmlns:a16="http://schemas.microsoft.com/office/drawing/2014/main" id="{8DD42DFA-D720-454E-A6D0-3BD61650A07B}"/>
               </a:ext>
             </a:extLst>
           </p:cNvPr>
@@ -19690,7 +19690,7 @@
     </p:spTree>
     <p:extLst>
       <p:ext uri="{BB962C8B-B14F-4D97-AF65-F5344CB8AC3E}">
-        <p14:creationId xmlns:p14="http://schemas.microsoft.com/office/powerpoint/2010/main" val="1004324616"/>
+        <p14:creationId xmlns:p14="http://schemas.microsoft.com/office/powerpoint/2010/main" val="1082741093"/>
       </p:ext>
     </p:extLst>
   </p:cSld>
@@ -19718,10 +19718,10 @@
       </p:grpSpPr>
       <p:sp>
         <p:nvSpPr>
-          <p:cNvPr id="49" name="f142">
+          <p:cNvPr id="50" name="f142">
             <a:extLst xmlns:a="http://schemas.openxmlformats.org/drawingml/2006/main">
               <a:ext uri="{FF2B5EF4-FFF2-40B4-BE49-F238E27FC236}">
-                <a16:creationId xmlns:a16="http://schemas.microsoft.com/office/drawing/2014/main" id="{FAE84D9B-4533-457A-ACB1-4CFFBCB6F928}"/>
+                <a16:creationId xmlns:a16="http://schemas.microsoft.com/office/drawing/2014/main" id="{C9D4E24B-E91A-4A52-B9E7-0E9D28CCD085}"/>
               </a:ext>
             </a:extLst>
           </p:cNvPr>
@@ -19880,7 +19880,7 @@
           <p:cNvPr id="2" name="f143">
             <a:extLst xmlns:a="http://schemas.openxmlformats.org/drawingml/2006/main">
               <a:ext uri="{FF2B5EF4-FFF2-40B4-BE49-F238E27FC236}">
-                <a16:creationId xmlns:a16="http://schemas.microsoft.com/office/drawing/2014/main" id="{E940BB28-2915-4B3F-87D5-2664F44CB464}"/>
+                <a16:creationId xmlns:a16="http://schemas.microsoft.com/office/drawing/2014/main" id="{8548F51F-218D-47B1-897D-E8F7FE572C9F}"/>
               </a:ext>
             </a:extLst>
           </p:cNvPr>
@@ -20039,7 +20039,7 @@
           <p:cNvPr id="3" name="f144">
             <a:extLst xmlns:a="http://schemas.openxmlformats.org/drawingml/2006/main">
               <a:ext uri="{FF2B5EF4-FFF2-40B4-BE49-F238E27FC236}">
-                <a16:creationId xmlns:a16="http://schemas.microsoft.com/office/drawing/2014/main" id="{517110F0-F8BF-4118-BFFE-7E3778B30CA5}"/>
+                <a16:creationId xmlns:a16="http://schemas.microsoft.com/office/drawing/2014/main" id="{BF2D923E-2B53-4BFA-A0B0-785FAD821505}"/>
               </a:ext>
             </a:extLst>
           </p:cNvPr>
@@ -20198,7 +20198,7 @@
           <p:cNvPr id="4" name="f145">
             <a:extLst xmlns:a="http://schemas.openxmlformats.org/drawingml/2006/main">
               <a:ext uri="{FF2B5EF4-FFF2-40B4-BE49-F238E27FC236}">
-                <a16:creationId xmlns:a16="http://schemas.microsoft.com/office/drawing/2014/main" id="{C6D95EBD-E461-4B54-BC2B-FC82E1E33EE6}"/>
+                <a16:creationId xmlns:a16="http://schemas.microsoft.com/office/drawing/2014/main" id="{CA648F6F-9E4F-4F02-8EB7-A4CD5E41D2D8}"/>
               </a:ext>
             </a:extLst>
           </p:cNvPr>
@@ -20357,7 +20357,7 @@
           <p:cNvPr id="5" name="f146">
             <a:extLst xmlns:a="http://schemas.openxmlformats.org/drawingml/2006/main">
               <a:ext uri="{FF2B5EF4-FFF2-40B4-BE49-F238E27FC236}">
-                <a16:creationId xmlns:a16="http://schemas.microsoft.com/office/drawing/2014/main" id="{542E68A1-A13E-4A6E-B1FC-DE278B495DBD}"/>
+                <a16:creationId xmlns:a16="http://schemas.microsoft.com/office/drawing/2014/main" id="{C2E20DF5-6D16-4149-B71B-1EEDBC9A1CED}"/>
               </a:ext>
             </a:extLst>
           </p:cNvPr>
@@ -20392,7 +20392,7 @@
           <p:cNvPr id="6" name="f147">
             <a:extLst xmlns:a="http://schemas.openxmlformats.org/drawingml/2006/main">
               <a:ext uri="{FF2B5EF4-FFF2-40B4-BE49-F238E27FC236}">
-                <a16:creationId xmlns:a16="http://schemas.microsoft.com/office/drawing/2014/main" id="{79DAFEEE-837D-4316-A1D9-9849888D73FD}"/>
+                <a16:creationId xmlns:a16="http://schemas.microsoft.com/office/drawing/2014/main" id="{AF24B891-D213-453F-8A16-C0DC7EB8C2B9}"/>
               </a:ext>
             </a:extLst>
           </p:cNvPr>
@@ -20551,7 +20551,7 @@
           <p:cNvPr id="7" name="f148">
             <a:extLst xmlns:a="http://schemas.openxmlformats.org/drawingml/2006/main">
               <a:ext uri="{FF2B5EF4-FFF2-40B4-BE49-F238E27FC236}">
-                <a16:creationId xmlns:a16="http://schemas.microsoft.com/office/drawing/2014/main" id="{23B54C86-3E35-4D23-A2F5-0B43F53F3C00}"/>
+                <a16:creationId xmlns:a16="http://schemas.microsoft.com/office/drawing/2014/main" id="{2C4C7E62-1C59-48D3-899B-8D7F97CC3D92}"/>
               </a:ext>
             </a:extLst>
           </p:cNvPr>
@@ -20586,7 +20586,7 @@
           <p:cNvPr id="8" name="f149">
             <a:extLst xmlns:a="http://schemas.openxmlformats.org/drawingml/2006/main">
               <a:ext uri="{FF2B5EF4-FFF2-40B4-BE49-F238E27FC236}">
-                <a16:creationId xmlns:a16="http://schemas.microsoft.com/office/drawing/2014/main" id="{28A1F048-6BAE-47F7-9D90-77FF3DE18793}"/>
+                <a16:creationId xmlns:a16="http://schemas.microsoft.com/office/drawing/2014/main" id="{0576CCF8-D6A0-4109-90BF-DC468C483402}"/>
               </a:ext>
             </a:extLst>
           </p:cNvPr>
@@ -20745,7 +20745,7 @@
           <p:cNvPr id="9" name="f150">
             <a:extLst xmlns:a="http://schemas.openxmlformats.org/drawingml/2006/main">
               <a:ext uri="{FF2B5EF4-FFF2-40B4-BE49-F238E27FC236}">
-                <a16:creationId xmlns:a16="http://schemas.microsoft.com/office/drawing/2014/main" id="{E56F0C01-7B21-49BB-A9A8-7C0225FC2232}"/>
+                <a16:creationId xmlns:a16="http://schemas.microsoft.com/office/drawing/2014/main" id="{FC75EB8A-5481-4BB7-BECB-029912F4BB0D}"/>
               </a:ext>
             </a:extLst>
           </p:cNvPr>
@@ -20780,7 +20780,7 @@
           <p:cNvPr id="10" name="f151">
             <a:extLst xmlns:a="http://schemas.openxmlformats.org/drawingml/2006/main">
               <a:ext uri="{FF2B5EF4-FFF2-40B4-BE49-F238E27FC236}">
-                <a16:creationId xmlns:a16="http://schemas.microsoft.com/office/drawing/2014/main" id="{7EA61ED8-5D5A-4847-BA1C-D281298946D0}"/>
+                <a16:creationId xmlns:a16="http://schemas.microsoft.com/office/drawing/2014/main" id="{F87DFBBA-C3EF-46F1-896D-FC3F7EEDFE28}"/>
               </a:ext>
             </a:extLst>
           </p:cNvPr>
@@ -20939,7 +20939,7 @@
           <p:cNvPr id="11" name="f152">
             <a:extLst xmlns:a="http://schemas.openxmlformats.org/drawingml/2006/main">
               <a:ext uri="{FF2B5EF4-FFF2-40B4-BE49-F238E27FC236}">
-                <a16:creationId xmlns:a16="http://schemas.microsoft.com/office/drawing/2014/main" id="{D11748A5-9A5B-4F65-96CB-1B1A6BF320C2}"/>
+                <a16:creationId xmlns:a16="http://schemas.microsoft.com/office/drawing/2014/main" id="{DE633995-6DF4-422D-95BE-C96284226157}"/>
               </a:ext>
             </a:extLst>
           </p:cNvPr>
@@ -20974,7 +20974,7 @@
           <p:cNvPr id="12" name="f153">
             <a:extLst xmlns:a="http://schemas.openxmlformats.org/drawingml/2006/main">
               <a:ext uri="{FF2B5EF4-FFF2-40B4-BE49-F238E27FC236}">
-                <a16:creationId xmlns:a16="http://schemas.microsoft.com/office/drawing/2014/main" id="{974D1534-78C1-4654-B544-9CFA33E1AAC5}"/>
+                <a16:creationId xmlns:a16="http://schemas.microsoft.com/office/drawing/2014/main" id="{B470C15F-7D98-49E7-AF00-3FAA7E005E52}"/>
               </a:ext>
             </a:extLst>
           </p:cNvPr>
@@ -21133,7 +21133,7 @@
           <p:cNvPr id="13" name="f154">
             <a:extLst xmlns:a="http://schemas.openxmlformats.org/drawingml/2006/main">
               <a:ext uri="{FF2B5EF4-FFF2-40B4-BE49-F238E27FC236}">
-                <a16:creationId xmlns:a16="http://schemas.microsoft.com/office/drawing/2014/main" id="{30FB1C78-4BF9-4C99-BC3E-D3D59336F81A}"/>
+                <a16:creationId xmlns:a16="http://schemas.microsoft.com/office/drawing/2014/main" id="{899B8696-FC8D-4917-A388-56D2D6FDCDD6}"/>
               </a:ext>
             </a:extLst>
           </p:cNvPr>
@@ -21168,7 +21168,7 @@
           <p:cNvPr id="14" name="f155">
             <a:extLst xmlns:a="http://schemas.openxmlformats.org/drawingml/2006/main">
               <a:ext uri="{FF2B5EF4-FFF2-40B4-BE49-F238E27FC236}">
-                <a16:creationId xmlns:a16="http://schemas.microsoft.com/office/drawing/2014/main" id="{2B8A4262-44E6-4D7E-AE6D-4E5A0ED2FCC7}"/>
+                <a16:creationId xmlns:a16="http://schemas.microsoft.com/office/drawing/2014/main" id="{A1505EDF-56F6-455C-9B53-096EBA6C4A7D}"/>
               </a:ext>
             </a:extLst>
           </p:cNvPr>
@@ -21327,7 +21327,7 @@
           <p:cNvPr id="15" name="f156">
             <a:extLst xmlns:a="http://schemas.openxmlformats.org/drawingml/2006/main">
               <a:ext uri="{FF2B5EF4-FFF2-40B4-BE49-F238E27FC236}">
-                <a16:creationId xmlns:a16="http://schemas.microsoft.com/office/drawing/2014/main" id="{0EE0B4C8-6E54-4025-A295-6B6155B3D2E8}"/>
+                <a16:creationId xmlns:a16="http://schemas.microsoft.com/office/drawing/2014/main" id="{43A286DC-6333-4D5B-A997-49D563F210F2}"/>
               </a:ext>
             </a:extLst>
           </p:cNvPr>
@@ -21362,7 +21362,7 @@
           <p:cNvPr id="16" name="f157">
             <a:extLst xmlns:a="http://schemas.openxmlformats.org/drawingml/2006/main">
               <a:ext uri="{FF2B5EF4-FFF2-40B4-BE49-F238E27FC236}">
-                <a16:creationId xmlns:a16="http://schemas.microsoft.com/office/drawing/2014/main" id="{817729EF-6BC3-4ED4-8E9B-913D13211103}"/>
+                <a16:creationId xmlns:a16="http://schemas.microsoft.com/office/drawing/2014/main" id="{7901AD54-D980-4EDA-B846-A4D8720B01B1}"/>
               </a:ext>
             </a:extLst>
           </p:cNvPr>
@@ -21544,7 +21544,7 @@
           <p:cNvPr id="17" name="f158">
             <a:extLst xmlns:a="http://schemas.openxmlformats.org/drawingml/2006/main">
               <a:ext uri="{FF2B5EF4-FFF2-40B4-BE49-F238E27FC236}">
-                <a16:creationId xmlns:a16="http://schemas.microsoft.com/office/drawing/2014/main" id="{4CF83769-7222-44AB-8AFA-1D0D21F464B2}"/>
+                <a16:creationId xmlns:a16="http://schemas.microsoft.com/office/drawing/2014/main" id="{47863EEA-E4BB-429C-9DB5-3BA36CA2CFEB}"/>
               </a:ext>
             </a:extLst>
           </p:cNvPr>
@@ -21579,7 +21579,7 @@
           <p:cNvPr id="18" name="f159">
             <a:extLst xmlns:a="http://schemas.openxmlformats.org/drawingml/2006/main">
               <a:ext uri="{FF2B5EF4-FFF2-40B4-BE49-F238E27FC236}">
-                <a16:creationId xmlns:a16="http://schemas.microsoft.com/office/drawing/2014/main" id="{881383A0-BC12-42DC-A792-E717B34FD9B2}"/>
+                <a16:creationId xmlns:a16="http://schemas.microsoft.com/office/drawing/2014/main" id="{6B18EC87-6F35-4173-A0DB-0244EC91C07E}"/>
               </a:ext>
             </a:extLst>
           </p:cNvPr>
@@ -21738,7 +21738,7 @@
           <p:cNvPr id="19" name="f160">
             <a:extLst xmlns:a="http://schemas.openxmlformats.org/drawingml/2006/main">
               <a:ext uri="{FF2B5EF4-FFF2-40B4-BE49-F238E27FC236}">
-                <a16:creationId xmlns:a16="http://schemas.microsoft.com/office/drawing/2014/main" id="{A5762339-2D90-4801-B941-9EA12D960F27}"/>
+                <a16:creationId xmlns:a16="http://schemas.microsoft.com/office/drawing/2014/main" id="{D29BC21C-CC49-47D6-BA27-C4A2E69CF69C}"/>
               </a:ext>
             </a:extLst>
           </p:cNvPr>
@@ -21769,7 +21769,7 @@
           <p:cNvPr id="20" name="f161">
             <a:extLst xmlns:a="http://schemas.openxmlformats.org/drawingml/2006/main">
               <a:ext uri="{FF2B5EF4-FFF2-40B4-BE49-F238E27FC236}">
-                <a16:creationId xmlns:a16="http://schemas.microsoft.com/office/drawing/2014/main" id="{7AA446F9-328E-439A-A447-847AB0C2A61D}"/>
+                <a16:creationId xmlns:a16="http://schemas.microsoft.com/office/drawing/2014/main" id="{B9CC020C-7C72-462E-8065-7B1172EBBFA0}"/>
               </a:ext>
             </a:extLst>
           </p:cNvPr>
@@ -21800,7 +21800,7 @@
           <p:cNvPr id="21" name="f162">
             <a:extLst xmlns:a="http://schemas.openxmlformats.org/drawingml/2006/main">
               <a:ext uri="{FF2B5EF4-FFF2-40B4-BE49-F238E27FC236}">
-                <a16:creationId xmlns:a16="http://schemas.microsoft.com/office/drawing/2014/main" id="{86D6AB1B-06A9-48FB-B1C3-A2104935D95C}"/>
+                <a16:creationId xmlns:a16="http://schemas.microsoft.com/office/drawing/2014/main" id="{F5A9F0BB-A62B-4F8A-A9EF-EF43439530E3}"/>
               </a:ext>
             </a:extLst>
           </p:cNvPr>
@@ -21831,7 +21831,7 @@
           <p:cNvPr id="22" name="f163">
             <a:extLst xmlns:a="http://schemas.openxmlformats.org/drawingml/2006/main">
               <a:ext uri="{FF2B5EF4-FFF2-40B4-BE49-F238E27FC236}">
-                <a16:creationId xmlns:a16="http://schemas.microsoft.com/office/drawing/2014/main" id="{48DD45E2-9557-48FD-AECF-6DBB15E5EC2A}"/>
+                <a16:creationId xmlns:a16="http://schemas.microsoft.com/office/drawing/2014/main" id="{AD73A73D-14D0-4C63-B2FF-615068537C21}"/>
               </a:ext>
             </a:extLst>
           </p:cNvPr>
@@ -21862,7 +21862,7 @@
           <p:cNvPr id="23" name="f164">
             <a:extLst xmlns:a="http://schemas.openxmlformats.org/drawingml/2006/main">
               <a:ext uri="{FF2B5EF4-FFF2-40B4-BE49-F238E27FC236}">
-                <a16:creationId xmlns:a16="http://schemas.microsoft.com/office/drawing/2014/main" id="{A7D05815-7409-4546-8235-3CBFE0E8E759}"/>
+                <a16:creationId xmlns:a16="http://schemas.microsoft.com/office/drawing/2014/main" id="{E973E97C-F266-445B-B06D-E04EF5005954}"/>
               </a:ext>
             </a:extLst>
           </p:cNvPr>
@@ -21893,7 +21893,7 @@
           <p:cNvPr id="24" name="f165">
             <a:extLst xmlns:a="http://schemas.openxmlformats.org/drawingml/2006/main">
               <a:ext uri="{FF2B5EF4-FFF2-40B4-BE49-F238E27FC236}">
-                <a16:creationId xmlns:a16="http://schemas.microsoft.com/office/drawing/2014/main" id="{E0D433A7-D4FD-4681-A236-78B88BDC9649}"/>
+                <a16:creationId xmlns:a16="http://schemas.microsoft.com/office/drawing/2014/main" id="{00CCF043-4D9F-4D5F-92B6-FD0011D12E84}"/>
               </a:ext>
             </a:extLst>
           </p:cNvPr>
@@ -21924,7 +21924,7 @@
           <p:cNvPr id="25" name="f166">
             <a:extLst xmlns:a="http://schemas.openxmlformats.org/drawingml/2006/main">
               <a:ext uri="{FF2B5EF4-FFF2-40B4-BE49-F238E27FC236}">
-                <a16:creationId xmlns:a16="http://schemas.microsoft.com/office/drawing/2014/main" id="{199DFA5F-F6D2-4D93-A100-2EF3CA379762}"/>
+                <a16:creationId xmlns:a16="http://schemas.microsoft.com/office/drawing/2014/main" id="{CBC0F3B7-B3B6-40DF-A17A-12231D0C3106}"/>
               </a:ext>
             </a:extLst>
           </p:cNvPr>
@@ -21955,7 +21955,7 @@
           <p:cNvPr id="26" name="f167">
             <a:extLst xmlns:a="http://schemas.openxmlformats.org/drawingml/2006/main">
               <a:ext uri="{FF2B5EF4-FFF2-40B4-BE49-F238E27FC236}">
-                <a16:creationId xmlns:a16="http://schemas.microsoft.com/office/drawing/2014/main" id="{508FFB0E-93F6-4CB6-A160-AF7258B1EAAE}"/>
+                <a16:creationId xmlns:a16="http://schemas.microsoft.com/office/drawing/2014/main" id="{3C9D6D09-E455-46DD-930E-B499568B4480}"/>
               </a:ext>
             </a:extLst>
           </p:cNvPr>
@@ -21986,7 +21986,7 @@
           <p:cNvPr id="27" name="f168">
             <a:extLst xmlns:a="http://schemas.openxmlformats.org/drawingml/2006/main">
               <a:ext uri="{FF2B5EF4-FFF2-40B4-BE49-F238E27FC236}">
-                <a16:creationId xmlns:a16="http://schemas.microsoft.com/office/drawing/2014/main" id="{FEDDC2AC-677B-485B-B016-C50C18AC83C9}"/>
+                <a16:creationId xmlns:a16="http://schemas.microsoft.com/office/drawing/2014/main" id="{231E65D6-1AD0-498E-97A1-465682EE32BC}"/>
               </a:ext>
             </a:extLst>
           </p:cNvPr>
@@ -22017,7 +22017,7 @@
           <p:cNvPr id="28" name="f169">
             <a:extLst xmlns:a="http://schemas.openxmlformats.org/drawingml/2006/main">
               <a:ext uri="{FF2B5EF4-FFF2-40B4-BE49-F238E27FC236}">
-                <a16:creationId xmlns:a16="http://schemas.microsoft.com/office/drawing/2014/main" id="{A25FCD55-EE3F-44A4-8769-4D5487F38499}"/>
+                <a16:creationId xmlns:a16="http://schemas.microsoft.com/office/drawing/2014/main" id="{CB89FD41-E563-419F-BBFC-CB72EA7B78EB}"/>
               </a:ext>
             </a:extLst>
           </p:cNvPr>
@@ -22048,7 +22048,7 @@
           <p:cNvPr id="29" name="f170">
             <a:extLst xmlns:a="http://schemas.openxmlformats.org/drawingml/2006/main">
               <a:ext uri="{FF2B5EF4-FFF2-40B4-BE49-F238E27FC236}">
-                <a16:creationId xmlns:a16="http://schemas.microsoft.com/office/drawing/2014/main" id="{94A53E58-03AC-44AC-B207-1D2B5001901D}"/>
+                <a16:creationId xmlns:a16="http://schemas.microsoft.com/office/drawing/2014/main" id="{DDC6D984-48A0-435F-A3ED-817A86BE02F2}"/>
               </a:ext>
             </a:extLst>
           </p:cNvPr>
@@ -22079,7 +22079,7 @@
           <p:cNvPr id="30" name="f171">
             <a:extLst xmlns:a="http://schemas.openxmlformats.org/drawingml/2006/main">
               <a:ext uri="{FF2B5EF4-FFF2-40B4-BE49-F238E27FC236}">
-                <a16:creationId xmlns:a16="http://schemas.microsoft.com/office/drawing/2014/main" id="{39CE3B35-A428-4BA5-B1F8-5FA761A449DD}"/>
+                <a16:creationId xmlns:a16="http://schemas.microsoft.com/office/drawing/2014/main" id="{ED898031-45BE-46E7-BB1B-7685521148BF}"/>
               </a:ext>
             </a:extLst>
           </p:cNvPr>
@@ -22110,7 +22110,7 @@
           <p:cNvPr id="31" name="f172">
             <a:extLst xmlns:a="http://schemas.openxmlformats.org/drawingml/2006/main">
               <a:ext uri="{FF2B5EF4-FFF2-40B4-BE49-F238E27FC236}">
-                <a16:creationId xmlns:a16="http://schemas.microsoft.com/office/drawing/2014/main" id="{9C81D7A3-1C7E-4862-9985-D89C2A8D5C52}"/>
+                <a16:creationId xmlns:a16="http://schemas.microsoft.com/office/drawing/2014/main" id="{00DBDD0F-B1A2-482E-9682-EEB6D39FDA51}"/>
               </a:ext>
             </a:extLst>
           </p:cNvPr>
@@ -22141,7 +22141,7 @@
           <p:cNvPr id="32" name="f173">
             <a:extLst xmlns:a="http://schemas.openxmlformats.org/drawingml/2006/main">
               <a:ext uri="{FF2B5EF4-FFF2-40B4-BE49-F238E27FC236}">
-                <a16:creationId xmlns:a16="http://schemas.microsoft.com/office/drawing/2014/main" id="{2CEB84E7-C0E3-46B0-B122-0E932897A762}"/>
+                <a16:creationId xmlns:a16="http://schemas.microsoft.com/office/drawing/2014/main" id="{39748CE6-00A5-47BE-B5D2-BC78C7A532FD}"/>
               </a:ext>
             </a:extLst>
           </p:cNvPr>
@@ -22172,7 +22172,7 @@
           <p:cNvPr id="33" name="f174">
             <a:extLst xmlns:a="http://schemas.openxmlformats.org/drawingml/2006/main">
               <a:ext uri="{FF2B5EF4-FFF2-40B4-BE49-F238E27FC236}">
-                <a16:creationId xmlns:a16="http://schemas.microsoft.com/office/drawing/2014/main" id="{F0A97875-7CDE-4149-B3D1-58285CBB00BB}"/>
+                <a16:creationId xmlns:a16="http://schemas.microsoft.com/office/drawing/2014/main" id="{01DE5B95-FBD4-4FEC-BE8D-4B963E027DCC}"/>
               </a:ext>
             </a:extLst>
           </p:cNvPr>
@@ -22203,7 +22203,7 @@
           <p:cNvPr id="34" name="f175">
             <a:extLst xmlns:a="http://schemas.openxmlformats.org/drawingml/2006/main">
               <a:ext uri="{FF2B5EF4-FFF2-40B4-BE49-F238E27FC236}">
-                <a16:creationId xmlns:a16="http://schemas.microsoft.com/office/drawing/2014/main" id="{D3D4F963-4FB8-4ADE-A558-FCD72E73495B}"/>
+                <a16:creationId xmlns:a16="http://schemas.microsoft.com/office/drawing/2014/main" id="{4D11FD74-92A1-461C-A78D-1AF6EE81C431}"/>
               </a:ext>
             </a:extLst>
           </p:cNvPr>
@@ -22362,7 +22362,7 @@
           <p:cNvPr id="35" name="f176">
             <a:extLst xmlns:a="http://schemas.openxmlformats.org/drawingml/2006/main">
               <a:ext uri="{FF2B5EF4-FFF2-40B4-BE49-F238E27FC236}">
-                <a16:creationId xmlns:a16="http://schemas.microsoft.com/office/drawing/2014/main" id="{4BEF5EDE-5426-49BF-B692-9553EFDA265A}"/>
+                <a16:creationId xmlns:a16="http://schemas.microsoft.com/office/drawing/2014/main" id="{2A5FDF67-81ED-4A94-B913-8C63D5E6C26D}"/>
               </a:ext>
             </a:extLst>
           </p:cNvPr>
@@ -22393,7 +22393,7 @@
           <p:cNvPr id="36" name="f177">
             <a:extLst xmlns:a="http://schemas.openxmlformats.org/drawingml/2006/main">
               <a:ext uri="{FF2B5EF4-FFF2-40B4-BE49-F238E27FC236}">
-                <a16:creationId xmlns:a16="http://schemas.microsoft.com/office/drawing/2014/main" id="{A15C9C21-33AF-415C-BB6E-D8E851F25BA1}"/>
+                <a16:creationId xmlns:a16="http://schemas.microsoft.com/office/drawing/2014/main" id="{E9DA4510-7B4E-4528-B30E-3EB92CDBC884}"/>
               </a:ext>
             </a:extLst>
           </p:cNvPr>
@@ -22424,7 +22424,7 @@
           <p:cNvPr id="37" name="f178">
             <a:extLst xmlns:a="http://schemas.openxmlformats.org/drawingml/2006/main">
               <a:ext uri="{FF2B5EF4-FFF2-40B4-BE49-F238E27FC236}">
-                <a16:creationId xmlns:a16="http://schemas.microsoft.com/office/drawing/2014/main" id="{C6427012-EBA2-4CE0-B0B5-F39A63F12AB9}"/>
+                <a16:creationId xmlns:a16="http://schemas.microsoft.com/office/drawing/2014/main" id="{4A0B5937-4876-4DB8-A937-78494DB77548}"/>
               </a:ext>
             </a:extLst>
           </p:cNvPr>
@@ -22435,8 +22435,8 @@
         </p:nvSpPr>
         <p:spPr>
           <a:xfrm xmlns:a="http://schemas.openxmlformats.org/drawingml/2006/main">
-            <a:off x="7896225" y="5572125"/>
-            <a:ext cx="200025" cy="95"/>
+            <a:off x="7724775" y="5572125"/>
+            <a:ext cx="371475" cy="95"/>
           </a:xfrm>
           <a:prstGeom xmlns:a="http://schemas.openxmlformats.org/drawingml/2006/main" prst="line">
             <a:avLst/>
@@ -22455,7 +22455,38 @@
           <p:cNvPr id="38" name="f179">
             <a:extLst xmlns:a="http://schemas.openxmlformats.org/drawingml/2006/main">
               <a:ext uri="{FF2B5EF4-FFF2-40B4-BE49-F238E27FC236}">
-                <a16:creationId xmlns:a16="http://schemas.microsoft.com/office/drawing/2014/main" id="{AC12F035-4BCB-4BCA-963B-8D7444D7DF68}"/>
+                <a16:creationId xmlns:a16="http://schemas.microsoft.com/office/drawing/2014/main" id="{3E185338-3850-4240-B191-C8894DF6459C}"/>
+              </a:ext>
+            </a:extLst>
+          </p:cNvPr>
+          <p:cNvSpPr>
+            <a:spLocks xmlns:a="http://schemas.openxmlformats.org/drawingml/2006/main" noGrp="1"/>
+          </p:cNvSpPr>
+          <p:nvPr/>
+        </p:nvSpPr>
+        <p:spPr>
+          <a:xfrm xmlns:a="http://schemas.openxmlformats.org/drawingml/2006/main" flipH="1">
+            <a:off x="7724775" y="5514975"/>
+            <a:ext cx="95250" cy="57150"/>
+          </a:xfrm>
+          <a:prstGeom xmlns:a="http://schemas.openxmlformats.org/drawingml/2006/main" prst="line">
+            <a:avLst/>
+          </a:prstGeom>
+          <a:noFill xmlns:a="http://schemas.openxmlformats.org/drawingml/2006/main"/>
+          <a:ln xmlns:a="http://schemas.openxmlformats.org/drawingml/2006/main" w="28575">
+            <a:solidFill>
+              <a:srgbClr val="4264D0"/>
+            </a:solidFill>
+            <a:prstDash val="solid"/>
+          </a:ln>
+        </p:spPr>
+      </p:sp>
+      <p:sp>
+        <p:nvSpPr>
+          <p:cNvPr id="39" name="f180">
+            <a:extLst xmlns:a="http://schemas.openxmlformats.org/drawingml/2006/main">
+              <a:ext uri="{FF2B5EF4-FFF2-40B4-BE49-F238E27FC236}">
+                <a16:creationId xmlns:a16="http://schemas.microsoft.com/office/drawing/2014/main" id="{EA74EEAE-46DA-4336-B889-C65D5C664AD2}"/>
               </a:ext>
             </a:extLst>
           </p:cNvPr>
@@ -22466,27 +22497,27 @@
         </p:nvSpPr>
         <p:spPr>
           <a:xfrm xmlns:a="http://schemas.openxmlformats.org/drawingml/2006/main">
-            <a:off x="7724775" y="5486400"/>
-            <a:ext cx="171450" cy="171450"/>
+            <a:off x="7724775" y="5572125"/>
+            <a:ext cx="95250" cy="57150"/>
           </a:xfrm>
-          <a:prstGeom xmlns:a="http://schemas.openxmlformats.org/drawingml/2006/main" prst="leftArrow">
+          <a:prstGeom xmlns:a="http://schemas.openxmlformats.org/drawingml/2006/main" prst="line">
             <a:avLst/>
           </a:prstGeom>
-          <a:solidFill xmlns:a="http://schemas.openxmlformats.org/drawingml/2006/main">
-            <a:srgbClr val="4264D0"/>
-          </a:solidFill>
-          <a:ln xmlns:a="http://schemas.openxmlformats.org/drawingml/2006/main" w="0">
-            <a:noFill/>
+          <a:noFill xmlns:a="http://schemas.openxmlformats.org/drawingml/2006/main"/>
+          <a:ln xmlns:a="http://schemas.openxmlformats.org/drawingml/2006/main" w="28575">
+            <a:solidFill>
+              <a:srgbClr val="4264D0"/>
+            </a:solidFill>
             <a:prstDash val="solid"/>
           </a:ln>
         </p:spPr>
       </p:sp>
       <p:sp>
         <p:nvSpPr>
-          <p:cNvPr id="39" name="f180">
+          <p:cNvPr id="40" name="f181">
             <a:extLst xmlns:a="http://schemas.openxmlformats.org/drawingml/2006/main">
               <a:ext uri="{FF2B5EF4-FFF2-40B4-BE49-F238E27FC236}">
-                <a16:creationId xmlns:a16="http://schemas.microsoft.com/office/drawing/2014/main" id="{C0F6AF8A-6577-410A-AE59-79AC42662667}"/>
+                <a16:creationId xmlns:a16="http://schemas.microsoft.com/office/drawing/2014/main" id="{7E4BC1A8-9166-4751-91D6-593C7C813755}"/>
               </a:ext>
             </a:extLst>
           </p:cNvPr>
@@ -22514,10 +22545,10 @@
       </p:sp>
       <p:sp>
         <p:nvSpPr>
-          <p:cNvPr id="40" name="f181">
+          <p:cNvPr id="41" name="f182">
             <a:extLst xmlns:a="http://schemas.openxmlformats.org/drawingml/2006/main">
               <a:ext uri="{FF2B5EF4-FFF2-40B4-BE49-F238E27FC236}">
-                <a16:creationId xmlns:a16="http://schemas.microsoft.com/office/drawing/2014/main" id="{5322EFDC-0981-48CE-A939-9BB258970E3A}"/>
+                <a16:creationId xmlns:a16="http://schemas.microsoft.com/office/drawing/2014/main" id="{4D320560-3E8B-43FD-9FC4-1AAE0B44F238}"/>
               </a:ext>
             </a:extLst>
           </p:cNvPr>
@@ -22545,10 +22576,10 @@
       </p:sp>
       <p:sp>
         <p:nvSpPr>
-          <p:cNvPr id="41" name="f182">
+          <p:cNvPr id="42" name="f183">
             <a:extLst xmlns:a="http://schemas.openxmlformats.org/drawingml/2006/main">
               <a:ext uri="{FF2B5EF4-FFF2-40B4-BE49-F238E27FC236}">
-                <a16:creationId xmlns:a16="http://schemas.microsoft.com/office/drawing/2014/main" id="{53F69048-7F86-465E-BE72-19AF885B8E52}"/>
+                <a16:creationId xmlns:a16="http://schemas.microsoft.com/office/drawing/2014/main" id="{715C90DB-C362-4EDD-A117-7ABE99E3DC59}"/>
               </a:ext>
             </a:extLst>
           </p:cNvPr>
@@ -22576,10 +22607,10 @@
       </p:sp>
       <p:sp>
         <p:nvSpPr>
-          <p:cNvPr id="42" name="f183">
+          <p:cNvPr id="43" name="f184">
             <a:extLst xmlns:a="http://schemas.openxmlformats.org/drawingml/2006/main">
               <a:ext uri="{FF2B5EF4-FFF2-40B4-BE49-F238E27FC236}">
-                <a16:creationId xmlns:a16="http://schemas.microsoft.com/office/drawing/2014/main" id="{25537E6E-6D56-4625-969A-6249D127D949}"/>
+                <a16:creationId xmlns:a16="http://schemas.microsoft.com/office/drawing/2014/main" id="{2722BF4A-74AD-4CCA-983B-801BCCAC36D6}"/>
               </a:ext>
             </a:extLst>
           </p:cNvPr>
@@ -22607,10 +22638,10 @@
       </p:sp>
       <p:sp>
         <p:nvSpPr>
-          <p:cNvPr id="43" name="f184">
+          <p:cNvPr id="44" name="f185">
             <a:extLst xmlns:a="http://schemas.openxmlformats.org/drawingml/2006/main">
               <a:ext uri="{FF2B5EF4-FFF2-40B4-BE49-F238E27FC236}">
-                <a16:creationId xmlns:a16="http://schemas.microsoft.com/office/drawing/2014/main" id="{0C955191-543C-4881-BD76-790AB1E38FD1}"/>
+                <a16:creationId xmlns:a16="http://schemas.microsoft.com/office/drawing/2014/main" id="{32251178-C39A-42AF-B2D7-49CE1D147B59}"/>
               </a:ext>
             </a:extLst>
           </p:cNvPr>
@@ -22638,10 +22669,10 @@
       </p:sp>
       <p:sp>
         <p:nvSpPr>
-          <p:cNvPr id="44" name="f185">
+          <p:cNvPr id="45" name="f186">
             <a:extLst xmlns:a="http://schemas.openxmlformats.org/drawingml/2006/main">
               <a:ext uri="{FF2B5EF4-FFF2-40B4-BE49-F238E27FC236}">
-                <a16:creationId xmlns:a16="http://schemas.microsoft.com/office/drawing/2014/main" id="{148D418F-E4BB-492A-B8F5-A55BF01573BD}"/>
+                <a16:creationId xmlns:a16="http://schemas.microsoft.com/office/drawing/2014/main" id="{42BA663B-775A-4CE1-97EF-784B11E43825}"/>
               </a:ext>
             </a:extLst>
           </p:cNvPr>
@@ -22669,10 +22700,10 @@
       </p:sp>
       <p:sp>
         <p:nvSpPr>
-          <p:cNvPr id="45" name="f186">
+          <p:cNvPr id="46" name="f187">
             <a:extLst xmlns:a="http://schemas.openxmlformats.org/drawingml/2006/main">
               <a:ext uri="{FF2B5EF4-FFF2-40B4-BE49-F238E27FC236}">
-                <a16:creationId xmlns:a16="http://schemas.microsoft.com/office/drawing/2014/main" id="{2041356C-CEC8-4538-B207-67477330066F}"/>
+                <a16:creationId xmlns:a16="http://schemas.microsoft.com/office/drawing/2014/main" id="{F7C8AB7E-0D0D-4871-8146-C66989ED09B7}"/>
               </a:ext>
             </a:extLst>
           </p:cNvPr>
@@ -22828,10 +22859,10 @@
       </p:sp>
       <p:graphicFrame>
         <p:nvGraphicFramePr>
-          <p:cNvPr id="46" name="">
+          <p:cNvPr id="47" name="">
             <a:extLst xmlns:a="http://schemas.openxmlformats.org/drawingml/2006/main">
               <a:ext uri="{FF2B5EF4-FFF2-40B4-BE49-F238E27FC236}">
-                <a16:creationId xmlns:a16="http://schemas.microsoft.com/office/drawing/2014/main" id="{2574253D-69D1-46E1-BFDA-1B35A9B08D0C}"/>
+                <a16:creationId xmlns:a16="http://schemas.microsoft.com/office/drawing/2014/main" id="{DD6DC111-4EFC-45AB-813A-B4A8FC5970FB}"/>
               </a:ext>
             </a:extLst>
           </p:cNvPr>
@@ -23431,10 +23462,10 @@
       </p:graphicFrame>
       <p:sp>
         <p:nvSpPr>
-          <p:cNvPr id="47" name="f188">
+          <p:cNvPr id="48" name="f189">
             <a:extLst xmlns:a="http://schemas.openxmlformats.org/drawingml/2006/main">
               <a:ext uri="{FF2B5EF4-FFF2-40B4-BE49-F238E27FC236}">
-                <a16:creationId xmlns:a16="http://schemas.microsoft.com/office/drawing/2014/main" id="{C5A25857-740E-432B-A15C-63403E46EB36}"/>
+                <a16:creationId xmlns:a16="http://schemas.microsoft.com/office/drawing/2014/main" id="{1E58A7E9-4A67-4E54-86EE-69AAC2B2B253}"/>
               </a:ext>
             </a:extLst>
           </p:cNvPr>
@@ -23590,10 +23621,10 @@
       </p:sp>
       <p:sp>
         <p:nvSpPr>
-          <p:cNvPr id="48" name="f189">
+          <p:cNvPr id="49" name="f190">
             <a:extLst xmlns:a="http://schemas.openxmlformats.org/drawingml/2006/main">
               <a:ext uri="{FF2B5EF4-FFF2-40B4-BE49-F238E27FC236}">
-                <a16:creationId xmlns:a16="http://schemas.microsoft.com/office/drawing/2014/main" id="{51C27A74-1F2D-4863-866B-AB870A97AC79}"/>
+                <a16:creationId xmlns:a16="http://schemas.microsoft.com/office/drawing/2014/main" id="{FC77429B-DD8F-4C7E-891F-515592591B50}"/>
               </a:ext>
             </a:extLst>
           </p:cNvPr>
@@ -23773,7 +23804,7 @@
     </p:spTree>
     <p:extLst>
       <p:ext uri="{BB962C8B-B14F-4D97-AF65-F5344CB8AC3E}">
-        <p14:creationId xmlns:p14="http://schemas.microsoft.com/office/powerpoint/2010/main" val="632023586"/>
+        <p14:creationId xmlns:p14="http://schemas.microsoft.com/office/powerpoint/2010/main" val="127148856"/>
       </p:ext>
     </p:extLst>
   </p:cSld>

</xml_diff>

<commit_message>
Apply six editorial and layout revisions while preserving diagrams and animations
</commit_message>
<xml_diff>
--- a/5g-thesis-presentation-5min/tesi-5min-statico.pptx
+++ b/5g-thesis-presentation-5min/tesi-5min-statico.pptx
@@ -2,19 +2,19 @@
 <file path=ppt/presentation.xml><?xml version="1.0" encoding="utf-8"?>
 <p:presentation xmlns:p="http://schemas.openxmlformats.org/presentationml/2006/main">
   <p:sldMasterIdLst>
-    <p:sldMasterId xmlns:r="http://schemas.openxmlformats.org/officeDocument/2006/relationships" id="2147483648" r:id="Rc9a03ea16857466e"/>
+    <p:sldMasterId xmlns:r="http://schemas.openxmlformats.org/officeDocument/2006/relationships" id="2147483648" r:id="R28d66bf4a12a46fb"/>
   </p:sldMasterIdLst>
   <p:notesMasterIdLst>
-    <p:notesMasterId xmlns:r="http://schemas.openxmlformats.org/officeDocument/2006/relationships" r:id="R335d0ebf525a4447"/>
+    <p:notesMasterId xmlns:r="http://schemas.openxmlformats.org/officeDocument/2006/relationships" r:id="R8d2113278ea34c4c"/>
   </p:notesMasterIdLst>
   <p:sldIdLst>
-    <p:sldId xmlns:r="http://schemas.openxmlformats.org/officeDocument/2006/relationships" id="256" r:id="R07fce34d24e54e88"/>
-    <p:sldId xmlns:r="http://schemas.openxmlformats.org/officeDocument/2006/relationships" id="257" r:id="Rf943c923a7774e50"/>
-    <p:sldId xmlns:r="http://schemas.openxmlformats.org/officeDocument/2006/relationships" id="258" r:id="Re7a983aa8876476e"/>
-    <p:sldId xmlns:r="http://schemas.openxmlformats.org/officeDocument/2006/relationships" id="259" r:id="Rdd822fe2b47d4d43"/>
-    <p:sldId xmlns:r="http://schemas.openxmlformats.org/officeDocument/2006/relationships" id="260" r:id="Ref38538bd830463a"/>
-    <p:sldId xmlns:r="http://schemas.openxmlformats.org/officeDocument/2006/relationships" id="261" r:id="R2954225013c747d4"/>
-    <p:sldId xmlns:r="http://schemas.openxmlformats.org/officeDocument/2006/relationships" id="262" r:id="R8f5c574976534372"/>
+    <p:sldId xmlns:r="http://schemas.openxmlformats.org/officeDocument/2006/relationships" id="256" r:id="Rb812ca990d2e4825"/>
+    <p:sldId xmlns:r="http://schemas.openxmlformats.org/officeDocument/2006/relationships" id="257" r:id="R577f91db0327409b"/>
+    <p:sldId xmlns:r="http://schemas.openxmlformats.org/officeDocument/2006/relationships" id="258" r:id="R89014dbec34948b5"/>
+    <p:sldId xmlns:r="http://schemas.openxmlformats.org/officeDocument/2006/relationships" id="259" r:id="R4f83e73cc2964929"/>
+    <p:sldId xmlns:r="http://schemas.openxmlformats.org/officeDocument/2006/relationships" id="260" r:id="Rc477bfc206ba442a"/>
+    <p:sldId xmlns:r="http://schemas.openxmlformats.org/officeDocument/2006/relationships" id="261" r:id="R23f0bfa541d840c0"/>
+    <p:sldId xmlns:r="http://schemas.openxmlformats.org/officeDocument/2006/relationships" id="262" r:id="R0686553aceb44965"/>
   </p:sldIdLst>
   <p:sldSz cx="15240000" cy="8572500"/>
   <p:notesSz cx="6858000" cy="9144000"/>
@@ -738,7 +738,7 @@
           <a:lstStyle xmlns:a="http://schemas.openxmlformats.org/drawingml/2006/main"/>
           <a:p xmlns:a="http://schemas.openxmlformats.org/drawingml/2006/main">
             <a:r>
-              <a:t>Le specifiche SCAS sono scritte in linguaggio naturale e non possono essere interpretate direttamente dal verificatore. La prima schermata mostra tre estratti reali e uno pseudocodice soltanto illustrativo. [Primo clic] Nel caso NRF, riportato in forma semplificata nella tesi, distinguiamo i messaggi da individuare e il criterio da verificare: la risposta HTTP 403 alla discovery non autorizzata. [Secondo clic] Ho progettato il DSL per rappresentare questi due aspetti con costrutti riutilizzabili. Al posto del testo SCAS compare la regola: SEQUENCE descrive i messaggi, REQUIRE il criterio. Le due domande rimangono le stesse. Le regole sono scritte usando i costrutti del DSL: non ho sviluppato una traduzione automatica NLP né un sistema che esegue i test SCAS.</a:t>
+              <a:t>Il primo contributo è il DSL progettato. Le specifiche SCAS sono scritte in linguaggio naturale e non possono essere interpretate direttamente dal verificatore. La prima schermata mostra tre estratti reali e uno pseudocodice soltanto illustrativo. [Primo clic] Nel caso NRF, riportato in forma semplificata nella tesi, distinguiamo i messaggi da individuare e il criterio da verificare: la risposta HTTP 403 alla discovery non autorizzata. [Secondo clic] Ho progettato il DSL per rappresentare questi due aspetti con costrutti riutilizzabili. Al posto del testo SCAS compare la regola: SEQUENCE descrive i messaggi, REQUIRE il criterio. Le due domande rimangono le stesse. Le regole sono scritte usando i costrutti del DSL: non ho sviluppato una traduzione automatica NLP né un sistema che esegue i test SCAS.</a:t>
             </a:r>
           </a:p>
           <a:p xmlns:a="http://schemas.openxmlformats.org/drawingml/2006/main">
@@ -1135,7 +1135,7 @@
           <p:cNvPr id="3" name="Title">
             <a:extLst xmlns:a="http://schemas.openxmlformats.org/drawingml/2006/main">
               <a:ext uri="{FF2B5EF4-FFF2-40B4-BE49-F238E27FC236}">
-                <a16:creationId xmlns:a16="http://schemas.microsoft.com/office/drawing/2014/main" id="{EBEC20B4-2969-41EE-8B37-77440FF5B476}"/>
+                <a16:creationId xmlns:a16="http://schemas.microsoft.com/office/drawing/2014/main" id="{0B39142B-6BF2-48E6-9301-C6FA8BA45450}"/>
               </a:ext>
             </a:extLst>
           </p:cNvPr>
@@ -1364,7 +1364,7 @@
           <p:cNvPr id="2" name="Subtitle">
             <a:extLst xmlns:a="http://schemas.openxmlformats.org/drawingml/2006/main">
               <a:ext uri="{FF2B5EF4-FFF2-40B4-BE49-F238E27FC236}">
-                <a16:creationId xmlns:a16="http://schemas.microsoft.com/office/drawing/2014/main" id="{255CE1B1-00FB-41A7-8F7F-1FA0754EA09B}"/>
+                <a16:creationId xmlns:a16="http://schemas.microsoft.com/office/drawing/2014/main" id="{8F8C5ACF-B12B-425B-9408-28ED62E1A33A}"/>
               </a:ext>
             </a:extLst>
           </p:cNvPr>
@@ -1610,7 +1610,7 @@
           <p:cNvPr id="2" name="Section title">
             <a:extLst xmlns:a="http://schemas.openxmlformats.org/drawingml/2006/main">
               <a:ext uri="{FF2B5EF4-FFF2-40B4-BE49-F238E27FC236}">
-                <a16:creationId xmlns:a16="http://schemas.microsoft.com/office/drawing/2014/main" id="{90B0E8C9-A108-4C2C-8DD8-A810526B51DF}"/>
+                <a16:creationId xmlns:a16="http://schemas.microsoft.com/office/drawing/2014/main" id="{35A73A22-8D4C-4F36-A5AD-E9D2FC043F06}"/>
               </a:ext>
             </a:extLst>
           </p:cNvPr>
@@ -1856,7 +1856,7 @@
           <p:cNvPr id="3" name="Title">
             <a:extLst xmlns:a="http://schemas.openxmlformats.org/drawingml/2006/main">
               <a:ext uri="{FF2B5EF4-FFF2-40B4-BE49-F238E27FC236}">
-                <a16:creationId xmlns:a16="http://schemas.microsoft.com/office/drawing/2014/main" id="{B0E0CCA4-E384-44FA-9F0B-BD20C13C09C4}"/>
+                <a16:creationId xmlns:a16="http://schemas.microsoft.com/office/drawing/2014/main" id="{8C747E11-99BC-4D9A-82E5-7C9AAE5D5086}"/>
               </a:ext>
             </a:extLst>
           </p:cNvPr>
@@ -2085,7 +2085,7 @@
           <p:cNvPr id="2" name="Body">
             <a:extLst xmlns:a="http://schemas.openxmlformats.org/drawingml/2006/main">
               <a:ext uri="{FF2B5EF4-FFF2-40B4-BE49-F238E27FC236}">
-                <a16:creationId xmlns:a16="http://schemas.microsoft.com/office/drawing/2014/main" id="{E22AC889-5AFB-47D7-BB20-F656999EA961}"/>
+                <a16:creationId xmlns:a16="http://schemas.microsoft.com/office/drawing/2014/main" id="{985D7692-E3FA-4CEE-BAFF-EA26ADCD631C}"/>
               </a:ext>
             </a:extLst>
           </p:cNvPr>
@@ -2331,7 +2331,7 @@
           <p:cNvPr id="4" name="Title">
             <a:extLst xmlns:a="http://schemas.openxmlformats.org/drawingml/2006/main">
               <a:ext uri="{FF2B5EF4-FFF2-40B4-BE49-F238E27FC236}">
-                <a16:creationId xmlns:a16="http://schemas.microsoft.com/office/drawing/2014/main" id="{234E3200-0AD4-438B-9E1F-979702ECF0B3}"/>
+                <a16:creationId xmlns:a16="http://schemas.microsoft.com/office/drawing/2014/main" id="{7B5600ED-1473-4042-B847-1D3747BCACD2}"/>
               </a:ext>
             </a:extLst>
           </p:cNvPr>
@@ -2560,7 +2560,7 @@
           <p:cNvPr id="2" name="Left column">
             <a:extLst xmlns:a="http://schemas.openxmlformats.org/drawingml/2006/main">
               <a:ext uri="{FF2B5EF4-FFF2-40B4-BE49-F238E27FC236}">
-                <a16:creationId xmlns:a16="http://schemas.microsoft.com/office/drawing/2014/main" id="{B5C7A0EA-5A1D-49CC-9CB6-42CCD904251D}"/>
+                <a16:creationId xmlns:a16="http://schemas.microsoft.com/office/drawing/2014/main" id="{EE70D698-F243-4884-B77B-C8122B4EEE53}"/>
               </a:ext>
             </a:extLst>
           </p:cNvPr>
@@ -2789,7 +2789,7 @@
           <p:cNvPr id="3" name="Right column">
             <a:extLst xmlns:a="http://schemas.openxmlformats.org/drawingml/2006/main">
               <a:ext uri="{FF2B5EF4-FFF2-40B4-BE49-F238E27FC236}">
-                <a16:creationId xmlns:a16="http://schemas.microsoft.com/office/drawing/2014/main" id="{3254CABD-AE09-400E-85BE-050611654385}"/>
+                <a16:creationId xmlns:a16="http://schemas.microsoft.com/office/drawing/2014/main" id="{6B5EECB9-86CD-4EEE-8B7A-4D1CF75C954E}"/>
               </a:ext>
             </a:extLst>
           </p:cNvPr>
@@ -3035,7 +3035,7 @@
           <p:cNvPr id="3" name="Title">
             <a:extLst xmlns:a="http://schemas.openxmlformats.org/drawingml/2006/main">
               <a:ext uri="{FF2B5EF4-FFF2-40B4-BE49-F238E27FC236}">
-                <a16:creationId xmlns:a16="http://schemas.microsoft.com/office/drawing/2014/main" id="{3A55BAF0-1DCC-433C-BA1F-612092D5F4F8}"/>
+                <a16:creationId xmlns:a16="http://schemas.microsoft.com/office/drawing/2014/main" id="{277005B0-DC8C-4195-8AD7-18D5BCDAE963}"/>
               </a:ext>
             </a:extLst>
           </p:cNvPr>
@@ -3264,7 +3264,7 @@
           <p:cNvPr id="2" name="Left column">
             <a:extLst xmlns:a="http://schemas.openxmlformats.org/drawingml/2006/main">
               <a:ext uri="{FF2B5EF4-FFF2-40B4-BE49-F238E27FC236}">
-                <a16:creationId xmlns:a16="http://schemas.microsoft.com/office/drawing/2014/main" id="{91116FE8-A480-4F6C-97E8-8AF76DBED865}"/>
+                <a16:creationId xmlns:a16="http://schemas.microsoft.com/office/drawing/2014/main" id="{8141C69F-945B-4267-ACE9-8552683CCE13}"/>
               </a:ext>
             </a:extLst>
           </p:cNvPr>
@@ -3531,12 +3531,12 @@
   </p:cSld>
   <p:clrMap bg1="lt1" tx1="dk1" bg2="lt2" tx2="dk2" accent1="accent1" accent2="accent2" accent3="accent3" accent4="accent4" accent5="accent5" accent6="accent6" hlink="hlink" folHlink="folHlink"/>
   <p:sldLayoutIdLst>
-    <p:sldLayoutId xmlns:r="http://schemas.openxmlformats.org/officeDocument/2006/relationships" id="2147483649" r:id="R858fa8fe78a540cc"/>
-    <p:sldLayoutId xmlns:r="http://schemas.openxmlformats.org/officeDocument/2006/relationships" id="2147483650" r:id="R659360ab6eb1440a"/>
-    <p:sldLayoutId xmlns:r="http://schemas.openxmlformats.org/officeDocument/2006/relationships" id="2147483651" r:id="R69184f7349424297"/>
-    <p:sldLayoutId xmlns:r="http://schemas.openxmlformats.org/officeDocument/2006/relationships" id="2147483652" r:id="R8230d9cf907643da"/>
-    <p:sldLayoutId xmlns:r="http://schemas.openxmlformats.org/officeDocument/2006/relationships" id="2147483653" r:id="Rffcae840cf9742df"/>
-    <p:sldLayoutId xmlns:r="http://schemas.openxmlformats.org/officeDocument/2006/relationships" id="2147483654" r:id="R81a1a620cdbe4517"/>
+    <p:sldLayoutId xmlns:r="http://schemas.openxmlformats.org/officeDocument/2006/relationships" id="2147483649" r:id="Rddd2d3a141514265"/>
+    <p:sldLayoutId xmlns:r="http://schemas.openxmlformats.org/officeDocument/2006/relationships" id="2147483650" r:id="Rdb2b53ff255a4a9d"/>
+    <p:sldLayoutId xmlns:r="http://schemas.openxmlformats.org/officeDocument/2006/relationships" id="2147483651" r:id="Rb788dfb663b04c55"/>
+    <p:sldLayoutId xmlns:r="http://schemas.openxmlformats.org/officeDocument/2006/relationships" id="2147483652" r:id="Rbd503872eeb14c10"/>
+    <p:sldLayoutId xmlns:r="http://schemas.openxmlformats.org/officeDocument/2006/relationships" id="2147483653" r:id="R6b000824c1684cd3"/>
+    <p:sldLayoutId xmlns:r="http://schemas.openxmlformats.org/officeDocument/2006/relationships" id="2147483654" r:id="Rf572b49db79c42b7"/>
   </p:sldLayoutIdLst>
   <p:txStyles>
     <p:titleStyle>
@@ -4087,7 +4087,7 @@
           <p:cNvPr id="21" name="">
             <a:extLst xmlns:a="http://schemas.openxmlformats.org/drawingml/2006/main">
               <a:ext uri="{FF2B5EF4-FFF2-40B4-BE49-F238E27FC236}">
-                <a16:creationId xmlns:a16="http://schemas.microsoft.com/office/drawing/2014/main" id="{350D251C-EE3D-4522-9ABA-6DBB6F89AAF1}"/>
+                <a16:creationId xmlns:a16="http://schemas.microsoft.com/office/drawing/2014/main" id="{6516710D-B0DD-42E8-A790-C37733949609}"/>
               </a:ext>
             </a:extLst>
           </p:cNvPr>
@@ -4097,7 +4097,7 @@
           <p:nvPr/>
         </p:nvPicPr>
         <p:blipFill>
-          <a:blip xmlns:r="http://schemas.openxmlformats.org/officeDocument/2006/relationships" xmlns:a="http://schemas.openxmlformats.org/drawingml/2006/main" r:embed="R2d63f5637ce44d3e"/>
+          <a:blip xmlns:r="http://schemas.openxmlformats.org/officeDocument/2006/relationships" xmlns:a="http://schemas.openxmlformats.org/drawingml/2006/main" r:embed="R32bce73d270248e3"/>
           <a:stretch xmlns:a="http://schemas.openxmlformats.org/drawingml/2006/main"/>
         </p:blipFill>
         <p:spPr>
@@ -4115,7 +4115,7 @@
           <p:cNvPr id="2" name="f2">
             <a:extLst xmlns:a="http://schemas.openxmlformats.org/drawingml/2006/main">
               <a:ext uri="{FF2B5EF4-FFF2-40B4-BE49-F238E27FC236}">
-                <a16:creationId xmlns:a16="http://schemas.microsoft.com/office/drawing/2014/main" id="{837CA3D0-3017-4BF3-9C41-2DF22EFE7E0F}"/>
+                <a16:creationId xmlns:a16="http://schemas.microsoft.com/office/drawing/2014/main" id="{957BFEB9-951F-4A66-A56C-2F6A3F935696}"/>
               </a:ext>
             </a:extLst>
           </p:cNvPr>
@@ -4274,7 +4274,7 @@
           <p:cNvPr id="3" name="f3">
             <a:extLst xmlns:a="http://schemas.openxmlformats.org/drawingml/2006/main">
               <a:ext uri="{FF2B5EF4-FFF2-40B4-BE49-F238E27FC236}">
-                <a16:creationId xmlns:a16="http://schemas.microsoft.com/office/drawing/2014/main" id="{FE0D32E0-812C-4A53-B7FF-8FE000520777}"/>
+                <a16:creationId xmlns:a16="http://schemas.microsoft.com/office/drawing/2014/main" id="{34E0D8C1-10C6-4689-888E-D4CF8CA8EBC8}"/>
               </a:ext>
             </a:extLst>
           </p:cNvPr>
@@ -4433,7 +4433,7 @@
           <p:cNvPr id="4" name="f4">
             <a:extLst xmlns:a="http://schemas.openxmlformats.org/drawingml/2006/main">
               <a:ext uri="{FF2B5EF4-FFF2-40B4-BE49-F238E27FC236}">
-                <a16:creationId xmlns:a16="http://schemas.microsoft.com/office/drawing/2014/main" id="{375DDE56-A61C-445D-8409-2C37E37EE7D1}"/>
+                <a16:creationId xmlns:a16="http://schemas.microsoft.com/office/drawing/2014/main" id="{5E2B78A3-D381-4454-BF3B-3F62F1A7DBB9}"/>
               </a:ext>
             </a:extLst>
           </p:cNvPr>
@@ -4592,7 +4592,7 @@
           <p:cNvPr id="5" name="f5">
             <a:extLst xmlns:a="http://schemas.openxmlformats.org/drawingml/2006/main">
               <a:ext uri="{FF2B5EF4-FFF2-40B4-BE49-F238E27FC236}">
-                <a16:creationId xmlns:a16="http://schemas.microsoft.com/office/drawing/2014/main" id="{70C5113F-1649-4C08-8775-269B8A40F09D}"/>
+                <a16:creationId xmlns:a16="http://schemas.microsoft.com/office/drawing/2014/main" id="{3150FE58-5A32-49AE-86AE-3D7D905BBE75}"/>
               </a:ext>
             </a:extLst>
           </p:cNvPr>
@@ -4751,7 +4751,7 @@
           <p:cNvPr id="6" name="f6">
             <a:extLst xmlns:a="http://schemas.openxmlformats.org/drawingml/2006/main">
               <a:ext uri="{FF2B5EF4-FFF2-40B4-BE49-F238E27FC236}">
-                <a16:creationId xmlns:a16="http://schemas.microsoft.com/office/drawing/2014/main" id="{517676F4-2F86-4D68-BCCD-F60153802C91}"/>
+                <a16:creationId xmlns:a16="http://schemas.microsoft.com/office/drawing/2014/main" id="{7DC8A13E-EE6A-4CEF-9AAD-50B1C6AAA20D}"/>
               </a:ext>
             </a:extLst>
           </p:cNvPr>
@@ -4910,7 +4910,7 @@
           <p:cNvPr id="7" name="f7">
             <a:extLst xmlns:a="http://schemas.openxmlformats.org/drawingml/2006/main">
               <a:ext uri="{FF2B5EF4-FFF2-40B4-BE49-F238E27FC236}">
-                <a16:creationId xmlns:a16="http://schemas.microsoft.com/office/drawing/2014/main" id="{544FB8D3-0E9F-4D83-8AC7-2B36676BF299}"/>
+                <a16:creationId xmlns:a16="http://schemas.microsoft.com/office/drawing/2014/main" id="{3E73BABC-EDA2-4830-AFA6-02DCB57D7286}"/>
               </a:ext>
             </a:extLst>
           </p:cNvPr>
@@ -5069,7 +5069,7 @@
           <p:cNvPr id="8" name="f8">
             <a:extLst xmlns:a="http://schemas.openxmlformats.org/drawingml/2006/main">
               <a:ext uri="{FF2B5EF4-FFF2-40B4-BE49-F238E27FC236}">
-                <a16:creationId xmlns:a16="http://schemas.microsoft.com/office/drawing/2014/main" id="{2F9A7DBC-690E-4812-B0FE-8B587A3F0F05}"/>
+                <a16:creationId xmlns:a16="http://schemas.microsoft.com/office/drawing/2014/main" id="{230346E9-89B4-4D49-B907-C8487E6EBD38}"/>
               </a:ext>
             </a:extLst>
           </p:cNvPr>
@@ -5228,7 +5228,7 @@
           <p:cNvPr id="9" name="f9">
             <a:extLst xmlns:a="http://schemas.openxmlformats.org/drawingml/2006/main">
               <a:ext uri="{FF2B5EF4-FFF2-40B4-BE49-F238E27FC236}">
-                <a16:creationId xmlns:a16="http://schemas.microsoft.com/office/drawing/2014/main" id="{8C4BFF19-E256-4503-838F-E628649EDBF4}"/>
+                <a16:creationId xmlns:a16="http://schemas.microsoft.com/office/drawing/2014/main" id="{B9DA4782-B4EE-40EB-92F3-D1C6E176AC0C}"/>
               </a:ext>
             </a:extLst>
           </p:cNvPr>
@@ -5387,7 +5387,7 @@
           <p:cNvPr id="10" name="f10">
             <a:extLst xmlns:a="http://schemas.openxmlformats.org/drawingml/2006/main">
               <a:ext uri="{FF2B5EF4-FFF2-40B4-BE49-F238E27FC236}">
-                <a16:creationId xmlns:a16="http://schemas.microsoft.com/office/drawing/2014/main" id="{E6E01563-97D9-4F65-8AE6-7A46BB74DB85}"/>
+                <a16:creationId xmlns:a16="http://schemas.microsoft.com/office/drawing/2014/main" id="{B454D1EA-CB46-456C-808F-5B3D8F4597B8}"/>
               </a:ext>
             </a:extLst>
           </p:cNvPr>
@@ -5546,7 +5546,7 @@
           <p:cNvPr id="11" name="f11">
             <a:extLst xmlns:a="http://schemas.openxmlformats.org/drawingml/2006/main">
               <a:ext uri="{FF2B5EF4-FFF2-40B4-BE49-F238E27FC236}">
-                <a16:creationId xmlns:a16="http://schemas.microsoft.com/office/drawing/2014/main" id="{5162F518-FDEE-4463-BA2C-F6A46C45927A}"/>
+                <a16:creationId xmlns:a16="http://schemas.microsoft.com/office/drawing/2014/main" id="{67718F60-B3E2-4FE4-8F1C-DA3DE84E3E67}"/>
               </a:ext>
             </a:extLst>
           </p:cNvPr>
@@ -5705,7 +5705,7 @@
           <p:cNvPr id="12" name="f12">
             <a:extLst xmlns:a="http://schemas.openxmlformats.org/drawingml/2006/main">
               <a:ext uri="{FF2B5EF4-FFF2-40B4-BE49-F238E27FC236}">
-                <a16:creationId xmlns:a16="http://schemas.microsoft.com/office/drawing/2014/main" id="{77323399-B60F-46C9-AE92-6845D6D418C8}"/>
+                <a16:creationId xmlns:a16="http://schemas.microsoft.com/office/drawing/2014/main" id="{71DFBB5A-16BA-4251-8596-EDE21B18FEA8}"/>
               </a:ext>
             </a:extLst>
           </p:cNvPr>
@@ -5864,7 +5864,7 @@
           <p:cNvPr id="13" name="f13">
             <a:extLst xmlns:a="http://schemas.openxmlformats.org/drawingml/2006/main">
               <a:ext uri="{FF2B5EF4-FFF2-40B4-BE49-F238E27FC236}">
-                <a16:creationId xmlns:a16="http://schemas.microsoft.com/office/drawing/2014/main" id="{93D23B5F-170B-40B9-A7A0-89D22951BEF2}"/>
+                <a16:creationId xmlns:a16="http://schemas.microsoft.com/office/drawing/2014/main" id="{514769DD-76B8-4298-B3A1-6F8DE16A8DCA}"/>
               </a:ext>
             </a:extLst>
           </p:cNvPr>
@@ -6023,7 +6023,7 @@
           <p:cNvPr id="14" name="f14">
             <a:extLst xmlns:a="http://schemas.openxmlformats.org/drawingml/2006/main">
               <a:ext uri="{FF2B5EF4-FFF2-40B4-BE49-F238E27FC236}">
-                <a16:creationId xmlns:a16="http://schemas.microsoft.com/office/drawing/2014/main" id="{2583CB11-DB60-4261-98F5-8DB2D9C58398}"/>
+                <a16:creationId xmlns:a16="http://schemas.microsoft.com/office/drawing/2014/main" id="{8E326E81-D27C-462A-8BF7-78A32AD19B6E}"/>
               </a:ext>
             </a:extLst>
           </p:cNvPr>
@@ -6182,7 +6182,7 @@
           <p:cNvPr id="15" name="f15">
             <a:extLst xmlns:a="http://schemas.openxmlformats.org/drawingml/2006/main">
               <a:ext uri="{FF2B5EF4-FFF2-40B4-BE49-F238E27FC236}">
-                <a16:creationId xmlns:a16="http://schemas.microsoft.com/office/drawing/2014/main" id="{AA11CFFD-2458-4E61-979B-8143CD17EE2E}"/>
+                <a16:creationId xmlns:a16="http://schemas.microsoft.com/office/drawing/2014/main" id="{E4D31AC5-7F1F-48CA-9947-25474E4A5CCE}"/>
               </a:ext>
             </a:extLst>
           </p:cNvPr>
@@ -6341,7 +6341,7 @@
           <p:cNvPr id="16" name="f16">
             <a:extLst xmlns:a="http://schemas.openxmlformats.org/drawingml/2006/main">
               <a:ext uri="{FF2B5EF4-FFF2-40B4-BE49-F238E27FC236}">
-                <a16:creationId xmlns:a16="http://schemas.microsoft.com/office/drawing/2014/main" id="{A9AE0CBD-5431-4863-A4DC-3A901BF96AE1}"/>
+                <a16:creationId xmlns:a16="http://schemas.microsoft.com/office/drawing/2014/main" id="{9BE88533-0DEB-4B47-8CE1-5FAB2AFA19C5}"/>
               </a:ext>
             </a:extLst>
           </p:cNvPr>
@@ -6500,7 +6500,7 @@
           <p:cNvPr id="17" name="f17">
             <a:extLst xmlns:a="http://schemas.openxmlformats.org/drawingml/2006/main">
               <a:ext uri="{FF2B5EF4-FFF2-40B4-BE49-F238E27FC236}">
-                <a16:creationId xmlns:a16="http://schemas.microsoft.com/office/drawing/2014/main" id="{B2D70A4A-FC99-493E-A11E-FAD49B056407}"/>
+                <a16:creationId xmlns:a16="http://schemas.microsoft.com/office/drawing/2014/main" id="{6C0DFD20-C3D4-4EBD-A214-F5E2D840E033}"/>
               </a:ext>
             </a:extLst>
           </p:cNvPr>
@@ -6659,7 +6659,7 @@
           <p:cNvPr id="18" name="f18">
             <a:extLst xmlns:a="http://schemas.openxmlformats.org/drawingml/2006/main">
               <a:ext uri="{FF2B5EF4-FFF2-40B4-BE49-F238E27FC236}">
-                <a16:creationId xmlns:a16="http://schemas.microsoft.com/office/drawing/2014/main" id="{126EB52B-C181-4ACE-8C44-51718BA0DAA7}"/>
+                <a16:creationId xmlns:a16="http://schemas.microsoft.com/office/drawing/2014/main" id="{6D722372-5245-4C38-B6D8-25C3891B95D2}"/>
               </a:ext>
             </a:extLst>
           </p:cNvPr>
@@ -6818,7 +6818,7 @@
           <p:cNvPr id="19" name="f19">
             <a:extLst xmlns:a="http://schemas.openxmlformats.org/drawingml/2006/main">
               <a:ext uri="{FF2B5EF4-FFF2-40B4-BE49-F238E27FC236}">
-                <a16:creationId xmlns:a16="http://schemas.microsoft.com/office/drawing/2014/main" id="{168C3727-6796-4423-AC61-04FF336037CB}"/>
+                <a16:creationId xmlns:a16="http://schemas.microsoft.com/office/drawing/2014/main" id="{B199EFDA-42D0-426C-8E8A-26EDE8CA59A8}"/>
               </a:ext>
             </a:extLst>
           </p:cNvPr>
@@ -6977,7 +6977,7 @@
           <p:cNvPr id="20" name="f20">
             <a:extLst xmlns:a="http://schemas.openxmlformats.org/drawingml/2006/main">
               <a:ext uri="{FF2B5EF4-FFF2-40B4-BE49-F238E27FC236}">
-                <a16:creationId xmlns:a16="http://schemas.microsoft.com/office/drawing/2014/main" id="{8D08D468-6E5A-4D96-AE0A-8BA89B98F8A0}"/>
+                <a16:creationId xmlns:a16="http://schemas.microsoft.com/office/drawing/2014/main" id="{D81B06AD-5025-45B0-9724-0F9A36D4704E}"/>
               </a:ext>
             </a:extLst>
           </p:cNvPr>
@@ -7134,7 +7134,7 @@
     </p:spTree>
     <p:extLst>
       <p:ext uri="{BB962C8B-B14F-4D97-AF65-F5344CB8AC3E}">
-        <p14:creationId xmlns:p14="http://schemas.microsoft.com/office/powerpoint/2010/main" val="1744321142"/>
+        <p14:creationId xmlns:p14="http://schemas.microsoft.com/office/powerpoint/2010/main" val="656116278"/>
       </p:ext>
     </p:extLst>
   </p:cSld>
@@ -7165,7 +7165,7 @@
           <p:cNvPr id="24" name="f21">
             <a:extLst xmlns:a="http://schemas.openxmlformats.org/drawingml/2006/main">
               <a:ext uri="{FF2B5EF4-FFF2-40B4-BE49-F238E27FC236}">
-                <a16:creationId xmlns:a16="http://schemas.microsoft.com/office/drawing/2014/main" id="{62570958-586B-49CE-AC66-D9FE9DA67AE3}"/>
+                <a16:creationId xmlns:a16="http://schemas.microsoft.com/office/drawing/2014/main" id="{EE4F07C7-2534-4DEC-84F7-332AB758DD07}"/>
               </a:ext>
             </a:extLst>
           </p:cNvPr>
@@ -7196,7 +7196,7 @@
             <a:defPPr algn="l">
               <a:defRPr sz="1500" b="0">
                 <a:solidFill>
-                  <a:srgbClr val="4264D0"/>
+                  <a:srgbClr val="52627B"/>
                 </a:solidFill>
                 <a:latin typeface="Nimbus Sans"/>
                 <a:ea typeface="Nimbus Sans"/>
@@ -7206,7 +7206,7 @@
             <a:lvl1pPr algn="l">
               <a:defRPr sz="1500" b="0">
                 <a:solidFill>
-                  <a:srgbClr val="4264D0"/>
+                  <a:srgbClr val="52627B"/>
                 </a:solidFill>
                 <a:latin typeface="Nimbus Sans"/>
                 <a:ea typeface="Nimbus Sans"/>
@@ -7216,7 +7216,7 @@
             <a:lvl2pPr algn="l">
               <a:defRPr sz="1500" b="0">
                 <a:solidFill>
-                  <a:srgbClr val="4264D0"/>
+                  <a:srgbClr val="52627B"/>
                 </a:solidFill>
                 <a:latin typeface="Nimbus Sans"/>
                 <a:ea typeface="Nimbus Sans"/>
@@ -7226,7 +7226,7 @@
             <a:lvl3pPr algn="l">
               <a:defRPr sz="1500" b="0">
                 <a:solidFill>
-                  <a:srgbClr val="4264D0"/>
+                  <a:srgbClr val="52627B"/>
                 </a:solidFill>
                 <a:latin typeface="Nimbus Sans"/>
                 <a:ea typeface="Nimbus Sans"/>
@@ -7236,7 +7236,7 @@
             <a:lvl4pPr algn="l">
               <a:defRPr sz="1500" b="0">
                 <a:solidFill>
-                  <a:srgbClr val="4264D0"/>
+                  <a:srgbClr val="52627B"/>
                 </a:solidFill>
                 <a:latin typeface="Nimbus Sans"/>
                 <a:ea typeface="Nimbus Sans"/>
@@ -7246,7 +7246,7 @@
             <a:lvl5pPr algn="l">
               <a:defRPr sz="1500" b="0">
                 <a:solidFill>
-                  <a:srgbClr val="4264D0"/>
+                  <a:srgbClr val="52627B"/>
                 </a:solidFill>
                 <a:latin typeface="Nimbus Sans"/>
                 <a:ea typeface="Nimbus Sans"/>
@@ -7256,7 +7256,7 @@
             <a:lvl6pPr algn="l">
               <a:defRPr sz="1500" b="0">
                 <a:solidFill>
-                  <a:srgbClr val="4264D0"/>
+                  <a:srgbClr val="52627B"/>
                 </a:solidFill>
                 <a:latin typeface="Nimbus Sans"/>
                 <a:ea typeface="Nimbus Sans"/>
@@ -7266,7 +7266,7 @@
             <a:lvl7pPr algn="l">
               <a:defRPr sz="1500" b="0">
                 <a:solidFill>
-                  <a:srgbClr val="4264D0"/>
+                  <a:srgbClr val="52627B"/>
                 </a:solidFill>
                 <a:latin typeface="Nimbus Sans"/>
                 <a:ea typeface="Nimbus Sans"/>
@@ -7276,7 +7276,7 @@
             <a:lvl8pPr algn="l">
               <a:defRPr sz="1500" b="0">
                 <a:solidFill>
-                  <a:srgbClr val="4264D0"/>
+                  <a:srgbClr val="52627B"/>
                 </a:solidFill>
                 <a:latin typeface="Nimbus Sans"/>
                 <a:ea typeface="Nimbus Sans"/>
@@ -7286,7 +7286,7 @@
             <a:lvl9pPr algn="l">
               <a:defRPr sz="1500" b="0">
                 <a:solidFill>
-                  <a:srgbClr val="4264D0"/>
+                  <a:srgbClr val="52627B"/>
                 </a:solidFill>
                 <a:latin typeface="Nimbus Sans"/>
                 <a:ea typeface="Nimbus Sans"/>
@@ -7298,7 +7298,7 @@
             <a:pPr algn="l">
               <a:defRPr sz="1500" b="0">
                 <a:solidFill>
-                  <a:srgbClr val="4264D0"/>
+                  <a:srgbClr val="52627B"/>
                 </a:solidFill>
                 <a:latin typeface="Nimbus Sans"/>
                 <a:ea typeface="Nimbus Sans"/>
@@ -7308,7 +7308,7 @@
             <a:r>
               <a:rPr sz="1500" b="0">
                 <a:solidFill>
-                  <a:srgbClr val="4264D0"/>
+                  <a:srgbClr val="52627B"/>
                 </a:solidFill>
                 <a:latin typeface="Nimbus Sans"/>
                 <a:ea typeface="Nimbus Sans"/>
@@ -7324,7 +7324,7 @@
           <p:cNvPr id="2" name="f22">
             <a:extLst xmlns:a="http://schemas.openxmlformats.org/drawingml/2006/main">
               <a:ext uri="{FF2B5EF4-FFF2-40B4-BE49-F238E27FC236}">
-                <a16:creationId xmlns:a16="http://schemas.microsoft.com/office/drawing/2014/main" id="{2A7D9506-8F4C-41F4-BC01-22FDC6491284}"/>
+                <a16:creationId xmlns:a16="http://schemas.microsoft.com/office/drawing/2014/main" id="{1B81CBB5-11A0-4A34-B33F-E9E38469EE57}"/>
               </a:ext>
             </a:extLst>
           </p:cNvPr>
@@ -7483,7 +7483,7 @@
           <p:cNvPr id="3" name="f23">
             <a:extLst xmlns:a="http://schemas.openxmlformats.org/drawingml/2006/main">
               <a:ext uri="{FF2B5EF4-FFF2-40B4-BE49-F238E27FC236}">
-                <a16:creationId xmlns:a16="http://schemas.microsoft.com/office/drawing/2014/main" id="{60AB98BD-4B1D-4427-A612-9BECFB6E65D3}"/>
+                <a16:creationId xmlns:a16="http://schemas.microsoft.com/office/drawing/2014/main" id="{C7F02DD1-CBD3-4CBE-89BE-143B21199990}"/>
               </a:ext>
             </a:extLst>
           </p:cNvPr>
@@ -7642,7 +7642,7 @@
           <p:cNvPr id="4" name="f24">
             <a:extLst xmlns:a="http://schemas.openxmlformats.org/drawingml/2006/main">
               <a:ext uri="{FF2B5EF4-FFF2-40B4-BE49-F238E27FC236}">
-                <a16:creationId xmlns:a16="http://schemas.microsoft.com/office/drawing/2014/main" id="{94A914AD-9E9F-4305-9EFD-89A4CD54F67E}"/>
+                <a16:creationId xmlns:a16="http://schemas.microsoft.com/office/drawing/2014/main" id="{1FABB5DB-BFA5-422A-978D-B80C3FBCC1B0}"/>
               </a:ext>
             </a:extLst>
           </p:cNvPr>
@@ -7654,7 +7654,7 @@
         <p:spPr>
           <a:xfrm xmlns:a="http://schemas.openxmlformats.org/drawingml/2006/main">
             <a:off x="1066800" y="2000250"/>
-            <a:ext cx="13106400" cy="438150"/>
+            <a:ext cx="13106400" cy="704850"/>
           </a:xfrm>
           <a:prstGeom xmlns:a="http://schemas.openxmlformats.org/drawingml/2006/main" prst="rect">
             <a:avLst/>
@@ -7791,7 +7791,30 @@
                 <a:ea typeface="Nimbus Sans"/>
                 <a:cs typeface="Nimbus Sans"/>
               </a:rPr>
-              <a:t>Definire un requisito non garantisce che il software lo rispetti.</a:t>
+              <a:t>Definire un requisito di sicurezza non garantisce</a:t>
+            </a:r>
+          </a:p>
+          <a:p xmlns:a="http://schemas.openxmlformats.org/drawingml/2006/main">
+            <a:pPr algn="l">
+              <a:defRPr sz="2025" b="0">
+                <a:solidFill>
+                  <a:srgbClr val="52627B"/>
+                </a:solidFill>
+                <a:latin typeface="Nimbus Sans"/>
+                <a:ea typeface="Nimbus Sans"/>
+                <a:cs typeface="Nimbus Sans"/>
+              </a:defRPr>
+            </a:pPr>
+            <a:r>
+              <a:rPr sz="2025" b="0">
+                <a:solidFill>
+                  <a:srgbClr val="52627B"/>
+                </a:solidFill>
+                <a:latin typeface="Nimbus Sans"/>
+                <a:ea typeface="Nimbus Sans"/>
+                <a:cs typeface="Nimbus Sans"/>
+              </a:rPr>
+              <a:t>che venga rispettato.</a:t>
             </a:r>
           </a:p>
         </p:txBody>
@@ -7801,7 +7824,7 @@
           <p:cNvPr id="5" name="f25">
             <a:extLst xmlns:a="http://schemas.openxmlformats.org/drawingml/2006/main">
               <a:ext uri="{FF2B5EF4-FFF2-40B4-BE49-F238E27FC236}">
-                <a16:creationId xmlns:a16="http://schemas.microsoft.com/office/drawing/2014/main" id="{62EACF9A-C57B-4FDA-B1FE-2EA240401595}"/>
+                <a16:creationId xmlns:a16="http://schemas.microsoft.com/office/drawing/2014/main" id="{ECB45CF5-FD6A-446E-80B7-F4DE4D345F38}"/>
               </a:ext>
             </a:extLst>
           </p:cNvPr>
@@ -7960,7 +7983,7 @@
           <p:cNvPr id="6" name="f26">
             <a:extLst xmlns:a="http://schemas.openxmlformats.org/drawingml/2006/main">
               <a:ext uri="{FF2B5EF4-FFF2-40B4-BE49-F238E27FC236}">
-                <a16:creationId xmlns:a16="http://schemas.microsoft.com/office/drawing/2014/main" id="{489BFE3A-6297-49CC-9E8B-3CC7D08E4527}"/>
+                <a16:creationId xmlns:a16="http://schemas.microsoft.com/office/drawing/2014/main" id="{8C047153-FC70-4E7C-8FD4-450175CCB875}"/>
               </a:ext>
             </a:extLst>
           </p:cNvPr>
@@ -8119,7 +8142,7 @@
           <p:cNvPr id="7" name="f27">
             <a:extLst xmlns:a="http://schemas.openxmlformats.org/drawingml/2006/main">
               <a:ext uri="{FF2B5EF4-FFF2-40B4-BE49-F238E27FC236}">
-                <a16:creationId xmlns:a16="http://schemas.microsoft.com/office/drawing/2014/main" id="{4574B24D-E1BC-4077-99C0-0CA5F409F155}"/>
+                <a16:creationId xmlns:a16="http://schemas.microsoft.com/office/drawing/2014/main" id="{3B30028B-CECE-41E3-AB3E-1D6767777716}"/>
               </a:ext>
             </a:extLst>
           </p:cNvPr>
@@ -8154,7 +8177,7 @@
           <p:cNvPr id="8" name="f28">
             <a:extLst xmlns:a="http://schemas.openxmlformats.org/drawingml/2006/main">
               <a:ext uri="{FF2B5EF4-FFF2-40B4-BE49-F238E27FC236}">
-                <a16:creationId xmlns:a16="http://schemas.microsoft.com/office/drawing/2014/main" id="{F7F46016-5E75-49CB-B3FE-6BC6B8C491DC}"/>
+                <a16:creationId xmlns:a16="http://schemas.microsoft.com/office/drawing/2014/main" id="{B651D717-EA02-4D25-9C10-184A823F19B4}"/>
               </a:ext>
             </a:extLst>
           </p:cNvPr>
@@ -8185,7 +8208,7 @@
           <p:cNvPr id="9" name="f29">
             <a:extLst xmlns:a="http://schemas.openxmlformats.org/drawingml/2006/main">
               <a:ext uri="{FF2B5EF4-FFF2-40B4-BE49-F238E27FC236}">
-                <a16:creationId xmlns:a16="http://schemas.microsoft.com/office/drawing/2014/main" id="{8B4F4516-2375-42FB-8045-089EB4CE7899}"/>
+                <a16:creationId xmlns:a16="http://schemas.microsoft.com/office/drawing/2014/main" id="{707171A7-CC45-40E2-B5C8-E061F0DFDA38}"/>
               </a:ext>
             </a:extLst>
           </p:cNvPr>
@@ -8216,7 +8239,7 @@
           <p:cNvPr id="10" name="f30">
             <a:extLst xmlns:a="http://schemas.openxmlformats.org/drawingml/2006/main">
               <a:ext uri="{FF2B5EF4-FFF2-40B4-BE49-F238E27FC236}">
-                <a16:creationId xmlns:a16="http://schemas.microsoft.com/office/drawing/2014/main" id="{08A53876-B2CA-42AB-A77D-8B4FDDB37115}"/>
+                <a16:creationId xmlns:a16="http://schemas.microsoft.com/office/drawing/2014/main" id="{6222371B-7084-4795-8174-548EEA63E3B3}"/>
               </a:ext>
             </a:extLst>
           </p:cNvPr>
@@ -8247,7 +8270,7 @@
           <p:cNvPr id="11" name="f31">
             <a:extLst xmlns:a="http://schemas.openxmlformats.org/drawingml/2006/main">
               <a:ext uri="{FF2B5EF4-FFF2-40B4-BE49-F238E27FC236}">
-                <a16:creationId xmlns:a16="http://schemas.microsoft.com/office/drawing/2014/main" id="{D68EFDFF-8C6C-4230-BFCF-73F0D42E1345}"/>
+                <a16:creationId xmlns:a16="http://schemas.microsoft.com/office/drawing/2014/main" id="{0AA83926-304D-4D87-96B8-C2AE8FB73C3D}"/>
               </a:ext>
             </a:extLst>
           </p:cNvPr>
@@ -8282,7 +8305,7 @@
           <p:cNvPr id="12" name="f32">
             <a:extLst xmlns:a="http://schemas.openxmlformats.org/drawingml/2006/main">
               <a:ext uri="{FF2B5EF4-FFF2-40B4-BE49-F238E27FC236}">
-                <a16:creationId xmlns:a16="http://schemas.microsoft.com/office/drawing/2014/main" id="{391A96F9-D2DD-400F-8F23-75AD2B92F673}"/>
+                <a16:creationId xmlns:a16="http://schemas.microsoft.com/office/drawing/2014/main" id="{C049790A-D613-41A6-BA80-02774A54BAE3}"/>
               </a:ext>
             </a:extLst>
           </p:cNvPr>
@@ -8313,7 +8336,7 @@
           <p:cNvPr id="13" name="f33">
             <a:extLst xmlns:a="http://schemas.openxmlformats.org/drawingml/2006/main">
               <a:ext uri="{FF2B5EF4-FFF2-40B4-BE49-F238E27FC236}">
-                <a16:creationId xmlns:a16="http://schemas.microsoft.com/office/drawing/2014/main" id="{EDE5CA66-8256-424F-8DAC-05E8460DFE61}"/>
+                <a16:creationId xmlns:a16="http://schemas.microsoft.com/office/drawing/2014/main" id="{A9247DF6-073F-475E-A694-09CEAB80B75A}"/>
               </a:ext>
             </a:extLst>
           </p:cNvPr>
@@ -8346,7 +8369,7 @@
           <p:cNvPr id="14" name="f34">
             <a:extLst xmlns:a="http://schemas.openxmlformats.org/drawingml/2006/main">
               <a:ext uri="{FF2B5EF4-FFF2-40B4-BE49-F238E27FC236}">
-                <a16:creationId xmlns:a16="http://schemas.microsoft.com/office/drawing/2014/main" id="{52632440-2C33-44D7-B92E-5942F7A10A17}"/>
+                <a16:creationId xmlns:a16="http://schemas.microsoft.com/office/drawing/2014/main" id="{86616814-FB75-4C92-960A-6F54597D67DF}"/>
               </a:ext>
             </a:extLst>
           </p:cNvPr>
@@ -8379,7 +8402,7 @@
           <p:cNvPr id="15" name="f35">
             <a:extLst xmlns:a="http://schemas.openxmlformats.org/drawingml/2006/main">
               <a:ext uri="{FF2B5EF4-FFF2-40B4-BE49-F238E27FC236}">
-                <a16:creationId xmlns:a16="http://schemas.microsoft.com/office/drawing/2014/main" id="{6C7DB64C-35A5-4704-AD66-E540BDC4675D}"/>
+                <a16:creationId xmlns:a16="http://schemas.microsoft.com/office/drawing/2014/main" id="{B8425C6B-BED0-41E8-9830-881F5C641680}"/>
               </a:ext>
             </a:extLst>
           </p:cNvPr>
@@ -8412,7 +8435,7 @@
           <p:cNvPr id="16" name="f36">
             <a:extLst xmlns:a="http://schemas.openxmlformats.org/drawingml/2006/main">
               <a:ext uri="{FF2B5EF4-FFF2-40B4-BE49-F238E27FC236}">
-                <a16:creationId xmlns:a16="http://schemas.microsoft.com/office/drawing/2014/main" id="{9F414B2A-5A93-45E2-AE5A-45B2F94E4B6F}"/>
+                <a16:creationId xmlns:a16="http://schemas.microsoft.com/office/drawing/2014/main" id="{86BACB30-64B9-4CB5-A554-E792E518D7B4}"/>
               </a:ext>
             </a:extLst>
           </p:cNvPr>
@@ -8571,7 +8594,7 @@
           <p:cNvPr id="17" name="f37">
             <a:extLst xmlns:a="http://schemas.openxmlformats.org/drawingml/2006/main">
               <a:ext uri="{FF2B5EF4-FFF2-40B4-BE49-F238E27FC236}">
-                <a16:creationId xmlns:a16="http://schemas.microsoft.com/office/drawing/2014/main" id="{1C52070E-AF6A-4F18-907C-CA4C7B98AE99}"/>
+                <a16:creationId xmlns:a16="http://schemas.microsoft.com/office/drawing/2014/main" id="{385596BE-6E4A-42CD-996B-2D030447A1FD}"/>
               </a:ext>
             </a:extLst>
           </p:cNvPr>
@@ -8602,7 +8625,7 @@
           <p:cNvPr id="18" name="f38">
             <a:extLst xmlns:a="http://schemas.openxmlformats.org/drawingml/2006/main">
               <a:ext uri="{FF2B5EF4-FFF2-40B4-BE49-F238E27FC236}">
-                <a16:creationId xmlns:a16="http://schemas.microsoft.com/office/drawing/2014/main" id="{FDC89246-E971-4A38-9609-50FF2DFA7C89}"/>
+                <a16:creationId xmlns:a16="http://schemas.microsoft.com/office/drawing/2014/main" id="{99EEB5F3-A0E4-4D05-885A-45B67A937DBA}"/>
               </a:ext>
             </a:extLst>
           </p:cNvPr>
@@ -8633,7 +8656,7 @@
           <p:cNvPr id="19" name="f39">
             <a:extLst xmlns:a="http://schemas.openxmlformats.org/drawingml/2006/main">
               <a:ext uri="{FF2B5EF4-FFF2-40B4-BE49-F238E27FC236}">
-                <a16:creationId xmlns:a16="http://schemas.microsoft.com/office/drawing/2014/main" id="{9270F574-5A2B-4DA2-8830-50A61AC612AB}"/>
+                <a16:creationId xmlns:a16="http://schemas.microsoft.com/office/drawing/2014/main" id="{93C89A8F-92E1-465C-80BE-229130C2BAEF}"/>
               </a:ext>
             </a:extLst>
           </p:cNvPr>
@@ -8668,7 +8691,7 @@
           <p:cNvPr id="20" name="f40">
             <a:extLst xmlns:a="http://schemas.openxmlformats.org/drawingml/2006/main">
               <a:ext uri="{FF2B5EF4-FFF2-40B4-BE49-F238E27FC236}">
-                <a16:creationId xmlns:a16="http://schemas.microsoft.com/office/drawing/2014/main" id="{C56D62E3-6A8C-402F-A76A-73AC4B05F679}"/>
+                <a16:creationId xmlns:a16="http://schemas.microsoft.com/office/drawing/2014/main" id="{2F19A0F2-0040-48F3-8084-3423B3BB6F43}"/>
               </a:ext>
             </a:extLst>
           </p:cNvPr>
@@ -8850,7 +8873,7 @@
           <p:cNvPr id="21" name="f41">
             <a:extLst xmlns:a="http://schemas.openxmlformats.org/drawingml/2006/main">
               <a:ext uri="{FF2B5EF4-FFF2-40B4-BE49-F238E27FC236}">
-                <a16:creationId xmlns:a16="http://schemas.microsoft.com/office/drawing/2014/main" id="{8F8801BB-EC7E-4E4E-954E-CF96CD0AACF7}"/>
+                <a16:creationId xmlns:a16="http://schemas.microsoft.com/office/drawing/2014/main" id="{4C6A8E9A-9FC0-454B-84BA-CD8EBF630B3E}"/>
               </a:ext>
             </a:extLst>
           </p:cNvPr>
@@ -9032,7 +9055,7 @@
           <p:cNvPr id="22" name="f42">
             <a:extLst xmlns:a="http://schemas.openxmlformats.org/drawingml/2006/main">
               <a:ext uri="{FF2B5EF4-FFF2-40B4-BE49-F238E27FC236}">
-                <a16:creationId xmlns:a16="http://schemas.microsoft.com/office/drawing/2014/main" id="{C93B46A9-9CFB-497B-A138-15387DF619E2}"/>
+                <a16:creationId xmlns:a16="http://schemas.microsoft.com/office/drawing/2014/main" id="{DB0779A4-76A9-4656-8CB7-C8C37EDA5E5F}"/>
               </a:ext>
             </a:extLst>
           </p:cNvPr>
@@ -9191,7 +9214,7 @@
           <p:cNvPr id="23" name="f43">
             <a:extLst xmlns:a="http://schemas.openxmlformats.org/drawingml/2006/main">
               <a:ext uri="{FF2B5EF4-FFF2-40B4-BE49-F238E27FC236}">
-                <a16:creationId xmlns:a16="http://schemas.microsoft.com/office/drawing/2014/main" id="{32A52FA9-65B0-425E-A8BF-C5EB7A81A32B}"/>
+                <a16:creationId xmlns:a16="http://schemas.microsoft.com/office/drawing/2014/main" id="{795C192E-8F8B-4ED6-B0BE-D09D06F269ED}"/>
               </a:ext>
             </a:extLst>
           </p:cNvPr>
@@ -9348,7 +9371,7 @@
     </p:spTree>
     <p:extLst>
       <p:ext uri="{BB962C8B-B14F-4D97-AF65-F5344CB8AC3E}">
-        <p14:creationId xmlns:p14="http://schemas.microsoft.com/office/powerpoint/2010/main" val="2063352064"/>
+        <p14:creationId xmlns:p14="http://schemas.microsoft.com/office/powerpoint/2010/main" val="984787665"/>
       </p:ext>
     </p:extLst>
   </p:cSld>
@@ -9379,7 +9402,7 @@
           <p:cNvPr id="24" name="">
             <a:extLst xmlns:a="http://schemas.openxmlformats.org/drawingml/2006/main">
               <a:ext uri="{FF2B5EF4-FFF2-40B4-BE49-F238E27FC236}">
-                <a16:creationId xmlns:a16="http://schemas.microsoft.com/office/drawing/2014/main" id="{2C4DB6D7-DE71-4861-92DB-CF6A79693E7E}"/>
+                <a16:creationId xmlns:a16="http://schemas.microsoft.com/office/drawing/2014/main" id="{AB0F512A-5E18-4BAC-BB50-34FAA2FCDEB6}"/>
               </a:ext>
             </a:extLst>
           </p:cNvPr>
@@ -9389,7 +9412,7 @@
           <p:nvPr/>
         </p:nvPicPr>
         <p:blipFill>
-          <a:blip xmlns:r="http://schemas.openxmlformats.org/officeDocument/2006/relationships" xmlns:a="http://schemas.openxmlformats.org/drawingml/2006/main" r:embed="Ra8e0551fe56e43f0"/>
+          <a:blip xmlns:r="http://schemas.openxmlformats.org/officeDocument/2006/relationships" xmlns:a="http://schemas.openxmlformats.org/drawingml/2006/main" r:embed="Rfa1b5a99505b4078"/>
           <a:stretch xmlns:a="http://schemas.openxmlformats.org/drawingml/2006/main"/>
         </p:blipFill>
         <p:spPr>
@@ -9407,7 +9430,7 @@
           <p:cNvPr id="2" name="f45">
             <a:extLst xmlns:a="http://schemas.openxmlformats.org/drawingml/2006/main">
               <a:ext uri="{FF2B5EF4-FFF2-40B4-BE49-F238E27FC236}">
-                <a16:creationId xmlns:a16="http://schemas.microsoft.com/office/drawing/2014/main" id="{7DEE054C-D21A-4FD2-A63B-0D1339E0F1C7}"/>
+                <a16:creationId xmlns:a16="http://schemas.microsoft.com/office/drawing/2014/main" id="{7BE0F338-B1A1-4A5A-AB1B-F84A73C5AE61}"/>
               </a:ext>
             </a:extLst>
           </p:cNvPr>
@@ -9566,7 +9589,7 @@
           <p:cNvPr id="3" name="f46">
             <a:extLst xmlns:a="http://schemas.openxmlformats.org/drawingml/2006/main">
               <a:ext uri="{FF2B5EF4-FFF2-40B4-BE49-F238E27FC236}">
-                <a16:creationId xmlns:a16="http://schemas.microsoft.com/office/drawing/2014/main" id="{9EA49102-D1D6-46A5-A87E-20637AACB8AA}"/>
+                <a16:creationId xmlns:a16="http://schemas.microsoft.com/office/drawing/2014/main" id="{148AA782-23A6-47FE-8D5F-1C6554B602C5}"/>
               </a:ext>
             </a:extLst>
           </p:cNvPr>
@@ -9725,7 +9748,7 @@
           <p:cNvPr id="4" name="f47">
             <a:extLst xmlns:a="http://schemas.openxmlformats.org/drawingml/2006/main">
               <a:ext uri="{FF2B5EF4-FFF2-40B4-BE49-F238E27FC236}">
-                <a16:creationId xmlns:a16="http://schemas.microsoft.com/office/drawing/2014/main" id="{7B484570-69BD-4257-A7CD-0C4C05B66B93}"/>
+                <a16:creationId xmlns:a16="http://schemas.microsoft.com/office/drawing/2014/main" id="{AE824E0E-864A-420E-B720-82FD1A629BDB}"/>
               </a:ext>
             </a:extLst>
           </p:cNvPr>
@@ -9737,7 +9760,7 @@
         <p:spPr>
           <a:xfrm xmlns:a="http://schemas.openxmlformats.org/drawingml/2006/main">
             <a:off x="1066800" y="1163765"/>
-            <a:ext cx="2631877" cy="694373"/>
+            <a:ext cx="7395418" cy="694373"/>
           </a:xfrm>
           <a:prstGeom xmlns:a="http://schemas.openxmlformats.org/drawingml/2006/main" prst="rect">
             <a:avLst/>
@@ -9874,7 +9897,7 @@
                 <a:ea typeface="Nimbus Sans"/>
                 <a:cs typeface="Nimbus Sans"/>
               </a:rPr>
-              <a:t>La rete 5G</a:t>
+              <a:t>La Security Assurance nel 5G</a:t>
             </a:r>
           </a:p>
         </p:txBody>
@@ -9884,7 +9907,7 @@
           <p:cNvPr id="5" name="f48">
             <a:extLst xmlns:a="http://schemas.openxmlformats.org/drawingml/2006/main">
               <a:ext uri="{FF2B5EF4-FFF2-40B4-BE49-F238E27FC236}">
-                <a16:creationId xmlns:a16="http://schemas.microsoft.com/office/drawing/2014/main" id="{D322E0FB-73B9-4A7D-9EA4-3029204AE5A8}"/>
+                <a16:creationId xmlns:a16="http://schemas.microsoft.com/office/drawing/2014/main" id="{7DB7494D-22A0-40DF-9016-BCEABD4111CC}"/>
               </a:ext>
             </a:extLst>
           </p:cNvPr>
@@ -9896,7 +9919,7 @@
         <p:spPr>
           <a:xfrm xmlns:a="http://schemas.openxmlformats.org/drawingml/2006/main">
             <a:off x="1066800" y="1901095"/>
-            <a:ext cx="7205811" cy="347186"/>
+            <a:ext cx="6726734" cy="347186"/>
           </a:xfrm>
           <a:prstGeom xmlns:a="http://schemas.openxmlformats.org/drawingml/2006/main" prst="rect">
             <a:avLst/>
@@ -10033,7 +10056,7 @@
                 <a:ea typeface="Nimbus Sans"/>
                 <a:cs typeface="Nimbus Sans"/>
               </a:rPr>
-              <a:t>Le NF cooperano tramite protocolli e procedure standardizzati.</a:t>
+              <a:t>Nel 5G, la sicurezza riguarda anche le Network Functions,</a:t>
             </a:r>
           </a:p>
         </p:txBody>
@@ -10043,7 +10066,7 @@
           <p:cNvPr id="6" name="f49">
             <a:extLst xmlns:a="http://schemas.openxmlformats.org/drawingml/2006/main">
               <a:ext uri="{FF2B5EF4-FFF2-40B4-BE49-F238E27FC236}">
-                <a16:creationId xmlns:a16="http://schemas.microsoft.com/office/drawing/2014/main" id="{F03F0AC6-51F3-4BE9-8C8D-839816C438CE}"/>
+                <a16:creationId xmlns:a16="http://schemas.microsoft.com/office/drawing/2014/main" id="{D29580B1-BCC9-4877-99D0-8EA176E17A3B}"/>
               </a:ext>
             </a:extLst>
           </p:cNvPr>
@@ -10055,7 +10078,7 @@
         <p:spPr>
           <a:xfrm xmlns:a="http://schemas.openxmlformats.org/drawingml/2006/main">
             <a:off x="1066800" y="2263045"/>
-            <a:ext cx="9847511" cy="347186"/>
+            <a:ext cx="5375225" cy="347186"/>
           </a:xfrm>
           <a:prstGeom xmlns:a="http://schemas.openxmlformats.org/drawingml/2006/main" prst="rect">
             <a:avLst/>
@@ -10192,7 +10215,7 @@
                 <a:ea typeface="Nimbus Sans"/>
                 <a:cs typeface="Nimbus Sans"/>
               </a:rPr>
-              <a:t>Per valutare i criteri di sicurezza occorre quindi valutare le funzioni e le loro interazioni</a:t>
+              <a:t>componenti software che comunicano tra loro.</a:t>
             </a:r>
           </a:p>
         </p:txBody>
@@ -10202,7 +10225,7 @@
           <p:cNvPr id="7" name="f50">
             <a:extLst xmlns:a="http://schemas.openxmlformats.org/drawingml/2006/main">
               <a:ext uri="{FF2B5EF4-FFF2-40B4-BE49-F238E27FC236}">
-                <a16:creationId xmlns:a16="http://schemas.microsoft.com/office/drawing/2014/main" id="{948C47F3-A0D7-44B2-B7AD-C25786BC16F1}"/>
+                <a16:creationId xmlns:a16="http://schemas.microsoft.com/office/drawing/2014/main" id="{E7444635-587D-409B-A44E-0096A36AE6C7}"/>
               </a:ext>
             </a:extLst>
           </p:cNvPr>
@@ -10361,7 +10384,7 @@
           <p:cNvPr id="8" name="f51">
             <a:extLst xmlns:a="http://schemas.openxmlformats.org/drawingml/2006/main">
               <a:ext uri="{FF2B5EF4-FFF2-40B4-BE49-F238E27FC236}">
-                <a16:creationId xmlns:a16="http://schemas.microsoft.com/office/drawing/2014/main" id="{283AA079-1097-4BB9-8B45-C5A6F637E035}"/>
+                <a16:creationId xmlns:a16="http://schemas.microsoft.com/office/drawing/2014/main" id="{2D4D9C5C-9AF0-43A9-8A52-095AECEE14DA}"/>
               </a:ext>
             </a:extLst>
           </p:cNvPr>
@@ -10520,7 +10543,7 @@
           <p:cNvPr id="9" name="f52">
             <a:extLst xmlns:a="http://schemas.openxmlformats.org/drawingml/2006/main">
               <a:ext uri="{FF2B5EF4-FFF2-40B4-BE49-F238E27FC236}">
-                <a16:creationId xmlns:a16="http://schemas.microsoft.com/office/drawing/2014/main" id="{351A331E-C140-4EBA-8C0E-360F1B571F9A}"/>
+                <a16:creationId xmlns:a16="http://schemas.microsoft.com/office/drawing/2014/main" id="{251892E8-9C2A-4B07-982E-DF25AE7E2561}"/>
               </a:ext>
             </a:extLst>
           </p:cNvPr>
@@ -10679,7 +10702,7 @@
           <p:cNvPr id="10" name="f53">
             <a:extLst xmlns:a="http://schemas.openxmlformats.org/drawingml/2006/main">
               <a:ext uri="{FF2B5EF4-FFF2-40B4-BE49-F238E27FC236}">
-                <a16:creationId xmlns:a16="http://schemas.microsoft.com/office/drawing/2014/main" id="{F6D09079-909B-456D-8814-5EF2F8F1E1F3}"/>
+                <a16:creationId xmlns:a16="http://schemas.microsoft.com/office/drawing/2014/main" id="{2A99C243-091A-46A0-B640-0F20D59F535B}"/>
               </a:ext>
             </a:extLst>
           </p:cNvPr>
@@ -10838,7 +10861,7 @@
           <p:cNvPr id="11" name="f54">
             <a:extLst xmlns:a="http://schemas.openxmlformats.org/drawingml/2006/main">
               <a:ext uri="{FF2B5EF4-FFF2-40B4-BE49-F238E27FC236}">
-                <a16:creationId xmlns:a16="http://schemas.microsoft.com/office/drawing/2014/main" id="{92D3FCBE-06F2-4C5D-A530-A42E0504F0A5}"/>
+                <a16:creationId xmlns:a16="http://schemas.microsoft.com/office/drawing/2014/main" id="{2C9E162A-EA22-4004-8636-4265920E1051}"/>
               </a:ext>
             </a:extLst>
           </p:cNvPr>
@@ -10997,7 +11020,7 @@
           <p:cNvPr id="12" name="f55">
             <a:extLst xmlns:a="http://schemas.openxmlformats.org/drawingml/2006/main">
               <a:ext uri="{FF2B5EF4-FFF2-40B4-BE49-F238E27FC236}">
-                <a16:creationId xmlns:a16="http://schemas.microsoft.com/office/drawing/2014/main" id="{AA86459E-F1A0-427E-916C-A3B4298A018A}"/>
+                <a16:creationId xmlns:a16="http://schemas.microsoft.com/office/drawing/2014/main" id="{B7FB1F67-134E-4B39-9035-7C11DA0B8228}"/>
               </a:ext>
             </a:extLst>
           </p:cNvPr>
@@ -11156,7 +11179,7 @@
           <p:cNvPr id="13" name="f56">
             <a:extLst xmlns:a="http://schemas.openxmlformats.org/drawingml/2006/main">
               <a:ext uri="{FF2B5EF4-FFF2-40B4-BE49-F238E27FC236}">
-                <a16:creationId xmlns:a16="http://schemas.microsoft.com/office/drawing/2014/main" id="{C5FCB904-A75F-485A-B59C-5BAD3A850B85}"/>
+                <a16:creationId xmlns:a16="http://schemas.microsoft.com/office/drawing/2014/main" id="{00A237A0-E777-4F86-87B9-301651356401}"/>
               </a:ext>
             </a:extLst>
           </p:cNvPr>
@@ -11315,7 +11338,7 @@
           <p:cNvPr id="14" name="f57">
             <a:extLst xmlns:a="http://schemas.openxmlformats.org/drawingml/2006/main">
               <a:ext uri="{FF2B5EF4-FFF2-40B4-BE49-F238E27FC236}">
-                <a16:creationId xmlns:a16="http://schemas.microsoft.com/office/drawing/2014/main" id="{BE5AF7C9-3C5D-42D0-86C7-4E0BF2098B43}"/>
+                <a16:creationId xmlns:a16="http://schemas.microsoft.com/office/drawing/2014/main" id="{51083CA8-F41C-4651-9C67-0843A90C04C1}"/>
               </a:ext>
             </a:extLst>
           </p:cNvPr>
@@ -11474,7 +11497,7 @@
           <p:cNvPr id="15" name="f58">
             <a:extLst xmlns:a="http://schemas.openxmlformats.org/drawingml/2006/main">
               <a:ext uri="{FF2B5EF4-FFF2-40B4-BE49-F238E27FC236}">
-                <a16:creationId xmlns:a16="http://schemas.microsoft.com/office/drawing/2014/main" id="{ED5CB014-FFAF-47A6-BAA4-FB9689BEAF34}"/>
+                <a16:creationId xmlns:a16="http://schemas.microsoft.com/office/drawing/2014/main" id="{213B8526-18FA-413A-8863-69B266763F28}"/>
               </a:ext>
             </a:extLst>
           </p:cNvPr>
@@ -11633,7 +11656,7 @@
           <p:cNvPr id="16" name="f59">
             <a:extLst xmlns:a="http://schemas.openxmlformats.org/drawingml/2006/main">
               <a:ext uri="{FF2B5EF4-FFF2-40B4-BE49-F238E27FC236}">
-                <a16:creationId xmlns:a16="http://schemas.microsoft.com/office/drawing/2014/main" id="{CFE5807F-3820-40EE-BFFE-700390D954C2}"/>
+                <a16:creationId xmlns:a16="http://schemas.microsoft.com/office/drawing/2014/main" id="{419C9AED-3A3B-45B2-A246-9A28EE2E01E5}"/>
               </a:ext>
             </a:extLst>
           </p:cNvPr>
@@ -11792,7 +11815,7 @@
           <p:cNvPr id="17" name="f60">
             <a:extLst xmlns:a="http://schemas.openxmlformats.org/drawingml/2006/main">
               <a:ext uri="{FF2B5EF4-FFF2-40B4-BE49-F238E27FC236}">
-                <a16:creationId xmlns:a16="http://schemas.microsoft.com/office/drawing/2014/main" id="{4E8953DA-2692-4957-AD4D-DD2C7195109E}"/>
+                <a16:creationId xmlns:a16="http://schemas.microsoft.com/office/drawing/2014/main" id="{E2761B7E-DB4E-43DA-BAA7-31D2E91ABA05}"/>
               </a:ext>
             </a:extLst>
           </p:cNvPr>
@@ -11951,7 +11974,7 @@
           <p:cNvPr id="18" name="f61">
             <a:extLst xmlns:a="http://schemas.openxmlformats.org/drawingml/2006/main">
               <a:ext uri="{FF2B5EF4-FFF2-40B4-BE49-F238E27FC236}">
-                <a16:creationId xmlns:a16="http://schemas.microsoft.com/office/drawing/2014/main" id="{34C61DA7-FDE8-4D55-885F-065894E3E90D}"/>
+                <a16:creationId xmlns:a16="http://schemas.microsoft.com/office/drawing/2014/main" id="{6A87CA0E-B6A5-497F-814D-83C8A92F1671}"/>
               </a:ext>
             </a:extLst>
           </p:cNvPr>
@@ -12110,7 +12133,7 @@
           <p:cNvPr id="19" name="f62">
             <a:extLst xmlns:a="http://schemas.openxmlformats.org/drawingml/2006/main">
               <a:ext uri="{FF2B5EF4-FFF2-40B4-BE49-F238E27FC236}">
-                <a16:creationId xmlns:a16="http://schemas.microsoft.com/office/drawing/2014/main" id="{B010F025-ACC8-4FAD-8D19-A9D246E61B38}"/>
+                <a16:creationId xmlns:a16="http://schemas.microsoft.com/office/drawing/2014/main" id="{90ACB01F-6B2B-4206-8B94-532802E3AEEA}"/>
               </a:ext>
             </a:extLst>
           </p:cNvPr>
@@ -12269,7 +12292,7 @@
           <p:cNvPr id="20" name="f63">
             <a:extLst xmlns:a="http://schemas.openxmlformats.org/drawingml/2006/main">
               <a:ext uri="{FF2B5EF4-FFF2-40B4-BE49-F238E27FC236}">
-                <a16:creationId xmlns:a16="http://schemas.microsoft.com/office/drawing/2014/main" id="{1501B4AD-D129-4162-A247-1D34F7DD4B78}"/>
+                <a16:creationId xmlns:a16="http://schemas.microsoft.com/office/drawing/2014/main" id="{ACD8190E-AAF9-4A81-952C-A56BD3EC8740}"/>
               </a:ext>
             </a:extLst>
           </p:cNvPr>
@@ -12428,7 +12451,7 @@
           <p:cNvPr id="21" name="f64">
             <a:extLst xmlns:a="http://schemas.openxmlformats.org/drawingml/2006/main">
               <a:ext uri="{FF2B5EF4-FFF2-40B4-BE49-F238E27FC236}">
-                <a16:creationId xmlns:a16="http://schemas.microsoft.com/office/drawing/2014/main" id="{CE87DE8C-57A5-4563-BF5F-636730F66967}"/>
+                <a16:creationId xmlns:a16="http://schemas.microsoft.com/office/drawing/2014/main" id="{16F835C2-9A98-48C0-A5DC-8EEF9BAB9ADB}"/>
               </a:ext>
             </a:extLst>
           </p:cNvPr>
@@ -12587,7 +12610,7 @@
           <p:cNvPr id="22" name="f65">
             <a:extLst xmlns:a="http://schemas.openxmlformats.org/drawingml/2006/main">
               <a:ext uri="{FF2B5EF4-FFF2-40B4-BE49-F238E27FC236}">
-                <a16:creationId xmlns:a16="http://schemas.microsoft.com/office/drawing/2014/main" id="{0964302F-17F8-4C62-ACC5-DE6AE8AA15C2}"/>
+                <a16:creationId xmlns:a16="http://schemas.microsoft.com/office/drawing/2014/main" id="{F733E88C-BB92-4110-97CE-06DD9AA5E501}"/>
               </a:ext>
             </a:extLst>
           </p:cNvPr>
@@ -12746,7 +12769,7 @@
           <p:cNvPr id="23" name="f66">
             <a:extLst xmlns:a="http://schemas.openxmlformats.org/drawingml/2006/main">
               <a:ext uri="{FF2B5EF4-FFF2-40B4-BE49-F238E27FC236}">
-                <a16:creationId xmlns:a16="http://schemas.microsoft.com/office/drawing/2014/main" id="{ED4880FF-DE58-4CB4-810D-39534E790385}"/>
+                <a16:creationId xmlns:a16="http://schemas.microsoft.com/office/drawing/2014/main" id="{CE558097-0493-4C58-8FE3-6A5408F7B34B}"/>
               </a:ext>
             </a:extLst>
           </p:cNvPr>
@@ -12903,7 +12926,7 @@
     </p:spTree>
     <p:extLst>
       <p:ext uri="{BB962C8B-B14F-4D97-AF65-F5344CB8AC3E}">
-        <p14:creationId xmlns:p14="http://schemas.microsoft.com/office/powerpoint/2010/main" val="113186871"/>
+        <p14:creationId xmlns:p14="http://schemas.microsoft.com/office/powerpoint/2010/main" val="1041079110"/>
       </p:ext>
     </p:extLst>
   </p:cSld>
@@ -12934,7 +12957,7 @@
           <p:cNvPr id="18" name="f67">
             <a:extLst xmlns:a="http://schemas.openxmlformats.org/drawingml/2006/main">
               <a:ext uri="{FF2B5EF4-FFF2-40B4-BE49-F238E27FC236}">
-                <a16:creationId xmlns:a16="http://schemas.microsoft.com/office/drawing/2014/main" id="{F682ED86-53DF-462C-A6F2-B840415A254C}"/>
+                <a16:creationId xmlns:a16="http://schemas.microsoft.com/office/drawing/2014/main" id="{882902BE-A316-467A-9FB0-13879BF73197}"/>
               </a:ext>
             </a:extLst>
           </p:cNvPr>
@@ -12965,7 +12988,7 @@
             <a:defPPr algn="l">
               <a:defRPr sz="1500" b="0">
                 <a:solidFill>
-                  <a:srgbClr val="4264D0"/>
+                  <a:srgbClr val="52627B"/>
                 </a:solidFill>
                 <a:latin typeface="Nimbus Sans"/>
                 <a:ea typeface="Nimbus Sans"/>
@@ -12975,7 +12998,7 @@
             <a:lvl1pPr algn="l">
               <a:defRPr sz="1500" b="0">
                 <a:solidFill>
-                  <a:srgbClr val="4264D0"/>
+                  <a:srgbClr val="52627B"/>
                 </a:solidFill>
                 <a:latin typeface="Nimbus Sans"/>
                 <a:ea typeface="Nimbus Sans"/>
@@ -12985,7 +13008,7 @@
             <a:lvl2pPr algn="l">
               <a:defRPr sz="1500" b="0">
                 <a:solidFill>
-                  <a:srgbClr val="4264D0"/>
+                  <a:srgbClr val="52627B"/>
                 </a:solidFill>
                 <a:latin typeface="Nimbus Sans"/>
                 <a:ea typeface="Nimbus Sans"/>
@@ -12995,7 +13018,7 @@
             <a:lvl3pPr algn="l">
               <a:defRPr sz="1500" b="0">
                 <a:solidFill>
-                  <a:srgbClr val="4264D0"/>
+                  <a:srgbClr val="52627B"/>
                 </a:solidFill>
                 <a:latin typeface="Nimbus Sans"/>
                 <a:ea typeface="Nimbus Sans"/>
@@ -13005,7 +13028,7 @@
             <a:lvl4pPr algn="l">
               <a:defRPr sz="1500" b="0">
                 <a:solidFill>
-                  <a:srgbClr val="4264D0"/>
+                  <a:srgbClr val="52627B"/>
                 </a:solidFill>
                 <a:latin typeface="Nimbus Sans"/>
                 <a:ea typeface="Nimbus Sans"/>
@@ -13015,7 +13038,7 @@
             <a:lvl5pPr algn="l">
               <a:defRPr sz="1500" b="0">
                 <a:solidFill>
-                  <a:srgbClr val="4264D0"/>
+                  <a:srgbClr val="52627B"/>
                 </a:solidFill>
                 <a:latin typeface="Nimbus Sans"/>
                 <a:ea typeface="Nimbus Sans"/>
@@ -13025,7 +13048,7 @@
             <a:lvl6pPr algn="l">
               <a:defRPr sz="1500" b="0">
                 <a:solidFill>
-                  <a:srgbClr val="4264D0"/>
+                  <a:srgbClr val="52627B"/>
                 </a:solidFill>
                 <a:latin typeface="Nimbus Sans"/>
                 <a:ea typeface="Nimbus Sans"/>
@@ -13035,7 +13058,7 @@
             <a:lvl7pPr algn="l">
               <a:defRPr sz="1500" b="0">
                 <a:solidFill>
-                  <a:srgbClr val="4264D0"/>
+                  <a:srgbClr val="52627B"/>
                 </a:solidFill>
                 <a:latin typeface="Nimbus Sans"/>
                 <a:ea typeface="Nimbus Sans"/>
@@ -13045,7 +13068,7 @@
             <a:lvl8pPr algn="l">
               <a:defRPr sz="1500" b="0">
                 <a:solidFill>
-                  <a:srgbClr val="4264D0"/>
+                  <a:srgbClr val="52627B"/>
                 </a:solidFill>
                 <a:latin typeface="Nimbus Sans"/>
                 <a:ea typeface="Nimbus Sans"/>
@@ -13055,7 +13078,7 @@
             <a:lvl9pPr algn="l">
               <a:defRPr sz="1500" b="0">
                 <a:solidFill>
-                  <a:srgbClr val="4264D0"/>
+                  <a:srgbClr val="52627B"/>
                 </a:solidFill>
                 <a:latin typeface="Nimbus Sans"/>
                 <a:ea typeface="Nimbus Sans"/>
@@ -13067,7 +13090,7 @@
             <a:pPr algn="l">
               <a:defRPr sz="1500" b="0">
                 <a:solidFill>
-                  <a:srgbClr val="4264D0"/>
+                  <a:srgbClr val="52627B"/>
                 </a:solidFill>
                 <a:latin typeface="Nimbus Sans"/>
                 <a:ea typeface="Nimbus Sans"/>
@@ -13077,13 +13100,13 @@
             <a:r>
               <a:rPr sz="1500" b="0">
                 <a:solidFill>
-                  <a:srgbClr val="4264D0"/>
+                  <a:srgbClr val="52627B"/>
                 </a:solidFill>
                 <a:latin typeface="Nimbus Sans"/>
                 <a:ea typeface="Nimbus Sans"/>
                 <a:cs typeface="Nimbus Sans"/>
               </a:rPr>
-              <a:t>1° CONTRIBUTO</a:t>
+              <a:t>CONTRIBUTI DELLA TESI</a:t>
             </a:r>
           </a:p>
         </p:txBody>
@@ -13093,7 +13116,7 @@
           <p:cNvPr id="2" name="f68">
             <a:extLst xmlns:a="http://schemas.openxmlformats.org/drawingml/2006/main">
               <a:ext uri="{FF2B5EF4-FFF2-40B4-BE49-F238E27FC236}">
-                <a16:creationId xmlns:a16="http://schemas.microsoft.com/office/drawing/2014/main" id="{5ACD5B2C-2D32-46A0-87F5-B9A539BE66F5}"/>
+                <a16:creationId xmlns:a16="http://schemas.microsoft.com/office/drawing/2014/main" id="{90C948FB-77FB-4F49-9B8B-A6A94DB350C8}"/>
               </a:ext>
             </a:extLst>
           </p:cNvPr>
@@ -13252,7 +13275,7 @@
           <p:cNvPr id="3" name="f69">
             <a:extLst xmlns:a="http://schemas.openxmlformats.org/drawingml/2006/main">
               <a:ext uri="{FF2B5EF4-FFF2-40B4-BE49-F238E27FC236}">
-                <a16:creationId xmlns:a16="http://schemas.microsoft.com/office/drawing/2014/main" id="{5B3B3CD2-8E00-4162-8223-0A55D9B84BB6}"/>
+                <a16:creationId xmlns:a16="http://schemas.microsoft.com/office/drawing/2014/main" id="{61A51454-21B0-4FE0-AD1F-EE46964CA83D}"/>
               </a:ext>
             </a:extLst>
           </p:cNvPr>
@@ -13408,10 +13431,10 @@
       </p:sp>
       <p:sp>
         <p:nvSpPr>
-          <p:cNvPr id="4" name="f70">
+          <p:cNvPr id="4" name="f72">
             <a:extLst xmlns:a="http://schemas.openxmlformats.org/drawingml/2006/main">
               <a:ext uri="{FF2B5EF4-FFF2-40B4-BE49-F238E27FC236}">
-                <a16:creationId xmlns:a16="http://schemas.microsoft.com/office/drawing/2014/main" id="{ABD488C5-CC21-4672-BC43-74A52DCBFE5D}"/>
+                <a16:creationId xmlns:a16="http://schemas.microsoft.com/office/drawing/2014/main" id="{BF5859FD-241F-4739-8380-1142F3FFE443}"/>
               </a:ext>
             </a:extLst>
           </p:cNvPr>
@@ -13423,7 +13446,7 @@
         <p:spPr>
           <a:xfrm xmlns:a="http://schemas.openxmlformats.org/drawingml/2006/main">
             <a:off x="1066800" y="2000250"/>
-            <a:ext cx="13106400" cy="438150"/>
+            <a:ext cx="13106400" cy="704850"/>
           </a:xfrm>
           <a:prstGeom xmlns:a="http://schemas.openxmlformats.org/drawingml/2006/main" prst="rect">
             <a:avLst/>
@@ -13560,17 +13583,40 @@
                 <a:ea typeface="Nimbus Sans"/>
                 <a:cs typeface="Nimbus Sans"/>
               </a:rPr>
-              <a:t>Un linguaggio per selezionare i messaggi e descrivere i criteri di verifica.</a:t>
+              <a:t>Il DSL permette di rappresentare queste operazioni</a:t>
+            </a:r>
+          </a:p>
+          <a:p xmlns:a="http://schemas.openxmlformats.org/drawingml/2006/main">
+            <a:pPr algn="l">
+              <a:defRPr sz="2025" b="0">
+                <a:solidFill>
+                  <a:srgbClr val="52627B"/>
+                </a:solidFill>
+                <a:latin typeface="Nimbus Sans"/>
+                <a:ea typeface="Nimbus Sans"/>
+                <a:cs typeface="Nimbus Sans"/>
+              </a:defRPr>
+            </a:pPr>
+            <a:r>
+              <a:rPr sz="2025" b="0">
+                <a:solidFill>
+                  <a:srgbClr val="52627B"/>
+                </a:solidFill>
+                <a:latin typeface="Nimbus Sans"/>
+                <a:ea typeface="Nimbus Sans"/>
+                <a:cs typeface="Nimbus Sans"/>
+              </a:rPr>
+              <a:t>attraverso regole riutilizzabili.</a:t>
             </a:r>
           </a:p>
         </p:txBody>
       </p:sp>
       <p:sp>
         <p:nvSpPr>
-          <p:cNvPr id="5" name="f103">
+          <p:cNvPr id="5" name="f105">
             <a:extLst xmlns:a="http://schemas.openxmlformats.org/drawingml/2006/main">
               <a:ext uri="{FF2B5EF4-FFF2-40B4-BE49-F238E27FC236}">
-                <a16:creationId xmlns:a16="http://schemas.microsoft.com/office/drawing/2014/main" id="{45A07D68-1995-4512-B38F-CAF620DF0480}"/>
+                <a16:creationId xmlns:a16="http://schemas.microsoft.com/office/drawing/2014/main" id="{6BE89582-A2F3-4ECA-9E67-8A3C2AD9246A}"/>
               </a:ext>
             </a:extLst>
           </p:cNvPr>
@@ -13726,10 +13772,10 @@
       </p:sp>
       <p:sp>
         <p:nvSpPr>
-          <p:cNvPr id="6" name="f104">
+          <p:cNvPr id="6" name="f106">
             <a:extLst xmlns:a="http://schemas.openxmlformats.org/drawingml/2006/main">
               <a:ext uri="{FF2B5EF4-FFF2-40B4-BE49-F238E27FC236}">
-                <a16:creationId xmlns:a16="http://schemas.microsoft.com/office/drawing/2014/main" id="{EF3C2E2F-E596-4E59-8CEB-72162625B8D2}"/>
+                <a16:creationId xmlns:a16="http://schemas.microsoft.com/office/drawing/2014/main" id="{F18789A4-E6B1-4B86-A42E-2F12A3D865FF}"/>
               </a:ext>
             </a:extLst>
           </p:cNvPr>
@@ -13740,12 +13786,12 @@
         </p:nvSpPr>
         <p:spPr>
           <a:xfrm xmlns:a="http://schemas.openxmlformats.org/drawingml/2006/main">
-            <a:off x="1066800" y="3381375"/>
-            <a:ext cx="7239000" cy="4276725"/>
+            <a:off x="1066800" y="4000500"/>
+            <a:ext cx="7239000" cy="3657600"/>
           </a:xfrm>
           <a:prstGeom xmlns:a="http://schemas.openxmlformats.org/drawingml/2006/main" prst="roundRect">
             <a:avLst>
-              <a:gd name="adj" fmla="val 3563"/>
+              <a:gd name="adj" fmla="val 4167"/>
             </a:avLst>
           </a:prstGeom>
           <a:solidFill xmlns:a="http://schemas.openxmlformats.org/drawingml/2006/main">
@@ -13761,10 +13807,10 @@
       </p:sp>
       <p:sp>
         <p:nvSpPr>
-          <p:cNvPr id="7" name="f105">
+          <p:cNvPr id="7" name="f107">
             <a:extLst xmlns:a="http://schemas.openxmlformats.org/drawingml/2006/main">
               <a:ext uri="{FF2B5EF4-FFF2-40B4-BE49-F238E27FC236}">
-                <a16:creationId xmlns:a16="http://schemas.microsoft.com/office/drawing/2014/main" id="{5D46CAC1-2FBA-4C4A-9666-E773AB73F963}"/>
+                <a16:creationId xmlns:a16="http://schemas.microsoft.com/office/drawing/2014/main" id="{09F1193A-D421-439F-A9F8-77481E968FBF}"/>
               </a:ext>
             </a:extLst>
           </p:cNvPr>
@@ -13920,10 +13966,10 @@
       </p:sp>
       <p:sp>
         <p:nvSpPr>
-          <p:cNvPr id="8" name="f106">
+          <p:cNvPr id="8" name="f108">
             <a:extLst xmlns:a="http://schemas.openxmlformats.org/drawingml/2006/main">
               <a:ext uri="{FF2B5EF4-FFF2-40B4-BE49-F238E27FC236}">
-                <a16:creationId xmlns:a16="http://schemas.microsoft.com/office/drawing/2014/main" id="{FDE863F6-60E0-42C9-B156-ED29985B84DA}"/>
+                <a16:creationId xmlns:a16="http://schemas.microsoft.com/office/drawing/2014/main" id="{5884D5A1-60EB-4766-B421-A7C590E87E4E}"/>
               </a:ext>
             </a:extLst>
           </p:cNvPr>
@@ -14102,10 +14148,10 @@
       </p:sp>
       <p:sp>
         <p:nvSpPr>
-          <p:cNvPr id="9" name="f107">
+          <p:cNvPr id="9" name="f109">
             <a:extLst xmlns:a="http://schemas.openxmlformats.org/drawingml/2006/main">
               <a:ext uri="{FF2B5EF4-FFF2-40B4-BE49-F238E27FC236}">
-                <a16:creationId xmlns:a16="http://schemas.microsoft.com/office/drawing/2014/main" id="{B368EC5F-B691-410F-A05D-F85D1D98075D}"/>
+                <a16:creationId xmlns:a16="http://schemas.microsoft.com/office/drawing/2014/main" id="{B8AD8DFE-551D-4918-A242-037C8E47AF72}"/>
               </a:ext>
             </a:extLst>
           </p:cNvPr>
@@ -14261,10 +14307,10 @@
       </p:sp>
       <p:sp>
         <p:nvSpPr>
-          <p:cNvPr id="10" name="f108">
+          <p:cNvPr id="10" name="f110">
             <a:extLst xmlns:a="http://schemas.openxmlformats.org/drawingml/2006/main">
               <a:ext uri="{FF2B5EF4-FFF2-40B4-BE49-F238E27FC236}">
-                <a16:creationId xmlns:a16="http://schemas.microsoft.com/office/drawing/2014/main" id="{2E65BE27-F92F-4F67-B7D4-B4A7DC7749F4}"/>
+                <a16:creationId xmlns:a16="http://schemas.microsoft.com/office/drawing/2014/main" id="{908B553A-1D33-4489-83D9-BD77FED71558}"/>
               </a:ext>
             </a:extLst>
           </p:cNvPr>
@@ -14420,10 +14466,10 @@
       </p:sp>
       <p:sp>
         <p:nvSpPr>
-          <p:cNvPr id="11" name="f109">
+          <p:cNvPr id="11" name="f111">
             <a:extLst xmlns:a="http://schemas.openxmlformats.org/drawingml/2006/main">
               <a:ext uri="{FF2B5EF4-FFF2-40B4-BE49-F238E27FC236}">
-                <a16:creationId xmlns:a16="http://schemas.microsoft.com/office/drawing/2014/main" id="{AE367173-51D4-4DCC-94C7-7C016E8AF642}"/>
+                <a16:creationId xmlns:a16="http://schemas.microsoft.com/office/drawing/2014/main" id="{88513D94-9A56-41A8-A97F-E3ECB8562AF5}"/>
               </a:ext>
             </a:extLst>
           </p:cNvPr>
@@ -14451,10 +14497,10 @@
       </p:sp>
       <p:sp>
         <p:nvSpPr>
-          <p:cNvPr id="12" name="f110">
+          <p:cNvPr id="12" name="f112">
             <a:extLst xmlns:a="http://schemas.openxmlformats.org/drawingml/2006/main">
               <a:ext uri="{FF2B5EF4-FFF2-40B4-BE49-F238E27FC236}">
-                <a16:creationId xmlns:a16="http://schemas.microsoft.com/office/drawing/2014/main" id="{699CD188-704D-49D4-BDE4-58F917B3D825}"/>
+                <a16:creationId xmlns:a16="http://schemas.microsoft.com/office/drawing/2014/main" id="{C065348A-C38F-4E6C-98B3-4D3194C62A5A}"/>
               </a:ext>
             </a:extLst>
           </p:cNvPr>
@@ -14482,10 +14528,10 @@
       </p:sp>
       <p:sp>
         <p:nvSpPr>
-          <p:cNvPr id="13" name="f111">
+          <p:cNvPr id="13" name="f113">
             <a:extLst xmlns:a="http://schemas.openxmlformats.org/drawingml/2006/main">
               <a:ext uri="{FF2B5EF4-FFF2-40B4-BE49-F238E27FC236}">
-                <a16:creationId xmlns:a16="http://schemas.microsoft.com/office/drawing/2014/main" id="{8A9A31D8-216E-45F9-9E26-72F107FC0507}"/>
+                <a16:creationId xmlns:a16="http://schemas.microsoft.com/office/drawing/2014/main" id="{8DBCFD10-35FE-4784-A351-4F8B3F391501}"/>
               </a:ext>
             </a:extLst>
           </p:cNvPr>
@@ -14641,10 +14687,10 @@
       </p:sp>
       <p:sp>
         <p:nvSpPr>
-          <p:cNvPr id="14" name="f112">
+          <p:cNvPr id="14" name="f114">
             <a:extLst xmlns:a="http://schemas.openxmlformats.org/drawingml/2006/main">
               <a:ext uri="{FF2B5EF4-FFF2-40B4-BE49-F238E27FC236}">
-                <a16:creationId xmlns:a16="http://schemas.microsoft.com/office/drawing/2014/main" id="{C30B618D-6C27-4A48-9E38-01AE8C65BC2F}"/>
+                <a16:creationId xmlns:a16="http://schemas.microsoft.com/office/drawing/2014/main" id="{800FCF7F-25FB-4155-8C55-D2951BF4EEB6}"/>
               </a:ext>
             </a:extLst>
           </p:cNvPr>
@@ -14676,10 +14722,10 @@
       </p:sp>
       <p:sp>
         <p:nvSpPr>
-          <p:cNvPr id="15" name="f113">
+          <p:cNvPr id="15" name="f115">
             <a:extLst xmlns:a="http://schemas.openxmlformats.org/drawingml/2006/main">
               <a:ext uri="{FF2B5EF4-FFF2-40B4-BE49-F238E27FC236}">
-                <a16:creationId xmlns:a16="http://schemas.microsoft.com/office/drawing/2014/main" id="{1A2D487D-0EFD-48F8-BCC7-250674341B92}"/>
+                <a16:creationId xmlns:a16="http://schemas.microsoft.com/office/drawing/2014/main" id="{756F99DC-8BD5-4847-86E7-4DE0D2D9DFF2}"/>
               </a:ext>
             </a:extLst>
           </p:cNvPr>
@@ -14858,10 +14904,10 @@
       </p:sp>
       <p:sp>
         <p:nvSpPr>
-          <p:cNvPr id="16" name="f114">
+          <p:cNvPr id="16" name="f116">
             <a:extLst xmlns:a="http://schemas.openxmlformats.org/drawingml/2006/main">
               <a:ext uri="{FF2B5EF4-FFF2-40B4-BE49-F238E27FC236}">
-                <a16:creationId xmlns:a16="http://schemas.microsoft.com/office/drawing/2014/main" id="{8BBB4C04-98D3-4E57-AB01-B825422B8BEB}"/>
+                <a16:creationId xmlns:a16="http://schemas.microsoft.com/office/drawing/2014/main" id="{8D2C59A9-5575-4C9F-8BA5-D0E3171210DE}"/>
               </a:ext>
             </a:extLst>
           </p:cNvPr>
@@ -14893,10 +14939,10 @@
       </p:sp>
       <p:sp>
         <p:nvSpPr>
-          <p:cNvPr id="17" name="f115">
+          <p:cNvPr id="17" name="f117">
             <a:extLst xmlns:a="http://schemas.openxmlformats.org/drawingml/2006/main">
               <a:ext uri="{FF2B5EF4-FFF2-40B4-BE49-F238E27FC236}">
-                <a16:creationId xmlns:a16="http://schemas.microsoft.com/office/drawing/2014/main" id="{0295BD96-CE92-40B5-B5AE-A44D904AF6DA}"/>
+                <a16:creationId xmlns:a16="http://schemas.microsoft.com/office/drawing/2014/main" id="{F6095C47-8CBE-4A13-AB88-3C5C4480DAF9}"/>
               </a:ext>
             </a:extLst>
           </p:cNvPr>
@@ -15076,7 +15122,7 @@
     </p:spTree>
     <p:extLst>
       <p:ext uri="{BB962C8B-B14F-4D97-AF65-F5344CB8AC3E}">
-        <p14:creationId xmlns:p14="http://schemas.microsoft.com/office/powerpoint/2010/main" val="691460266"/>
+        <p14:creationId xmlns:p14="http://schemas.microsoft.com/office/powerpoint/2010/main" val="296700713"/>
       </p:ext>
     </p:extLst>
   </p:cSld>
@@ -15107,7 +15153,7 @@
           <p:cNvPr id="15" name="">
             <a:extLst xmlns:a="http://schemas.openxmlformats.org/drawingml/2006/main">
               <a:ext uri="{FF2B5EF4-FFF2-40B4-BE49-F238E27FC236}">
-                <a16:creationId xmlns:a16="http://schemas.microsoft.com/office/drawing/2014/main" id="{D4FD475B-A86A-432B-9BEB-0A1BE2641D01}"/>
+                <a16:creationId xmlns:a16="http://schemas.microsoft.com/office/drawing/2014/main" id="{2AD534DC-4080-4EE4-B65B-8D7992C1FA74}"/>
               </a:ext>
             </a:extLst>
           </p:cNvPr>
@@ -15117,7 +15163,7 @@
           <p:nvPr/>
         </p:nvPicPr>
         <p:blipFill>
-          <a:blip xmlns:r="http://schemas.openxmlformats.org/officeDocument/2006/relationships" xmlns:a="http://schemas.openxmlformats.org/drawingml/2006/main" r:embed="Rf4b37f7578494f9b"/>
+          <a:blip xmlns:r="http://schemas.openxmlformats.org/officeDocument/2006/relationships" xmlns:a="http://schemas.openxmlformats.org/drawingml/2006/main" r:embed="R8c1d0e4330e54982"/>
           <a:stretch xmlns:a="http://schemas.openxmlformats.org/drawingml/2006/main"/>
         </p:blipFill>
         <p:spPr>
@@ -15132,10 +15178,10 @@
       </p:pic>
       <p:sp>
         <p:nvSpPr>
-          <p:cNvPr id="2" name="f117">
+          <p:cNvPr id="2" name="f119">
             <a:extLst xmlns:a="http://schemas.openxmlformats.org/drawingml/2006/main">
               <a:ext uri="{FF2B5EF4-FFF2-40B4-BE49-F238E27FC236}">
-                <a16:creationId xmlns:a16="http://schemas.microsoft.com/office/drawing/2014/main" id="{29DE5338-FC68-4CB0-9D22-A2388A7F367F}"/>
+                <a16:creationId xmlns:a16="http://schemas.microsoft.com/office/drawing/2014/main" id="{B5CF18BE-24AA-4662-A6F0-190DF52E184D}"/>
               </a:ext>
             </a:extLst>
           </p:cNvPr>
@@ -15146,8 +15192,8 @@
         </p:nvSpPr>
         <p:spPr>
           <a:xfrm xmlns:a="http://schemas.openxmlformats.org/drawingml/2006/main">
-            <a:off x="1066800" y="733997"/>
-            <a:ext cx="1440210" cy="231458"/>
+            <a:off x="1066800" y="718185"/>
+            <a:ext cx="2385417" cy="257175"/>
           </a:xfrm>
           <a:prstGeom xmlns:a="http://schemas.openxmlformats.org/drawingml/2006/main" prst="rect">
             <a:avLst/>
@@ -15164,7 +15210,7 @@
           </a:bodyPr>
           <a:lstStyle xmlns:a="http://schemas.openxmlformats.org/drawingml/2006/main">
             <a:defPPr algn="l">
-              <a:defRPr sz="1350" b="0">
+              <a:defRPr sz="1500" b="0">
                 <a:solidFill>
                   <a:srgbClr val="52627B"/>
                 </a:solidFill>
@@ -15174,7 +15220,7 @@
               </a:defRPr>
             </a:defPPr>
             <a:lvl1pPr algn="l">
-              <a:defRPr sz="1350" b="0">
+              <a:defRPr sz="1500" b="0">
                 <a:solidFill>
                   <a:srgbClr val="52627B"/>
                 </a:solidFill>
@@ -15184,7 +15230,7 @@
               </a:defRPr>
             </a:lvl1pPr>
             <a:lvl2pPr algn="l">
-              <a:defRPr sz="1350" b="0">
+              <a:defRPr sz="1500" b="0">
                 <a:solidFill>
                   <a:srgbClr val="52627B"/>
                 </a:solidFill>
@@ -15194,7 +15240,7 @@
               </a:defRPr>
             </a:lvl2pPr>
             <a:lvl3pPr algn="l">
-              <a:defRPr sz="1350" b="0">
+              <a:defRPr sz="1500" b="0">
                 <a:solidFill>
                   <a:srgbClr val="52627B"/>
                 </a:solidFill>
@@ -15204,7 +15250,7 @@
               </a:defRPr>
             </a:lvl3pPr>
             <a:lvl4pPr algn="l">
-              <a:defRPr sz="1350" b="0">
+              <a:defRPr sz="1500" b="0">
                 <a:solidFill>
                   <a:srgbClr val="52627B"/>
                 </a:solidFill>
@@ -15214,7 +15260,7 @@
               </a:defRPr>
             </a:lvl4pPr>
             <a:lvl5pPr algn="l">
-              <a:defRPr sz="1350" b="0">
+              <a:defRPr sz="1500" b="0">
                 <a:solidFill>
                   <a:srgbClr val="52627B"/>
                 </a:solidFill>
@@ -15224,7 +15270,7 @@
               </a:defRPr>
             </a:lvl5pPr>
             <a:lvl6pPr algn="l">
-              <a:defRPr sz="1350" b="0">
+              <a:defRPr sz="1500" b="0">
                 <a:solidFill>
                   <a:srgbClr val="52627B"/>
                 </a:solidFill>
@@ -15234,7 +15280,7 @@
               </a:defRPr>
             </a:lvl6pPr>
             <a:lvl7pPr algn="l">
-              <a:defRPr sz="1350" b="0">
+              <a:defRPr sz="1500" b="0">
                 <a:solidFill>
                   <a:srgbClr val="52627B"/>
                 </a:solidFill>
@@ -15244,7 +15290,7 @@
               </a:defRPr>
             </a:lvl7pPr>
             <a:lvl8pPr algn="l">
-              <a:defRPr sz="1350" b="0">
+              <a:defRPr sz="1500" b="0">
                 <a:solidFill>
                   <a:srgbClr val="52627B"/>
                 </a:solidFill>
@@ -15254,7 +15300,7 @@
               </a:defRPr>
             </a:lvl8pPr>
             <a:lvl9pPr algn="l">
-              <a:defRPr sz="1350" b="0">
+              <a:defRPr sz="1500" b="0">
                 <a:solidFill>
                   <a:srgbClr val="52627B"/>
                 </a:solidFill>
@@ -15266,7 +15312,7 @@
           </a:lstStyle>
           <a:p xmlns:a="http://schemas.openxmlformats.org/drawingml/2006/main">
             <a:pPr algn="l">
-              <a:defRPr sz="1350" b="0">
+              <a:defRPr sz="1500" b="0">
                 <a:solidFill>
                   <a:srgbClr val="52627B"/>
                 </a:solidFill>
@@ -15276,7 +15322,7 @@
               </a:defRPr>
             </a:pPr>
             <a:r>
-              <a:rPr sz="1350" b="0">
+              <a:rPr sz="1500" b="0">
                 <a:solidFill>
                   <a:srgbClr val="52627B"/>
                 </a:solidFill>
@@ -15284,17 +15330,17 @@
                 <a:ea typeface="Nimbus Sans"/>
                 <a:cs typeface="Nimbus Sans"/>
               </a:rPr>
-              <a:t>2° CONTRIBUTO</a:t>
+              <a:t>CONTRIBUTI DELLA TESI</a:t>
             </a:r>
           </a:p>
         </p:txBody>
       </p:sp>
       <p:sp>
         <p:nvSpPr>
-          <p:cNvPr id="3" name="f118">
+          <p:cNvPr id="3" name="f120">
             <a:extLst xmlns:a="http://schemas.openxmlformats.org/drawingml/2006/main">
               <a:ext uri="{FF2B5EF4-FFF2-40B4-BE49-F238E27FC236}">
-                <a16:creationId xmlns:a16="http://schemas.microsoft.com/office/drawing/2014/main" id="{7975B12F-C1C0-4634-87FD-062B57E0C00B}"/>
+                <a16:creationId xmlns:a16="http://schemas.microsoft.com/office/drawing/2014/main" id="{013FDCB5-4C5C-4E0C-86F2-23F2D8E177FA}"/>
               </a:ext>
             </a:extLst>
           </p:cNvPr>
@@ -15450,10 +15496,10 @@
       </p:sp>
       <p:sp>
         <p:nvSpPr>
-          <p:cNvPr id="4" name="f119">
+          <p:cNvPr id="4" name="f121">
             <a:extLst xmlns:a="http://schemas.openxmlformats.org/drawingml/2006/main">
               <a:ext uri="{FF2B5EF4-FFF2-40B4-BE49-F238E27FC236}">
-                <a16:creationId xmlns:a16="http://schemas.microsoft.com/office/drawing/2014/main" id="{036D022E-245C-40D1-A8F1-37315D31B5B1}"/>
+                <a16:creationId xmlns:a16="http://schemas.microsoft.com/office/drawing/2014/main" id="{9C2EB078-F21B-4BE9-8E83-423DE59E311B}"/>
               </a:ext>
             </a:extLst>
           </p:cNvPr>
@@ -15609,10 +15655,10 @@
       </p:sp>
       <p:sp>
         <p:nvSpPr>
-          <p:cNvPr id="5" name="f120">
+          <p:cNvPr id="5" name="f122">
             <a:extLst xmlns:a="http://schemas.openxmlformats.org/drawingml/2006/main">
               <a:ext uri="{FF2B5EF4-FFF2-40B4-BE49-F238E27FC236}">
-                <a16:creationId xmlns:a16="http://schemas.microsoft.com/office/drawing/2014/main" id="{96F52C9A-E7E3-4654-A5BD-31394727A6FD}"/>
+                <a16:creationId xmlns:a16="http://schemas.microsoft.com/office/drawing/2014/main" id="{3637A451-F6AD-46C8-A435-66CFCBCC0839}"/>
               </a:ext>
             </a:extLst>
           </p:cNvPr>
@@ -15768,10 +15814,10 @@
       </p:sp>
       <p:sp>
         <p:nvSpPr>
-          <p:cNvPr id="6" name="f121">
+          <p:cNvPr id="6" name="f123">
             <a:extLst xmlns:a="http://schemas.openxmlformats.org/drawingml/2006/main">
               <a:ext uri="{FF2B5EF4-FFF2-40B4-BE49-F238E27FC236}">
-                <a16:creationId xmlns:a16="http://schemas.microsoft.com/office/drawing/2014/main" id="{C2D3866C-9DFF-4A45-B6B3-6AF2F6762890}"/>
+                <a16:creationId xmlns:a16="http://schemas.microsoft.com/office/drawing/2014/main" id="{EC1A7182-5A61-43E6-A34B-D3B9956CCB6B}"/>
               </a:ext>
             </a:extLst>
           </p:cNvPr>
@@ -15927,10 +15973,10 @@
       </p:sp>
       <p:sp>
         <p:nvSpPr>
-          <p:cNvPr id="7" name="f122">
+          <p:cNvPr id="7" name="f124">
             <a:extLst xmlns:a="http://schemas.openxmlformats.org/drawingml/2006/main">
               <a:ext uri="{FF2B5EF4-FFF2-40B4-BE49-F238E27FC236}">
-                <a16:creationId xmlns:a16="http://schemas.microsoft.com/office/drawing/2014/main" id="{79C76C10-DB88-4AF7-9917-340CC3FFA2FD}"/>
+                <a16:creationId xmlns:a16="http://schemas.microsoft.com/office/drawing/2014/main" id="{576B5B23-61BC-416D-BF2E-79CBDB3292A6}"/>
               </a:ext>
             </a:extLst>
           </p:cNvPr>
@@ -16086,10 +16132,10 @@
       </p:sp>
       <p:sp>
         <p:nvSpPr>
-          <p:cNvPr id="8" name="f123">
+          <p:cNvPr id="8" name="f125">
             <a:extLst xmlns:a="http://schemas.openxmlformats.org/drawingml/2006/main">
               <a:ext uri="{FF2B5EF4-FFF2-40B4-BE49-F238E27FC236}">
-                <a16:creationId xmlns:a16="http://schemas.microsoft.com/office/drawing/2014/main" id="{0BD4A42B-3083-4F55-8CCE-32A18F537BBC}"/>
+                <a16:creationId xmlns:a16="http://schemas.microsoft.com/office/drawing/2014/main" id="{DD0AA4A9-A3C3-4D1D-A513-A44CC880C7B1}"/>
               </a:ext>
             </a:extLst>
           </p:cNvPr>
@@ -16245,10 +16291,10 @@
       </p:sp>
       <p:sp>
         <p:nvSpPr>
-          <p:cNvPr id="9" name="f124">
+          <p:cNvPr id="9" name="f126">
             <a:extLst xmlns:a="http://schemas.openxmlformats.org/drawingml/2006/main">
               <a:ext uri="{FF2B5EF4-FFF2-40B4-BE49-F238E27FC236}">
-                <a16:creationId xmlns:a16="http://schemas.microsoft.com/office/drawing/2014/main" id="{C3CEF9D9-851E-4BA9-AD44-741F1E365008}"/>
+                <a16:creationId xmlns:a16="http://schemas.microsoft.com/office/drawing/2014/main" id="{082726BC-A7FC-4D2A-BD6B-480FA420C16C}"/>
               </a:ext>
             </a:extLst>
           </p:cNvPr>
@@ -16404,10 +16450,10 @@
       </p:sp>
       <p:sp>
         <p:nvSpPr>
-          <p:cNvPr id="10" name="f125">
+          <p:cNvPr id="10" name="f127">
             <a:extLst xmlns:a="http://schemas.openxmlformats.org/drawingml/2006/main">
               <a:ext uri="{FF2B5EF4-FFF2-40B4-BE49-F238E27FC236}">
-                <a16:creationId xmlns:a16="http://schemas.microsoft.com/office/drawing/2014/main" id="{43EC270E-BA95-4D19-8CF3-2CF143D711ED}"/>
+                <a16:creationId xmlns:a16="http://schemas.microsoft.com/office/drawing/2014/main" id="{DFB7656D-1D0F-4655-A7AA-C81FD1ED4349}"/>
               </a:ext>
             </a:extLst>
           </p:cNvPr>
@@ -16563,10 +16609,10 @@
       </p:sp>
       <p:sp>
         <p:nvSpPr>
-          <p:cNvPr id="11" name="f126">
+          <p:cNvPr id="11" name="f128">
             <a:extLst xmlns:a="http://schemas.openxmlformats.org/drawingml/2006/main">
               <a:ext uri="{FF2B5EF4-FFF2-40B4-BE49-F238E27FC236}">
-                <a16:creationId xmlns:a16="http://schemas.microsoft.com/office/drawing/2014/main" id="{E06DAF17-599D-47BD-8DC9-150FC5EC3A58}"/>
+                <a16:creationId xmlns:a16="http://schemas.microsoft.com/office/drawing/2014/main" id="{4CF3EC47-A759-417A-87C4-2D91138F759A}"/>
               </a:ext>
             </a:extLst>
           </p:cNvPr>
@@ -16722,10 +16768,10 @@
       </p:sp>
       <p:sp>
         <p:nvSpPr>
-          <p:cNvPr id="12" name="f127">
+          <p:cNvPr id="12" name="f129">
             <a:extLst xmlns:a="http://schemas.openxmlformats.org/drawingml/2006/main">
               <a:ext uri="{FF2B5EF4-FFF2-40B4-BE49-F238E27FC236}">
-                <a16:creationId xmlns:a16="http://schemas.microsoft.com/office/drawing/2014/main" id="{39B2D913-6CE8-45A8-92A8-1E5B8289014E}"/>
+                <a16:creationId xmlns:a16="http://schemas.microsoft.com/office/drawing/2014/main" id="{D380B932-E18D-491E-BE13-0319E9382004}"/>
               </a:ext>
             </a:extLst>
           </p:cNvPr>
@@ -16881,10 +16927,10 @@
       </p:sp>
       <p:sp>
         <p:nvSpPr>
-          <p:cNvPr id="13" name="f128">
+          <p:cNvPr id="13" name="f130">
             <a:extLst xmlns:a="http://schemas.openxmlformats.org/drawingml/2006/main">
               <a:ext uri="{FF2B5EF4-FFF2-40B4-BE49-F238E27FC236}">
-                <a16:creationId xmlns:a16="http://schemas.microsoft.com/office/drawing/2014/main" id="{6DC9DDC7-1F64-473A-B35A-FFFBA3627555}"/>
+                <a16:creationId xmlns:a16="http://schemas.microsoft.com/office/drawing/2014/main" id="{9C31CD2B-E027-47B5-9759-50C98399ACEE}"/>
               </a:ext>
             </a:extLst>
           </p:cNvPr>
@@ -17040,10 +17086,10 @@
       </p:sp>
       <p:sp>
         <p:nvSpPr>
-          <p:cNvPr id="14" name="f129">
+          <p:cNvPr id="14" name="f131">
             <a:extLst xmlns:a="http://schemas.openxmlformats.org/drawingml/2006/main">
               <a:ext uri="{FF2B5EF4-FFF2-40B4-BE49-F238E27FC236}">
-                <a16:creationId xmlns:a16="http://schemas.microsoft.com/office/drawing/2014/main" id="{87DB7606-52BB-4047-9E66-61D846159192}"/>
+                <a16:creationId xmlns:a16="http://schemas.microsoft.com/office/drawing/2014/main" id="{8BAC995B-EBF7-4BFF-A56F-733A99528767}"/>
               </a:ext>
             </a:extLst>
           </p:cNvPr>
@@ -17200,7 +17246,7 @@
     </p:spTree>
     <p:extLst>
       <p:ext uri="{BB962C8B-B14F-4D97-AF65-F5344CB8AC3E}">
-        <p14:creationId xmlns:p14="http://schemas.microsoft.com/office/powerpoint/2010/main" val="1534536425"/>
+        <p14:creationId xmlns:p14="http://schemas.microsoft.com/office/powerpoint/2010/main" val="106827091"/>
       </p:ext>
     </p:extLst>
   </p:cSld>
@@ -17228,10 +17274,10 @@
       </p:grpSpPr>
       <p:sp>
         <p:nvSpPr>
-          <p:cNvPr id="13" name="f130">
+          <p:cNvPr id="13" name="f132">
             <a:extLst xmlns:a="http://schemas.openxmlformats.org/drawingml/2006/main">
               <a:ext uri="{FF2B5EF4-FFF2-40B4-BE49-F238E27FC236}">
-                <a16:creationId xmlns:a16="http://schemas.microsoft.com/office/drawing/2014/main" id="{67CE21E1-A8E7-4C78-BCE5-A685B29EA681}"/>
+                <a16:creationId xmlns:a16="http://schemas.microsoft.com/office/drawing/2014/main" id="{BB8EF939-DB91-43D5-9554-18DABA93056E}"/>
               </a:ext>
             </a:extLst>
           </p:cNvPr>
@@ -17262,7 +17308,7 @@
             <a:defPPr algn="l">
               <a:defRPr sz="1500" b="0">
                 <a:solidFill>
-                  <a:srgbClr val="4264D0"/>
+                  <a:srgbClr val="52627B"/>
                 </a:solidFill>
                 <a:latin typeface="Nimbus Sans"/>
                 <a:ea typeface="Nimbus Sans"/>
@@ -17272,7 +17318,7 @@
             <a:lvl1pPr algn="l">
               <a:defRPr sz="1500" b="0">
                 <a:solidFill>
-                  <a:srgbClr val="4264D0"/>
+                  <a:srgbClr val="52627B"/>
                 </a:solidFill>
                 <a:latin typeface="Nimbus Sans"/>
                 <a:ea typeface="Nimbus Sans"/>
@@ -17282,7 +17328,7 @@
             <a:lvl2pPr algn="l">
               <a:defRPr sz="1500" b="0">
                 <a:solidFill>
-                  <a:srgbClr val="4264D0"/>
+                  <a:srgbClr val="52627B"/>
                 </a:solidFill>
                 <a:latin typeface="Nimbus Sans"/>
                 <a:ea typeface="Nimbus Sans"/>
@@ -17292,7 +17338,7 @@
             <a:lvl3pPr algn="l">
               <a:defRPr sz="1500" b="0">
                 <a:solidFill>
-                  <a:srgbClr val="4264D0"/>
+                  <a:srgbClr val="52627B"/>
                 </a:solidFill>
                 <a:latin typeface="Nimbus Sans"/>
                 <a:ea typeface="Nimbus Sans"/>
@@ -17302,7 +17348,7 @@
             <a:lvl4pPr algn="l">
               <a:defRPr sz="1500" b="0">
                 <a:solidFill>
-                  <a:srgbClr val="4264D0"/>
+                  <a:srgbClr val="52627B"/>
                 </a:solidFill>
                 <a:latin typeface="Nimbus Sans"/>
                 <a:ea typeface="Nimbus Sans"/>
@@ -17312,7 +17358,7 @@
             <a:lvl5pPr algn="l">
               <a:defRPr sz="1500" b="0">
                 <a:solidFill>
-                  <a:srgbClr val="4264D0"/>
+                  <a:srgbClr val="52627B"/>
                 </a:solidFill>
                 <a:latin typeface="Nimbus Sans"/>
                 <a:ea typeface="Nimbus Sans"/>
@@ -17322,7 +17368,7 @@
             <a:lvl6pPr algn="l">
               <a:defRPr sz="1500" b="0">
                 <a:solidFill>
-                  <a:srgbClr val="4264D0"/>
+                  <a:srgbClr val="52627B"/>
                 </a:solidFill>
                 <a:latin typeface="Nimbus Sans"/>
                 <a:ea typeface="Nimbus Sans"/>
@@ -17332,7 +17378,7 @@
             <a:lvl7pPr algn="l">
               <a:defRPr sz="1500" b="0">
                 <a:solidFill>
-                  <a:srgbClr val="4264D0"/>
+                  <a:srgbClr val="52627B"/>
                 </a:solidFill>
                 <a:latin typeface="Nimbus Sans"/>
                 <a:ea typeface="Nimbus Sans"/>
@@ -17342,7 +17388,7 @@
             <a:lvl8pPr algn="l">
               <a:defRPr sz="1500" b="0">
                 <a:solidFill>
-                  <a:srgbClr val="4264D0"/>
+                  <a:srgbClr val="52627B"/>
                 </a:solidFill>
                 <a:latin typeface="Nimbus Sans"/>
                 <a:ea typeface="Nimbus Sans"/>
@@ -17352,7 +17398,7 @@
             <a:lvl9pPr algn="l">
               <a:defRPr sz="1500" b="0">
                 <a:solidFill>
-                  <a:srgbClr val="4264D0"/>
+                  <a:srgbClr val="52627B"/>
                 </a:solidFill>
                 <a:latin typeface="Nimbus Sans"/>
                 <a:ea typeface="Nimbus Sans"/>
@@ -17364,7 +17410,7 @@
             <a:pPr algn="l">
               <a:defRPr sz="1500" b="0">
                 <a:solidFill>
-                  <a:srgbClr val="4264D0"/>
+                  <a:srgbClr val="52627B"/>
                 </a:solidFill>
                 <a:latin typeface="Nimbus Sans"/>
                 <a:ea typeface="Nimbus Sans"/>
@@ -17374,7 +17420,7 @@
             <a:r>
               <a:rPr sz="1500" b="0">
                 <a:solidFill>
-                  <a:srgbClr val="4264D0"/>
+                  <a:srgbClr val="52627B"/>
                 </a:solidFill>
                 <a:latin typeface="Nimbus Sans"/>
                 <a:ea typeface="Nimbus Sans"/>
@@ -17387,10 +17433,10 @@
       </p:sp>
       <p:sp>
         <p:nvSpPr>
-          <p:cNvPr id="2" name="f131">
+          <p:cNvPr id="2" name="f133">
             <a:extLst xmlns:a="http://schemas.openxmlformats.org/drawingml/2006/main">
               <a:ext uri="{FF2B5EF4-FFF2-40B4-BE49-F238E27FC236}">
-                <a16:creationId xmlns:a16="http://schemas.microsoft.com/office/drawing/2014/main" id="{EDDC4C45-00F2-485D-8B36-14542002E599}"/>
+                <a16:creationId xmlns:a16="http://schemas.microsoft.com/office/drawing/2014/main" id="{7D5791D2-D10A-4FAD-8AF8-1403DB23F60F}"/>
               </a:ext>
             </a:extLst>
           </p:cNvPr>
@@ -17546,10 +17592,10 @@
       </p:sp>
       <p:sp>
         <p:nvSpPr>
-          <p:cNvPr id="3" name="f132">
+          <p:cNvPr id="3" name="f134">
             <a:extLst xmlns:a="http://schemas.openxmlformats.org/drawingml/2006/main">
               <a:ext uri="{FF2B5EF4-FFF2-40B4-BE49-F238E27FC236}">
-                <a16:creationId xmlns:a16="http://schemas.microsoft.com/office/drawing/2014/main" id="{6661C654-1EE6-49F6-8541-ECB3B2931C46}"/>
+                <a16:creationId xmlns:a16="http://schemas.microsoft.com/office/drawing/2014/main" id="{6DAD045B-10E2-41CB-B366-BE64A035CAD0}"/>
               </a:ext>
             </a:extLst>
           </p:cNvPr>
@@ -17705,10 +17751,10 @@
       </p:sp>
       <p:sp>
         <p:nvSpPr>
-          <p:cNvPr id="4" name="f133">
+          <p:cNvPr id="4" name="f135">
             <a:extLst xmlns:a="http://schemas.openxmlformats.org/drawingml/2006/main">
               <a:ext uri="{FF2B5EF4-FFF2-40B4-BE49-F238E27FC236}">
-                <a16:creationId xmlns:a16="http://schemas.microsoft.com/office/drawing/2014/main" id="{47F87975-511E-4A46-9AA3-8246BB6FB2A6}"/>
+                <a16:creationId xmlns:a16="http://schemas.microsoft.com/office/drawing/2014/main" id="{8041F0DD-0437-4934-A72A-0820A4B29A27}"/>
               </a:ext>
             </a:extLst>
           </p:cNvPr>
@@ -17857,7 +17903,7 @@
                 <a:ea typeface="Nimbus Sans"/>
                 <a:cs typeface="Nimbus Sans"/>
               </a:rPr>
-              <a:t>Verdetti sulle catture originali confrontati con gli esiti attesi.</a:t>
+              <a:t>16 catture di rete, con risultati ottenuti coerenti con quelli attesi.</a:t>
             </a:r>
           </a:p>
         </p:txBody>
@@ -17867,7 +17913,7 @@
           <p:cNvPr id="5" name="">
             <a:extLst xmlns:a="http://schemas.openxmlformats.org/drawingml/2006/main">
               <a:ext uri="{FF2B5EF4-FFF2-40B4-BE49-F238E27FC236}">
-                <a16:creationId xmlns:a16="http://schemas.microsoft.com/office/drawing/2014/main" id="{E3715459-DC23-46FD-A16B-C0E397885419}"/>
+                <a16:creationId xmlns:a16="http://schemas.microsoft.com/office/drawing/2014/main" id="{5836DC1D-6B45-414E-BAE6-CB63E4B0AC38}"/>
               </a:ext>
             </a:extLst>
           </p:cNvPr>
@@ -18700,10 +18746,10 @@
       </p:graphicFrame>
       <p:sp>
         <p:nvSpPr>
-          <p:cNvPr id="6" name="f135">
+          <p:cNvPr id="6" name="f137">
             <a:extLst xmlns:a="http://schemas.openxmlformats.org/drawingml/2006/main">
               <a:ext uri="{FF2B5EF4-FFF2-40B4-BE49-F238E27FC236}">
-                <a16:creationId xmlns:a16="http://schemas.microsoft.com/office/drawing/2014/main" id="{146646E8-1534-4451-9A3C-C7C739A82D12}"/>
+                <a16:creationId xmlns:a16="http://schemas.microsoft.com/office/drawing/2014/main" id="{C693AC93-1C99-4E8E-880E-875B32D22E1A}"/>
               </a:ext>
             </a:extLst>
           </p:cNvPr>
@@ -18735,10 +18781,10 @@
       </p:sp>
       <p:sp>
         <p:nvSpPr>
-          <p:cNvPr id="7" name="f136">
+          <p:cNvPr id="7" name="f138">
             <a:extLst xmlns:a="http://schemas.openxmlformats.org/drawingml/2006/main">
               <a:ext uri="{FF2B5EF4-FFF2-40B4-BE49-F238E27FC236}">
-                <a16:creationId xmlns:a16="http://schemas.microsoft.com/office/drawing/2014/main" id="{5B8B7961-463B-48AA-8B50-0E019ADF82AE}"/>
+                <a16:creationId xmlns:a16="http://schemas.microsoft.com/office/drawing/2014/main" id="{C2B91122-EADA-4294-A30C-B16034E69964}"/>
               </a:ext>
             </a:extLst>
           </p:cNvPr>
@@ -18894,10 +18940,10 @@
       </p:sp>
       <p:sp>
         <p:nvSpPr>
-          <p:cNvPr id="8" name="f137">
+          <p:cNvPr id="8" name="f139">
             <a:extLst xmlns:a="http://schemas.openxmlformats.org/drawingml/2006/main">
               <a:ext uri="{FF2B5EF4-FFF2-40B4-BE49-F238E27FC236}">
-                <a16:creationId xmlns:a16="http://schemas.microsoft.com/office/drawing/2014/main" id="{CE7289F5-74D7-4D79-9804-D0A82A202753}"/>
+                <a16:creationId xmlns:a16="http://schemas.microsoft.com/office/drawing/2014/main" id="{AC2C88D5-1730-4024-B4EA-DBA99A37A2C4}"/>
               </a:ext>
             </a:extLst>
           </p:cNvPr>
@@ -19053,10 +19099,10 @@
       </p:sp>
       <p:sp>
         <p:nvSpPr>
-          <p:cNvPr id="9" name="f138">
+          <p:cNvPr id="9" name="f140">
             <a:extLst xmlns:a="http://schemas.openxmlformats.org/drawingml/2006/main">
               <a:ext uri="{FF2B5EF4-FFF2-40B4-BE49-F238E27FC236}">
-                <a16:creationId xmlns:a16="http://schemas.microsoft.com/office/drawing/2014/main" id="{B6F7E517-C236-481F-9FF5-C71BB6EA0D57}"/>
+                <a16:creationId xmlns:a16="http://schemas.microsoft.com/office/drawing/2014/main" id="{07EFBC96-30D2-49A3-9ECB-24BF17A3E19C}"/>
               </a:ext>
             </a:extLst>
           </p:cNvPr>
@@ -19212,10 +19258,10 @@
       </p:sp>
       <p:sp>
         <p:nvSpPr>
-          <p:cNvPr id="10" name="f139">
+          <p:cNvPr id="10" name="f141">
             <a:extLst xmlns:a="http://schemas.openxmlformats.org/drawingml/2006/main">
               <a:ext uri="{FF2B5EF4-FFF2-40B4-BE49-F238E27FC236}">
-                <a16:creationId xmlns:a16="http://schemas.microsoft.com/office/drawing/2014/main" id="{CA126CDA-1B29-4729-9606-82D8B88A8EB6}"/>
+                <a16:creationId xmlns:a16="http://schemas.microsoft.com/office/drawing/2014/main" id="{E6CB828A-D891-443A-B9BD-1E9A73F51DEF}"/>
               </a:ext>
             </a:extLst>
           </p:cNvPr>
@@ -19371,10 +19417,10 @@
       </p:sp>
       <p:sp>
         <p:nvSpPr>
-          <p:cNvPr id="11" name="f140">
+          <p:cNvPr id="11" name="f142">
             <a:extLst xmlns:a="http://schemas.openxmlformats.org/drawingml/2006/main">
               <a:ext uri="{FF2B5EF4-FFF2-40B4-BE49-F238E27FC236}">
-                <a16:creationId xmlns:a16="http://schemas.microsoft.com/office/drawing/2014/main" id="{BFCD0EC4-76E4-4AC1-AABD-EF41CB31C8C5}"/>
+                <a16:creationId xmlns:a16="http://schemas.microsoft.com/office/drawing/2014/main" id="{4B58AB90-CEE2-4891-86D9-179B5CA5AFE3}"/>
               </a:ext>
             </a:extLst>
           </p:cNvPr>
@@ -19530,10 +19576,10 @@
       </p:sp>
       <p:sp>
         <p:nvSpPr>
-          <p:cNvPr id="12" name="f141">
+          <p:cNvPr id="12" name="f143">
             <a:extLst xmlns:a="http://schemas.openxmlformats.org/drawingml/2006/main">
               <a:ext uri="{FF2B5EF4-FFF2-40B4-BE49-F238E27FC236}">
-                <a16:creationId xmlns:a16="http://schemas.microsoft.com/office/drawing/2014/main" id="{8DD42DFA-D720-454E-A6D0-3BD61650A07B}"/>
+                <a16:creationId xmlns:a16="http://schemas.microsoft.com/office/drawing/2014/main" id="{66F2D0D6-B584-4E60-A3D4-D743E1677DD1}"/>
               </a:ext>
             </a:extLst>
           </p:cNvPr>
@@ -19544,8 +19590,8 @@
         </p:nvSpPr>
         <p:spPr>
           <a:xfrm xmlns:a="http://schemas.openxmlformats.org/drawingml/2006/main">
-            <a:off x="1066800" y="7981950"/>
-            <a:ext cx="13106400" cy="381000"/>
+            <a:off x="1066800" y="7534275"/>
+            <a:ext cx="9429750" cy="285750"/>
           </a:xfrm>
           <a:prstGeom xmlns:a="http://schemas.openxmlformats.org/drawingml/2006/main" prst="rect">
             <a:avLst/>
@@ -19561,8 +19607,8 @@
             <a:noAutofit/>
           </a:bodyPr>
           <a:lstStyle xmlns:a="http://schemas.openxmlformats.org/drawingml/2006/main">
-            <a:defPPr algn="l">
-              <a:defRPr sz="2025" b="0">
+            <a:defPPr algn="ctr">
+              <a:defRPr sz="1575" b="0">
                 <a:solidFill>
                   <a:srgbClr val="52627B"/>
                 </a:solidFill>
@@ -19571,8 +19617,8 @@
                 <a:cs typeface="Nimbus Sans"/>
               </a:defRPr>
             </a:defPPr>
-            <a:lvl1pPr algn="l">
-              <a:defRPr sz="2025" b="0">
+            <a:lvl1pPr algn="ctr">
+              <a:defRPr sz="1575" b="0">
                 <a:solidFill>
                   <a:srgbClr val="52627B"/>
                 </a:solidFill>
@@ -19581,8 +19627,8 @@
                 <a:cs typeface="Nimbus Sans"/>
               </a:defRPr>
             </a:lvl1pPr>
-            <a:lvl2pPr algn="l">
-              <a:defRPr sz="2025" b="0">
+            <a:lvl2pPr algn="ctr">
+              <a:defRPr sz="1575" b="0">
                 <a:solidFill>
                   <a:srgbClr val="52627B"/>
                 </a:solidFill>
@@ -19591,8 +19637,8 @@
                 <a:cs typeface="Nimbus Sans"/>
               </a:defRPr>
             </a:lvl2pPr>
-            <a:lvl3pPr algn="l">
-              <a:defRPr sz="2025" b="0">
+            <a:lvl3pPr algn="ctr">
+              <a:defRPr sz="1575" b="0">
                 <a:solidFill>
                   <a:srgbClr val="52627B"/>
                 </a:solidFill>
@@ -19601,8 +19647,8 @@
                 <a:cs typeface="Nimbus Sans"/>
               </a:defRPr>
             </a:lvl3pPr>
-            <a:lvl4pPr algn="l">
-              <a:defRPr sz="2025" b="0">
+            <a:lvl4pPr algn="ctr">
+              <a:defRPr sz="1575" b="0">
                 <a:solidFill>
                   <a:srgbClr val="52627B"/>
                 </a:solidFill>
@@ -19611,8 +19657,8 @@
                 <a:cs typeface="Nimbus Sans"/>
               </a:defRPr>
             </a:lvl4pPr>
-            <a:lvl5pPr algn="l">
-              <a:defRPr sz="2025" b="0">
+            <a:lvl5pPr algn="ctr">
+              <a:defRPr sz="1575" b="0">
                 <a:solidFill>
                   <a:srgbClr val="52627B"/>
                 </a:solidFill>
@@ -19621,8 +19667,8 @@
                 <a:cs typeface="Nimbus Sans"/>
               </a:defRPr>
             </a:lvl5pPr>
-            <a:lvl6pPr algn="l">
-              <a:defRPr sz="2025" b="0">
+            <a:lvl6pPr algn="ctr">
+              <a:defRPr sz="1575" b="0">
                 <a:solidFill>
                   <a:srgbClr val="52627B"/>
                 </a:solidFill>
@@ -19631,8 +19677,8 @@
                 <a:cs typeface="Nimbus Sans"/>
               </a:defRPr>
             </a:lvl6pPr>
-            <a:lvl7pPr algn="l">
-              <a:defRPr sz="2025" b="0">
+            <a:lvl7pPr algn="ctr">
+              <a:defRPr sz="1575" b="0">
                 <a:solidFill>
                   <a:srgbClr val="52627B"/>
                 </a:solidFill>
@@ -19641,8 +19687,8 @@
                 <a:cs typeface="Nimbus Sans"/>
               </a:defRPr>
             </a:lvl7pPr>
-            <a:lvl8pPr algn="l">
-              <a:defRPr sz="2025" b="0">
+            <a:lvl8pPr algn="ctr">
+              <a:defRPr sz="1575" b="0">
                 <a:solidFill>
                   <a:srgbClr val="52627B"/>
                 </a:solidFill>
@@ -19651,8 +19697,8 @@
                 <a:cs typeface="Nimbus Sans"/>
               </a:defRPr>
             </a:lvl8pPr>
-            <a:lvl9pPr algn="l">
-              <a:defRPr sz="2025" b="0">
+            <a:lvl9pPr algn="ctr">
+              <a:defRPr sz="1575" b="0">
                 <a:solidFill>
                   <a:srgbClr val="52627B"/>
                 </a:solidFill>
@@ -19663,8 +19709,8 @@
             </a:lvl9pPr>
           </a:lstStyle>
           <a:p xmlns:a="http://schemas.openxmlformats.org/drawingml/2006/main">
-            <a:pPr algn="l">
-              <a:defRPr sz="2025" b="0">
+            <a:pPr algn="ctr">
+              <a:defRPr sz="1575" b="0">
                 <a:solidFill>
                   <a:srgbClr val="52627B"/>
                 </a:solidFill>
@@ -19674,7 +19720,7 @@
               </a:defRPr>
             </a:pPr>
             <a:r>
-              <a:rPr sz="2025" b="0">
+              <a:rPr sz="1575" b="0">
                 <a:solidFill>
                   <a:srgbClr val="52627B"/>
                 </a:solidFill>
@@ -19690,7 +19736,7 @@
     </p:spTree>
     <p:extLst>
       <p:ext uri="{BB962C8B-B14F-4D97-AF65-F5344CB8AC3E}">
-        <p14:creationId xmlns:p14="http://schemas.microsoft.com/office/powerpoint/2010/main" val="1082741093"/>
+        <p14:creationId xmlns:p14="http://schemas.microsoft.com/office/powerpoint/2010/main" val="501538323"/>
       </p:ext>
     </p:extLst>
   </p:cSld>
@@ -19718,10 +19764,10 @@
       </p:grpSpPr>
       <p:sp>
         <p:nvSpPr>
-          <p:cNvPr id="50" name="f142">
+          <p:cNvPr id="49" name="f144">
             <a:extLst xmlns:a="http://schemas.openxmlformats.org/drawingml/2006/main">
               <a:ext uri="{FF2B5EF4-FFF2-40B4-BE49-F238E27FC236}">
-                <a16:creationId xmlns:a16="http://schemas.microsoft.com/office/drawing/2014/main" id="{C9D4E24B-E91A-4A52-B9E7-0E9D28CCD085}"/>
+                <a16:creationId xmlns:a16="http://schemas.microsoft.com/office/drawing/2014/main" id="{36C8E2FD-E395-4833-9439-C6CADDF0AD5B}"/>
               </a:ext>
             </a:extLst>
           </p:cNvPr>
@@ -19752,7 +19798,7 @@
             <a:defPPr algn="l">
               <a:defRPr sz="1500" b="0">
                 <a:solidFill>
-                  <a:srgbClr val="4264D0"/>
+                  <a:srgbClr val="52627B"/>
                 </a:solidFill>
                 <a:latin typeface="Nimbus Sans"/>
                 <a:ea typeface="Nimbus Sans"/>
@@ -19762,7 +19808,7 @@
             <a:lvl1pPr algn="l">
               <a:defRPr sz="1500" b="0">
                 <a:solidFill>
-                  <a:srgbClr val="4264D0"/>
+                  <a:srgbClr val="52627B"/>
                 </a:solidFill>
                 <a:latin typeface="Nimbus Sans"/>
                 <a:ea typeface="Nimbus Sans"/>
@@ -19772,7 +19818,7 @@
             <a:lvl2pPr algn="l">
               <a:defRPr sz="1500" b="0">
                 <a:solidFill>
-                  <a:srgbClr val="4264D0"/>
+                  <a:srgbClr val="52627B"/>
                 </a:solidFill>
                 <a:latin typeface="Nimbus Sans"/>
                 <a:ea typeface="Nimbus Sans"/>
@@ -19782,7 +19828,7 @@
             <a:lvl3pPr algn="l">
               <a:defRPr sz="1500" b="0">
                 <a:solidFill>
-                  <a:srgbClr val="4264D0"/>
+                  <a:srgbClr val="52627B"/>
                 </a:solidFill>
                 <a:latin typeface="Nimbus Sans"/>
                 <a:ea typeface="Nimbus Sans"/>
@@ -19792,7 +19838,7 @@
             <a:lvl4pPr algn="l">
               <a:defRPr sz="1500" b="0">
                 <a:solidFill>
-                  <a:srgbClr val="4264D0"/>
+                  <a:srgbClr val="52627B"/>
                 </a:solidFill>
                 <a:latin typeface="Nimbus Sans"/>
                 <a:ea typeface="Nimbus Sans"/>
@@ -19802,7 +19848,7 @@
             <a:lvl5pPr algn="l">
               <a:defRPr sz="1500" b="0">
                 <a:solidFill>
-                  <a:srgbClr val="4264D0"/>
+                  <a:srgbClr val="52627B"/>
                 </a:solidFill>
                 <a:latin typeface="Nimbus Sans"/>
                 <a:ea typeface="Nimbus Sans"/>
@@ -19812,7 +19858,7 @@
             <a:lvl6pPr algn="l">
               <a:defRPr sz="1500" b="0">
                 <a:solidFill>
-                  <a:srgbClr val="4264D0"/>
+                  <a:srgbClr val="52627B"/>
                 </a:solidFill>
                 <a:latin typeface="Nimbus Sans"/>
                 <a:ea typeface="Nimbus Sans"/>
@@ -19822,7 +19868,7 @@
             <a:lvl7pPr algn="l">
               <a:defRPr sz="1500" b="0">
                 <a:solidFill>
-                  <a:srgbClr val="4264D0"/>
+                  <a:srgbClr val="52627B"/>
                 </a:solidFill>
                 <a:latin typeface="Nimbus Sans"/>
                 <a:ea typeface="Nimbus Sans"/>
@@ -19832,7 +19878,7 @@
             <a:lvl8pPr algn="l">
               <a:defRPr sz="1500" b="0">
                 <a:solidFill>
-                  <a:srgbClr val="4264D0"/>
+                  <a:srgbClr val="52627B"/>
                 </a:solidFill>
                 <a:latin typeface="Nimbus Sans"/>
                 <a:ea typeface="Nimbus Sans"/>
@@ -19842,7 +19888,7 @@
             <a:lvl9pPr algn="l">
               <a:defRPr sz="1500" b="0">
                 <a:solidFill>
-                  <a:srgbClr val="4264D0"/>
+                  <a:srgbClr val="52627B"/>
                 </a:solidFill>
                 <a:latin typeface="Nimbus Sans"/>
                 <a:ea typeface="Nimbus Sans"/>
@@ -19854,7 +19900,7 @@
             <a:pPr algn="l">
               <a:defRPr sz="1500" b="0">
                 <a:solidFill>
-                  <a:srgbClr val="4264D0"/>
+                  <a:srgbClr val="52627B"/>
                 </a:solidFill>
                 <a:latin typeface="Nimbus Sans"/>
                 <a:ea typeface="Nimbus Sans"/>
@@ -19864,7 +19910,7 @@
             <a:r>
               <a:rPr sz="1500" b="0">
                 <a:solidFill>
-                  <a:srgbClr val="4264D0"/>
+                  <a:srgbClr val="52627B"/>
                 </a:solidFill>
                 <a:latin typeface="Nimbus Sans"/>
                 <a:ea typeface="Nimbus Sans"/>
@@ -19877,10 +19923,10 @@
       </p:sp>
       <p:sp>
         <p:nvSpPr>
-          <p:cNvPr id="2" name="f143">
+          <p:cNvPr id="2" name="f145">
             <a:extLst xmlns:a="http://schemas.openxmlformats.org/drawingml/2006/main">
               <a:ext uri="{FF2B5EF4-FFF2-40B4-BE49-F238E27FC236}">
-                <a16:creationId xmlns:a16="http://schemas.microsoft.com/office/drawing/2014/main" id="{8548F51F-218D-47B1-897D-E8F7FE572C9F}"/>
+                <a16:creationId xmlns:a16="http://schemas.microsoft.com/office/drawing/2014/main" id="{00511CC5-4585-4AE5-817A-FE7D28CE2A9B}"/>
               </a:ext>
             </a:extLst>
           </p:cNvPr>
@@ -20036,10 +20082,10 @@
       </p:sp>
       <p:sp>
         <p:nvSpPr>
-          <p:cNvPr id="3" name="f144">
+          <p:cNvPr id="3" name="f146">
             <a:extLst xmlns:a="http://schemas.openxmlformats.org/drawingml/2006/main">
               <a:ext uri="{FF2B5EF4-FFF2-40B4-BE49-F238E27FC236}">
-                <a16:creationId xmlns:a16="http://schemas.microsoft.com/office/drawing/2014/main" id="{BF2D923E-2B53-4BFA-A0B0-785FAD821505}"/>
+                <a16:creationId xmlns:a16="http://schemas.microsoft.com/office/drawing/2014/main" id="{35043BA8-DC6C-4B64-AB82-DD67FD19A666}"/>
               </a:ext>
             </a:extLst>
           </p:cNvPr>
@@ -20195,10 +20241,10 @@
       </p:sp>
       <p:sp>
         <p:nvSpPr>
-          <p:cNvPr id="4" name="f145">
+          <p:cNvPr id="4" name="f147">
             <a:extLst xmlns:a="http://schemas.openxmlformats.org/drawingml/2006/main">
               <a:ext uri="{FF2B5EF4-FFF2-40B4-BE49-F238E27FC236}">
-                <a16:creationId xmlns:a16="http://schemas.microsoft.com/office/drawing/2014/main" id="{CA648F6F-9E4F-4F02-8EB7-A4CD5E41D2D8}"/>
+                <a16:creationId xmlns:a16="http://schemas.microsoft.com/office/drawing/2014/main" id="{96A5EE3F-4006-47EE-82D6-85A5BFC35A43}"/>
               </a:ext>
             </a:extLst>
           </p:cNvPr>
@@ -20347,17 +20393,17 @@
                 <a:ea typeface="Nimbus Sans"/>
                 <a:cs typeface="Nimbus Sans"/>
               </a:rPr>
-              <a:t>Stesse regole e stesso sistema, su evidenze modificate in modo controllato.</a:t>
+              <a:t>Mutazioni controllate sul PCAP originale e verifica mediante la stessa pipeline e le stesse regole DSL.</a:t>
             </a:r>
           </a:p>
         </p:txBody>
       </p:sp>
       <p:sp>
         <p:nvSpPr>
-          <p:cNvPr id="5" name="f146">
+          <p:cNvPr id="5" name="f148">
             <a:extLst xmlns:a="http://schemas.openxmlformats.org/drawingml/2006/main">
               <a:ext uri="{FF2B5EF4-FFF2-40B4-BE49-F238E27FC236}">
-                <a16:creationId xmlns:a16="http://schemas.microsoft.com/office/drawing/2014/main" id="{C2E20DF5-6D16-4149-B71B-1EEDBC9A1CED}"/>
+                <a16:creationId xmlns:a16="http://schemas.microsoft.com/office/drawing/2014/main" id="{B44E52BE-03CE-4BD5-A83E-B3AE251C0CB0}"/>
               </a:ext>
             </a:extLst>
           </p:cNvPr>
@@ -20389,10 +20435,10 @@
       </p:sp>
       <p:sp>
         <p:nvSpPr>
-          <p:cNvPr id="6" name="f147">
+          <p:cNvPr id="6" name="f149">
             <a:extLst xmlns:a="http://schemas.openxmlformats.org/drawingml/2006/main">
               <a:ext uri="{FF2B5EF4-FFF2-40B4-BE49-F238E27FC236}">
-                <a16:creationId xmlns:a16="http://schemas.microsoft.com/office/drawing/2014/main" id="{AF24B891-D213-453F-8A16-C0DC7EB8C2B9}"/>
+                <a16:creationId xmlns:a16="http://schemas.microsoft.com/office/drawing/2014/main" id="{9B061945-26B3-4C5A-9BB9-97C5E0B14D2A}"/>
               </a:ext>
             </a:extLst>
           </p:cNvPr>
@@ -20548,10 +20594,10 @@
       </p:sp>
       <p:sp>
         <p:nvSpPr>
-          <p:cNvPr id="7" name="f148">
+          <p:cNvPr id="7" name="f150">
             <a:extLst xmlns:a="http://schemas.openxmlformats.org/drawingml/2006/main">
               <a:ext uri="{FF2B5EF4-FFF2-40B4-BE49-F238E27FC236}">
-                <a16:creationId xmlns:a16="http://schemas.microsoft.com/office/drawing/2014/main" id="{2C4C7E62-1C59-48D3-899B-8D7F97CC3D92}"/>
+                <a16:creationId xmlns:a16="http://schemas.microsoft.com/office/drawing/2014/main" id="{AF978F90-28D8-40CD-8151-3243465C6442}"/>
               </a:ext>
             </a:extLst>
           </p:cNvPr>
@@ -20583,10 +20629,10 @@
       </p:sp>
       <p:sp>
         <p:nvSpPr>
-          <p:cNvPr id="8" name="f149">
+          <p:cNvPr id="8" name="f151">
             <a:extLst xmlns:a="http://schemas.openxmlformats.org/drawingml/2006/main">
               <a:ext uri="{FF2B5EF4-FFF2-40B4-BE49-F238E27FC236}">
-                <a16:creationId xmlns:a16="http://schemas.microsoft.com/office/drawing/2014/main" id="{0576CCF8-D6A0-4109-90BF-DC468C483402}"/>
+                <a16:creationId xmlns:a16="http://schemas.microsoft.com/office/drawing/2014/main" id="{90F61FB3-0ED2-4646-AD90-6B3900AFAE80}"/>
               </a:ext>
             </a:extLst>
           </p:cNvPr>
@@ -20742,10 +20788,10 @@
       </p:sp>
       <p:sp>
         <p:nvSpPr>
-          <p:cNvPr id="9" name="f150">
+          <p:cNvPr id="9" name="f152">
             <a:extLst xmlns:a="http://schemas.openxmlformats.org/drawingml/2006/main">
               <a:ext uri="{FF2B5EF4-FFF2-40B4-BE49-F238E27FC236}">
-                <a16:creationId xmlns:a16="http://schemas.microsoft.com/office/drawing/2014/main" id="{FC75EB8A-5481-4BB7-BECB-029912F4BB0D}"/>
+                <a16:creationId xmlns:a16="http://schemas.microsoft.com/office/drawing/2014/main" id="{0BCB4A6B-9F89-4062-A343-F593F9520A92}"/>
               </a:ext>
             </a:extLst>
           </p:cNvPr>
@@ -20777,10 +20823,10 @@
       </p:sp>
       <p:sp>
         <p:nvSpPr>
-          <p:cNvPr id="10" name="f151">
+          <p:cNvPr id="10" name="f153">
             <a:extLst xmlns:a="http://schemas.openxmlformats.org/drawingml/2006/main">
               <a:ext uri="{FF2B5EF4-FFF2-40B4-BE49-F238E27FC236}">
-                <a16:creationId xmlns:a16="http://schemas.microsoft.com/office/drawing/2014/main" id="{F87DFBBA-C3EF-46F1-896D-FC3F7EEDFE28}"/>
+                <a16:creationId xmlns:a16="http://schemas.microsoft.com/office/drawing/2014/main" id="{8F92213C-EBD3-41E4-A835-6F6DB0B24264}"/>
               </a:ext>
             </a:extLst>
           </p:cNvPr>
@@ -20936,10 +20982,10 @@
       </p:sp>
       <p:sp>
         <p:nvSpPr>
-          <p:cNvPr id="11" name="f152">
+          <p:cNvPr id="11" name="f154">
             <a:extLst xmlns:a="http://schemas.openxmlformats.org/drawingml/2006/main">
               <a:ext uri="{FF2B5EF4-FFF2-40B4-BE49-F238E27FC236}">
-                <a16:creationId xmlns:a16="http://schemas.microsoft.com/office/drawing/2014/main" id="{DE633995-6DF4-422D-95BE-C96284226157}"/>
+                <a16:creationId xmlns:a16="http://schemas.microsoft.com/office/drawing/2014/main" id="{5D05F89C-5664-472D-A05E-A7C22066DCE3}"/>
               </a:ext>
             </a:extLst>
           </p:cNvPr>
@@ -20971,10 +21017,10 @@
       </p:sp>
       <p:sp>
         <p:nvSpPr>
-          <p:cNvPr id="12" name="f153">
+          <p:cNvPr id="12" name="f155">
             <a:extLst xmlns:a="http://schemas.openxmlformats.org/drawingml/2006/main">
               <a:ext uri="{FF2B5EF4-FFF2-40B4-BE49-F238E27FC236}">
-                <a16:creationId xmlns:a16="http://schemas.microsoft.com/office/drawing/2014/main" id="{B470C15F-7D98-49E7-AF00-3FAA7E005E52}"/>
+                <a16:creationId xmlns:a16="http://schemas.microsoft.com/office/drawing/2014/main" id="{8D18ED16-76CE-4BF2-A8C1-CF4CD73E7610}"/>
               </a:ext>
             </a:extLst>
           </p:cNvPr>
@@ -21130,10 +21176,10 @@
       </p:sp>
       <p:sp>
         <p:nvSpPr>
-          <p:cNvPr id="13" name="f154">
+          <p:cNvPr id="13" name="f156">
             <a:extLst xmlns:a="http://schemas.openxmlformats.org/drawingml/2006/main">
               <a:ext uri="{FF2B5EF4-FFF2-40B4-BE49-F238E27FC236}">
-                <a16:creationId xmlns:a16="http://schemas.microsoft.com/office/drawing/2014/main" id="{899B8696-FC8D-4917-A388-56D2D6FDCDD6}"/>
+                <a16:creationId xmlns:a16="http://schemas.microsoft.com/office/drawing/2014/main" id="{960FE1D7-4D75-4370-A829-DE9D0B3F1C2F}"/>
               </a:ext>
             </a:extLst>
           </p:cNvPr>
@@ -21165,10 +21211,10 @@
       </p:sp>
       <p:sp>
         <p:nvSpPr>
-          <p:cNvPr id="14" name="f155">
+          <p:cNvPr id="14" name="f157">
             <a:extLst xmlns:a="http://schemas.openxmlformats.org/drawingml/2006/main">
               <a:ext uri="{FF2B5EF4-FFF2-40B4-BE49-F238E27FC236}">
-                <a16:creationId xmlns:a16="http://schemas.microsoft.com/office/drawing/2014/main" id="{A1505EDF-56F6-455C-9B53-096EBA6C4A7D}"/>
+                <a16:creationId xmlns:a16="http://schemas.microsoft.com/office/drawing/2014/main" id="{4F7EE53B-1E04-45F6-BED5-E7FB30F3887A}"/>
               </a:ext>
             </a:extLst>
           </p:cNvPr>
@@ -21324,10 +21370,10 @@
       </p:sp>
       <p:sp>
         <p:nvSpPr>
-          <p:cNvPr id="15" name="f156">
+          <p:cNvPr id="15" name="f158">
             <a:extLst xmlns:a="http://schemas.openxmlformats.org/drawingml/2006/main">
               <a:ext uri="{FF2B5EF4-FFF2-40B4-BE49-F238E27FC236}">
-                <a16:creationId xmlns:a16="http://schemas.microsoft.com/office/drawing/2014/main" id="{43A286DC-6333-4D5B-A997-49D563F210F2}"/>
+                <a16:creationId xmlns:a16="http://schemas.microsoft.com/office/drawing/2014/main" id="{504AC6BB-360E-431E-9579-F94F97522DE1}"/>
               </a:ext>
             </a:extLst>
           </p:cNvPr>
@@ -21359,10 +21405,10 @@
       </p:sp>
       <p:sp>
         <p:nvSpPr>
-          <p:cNvPr id="16" name="f157">
+          <p:cNvPr id="16" name="f159">
             <a:extLst xmlns:a="http://schemas.openxmlformats.org/drawingml/2006/main">
               <a:ext uri="{FF2B5EF4-FFF2-40B4-BE49-F238E27FC236}">
-                <a16:creationId xmlns:a16="http://schemas.microsoft.com/office/drawing/2014/main" id="{7901AD54-D980-4EDA-B846-A4D8720B01B1}"/>
+                <a16:creationId xmlns:a16="http://schemas.microsoft.com/office/drawing/2014/main" id="{6468F176-8897-46EF-BD73-4652FD7F5C39}"/>
               </a:ext>
             </a:extLst>
           </p:cNvPr>
@@ -21541,10 +21587,10 @@
       </p:sp>
       <p:sp>
         <p:nvSpPr>
-          <p:cNvPr id="17" name="f158">
+          <p:cNvPr id="17" name="f160">
             <a:extLst xmlns:a="http://schemas.openxmlformats.org/drawingml/2006/main">
               <a:ext uri="{FF2B5EF4-FFF2-40B4-BE49-F238E27FC236}">
-                <a16:creationId xmlns:a16="http://schemas.microsoft.com/office/drawing/2014/main" id="{47863EEA-E4BB-429C-9DB5-3BA36CA2CFEB}"/>
+                <a16:creationId xmlns:a16="http://schemas.microsoft.com/office/drawing/2014/main" id="{2BD80425-EBEB-4548-9CF7-56A9786A4E46}"/>
               </a:ext>
             </a:extLst>
           </p:cNvPr>
@@ -21576,10 +21622,10 @@
       </p:sp>
       <p:sp>
         <p:nvSpPr>
-          <p:cNvPr id="18" name="f159">
+          <p:cNvPr id="18" name="f161">
             <a:extLst xmlns:a="http://schemas.openxmlformats.org/drawingml/2006/main">
               <a:ext uri="{FF2B5EF4-FFF2-40B4-BE49-F238E27FC236}">
-                <a16:creationId xmlns:a16="http://schemas.microsoft.com/office/drawing/2014/main" id="{6B18EC87-6F35-4173-A0DB-0244EC91C07E}"/>
+                <a16:creationId xmlns:a16="http://schemas.microsoft.com/office/drawing/2014/main" id="{8FA727AD-D593-4355-AA5E-634E6BFE9FCC}"/>
               </a:ext>
             </a:extLst>
           </p:cNvPr>
@@ -21735,10 +21781,10 @@
       </p:sp>
       <p:sp>
         <p:nvSpPr>
-          <p:cNvPr id="19" name="f160">
+          <p:cNvPr id="19" name="f162">
             <a:extLst xmlns:a="http://schemas.openxmlformats.org/drawingml/2006/main">
               <a:ext uri="{FF2B5EF4-FFF2-40B4-BE49-F238E27FC236}">
-                <a16:creationId xmlns:a16="http://schemas.microsoft.com/office/drawing/2014/main" id="{D29BC21C-CC49-47D6-BA27-C4A2E69CF69C}"/>
+                <a16:creationId xmlns:a16="http://schemas.microsoft.com/office/drawing/2014/main" id="{A7C121FD-4A6E-48DA-B177-AE62C8DACB8C}"/>
               </a:ext>
             </a:extLst>
           </p:cNvPr>
@@ -21766,10 +21812,10 @@
       </p:sp>
       <p:sp>
         <p:nvSpPr>
-          <p:cNvPr id="20" name="f161">
+          <p:cNvPr id="20" name="f163">
             <a:extLst xmlns:a="http://schemas.openxmlformats.org/drawingml/2006/main">
               <a:ext uri="{FF2B5EF4-FFF2-40B4-BE49-F238E27FC236}">
-                <a16:creationId xmlns:a16="http://schemas.microsoft.com/office/drawing/2014/main" id="{B9CC020C-7C72-462E-8065-7B1172EBBFA0}"/>
+                <a16:creationId xmlns:a16="http://schemas.microsoft.com/office/drawing/2014/main" id="{0CAAE774-6A55-4C91-A060-B270313A3BB0}"/>
               </a:ext>
             </a:extLst>
           </p:cNvPr>
@@ -21779,11 +21825,11 @@
           <p:nvPr/>
         </p:nvSpPr>
         <p:spPr>
-          <a:xfrm xmlns:a="http://schemas.openxmlformats.org/drawingml/2006/main">
+          <a:xfrm xmlns:a="http://schemas.openxmlformats.org/drawingml/2006/main" rot="10800000">
             <a:off x="1228725" y="4371975"/>
             <a:ext cx="114300" cy="114300"/>
           </a:xfrm>
-          <a:prstGeom xmlns:a="http://schemas.openxmlformats.org/drawingml/2006/main" prst="downArrow">
+          <a:prstGeom xmlns:a="http://schemas.openxmlformats.org/drawingml/2006/main" prst="triangle">
             <a:avLst/>
           </a:prstGeom>
           <a:solidFill xmlns:a="http://schemas.openxmlformats.org/drawingml/2006/main">
@@ -21797,10 +21843,10 @@
       </p:sp>
       <p:sp>
         <p:nvSpPr>
-          <p:cNvPr id="21" name="f162">
+          <p:cNvPr id="21" name="f164">
             <a:extLst xmlns:a="http://schemas.openxmlformats.org/drawingml/2006/main">
               <a:ext uri="{FF2B5EF4-FFF2-40B4-BE49-F238E27FC236}">
-                <a16:creationId xmlns:a16="http://schemas.microsoft.com/office/drawing/2014/main" id="{F5A9F0BB-A62B-4F8A-A9EF-EF43439530E3}"/>
+                <a16:creationId xmlns:a16="http://schemas.microsoft.com/office/drawing/2014/main" id="{041D1625-208D-4735-9C37-D7A6F89D5F8E}"/>
               </a:ext>
             </a:extLst>
           </p:cNvPr>
@@ -21828,10 +21874,10 @@
       </p:sp>
       <p:sp>
         <p:nvSpPr>
-          <p:cNvPr id="22" name="f163">
+          <p:cNvPr id="22" name="f165">
             <a:extLst xmlns:a="http://schemas.openxmlformats.org/drawingml/2006/main">
               <a:ext uri="{FF2B5EF4-FFF2-40B4-BE49-F238E27FC236}">
-                <a16:creationId xmlns:a16="http://schemas.microsoft.com/office/drawing/2014/main" id="{AD73A73D-14D0-4C63-B2FF-615068537C21}"/>
+                <a16:creationId xmlns:a16="http://schemas.microsoft.com/office/drawing/2014/main" id="{B90C2CBD-E2A6-4979-8D0C-D7BA57530A8E}"/>
               </a:ext>
             </a:extLst>
           </p:cNvPr>
@@ -21841,11 +21887,11 @@
           <p:nvPr/>
         </p:nvSpPr>
         <p:spPr>
-          <a:xfrm xmlns:a="http://schemas.openxmlformats.org/drawingml/2006/main">
+          <a:xfrm xmlns:a="http://schemas.openxmlformats.org/drawingml/2006/main" rot="10800000">
             <a:off x="3943350" y="4371975"/>
             <a:ext cx="114300" cy="114300"/>
           </a:xfrm>
-          <a:prstGeom xmlns:a="http://schemas.openxmlformats.org/drawingml/2006/main" prst="downArrow">
+          <a:prstGeom xmlns:a="http://schemas.openxmlformats.org/drawingml/2006/main" prst="triangle">
             <a:avLst/>
           </a:prstGeom>
           <a:solidFill xmlns:a="http://schemas.openxmlformats.org/drawingml/2006/main">
@@ -21859,10 +21905,10 @@
       </p:sp>
       <p:sp>
         <p:nvSpPr>
-          <p:cNvPr id="23" name="f164">
+          <p:cNvPr id="23" name="f166">
             <a:extLst xmlns:a="http://schemas.openxmlformats.org/drawingml/2006/main">
               <a:ext uri="{FF2B5EF4-FFF2-40B4-BE49-F238E27FC236}">
-                <a16:creationId xmlns:a16="http://schemas.microsoft.com/office/drawing/2014/main" id="{E973E97C-F266-445B-B06D-E04EF5005954}"/>
+                <a16:creationId xmlns:a16="http://schemas.microsoft.com/office/drawing/2014/main" id="{3D68551F-8EEA-470A-A10C-4201A1CF77DA}"/>
               </a:ext>
             </a:extLst>
           </p:cNvPr>
@@ -21890,10 +21936,10 @@
       </p:sp>
       <p:sp>
         <p:nvSpPr>
-          <p:cNvPr id="24" name="f165">
+          <p:cNvPr id="24" name="f167">
             <a:extLst xmlns:a="http://schemas.openxmlformats.org/drawingml/2006/main">
               <a:ext uri="{FF2B5EF4-FFF2-40B4-BE49-F238E27FC236}">
-                <a16:creationId xmlns:a16="http://schemas.microsoft.com/office/drawing/2014/main" id="{00CCF043-4D9F-4D5F-92B6-FD0011D12E84}"/>
+                <a16:creationId xmlns:a16="http://schemas.microsoft.com/office/drawing/2014/main" id="{5B16B8D8-F141-44C3-8BE2-1D422BD4ED3C}"/>
               </a:ext>
             </a:extLst>
           </p:cNvPr>
@@ -21921,10 +21967,10 @@
       </p:sp>
       <p:sp>
         <p:nvSpPr>
-          <p:cNvPr id="25" name="f166">
+          <p:cNvPr id="25" name="f168">
             <a:extLst xmlns:a="http://schemas.openxmlformats.org/drawingml/2006/main">
               <a:ext uri="{FF2B5EF4-FFF2-40B4-BE49-F238E27FC236}">
-                <a16:creationId xmlns:a16="http://schemas.microsoft.com/office/drawing/2014/main" id="{CBC0F3B7-B3B6-40DF-A17A-12231D0C3106}"/>
+                <a16:creationId xmlns:a16="http://schemas.microsoft.com/office/drawing/2014/main" id="{B38E4ACB-55C6-4827-9CF1-CDF68D1363F4}"/>
               </a:ext>
             </a:extLst>
           </p:cNvPr>
@@ -21952,10 +21998,10 @@
       </p:sp>
       <p:sp>
         <p:nvSpPr>
-          <p:cNvPr id="26" name="f167">
+          <p:cNvPr id="26" name="f169">
             <a:extLst xmlns:a="http://schemas.openxmlformats.org/drawingml/2006/main">
               <a:ext uri="{FF2B5EF4-FFF2-40B4-BE49-F238E27FC236}">
-                <a16:creationId xmlns:a16="http://schemas.microsoft.com/office/drawing/2014/main" id="{3C9D6D09-E455-46DD-930E-B499568B4480}"/>
+                <a16:creationId xmlns:a16="http://schemas.microsoft.com/office/drawing/2014/main" id="{1FE75A4F-942A-4A63-8FE6-6B0FA51D8B10}"/>
               </a:ext>
             </a:extLst>
           </p:cNvPr>
@@ -21965,11 +22011,11 @@
           <p:nvPr/>
         </p:nvSpPr>
         <p:spPr>
-          <a:xfrm xmlns:a="http://schemas.openxmlformats.org/drawingml/2006/main">
+          <a:xfrm xmlns:a="http://schemas.openxmlformats.org/drawingml/2006/main" rot="10800000">
             <a:off x="1371600" y="6124575"/>
             <a:ext cx="114300" cy="114300"/>
           </a:xfrm>
-          <a:prstGeom xmlns:a="http://schemas.openxmlformats.org/drawingml/2006/main" prst="downArrow">
+          <a:prstGeom xmlns:a="http://schemas.openxmlformats.org/drawingml/2006/main" prst="triangle">
             <a:avLst/>
           </a:prstGeom>
           <a:solidFill xmlns:a="http://schemas.openxmlformats.org/drawingml/2006/main">
@@ -21983,10 +22029,10 @@
       </p:sp>
       <p:sp>
         <p:nvSpPr>
-          <p:cNvPr id="27" name="f168">
+          <p:cNvPr id="27" name="f170">
             <a:extLst xmlns:a="http://schemas.openxmlformats.org/drawingml/2006/main">
               <a:ext uri="{FF2B5EF4-FFF2-40B4-BE49-F238E27FC236}">
-                <a16:creationId xmlns:a16="http://schemas.microsoft.com/office/drawing/2014/main" id="{231E65D6-1AD0-498E-97A1-465682EE32BC}"/>
+                <a16:creationId xmlns:a16="http://schemas.microsoft.com/office/drawing/2014/main" id="{1D878B2E-6E34-4D1F-8B5C-1C9485B3E551}"/>
               </a:ext>
             </a:extLst>
           </p:cNvPr>
@@ -22014,10 +22060,10 @@
       </p:sp>
       <p:sp>
         <p:nvSpPr>
-          <p:cNvPr id="28" name="f169">
+          <p:cNvPr id="28" name="f171">
             <a:extLst xmlns:a="http://schemas.openxmlformats.org/drawingml/2006/main">
               <a:ext uri="{FF2B5EF4-FFF2-40B4-BE49-F238E27FC236}">
-                <a16:creationId xmlns:a16="http://schemas.microsoft.com/office/drawing/2014/main" id="{CB89FD41-E563-419F-BBFC-CB72EA7B78EB}"/>
+                <a16:creationId xmlns:a16="http://schemas.microsoft.com/office/drawing/2014/main" id="{2CD363E8-42C9-45A5-A394-44C541C99A0F}"/>
               </a:ext>
             </a:extLst>
           </p:cNvPr>
@@ -22045,10 +22091,10 @@
       </p:sp>
       <p:sp>
         <p:nvSpPr>
-          <p:cNvPr id="29" name="f170">
+          <p:cNvPr id="29" name="f172">
             <a:extLst xmlns:a="http://schemas.openxmlformats.org/drawingml/2006/main">
               <a:ext uri="{FF2B5EF4-FFF2-40B4-BE49-F238E27FC236}">
-                <a16:creationId xmlns:a16="http://schemas.microsoft.com/office/drawing/2014/main" id="{DDC6D984-48A0-435F-A3ED-817A86BE02F2}"/>
+                <a16:creationId xmlns:a16="http://schemas.microsoft.com/office/drawing/2014/main" id="{0DBB869A-7999-4A8F-8B12-8AFDFA80E5D6}"/>
               </a:ext>
             </a:extLst>
           </p:cNvPr>
@@ -22058,11 +22104,11 @@
           <p:nvPr/>
         </p:nvSpPr>
         <p:spPr>
-          <a:xfrm xmlns:a="http://schemas.openxmlformats.org/drawingml/2006/main">
+          <a:xfrm xmlns:a="http://schemas.openxmlformats.org/drawingml/2006/main" rot="10800000">
             <a:off x="3943350" y="6124575"/>
             <a:ext cx="114300" cy="114300"/>
           </a:xfrm>
-          <a:prstGeom xmlns:a="http://schemas.openxmlformats.org/drawingml/2006/main" prst="downArrow">
+          <a:prstGeom xmlns:a="http://schemas.openxmlformats.org/drawingml/2006/main" prst="triangle">
             <a:avLst/>
           </a:prstGeom>
           <a:solidFill xmlns:a="http://schemas.openxmlformats.org/drawingml/2006/main">
@@ -22076,10 +22122,10 @@
       </p:sp>
       <p:sp>
         <p:nvSpPr>
-          <p:cNvPr id="30" name="f171">
+          <p:cNvPr id="30" name="f173">
             <a:extLst xmlns:a="http://schemas.openxmlformats.org/drawingml/2006/main">
               <a:ext uri="{FF2B5EF4-FFF2-40B4-BE49-F238E27FC236}">
-                <a16:creationId xmlns:a16="http://schemas.microsoft.com/office/drawing/2014/main" id="{ED898031-45BE-46E7-BB1B-7685521148BF}"/>
+                <a16:creationId xmlns:a16="http://schemas.microsoft.com/office/drawing/2014/main" id="{2A719C4B-8F82-4F08-BD8E-0B313E9E2D29}"/>
               </a:ext>
             </a:extLst>
           </p:cNvPr>
@@ -22107,10 +22153,10 @@
       </p:sp>
       <p:sp>
         <p:nvSpPr>
-          <p:cNvPr id="31" name="f172">
+          <p:cNvPr id="31" name="f174">
             <a:extLst xmlns:a="http://schemas.openxmlformats.org/drawingml/2006/main">
               <a:ext uri="{FF2B5EF4-FFF2-40B4-BE49-F238E27FC236}">
-                <a16:creationId xmlns:a16="http://schemas.microsoft.com/office/drawing/2014/main" id="{00DBDD0F-B1A2-482E-9682-EEB6D39FDA51}"/>
+                <a16:creationId xmlns:a16="http://schemas.microsoft.com/office/drawing/2014/main" id="{31B1CC4F-60E2-42D1-93F2-ED3B1EB22012}"/>
               </a:ext>
             </a:extLst>
           </p:cNvPr>
@@ -22138,10 +22184,10 @@
       </p:sp>
       <p:sp>
         <p:nvSpPr>
-          <p:cNvPr id="32" name="f173">
+          <p:cNvPr id="32" name="f175">
             <a:extLst xmlns:a="http://schemas.openxmlformats.org/drawingml/2006/main">
               <a:ext uri="{FF2B5EF4-FFF2-40B4-BE49-F238E27FC236}">
-                <a16:creationId xmlns:a16="http://schemas.microsoft.com/office/drawing/2014/main" id="{39748CE6-00A5-47BE-B5D2-BC78C7A532FD}"/>
+                <a16:creationId xmlns:a16="http://schemas.microsoft.com/office/drawing/2014/main" id="{B192F68E-1246-42BF-92B7-E258D893B672}"/>
               </a:ext>
             </a:extLst>
           </p:cNvPr>
@@ -22169,10 +22215,10 @@
       </p:sp>
       <p:sp>
         <p:nvSpPr>
-          <p:cNvPr id="33" name="f174">
+          <p:cNvPr id="33" name="f176">
             <a:extLst xmlns:a="http://schemas.openxmlformats.org/drawingml/2006/main">
               <a:ext uri="{FF2B5EF4-FFF2-40B4-BE49-F238E27FC236}">
-                <a16:creationId xmlns:a16="http://schemas.microsoft.com/office/drawing/2014/main" id="{01DE5B95-FBD4-4FEC-BE8D-4B963E027DCC}"/>
+                <a16:creationId xmlns:a16="http://schemas.microsoft.com/office/drawing/2014/main" id="{9EF6BD25-F462-4669-A631-8CD87FF7D03D}"/>
               </a:ext>
             </a:extLst>
           </p:cNvPr>
@@ -22182,11 +22228,11 @@
           <p:nvPr/>
         </p:nvSpPr>
         <p:spPr>
-          <a:xfrm xmlns:a="http://schemas.openxmlformats.org/drawingml/2006/main">
+          <a:xfrm xmlns:a="http://schemas.openxmlformats.org/drawingml/2006/main" rot="0">
             <a:off x="6753225" y="6057900"/>
             <a:ext cx="114300" cy="114300"/>
           </a:xfrm>
-          <a:prstGeom xmlns:a="http://schemas.openxmlformats.org/drawingml/2006/main" prst="upArrow">
+          <a:prstGeom xmlns:a="http://schemas.openxmlformats.org/drawingml/2006/main" prst="triangle">
             <a:avLst/>
           </a:prstGeom>
           <a:solidFill xmlns:a="http://schemas.openxmlformats.org/drawingml/2006/main">
@@ -22200,10 +22246,10 @@
       </p:sp>
       <p:sp>
         <p:nvSpPr>
-          <p:cNvPr id="34" name="f175">
+          <p:cNvPr id="34" name="f177">
             <a:extLst xmlns:a="http://schemas.openxmlformats.org/drawingml/2006/main">
               <a:ext uri="{FF2B5EF4-FFF2-40B4-BE49-F238E27FC236}">
-                <a16:creationId xmlns:a16="http://schemas.microsoft.com/office/drawing/2014/main" id="{4D11FD74-92A1-461C-A78D-1AF6EE81C431}"/>
+                <a16:creationId xmlns:a16="http://schemas.microsoft.com/office/drawing/2014/main" id="{D89337D6-2A02-431A-BCF1-22DBAC12E387}"/>
               </a:ext>
             </a:extLst>
           </p:cNvPr>
@@ -22359,10 +22405,10 @@
       </p:sp>
       <p:sp>
         <p:nvSpPr>
-          <p:cNvPr id="35" name="f176">
+          <p:cNvPr id="35" name="f178">
             <a:extLst xmlns:a="http://schemas.openxmlformats.org/drawingml/2006/main">
               <a:ext uri="{FF2B5EF4-FFF2-40B4-BE49-F238E27FC236}">
-                <a16:creationId xmlns:a16="http://schemas.microsoft.com/office/drawing/2014/main" id="{2A5FDF67-81ED-4A94-B913-8C63D5E6C26D}"/>
+                <a16:creationId xmlns:a16="http://schemas.microsoft.com/office/drawing/2014/main" id="{3B661E07-6C56-4A93-BBB7-6C4E8F381DB2}"/>
               </a:ext>
             </a:extLst>
           </p:cNvPr>
@@ -22390,10 +22436,10 @@
       </p:sp>
       <p:sp>
         <p:nvSpPr>
-          <p:cNvPr id="36" name="f177">
+          <p:cNvPr id="36" name="f179">
             <a:extLst xmlns:a="http://schemas.openxmlformats.org/drawingml/2006/main">
               <a:ext uri="{FF2B5EF4-FFF2-40B4-BE49-F238E27FC236}">
-                <a16:creationId xmlns:a16="http://schemas.microsoft.com/office/drawing/2014/main" id="{E9DA4510-7B4E-4528-B30E-3EB92CDBC884}"/>
+                <a16:creationId xmlns:a16="http://schemas.microsoft.com/office/drawing/2014/main" id="{82C8195E-7D88-4636-8CB6-2EFEF8F8F0D0}"/>
               </a:ext>
             </a:extLst>
           </p:cNvPr>
@@ -22421,10 +22467,10 @@
       </p:sp>
       <p:sp>
         <p:nvSpPr>
-          <p:cNvPr id="37" name="f178">
+          <p:cNvPr id="37" name="f180">
             <a:extLst xmlns:a="http://schemas.openxmlformats.org/drawingml/2006/main">
               <a:ext uri="{FF2B5EF4-FFF2-40B4-BE49-F238E27FC236}">
-                <a16:creationId xmlns:a16="http://schemas.microsoft.com/office/drawing/2014/main" id="{4A0B5937-4876-4DB8-A937-78494DB77548}"/>
+                <a16:creationId xmlns:a16="http://schemas.microsoft.com/office/drawing/2014/main" id="{47F88311-20D5-4C1C-B66C-1AE03AB83125}"/>
               </a:ext>
             </a:extLst>
           </p:cNvPr>
@@ -22435,8 +22481,8 @@
         </p:nvSpPr>
         <p:spPr>
           <a:xfrm xmlns:a="http://schemas.openxmlformats.org/drawingml/2006/main">
-            <a:off x="7724775" y="5572125"/>
-            <a:ext cx="371475" cy="95"/>
+            <a:off x="7839075" y="5572125"/>
+            <a:ext cx="257175" cy="95"/>
           </a:xfrm>
           <a:prstGeom xmlns:a="http://schemas.openxmlformats.org/drawingml/2006/main" prst="line">
             <a:avLst/>
@@ -22452,10 +22498,10 @@
       </p:sp>
       <p:sp>
         <p:nvSpPr>
-          <p:cNvPr id="38" name="f179">
+          <p:cNvPr id="38" name="f181">
             <a:extLst xmlns:a="http://schemas.openxmlformats.org/drawingml/2006/main">
               <a:ext uri="{FF2B5EF4-FFF2-40B4-BE49-F238E27FC236}">
-                <a16:creationId xmlns:a16="http://schemas.microsoft.com/office/drawing/2014/main" id="{3E185338-3850-4240-B191-C8894DF6459C}"/>
+                <a16:creationId xmlns:a16="http://schemas.microsoft.com/office/drawing/2014/main" id="{CDA596BB-DB51-4BF4-A0D0-8C37D93BC502}"/>
               </a:ext>
             </a:extLst>
           </p:cNvPr>
@@ -22465,59 +22511,28 @@
           <p:nvPr/>
         </p:nvSpPr>
         <p:spPr>
-          <a:xfrm xmlns:a="http://schemas.openxmlformats.org/drawingml/2006/main" flipH="1">
+          <a:xfrm xmlns:a="http://schemas.openxmlformats.org/drawingml/2006/main" rot="16200000">
             <a:off x="7724775" y="5514975"/>
-            <a:ext cx="95250" cy="57150"/>
+            <a:ext cx="114300" cy="114300"/>
           </a:xfrm>
-          <a:prstGeom xmlns:a="http://schemas.openxmlformats.org/drawingml/2006/main" prst="line">
+          <a:prstGeom xmlns:a="http://schemas.openxmlformats.org/drawingml/2006/main" prst="triangle">
             <a:avLst/>
           </a:prstGeom>
-          <a:noFill xmlns:a="http://schemas.openxmlformats.org/drawingml/2006/main"/>
-          <a:ln xmlns:a="http://schemas.openxmlformats.org/drawingml/2006/main" w="28575">
-            <a:solidFill>
-              <a:srgbClr val="4264D0"/>
-            </a:solidFill>
+          <a:solidFill xmlns:a="http://schemas.openxmlformats.org/drawingml/2006/main">
+            <a:srgbClr val="4264D0"/>
+          </a:solidFill>
+          <a:ln xmlns:a="http://schemas.openxmlformats.org/drawingml/2006/main" w="0">
+            <a:noFill/>
             <a:prstDash val="solid"/>
           </a:ln>
         </p:spPr>
       </p:sp>
       <p:sp>
         <p:nvSpPr>
-          <p:cNvPr id="39" name="f180">
+          <p:cNvPr id="39" name="f182">
             <a:extLst xmlns:a="http://schemas.openxmlformats.org/drawingml/2006/main">
               <a:ext uri="{FF2B5EF4-FFF2-40B4-BE49-F238E27FC236}">
-                <a16:creationId xmlns:a16="http://schemas.microsoft.com/office/drawing/2014/main" id="{EA74EEAE-46DA-4336-B889-C65D5C664AD2}"/>
-              </a:ext>
-            </a:extLst>
-          </p:cNvPr>
-          <p:cNvSpPr>
-            <a:spLocks xmlns:a="http://schemas.openxmlformats.org/drawingml/2006/main" noGrp="1"/>
-          </p:cNvSpPr>
-          <p:nvPr/>
-        </p:nvSpPr>
-        <p:spPr>
-          <a:xfrm xmlns:a="http://schemas.openxmlformats.org/drawingml/2006/main">
-            <a:off x="7724775" y="5572125"/>
-            <a:ext cx="95250" cy="57150"/>
-          </a:xfrm>
-          <a:prstGeom xmlns:a="http://schemas.openxmlformats.org/drawingml/2006/main" prst="line">
-            <a:avLst/>
-          </a:prstGeom>
-          <a:noFill xmlns:a="http://schemas.openxmlformats.org/drawingml/2006/main"/>
-          <a:ln xmlns:a="http://schemas.openxmlformats.org/drawingml/2006/main" w="28575">
-            <a:solidFill>
-              <a:srgbClr val="4264D0"/>
-            </a:solidFill>
-            <a:prstDash val="solid"/>
-          </a:ln>
-        </p:spPr>
-      </p:sp>
-      <p:sp>
-        <p:nvSpPr>
-          <p:cNvPr id="40" name="f181">
-            <a:extLst xmlns:a="http://schemas.openxmlformats.org/drawingml/2006/main">
-              <a:ext uri="{FF2B5EF4-FFF2-40B4-BE49-F238E27FC236}">
-                <a16:creationId xmlns:a16="http://schemas.microsoft.com/office/drawing/2014/main" id="{7E4BC1A8-9166-4751-91D6-593C7C813755}"/>
+                <a16:creationId xmlns:a16="http://schemas.microsoft.com/office/drawing/2014/main" id="{A77D9290-0020-4231-9589-56554E540FC3}"/>
               </a:ext>
             </a:extLst>
           </p:cNvPr>
@@ -22545,10 +22560,10 @@
       </p:sp>
       <p:sp>
         <p:nvSpPr>
-          <p:cNvPr id="41" name="f182">
+          <p:cNvPr id="40" name="f183">
             <a:extLst xmlns:a="http://schemas.openxmlformats.org/drawingml/2006/main">
               <a:ext uri="{FF2B5EF4-FFF2-40B4-BE49-F238E27FC236}">
-                <a16:creationId xmlns:a16="http://schemas.microsoft.com/office/drawing/2014/main" id="{4D320560-3E8B-43FD-9FC4-1AAE0B44F238}"/>
+                <a16:creationId xmlns:a16="http://schemas.microsoft.com/office/drawing/2014/main" id="{BA20F3D6-2581-4AD1-B548-AE1DC4368CF3}"/>
               </a:ext>
             </a:extLst>
           </p:cNvPr>
@@ -22558,11 +22573,11 @@
           <p:nvPr/>
         </p:nvSpPr>
         <p:spPr>
-          <a:xfrm xmlns:a="http://schemas.openxmlformats.org/drawingml/2006/main">
+          <a:xfrm xmlns:a="http://schemas.openxmlformats.org/drawingml/2006/main" rot="0">
             <a:off x="6753225" y="4362450"/>
             <a:ext cx="114300" cy="114300"/>
           </a:xfrm>
-          <a:prstGeom xmlns:a="http://schemas.openxmlformats.org/drawingml/2006/main" prst="upArrow">
+          <a:prstGeom xmlns:a="http://schemas.openxmlformats.org/drawingml/2006/main" prst="triangle">
             <a:avLst/>
           </a:prstGeom>
           <a:solidFill xmlns:a="http://schemas.openxmlformats.org/drawingml/2006/main">
@@ -22576,10 +22591,10 @@
       </p:sp>
       <p:sp>
         <p:nvSpPr>
-          <p:cNvPr id="42" name="f183">
+          <p:cNvPr id="41" name="f184">
             <a:extLst xmlns:a="http://schemas.openxmlformats.org/drawingml/2006/main">
               <a:ext uri="{FF2B5EF4-FFF2-40B4-BE49-F238E27FC236}">
-                <a16:creationId xmlns:a16="http://schemas.microsoft.com/office/drawing/2014/main" id="{715C90DB-C362-4EDD-A117-7ABE99E3DC59}"/>
+                <a16:creationId xmlns:a16="http://schemas.microsoft.com/office/drawing/2014/main" id="{D4985726-9C0B-467E-AB92-D8EA45206DE2}"/>
               </a:ext>
             </a:extLst>
           </p:cNvPr>
@@ -22607,10 +22622,10 @@
       </p:sp>
       <p:sp>
         <p:nvSpPr>
-          <p:cNvPr id="43" name="f184">
+          <p:cNvPr id="42" name="f185">
             <a:extLst xmlns:a="http://schemas.openxmlformats.org/drawingml/2006/main">
               <a:ext uri="{FF2B5EF4-FFF2-40B4-BE49-F238E27FC236}">
-                <a16:creationId xmlns:a16="http://schemas.microsoft.com/office/drawing/2014/main" id="{2722BF4A-74AD-4CCA-983B-801BCCAC36D6}"/>
+                <a16:creationId xmlns:a16="http://schemas.microsoft.com/office/drawing/2014/main" id="{33C5751C-1092-4652-86EC-9172A5590746}"/>
               </a:ext>
             </a:extLst>
           </p:cNvPr>
@@ -22638,10 +22653,10 @@
       </p:sp>
       <p:sp>
         <p:nvSpPr>
-          <p:cNvPr id="44" name="f185">
+          <p:cNvPr id="43" name="f186">
             <a:extLst xmlns:a="http://schemas.openxmlformats.org/drawingml/2006/main">
               <a:ext uri="{FF2B5EF4-FFF2-40B4-BE49-F238E27FC236}">
-                <a16:creationId xmlns:a16="http://schemas.microsoft.com/office/drawing/2014/main" id="{32251178-C39A-42AF-B2D7-49CE1D147B59}"/>
+                <a16:creationId xmlns:a16="http://schemas.microsoft.com/office/drawing/2014/main" id="{339E2951-48DF-43D4-BD7B-43B9B3B04989}"/>
               </a:ext>
             </a:extLst>
           </p:cNvPr>
@@ -22669,10 +22684,10 @@
       </p:sp>
       <p:sp>
         <p:nvSpPr>
-          <p:cNvPr id="45" name="f186">
+          <p:cNvPr id="44" name="f187">
             <a:extLst xmlns:a="http://schemas.openxmlformats.org/drawingml/2006/main">
               <a:ext uri="{FF2B5EF4-FFF2-40B4-BE49-F238E27FC236}">
-                <a16:creationId xmlns:a16="http://schemas.microsoft.com/office/drawing/2014/main" id="{42BA663B-775A-4CE1-97EF-784B11E43825}"/>
+                <a16:creationId xmlns:a16="http://schemas.microsoft.com/office/drawing/2014/main" id="{F637F04B-ED7D-43B3-B7E4-7E057609FC8A}"/>
               </a:ext>
             </a:extLst>
           </p:cNvPr>
@@ -22682,11 +22697,11 @@
           <p:nvPr/>
         </p:nvSpPr>
         <p:spPr>
-          <a:xfrm xmlns:a="http://schemas.openxmlformats.org/drawingml/2006/main">
-            <a:off x="5105400" y="4724400"/>
-            <a:ext cx="114300" cy="171450"/>
+          <a:xfrm xmlns:a="http://schemas.openxmlformats.org/drawingml/2006/main" rot="16200000">
+            <a:off x="5105400" y="4752975"/>
+            <a:ext cx="114300" cy="114300"/>
           </a:xfrm>
-          <a:prstGeom xmlns:a="http://schemas.openxmlformats.org/drawingml/2006/main" prst="leftArrow">
+          <a:prstGeom xmlns:a="http://schemas.openxmlformats.org/drawingml/2006/main" prst="triangle">
             <a:avLst/>
           </a:prstGeom>
           <a:solidFill xmlns:a="http://schemas.openxmlformats.org/drawingml/2006/main">
@@ -22700,10 +22715,10 @@
       </p:sp>
       <p:sp>
         <p:nvSpPr>
-          <p:cNvPr id="46" name="f187">
+          <p:cNvPr id="45" name="f188">
             <a:extLst xmlns:a="http://schemas.openxmlformats.org/drawingml/2006/main">
               <a:ext uri="{FF2B5EF4-FFF2-40B4-BE49-F238E27FC236}">
-                <a16:creationId xmlns:a16="http://schemas.microsoft.com/office/drawing/2014/main" id="{F7C8AB7E-0D0D-4871-8146-C66989ED09B7}"/>
+                <a16:creationId xmlns:a16="http://schemas.microsoft.com/office/drawing/2014/main" id="{E92FACDB-EC1C-4CFF-B7F2-D7509A98A63D}"/>
               </a:ext>
             </a:extLst>
           </p:cNvPr>
@@ -22859,10 +22874,10 @@
       </p:sp>
       <p:graphicFrame>
         <p:nvGraphicFramePr>
-          <p:cNvPr id="47" name="">
+          <p:cNvPr id="46" name="">
             <a:extLst xmlns:a="http://schemas.openxmlformats.org/drawingml/2006/main">
               <a:ext uri="{FF2B5EF4-FFF2-40B4-BE49-F238E27FC236}">
-                <a16:creationId xmlns:a16="http://schemas.microsoft.com/office/drawing/2014/main" id="{DD6DC111-4EFC-45AB-813A-B4A8FC5970FB}"/>
+                <a16:creationId xmlns:a16="http://schemas.microsoft.com/office/drawing/2014/main" id="{CA704290-E133-4404-879E-70F4EEEA9CA1}"/>
               </a:ext>
             </a:extLst>
           </p:cNvPr>
@@ -23462,10 +23477,10 @@
       </p:graphicFrame>
       <p:sp>
         <p:nvSpPr>
-          <p:cNvPr id="48" name="f189">
+          <p:cNvPr id="47" name="f190">
             <a:extLst xmlns:a="http://schemas.openxmlformats.org/drawingml/2006/main">
               <a:ext uri="{FF2B5EF4-FFF2-40B4-BE49-F238E27FC236}">
-                <a16:creationId xmlns:a16="http://schemas.microsoft.com/office/drawing/2014/main" id="{1E58A7E9-4A67-4E54-86EE-69AAC2B2B253}"/>
+                <a16:creationId xmlns:a16="http://schemas.microsoft.com/office/drawing/2014/main" id="{8C58B910-33BF-4A9B-93DB-B86557928B71}"/>
               </a:ext>
             </a:extLst>
           </p:cNvPr>
@@ -23621,10 +23636,10 @@
       </p:sp>
       <p:sp>
         <p:nvSpPr>
-          <p:cNvPr id="49" name="f190">
+          <p:cNvPr id="48" name="f191">
             <a:extLst xmlns:a="http://schemas.openxmlformats.org/drawingml/2006/main">
               <a:ext uri="{FF2B5EF4-FFF2-40B4-BE49-F238E27FC236}">
-                <a16:creationId xmlns:a16="http://schemas.microsoft.com/office/drawing/2014/main" id="{FC77429B-DD8F-4C7E-891F-515592591B50}"/>
+                <a16:creationId xmlns:a16="http://schemas.microsoft.com/office/drawing/2014/main" id="{DBE2DE84-1132-47EB-9CFB-DDF419284B7D}"/>
               </a:ext>
             </a:extLst>
           </p:cNvPr>
@@ -23804,7 +23819,7 @@
     </p:spTree>
     <p:extLst>
       <p:ext uri="{BB962C8B-B14F-4D97-AF65-F5344CB8AC3E}">
-        <p14:creationId xmlns:p14="http://schemas.microsoft.com/office/powerpoint/2010/main" val="127148856"/>
+        <p14:creationId xmlns:p14="http://schemas.microsoft.com/office/powerpoint/2010/main" val="858717008"/>
       </p:ext>
     </p:extLst>
   </p:cSld>

</xml_diff>

<commit_message>
Compact subtitles and SCAS layout; add subtle active-node elevation
</commit_message>
<xml_diff>
--- a/5g-thesis-presentation-5min/tesi-5min-statico.pptx
+++ b/5g-thesis-presentation-5min/tesi-5min-statico.pptx
@@ -2,19 +2,19 @@
 <file path=ppt/presentation.xml><?xml version="1.0" encoding="utf-8"?>
 <p:presentation xmlns:p="http://schemas.openxmlformats.org/presentationml/2006/main">
   <p:sldMasterIdLst>
-    <p:sldMasterId xmlns:r="http://schemas.openxmlformats.org/officeDocument/2006/relationships" id="2147483648" r:id="R28d66bf4a12a46fb"/>
+    <p:sldMasterId xmlns:r="http://schemas.openxmlformats.org/officeDocument/2006/relationships" id="2147483648" r:id="R080e829da4934443"/>
   </p:sldMasterIdLst>
   <p:notesMasterIdLst>
-    <p:notesMasterId xmlns:r="http://schemas.openxmlformats.org/officeDocument/2006/relationships" r:id="R8d2113278ea34c4c"/>
+    <p:notesMasterId xmlns:r="http://schemas.openxmlformats.org/officeDocument/2006/relationships" r:id="Rf2006a3f0b4742e3"/>
   </p:notesMasterIdLst>
   <p:sldIdLst>
-    <p:sldId xmlns:r="http://schemas.openxmlformats.org/officeDocument/2006/relationships" id="256" r:id="Rb812ca990d2e4825"/>
-    <p:sldId xmlns:r="http://schemas.openxmlformats.org/officeDocument/2006/relationships" id="257" r:id="R577f91db0327409b"/>
-    <p:sldId xmlns:r="http://schemas.openxmlformats.org/officeDocument/2006/relationships" id="258" r:id="R89014dbec34948b5"/>
-    <p:sldId xmlns:r="http://schemas.openxmlformats.org/officeDocument/2006/relationships" id="259" r:id="R4f83e73cc2964929"/>
-    <p:sldId xmlns:r="http://schemas.openxmlformats.org/officeDocument/2006/relationships" id="260" r:id="Rc477bfc206ba442a"/>
-    <p:sldId xmlns:r="http://schemas.openxmlformats.org/officeDocument/2006/relationships" id="261" r:id="R23f0bfa541d840c0"/>
-    <p:sldId xmlns:r="http://schemas.openxmlformats.org/officeDocument/2006/relationships" id="262" r:id="R0686553aceb44965"/>
+    <p:sldId xmlns:r="http://schemas.openxmlformats.org/officeDocument/2006/relationships" id="256" r:id="R7ebcd7383ebe4b0f"/>
+    <p:sldId xmlns:r="http://schemas.openxmlformats.org/officeDocument/2006/relationships" id="257" r:id="Rf8a1fc615f8c4bc4"/>
+    <p:sldId xmlns:r="http://schemas.openxmlformats.org/officeDocument/2006/relationships" id="258" r:id="Rbce2ee4c1c3a4fd4"/>
+    <p:sldId xmlns:r="http://schemas.openxmlformats.org/officeDocument/2006/relationships" id="259" r:id="Rb8d0b8ef55664195"/>
+    <p:sldId xmlns:r="http://schemas.openxmlformats.org/officeDocument/2006/relationships" id="260" r:id="Re670753c6e354911"/>
+    <p:sldId xmlns:r="http://schemas.openxmlformats.org/officeDocument/2006/relationships" id="261" r:id="R127d50fc892543ed"/>
+    <p:sldId xmlns:r="http://schemas.openxmlformats.org/officeDocument/2006/relationships" id="262" r:id="Ra176352badf542d1"/>
   </p:sldIdLst>
   <p:sldSz cx="15240000" cy="8572500"/>
   <p:notesSz cx="6858000" cy="9144000"/>
@@ -1135,7 +1135,7 @@
           <p:cNvPr id="3" name="Title">
             <a:extLst xmlns:a="http://schemas.openxmlformats.org/drawingml/2006/main">
               <a:ext uri="{FF2B5EF4-FFF2-40B4-BE49-F238E27FC236}">
-                <a16:creationId xmlns:a16="http://schemas.microsoft.com/office/drawing/2014/main" id="{0B39142B-6BF2-48E6-9301-C6FA8BA45450}"/>
+                <a16:creationId xmlns:a16="http://schemas.microsoft.com/office/drawing/2014/main" id="{719D4EF0-DAE2-4CBE-AFAA-364F5523ADA5}"/>
               </a:ext>
             </a:extLst>
           </p:cNvPr>
@@ -1364,7 +1364,7 @@
           <p:cNvPr id="2" name="Subtitle">
             <a:extLst xmlns:a="http://schemas.openxmlformats.org/drawingml/2006/main">
               <a:ext uri="{FF2B5EF4-FFF2-40B4-BE49-F238E27FC236}">
-                <a16:creationId xmlns:a16="http://schemas.microsoft.com/office/drawing/2014/main" id="{8F8C5ACF-B12B-425B-9408-28ED62E1A33A}"/>
+                <a16:creationId xmlns:a16="http://schemas.microsoft.com/office/drawing/2014/main" id="{52C4BBCF-E99E-49DE-82E5-CD19BC22D76D}"/>
               </a:ext>
             </a:extLst>
           </p:cNvPr>
@@ -1610,7 +1610,7 @@
           <p:cNvPr id="2" name="Section title">
             <a:extLst xmlns:a="http://schemas.openxmlformats.org/drawingml/2006/main">
               <a:ext uri="{FF2B5EF4-FFF2-40B4-BE49-F238E27FC236}">
-                <a16:creationId xmlns:a16="http://schemas.microsoft.com/office/drawing/2014/main" id="{35A73A22-8D4C-4F36-A5AD-E9D2FC043F06}"/>
+                <a16:creationId xmlns:a16="http://schemas.microsoft.com/office/drawing/2014/main" id="{F20B08C7-9900-468E-ACF3-E04D8BDBCC5B}"/>
               </a:ext>
             </a:extLst>
           </p:cNvPr>
@@ -1856,7 +1856,7 @@
           <p:cNvPr id="3" name="Title">
             <a:extLst xmlns:a="http://schemas.openxmlformats.org/drawingml/2006/main">
               <a:ext uri="{FF2B5EF4-FFF2-40B4-BE49-F238E27FC236}">
-                <a16:creationId xmlns:a16="http://schemas.microsoft.com/office/drawing/2014/main" id="{8C747E11-99BC-4D9A-82E5-7C9AAE5D5086}"/>
+                <a16:creationId xmlns:a16="http://schemas.microsoft.com/office/drawing/2014/main" id="{8BBD0890-E6FA-46C4-BF42-6374E589E42A}"/>
               </a:ext>
             </a:extLst>
           </p:cNvPr>
@@ -2085,7 +2085,7 @@
           <p:cNvPr id="2" name="Body">
             <a:extLst xmlns:a="http://schemas.openxmlformats.org/drawingml/2006/main">
               <a:ext uri="{FF2B5EF4-FFF2-40B4-BE49-F238E27FC236}">
-                <a16:creationId xmlns:a16="http://schemas.microsoft.com/office/drawing/2014/main" id="{985D7692-E3FA-4CEE-BAFF-EA26ADCD631C}"/>
+                <a16:creationId xmlns:a16="http://schemas.microsoft.com/office/drawing/2014/main" id="{4F78370C-E516-4283-A947-63C2D2A9971B}"/>
               </a:ext>
             </a:extLst>
           </p:cNvPr>
@@ -2331,7 +2331,7 @@
           <p:cNvPr id="4" name="Title">
             <a:extLst xmlns:a="http://schemas.openxmlformats.org/drawingml/2006/main">
               <a:ext uri="{FF2B5EF4-FFF2-40B4-BE49-F238E27FC236}">
-                <a16:creationId xmlns:a16="http://schemas.microsoft.com/office/drawing/2014/main" id="{7B5600ED-1473-4042-B847-1D3747BCACD2}"/>
+                <a16:creationId xmlns:a16="http://schemas.microsoft.com/office/drawing/2014/main" id="{3F868E99-1987-44EF-B031-D32A45660182}"/>
               </a:ext>
             </a:extLst>
           </p:cNvPr>
@@ -2560,7 +2560,7 @@
           <p:cNvPr id="2" name="Left column">
             <a:extLst xmlns:a="http://schemas.openxmlformats.org/drawingml/2006/main">
               <a:ext uri="{FF2B5EF4-FFF2-40B4-BE49-F238E27FC236}">
-                <a16:creationId xmlns:a16="http://schemas.microsoft.com/office/drawing/2014/main" id="{EE70D698-F243-4884-B77B-C8122B4EEE53}"/>
+                <a16:creationId xmlns:a16="http://schemas.microsoft.com/office/drawing/2014/main" id="{6A911FD3-3F68-477F-A529-8DCEC112553A}"/>
               </a:ext>
             </a:extLst>
           </p:cNvPr>
@@ -2789,7 +2789,7 @@
           <p:cNvPr id="3" name="Right column">
             <a:extLst xmlns:a="http://schemas.openxmlformats.org/drawingml/2006/main">
               <a:ext uri="{FF2B5EF4-FFF2-40B4-BE49-F238E27FC236}">
-                <a16:creationId xmlns:a16="http://schemas.microsoft.com/office/drawing/2014/main" id="{6B5EECB9-86CD-4EEE-8B7A-4D1CF75C954E}"/>
+                <a16:creationId xmlns:a16="http://schemas.microsoft.com/office/drawing/2014/main" id="{743E4415-0E2D-48B8-AB25-581E79558945}"/>
               </a:ext>
             </a:extLst>
           </p:cNvPr>
@@ -3035,7 +3035,7 @@
           <p:cNvPr id="3" name="Title">
             <a:extLst xmlns:a="http://schemas.openxmlformats.org/drawingml/2006/main">
               <a:ext uri="{FF2B5EF4-FFF2-40B4-BE49-F238E27FC236}">
-                <a16:creationId xmlns:a16="http://schemas.microsoft.com/office/drawing/2014/main" id="{277005B0-DC8C-4195-8AD7-18D5BCDAE963}"/>
+                <a16:creationId xmlns:a16="http://schemas.microsoft.com/office/drawing/2014/main" id="{E1780E46-88F6-4ED8-8E03-18D614C4EE0C}"/>
               </a:ext>
             </a:extLst>
           </p:cNvPr>
@@ -3264,7 +3264,7 @@
           <p:cNvPr id="2" name="Left column">
             <a:extLst xmlns:a="http://schemas.openxmlformats.org/drawingml/2006/main">
               <a:ext uri="{FF2B5EF4-FFF2-40B4-BE49-F238E27FC236}">
-                <a16:creationId xmlns:a16="http://schemas.microsoft.com/office/drawing/2014/main" id="{8141C69F-945B-4267-ACE9-8552683CCE13}"/>
+                <a16:creationId xmlns:a16="http://schemas.microsoft.com/office/drawing/2014/main" id="{D31D9725-9953-4C39-B25C-1FEAFC25E147}"/>
               </a:ext>
             </a:extLst>
           </p:cNvPr>
@@ -3531,12 +3531,12 @@
   </p:cSld>
   <p:clrMap bg1="lt1" tx1="dk1" bg2="lt2" tx2="dk2" accent1="accent1" accent2="accent2" accent3="accent3" accent4="accent4" accent5="accent5" accent6="accent6" hlink="hlink" folHlink="folHlink"/>
   <p:sldLayoutIdLst>
-    <p:sldLayoutId xmlns:r="http://schemas.openxmlformats.org/officeDocument/2006/relationships" id="2147483649" r:id="Rddd2d3a141514265"/>
-    <p:sldLayoutId xmlns:r="http://schemas.openxmlformats.org/officeDocument/2006/relationships" id="2147483650" r:id="Rdb2b53ff255a4a9d"/>
-    <p:sldLayoutId xmlns:r="http://schemas.openxmlformats.org/officeDocument/2006/relationships" id="2147483651" r:id="Rb788dfb663b04c55"/>
-    <p:sldLayoutId xmlns:r="http://schemas.openxmlformats.org/officeDocument/2006/relationships" id="2147483652" r:id="Rbd503872eeb14c10"/>
-    <p:sldLayoutId xmlns:r="http://schemas.openxmlformats.org/officeDocument/2006/relationships" id="2147483653" r:id="R6b000824c1684cd3"/>
-    <p:sldLayoutId xmlns:r="http://schemas.openxmlformats.org/officeDocument/2006/relationships" id="2147483654" r:id="Rf572b49db79c42b7"/>
+    <p:sldLayoutId xmlns:r="http://schemas.openxmlformats.org/officeDocument/2006/relationships" id="2147483649" r:id="R322b171288f247fd"/>
+    <p:sldLayoutId xmlns:r="http://schemas.openxmlformats.org/officeDocument/2006/relationships" id="2147483650" r:id="R7c7a73203a384888"/>
+    <p:sldLayoutId xmlns:r="http://schemas.openxmlformats.org/officeDocument/2006/relationships" id="2147483651" r:id="Rde42efc10431451e"/>
+    <p:sldLayoutId xmlns:r="http://schemas.openxmlformats.org/officeDocument/2006/relationships" id="2147483652" r:id="R9e8e37f8e5a142c9"/>
+    <p:sldLayoutId xmlns:r="http://schemas.openxmlformats.org/officeDocument/2006/relationships" id="2147483653" r:id="Reafdd39df2b043f4"/>
+    <p:sldLayoutId xmlns:r="http://schemas.openxmlformats.org/officeDocument/2006/relationships" id="2147483654" r:id="Rf548e6d54aba465f"/>
   </p:sldLayoutIdLst>
   <p:txStyles>
     <p:titleStyle>
@@ -4087,7 +4087,7 @@
           <p:cNvPr id="21" name="">
             <a:extLst xmlns:a="http://schemas.openxmlformats.org/drawingml/2006/main">
               <a:ext uri="{FF2B5EF4-FFF2-40B4-BE49-F238E27FC236}">
-                <a16:creationId xmlns:a16="http://schemas.microsoft.com/office/drawing/2014/main" id="{6516710D-B0DD-42E8-A790-C37733949609}"/>
+                <a16:creationId xmlns:a16="http://schemas.microsoft.com/office/drawing/2014/main" id="{657D2786-6C97-4B9A-AFEB-E2F14EA1590D}"/>
               </a:ext>
             </a:extLst>
           </p:cNvPr>
@@ -4097,7 +4097,7 @@
           <p:nvPr/>
         </p:nvPicPr>
         <p:blipFill>
-          <a:blip xmlns:r="http://schemas.openxmlformats.org/officeDocument/2006/relationships" xmlns:a="http://schemas.openxmlformats.org/drawingml/2006/main" r:embed="R32bce73d270248e3"/>
+          <a:blip xmlns:r="http://schemas.openxmlformats.org/officeDocument/2006/relationships" xmlns:a="http://schemas.openxmlformats.org/drawingml/2006/main" r:embed="R6b867c90f8524082"/>
           <a:stretch xmlns:a="http://schemas.openxmlformats.org/drawingml/2006/main"/>
         </p:blipFill>
         <p:spPr>
@@ -4115,7 +4115,7 @@
           <p:cNvPr id="2" name="f2">
             <a:extLst xmlns:a="http://schemas.openxmlformats.org/drawingml/2006/main">
               <a:ext uri="{FF2B5EF4-FFF2-40B4-BE49-F238E27FC236}">
-                <a16:creationId xmlns:a16="http://schemas.microsoft.com/office/drawing/2014/main" id="{957BFEB9-951F-4A66-A56C-2F6A3F935696}"/>
+                <a16:creationId xmlns:a16="http://schemas.microsoft.com/office/drawing/2014/main" id="{29ABFA5E-9420-4E41-8AA0-1B7F482EFE59}"/>
               </a:ext>
             </a:extLst>
           </p:cNvPr>
@@ -4274,7 +4274,7 @@
           <p:cNvPr id="3" name="f3">
             <a:extLst xmlns:a="http://schemas.openxmlformats.org/drawingml/2006/main">
               <a:ext uri="{FF2B5EF4-FFF2-40B4-BE49-F238E27FC236}">
-                <a16:creationId xmlns:a16="http://schemas.microsoft.com/office/drawing/2014/main" id="{34E0D8C1-10C6-4689-888E-D4CF8CA8EBC8}"/>
+                <a16:creationId xmlns:a16="http://schemas.microsoft.com/office/drawing/2014/main" id="{2367EF65-31D1-4485-AE5D-767CB5BE5DB9}"/>
               </a:ext>
             </a:extLst>
           </p:cNvPr>
@@ -4433,7 +4433,7 @@
           <p:cNvPr id="4" name="f4">
             <a:extLst xmlns:a="http://schemas.openxmlformats.org/drawingml/2006/main">
               <a:ext uri="{FF2B5EF4-FFF2-40B4-BE49-F238E27FC236}">
-                <a16:creationId xmlns:a16="http://schemas.microsoft.com/office/drawing/2014/main" id="{5E2B78A3-D381-4454-BF3B-3F62F1A7DBB9}"/>
+                <a16:creationId xmlns:a16="http://schemas.microsoft.com/office/drawing/2014/main" id="{0BAB1DC3-0D8F-484F-A212-522DB1E8157F}"/>
               </a:ext>
             </a:extLst>
           </p:cNvPr>
@@ -4592,7 +4592,7 @@
           <p:cNvPr id="5" name="f5">
             <a:extLst xmlns:a="http://schemas.openxmlformats.org/drawingml/2006/main">
               <a:ext uri="{FF2B5EF4-FFF2-40B4-BE49-F238E27FC236}">
-                <a16:creationId xmlns:a16="http://schemas.microsoft.com/office/drawing/2014/main" id="{3150FE58-5A32-49AE-86AE-3D7D905BBE75}"/>
+                <a16:creationId xmlns:a16="http://schemas.microsoft.com/office/drawing/2014/main" id="{D2E8966A-AF1F-4988-8441-B7365EC245C1}"/>
               </a:ext>
             </a:extLst>
           </p:cNvPr>
@@ -4751,7 +4751,7 @@
           <p:cNvPr id="6" name="f6">
             <a:extLst xmlns:a="http://schemas.openxmlformats.org/drawingml/2006/main">
               <a:ext uri="{FF2B5EF4-FFF2-40B4-BE49-F238E27FC236}">
-                <a16:creationId xmlns:a16="http://schemas.microsoft.com/office/drawing/2014/main" id="{7DC8A13E-EE6A-4CEF-9AAD-50B1C6AAA20D}"/>
+                <a16:creationId xmlns:a16="http://schemas.microsoft.com/office/drawing/2014/main" id="{C7BB09E2-E3CF-4865-8A8C-ED45A26F1C17}"/>
               </a:ext>
             </a:extLst>
           </p:cNvPr>
@@ -4910,7 +4910,7 @@
           <p:cNvPr id="7" name="f7">
             <a:extLst xmlns:a="http://schemas.openxmlformats.org/drawingml/2006/main">
               <a:ext uri="{FF2B5EF4-FFF2-40B4-BE49-F238E27FC236}">
-                <a16:creationId xmlns:a16="http://schemas.microsoft.com/office/drawing/2014/main" id="{3E73BABC-EDA2-4830-AFA6-02DCB57D7286}"/>
+                <a16:creationId xmlns:a16="http://schemas.microsoft.com/office/drawing/2014/main" id="{EDEEE779-3543-4F80-9435-7DA3CE51A1DD}"/>
               </a:ext>
             </a:extLst>
           </p:cNvPr>
@@ -5069,7 +5069,7 @@
           <p:cNvPr id="8" name="f8">
             <a:extLst xmlns:a="http://schemas.openxmlformats.org/drawingml/2006/main">
               <a:ext uri="{FF2B5EF4-FFF2-40B4-BE49-F238E27FC236}">
-                <a16:creationId xmlns:a16="http://schemas.microsoft.com/office/drawing/2014/main" id="{230346E9-89B4-4D49-B907-C8487E6EBD38}"/>
+                <a16:creationId xmlns:a16="http://schemas.microsoft.com/office/drawing/2014/main" id="{F4B5FC35-330C-4C1D-9076-5CB0AD513F91}"/>
               </a:ext>
             </a:extLst>
           </p:cNvPr>
@@ -5228,7 +5228,7 @@
           <p:cNvPr id="9" name="f9">
             <a:extLst xmlns:a="http://schemas.openxmlformats.org/drawingml/2006/main">
               <a:ext uri="{FF2B5EF4-FFF2-40B4-BE49-F238E27FC236}">
-                <a16:creationId xmlns:a16="http://schemas.microsoft.com/office/drawing/2014/main" id="{B9DA4782-B4EE-40EB-92F3-D1C6E176AC0C}"/>
+                <a16:creationId xmlns:a16="http://schemas.microsoft.com/office/drawing/2014/main" id="{62067359-B5A9-459E-A9B0-0A9E36DA902F}"/>
               </a:ext>
             </a:extLst>
           </p:cNvPr>
@@ -5387,7 +5387,7 @@
           <p:cNvPr id="10" name="f10">
             <a:extLst xmlns:a="http://schemas.openxmlformats.org/drawingml/2006/main">
               <a:ext uri="{FF2B5EF4-FFF2-40B4-BE49-F238E27FC236}">
-                <a16:creationId xmlns:a16="http://schemas.microsoft.com/office/drawing/2014/main" id="{B454D1EA-CB46-456C-808F-5B3D8F4597B8}"/>
+                <a16:creationId xmlns:a16="http://schemas.microsoft.com/office/drawing/2014/main" id="{5DA44565-0873-40D4-A4BF-1C0CF7ACEF44}"/>
               </a:ext>
             </a:extLst>
           </p:cNvPr>
@@ -5546,7 +5546,7 @@
           <p:cNvPr id="11" name="f11">
             <a:extLst xmlns:a="http://schemas.openxmlformats.org/drawingml/2006/main">
               <a:ext uri="{FF2B5EF4-FFF2-40B4-BE49-F238E27FC236}">
-                <a16:creationId xmlns:a16="http://schemas.microsoft.com/office/drawing/2014/main" id="{67718F60-B3E2-4FE4-8F1C-DA3DE84E3E67}"/>
+                <a16:creationId xmlns:a16="http://schemas.microsoft.com/office/drawing/2014/main" id="{1AEB2D7A-3B24-4DA1-BC84-18C4FAFE3A14}"/>
               </a:ext>
             </a:extLst>
           </p:cNvPr>
@@ -5705,7 +5705,7 @@
           <p:cNvPr id="12" name="f12">
             <a:extLst xmlns:a="http://schemas.openxmlformats.org/drawingml/2006/main">
               <a:ext uri="{FF2B5EF4-FFF2-40B4-BE49-F238E27FC236}">
-                <a16:creationId xmlns:a16="http://schemas.microsoft.com/office/drawing/2014/main" id="{71DFBB5A-16BA-4251-8596-EDE21B18FEA8}"/>
+                <a16:creationId xmlns:a16="http://schemas.microsoft.com/office/drawing/2014/main" id="{55780277-F541-45F6-8F2B-8D7C5A9B90CA}"/>
               </a:ext>
             </a:extLst>
           </p:cNvPr>
@@ -5864,7 +5864,7 @@
           <p:cNvPr id="13" name="f13">
             <a:extLst xmlns:a="http://schemas.openxmlformats.org/drawingml/2006/main">
               <a:ext uri="{FF2B5EF4-FFF2-40B4-BE49-F238E27FC236}">
-                <a16:creationId xmlns:a16="http://schemas.microsoft.com/office/drawing/2014/main" id="{514769DD-76B8-4298-B3A1-6F8DE16A8DCA}"/>
+                <a16:creationId xmlns:a16="http://schemas.microsoft.com/office/drawing/2014/main" id="{33838266-49BE-4337-ACE4-9AA4098C4358}"/>
               </a:ext>
             </a:extLst>
           </p:cNvPr>
@@ -6023,7 +6023,7 @@
           <p:cNvPr id="14" name="f14">
             <a:extLst xmlns:a="http://schemas.openxmlformats.org/drawingml/2006/main">
               <a:ext uri="{FF2B5EF4-FFF2-40B4-BE49-F238E27FC236}">
-                <a16:creationId xmlns:a16="http://schemas.microsoft.com/office/drawing/2014/main" id="{8E326E81-D27C-462A-8BF7-78A32AD19B6E}"/>
+                <a16:creationId xmlns:a16="http://schemas.microsoft.com/office/drawing/2014/main" id="{0DA2BD25-AC39-4ED2-9298-079C9D5C2D5A}"/>
               </a:ext>
             </a:extLst>
           </p:cNvPr>
@@ -6182,7 +6182,7 @@
           <p:cNvPr id="15" name="f15">
             <a:extLst xmlns:a="http://schemas.openxmlformats.org/drawingml/2006/main">
               <a:ext uri="{FF2B5EF4-FFF2-40B4-BE49-F238E27FC236}">
-                <a16:creationId xmlns:a16="http://schemas.microsoft.com/office/drawing/2014/main" id="{E4D31AC5-7F1F-48CA-9947-25474E4A5CCE}"/>
+                <a16:creationId xmlns:a16="http://schemas.microsoft.com/office/drawing/2014/main" id="{2CC299C9-667B-4EA2-B6E5-9652A6E71B53}"/>
               </a:ext>
             </a:extLst>
           </p:cNvPr>
@@ -6341,7 +6341,7 @@
           <p:cNvPr id="16" name="f16">
             <a:extLst xmlns:a="http://schemas.openxmlformats.org/drawingml/2006/main">
               <a:ext uri="{FF2B5EF4-FFF2-40B4-BE49-F238E27FC236}">
-                <a16:creationId xmlns:a16="http://schemas.microsoft.com/office/drawing/2014/main" id="{9BE88533-0DEB-4B47-8CE1-5FAB2AFA19C5}"/>
+                <a16:creationId xmlns:a16="http://schemas.microsoft.com/office/drawing/2014/main" id="{82ABDDB2-A76C-4D3F-B010-A5D301072B40}"/>
               </a:ext>
             </a:extLst>
           </p:cNvPr>
@@ -6500,7 +6500,7 @@
           <p:cNvPr id="17" name="f17">
             <a:extLst xmlns:a="http://schemas.openxmlformats.org/drawingml/2006/main">
               <a:ext uri="{FF2B5EF4-FFF2-40B4-BE49-F238E27FC236}">
-                <a16:creationId xmlns:a16="http://schemas.microsoft.com/office/drawing/2014/main" id="{6C0DFD20-C3D4-4EBD-A214-F5E2D840E033}"/>
+                <a16:creationId xmlns:a16="http://schemas.microsoft.com/office/drawing/2014/main" id="{28545612-A992-49BA-94B3-7D9C6471A642}"/>
               </a:ext>
             </a:extLst>
           </p:cNvPr>
@@ -6659,7 +6659,7 @@
           <p:cNvPr id="18" name="f18">
             <a:extLst xmlns:a="http://schemas.openxmlformats.org/drawingml/2006/main">
               <a:ext uri="{FF2B5EF4-FFF2-40B4-BE49-F238E27FC236}">
-                <a16:creationId xmlns:a16="http://schemas.microsoft.com/office/drawing/2014/main" id="{6D722372-5245-4C38-B6D8-25C3891B95D2}"/>
+                <a16:creationId xmlns:a16="http://schemas.microsoft.com/office/drawing/2014/main" id="{EC47CD08-80E2-4169-A38C-485B65FC5A4C}"/>
               </a:ext>
             </a:extLst>
           </p:cNvPr>
@@ -6818,7 +6818,7 @@
           <p:cNvPr id="19" name="f19">
             <a:extLst xmlns:a="http://schemas.openxmlformats.org/drawingml/2006/main">
               <a:ext uri="{FF2B5EF4-FFF2-40B4-BE49-F238E27FC236}">
-                <a16:creationId xmlns:a16="http://schemas.microsoft.com/office/drawing/2014/main" id="{B199EFDA-42D0-426C-8E8A-26EDE8CA59A8}"/>
+                <a16:creationId xmlns:a16="http://schemas.microsoft.com/office/drawing/2014/main" id="{15B098D0-5631-476D-95F1-19FB35A51686}"/>
               </a:ext>
             </a:extLst>
           </p:cNvPr>
@@ -6977,7 +6977,7 @@
           <p:cNvPr id="20" name="f20">
             <a:extLst xmlns:a="http://schemas.openxmlformats.org/drawingml/2006/main">
               <a:ext uri="{FF2B5EF4-FFF2-40B4-BE49-F238E27FC236}">
-                <a16:creationId xmlns:a16="http://schemas.microsoft.com/office/drawing/2014/main" id="{D81B06AD-5025-45B0-9724-0F9A36D4704E}"/>
+                <a16:creationId xmlns:a16="http://schemas.microsoft.com/office/drawing/2014/main" id="{87274623-171C-41BC-9A9D-593D5682D4FC}"/>
               </a:ext>
             </a:extLst>
           </p:cNvPr>
@@ -7134,7 +7134,7 @@
     </p:spTree>
     <p:extLst>
       <p:ext uri="{BB962C8B-B14F-4D97-AF65-F5344CB8AC3E}">
-        <p14:creationId xmlns:p14="http://schemas.microsoft.com/office/powerpoint/2010/main" val="656116278"/>
+        <p14:creationId xmlns:p14="http://schemas.microsoft.com/office/powerpoint/2010/main" val="1210442549"/>
       </p:ext>
     </p:extLst>
   </p:cSld>
@@ -7165,7 +7165,7 @@
           <p:cNvPr id="24" name="f21">
             <a:extLst xmlns:a="http://schemas.openxmlformats.org/drawingml/2006/main">
               <a:ext uri="{FF2B5EF4-FFF2-40B4-BE49-F238E27FC236}">
-                <a16:creationId xmlns:a16="http://schemas.microsoft.com/office/drawing/2014/main" id="{EE4F07C7-2534-4DEC-84F7-332AB758DD07}"/>
+                <a16:creationId xmlns:a16="http://schemas.microsoft.com/office/drawing/2014/main" id="{8CB3FFCF-38F0-4A0D-9BC6-7ACA96271C9D}"/>
               </a:ext>
             </a:extLst>
           </p:cNvPr>
@@ -7324,7 +7324,7 @@
           <p:cNvPr id="2" name="f22">
             <a:extLst xmlns:a="http://schemas.openxmlformats.org/drawingml/2006/main">
               <a:ext uri="{FF2B5EF4-FFF2-40B4-BE49-F238E27FC236}">
-                <a16:creationId xmlns:a16="http://schemas.microsoft.com/office/drawing/2014/main" id="{1B81CBB5-11A0-4A34-B33F-E9E38469EE57}"/>
+                <a16:creationId xmlns:a16="http://schemas.microsoft.com/office/drawing/2014/main" id="{9BF28147-A552-4E06-8E48-B6B06355886E}"/>
               </a:ext>
             </a:extLst>
           </p:cNvPr>
@@ -7483,7 +7483,7 @@
           <p:cNvPr id="3" name="f23">
             <a:extLst xmlns:a="http://schemas.openxmlformats.org/drawingml/2006/main">
               <a:ext uri="{FF2B5EF4-FFF2-40B4-BE49-F238E27FC236}">
-                <a16:creationId xmlns:a16="http://schemas.microsoft.com/office/drawing/2014/main" id="{C7F02DD1-CBD3-4CBE-89BE-143B21199990}"/>
+                <a16:creationId xmlns:a16="http://schemas.microsoft.com/office/drawing/2014/main" id="{E6A41F6A-025B-4855-B3F0-3CCB4B07BE94}"/>
               </a:ext>
             </a:extLst>
           </p:cNvPr>
@@ -7642,7 +7642,7 @@
           <p:cNvPr id="4" name="f24">
             <a:extLst xmlns:a="http://schemas.openxmlformats.org/drawingml/2006/main">
               <a:ext uri="{FF2B5EF4-FFF2-40B4-BE49-F238E27FC236}">
-                <a16:creationId xmlns:a16="http://schemas.microsoft.com/office/drawing/2014/main" id="{1FABB5DB-BFA5-422A-978D-B80C3FBCC1B0}"/>
+                <a16:creationId xmlns:a16="http://schemas.microsoft.com/office/drawing/2014/main" id="{5BE1E8F8-2CD6-44C7-A347-B065AAE66E52}"/>
               </a:ext>
             </a:extLst>
           </p:cNvPr>
@@ -7654,7 +7654,7 @@
         <p:spPr>
           <a:xfrm xmlns:a="http://schemas.openxmlformats.org/drawingml/2006/main">
             <a:off x="1066800" y="2000250"/>
-            <a:ext cx="13106400" cy="704850"/>
+            <a:ext cx="13106400" cy="438150"/>
           </a:xfrm>
           <a:prstGeom xmlns:a="http://schemas.openxmlformats.org/drawingml/2006/main" prst="rect">
             <a:avLst/>
@@ -7791,30 +7791,7 @@
                 <a:ea typeface="Nimbus Sans"/>
                 <a:cs typeface="Nimbus Sans"/>
               </a:rPr>
-              <a:t>Definire un requisito di sicurezza non garantisce</a:t>
-            </a:r>
-          </a:p>
-          <a:p xmlns:a="http://schemas.openxmlformats.org/drawingml/2006/main">
-            <a:pPr algn="l">
-              <a:defRPr sz="2025" b="0">
-                <a:solidFill>
-                  <a:srgbClr val="52627B"/>
-                </a:solidFill>
-                <a:latin typeface="Nimbus Sans"/>
-                <a:ea typeface="Nimbus Sans"/>
-                <a:cs typeface="Nimbus Sans"/>
-              </a:defRPr>
-            </a:pPr>
-            <a:r>
-              <a:rPr sz="2025" b="0">
-                <a:solidFill>
-                  <a:srgbClr val="52627B"/>
-                </a:solidFill>
-                <a:latin typeface="Nimbus Sans"/>
-                <a:ea typeface="Nimbus Sans"/>
-                <a:cs typeface="Nimbus Sans"/>
-              </a:rPr>
-              <a:t>che venga rispettato.</a:t>
+              <a:t>Definire un requisito di sicurezza non garantisce che venga rispettato.</a:t>
             </a:r>
           </a:p>
         </p:txBody>
@@ -7824,7 +7801,7 @@
           <p:cNvPr id="5" name="f25">
             <a:extLst xmlns:a="http://schemas.openxmlformats.org/drawingml/2006/main">
               <a:ext uri="{FF2B5EF4-FFF2-40B4-BE49-F238E27FC236}">
-                <a16:creationId xmlns:a16="http://schemas.microsoft.com/office/drawing/2014/main" id="{ECB45CF5-FD6A-446E-80B7-F4DE4D345F38}"/>
+                <a16:creationId xmlns:a16="http://schemas.microsoft.com/office/drawing/2014/main" id="{40676EF3-07AA-45BC-A0E8-B20A03D4ECD0}"/>
               </a:ext>
             </a:extLst>
           </p:cNvPr>
@@ -7983,7 +7960,7 @@
           <p:cNvPr id="6" name="f26">
             <a:extLst xmlns:a="http://schemas.openxmlformats.org/drawingml/2006/main">
               <a:ext uri="{FF2B5EF4-FFF2-40B4-BE49-F238E27FC236}">
-                <a16:creationId xmlns:a16="http://schemas.microsoft.com/office/drawing/2014/main" id="{8C047153-FC70-4E7C-8FD4-450175CCB875}"/>
+                <a16:creationId xmlns:a16="http://schemas.microsoft.com/office/drawing/2014/main" id="{6778F7EC-FFE9-4F6D-9484-8745E1DE4A35}"/>
               </a:ext>
             </a:extLst>
           </p:cNvPr>
@@ -8142,7 +8119,7 @@
           <p:cNvPr id="7" name="f27">
             <a:extLst xmlns:a="http://schemas.openxmlformats.org/drawingml/2006/main">
               <a:ext uri="{FF2B5EF4-FFF2-40B4-BE49-F238E27FC236}">
-                <a16:creationId xmlns:a16="http://schemas.microsoft.com/office/drawing/2014/main" id="{3B30028B-CECE-41E3-AB3E-1D6767777716}"/>
+                <a16:creationId xmlns:a16="http://schemas.microsoft.com/office/drawing/2014/main" id="{793D4F68-A06C-483B-A4C6-F8C3F58896E0}"/>
               </a:ext>
             </a:extLst>
           </p:cNvPr>
@@ -8177,7 +8154,7 @@
           <p:cNvPr id="8" name="f28">
             <a:extLst xmlns:a="http://schemas.openxmlformats.org/drawingml/2006/main">
               <a:ext uri="{FF2B5EF4-FFF2-40B4-BE49-F238E27FC236}">
-                <a16:creationId xmlns:a16="http://schemas.microsoft.com/office/drawing/2014/main" id="{B651D717-EA02-4D25-9C10-184A823F19B4}"/>
+                <a16:creationId xmlns:a16="http://schemas.microsoft.com/office/drawing/2014/main" id="{AA900B61-2A66-4077-AB66-0AADEDCA2642}"/>
               </a:ext>
             </a:extLst>
           </p:cNvPr>
@@ -8208,7 +8185,7 @@
           <p:cNvPr id="9" name="f29">
             <a:extLst xmlns:a="http://schemas.openxmlformats.org/drawingml/2006/main">
               <a:ext uri="{FF2B5EF4-FFF2-40B4-BE49-F238E27FC236}">
-                <a16:creationId xmlns:a16="http://schemas.microsoft.com/office/drawing/2014/main" id="{707171A7-CC45-40E2-B5C8-E061F0DFDA38}"/>
+                <a16:creationId xmlns:a16="http://schemas.microsoft.com/office/drawing/2014/main" id="{B787AB46-108B-4A72-A6C8-8A11AB36F264}"/>
               </a:ext>
             </a:extLst>
           </p:cNvPr>
@@ -8239,7 +8216,7 @@
           <p:cNvPr id="10" name="f30">
             <a:extLst xmlns:a="http://schemas.openxmlformats.org/drawingml/2006/main">
               <a:ext uri="{FF2B5EF4-FFF2-40B4-BE49-F238E27FC236}">
-                <a16:creationId xmlns:a16="http://schemas.microsoft.com/office/drawing/2014/main" id="{6222371B-7084-4795-8174-548EEA63E3B3}"/>
+                <a16:creationId xmlns:a16="http://schemas.microsoft.com/office/drawing/2014/main" id="{41FD3305-911E-4D68-9B3C-02EDEAD9F207}"/>
               </a:ext>
             </a:extLst>
           </p:cNvPr>
@@ -8270,7 +8247,7 @@
           <p:cNvPr id="11" name="f31">
             <a:extLst xmlns:a="http://schemas.openxmlformats.org/drawingml/2006/main">
               <a:ext uri="{FF2B5EF4-FFF2-40B4-BE49-F238E27FC236}">
-                <a16:creationId xmlns:a16="http://schemas.microsoft.com/office/drawing/2014/main" id="{0AA83926-304D-4D87-96B8-C2AE8FB73C3D}"/>
+                <a16:creationId xmlns:a16="http://schemas.microsoft.com/office/drawing/2014/main" id="{CBA52584-C9D4-475C-8B87-26B5DB5A1C96}"/>
               </a:ext>
             </a:extLst>
           </p:cNvPr>
@@ -8305,7 +8282,7 @@
           <p:cNvPr id="12" name="f32">
             <a:extLst xmlns:a="http://schemas.openxmlformats.org/drawingml/2006/main">
               <a:ext uri="{FF2B5EF4-FFF2-40B4-BE49-F238E27FC236}">
-                <a16:creationId xmlns:a16="http://schemas.microsoft.com/office/drawing/2014/main" id="{C049790A-D613-41A6-BA80-02774A54BAE3}"/>
+                <a16:creationId xmlns:a16="http://schemas.microsoft.com/office/drawing/2014/main" id="{4ECAB9D3-6A18-431C-BBA5-6F96DED3709D}"/>
               </a:ext>
             </a:extLst>
           </p:cNvPr>
@@ -8336,7 +8313,7 @@
           <p:cNvPr id="13" name="f33">
             <a:extLst xmlns:a="http://schemas.openxmlformats.org/drawingml/2006/main">
               <a:ext uri="{FF2B5EF4-FFF2-40B4-BE49-F238E27FC236}">
-                <a16:creationId xmlns:a16="http://schemas.microsoft.com/office/drawing/2014/main" id="{A9247DF6-073F-475E-A694-09CEAB80B75A}"/>
+                <a16:creationId xmlns:a16="http://schemas.microsoft.com/office/drawing/2014/main" id="{AB62E352-E176-4CE1-B3A7-2516D93FDF46}"/>
               </a:ext>
             </a:extLst>
           </p:cNvPr>
@@ -8369,7 +8346,7 @@
           <p:cNvPr id="14" name="f34">
             <a:extLst xmlns:a="http://schemas.openxmlformats.org/drawingml/2006/main">
               <a:ext uri="{FF2B5EF4-FFF2-40B4-BE49-F238E27FC236}">
-                <a16:creationId xmlns:a16="http://schemas.microsoft.com/office/drawing/2014/main" id="{86616814-FB75-4C92-960A-6F54597D67DF}"/>
+                <a16:creationId xmlns:a16="http://schemas.microsoft.com/office/drawing/2014/main" id="{C24AC88F-72A9-46B0-A70C-7D38A52B3FA6}"/>
               </a:ext>
             </a:extLst>
           </p:cNvPr>
@@ -8402,7 +8379,7 @@
           <p:cNvPr id="15" name="f35">
             <a:extLst xmlns:a="http://schemas.openxmlformats.org/drawingml/2006/main">
               <a:ext uri="{FF2B5EF4-FFF2-40B4-BE49-F238E27FC236}">
-                <a16:creationId xmlns:a16="http://schemas.microsoft.com/office/drawing/2014/main" id="{B8425C6B-BED0-41E8-9830-881F5C641680}"/>
+                <a16:creationId xmlns:a16="http://schemas.microsoft.com/office/drawing/2014/main" id="{C1AE2DB6-16BA-4F30-8099-EDFDB565430F}"/>
               </a:ext>
             </a:extLst>
           </p:cNvPr>
@@ -8435,7 +8412,7 @@
           <p:cNvPr id="16" name="f36">
             <a:extLst xmlns:a="http://schemas.openxmlformats.org/drawingml/2006/main">
               <a:ext uri="{FF2B5EF4-FFF2-40B4-BE49-F238E27FC236}">
-                <a16:creationId xmlns:a16="http://schemas.microsoft.com/office/drawing/2014/main" id="{86BACB30-64B9-4CB5-A554-E792E518D7B4}"/>
+                <a16:creationId xmlns:a16="http://schemas.microsoft.com/office/drawing/2014/main" id="{BA0D7D9B-F878-48E4-A931-310DA8F02B95}"/>
               </a:ext>
             </a:extLst>
           </p:cNvPr>
@@ -8594,7 +8571,7 @@
           <p:cNvPr id="17" name="f37">
             <a:extLst xmlns:a="http://schemas.openxmlformats.org/drawingml/2006/main">
               <a:ext uri="{FF2B5EF4-FFF2-40B4-BE49-F238E27FC236}">
-                <a16:creationId xmlns:a16="http://schemas.microsoft.com/office/drawing/2014/main" id="{385596BE-6E4A-42CD-996B-2D030447A1FD}"/>
+                <a16:creationId xmlns:a16="http://schemas.microsoft.com/office/drawing/2014/main" id="{490A2AB2-125A-4123-9405-01AE0CB592D8}"/>
               </a:ext>
             </a:extLst>
           </p:cNvPr>
@@ -8625,7 +8602,7 @@
           <p:cNvPr id="18" name="f38">
             <a:extLst xmlns:a="http://schemas.openxmlformats.org/drawingml/2006/main">
               <a:ext uri="{FF2B5EF4-FFF2-40B4-BE49-F238E27FC236}">
-                <a16:creationId xmlns:a16="http://schemas.microsoft.com/office/drawing/2014/main" id="{99EEB5F3-A0E4-4D05-885A-45B67A937DBA}"/>
+                <a16:creationId xmlns:a16="http://schemas.microsoft.com/office/drawing/2014/main" id="{1766EF5B-E7C1-46D8-BFBD-2470D35F805F}"/>
               </a:ext>
             </a:extLst>
           </p:cNvPr>
@@ -8656,7 +8633,7 @@
           <p:cNvPr id="19" name="f39">
             <a:extLst xmlns:a="http://schemas.openxmlformats.org/drawingml/2006/main">
               <a:ext uri="{FF2B5EF4-FFF2-40B4-BE49-F238E27FC236}">
-                <a16:creationId xmlns:a16="http://schemas.microsoft.com/office/drawing/2014/main" id="{93C89A8F-92E1-465C-80BE-229130C2BAEF}"/>
+                <a16:creationId xmlns:a16="http://schemas.microsoft.com/office/drawing/2014/main" id="{4A86ED31-F2DC-4C61-9074-2860F1524B40}"/>
               </a:ext>
             </a:extLst>
           </p:cNvPr>
@@ -8691,7 +8668,7 @@
           <p:cNvPr id="20" name="f40">
             <a:extLst xmlns:a="http://schemas.openxmlformats.org/drawingml/2006/main">
               <a:ext uri="{FF2B5EF4-FFF2-40B4-BE49-F238E27FC236}">
-                <a16:creationId xmlns:a16="http://schemas.microsoft.com/office/drawing/2014/main" id="{2F19A0F2-0040-48F3-8084-3423B3BB6F43}"/>
+                <a16:creationId xmlns:a16="http://schemas.microsoft.com/office/drawing/2014/main" id="{638DF816-4637-4025-8CF1-0C1A25616C92}"/>
               </a:ext>
             </a:extLst>
           </p:cNvPr>
@@ -8873,7 +8850,7 @@
           <p:cNvPr id="21" name="f41">
             <a:extLst xmlns:a="http://schemas.openxmlformats.org/drawingml/2006/main">
               <a:ext uri="{FF2B5EF4-FFF2-40B4-BE49-F238E27FC236}">
-                <a16:creationId xmlns:a16="http://schemas.microsoft.com/office/drawing/2014/main" id="{4C6A8E9A-9FC0-454B-84BA-CD8EBF630B3E}"/>
+                <a16:creationId xmlns:a16="http://schemas.microsoft.com/office/drawing/2014/main" id="{5FEF9C71-5273-41C2-B05D-3EB6EF8798F9}"/>
               </a:ext>
             </a:extLst>
           </p:cNvPr>
@@ -9055,7 +9032,7 @@
           <p:cNvPr id="22" name="f42">
             <a:extLst xmlns:a="http://schemas.openxmlformats.org/drawingml/2006/main">
               <a:ext uri="{FF2B5EF4-FFF2-40B4-BE49-F238E27FC236}">
-                <a16:creationId xmlns:a16="http://schemas.microsoft.com/office/drawing/2014/main" id="{DB0779A4-76A9-4656-8CB7-C8C37EDA5E5F}"/>
+                <a16:creationId xmlns:a16="http://schemas.microsoft.com/office/drawing/2014/main" id="{96A85D91-0AEF-4D2C-96A7-12936BA8B67A}"/>
               </a:ext>
             </a:extLst>
           </p:cNvPr>
@@ -9214,7 +9191,7 @@
           <p:cNvPr id="23" name="f43">
             <a:extLst xmlns:a="http://schemas.openxmlformats.org/drawingml/2006/main">
               <a:ext uri="{FF2B5EF4-FFF2-40B4-BE49-F238E27FC236}">
-                <a16:creationId xmlns:a16="http://schemas.microsoft.com/office/drawing/2014/main" id="{795C192E-8F8B-4ED6-B0BE-D09D06F269ED}"/>
+                <a16:creationId xmlns:a16="http://schemas.microsoft.com/office/drawing/2014/main" id="{BF5D71EB-2F6A-4D39-A10C-8183318DF725}"/>
               </a:ext>
             </a:extLst>
           </p:cNvPr>
@@ -9371,7 +9348,7 @@
     </p:spTree>
     <p:extLst>
       <p:ext uri="{BB962C8B-B14F-4D97-AF65-F5344CB8AC3E}">
-        <p14:creationId xmlns:p14="http://schemas.microsoft.com/office/powerpoint/2010/main" val="984787665"/>
+        <p14:creationId xmlns:p14="http://schemas.microsoft.com/office/powerpoint/2010/main" val="194224418"/>
       </p:ext>
     </p:extLst>
   </p:cSld>
@@ -9399,10 +9376,10 @@
       </p:grpSpPr>
       <p:pic>
         <p:nvPicPr>
-          <p:cNvPr id="24" name="">
+          <p:cNvPr id="23" name="">
             <a:extLst xmlns:a="http://schemas.openxmlformats.org/drawingml/2006/main">
               <a:ext uri="{FF2B5EF4-FFF2-40B4-BE49-F238E27FC236}">
-                <a16:creationId xmlns:a16="http://schemas.microsoft.com/office/drawing/2014/main" id="{AB0F512A-5E18-4BAC-BB50-34FAA2FCDEB6}"/>
+                <a16:creationId xmlns:a16="http://schemas.microsoft.com/office/drawing/2014/main" id="{423523A1-599C-442D-9E0F-8DA550A09024}"/>
               </a:ext>
             </a:extLst>
           </p:cNvPr>
@@ -9412,7 +9389,7 @@
           <p:nvPr/>
         </p:nvPicPr>
         <p:blipFill>
-          <a:blip xmlns:r="http://schemas.openxmlformats.org/officeDocument/2006/relationships" xmlns:a="http://schemas.openxmlformats.org/drawingml/2006/main" r:embed="Rfa1b5a99505b4078"/>
+          <a:blip xmlns:r="http://schemas.openxmlformats.org/officeDocument/2006/relationships" xmlns:a="http://schemas.openxmlformats.org/drawingml/2006/main" r:embed="Rb7fdc70e3687479b"/>
           <a:stretch xmlns:a="http://schemas.openxmlformats.org/drawingml/2006/main"/>
         </p:blipFill>
         <p:spPr>
@@ -9430,7 +9407,7 @@
           <p:cNvPr id="2" name="f45">
             <a:extLst xmlns:a="http://schemas.openxmlformats.org/drawingml/2006/main">
               <a:ext uri="{FF2B5EF4-FFF2-40B4-BE49-F238E27FC236}">
-                <a16:creationId xmlns:a16="http://schemas.microsoft.com/office/drawing/2014/main" id="{7BE0F338-B1A1-4A5A-AB1B-F84A73C5AE61}"/>
+                <a16:creationId xmlns:a16="http://schemas.microsoft.com/office/drawing/2014/main" id="{7D75330C-B570-469B-B8CB-1A3EE13E4488}"/>
               </a:ext>
             </a:extLst>
           </p:cNvPr>
@@ -9589,7 +9566,7 @@
           <p:cNvPr id="3" name="f46">
             <a:extLst xmlns:a="http://schemas.openxmlformats.org/drawingml/2006/main">
               <a:ext uri="{FF2B5EF4-FFF2-40B4-BE49-F238E27FC236}">
-                <a16:creationId xmlns:a16="http://schemas.microsoft.com/office/drawing/2014/main" id="{148AA782-23A6-47FE-8D5F-1C6554B602C5}"/>
+                <a16:creationId xmlns:a16="http://schemas.microsoft.com/office/drawing/2014/main" id="{DF1E634D-0682-47BF-90FE-9C3B4BA3B63C}"/>
               </a:ext>
             </a:extLst>
           </p:cNvPr>
@@ -9748,7 +9725,7 @@
           <p:cNvPr id="4" name="f47">
             <a:extLst xmlns:a="http://schemas.openxmlformats.org/drawingml/2006/main">
               <a:ext uri="{FF2B5EF4-FFF2-40B4-BE49-F238E27FC236}">
-                <a16:creationId xmlns:a16="http://schemas.microsoft.com/office/drawing/2014/main" id="{AE824E0E-864A-420E-B720-82FD1A629BDB}"/>
+                <a16:creationId xmlns:a16="http://schemas.microsoft.com/office/drawing/2014/main" id="{F28DA352-8762-4B32-BE95-AB03C2FA062B}"/>
               </a:ext>
             </a:extLst>
           </p:cNvPr>
@@ -9907,7 +9884,7 @@
           <p:cNvPr id="5" name="f48">
             <a:extLst xmlns:a="http://schemas.openxmlformats.org/drawingml/2006/main">
               <a:ext uri="{FF2B5EF4-FFF2-40B4-BE49-F238E27FC236}">
-                <a16:creationId xmlns:a16="http://schemas.microsoft.com/office/drawing/2014/main" id="{7DB7494D-22A0-40DF-9016-BCEABD4111CC}"/>
+                <a16:creationId xmlns:a16="http://schemas.microsoft.com/office/drawing/2014/main" id="{AA42897C-E606-4EA9-BCA1-7F4D12308DE5}"/>
               </a:ext>
             </a:extLst>
           </p:cNvPr>
@@ -9919,7 +9896,7 @@
         <p:spPr>
           <a:xfrm xmlns:a="http://schemas.openxmlformats.org/drawingml/2006/main">
             <a:off x="1066800" y="1901095"/>
-            <a:ext cx="6726734" cy="347186"/>
+            <a:ext cx="12059096" cy="347186"/>
           </a:xfrm>
           <a:prstGeom xmlns:a="http://schemas.openxmlformats.org/drawingml/2006/main" prst="rect">
             <a:avLst/>
@@ -10056,7 +10033,7 @@
                 <a:ea typeface="Nimbus Sans"/>
                 <a:cs typeface="Nimbus Sans"/>
               </a:rPr>
-              <a:t>Nel 5G, la sicurezza riguarda anche le Network Functions,</a:t>
+              <a:t>Nel 5G, la sicurezza riguarda anche le Network Functions, componenti software che comunicano tra loro.</a:t>
             </a:r>
           </a:p>
         </p:txBody>
@@ -10066,7 +10043,7 @@
           <p:cNvPr id="6" name="f49">
             <a:extLst xmlns:a="http://schemas.openxmlformats.org/drawingml/2006/main">
               <a:ext uri="{FF2B5EF4-FFF2-40B4-BE49-F238E27FC236}">
-                <a16:creationId xmlns:a16="http://schemas.microsoft.com/office/drawing/2014/main" id="{D29580B1-BCC9-4877-99D0-8EA176E17A3B}"/>
+                <a16:creationId xmlns:a16="http://schemas.microsoft.com/office/drawing/2014/main" id="{B8E933E6-6D41-49AC-AE1F-A78FCAF0AF58}"/>
               </a:ext>
             </a:extLst>
           </p:cNvPr>
@@ -10077,166 +10054,7 @@
         </p:nvSpPr>
         <p:spPr>
           <a:xfrm xmlns:a="http://schemas.openxmlformats.org/drawingml/2006/main">
-            <a:off x="1066800" y="2263045"/>
-            <a:ext cx="5375225" cy="347186"/>
-          </a:xfrm>
-          <a:prstGeom xmlns:a="http://schemas.openxmlformats.org/drawingml/2006/main" prst="rect">
-            <a:avLst/>
-          </a:prstGeom>
-          <a:noFill xmlns:a="http://schemas.openxmlformats.org/drawingml/2006/main"/>
-          <a:ln xmlns:a="http://schemas.openxmlformats.org/drawingml/2006/main" w="0">
-            <a:noFill/>
-            <a:prstDash val="solid"/>
-          </a:ln>
-        </p:spPr>
-        <p:txBody>
-          <a:bodyPr xmlns:a="http://schemas.openxmlformats.org/drawingml/2006/main" wrap="none" lIns="0" tIns="0" rIns="0" bIns="0" anchor="t">
-            <a:noAutofit/>
-          </a:bodyPr>
-          <a:lstStyle xmlns:a="http://schemas.openxmlformats.org/drawingml/2006/main">
-            <a:defPPr algn="l">
-              <a:defRPr sz="2025" b="0">
-                <a:solidFill>
-                  <a:srgbClr val="52627B"/>
-                </a:solidFill>
-                <a:latin typeface="Nimbus Sans"/>
-                <a:ea typeface="Nimbus Sans"/>
-                <a:cs typeface="Nimbus Sans"/>
-              </a:defRPr>
-            </a:defPPr>
-            <a:lvl1pPr algn="l">
-              <a:defRPr sz="2025" b="0">
-                <a:solidFill>
-                  <a:srgbClr val="52627B"/>
-                </a:solidFill>
-                <a:latin typeface="Nimbus Sans"/>
-                <a:ea typeface="Nimbus Sans"/>
-                <a:cs typeface="Nimbus Sans"/>
-              </a:defRPr>
-            </a:lvl1pPr>
-            <a:lvl2pPr algn="l">
-              <a:defRPr sz="2025" b="0">
-                <a:solidFill>
-                  <a:srgbClr val="52627B"/>
-                </a:solidFill>
-                <a:latin typeface="Nimbus Sans"/>
-                <a:ea typeface="Nimbus Sans"/>
-                <a:cs typeface="Nimbus Sans"/>
-              </a:defRPr>
-            </a:lvl2pPr>
-            <a:lvl3pPr algn="l">
-              <a:defRPr sz="2025" b="0">
-                <a:solidFill>
-                  <a:srgbClr val="52627B"/>
-                </a:solidFill>
-                <a:latin typeface="Nimbus Sans"/>
-                <a:ea typeface="Nimbus Sans"/>
-                <a:cs typeface="Nimbus Sans"/>
-              </a:defRPr>
-            </a:lvl3pPr>
-            <a:lvl4pPr algn="l">
-              <a:defRPr sz="2025" b="0">
-                <a:solidFill>
-                  <a:srgbClr val="52627B"/>
-                </a:solidFill>
-                <a:latin typeface="Nimbus Sans"/>
-                <a:ea typeface="Nimbus Sans"/>
-                <a:cs typeface="Nimbus Sans"/>
-              </a:defRPr>
-            </a:lvl4pPr>
-            <a:lvl5pPr algn="l">
-              <a:defRPr sz="2025" b="0">
-                <a:solidFill>
-                  <a:srgbClr val="52627B"/>
-                </a:solidFill>
-                <a:latin typeface="Nimbus Sans"/>
-                <a:ea typeface="Nimbus Sans"/>
-                <a:cs typeface="Nimbus Sans"/>
-              </a:defRPr>
-            </a:lvl5pPr>
-            <a:lvl6pPr algn="l">
-              <a:defRPr sz="2025" b="0">
-                <a:solidFill>
-                  <a:srgbClr val="52627B"/>
-                </a:solidFill>
-                <a:latin typeface="Nimbus Sans"/>
-                <a:ea typeface="Nimbus Sans"/>
-                <a:cs typeface="Nimbus Sans"/>
-              </a:defRPr>
-            </a:lvl6pPr>
-            <a:lvl7pPr algn="l">
-              <a:defRPr sz="2025" b="0">
-                <a:solidFill>
-                  <a:srgbClr val="52627B"/>
-                </a:solidFill>
-                <a:latin typeface="Nimbus Sans"/>
-                <a:ea typeface="Nimbus Sans"/>
-                <a:cs typeface="Nimbus Sans"/>
-              </a:defRPr>
-            </a:lvl7pPr>
-            <a:lvl8pPr algn="l">
-              <a:defRPr sz="2025" b="0">
-                <a:solidFill>
-                  <a:srgbClr val="52627B"/>
-                </a:solidFill>
-                <a:latin typeface="Nimbus Sans"/>
-                <a:ea typeface="Nimbus Sans"/>
-                <a:cs typeface="Nimbus Sans"/>
-              </a:defRPr>
-            </a:lvl8pPr>
-            <a:lvl9pPr algn="l">
-              <a:defRPr sz="2025" b="0">
-                <a:solidFill>
-                  <a:srgbClr val="52627B"/>
-                </a:solidFill>
-                <a:latin typeface="Nimbus Sans"/>
-                <a:ea typeface="Nimbus Sans"/>
-                <a:cs typeface="Nimbus Sans"/>
-              </a:defRPr>
-            </a:lvl9pPr>
-          </a:lstStyle>
-          <a:p xmlns:a="http://schemas.openxmlformats.org/drawingml/2006/main">
-            <a:pPr algn="l">
-              <a:defRPr sz="2025" b="0">
-                <a:solidFill>
-                  <a:srgbClr val="52627B"/>
-                </a:solidFill>
-                <a:latin typeface="Nimbus Sans"/>
-                <a:ea typeface="Nimbus Sans"/>
-                <a:cs typeface="Nimbus Sans"/>
-              </a:defRPr>
-            </a:pPr>
-            <a:r>
-              <a:rPr sz="2025" b="0">
-                <a:solidFill>
-                  <a:srgbClr val="52627B"/>
-                </a:solidFill>
-                <a:latin typeface="Nimbus Sans"/>
-                <a:ea typeface="Nimbus Sans"/>
-                <a:cs typeface="Nimbus Sans"/>
-              </a:rPr>
-              <a:t>componenti software che comunicano tra loro.</a:t>
-            </a:r>
-          </a:p>
-        </p:txBody>
-      </p:sp>
-      <p:sp>
-        <p:nvSpPr>
-          <p:cNvPr id="7" name="f50">
-            <a:extLst xmlns:a="http://schemas.openxmlformats.org/drawingml/2006/main">
-              <a:ext uri="{FF2B5EF4-FFF2-40B4-BE49-F238E27FC236}">
-                <a16:creationId xmlns:a16="http://schemas.microsoft.com/office/drawing/2014/main" id="{E7444635-587D-409B-A44E-0096A36AE6C7}"/>
-              </a:ext>
-            </a:extLst>
-          </p:cNvPr>
-          <p:cNvSpPr>
-            <a:spLocks xmlns:a="http://schemas.openxmlformats.org/drawingml/2006/main" noGrp="1"/>
-          </p:cNvSpPr>
-          <p:nvPr/>
-        </p:nvSpPr>
-        <p:spPr>
-          <a:xfrm xmlns:a="http://schemas.openxmlformats.org/drawingml/2006/main">
-            <a:off x="2801234" y="3112930"/>
+            <a:off x="2801234" y="2750980"/>
             <a:ext cx="1302395" cy="424853"/>
           </a:xfrm>
           <a:prstGeom xmlns:a="http://schemas.openxmlformats.org/drawingml/2006/main" prst="rect">
@@ -10381,10 +10199,10 @@
       </p:sp>
       <p:sp>
         <p:nvSpPr>
-          <p:cNvPr id="8" name="f51">
+          <p:cNvPr id="7" name="f50">
             <a:extLst xmlns:a="http://schemas.openxmlformats.org/drawingml/2006/main">
               <a:ext uri="{FF2B5EF4-FFF2-40B4-BE49-F238E27FC236}">
-                <a16:creationId xmlns:a16="http://schemas.microsoft.com/office/drawing/2014/main" id="{2D4D9C5C-9AF0-43A9-8A52-095AECEE14DA}"/>
+                <a16:creationId xmlns:a16="http://schemas.microsoft.com/office/drawing/2014/main" id="{3E836F38-DFB3-4858-8B25-B8E0057702AE}"/>
               </a:ext>
             </a:extLst>
           </p:cNvPr>
@@ -10395,7 +10213,7 @@
         </p:nvSpPr>
         <p:spPr>
           <a:xfrm xmlns:a="http://schemas.openxmlformats.org/drawingml/2006/main">
-            <a:off x="7994359" y="3112930"/>
+            <a:off x="7994359" y="2750980"/>
             <a:ext cx="1526232" cy="424853"/>
           </a:xfrm>
           <a:prstGeom xmlns:a="http://schemas.openxmlformats.org/drawingml/2006/main" prst="rect">
@@ -10540,10 +10358,10 @@
       </p:sp>
       <p:sp>
         <p:nvSpPr>
-          <p:cNvPr id="9" name="f52">
+          <p:cNvPr id="8" name="f51">
             <a:extLst xmlns:a="http://schemas.openxmlformats.org/drawingml/2006/main">
               <a:ext uri="{FF2B5EF4-FFF2-40B4-BE49-F238E27FC236}">
-                <a16:creationId xmlns:a16="http://schemas.microsoft.com/office/drawing/2014/main" id="{251892E8-9C2A-4B07-982E-DF25AE7E2561}"/>
+                <a16:creationId xmlns:a16="http://schemas.microsoft.com/office/drawing/2014/main" id="{9FF42805-3588-4CE4-A4B0-30411C3600F5}"/>
               </a:ext>
             </a:extLst>
           </p:cNvPr>
@@ -10554,7 +10372,7 @@
         </p:nvSpPr>
         <p:spPr>
           <a:xfrm xmlns:a="http://schemas.openxmlformats.org/drawingml/2006/main">
-            <a:off x="5868924" y="3773925"/>
+            <a:off x="5868924" y="3411975"/>
             <a:ext cx="2156371" cy="318640"/>
           </a:xfrm>
           <a:prstGeom xmlns:a="http://schemas.openxmlformats.org/drawingml/2006/main" prst="rect">
@@ -10699,10 +10517,10 @@
       </p:sp>
       <p:sp>
         <p:nvSpPr>
-          <p:cNvPr id="10" name="f53">
+          <p:cNvPr id="9" name="f52">
             <a:extLst xmlns:a="http://schemas.openxmlformats.org/drawingml/2006/main">
               <a:ext uri="{FF2B5EF4-FFF2-40B4-BE49-F238E27FC236}">
-                <a16:creationId xmlns:a16="http://schemas.microsoft.com/office/drawing/2014/main" id="{2A99C243-091A-46A0-B640-0F20D59F535B}"/>
+                <a16:creationId xmlns:a16="http://schemas.microsoft.com/office/drawing/2014/main" id="{411EAB08-B9F8-4130-80AF-34431FF645EE}"/>
               </a:ext>
             </a:extLst>
           </p:cNvPr>
@@ -10713,7 +10531,7 @@
         </p:nvSpPr>
         <p:spPr>
           <a:xfrm xmlns:a="http://schemas.openxmlformats.org/drawingml/2006/main">
-            <a:off x="5868924" y="7494200"/>
+            <a:off x="5868924" y="7132250"/>
             <a:ext cx="1646783" cy="318640"/>
           </a:xfrm>
           <a:prstGeom xmlns:a="http://schemas.openxmlformats.org/drawingml/2006/main" prst="rect">
@@ -10858,10 +10676,10 @@
       </p:sp>
       <p:sp>
         <p:nvSpPr>
-          <p:cNvPr id="11" name="f54">
+          <p:cNvPr id="10" name="f53">
             <a:extLst xmlns:a="http://schemas.openxmlformats.org/drawingml/2006/main">
               <a:ext uri="{FF2B5EF4-FFF2-40B4-BE49-F238E27FC236}">
-                <a16:creationId xmlns:a16="http://schemas.microsoft.com/office/drawing/2014/main" id="{2C9E162A-EA22-4004-8636-4265920E1051}"/>
+                <a16:creationId xmlns:a16="http://schemas.microsoft.com/office/drawing/2014/main" id="{6F08BCC0-9B1E-4604-9824-F38904BC953D}"/>
               </a:ext>
             </a:extLst>
           </p:cNvPr>
@@ -10872,7 +10690,7 @@
         </p:nvSpPr>
         <p:spPr>
           <a:xfrm xmlns:a="http://schemas.openxmlformats.org/drawingml/2006/main">
-            <a:off x="6026789" y="4467402"/>
+            <a:off x="6026789" y="4105452"/>
             <a:ext cx="774502" cy="409680"/>
           </a:xfrm>
           <a:prstGeom xmlns:a="http://schemas.openxmlformats.org/drawingml/2006/main" prst="rect">
@@ -11017,10 +10835,10 @@
       </p:sp>
       <p:sp>
         <p:nvSpPr>
-          <p:cNvPr id="12" name="f55">
+          <p:cNvPr id="11" name="f54">
             <a:extLst xmlns:a="http://schemas.openxmlformats.org/drawingml/2006/main">
               <a:ext uri="{FF2B5EF4-FFF2-40B4-BE49-F238E27FC236}">
-                <a16:creationId xmlns:a16="http://schemas.microsoft.com/office/drawing/2014/main" id="{B7FB1F67-134E-4B39-9035-7C11DA0B8228}"/>
+                <a16:creationId xmlns:a16="http://schemas.microsoft.com/office/drawing/2014/main" id="{1A934ECB-56AA-4C78-9D08-CF11D54FC036}"/>
               </a:ext>
             </a:extLst>
           </p:cNvPr>
@@ -11031,7 +10849,7 @@
         </p:nvSpPr>
         <p:spPr>
           <a:xfrm xmlns:a="http://schemas.openxmlformats.org/drawingml/2006/main">
-            <a:off x="7563770" y="4467402"/>
+            <a:off x="7563770" y="4105452"/>
             <a:ext cx="757684" cy="409680"/>
           </a:xfrm>
           <a:prstGeom xmlns:a="http://schemas.openxmlformats.org/drawingml/2006/main" prst="rect">
@@ -11176,10 +10994,10 @@
       </p:sp>
       <p:sp>
         <p:nvSpPr>
-          <p:cNvPr id="13" name="f56">
+          <p:cNvPr id="12" name="f55">
             <a:extLst xmlns:a="http://schemas.openxmlformats.org/drawingml/2006/main">
               <a:ext uri="{FF2B5EF4-FFF2-40B4-BE49-F238E27FC236}">
-                <a16:creationId xmlns:a16="http://schemas.microsoft.com/office/drawing/2014/main" id="{00A237A0-E777-4F86-87B9-301651356401}"/>
+                <a16:creationId xmlns:a16="http://schemas.microsoft.com/office/drawing/2014/main" id="{F5ACEB8D-E859-4CFB-8E81-FBF4AC0DF766}"/>
               </a:ext>
             </a:extLst>
           </p:cNvPr>
@@ -11190,7 +11008,7 @@
         </p:nvSpPr>
         <p:spPr>
           <a:xfrm xmlns:a="http://schemas.openxmlformats.org/drawingml/2006/main">
-            <a:off x="9004087" y="4467402"/>
+            <a:off x="9004087" y="4105452"/>
             <a:ext cx="934194" cy="409680"/>
           </a:xfrm>
           <a:prstGeom xmlns:a="http://schemas.openxmlformats.org/drawingml/2006/main" prst="rect">
@@ -11335,10 +11153,10 @@
       </p:sp>
       <p:sp>
         <p:nvSpPr>
-          <p:cNvPr id="14" name="f57">
+          <p:cNvPr id="13" name="f56">
             <a:extLst xmlns:a="http://schemas.openxmlformats.org/drawingml/2006/main">
               <a:ext uri="{FF2B5EF4-FFF2-40B4-BE49-F238E27FC236}">
-                <a16:creationId xmlns:a16="http://schemas.microsoft.com/office/drawing/2014/main" id="{51083CA8-F41C-4651-9C67-0843A90C04C1}"/>
+                <a16:creationId xmlns:a16="http://schemas.microsoft.com/office/drawing/2014/main" id="{E82CA93B-77ED-4A49-B4FB-94AF788357B8}"/>
               </a:ext>
             </a:extLst>
           </p:cNvPr>
@@ -11349,7 +11167,7 @@
         </p:nvSpPr>
         <p:spPr>
           <a:xfrm xmlns:a="http://schemas.openxmlformats.org/drawingml/2006/main">
-            <a:off x="10595539" y="4467402"/>
+            <a:off x="10595539" y="4105452"/>
             <a:ext cx="808434" cy="409680"/>
           </a:xfrm>
           <a:prstGeom xmlns:a="http://schemas.openxmlformats.org/drawingml/2006/main" prst="rect">
@@ -11494,10 +11312,10 @@
       </p:sp>
       <p:sp>
         <p:nvSpPr>
-          <p:cNvPr id="15" name="f58">
+          <p:cNvPr id="14" name="f57">
             <a:extLst xmlns:a="http://schemas.openxmlformats.org/drawingml/2006/main">
               <a:ext uri="{FF2B5EF4-FFF2-40B4-BE49-F238E27FC236}">
-                <a16:creationId xmlns:a16="http://schemas.microsoft.com/office/drawing/2014/main" id="{213B8526-18FA-413A-8863-69B266763F28}"/>
+                <a16:creationId xmlns:a16="http://schemas.microsoft.com/office/drawing/2014/main" id="{4EC9C149-2225-46A7-B7E5-F476545ED1CD}"/>
               </a:ext>
             </a:extLst>
           </p:cNvPr>
@@ -11508,7 +11326,7 @@
         </p:nvSpPr>
         <p:spPr>
           <a:xfrm xmlns:a="http://schemas.openxmlformats.org/drawingml/2006/main">
-            <a:off x="7573667" y="6597400"/>
+            <a:off x="7573667" y="6235450"/>
             <a:ext cx="737890" cy="424853"/>
           </a:xfrm>
           <a:prstGeom xmlns:a="http://schemas.openxmlformats.org/drawingml/2006/main" prst="rect">
@@ -11653,10 +11471,10 @@
       </p:sp>
       <p:sp>
         <p:nvSpPr>
-          <p:cNvPr id="16" name="f59">
+          <p:cNvPr id="15" name="f58">
             <a:extLst xmlns:a="http://schemas.openxmlformats.org/drawingml/2006/main">
               <a:ext uri="{FF2B5EF4-FFF2-40B4-BE49-F238E27FC236}">
-                <a16:creationId xmlns:a16="http://schemas.microsoft.com/office/drawing/2014/main" id="{419C9AED-3A3B-45B2-A246-9A28EE2E01E5}"/>
+                <a16:creationId xmlns:a16="http://schemas.microsoft.com/office/drawing/2014/main" id="{5E08B6D7-C735-4362-A95A-B1E3F4416F55}"/>
               </a:ext>
             </a:extLst>
           </p:cNvPr>
@@ -11667,7 +11485,7 @@
         </p:nvSpPr>
         <p:spPr>
           <a:xfrm xmlns:a="http://schemas.openxmlformats.org/drawingml/2006/main">
-            <a:off x="11398758" y="3779432"/>
+            <a:off x="11398758" y="3417482"/>
             <a:ext cx="436662" cy="273120"/>
           </a:xfrm>
           <a:prstGeom xmlns:a="http://schemas.openxmlformats.org/drawingml/2006/main" prst="rect">
@@ -11812,10 +11630,10 @@
       </p:sp>
       <p:sp>
         <p:nvSpPr>
-          <p:cNvPr id="17" name="f60">
+          <p:cNvPr id="16" name="f59">
             <a:extLst xmlns:a="http://schemas.openxmlformats.org/drawingml/2006/main">
               <a:ext uri="{FF2B5EF4-FFF2-40B4-BE49-F238E27FC236}">
-                <a16:creationId xmlns:a16="http://schemas.microsoft.com/office/drawing/2014/main" id="{E2761B7E-DB4E-43DA-BAA7-31D2E91ABA05}"/>
+                <a16:creationId xmlns:a16="http://schemas.microsoft.com/office/drawing/2014/main" id="{7D8E5A4C-0264-4254-8980-61DEF06E62F9}"/>
               </a:ext>
             </a:extLst>
           </p:cNvPr>
@@ -11826,7 +11644,7 @@
         </p:nvSpPr>
         <p:spPr>
           <a:xfrm xmlns:a="http://schemas.openxmlformats.org/drawingml/2006/main">
-            <a:off x="8139303" y="5605964"/>
+            <a:off x="8139303" y="5244014"/>
             <a:ext cx="418654" cy="318640"/>
           </a:xfrm>
           <a:prstGeom xmlns:a="http://schemas.openxmlformats.org/drawingml/2006/main" prst="rect">
@@ -11971,10 +11789,10 @@
       </p:sp>
       <p:sp>
         <p:nvSpPr>
-          <p:cNvPr id="18" name="f61">
+          <p:cNvPr id="17" name="f60">
             <a:extLst xmlns:a="http://schemas.openxmlformats.org/drawingml/2006/main">
               <a:ext uri="{FF2B5EF4-FFF2-40B4-BE49-F238E27FC236}">
-                <a16:creationId xmlns:a16="http://schemas.microsoft.com/office/drawing/2014/main" id="{6A87CA0E-B6A5-497F-814D-83C8A92F1671}"/>
+                <a16:creationId xmlns:a16="http://schemas.microsoft.com/office/drawing/2014/main" id="{B35975A0-0E73-4675-B695-D2C925C61EC3}"/>
               </a:ext>
             </a:extLst>
           </p:cNvPr>
@@ -11985,7 +11803,7 @@
         </p:nvSpPr>
         <p:spPr>
           <a:xfrm xmlns:a="http://schemas.openxmlformats.org/drawingml/2006/main">
-            <a:off x="2286420" y="7423166"/>
+            <a:off x="2286420" y="7061216"/>
             <a:ext cx="511225" cy="379333"/>
           </a:xfrm>
           <a:prstGeom xmlns:a="http://schemas.openxmlformats.org/drawingml/2006/main" prst="rect">
@@ -12130,10 +11948,10 @@
       </p:sp>
       <p:sp>
         <p:nvSpPr>
-          <p:cNvPr id="19" name="f62">
+          <p:cNvPr id="18" name="f61">
             <a:extLst xmlns:a="http://schemas.openxmlformats.org/drawingml/2006/main">
               <a:ext uri="{FF2B5EF4-FFF2-40B4-BE49-F238E27FC236}">
-                <a16:creationId xmlns:a16="http://schemas.microsoft.com/office/drawing/2014/main" id="{90ACB01F-6B2B-4206-8B94-532802E3AEEA}"/>
+                <a16:creationId xmlns:a16="http://schemas.microsoft.com/office/drawing/2014/main" id="{DE788D6F-A820-4E4D-8FD0-83735BE74DAF}"/>
               </a:ext>
             </a:extLst>
           </p:cNvPr>
@@ -12144,7 +11962,7 @@
         </p:nvSpPr>
         <p:spPr>
           <a:xfrm xmlns:a="http://schemas.openxmlformats.org/drawingml/2006/main">
-            <a:off x="3753609" y="7423166"/>
+            <a:off x="3753609" y="7061216"/>
             <a:ext cx="701427" cy="379333"/>
           </a:xfrm>
           <a:prstGeom xmlns:a="http://schemas.openxmlformats.org/drawingml/2006/main" prst="rect">
@@ -12289,10 +12107,10 @@
       </p:sp>
       <p:sp>
         <p:nvSpPr>
-          <p:cNvPr id="20" name="f63">
+          <p:cNvPr id="19" name="f62">
             <a:extLst xmlns:a="http://schemas.openxmlformats.org/drawingml/2006/main">
               <a:ext uri="{FF2B5EF4-FFF2-40B4-BE49-F238E27FC236}">
-                <a16:creationId xmlns:a16="http://schemas.microsoft.com/office/drawing/2014/main" id="{ACD8190E-AAF9-4A81-952C-A56BD3EC8740}"/>
+                <a16:creationId xmlns:a16="http://schemas.microsoft.com/office/drawing/2014/main" id="{0FCEE583-597D-4B0A-9369-2C47F50DE32E}"/>
               </a:ext>
             </a:extLst>
           </p:cNvPr>
@@ -12303,7 +12121,7 @@
         </p:nvSpPr>
         <p:spPr>
           <a:xfrm xmlns:a="http://schemas.openxmlformats.org/drawingml/2006/main">
-            <a:off x="5018946" y="5313737"/>
+            <a:off x="5018946" y="4951787"/>
             <a:ext cx="418654" cy="318640"/>
           </a:xfrm>
           <a:prstGeom xmlns:a="http://schemas.openxmlformats.org/drawingml/2006/main" prst="rect">
@@ -12448,10 +12266,10 @@
       </p:sp>
       <p:sp>
         <p:nvSpPr>
-          <p:cNvPr id="21" name="f64">
+          <p:cNvPr id="20" name="f63">
             <a:extLst xmlns:a="http://schemas.openxmlformats.org/drawingml/2006/main">
               <a:ext uri="{FF2B5EF4-FFF2-40B4-BE49-F238E27FC236}">
-                <a16:creationId xmlns:a16="http://schemas.microsoft.com/office/drawing/2014/main" id="{16F835C2-9A98-48C0-A5DC-8EEF9BAB9ADB}"/>
+                <a16:creationId xmlns:a16="http://schemas.microsoft.com/office/drawing/2014/main" id="{0E4CCAF4-73DD-47B9-9DFA-1892B67039E5}"/>
               </a:ext>
             </a:extLst>
           </p:cNvPr>
@@ -12462,7 +12280,7 @@
         </p:nvSpPr>
         <p:spPr>
           <a:xfrm xmlns:a="http://schemas.openxmlformats.org/drawingml/2006/main">
-            <a:off x="6206109" y="6403968"/>
+            <a:off x="6206109" y="6042018"/>
             <a:ext cx="418654" cy="318640"/>
           </a:xfrm>
           <a:prstGeom xmlns:a="http://schemas.openxmlformats.org/drawingml/2006/main" prst="rect">
@@ -12607,10 +12425,10 @@
       </p:sp>
       <p:sp>
         <p:nvSpPr>
-          <p:cNvPr id="22" name="f65">
+          <p:cNvPr id="21" name="f64">
             <a:extLst xmlns:a="http://schemas.openxmlformats.org/drawingml/2006/main">
               <a:ext uri="{FF2B5EF4-FFF2-40B4-BE49-F238E27FC236}">
-                <a16:creationId xmlns:a16="http://schemas.microsoft.com/office/drawing/2014/main" id="{F733E88C-BB92-4110-97CE-06DD9AA5E501}"/>
+                <a16:creationId xmlns:a16="http://schemas.microsoft.com/office/drawing/2014/main" id="{5AAFAFD0-D881-4457-ADA6-48DBC34D7FF1}"/>
               </a:ext>
             </a:extLst>
           </p:cNvPr>
@@ -12621,7 +12439,7 @@
         </p:nvSpPr>
         <p:spPr>
           <a:xfrm xmlns:a="http://schemas.openxmlformats.org/drawingml/2006/main">
-            <a:off x="10544556" y="6403968"/>
+            <a:off x="10544556" y="6042018"/>
             <a:ext cx="418654" cy="318640"/>
           </a:xfrm>
           <a:prstGeom xmlns:a="http://schemas.openxmlformats.org/drawingml/2006/main" prst="rect">
@@ -12766,10 +12584,10 @@
       </p:sp>
       <p:sp>
         <p:nvSpPr>
-          <p:cNvPr id="23" name="f66">
+          <p:cNvPr id="22" name="f65">
             <a:extLst xmlns:a="http://schemas.openxmlformats.org/drawingml/2006/main">
               <a:ext uri="{FF2B5EF4-FFF2-40B4-BE49-F238E27FC236}">
-                <a16:creationId xmlns:a16="http://schemas.microsoft.com/office/drawing/2014/main" id="{CE558097-0493-4C58-8FE3-6A5408F7B34B}"/>
+                <a16:creationId xmlns:a16="http://schemas.microsoft.com/office/drawing/2014/main" id="{C6D359DF-C806-4215-8B48-084A3595E8FC}"/>
               </a:ext>
             </a:extLst>
           </p:cNvPr>
@@ -12780,7 +12598,7 @@
         </p:nvSpPr>
         <p:spPr>
           <a:xfrm xmlns:a="http://schemas.openxmlformats.org/drawingml/2006/main">
-            <a:off x="12291670" y="7423166"/>
+            <a:off x="12291670" y="7061216"/>
             <a:ext cx="1158925" cy="379333"/>
           </a:xfrm>
           <a:prstGeom xmlns:a="http://schemas.openxmlformats.org/drawingml/2006/main" prst="rect">
@@ -12926,7 +12744,7 @@
     </p:spTree>
     <p:extLst>
       <p:ext uri="{BB962C8B-B14F-4D97-AF65-F5344CB8AC3E}">
-        <p14:creationId xmlns:p14="http://schemas.microsoft.com/office/powerpoint/2010/main" val="1041079110"/>
+        <p14:creationId xmlns:p14="http://schemas.microsoft.com/office/powerpoint/2010/main" val="382457258"/>
       </p:ext>
     </p:extLst>
   </p:cSld>
@@ -12954,10 +12772,10 @@
       </p:grpSpPr>
       <p:sp>
         <p:nvSpPr>
-          <p:cNvPr id="18" name="f67">
+          <p:cNvPr id="18" name="f66">
             <a:extLst xmlns:a="http://schemas.openxmlformats.org/drawingml/2006/main">
               <a:ext uri="{FF2B5EF4-FFF2-40B4-BE49-F238E27FC236}">
-                <a16:creationId xmlns:a16="http://schemas.microsoft.com/office/drawing/2014/main" id="{882902BE-A316-467A-9FB0-13879BF73197}"/>
+                <a16:creationId xmlns:a16="http://schemas.microsoft.com/office/drawing/2014/main" id="{EC49C9F4-67C3-4032-9379-CC0C0BCAC7EB}"/>
               </a:ext>
             </a:extLst>
           </p:cNvPr>
@@ -13113,10 +12931,10 @@
       </p:sp>
       <p:sp>
         <p:nvSpPr>
-          <p:cNvPr id="2" name="f68">
+          <p:cNvPr id="2" name="f67">
             <a:extLst xmlns:a="http://schemas.openxmlformats.org/drawingml/2006/main">
               <a:ext uri="{FF2B5EF4-FFF2-40B4-BE49-F238E27FC236}">
-                <a16:creationId xmlns:a16="http://schemas.microsoft.com/office/drawing/2014/main" id="{90C948FB-77FB-4F49-9B8B-A6A94DB350C8}"/>
+                <a16:creationId xmlns:a16="http://schemas.microsoft.com/office/drawing/2014/main" id="{CCF1BC29-9354-4D6D-A57E-46F761865737}"/>
               </a:ext>
             </a:extLst>
           </p:cNvPr>
@@ -13272,10 +13090,10 @@
       </p:sp>
       <p:sp>
         <p:nvSpPr>
-          <p:cNvPr id="3" name="f69">
+          <p:cNvPr id="3" name="f68">
             <a:extLst xmlns:a="http://schemas.openxmlformats.org/drawingml/2006/main">
               <a:ext uri="{FF2B5EF4-FFF2-40B4-BE49-F238E27FC236}">
-                <a16:creationId xmlns:a16="http://schemas.microsoft.com/office/drawing/2014/main" id="{61A51454-21B0-4FE0-AD1F-EE46964CA83D}"/>
+                <a16:creationId xmlns:a16="http://schemas.microsoft.com/office/drawing/2014/main" id="{AD92D764-A0CE-458C-933C-284EA0287B10}"/>
               </a:ext>
             </a:extLst>
           </p:cNvPr>
@@ -13431,10 +13249,10 @@
       </p:sp>
       <p:sp>
         <p:nvSpPr>
-          <p:cNvPr id="4" name="f72">
+          <p:cNvPr id="4" name="f71">
             <a:extLst xmlns:a="http://schemas.openxmlformats.org/drawingml/2006/main">
               <a:ext uri="{FF2B5EF4-FFF2-40B4-BE49-F238E27FC236}">
-                <a16:creationId xmlns:a16="http://schemas.microsoft.com/office/drawing/2014/main" id="{BF5859FD-241F-4739-8380-1142F3FFE443}"/>
+                <a16:creationId xmlns:a16="http://schemas.microsoft.com/office/drawing/2014/main" id="{9EF78936-2487-48AE-8296-538B85854201}"/>
               </a:ext>
             </a:extLst>
           </p:cNvPr>
@@ -13446,7 +13264,7 @@
         <p:spPr>
           <a:xfrm xmlns:a="http://schemas.openxmlformats.org/drawingml/2006/main">
             <a:off x="1066800" y="2000250"/>
-            <a:ext cx="13106400" cy="704850"/>
+            <a:ext cx="13106400" cy="438150"/>
           </a:xfrm>
           <a:prstGeom xmlns:a="http://schemas.openxmlformats.org/drawingml/2006/main" prst="rect">
             <a:avLst/>
@@ -13583,30 +13401,7 @@
                 <a:ea typeface="Nimbus Sans"/>
                 <a:cs typeface="Nimbus Sans"/>
               </a:rPr>
-              <a:t>Il DSL permette di rappresentare queste operazioni</a:t>
-            </a:r>
-          </a:p>
-          <a:p xmlns:a="http://schemas.openxmlformats.org/drawingml/2006/main">
-            <a:pPr algn="l">
-              <a:defRPr sz="2025" b="0">
-                <a:solidFill>
-                  <a:srgbClr val="52627B"/>
-                </a:solidFill>
-                <a:latin typeface="Nimbus Sans"/>
-                <a:ea typeface="Nimbus Sans"/>
-                <a:cs typeface="Nimbus Sans"/>
-              </a:defRPr>
-            </a:pPr>
-            <a:r>
-              <a:rPr sz="2025" b="0">
-                <a:solidFill>
-                  <a:srgbClr val="52627B"/>
-                </a:solidFill>
-                <a:latin typeface="Nimbus Sans"/>
-                <a:ea typeface="Nimbus Sans"/>
-                <a:cs typeface="Nimbus Sans"/>
-              </a:rPr>
-              <a:t>attraverso regole riutilizzabili.</a:t>
+              <a:t>Il DSL permette di rappresentare queste operazioni attraverso regole riutilizzabili.</a:t>
             </a:r>
           </a:p>
         </p:txBody>
@@ -13616,7 +13411,7 @@
           <p:cNvPr id="5" name="f105">
             <a:extLst xmlns:a="http://schemas.openxmlformats.org/drawingml/2006/main">
               <a:ext uri="{FF2B5EF4-FFF2-40B4-BE49-F238E27FC236}">
-                <a16:creationId xmlns:a16="http://schemas.microsoft.com/office/drawing/2014/main" id="{6BE89582-A2F3-4ECA-9E67-8A3C2AD9246A}"/>
+                <a16:creationId xmlns:a16="http://schemas.microsoft.com/office/drawing/2014/main" id="{203B02F9-9D7D-4D0F-A6C9-604591925041}"/>
               </a:ext>
             </a:extLst>
           </p:cNvPr>
@@ -13765,7 +13560,7 @@
                 <a:ea typeface="Nimbus Sans"/>
                 <a:cs typeface="Nimbus Sans"/>
               </a:rPr>
-              <a:t>NRF Discovery Authorization</a:t>
+              <a:t>Rappresentazione della regola</a:t>
             </a:r>
           </a:p>
         </p:txBody>
@@ -13775,7 +13570,7 @@
           <p:cNvPr id="6" name="f106">
             <a:extLst xmlns:a="http://schemas.openxmlformats.org/drawingml/2006/main">
               <a:ext uri="{FF2B5EF4-FFF2-40B4-BE49-F238E27FC236}">
-                <a16:creationId xmlns:a16="http://schemas.microsoft.com/office/drawing/2014/main" id="{F18789A4-E6B1-4B86-A42E-2F12A3D865FF}"/>
+                <a16:creationId xmlns:a16="http://schemas.microsoft.com/office/drawing/2014/main" id="{CE66D002-BA51-4EED-A3AE-63F2C8C45F99}"/>
               </a:ext>
             </a:extLst>
           </p:cNvPr>
@@ -13786,12 +13581,12 @@
         </p:nvSpPr>
         <p:spPr>
           <a:xfrm xmlns:a="http://schemas.openxmlformats.org/drawingml/2006/main">
-            <a:off x="1066800" y="4000500"/>
-            <a:ext cx="7239000" cy="3657600"/>
+            <a:off x="1066800" y="3381375"/>
+            <a:ext cx="7239000" cy="3581400"/>
           </a:xfrm>
           <a:prstGeom xmlns:a="http://schemas.openxmlformats.org/drawingml/2006/main" prst="roundRect">
             <a:avLst>
-              <a:gd name="adj" fmla="val 4167"/>
+              <a:gd name="adj" fmla="val 4255"/>
             </a:avLst>
           </a:prstGeom>
           <a:solidFill xmlns:a="http://schemas.openxmlformats.org/drawingml/2006/main">
@@ -13810,7 +13605,7 @@
           <p:cNvPr id="7" name="f107">
             <a:extLst xmlns:a="http://schemas.openxmlformats.org/drawingml/2006/main">
               <a:ext uri="{FF2B5EF4-FFF2-40B4-BE49-F238E27FC236}">
-                <a16:creationId xmlns:a16="http://schemas.microsoft.com/office/drawing/2014/main" id="{09F1193A-D421-439F-A9F8-77481E968FBF}"/>
+                <a16:creationId xmlns:a16="http://schemas.microsoft.com/office/drawing/2014/main" id="{5D011F89-3A57-4F76-8728-99CE9620ECAF}"/>
               </a:ext>
             </a:extLst>
           </p:cNvPr>
@@ -13821,7 +13616,7 @@
         </p:nvSpPr>
         <p:spPr>
           <a:xfrm xmlns:a="http://schemas.openxmlformats.org/drawingml/2006/main">
-            <a:off x="1295400" y="4324350"/>
+            <a:off x="1295400" y="3638550"/>
             <a:ext cx="6781800" cy="419100"/>
           </a:xfrm>
           <a:prstGeom xmlns:a="http://schemas.openxmlformats.org/drawingml/2006/main" prst="rect">
@@ -13969,7 +13764,7 @@
           <p:cNvPr id="8" name="f108">
             <a:extLst xmlns:a="http://schemas.openxmlformats.org/drawingml/2006/main">
               <a:ext uri="{FF2B5EF4-FFF2-40B4-BE49-F238E27FC236}">
-                <a16:creationId xmlns:a16="http://schemas.microsoft.com/office/drawing/2014/main" id="{5884D5A1-60EB-4766-B421-A7C590E87E4E}"/>
+                <a16:creationId xmlns:a16="http://schemas.microsoft.com/office/drawing/2014/main" id="{60937D08-3012-44AE-8B2F-BE3DB4B76D5B}"/>
               </a:ext>
             </a:extLst>
           </p:cNvPr>
@@ -13980,7 +13775,7 @@
         </p:nvSpPr>
         <p:spPr>
           <a:xfrm xmlns:a="http://schemas.openxmlformats.org/drawingml/2006/main">
-            <a:off x="1295400" y="4752975"/>
+            <a:off x="1295400" y="4067175"/>
             <a:ext cx="6781800" cy="800100"/>
           </a:xfrm>
           <a:prstGeom xmlns:a="http://schemas.openxmlformats.org/drawingml/2006/main" prst="rect">
@@ -14151,7 +13946,7 @@
           <p:cNvPr id="9" name="f109">
             <a:extLst xmlns:a="http://schemas.openxmlformats.org/drawingml/2006/main">
               <a:ext uri="{FF2B5EF4-FFF2-40B4-BE49-F238E27FC236}">
-                <a16:creationId xmlns:a16="http://schemas.microsoft.com/office/drawing/2014/main" id="{B8AD8DFE-551D-4918-A242-037C8E47AF72}"/>
+                <a16:creationId xmlns:a16="http://schemas.microsoft.com/office/drawing/2014/main" id="{7C23A772-FD19-4338-B9B6-07121DBFADC0}"/>
               </a:ext>
             </a:extLst>
           </p:cNvPr>
@@ -14162,7 +13957,7 @@
         </p:nvSpPr>
         <p:spPr>
           <a:xfrm xmlns:a="http://schemas.openxmlformats.org/drawingml/2006/main">
-            <a:off x="1295400" y="5467350"/>
+            <a:off x="1295400" y="4781550"/>
             <a:ext cx="6781800" cy="381000"/>
           </a:xfrm>
           <a:prstGeom xmlns:a="http://schemas.openxmlformats.org/drawingml/2006/main" prst="rect">
@@ -14310,7 +14105,7 @@
           <p:cNvPr id="10" name="f110">
             <a:extLst xmlns:a="http://schemas.openxmlformats.org/drawingml/2006/main">
               <a:ext uri="{FF2B5EF4-FFF2-40B4-BE49-F238E27FC236}">
-                <a16:creationId xmlns:a16="http://schemas.microsoft.com/office/drawing/2014/main" id="{908B553A-1D33-4489-83D9-BD77FED71558}"/>
+                <a16:creationId xmlns:a16="http://schemas.microsoft.com/office/drawing/2014/main" id="{871998AE-699C-41EC-BA10-855746DF1032}"/>
               </a:ext>
             </a:extLst>
           </p:cNvPr>
@@ -14321,7 +14116,7 @@
         </p:nvSpPr>
         <p:spPr>
           <a:xfrm xmlns:a="http://schemas.openxmlformats.org/drawingml/2006/main">
-            <a:off x="1295400" y="6924675"/>
+            <a:off x="1295400" y="6238875"/>
             <a:ext cx="6781800" cy="419100"/>
           </a:xfrm>
           <a:prstGeom xmlns:a="http://schemas.openxmlformats.org/drawingml/2006/main" prst="rect">
@@ -14469,7 +14264,7 @@
           <p:cNvPr id="11" name="f111">
             <a:extLst xmlns:a="http://schemas.openxmlformats.org/drawingml/2006/main">
               <a:ext uri="{FF2B5EF4-FFF2-40B4-BE49-F238E27FC236}">
-                <a16:creationId xmlns:a16="http://schemas.microsoft.com/office/drawing/2014/main" id="{88513D94-9A56-41A8-A97F-E3ECB8562AF5}"/>
+                <a16:creationId xmlns:a16="http://schemas.microsoft.com/office/drawing/2014/main" id="{293C0933-2A78-4B2C-B318-EF2918F2ED39}"/>
               </a:ext>
             </a:extLst>
           </p:cNvPr>
@@ -14480,7 +14275,7 @@
         </p:nvSpPr>
         <p:spPr>
           <a:xfrm xmlns:a="http://schemas.openxmlformats.org/drawingml/2006/main">
-            <a:off x="8382000" y="4953000"/>
+            <a:off x="8382000" y="4381500"/>
             <a:ext cx="1428750" cy="171450"/>
           </a:xfrm>
           <a:prstGeom xmlns:a="http://schemas.openxmlformats.org/drawingml/2006/main" prst="leftArrow">
@@ -14500,7 +14295,7 @@
           <p:cNvPr id="12" name="f112">
             <a:extLst xmlns:a="http://schemas.openxmlformats.org/drawingml/2006/main">
               <a:ext uri="{FF2B5EF4-FFF2-40B4-BE49-F238E27FC236}">
-                <a16:creationId xmlns:a16="http://schemas.microsoft.com/office/drawing/2014/main" id="{C065348A-C38F-4E6C-98B3-4D3194C62A5A}"/>
+                <a16:creationId xmlns:a16="http://schemas.microsoft.com/office/drawing/2014/main" id="{E916163A-1BD5-4C2C-BF71-EA31C717DC5B}"/>
               </a:ext>
             </a:extLst>
           </p:cNvPr>
@@ -14511,7 +14306,7 @@
         </p:nvSpPr>
         <p:spPr>
           <a:xfrm xmlns:a="http://schemas.openxmlformats.org/drawingml/2006/main">
-            <a:off x="8382000" y="7048500"/>
+            <a:off x="8382000" y="6362700"/>
             <a:ext cx="1428750" cy="171450"/>
           </a:xfrm>
           <a:prstGeom xmlns:a="http://schemas.openxmlformats.org/drawingml/2006/main" prst="leftArrow">
@@ -14531,7 +14326,7 @@
           <p:cNvPr id="13" name="f113">
             <a:extLst xmlns:a="http://schemas.openxmlformats.org/drawingml/2006/main">
               <a:ext uri="{FF2B5EF4-FFF2-40B4-BE49-F238E27FC236}">
-                <a16:creationId xmlns:a16="http://schemas.microsoft.com/office/drawing/2014/main" id="{8DBCFD10-35FE-4784-A351-4F8B3F391501}"/>
+                <a16:creationId xmlns:a16="http://schemas.microsoft.com/office/drawing/2014/main" id="{AF90BA0E-869D-4A72-A1BB-50C2CA5DE990}"/>
               </a:ext>
             </a:extLst>
           </p:cNvPr>
@@ -14542,7 +14337,7 @@
         </p:nvSpPr>
         <p:spPr>
           <a:xfrm xmlns:a="http://schemas.openxmlformats.org/drawingml/2006/main">
-            <a:off x="1066800" y="7934325"/>
+            <a:off x="1066800" y="7239000"/>
             <a:ext cx="7239000" cy="323850"/>
           </a:xfrm>
           <a:prstGeom xmlns:a="http://schemas.openxmlformats.org/drawingml/2006/main" prst="rect">
@@ -14690,7 +14485,7 @@
           <p:cNvPr id="14" name="f114">
             <a:extLst xmlns:a="http://schemas.openxmlformats.org/drawingml/2006/main">
               <a:ext uri="{FF2B5EF4-FFF2-40B4-BE49-F238E27FC236}">
-                <a16:creationId xmlns:a16="http://schemas.microsoft.com/office/drawing/2014/main" id="{800FCF7F-25FB-4155-8C55-D2951BF4EEB6}"/>
+                <a16:creationId xmlns:a16="http://schemas.microsoft.com/office/drawing/2014/main" id="{21EC9D3D-53C6-4A90-A4F6-E28C6E7C9823}"/>
               </a:ext>
             </a:extLst>
           </p:cNvPr>
@@ -14701,7 +14496,7 @@
         </p:nvSpPr>
         <p:spPr>
           <a:xfrm xmlns:a="http://schemas.openxmlformats.org/drawingml/2006/main">
-            <a:off x="10001250" y="4429125"/>
+            <a:off x="10001250" y="3857625"/>
             <a:ext cx="4171950" cy="1219200"/>
           </a:xfrm>
           <a:prstGeom xmlns:a="http://schemas.openxmlformats.org/drawingml/2006/main" prst="roundRect">
@@ -14725,7 +14520,7 @@
           <p:cNvPr id="15" name="f115">
             <a:extLst xmlns:a="http://schemas.openxmlformats.org/drawingml/2006/main">
               <a:ext uri="{FF2B5EF4-FFF2-40B4-BE49-F238E27FC236}">
-                <a16:creationId xmlns:a16="http://schemas.microsoft.com/office/drawing/2014/main" id="{756F99DC-8BD5-4847-86E7-4DE0D2D9DFF2}"/>
+                <a16:creationId xmlns:a16="http://schemas.microsoft.com/office/drawing/2014/main" id="{406C6930-A031-4393-80EC-7F59B6A086FB}"/>
               </a:ext>
             </a:extLst>
           </p:cNvPr>
@@ -14736,7 +14531,7 @@
         </p:nvSpPr>
         <p:spPr>
           <a:xfrm xmlns:a="http://schemas.openxmlformats.org/drawingml/2006/main">
-            <a:off x="10191750" y="4676775"/>
+            <a:off x="10191750" y="4105275"/>
             <a:ext cx="3790950" cy="885825"/>
           </a:xfrm>
           <a:prstGeom xmlns:a="http://schemas.openxmlformats.org/drawingml/2006/main" prst="rect">
@@ -14907,7 +14702,7 @@
           <p:cNvPr id="16" name="f116">
             <a:extLst xmlns:a="http://schemas.openxmlformats.org/drawingml/2006/main">
               <a:ext uri="{FF2B5EF4-FFF2-40B4-BE49-F238E27FC236}">
-                <a16:creationId xmlns:a16="http://schemas.microsoft.com/office/drawing/2014/main" id="{8D2C59A9-5575-4C9F-8BA5-D0E3171210DE}"/>
+                <a16:creationId xmlns:a16="http://schemas.microsoft.com/office/drawing/2014/main" id="{B5A1EBCF-24A4-4156-926B-2ED5F8759A97}"/>
               </a:ext>
             </a:extLst>
           </p:cNvPr>
@@ -14918,7 +14713,7 @@
         </p:nvSpPr>
         <p:spPr>
           <a:xfrm xmlns:a="http://schemas.openxmlformats.org/drawingml/2006/main">
-            <a:off x="10001250" y="6524625"/>
+            <a:off x="10001250" y="5838825"/>
             <a:ext cx="4171950" cy="1219200"/>
           </a:xfrm>
           <a:prstGeom xmlns:a="http://schemas.openxmlformats.org/drawingml/2006/main" prst="roundRect">
@@ -14942,7 +14737,7 @@
           <p:cNvPr id="17" name="f117">
             <a:extLst xmlns:a="http://schemas.openxmlformats.org/drawingml/2006/main">
               <a:ext uri="{FF2B5EF4-FFF2-40B4-BE49-F238E27FC236}">
-                <a16:creationId xmlns:a16="http://schemas.microsoft.com/office/drawing/2014/main" id="{F6095C47-8CBE-4A13-AB88-3C5C4480DAF9}"/>
+                <a16:creationId xmlns:a16="http://schemas.microsoft.com/office/drawing/2014/main" id="{45C04275-589D-4323-B052-440ACDA1585C}"/>
               </a:ext>
             </a:extLst>
           </p:cNvPr>
@@ -14953,7 +14748,7 @@
         </p:nvSpPr>
         <p:spPr>
           <a:xfrm xmlns:a="http://schemas.openxmlformats.org/drawingml/2006/main">
-            <a:off x="10191750" y="6762750"/>
+            <a:off x="10191750" y="6076950"/>
             <a:ext cx="3790950" cy="885825"/>
           </a:xfrm>
           <a:prstGeom xmlns:a="http://schemas.openxmlformats.org/drawingml/2006/main" prst="rect">
@@ -15122,7 +14917,7 @@
     </p:spTree>
     <p:extLst>
       <p:ext uri="{BB962C8B-B14F-4D97-AF65-F5344CB8AC3E}">
-        <p14:creationId xmlns:p14="http://schemas.microsoft.com/office/powerpoint/2010/main" val="296700713"/>
+        <p14:creationId xmlns:p14="http://schemas.microsoft.com/office/powerpoint/2010/main" val="1981823958"/>
       </p:ext>
     </p:extLst>
   </p:cSld>
@@ -15153,7 +14948,7 @@
           <p:cNvPr id="15" name="">
             <a:extLst xmlns:a="http://schemas.openxmlformats.org/drawingml/2006/main">
               <a:ext uri="{FF2B5EF4-FFF2-40B4-BE49-F238E27FC236}">
-                <a16:creationId xmlns:a16="http://schemas.microsoft.com/office/drawing/2014/main" id="{2AD534DC-4080-4EE4-B65B-8D7992C1FA74}"/>
+                <a16:creationId xmlns:a16="http://schemas.microsoft.com/office/drawing/2014/main" id="{17727C81-12DF-4032-8B63-80D7830D9C6A}"/>
               </a:ext>
             </a:extLst>
           </p:cNvPr>
@@ -15163,7 +14958,7 @@
           <p:nvPr/>
         </p:nvPicPr>
         <p:blipFill>
-          <a:blip xmlns:r="http://schemas.openxmlformats.org/officeDocument/2006/relationships" xmlns:a="http://schemas.openxmlformats.org/drawingml/2006/main" r:embed="R8c1d0e4330e54982"/>
+          <a:blip xmlns:r="http://schemas.openxmlformats.org/officeDocument/2006/relationships" xmlns:a="http://schemas.openxmlformats.org/drawingml/2006/main" r:embed="R155686fbcecd4b65"/>
           <a:stretch xmlns:a="http://schemas.openxmlformats.org/drawingml/2006/main"/>
         </p:blipFill>
         <p:spPr>
@@ -15181,7 +14976,7 @@
           <p:cNvPr id="2" name="f119">
             <a:extLst xmlns:a="http://schemas.openxmlformats.org/drawingml/2006/main">
               <a:ext uri="{FF2B5EF4-FFF2-40B4-BE49-F238E27FC236}">
-                <a16:creationId xmlns:a16="http://schemas.microsoft.com/office/drawing/2014/main" id="{B5CF18BE-24AA-4662-A6F0-190DF52E184D}"/>
+                <a16:creationId xmlns:a16="http://schemas.microsoft.com/office/drawing/2014/main" id="{ACDC2D8F-2150-4304-9A67-23115AE4A6FC}"/>
               </a:ext>
             </a:extLst>
           </p:cNvPr>
@@ -15340,7 +15135,7 @@
           <p:cNvPr id="3" name="f120">
             <a:extLst xmlns:a="http://schemas.openxmlformats.org/drawingml/2006/main">
               <a:ext uri="{FF2B5EF4-FFF2-40B4-BE49-F238E27FC236}">
-                <a16:creationId xmlns:a16="http://schemas.microsoft.com/office/drawing/2014/main" id="{013FDCB5-4C5C-4E0C-86F2-23F2D8E177FA}"/>
+                <a16:creationId xmlns:a16="http://schemas.microsoft.com/office/drawing/2014/main" id="{BD28AB83-CE7A-4FBE-BA3C-07F791CABBB4}"/>
               </a:ext>
             </a:extLst>
           </p:cNvPr>
@@ -15499,7 +15294,7 @@
           <p:cNvPr id="4" name="f121">
             <a:extLst xmlns:a="http://schemas.openxmlformats.org/drawingml/2006/main">
               <a:ext uri="{FF2B5EF4-FFF2-40B4-BE49-F238E27FC236}">
-                <a16:creationId xmlns:a16="http://schemas.microsoft.com/office/drawing/2014/main" id="{9C2EB078-F21B-4BE9-8E83-423DE59E311B}"/>
+                <a16:creationId xmlns:a16="http://schemas.microsoft.com/office/drawing/2014/main" id="{6BEBC79C-4519-4562-A743-B1A7C0130BAB}"/>
               </a:ext>
             </a:extLst>
           </p:cNvPr>
@@ -15658,7 +15453,7 @@
           <p:cNvPr id="5" name="f122">
             <a:extLst xmlns:a="http://schemas.openxmlformats.org/drawingml/2006/main">
               <a:ext uri="{FF2B5EF4-FFF2-40B4-BE49-F238E27FC236}">
-                <a16:creationId xmlns:a16="http://schemas.microsoft.com/office/drawing/2014/main" id="{3637A451-F6AD-46C8-A435-66CFCBCC0839}"/>
+                <a16:creationId xmlns:a16="http://schemas.microsoft.com/office/drawing/2014/main" id="{CBE175BE-9CD9-4520-A08A-47D382F43CCF}"/>
               </a:ext>
             </a:extLst>
           </p:cNvPr>
@@ -15817,7 +15612,7 @@
           <p:cNvPr id="6" name="f123">
             <a:extLst xmlns:a="http://schemas.openxmlformats.org/drawingml/2006/main">
               <a:ext uri="{FF2B5EF4-FFF2-40B4-BE49-F238E27FC236}">
-                <a16:creationId xmlns:a16="http://schemas.microsoft.com/office/drawing/2014/main" id="{EC1A7182-5A61-43E6-A34B-D3B9956CCB6B}"/>
+                <a16:creationId xmlns:a16="http://schemas.microsoft.com/office/drawing/2014/main" id="{7BE6DE5F-4F0C-4976-84C1-A8972E9D440C}"/>
               </a:ext>
             </a:extLst>
           </p:cNvPr>
@@ -15976,7 +15771,7 @@
           <p:cNvPr id="7" name="f124">
             <a:extLst xmlns:a="http://schemas.openxmlformats.org/drawingml/2006/main">
               <a:ext uri="{FF2B5EF4-FFF2-40B4-BE49-F238E27FC236}">
-                <a16:creationId xmlns:a16="http://schemas.microsoft.com/office/drawing/2014/main" id="{576B5B23-61BC-416D-BF2E-79CBDB3292A6}"/>
+                <a16:creationId xmlns:a16="http://schemas.microsoft.com/office/drawing/2014/main" id="{C7F57453-DBED-4E00-A34A-196265D05EC1}"/>
               </a:ext>
             </a:extLst>
           </p:cNvPr>
@@ -16135,7 +15930,7 @@
           <p:cNvPr id="8" name="f125">
             <a:extLst xmlns:a="http://schemas.openxmlformats.org/drawingml/2006/main">
               <a:ext uri="{FF2B5EF4-FFF2-40B4-BE49-F238E27FC236}">
-                <a16:creationId xmlns:a16="http://schemas.microsoft.com/office/drawing/2014/main" id="{DD0AA4A9-A3C3-4D1D-A513-A44CC880C7B1}"/>
+                <a16:creationId xmlns:a16="http://schemas.microsoft.com/office/drawing/2014/main" id="{2E617DDE-DB62-4C5C-AE52-46EE4BCF1726}"/>
               </a:ext>
             </a:extLst>
           </p:cNvPr>
@@ -16294,7 +16089,7 @@
           <p:cNvPr id="9" name="f126">
             <a:extLst xmlns:a="http://schemas.openxmlformats.org/drawingml/2006/main">
               <a:ext uri="{FF2B5EF4-FFF2-40B4-BE49-F238E27FC236}">
-                <a16:creationId xmlns:a16="http://schemas.microsoft.com/office/drawing/2014/main" id="{082726BC-A7FC-4D2A-BD6B-480FA420C16C}"/>
+                <a16:creationId xmlns:a16="http://schemas.microsoft.com/office/drawing/2014/main" id="{F81327E1-5183-4B5F-9AA7-2AF209747A75}"/>
               </a:ext>
             </a:extLst>
           </p:cNvPr>
@@ -16453,7 +16248,7 @@
           <p:cNvPr id="10" name="f127">
             <a:extLst xmlns:a="http://schemas.openxmlformats.org/drawingml/2006/main">
               <a:ext uri="{FF2B5EF4-FFF2-40B4-BE49-F238E27FC236}">
-                <a16:creationId xmlns:a16="http://schemas.microsoft.com/office/drawing/2014/main" id="{DFB7656D-1D0F-4655-A7AA-C81FD1ED4349}"/>
+                <a16:creationId xmlns:a16="http://schemas.microsoft.com/office/drawing/2014/main" id="{CF8F7D91-2524-49A4-A4DF-BA85DEF31634}"/>
               </a:ext>
             </a:extLst>
           </p:cNvPr>
@@ -16612,7 +16407,7 @@
           <p:cNvPr id="11" name="f128">
             <a:extLst xmlns:a="http://schemas.openxmlformats.org/drawingml/2006/main">
               <a:ext uri="{FF2B5EF4-FFF2-40B4-BE49-F238E27FC236}">
-                <a16:creationId xmlns:a16="http://schemas.microsoft.com/office/drawing/2014/main" id="{4CF3EC47-A759-417A-87C4-2D91138F759A}"/>
+                <a16:creationId xmlns:a16="http://schemas.microsoft.com/office/drawing/2014/main" id="{2E022BCF-567A-4914-9886-220D7179C021}"/>
               </a:ext>
             </a:extLst>
           </p:cNvPr>
@@ -16771,7 +16566,7 @@
           <p:cNvPr id="12" name="f129">
             <a:extLst xmlns:a="http://schemas.openxmlformats.org/drawingml/2006/main">
               <a:ext uri="{FF2B5EF4-FFF2-40B4-BE49-F238E27FC236}">
-                <a16:creationId xmlns:a16="http://schemas.microsoft.com/office/drawing/2014/main" id="{D380B932-E18D-491E-BE13-0319E9382004}"/>
+                <a16:creationId xmlns:a16="http://schemas.microsoft.com/office/drawing/2014/main" id="{CDF3392D-E213-4583-AF94-2B681E0B0742}"/>
               </a:ext>
             </a:extLst>
           </p:cNvPr>
@@ -16930,7 +16725,7 @@
           <p:cNvPr id="13" name="f130">
             <a:extLst xmlns:a="http://schemas.openxmlformats.org/drawingml/2006/main">
               <a:ext uri="{FF2B5EF4-FFF2-40B4-BE49-F238E27FC236}">
-                <a16:creationId xmlns:a16="http://schemas.microsoft.com/office/drawing/2014/main" id="{9C31CD2B-E027-47B5-9759-50C98399ACEE}"/>
+                <a16:creationId xmlns:a16="http://schemas.microsoft.com/office/drawing/2014/main" id="{14AD9C07-8E6D-4167-AEDC-067AC6D14928}"/>
               </a:ext>
             </a:extLst>
           </p:cNvPr>
@@ -17089,7 +16884,7 @@
           <p:cNvPr id="14" name="f131">
             <a:extLst xmlns:a="http://schemas.openxmlformats.org/drawingml/2006/main">
               <a:ext uri="{FF2B5EF4-FFF2-40B4-BE49-F238E27FC236}">
-                <a16:creationId xmlns:a16="http://schemas.microsoft.com/office/drawing/2014/main" id="{8BAC995B-EBF7-4BFF-A56F-733A99528767}"/>
+                <a16:creationId xmlns:a16="http://schemas.microsoft.com/office/drawing/2014/main" id="{7F4FB262-0538-45C1-80F4-1264D9ECB912}"/>
               </a:ext>
             </a:extLst>
           </p:cNvPr>
@@ -17246,7 +17041,7 @@
     </p:spTree>
     <p:extLst>
       <p:ext uri="{BB962C8B-B14F-4D97-AF65-F5344CB8AC3E}">
-        <p14:creationId xmlns:p14="http://schemas.microsoft.com/office/powerpoint/2010/main" val="106827091"/>
+        <p14:creationId xmlns:p14="http://schemas.microsoft.com/office/powerpoint/2010/main" val="308923364"/>
       </p:ext>
     </p:extLst>
   </p:cSld>
@@ -17277,7 +17072,7 @@
           <p:cNvPr id="13" name="f132">
             <a:extLst xmlns:a="http://schemas.openxmlformats.org/drawingml/2006/main">
               <a:ext uri="{FF2B5EF4-FFF2-40B4-BE49-F238E27FC236}">
-                <a16:creationId xmlns:a16="http://schemas.microsoft.com/office/drawing/2014/main" id="{BB8EF939-DB91-43D5-9554-18DABA93056E}"/>
+                <a16:creationId xmlns:a16="http://schemas.microsoft.com/office/drawing/2014/main" id="{3C327F76-1DF6-4B2C-BAE8-EC66702C6655}"/>
               </a:ext>
             </a:extLst>
           </p:cNvPr>
@@ -17436,7 +17231,7 @@
           <p:cNvPr id="2" name="f133">
             <a:extLst xmlns:a="http://schemas.openxmlformats.org/drawingml/2006/main">
               <a:ext uri="{FF2B5EF4-FFF2-40B4-BE49-F238E27FC236}">
-                <a16:creationId xmlns:a16="http://schemas.microsoft.com/office/drawing/2014/main" id="{7D5791D2-D10A-4FAD-8AF8-1403DB23F60F}"/>
+                <a16:creationId xmlns:a16="http://schemas.microsoft.com/office/drawing/2014/main" id="{04BDE209-10E7-4F56-A01E-F83C25C78287}"/>
               </a:ext>
             </a:extLst>
           </p:cNvPr>
@@ -17595,7 +17390,7 @@
           <p:cNvPr id="3" name="f134">
             <a:extLst xmlns:a="http://schemas.openxmlformats.org/drawingml/2006/main">
               <a:ext uri="{FF2B5EF4-FFF2-40B4-BE49-F238E27FC236}">
-                <a16:creationId xmlns:a16="http://schemas.microsoft.com/office/drawing/2014/main" id="{6DAD045B-10E2-41CB-B366-BE64A035CAD0}"/>
+                <a16:creationId xmlns:a16="http://schemas.microsoft.com/office/drawing/2014/main" id="{3BD40488-02A2-46BA-881A-ACD57C8B0AFE}"/>
               </a:ext>
             </a:extLst>
           </p:cNvPr>
@@ -17754,7 +17549,7 @@
           <p:cNvPr id="4" name="f135">
             <a:extLst xmlns:a="http://schemas.openxmlformats.org/drawingml/2006/main">
               <a:ext uri="{FF2B5EF4-FFF2-40B4-BE49-F238E27FC236}">
-                <a16:creationId xmlns:a16="http://schemas.microsoft.com/office/drawing/2014/main" id="{8041F0DD-0437-4934-A72A-0820A4B29A27}"/>
+                <a16:creationId xmlns:a16="http://schemas.microsoft.com/office/drawing/2014/main" id="{55E3868C-103D-4C86-A2BD-5C2BED6ACD2D}"/>
               </a:ext>
             </a:extLst>
           </p:cNvPr>
@@ -17913,7 +17708,7 @@
           <p:cNvPr id="5" name="">
             <a:extLst xmlns:a="http://schemas.openxmlformats.org/drawingml/2006/main">
               <a:ext uri="{FF2B5EF4-FFF2-40B4-BE49-F238E27FC236}">
-                <a16:creationId xmlns:a16="http://schemas.microsoft.com/office/drawing/2014/main" id="{5836DC1D-6B45-414E-BAE6-CB63E4B0AC38}"/>
+                <a16:creationId xmlns:a16="http://schemas.microsoft.com/office/drawing/2014/main" id="{599EDAC5-B0A4-4BCE-AD21-1FBFA61992D3}"/>
               </a:ext>
             </a:extLst>
           </p:cNvPr>
@@ -17921,7 +17716,7 @@
           <p:nvPr/>
         </p:nvGraphicFramePr>
         <p:xfrm>
-          <a:off xmlns:a="http://schemas.openxmlformats.org/drawingml/2006/main" x="1066800" y="3076575"/>
+          <a:off xmlns:a="http://schemas.openxmlformats.org/drawingml/2006/main" x="1066800" y="2619375"/>
           <a:ext xmlns:a="http://schemas.openxmlformats.org/drawingml/2006/main" cx="9429750" cy="4162425"/>
         </p:xfrm>
         <a:graphic xmlns:a="http://schemas.openxmlformats.org/drawingml/2006/main">
@@ -18749,7 +18544,7 @@
           <p:cNvPr id="6" name="f137">
             <a:extLst xmlns:a="http://schemas.openxmlformats.org/drawingml/2006/main">
               <a:ext uri="{FF2B5EF4-FFF2-40B4-BE49-F238E27FC236}">
-                <a16:creationId xmlns:a16="http://schemas.microsoft.com/office/drawing/2014/main" id="{C693AC93-1C99-4E8E-880E-875B32D22E1A}"/>
+                <a16:creationId xmlns:a16="http://schemas.microsoft.com/office/drawing/2014/main" id="{4E8ECAA4-92C0-4962-8748-C48070E17113}"/>
               </a:ext>
             </a:extLst>
           </p:cNvPr>
@@ -18760,7 +18555,7 @@
         </p:nvSpPr>
         <p:spPr>
           <a:xfrm xmlns:a="http://schemas.openxmlformats.org/drawingml/2006/main">
-            <a:off x="11049000" y="3352800"/>
+            <a:off x="11049000" y="2895600"/>
             <a:ext cx="3124200" cy="2190750"/>
           </a:xfrm>
           <a:prstGeom xmlns:a="http://schemas.openxmlformats.org/drawingml/2006/main" prst="roundRect">
@@ -18784,7 +18579,7 @@
           <p:cNvPr id="7" name="f138">
             <a:extLst xmlns:a="http://schemas.openxmlformats.org/drawingml/2006/main">
               <a:ext uri="{FF2B5EF4-FFF2-40B4-BE49-F238E27FC236}">
-                <a16:creationId xmlns:a16="http://schemas.microsoft.com/office/drawing/2014/main" id="{C2B91122-EADA-4294-A30C-B16034E69964}"/>
+                <a16:creationId xmlns:a16="http://schemas.microsoft.com/office/drawing/2014/main" id="{DD1DDF96-FA31-4B98-B403-AA0D051E2161}"/>
               </a:ext>
             </a:extLst>
           </p:cNvPr>
@@ -18795,7 +18590,7 @@
         </p:nvSpPr>
         <p:spPr>
           <a:xfrm xmlns:a="http://schemas.openxmlformats.org/drawingml/2006/main">
-            <a:off x="11220450" y="3867150"/>
+            <a:off x="11220450" y="3409950"/>
             <a:ext cx="2781300" cy="971550"/>
           </a:xfrm>
           <a:prstGeom xmlns:a="http://schemas.openxmlformats.org/drawingml/2006/main" prst="rect">
@@ -18943,7 +18738,7 @@
           <p:cNvPr id="8" name="f139">
             <a:extLst xmlns:a="http://schemas.openxmlformats.org/drawingml/2006/main">
               <a:ext uri="{FF2B5EF4-FFF2-40B4-BE49-F238E27FC236}">
-                <a16:creationId xmlns:a16="http://schemas.microsoft.com/office/drawing/2014/main" id="{AC2C88D5-1730-4024-B4EA-DBA99A37A2C4}"/>
+                <a16:creationId xmlns:a16="http://schemas.microsoft.com/office/drawing/2014/main" id="{8925AF10-A27D-4B4E-AAA4-84CEF3DD52C0}"/>
               </a:ext>
             </a:extLst>
           </p:cNvPr>
@@ -18954,7 +18749,7 @@
         </p:nvSpPr>
         <p:spPr>
           <a:xfrm xmlns:a="http://schemas.openxmlformats.org/drawingml/2006/main">
-            <a:off x="11220450" y="4876800"/>
+            <a:off x="11220450" y="4419600"/>
             <a:ext cx="2781300" cy="400050"/>
           </a:xfrm>
           <a:prstGeom xmlns:a="http://schemas.openxmlformats.org/drawingml/2006/main" prst="rect">
@@ -19102,7 +18897,7 @@
           <p:cNvPr id="9" name="f140">
             <a:extLst xmlns:a="http://schemas.openxmlformats.org/drawingml/2006/main">
               <a:ext uri="{FF2B5EF4-FFF2-40B4-BE49-F238E27FC236}">
-                <a16:creationId xmlns:a16="http://schemas.microsoft.com/office/drawing/2014/main" id="{07EFBC96-30D2-49A3-9ECB-24BF17A3E19C}"/>
+                <a16:creationId xmlns:a16="http://schemas.microsoft.com/office/drawing/2014/main" id="{CBA63465-F630-473C-8C37-340A993DB60D}"/>
               </a:ext>
             </a:extLst>
           </p:cNvPr>
@@ -19113,7 +18908,7 @@
         </p:nvSpPr>
         <p:spPr>
           <a:xfrm xmlns:a="http://schemas.openxmlformats.org/drawingml/2006/main">
-            <a:off x="11258550" y="5924550"/>
+            <a:off x="11258550" y="5467350"/>
             <a:ext cx="2705100" cy="400050"/>
           </a:xfrm>
           <a:prstGeom xmlns:a="http://schemas.openxmlformats.org/drawingml/2006/main" prst="rect">
@@ -19261,7 +19056,7 @@
           <p:cNvPr id="10" name="f141">
             <a:extLst xmlns:a="http://schemas.openxmlformats.org/drawingml/2006/main">
               <a:ext uri="{FF2B5EF4-FFF2-40B4-BE49-F238E27FC236}">
-                <a16:creationId xmlns:a16="http://schemas.microsoft.com/office/drawing/2014/main" id="{E6CB828A-D891-443A-B9BD-1E9A73F51DEF}"/>
+                <a16:creationId xmlns:a16="http://schemas.microsoft.com/office/drawing/2014/main" id="{AB11A6BA-6100-48A2-AFFA-FFBB27B026FC}"/>
               </a:ext>
             </a:extLst>
           </p:cNvPr>
@@ -19272,7 +19067,7 @@
         </p:nvSpPr>
         <p:spPr>
           <a:xfrm xmlns:a="http://schemas.openxmlformats.org/drawingml/2006/main">
-            <a:off x="11258550" y="6448425"/>
+            <a:off x="11258550" y="5991225"/>
             <a:ext cx="2705100" cy="400050"/>
           </a:xfrm>
           <a:prstGeom xmlns:a="http://schemas.openxmlformats.org/drawingml/2006/main" prst="rect">
@@ -19420,7 +19215,7 @@
           <p:cNvPr id="11" name="f142">
             <a:extLst xmlns:a="http://schemas.openxmlformats.org/drawingml/2006/main">
               <a:ext uri="{FF2B5EF4-FFF2-40B4-BE49-F238E27FC236}">
-                <a16:creationId xmlns:a16="http://schemas.microsoft.com/office/drawing/2014/main" id="{4B58AB90-CEE2-4891-86D9-179B5CA5AFE3}"/>
+                <a16:creationId xmlns:a16="http://schemas.microsoft.com/office/drawing/2014/main" id="{6E5DAECD-DCB7-4F25-A275-86AE11249E47}"/>
               </a:ext>
             </a:extLst>
           </p:cNvPr>
@@ -19431,7 +19226,7 @@
         </p:nvSpPr>
         <p:spPr>
           <a:xfrm xmlns:a="http://schemas.openxmlformats.org/drawingml/2006/main">
-            <a:off x="11258550" y="6972300"/>
+            <a:off x="11258550" y="6515100"/>
             <a:ext cx="2705100" cy="381000"/>
           </a:xfrm>
           <a:prstGeom xmlns:a="http://schemas.openxmlformats.org/drawingml/2006/main" prst="rect">
@@ -19579,7 +19374,7 @@
           <p:cNvPr id="12" name="f143">
             <a:extLst xmlns:a="http://schemas.openxmlformats.org/drawingml/2006/main">
               <a:ext uri="{FF2B5EF4-FFF2-40B4-BE49-F238E27FC236}">
-                <a16:creationId xmlns:a16="http://schemas.microsoft.com/office/drawing/2014/main" id="{66F2D0D6-B584-4E60-A3D4-D743E1677DD1}"/>
+                <a16:creationId xmlns:a16="http://schemas.microsoft.com/office/drawing/2014/main" id="{142387E4-37F5-4C50-80D8-13C4F58E3CF0}"/>
               </a:ext>
             </a:extLst>
           </p:cNvPr>
@@ -19590,7 +19385,7 @@
         </p:nvSpPr>
         <p:spPr>
           <a:xfrm xmlns:a="http://schemas.openxmlformats.org/drawingml/2006/main">
-            <a:off x="1066800" y="7534275"/>
+            <a:off x="1066800" y="7077075"/>
             <a:ext cx="9429750" cy="285750"/>
           </a:xfrm>
           <a:prstGeom xmlns:a="http://schemas.openxmlformats.org/drawingml/2006/main" prst="rect">
@@ -19736,7 +19531,7 @@
     </p:spTree>
     <p:extLst>
       <p:ext uri="{BB962C8B-B14F-4D97-AF65-F5344CB8AC3E}">
-        <p14:creationId xmlns:p14="http://schemas.microsoft.com/office/powerpoint/2010/main" val="501538323"/>
+        <p14:creationId xmlns:p14="http://schemas.microsoft.com/office/powerpoint/2010/main" val="557509514"/>
       </p:ext>
     </p:extLst>
   </p:cSld>
@@ -19767,7 +19562,7 @@
           <p:cNvPr id="49" name="f144">
             <a:extLst xmlns:a="http://schemas.openxmlformats.org/drawingml/2006/main">
               <a:ext uri="{FF2B5EF4-FFF2-40B4-BE49-F238E27FC236}">
-                <a16:creationId xmlns:a16="http://schemas.microsoft.com/office/drawing/2014/main" id="{36C8E2FD-E395-4833-9439-C6CADDF0AD5B}"/>
+                <a16:creationId xmlns:a16="http://schemas.microsoft.com/office/drawing/2014/main" id="{1DDDF487-2240-452D-B61B-A2775F0C8F31}"/>
               </a:ext>
             </a:extLst>
           </p:cNvPr>
@@ -19926,7 +19721,7 @@
           <p:cNvPr id="2" name="f145">
             <a:extLst xmlns:a="http://schemas.openxmlformats.org/drawingml/2006/main">
               <a:ext uri="{FF2B5EF4-FFF2-40B4-BE49-F238E27FC236}">
-                <a16:creationId xmlns:a16="http://schemas.microsoft.com/office/drawing/2014/main" id="{00511CC5-4585-4AE5-817A-FE7D28CE2A9B}"/>
+                <a16:creationId xmlns:a16="http://schemas.microsoft.com/office/drawing/2014/main" id="{AFA9F55E-E6E1-4D8D-BADA-103EC1F974F9}"/>
               </a:ext>
             </a:extLst>
           </p:cNvPr>
@@ -20085,7 +19880,7 @@
           <p:cNvPr id="3" name="f146">
             <a:extLst xmlns:a="http://schemas.openxmlformats.org/drawingml/2006/main">
               <a:ext uri="{FF2B5EF4-FFF2-40B4-BE49-F238E27FC236}">
-                <a16:creationId xmlns:a16="http://schemas.microsoft.com/office/drawing/2014/main" id="{35043BA8-DC6C-4B64-AB82-DD67FD19A666}"/>
+                <a16:creationId xmlns:a16="http://schemas.microsoft.com/office/drawing/2014/main" id="{89C89C12-B965-46E7-A9F2-3925BFF74009}"/>
               </a:ext>
             </a:extLst>
           </p:cNvPr>
@@ -20244,7 +20039,7 @@
           <p:cNvPr id="4" name="f147">
             <a:extLst xmlns:a="http://schemas.openxmlformats.org/drawingml/2006/main">
               <a:ext uri="{FF2B5EF4-FFF2-40B4-BE49-F238E27FC236}">
-                <a16:creationId xmlns:a16="http://schemas.microsoft.com/office/drawing/2014/main" id="{96A5EE3F-4006-47EE-82D6-85A5BFC35A43}"/>
+                <a16:creationId xmlns:a16="http://schemas.microsoft.com/office/drawing/2014/main" id="{8E96D920-3FC0-489C-9337-34D1D91D4B6B}"/>
               </a:ext>
             </a:extLst>
           </p:cNvPr>
@@ -20403,7 +20198,7 @@
           <p:cNvPr id="5" name="f148">
             <a:extLst xmlns:a="http://schemas.openxmlformats.org/drawingml/2006/main">
               <a:ext uri="{FF2B5EF4-FFF2-40B4-BE49-F238E27FC236}">
-                <a16:creationId xmlns:a16="http://schemas.microsoft.com/office/drawing/2014/main" id="{B44E52BE-03CE-4BD5-A83E-B3AE251C0CB0}"/>
+                <a16:creationId xmlns:a16="http://schemas.microsoft.com/office/drawing/2014/main" id="{26586A5C-9C2C-4E52-AEDD-8F92C8E40361}"/>
               </a:ext>
             </a:extLst>
           </p:cNvPr>
@@ -20438,7 +20233,7 @@
           <p:cNvPr id="6" name="f149">
             <a:extLst xmlns:a="http://schemas.openxmlformats.org/drawingml/2006/main">
               <a:ext uri="{FF2B5EF4-FFF2-40B4-BE49-F238E27FC236}">
-                <a16:creationId xmlns:a16="http://schemas.microsoft.com/office/drawing/2014/main" id="{9B061945-26B3-4C5A-9BB9-97C5E0B14D2A}"/>
+                <a16:creationId xmlns:a16="http://schemas.microsoft.com/office/drawing/2014/main" id="{4553D562-E450-4CBF-AB0A-841DD2B1FDE8}"/>
               </a:ext>
             </a:extLst>
           </p:cNvPr>
@@ -20597,7 +20392,7 @@
           <p:cNvPr id="7" name="f150">
             <a:extLst xmlns:a="http://schemas.openxmlformats.org/drawingml/2006/main">
               <a:ext uri="{FF2B5EF4-FFF2-40B4-BE49-F238E27FC236}">
-                <a16:creationId xmlns:a16="http://schemas.microsoft.com/office/drawing/2014/main" id="{AF978F90-28D8-40CD-8151-3243465C6442}"/>
+                <a16:creationId xmlns:a16="http://schemas.microsoft.com/office/drawing/2014/main" id="{35FBC402-A4D0-4D86-8BC3-0A4AC2D62C01}"/>
               </a:ext>
             </a:extLst>
           </p:cNvPr>
@@ -20632,7 +20427,7 @@
           <p:cNvPr id="8" name="f151">
             <a:extLst xmlns:a="http://schemas.openxmlformats.org/drawingml/2006/main">
               <a:ext uri="{FF2B5EF4-FFF2-40B4-BE49-F238E27FC236}">
-                <a16:creationId xmlns:a16="http://schemas.microsoft.com/office/drawing/2014/main" id="{90F61FB3-0ED2-4646-AD90-6B3900AFAE80}"/>
+                <a16:creationId xmlns:a16="http://schemas.microsoft.com/office/drawing/2014/main" id="{09A7665F-1AA9-4034-B887-5A74DBD77070}"/>
               </a:ext>
             </a:extLst>
           </p:cNvPr>
@@ -20791,7 +20586,7 @@
           <p:cNvPr id="9" name="f152">
             <a:extLst xmlns:a="http://schemas.openxmlformats.org/drawingml/2006/main">
               <a:ext uri="{FF2B5EF4-FFF2-40B4-BE49-F238E27FC236}">
-                <a16:creationId xmlns:a16="http://schemas.microsoft.com/office/drawing/2014/main" id="{0BCB4A6B-9F89-4062-A343-F593F9520A92}"/>
+                <a16:creationId xmlns:a16="http://schemas.microsoft.com/office/drawing/2014/main" id="{032A6CD8-C12E-49DF-9C45-991B4315A69A}"/>
               </a:ext>
             </a:extLst>
           </p:cNvPr>
@@ -20826,7 +20621,7 @@
           <p:cNvPr id="10" name="f153">
             <a:extLst xmlns:a="http://schemas.openxmlformats.org/drawingml/2006/main">
               <a:ext uri="{FF2B5EF4-FFF2-40B4-BE49-F238E27FC236}">
-                <a16:creationId xmlns:a16="http://schemas.microsoft.com/office/drawing/2014/main" id="{8F92213C-EBD3-41E4-A835-6F6DB0B24264}"/>
+                <a16:creationId xmlns:a16="http://schemas.microsoft.com/office/drawing/2014/main" id="{2B86DCDF-2D6F-49B8-B7F6-2BB3749C2CAC}"/>
               </a:ext>
             </a:extLst>
           </p:cNvPr>
@@ -20985,7 +20780,7 @@
           <p:cNvPr id="11" name="f154">
             <a:extLst xmlns:a="http://schemas.openxmlformats.org/drawingml/2006/main">
               <a:ext uri="{FF2B5EF4-FFF2-40B4-BE49-F238E27FC236}">
-                <a16:creationId xmlns:a16="http://schemas.microsoft.com/office/drawing/2014/main" id="{5D05F89C-5664-472D-A05E-A7C22066DCE3}"/>
+                <a16:creationId xmlns:a16="http://schemas.microsoft.com/office/drawing/2014/main" id="{7180FAF6-3DC8-40A1-A2F5-140B5F252CBB}"/>
               </a:ext>
             </a:extLst>
           </p:cNvPr>
@@ -21020,7 +20815,7 @@
           <p:cNvPr id="12" name="f155">
             <a:extLst xmlns:a="http://schemas.openxmlformats.org/drawingml/2006/main">
               <a:ext uri="{FF2B5EF4-FFF2-40B4-BE49-F238E27FC236}">
-                <a16:creationId xmlns:a16="http://schemas.microsoft.com/office/drawing/2014/main" id="{8D18ED16-76CE-4BF2-A8C1-CF4CD73E7610}"/>
+                <a16:creationId xmlns:a16="http://schemas.microsoft.com/office/drawing/2014/main" id="{76159C0C-0534-4820-8DC5-E4699B6F5162}"/>
               </a:ext>
             </a:extLst>
           </p:cNvPr>
@@ -21179,7 +20974,7 @@
           <p:cNvPr id="13" name="f156">
             <a:extLst xmlns:a="http://schemas.openxmlformats.org/drawingml/2006/main">
               <a:ext uri="{FF2B5EF4-FFF2-40B4-BE49-F238E27FC236}">
-                <a16:creationId xmlns:a16="http://schemas.microsoft.com/office/drawing/2014/main" id="{960FE1D7-4D75-4370-A829-DE9D0B3F1C2F}"/>
+                <a16:creationId xmlns:a16="http://schemas.microsoft.com/office/drawing/2014/main" id="{483A3DF5-D15F-4FD7-A3ED-637359E09182}"/>
               </a:ext>
             </a:extLst>
           </p:cNvPr>
@@ -21214,7 +21009,7 @@
           <p:cNvPr id="14" name="f157">
             <a:extLst xmlns:a="http://schemas.openxmlformats.org/drawingml/2006/main">
               <a:ext uri="{FF2B5EF4-FFF2-40B4-BE49-F238E27FC236}">
-                <a16:creationId xmlns:a16="http://schemas.microsoft.com/office/drawing/2014/main" id="{4F7EE53B-1E04-45F6-BED5-E7FB30F3887A}"/>
+                <a16:creationId xmlns:a16="http://schemas.microsoft.com/office/drawing/2014/main" id="{0C68D93F-1CB2-4C4D-9004-76F2870941C7}"/>
               </a:ext>
             </a:extLst>
           </p:cNvPr>
@@ -21373,7 +21168,7 @@
           <p:cNvPr id="15" name="f158">
             <a:extLst xmlns:a="http://schemas.openxmlformats.org/drawingml/2006/main">
               <a:ext uri="{FF2B5EF4-FFF2-40B4-BE49-F238E27FC236}">
-                <a16:creationId xmlns:a16="http://schemas.microsoft.com/office/drawing/2014/main" id="{504AC6BB-360E-431E-9579-F94F97522DE1}"/>
+                <a16:creationId xmlns:a16="http://schemas.microsoft.com/office/drawing/2014/main" id="{3788064E-0621-47C8-A4F9-51417F3CDB47}"/>
               </a:ext>
             </a:extLst>
           </p:cNvPr>
@@ -21408,7 +21203,7 @@
           <p:cNvPr id="16" name="f159">
             <a:extLst xmlns:a="http://schemas.openxmlformats.org/drawingml/2006/main">
               <a:ext uri="{FF2B5EF4-FFF2-40B4-BE49-F238E27FC236}">
-                <a16:creationId xmlns:a16="http://schemas.microsoft.com/office/drawing/2014/main" id="{6468F176-8897-46EF-BD73-4652FD7F5C39}"/>
+                <a16:creationId xmlns:a16="http://schemas.microsoft.com/office/drawing/2014/main" id="{F338787D-A4D4-494A-AC05-6AF2D907E969}"/>
               </a:ext>
             </a:extLst>
           </p:cNvPr>
@@ -21590,7 +21385,7 @@
           <p:cNvPr id="17" name="f160">
             <a:extLst xmlns:a="http://schemas.openxmlformats.org/drawingml/2006/main">
               <a:ext uri="{FF2B5EF4-FFF2-40B4-BE49-F238E27FC236}">
-                <a16:creationId xmlns:a16="http://schemas.microsoft.com/office/drawing/2014/main" id="{2BD80425-EBEB-4548-9CF7-56A9786A4E46}"/>
+                <a16:creationId xmlns:a16="http://schemas.microsoft.com/office/drawing/2014/main" id="{18B439E4-F392-4E70-8F81-D07C0E7E418E}"/>
               </a:ext>
             </a:extLst>
           </p:cNvPr>
@@ -21625,7 +21420,7 @@
           <p:cNvPr id="18" name="f161">
             <a:extLst xmlns:a="http://schemas.openxmlformats.org/drawingml/2006/main">
               <a:ext uri="{FF2B5EF4-FFF2-40B4-BE49-F238E27FC236}">
-                <a16:creationId xmlns:a16="http://schemas.microsoft.com/office/drawing/2014/main" id="{8FA727AD-D593-4355-AA5E-634E6BFE9FCC}"/>
+                <a16:creationId xmlns:a16="http://schemas.microsoft.com/office/drawing/2014/main" id="{6C8915AE-5A18-439A-8AE5-C1F043E9FE0D}"/>
               </a:ext>
             </a:extLst>
           </p:cNvPr>
@@ -21784,7 +21579,7 @@
           <p:cNvPr id="19" name="f162">
             <a:extLst xmlns:a="http://schemas.openxmlformats.org/drawingml/2006/main">
               <a:ext uri="{FF2B5EF4-FFF2-40B4-BE49-F238E27FC236}">
-                <a16:creationId xmlns:a16="http://schemas.microsoft.com/office/drawing/2014/main" id="{A7C121FD-4A6E-48DA-B177-AE62C8DACB8C}"/>
+                <a16:creationId xmlns:a16="http://schemas.microsoft.com/office/drawing/2014/main" id="{5A3CA7E9-6F29-4349-8EAE-963E63818A42}"/>
               </a:ext>
             </a:extLst>
           </p:cNvPr>
@@ -21815,7 +21610,7 @@
           <p:cNvPr id="20" name="f163">
             <a:extLst xmlns:a="http://schemas.openxmlformats.org/drawingml/2006/main">
               <a:ext uri="{FF2B5EF4-FFF2-40B4-BE49-F238E27FC236}">
-                <a16:creationId xmlns:a16="http://schemas.microsoft.com/office/drawing/2014/main" id="{0CAAE774-6A55-4C91-A060-B270313A3BB0}"/>
+                <a16:creationId xmlns:a16="http://schemas.microsoft.com/office/drawing/2014/main" id="{73153D25-025B-45FB-A577-0E8B888545E9}"/>
               </a:ext>
             </a:extLst>
           </p:cNvPr>
@@ -21846,7 +21641,7 @@
           <p:cNvPr id="21" name="f164">
             <a:extLst xmlns:a="http://schemas.openxmlformats.org/drawingml/2006/main">
               <a:ext uri="{FF2B5EF4-FFF2-40B4-BE49-F238E27FC236}">
-                <a16:creationId xmlns:a16="http://schemas.microsoft.com/office/drawing/2014/main" id="{041D1625-208D-4735-9C37-D7A6F89D5F8E}"/>
+                <a16:creationId xmlns:a16="http://schemas.microsoft.com/office/drawing/2014/main" id="{BC771DFA-E54B-4108-999C-0FE1C3A7C8E4}"/>
               </a:ext>
             </a:extLst>
           </p:cNvPr>
@@ -21877,7 +21672,7 @@
           <p:cNvPr id="22" name="f165">
             <a:extLst xmlns:a="http://schemas.openxmlformats.org/drawingml/2006/main">
               <a:ext uri="{FF2B5EF4-FFF2-40B4-BE49-F238E27FC236}">
-                <a16:creationId xmlns:a16="http://schemas.microsoft.com/office/drawing/2014/main" id="{B90C2CBD-E2A6-4979-8D0C-D7BA57530A8E}"/>
+                <a16:creationId xmlns:a16="http://schemas.microsoft.com/office/drawing/2014/main" id="{28E57B43-2982-4C41-AFBD-FD12FA1C8757}"/>
               </a:ext>
             </a:extLst>
           </p:cNvPr>
@@ -21908,7 +21703,7 @@
           <p:cNvPr id="23" name="f166">
             <a:extLst xmlns:a="http://schemas.openxmlformats.org/drawingml/2006/main">
               <a:ext uri="{FF2B5EF4-FFF2-40B4-BE49-F238E27FC236}">
-                <a16:creationId xmlns:a16="http://schemas.microsoft.com/office/drawing/2014/main" id="{3D68551F-8EEA-470A-A10C-4201A1CF77DA}"/>
+                <a16:creationId xmlns:a16="http://schemas.microsoft.com/office/drawing/2014/main" id="{085DC25B-1477-4F97-9E57-C2326CC3100D}"/>
               </a:ext>
             </a:extLst>
           </p:cNvPr>
@@ -21939,7 +21734,7 @@
           <p:cNvPr id="24" name="f167">
             <a:extLst xmlns:a="http://schemas.openxmlformats.org/drawingml/2006/main">
               <a:ext uri="{FF2B5EF4-FFF2-40B4-BE49-F238E27FC236}">
-                <a16:creationId xmlns:a16="http://schemas.microsoft.com/office/drawing/2014/main" id="{5B16B8D8-F141-44C3-8BE2-1D422BD4ED3C}"/>
+                <a16:creationId xmlns:a16="http://schemas.microsoft.com/office/drawing/2014/main" id="{5FF97A97-77E0-469B-9083-DA21F13C1586}"/>
               </a:ext>
             </a:extLst>
           </p:cNvPr>
@@ -21970,7 +21765,7 @@
           <p:cNvPr id="25" name="f168">
             <a:extLst xmlns:a="http://schemas.openxmlformats.org/drawingml/2006/main">
               <a:ext uri="{FF2B5EF4-FFF2-40B4-BE49-F238E27FC236}">
-                <a16:creationId xmlns:a16="http://schemas.microsoft.com/office/drawing/2014/main" id="{B38E4ACB-55C6-4827-9CF1-CDF68D1363F4}"/>
+                <a16:creationId xmlns:a16="http://schemas.microsoft.com/office/drawing/2014/main" id="{689327B9-05D7-4FCB-BEA2-84FC4FABE238}"/>
               </a:ext>
             </a:extLst>
           </p:cNvPr>
@@ -22001,7 +21796,7 @@
           <p:cNvPr id="26" name="f169">
             <a:extLst xmlns:a="http://schemas.openxmlformats.org/drawingml/2006/main">
               <a:ext uri="{FF2B5EF4-FFF2-40B4-BE49-F238E27FC236}">
-                <a16:creationId xmlns:a16="http://schemas.microsoft.com/office/drawing/2014/main" id="{1FE75A4F-942A-4A63-8FE6-6B0FA51D8B10}"/>
+                <a16:creationId xmlns:a16="http://schemas.microsoft.com/office/drawing/2014/main" id="{13C6AB67-78A6-40A1-A828-1E83AFFECB11}"/>
               </a:ext>
             </a:extLst>
           </p:cNvPr>
@@ -22032,7 +21827,7 @@
           <p:cNvPr id="27" name="f170">
             <a:extLst xmlns:a="http://schemas.openxmlformats.org/drawingml/2006/main">
               <a:ext uri="{FF2B5EF4-FFF2-40B4-BE49-F238E27FC236}">
-                <a16:creationId xmlns:a16="http://schemas.microsoft.com/office/drawing/2014/main" id="{1D878B2E-6E34-4D1F-8B5C-1C9485B3E551}"/>
+                <a16:creationId xmlns:a16="http://schemas.microsoft.com/office/drawing/2014/main" id="{71F98747-0474-47FA-8086-51D8F3CE3F32}"/>
               </a:ext>
             </a:extLst>
           </p:cNvPr>
@@ -22063,7 +21858,7 @@
           <p:cNvPr id="28" name="f171">
             <a:extLst xmlns:a="http://schemas.openxmlformats.org/drawingml/2006/main">
               <a:ext uri="{FF2B5EF4-FFF2-40B4-BE49-F238E27FC236}">
-                <a16:creationId xmlns:a16="http://schemas.microsoft.com/office/drawing/2014/main" id="{2CD363E8-42C9-45A5-A394-44C541C99A0F}"/>
+                <a16:creationId xmlns:a16="http://schemas.microsoft.com/office/drawing/2014/main" id="{DFC60DF5-892E-4C97-90BB-0DE2742B7925}"/>
               </a:ext>
             </a:extLst>
           </p:cNvPr>
@@ -22094,7 +21889,7 @@
           <p:cNvPr id="29" name="f172">
             <a:extLst xmlns:a="http://schemas.openxmlformats.org/drawingml/2006/main">
               <a:ext uri="{FF2B5EF4-FFF2-40B4-BE49-F238E27FC236}">
-                <a16:creationId xmlns:a16="http://schemas.microsoft.com/office/drawing/2014/main" id="{0DBB869A-7999-4A8F-8B12-8AFDFA80E5D6}"/>
+                <a16:creationId xmlns:a16="http://schemas.microsoft.com/office/drawing/2014/main" id="{6CC3148C-7AF0-4649-BBAF-2F449C0E6141}"/>
               </a:ext>
             </a:extLst>
           </p:cNvPr>
@@ -22125,7 +21920,7 @@
           <p:cNvPr id="30" name="f173">
             <a:extLst xmlns:a="http://schemas.openxmlformats.org/drawingml/2006/main">
               <a:ext uri="{FF2B5EF4-FFF2-40B4-BE49-F238E27FC236}">
-                <a16:creationId xmlns:a16="http://schemas.microsoft.com/office/drawing/2014/main" id="{2A719C4B-8F82-4F08-BD8E-0B313E9E2D29}"/>
+                <a16:creationId xmlns:a16="http://schemas.microsoft.com/office/drawing/2014/main" id="{1F94A9E1-8ACD-4E1E-AB63-0B9073C65A02}"/>
               </a:ext>
             </a:extLst>
           </p:cNvPr>
@@ -22156,7 +21951,7 @@
           <p:cNvPr id="31" name="f174">
             <a:extLst xmlns:a="http://schemas.openxmlformats.org/drawingml/2006/main">
               <a:ext uri="{FF2B5EF4-FFF2-40B4-BE49-F238E27FC236}">
-                <a16:creationId xmlns:a16="http://schemas.microsoft.com/office/drawing/2014/main" id="{31B1CC4F-60E2-42D1-93F2-ED3B1EB22012}"/>
+                <a16:creationId xmlns:a16="http://schemas.microsoft.com/office/drawing/2014/main" id="{F086FB46-476F-424C-865A-FEE3640BB69C}"/>
               </a:ext>
             </a:extLst>
           </p:cNvPr>
@@ -22187,7 +21982,7 @@
           <p:cNvPr id="32" name="f175">
             <a:extLst xmlns:a="http://schemas.openxmlformats.org/drawingml/2006/main">
               <a:ext uri="{FF2B5EF4-FFF2-40B4-BE49-F238E27FC236}">
-                <a16:creationId xmlns:a16="http://schemas.microsoft.com/office/drawing/2014/main" id="{B192F68E-1246-42BF-92B7-E258D893B672}"/>
+                <a16:creationId xmlns:a16="http://schemas.microsoft.com/office/drawing/2014/main" id="{E657DBB7-0E07-4C82-B1BE-DA9895AEA06C}"/>
               </a:ext>
             </a:extLst>
           </p:cNvPr>
@@ -22218,7 +22013,7 @@
           <p:cNvPr id="33" name="f176">
             <a:extLst xmlns:a="http://schemas.openxmlformats.org/drawingml/2006/main">
               <a:ext uri="{FF2B5EF4-FFF2-40B4-BE49-F238E27FC236}">
-                <a16:creationId xmlns:a16="http://schemas.microsoft.com/office/drawing/2014/main" id="{9EF6BD25-F462-4669-A631-8CD87FF7D03D}"/>
+                <a16:creationId xmlns:a16="http://schemas.microsoft.com/office/drawing/2014/main" id="{1674C8AA-8714-4825-8D13-1BFD7D7AA969}"/>
               </a:ext>
             </a:extLst>
           </p:cNvPr>
@@ -22249,7 +22044,7 @@
           <p:cNvPr id="34" name="f177">
             <a:extLst xmlns:a="http://schemas.openxmlformats.org/drawingml/2006/main">
               <a:ext uri="{FF2B5EF4-FFF2-40B4-BE49-F238E27FC236}">
-                <a16:creationId xmlns:a16="http://schemas.microsoft.com/office/drawing/2014/main" id="{D89337D6-2A02-431A-BCF1-22DBAC12E387}"/>
+                <a16:creationId xmlns:a16="http://schemas.microsoft.com/office/drawing/2014/main" id="{E96B493D-1AB8-425B-9398-008013999E6E}"/>
               </a:ext>
             </a:extLst>
           </p:cNvPr>
@@ -22408,7 +22203,7 @@
           <p:cNvPr id="35" name="f178">
             <a:extLst xmlns:a="http://schemas.openxmlformats.org/drawingml/2006/main">
               <a:ext uri="{FF2B5EF4-FFF2-40B4-BE49-F238E27FC236}">
-                <a16:creationId xmlns:a16="http://schemas.microsoft.com/office/drawing/2014/main" id="{3B661E07-6C56-4A93-BBB7-6C4E8F381DB2}"/>
+                <a16:creationId xmlns:a16="http://schemas.microsoft.com/office/drawing/2014/main" id="{D6AA45BA-A915-43F7-9278-1FF1F0091132}"/>
               </a:ext>
             </a:extLst>
           </p:cNvPr>
@@ -22439,7 +22234,7 @@
           <p:cNvPr id="36" name="f179">
             <a:extLst xmlns:a="http://schemas.openxmlformats.org/drawingml/2006/main">
               <a:ext uri="{FF2B5EF4-FFF2-40B4-BE49-F238E27FC236}">
-                <a16:creationId xmlns:a16="http://schemas.microsoft.com/office/drawing/2014/main" id="{82C8195E-7D88-4636-8CB6-2EFEF8F8F0D0}"/>
+                <a16:creationId xmlns:a16="http://schemas.microsoft.com/office/drawing/2014/main" id="{187A2D89-B88C-45AB-99C0-24E13466B66F}"/>
               </a:ext>
             </a:extLst>
           </p:cNvPr>
@@ -22470,7 +22265,7 @@
           <p:cNvPr id="37" name="f180">
             <a:extLst xmlns:a="http://schemas.openxmlformats.org/drawingml/2006/main">
               <a:ext uri="{FF2B5EF4-FFF2-40B4-BE49-F238E27FC236}">
-                <a16:creationId xmlns:a16="http://schemas.microsoft.com/office/drawing/2014/main" id="{47F88311-20D5-4C1C-B66C-1AE03AB83125}"/>
+                <a16:creationId xmlns:a16="http://schemas.microsoft.com/office/drawing/2014/main" id="{D8B15C1C-FFDB-49DE-A6AF-C8D95B720805}"/>
               </a:ext>
             </a:extLst>
           </p:cNvPr>
@@ -22501,7 +22296,7 @@
           <p:cNvPr id="38" name="f181">
             <a:extLst xmlns:a="http://schemas.openxmlformats.org/drawingml/2006/main">
               <a:ext uri="{FF2B5EF4-FFF2-40B4-BE49-F238E27FC236}">
-                <a16:creationId xmlns:a16="http://schemas.microsoft.com/office/drawing/2014/main" id="{CDA596BB-DB51-4BF4-A0D0-8C37D93BC502}"/>
+                <a16:creationId xmlns:a16="http://schemas.microsoft.com/office/drawing/2014/main" id="{E67F4B52-FD79-4CB0-9681-CF61A545DA56}"/>
               </a:ext>
             </a:extLst>
           </p:cNvPr>
@@ -22532,7 +22327,7 @@
           <p:cNvPr id="39" name="f182">
             <a:extLst xmlns:a="http://schemas.openxmlformats.org/drawingml/2006/main">
               <a:ext uri="{FF2B5EF4-FFF2-40B4-BE49-F238E27FC236}">
-                <a16:creationId xmlns:a16="http://schemas.microsoft.com/office/drawing/2014/main" id="{A77D9290-0020-4231-9589-56554E540FC3}"/>
+                <a16:creationId xmlns:a16="http://schemas.microsoft.com/office/drawing/2014/main" id="{759989F0-EFD3-4463-9B2E-023F73D0057B}"/>
               </a:ext>
             </a:extLst>
           </p:cNvPr>
@@ -22563,7 +22358,7 @@
           <p:cNvPr id="40" name="f183">
             <a:extLst xmlns:a="http://schemas.openxmlformats.org/drawingml/2006/main">
               <a:ext uri="{FF2B5EF4-FFF2-40B4-BE49-F238E27FC236}">
-                <a16:creationId xmlns:a16="http://schemas.microsoft.com/office/drawing/2014/main" id="{BA20F3D6-2581-4AD1-B548-AE1DC4368CF3}"/>
+                <a16:creationId xmlns:a16="http://schemas.microsoft.com/office/drawing/2014/main" id="{E63C763D-43EF-4733-882A-A627F84B1604}"/>
               </a:ext>
             </a:extLst>
           </p:cNvPr>
@@ -22594,7 +22389,7 @@
           <p:cNvPr id="41" name="f184">
             <a:extLst xmlns:a="http://schemas.openxmlformats.org/drawingml/2006/main">
               <a:ext uri="{FF2B5EF4-FFF2-40B4-BE49-F238E27FC236}">
-                <a16:creationId xmlns:a16="http://schemas.microsoft.com/office/drawing/2014/main" id="{D4985726-9C0B-467E-AB92-D8EA45206DE2}"/>
+                <a16:creationId xmlns:a16="http://schemas.microsoft.com/office/drawing/2014/main" id="{2418BC82-1F6F-43AC-8DA5-CA029F5D9B92}"/>
               </a:ext>
             </a:extLst>
           </p:cNvPr>
@@ -22625,7 +22420,7 @@
           <p:cNvPr id="42" name="f185">
             <a:extLst xmlns:a="http://schemas.openxmlformats.org/drawingml/2006/main">
               <a:ext uri="{FF2B5EF4-FFF2-40B4-BE49-F238E27FC236}">
-                <a16:creationId xmlns:a16="http://schemas.microsoft.com/office/drawing/2014/main" id="{33C5751C-1092-4652-86EC-9172A5590746}"/>
+                <a16:creationId xmlns:a16="http://schemas.microsoft.com/office/drawing/2014/main" id="{4164A735-0E79-418B-BCC0-048ABFE025FA}"/>
               </a:ext>
             </a:extLst>
           </p:cNvPr>
@@ -22656,7 +22451,7 @@
           <p:cNvPr id="43" name="f186">
             <a:extLst xmlns:a="http://schemas.openxmlformats.org/drawingml/2006/main">
               <a:ext uri="{FF2B5EF4-FFF2-40B4-BE49-F238E27FC236}">
-                <a16:creationId xmlns:a16="http://schemas.microsoft.com/office/drawing/2014/main" id="{339E2951-48DF-43D4-BD7B-43B9B3B04989}"/>
+                <a16:creationId xmlns:a16="http://schemas.microsoft.com/office/drawing/2014/main" id="{E621B0A4-E124-41F9-BF3F-BD26980DCE48}"/>
               </a:ext>
             </a:extLst>
           </p:cNvPr>
@@ -22687,7 +22482,7 @@
           <p:cNvPr id="44" name="f187">
             <a:extLst xmlns:a="http://schemas.openxmlformats.org/drawingml/2006/main">
               <a:ext uri="{FF2B5EF4-FFF2-40B4-BE49-F238E27FC236}">
-                <a16:creationId xmlns:a16="http://schemas.microsoft.com/office/drawing/2014/main" id="{F637F04B-ED7D-43B3-B7E4-7E057609FC8A}"/>
+                <a16:creationId xmlns:a16="http://schemas.microsoft.com/office/drawing/2014/main" id="{7C24E027-ECAD-46F7-8DCB-9C8829F2BB4B}"/>
               </a:ext>
             </a:extLst>
           </p:cNvPr>
@@ -22718,7 +22513,7 @@
           <p:cNvPr id="45" name="f188">
             <a:extLst xmlns:a="http://schemas.openxmlformats.org/drawingml/2006/main">
               <a:ext uri="{FF2B5EF4-FFF2-40B4-BE49-F238E27FC236}">
-                <a16:creationId xmlns:a16="http://schemas.microsoft.com/office/drawing/2014/main" id="{E92FACDB-EC1C-4CFF-B7F2-D7509A98A63D}"/>
+                <a16:creationId xmlns:a16="http://schemas.microsoft.com/office/drawing/2014/main" id="{F4B8E756-B76C-4B86-B251-C5461BB3DA31}"/>
               </a:ext>
             </a:extLst>
           </p:cNvPr>
@@ -22877,7 +22672,7 @@
           <p:cNvPr id="46" name="">
             <a:extLst xmlns:a="http://schemas.openxmlformats.org/drawingml/2006/main">
               <a:ext uri="{FF2B5EF4-FFF2-40B4-BE49-F238E27FC236}">
-                <a16:creationId xmlns:a16="http://schemas.microsoft.com/office/drawing/2014/main" id="{CA704290-E133-4404-879E-70F4EEEA9CA1}"/>
+                <a16:creationId xmlns:a16="http://schemas.microsoft.com/office/drawing/2014/main" id="{50F8AB88-FDD7-4FC1-AA5F-5E8306831C88}"/>
               </a:ext>
             </a:extLst>
           </p:cNvPr>
@@ -23480,7 +23275,7 @@
           <p:cNvPr id="47" name="f190">
             <a:extLst xmlns:a="http://schemas.openxmlformats.org/drawingml/2006/main">
               <a:ext uri="{FF2B5EF4-FFF2-40B4-BE49-F238E27FC236}">
-                <a16:creationId xmlns:a16="http://schemas.microsoft.com/office/drawing/2014/main" id="{8C58B910-33BF-4A9B-93DB-B86557928B71}"/>
+                <a16:creationId xmlns:a16="http://schemas.microsoft.com/office/drawing/2014/main" id="{DB013DA0-C5D0-4312-8ACB-D6EDC95AB21A}"/>
               </a:ext>
             </a:extLst>
           </p:cNvPr>
@@ -23639,7 +23434,7 @@
           <p:cNvPr id="48" name="f191">
             <a:extLst xmlns:a="http://schemas.openxmlformats.org/drawingml/2006/main">
               <a:ext uri="{FF2B5EF4-FFF2-40B4-BE49-F238E27FC236}">
-                <a16:creationId xmlns:a16="http://schemas.microsoft.com/office/drawing/2014/main" id="{DBE2DE84-1132-47EB-9CFB-DDF419284B7D}"/>
+                <a16:creationId xmlns:a16="http://schemas.microsoft.com/office/drawing/2014/main" id="{DACFD009-A1CE-4BDB-BC6C-FDFB9624D885}"/>
               </a:ext>
             </a:extLst>
           </p:cNvPr>
@@ -23819,7 +23614,7 @@
     </p:spTree>
     <p:extLst>
       <p:ext uri="{BB962C8B-B14F-4D97-AF65-F5344CB8AC3E}">
-        <p14:creationId xmlns:p14="http://schemas.microsoft.com/office/powerpoint/2010/main" val="858717008"/>
+        <p14:creationId xmlns:p14="http://schemas.microsoft.com/office/powerpoint/2010/main" val="518081371"/>
       </p:ext>
     </p:extLst>
   </p:cSld>

</xml_diff>